<commit_message>
Lighten PPTX: reduce all overlays, brighter cards and text
Cut dark overlays roughly in half (84%→50%, 87%→52%, 74%→42%, 72%→40%),
lighten card backgrounds (#0E1E4A→#162A68), brighter bullet text (#E4EEFF),
brighter cover gradient and blue glow, lighter card borders.

Co-Authored-By: Claude Sonnet 4.6 <noreply@anthropic.com>
Claude-Session: https://claude.ai/code/session_01BiSyRij3iqrCgrJJFpGphy
</commit_message>
<xml_diff>
--- a/sendacredit_propuesta.pptx
+++ b/sendacredit_propuesta.pptx
@@ -3158,7 +3158,7 @@
           </a:prstGeom>
           <a:solidFill>
             <a:srgbClr val="060E24">
-              <a:alpha val="74000"/>
+              <a:alpha val="42000"/>
             </a:srgbClr>
           </a:solidFill>
           <a:ln>
@@ -3383,7 +3383,7 @@
             <a:r>
               <a:rPr sz="2200">
                 <a:solidFill>
-                  <a:srgbClr val="ADD8E6"/>
+                  <a:srgbClr val="C8E8FF"/>
                 </a:solidFill>
               </a:rPr>
               <a:t>ID Finance</a:t>
@@ -3520,7 +3520,7 @@
           </a:prstGeom>
           <a:solidFill>
             <a:srgbClr val="060E24">
-              <a:alpha val="84000"/>
+              <a:alpha val="50000"/>
             </a:srgbClr>
           </a:solidFill>
           <a:ln>
@@ -3810,11 +3810,11 @@
             <a:avLst/>
           </a:prstGeom>
           <a:solidFill>
-            <a:srgbClr val="0E1E4A"/>
+            <a:srgbClr val="162A68"/>
           </a:solidFill>
           <a:ln w="9525">
             <a:solidFill>
-              <a:srgbClr val="2A4288"/>
+              <a:srgbClr val="4A68B8"/>
             </a:solidFill>
           </a:ln>
         </p:spPr>
@@ -4077,7 +4077,7 @@
             <a:r>
               <a:rPr sz="750">
                 <a:solidFill>
-                  <a:srgbClr val="CCD8EC"/>
+                  <a:srgbClr val="E4EEFF"/>
                 </a:solidFill>
               </a:rPr>
               <a:t>Integración vía SFTP seguro o API REST</a:t>
@@ -4100,7 +4100,7 @@
             <a:r>
               <a:rPr sz="750">
                 <a:solidFill>
-                  <a:srgbClr val="CCD8EC"/>
+                  <a:srgbClr val="E4EEFF"/>
                 </a:solidFill>
               </a:rPr>
               <a:t>Formatos: CSV, Excel, XML, JSON</a:t>
@@ -4123,7 +4123,7 @@
             <a:r>
               <a:rPr sz="750">
                 <a:solidFill>
-                  <a:srgbClr val="CCD8EC"/>
+                  <a:srgbClr val="E4EEFF"/>
                 </a:solidFill>
               </a:rPr>
               <a:t>Hasta 100.000 registros por lote</a:t>
@@ -4146,7 +4146,7 @@
             <a:r>
               <a:rPr sz="750">
                 <a:solidFill>
-                  <a:srgbClr val="CCD8EC"/>
+                  <a:srgbClr val="E4EEFF"/>
                 </a:solidFill>
               </a:rPr>
               <a:t>Acuse con hash de integridad automático</a:t>
@@ -4169,11 +4169,11 @@
             <a:avLst/>
           </a:prstGeom>
           <a:solidFill>
-            <a:srgbClr val="0E1E4A"/>
+            <a:srgbClr val="162A68"/>
           </a:solidFill>
           <a:ln w="9525">
             <a:solidFill>
-              <a:srgbClr val="2A4288"/>
+              <a:srgbClr val="4A68B8"/>
             </a:solidFill>
           </a:ln>
         </p:spPr>
@@ -4436,7 +4436,7 @@
             <a:r>
               <a:rPr sz="750">
                 <a:solidFill>
-                  <a:srgbClr val="CCD8EC"/>
+                  <a:srgbClr val="E4EEFF"/>
                 </a:solidFill>
               </a:rPr>
               <a:t>Deduplicación y normalización de datos</a:t>
@@ -4459,7 +4459,7 @@
             <a:r>
               <a:rPr sz="750">
                 <a:solidFill>
-                  <a:srgbClr val="CCD8EC"/>
+                  <a:srgbClr val="E4EEFF"/>
                 </a:solidFill>
               </a:rPr>
               <a:t>Verificación de DNI/NIE y datos civiles</a:t>
@@ -4482,7 +4482,7 @@
             <a:r>
               <a:rPr sz="750">
                 <a:solidFill>
-                  <a:srgbClr val="CCD8EC"/>
+                  <a:srgbClr val="E4EEFF"/>
                 </a:solidFill>
               </a:rPr>
               <a:t>Actualización de contactos (ASNEF, GGSS)</a:t>
@@ -4505,7 +4505,7 @@
             <a:r>
               <a:rPr sz="750">
                 <a:solidFill>
-                  <a:srgbClr val="CCD8EC"/>
+                  <a:srgbClr val="E4EEFF"/>
                 </a:solidFill>
               </a:rPr>
               <a:t>Informe de calidad de cartera en 24 h</a:t>
@@ -4528,11 +4528,11 @@
             <a:avLst/>
           </a:prstGeom>
           <a:solidFill>
-            <a:srgbClr val="0E1E4A"/>
+            <a:srgbClr val="162A68"/>
           </a:solidFill>
           <a:ln w="9525">
             <a:solidFill>
-              <a:srgbClr val="2A4288"/>
+              <a:srgbClr val="4A68B8"/>
             </a:solidFill>
           </a:ln>
         </p:spPr>
@@ -4795,7 +4795,7 @@
             <a:r>
               <a:rPr sz="750">
                 <a:solidFill>
-                  <a:srgbClr val="CCD8EC"/>
+                  <a:srgbClr val="E4EEFF"/>
                 </a:solidFill>
               </a:rPr>
               <a:t>Clasificación por antigüedad e importe</a:t>
@@ -4818,7 +4818,7 @@
             <a:r>
               <a:rPr sz="750">
                 <a:solidFill>
-                  <a:srgbClr val="CCD8EC"/>
+                  <a:srgbClr val="E4EEFF"/>
                 </a:solidFill>
               </a:rPr>
               <a:t>Scoring de cobrabilidad con modelo ML</a:t>
@@ -4841,7 +4841,7 @@
             <a:r>
               <a:rPr sz="750">
                 <a:solidFill>
-                  <a:srgbClr val="CCD8EC"/>
+                  <a:srgbClr val="E4EEFF"/>
                 </a:solidFill>
               </a:rPr>
               <a:t>Asignación de canal de recobro óptimo</a:t>
@@ -4864,7 +4864,7 @@
             <a:r>
               <a:rPr sz="750">
                 <a:solidFill>
-                  <a:srgbClr val="CCD8EC"/>
+                  <a:srgbClr val="E4EEFF"/>
                 </a:solidFill>
               </a:rPr>
               <a:t>Priorización por rentabilidad esperada</a:t>
@@ -4933,7 +4933,7 @@
           </a:prstGeom>
           <a:solidFill>
             <a:srgbClr val="060E24">
-              <a:alpha val="84000"/>
+              <a:alpha val="50000"/>
             </a:srgbClr>
           </a:solidFill>
           <a:ln>
@@ -5223,11 +5223,11 @@
             <a:avLst/>
           </a:prstGeom>
           <a:solidFill>
-            <a:srgbClr val="0E1E4A"/>
+            <a:srgbClr val="162A68"/>
           </a:solidFill>
           <a:ln w="9525">
             <a:solidFill>
-              <a:srgbClr val="2A4288"/>
+              <a:srgbClr val="4A68B8"/>
             </a:solidFill>
           </a:ln>
         </p:spPr>
@@ -5490,7 +5490,7 @@
             <a:r>
               <a:rPr sz="750">
                 <a:solidFill>
-                  <a:srgbClr val="CCD8EC"/>
+                  <a:srgbClr val="E4EEFF"/>
                 </a:solidFill>
               </a:rPr>
               <a:t>Llamadas outbound con IVR especializado</a:t>
@@ -5513,7 +5513,7 @@
             <a:r>
               <a:rPr sz="750">
                 <a:solidFill>
-                  <a:srgbClr val="CCD8EC"/>
+                  <a:srgbClr val="E4EEFF"/>
                 </a:solidFill>
               </a:rPr>
               <a:t>SMS, email y WhatsApp Business certificado</a:t>
@@ -5536,7 +5536,7 @@
             <a:r>
               <a:rPr sz="750">
                 <a:solidFill>
-                  <a:srgbClr val="CCD8EC"/>
+                  <a:srgbClr val="E4EEFF"/>
                 </a:solidFill>
               </a:rPr>
               <a:t>Cartas físicas certificadas cuando procede</a:t>
@@ -5559,7 +5559,7 @@
             <a:r>
               <a:rPr sz="750">
                 <a:solidFill>
-                  <a:srgbClr val="CCD8EC"/>
+                  <a:srgbClr val="E4EEFF"/>
                 </a:solidFill>
               </a:rPr>
               <a:t>Ventana de contacto 8:00-22:00, L-S</a:t>
@@ -5582,11 +5582,11 @@
             <a:avLst/>
           </a:prstGeom>
           <a:solidFill>
-            <a:srgbClr val="0E1E4A"/>
+            <a:srgbClr val="162A68"/>
           </a:solidFill>
           <a:ln w="9525">
             <a:solidFill>
-              <a:srgbClr val="2A4288"/>
+              <a:srgbClr val="4A68B8"/>
             </a:solidFill>
           </a:ln>
         </p:spPr>
@@ -5849,7 +5849,7 @@
             <a:r>
               <a:rPr sz="750">
                 <a:solidFill>
-                  <a:srgbClr val="CCD8EC"/>
+                  <a:srgbClr val="E4EEFF"/>
                 </a:solidFill>
               </a:rPr>
               <a:t>Quitas y daciones dentro de límites pactados</a:t>
@@ -5872,7 +5872,7 @@
             <a:r>
               <a:rPr sz="750">
                 <a:solidFill>
-                  <a:srgbClr val="CCD8EC"/>
+                  <a:srgbClr val="E4EEFF"/>
                 </a:solidFill>
               </a:rPr>
               <a:t>Planes de pago de 3 a 48 meses</a:t>
@@ -5895,7 +5895,7 @@
             <a:r>
               <a:rPr sz="750">
                 <a:solidFill>
-                  <a:srgbClr val="CCD8EC"/>
+                  <a:srgbClr val="E4EEFF"/>
                 </a:solidFill>
               </a:rPr>
               <a:t>Firma de acuerdos digitales con validez legal</a:t>
@@ -5918,7 +5918,7 @@
             <a:r>
               <a:rPr sz="750">
                 <a:solidFill>
-                  <a:srgbClr val="CCD8EC"/>
+                  <a:srgbClr val="E4EEFF"/>
                 </a:solidFill>
               </a:rPr>
               <a:t>Grabación de llamadas como respaldo</a:t>
@@ -5941,11 +5941,11 @@
             <a:avLst/>
           </a:prstGeom>
           <a:solidFill>
-            <a:srgbClr val="0E1E4A"/>
+            <a:srgbClr val="162A68"/>
           </a:solidFill>
           <a:ln w="9525">
             <a:solidFill>
-              <a:srgbClr val="2A4288"/>
+              <a:srgbClr val="4A68B8"/>
             </a:solidFill>
           </a:ln>
         </p:spPr>
@@ -6208,7 +6208,7 @@
             <a:r>
               <a:rPr sz="750">
                 <a:solidFill>
-                  <a:srgbClr val="CCD8EC"/>
+                  <a:srgbClr val="E4EEFF"/>
                 </a:solidFill>
               </a:rPr>
               <a:t>Domiciliación SEPA y pasarela de pago online</a:t>
@@ -6231,7 +6231,7 @@
             <a:r>
               <a:rPr sz="750">
                 <a:solidFill>
-                  <a:srgbClr val="CCD8EC"/>
+                  <a:srgbClr val="E4EEFF"/>
                 </a:solidFill>
               </a:rPr>
               <a:t>Recordatorios automáticos de vencimientos</a:t>
@@ -6254,7 +6254,7 @@
             <a:r>
               <a:rPr sz="750">
                 <a:solidFill>
-                  <a:srgbClr val="CCD8EC"/>
+                  <a:srgbClr val="E4EEFF"/>
                 </a:solidFill>
               </a:rPr>
               <a:t>Renegociación ante impagos parciales</a:t>
@@ -6277,7 +6277,7 @@
             <a:r>
               <a:rPr sz="750">
                 <a:solidFill>
-                  <a:srgbClr val="CCD8EC"/>
+                  <a:srgbClr val="E4EEFF"/>
                 </a:solidFill>
               </a:rPr>
               <a:t>Dashboard de seguimiento en tiempo real</a:t>
@@ -6346,7 +6346,7 @@
           </a:prstGeom>
           <a:solidFill>
             <a:srgbClr val="060E24">
-              <a:alpha val="84000"/>
+              <a:alpha val="50000"/>
             </a:srgbClr>
           </a:solidFill>
           <a:ln>
@@ -6636,11 +6636,11 @@
             <a:avLst/>
           </a:prstGeom>
           <a:solidFill>
-            <a:srgbClr val="0E1E4A"/>
+            <a:srgbClr val="162A68"/>
           </a:solidFill>
           <a:ln w="9525">
             <a:solidFill>
-              <a:srgbClr val="2A4288"/>
+              <a:srgbClr val="4A68B8"/>
             </a:solidFill>
           </a:ln>
         </p:spPr>
@@ -6903,7 +6903,7 @@
             <a:r>
               <a:rPr sz="750">
                 <a:solidFill>
-                  <a:srgbClr val="CCD8EC"/>
+                  <a:srgbClr val="E4EEFF"/>
                 </a:solidFill>
               </a:rPr>
               <a:t>Revisión de prescripción y documentación</a:t>
@@ -6926,7 +6926,7 @@
             <a:r>
               <a:rPr sz="750">
                 <a:solidFill>
-                  <a:srgbClr val="CCD8EC"/>
+                  <a:srgbClr val="E4EEFF"/>
                 </a:solidFill>
               </a:rPr>
               <a:t>Estudio de solvencia y localización de bienes</a:t>
@@ -6949,7 +6949,7 @@
             <a:r>
               <a:rPr sz="750">
                 <a:solidFill>
-                  <a:srgbClr val="CCD8EC"/>
+                  <a:srgbClr val="E4EEFF"/>
                 </a:solidFill>
               </a:rPr>
               <a:t>Valoración coste-beneficio por expediente</a:t>
@@ -6972,7 +6972,7 @@
             <a:r>
               <a:rPr sz="750">
                 <a:solidFill>
-                  <a:srgbClr val="CCD8EC"/>
+                  <a:srgbClr val="E4EEFF"/>
                 </a:solidFill>
               </a:rPr>
               <a:t>Decisión de elevación judicial en 48-72 h</a:t>
@@ -6995,11 +6995,11 @@
             <a:avLst/>
           </a:prstGeom>
           <a:solidFill>
-            <a:srgbClr val="0E1E4A"/>
+            <a:srgbClr val="162A68"/>
           </a:solidFill>
           <a:ln w="9525">
             <a:solidFill>
-              <a:srgbClr val="2A4288"/>
+              <a:srgbClr val="4A68B8"/>
             </a:solidFill>
           </a:ln>
         </p:spPr>
@@ -7262,7 +7262,7 @@
             <a:r>
               <a:rPr sz="750">
                 <a:solidFill>
-                  <a:srgbClr val="CCD8EC"/>
+                  <a:srgbClr val="E4EEFF"/>
                 </a:solidFill>
               </a:rPr>
               <a:t>Interposición de monitorio o juicio verbal</a:t>
@@ -7285,7 +7285,7 @@
             <a:r>
               <a:rPr sz="750">
                 <a:solidFill>
-                  <a:srgbClr val="CCD8EC"/>
+                  <a:srgbClr val="E4EEFF"/>
                 </a:solidFill>
               </a:rPr>
               <a:t>Red de letrados en todas las CC.AA.</a:t>
@@ -7308,7 +7308,7 @@
             <a:r>
               <a:rPr sz="750">
                 <a:solidFill>
-                  <a:srgbClr val="CCD8EC"/>
+                  <a:srgbClr val="E4EEFF"/>
                 </a:solidFill>
               </a:rPr>
               <a:t>Coordinación con procuradores y notificaciones</a:t>
@@ -7331,7 +7331,7 @@
             <a:r>
               <a:rPr sz="750">
                 <a:solidFill>
-                  <a:srgbClr val="CCD8EC"/>
+                  <a:srgbClr val="E4EEFF"/>
                 </a:solidFill>
               </a:rPr>
               <a:t>Reporting de estado mensual</a:t>
@@ -7354,11 +7354,11 @@
             <a:avLst/>
           </a:prstGeom>
           <a:solidFill>
-            <a:srgbClr val="0E1E4A"/>
+            <a:srgbClr val="162A68"/>
           </a:solidFill>
           <a:ln w="9525">
             <a:solidFill>
-              <a:srgbClr val="2A4288"/>
+              <a:srgbClr val="4A68B8"/>
             </a:solidFill>
           </a:ln>
         </p:spPr>
@@ -7621,7 +7621,7 @@
             <a:r>
               <a:rPr sz="750">
                 <a:solidFill>
-                  <a:srgbClr val="CCD8EC"/>
+                  <a:srgbClr val="E4EEFF"/>
                 </a:solidFill>
               </a:rPr>
               <a:t>Embargo de cuentas, nóminas e inmuebles</a:t>
@@ -7644,7 +7644,7 @@
             <a:r>
               <a:rPr sz="750">
                 <a:solidFill>
-                  <a:srgbClr val="CCD8EC"/>
+                  <a:srgbClr val="E4EEFF"/>
                 </a:solidFill>
               </a:rPr>
               <a:t>Seguimiento de subastas judiciales</a:t>
@@ -7667,7 +7667,7 @@
             <a:r>
               <a:rPr sz="750">
                 <a:solidFill>
-                  <a:srgbClr val="CCD8EC"/>
+                  <a:srgbClr val="E4EEFF"/>
                 </a:solidFill>
               </a:rPr>
               <a:t>Liquidación y transferencia en 5 días hábiles</a:t>
@@ -7690,7 +7690,7 @@
             <a:r>
               <a:rPr sz="750">
                 <a:solidFill>
-                  <a:srgbClr val="CCD8EC"/>
+                  <a:srgbClr val="E4EEFF"/>
                 </a:solidFill>
               </a:rPr>
               <a:t>Acta de cierre con detalle de costas</a:t>
@@ -7759,7 +7759,7 @@
           </a:prstGeom>
           <a:solidFill>
             <a:srgbClr val="060E24">
-              <a:alpha val="84000"/>
+              <a:alpha val="50000"/>
             </a:srgbClr>
           </a:solidFill>
           <a:ln>
@@ -8049,11 +8049,11 @@
             <a:avLst/>
           </a:prstGeom>
           <a:solidFill>
-            <a:srgbClr val="0E1E4A"/>
+            <a:srgbClr val="162A68"/>
           </a:solidFill>
           <a:ln w="9525">
             <a:solidFill>
-              <a:srgbClr val="2A4288"/>
+              <a:srgbClr val="4A68B8"/>
             </a:solidFill>
           </a:ln>
         </p:spPr>
@@ -8316,7 +8316,7 @@
             <a:r>
               <a:rPr sz="750">
                 <a:solidFill>
-                  <a:srgbClr val="CCD8EC"/>
+                  <a:srgbClr val="E4EEFF"/>
                 </a:solidFill>
               </a:rPr>
               <a:t>Informe semanal de actividad y contactaciones</a:t>
@@ -8339,7 +8339,7 @@
             <a:r>
               <a:rPr sz="750">
                 <a:solidFill>
-                  <a:srgbClr val="CCD8EC"/>
+                  <a:srgbClr val="E4EEFF"/>
                 </a:solidFill>
               </a:rPr>
               <a:t>Reporte mensual de recuperación y aging</a:t>
@@ -8362,7 +8362,7 @@
             <a:r>
               <a:rPr sz="750">
                 <a:solidFill>
-                  <a:srgbClr val="CCD8EC"/>
+                  <a:srgbClr val="E4EEFF"/>
                 </a:solidFill>
               </a:rPr>
               <a:t>Cuadro de mando ejecutivo trimestral</a:t>
@@ -8385,7 +8385,7 @@
             <a:r>
               <a:rPr sz="750">
                 <a:solidFill>
-                  <a:srgbClr val="CCD8EC"/>
+                  <a:srgbClr val="E4EEFF"/>
                 </a:solidFill>
               </a:rPr>
               <a:t>Exportación en PDF, Excel y API JSON</a:t>
@@ -8408,11 +8408,11 @@
             <a:avLst/>
           </a:prstGeom>
           <a:solidFill>
-            <a:srgbClr val="0E1E4A"/>
+            <a:srgbClr val="162A68"/>
           </a:solidFill>
           <a:ln w="9525">
             <a:solidFill>
-              <a:srgbClr val="2A4288"/>
+              <a:srgbClr val="4A68B8"/>
             </a:solidFill>
           </a:ln>
         </p:spPr>
@@ -8675,7 +8675,7 @@
             <a:r>
               <a:rPr sz="750">
                 <a:solidFill>
-                  <a:srgbClr val="CCD8EC"/>
+                  <a:srgbClr val="E4EEFF"/>
                 </a:solidFill>
               </a:rPr>
               <a:t>Liquidación quincenal por expediente</a:t>
@@ -8698,7 +8698,7 @@
             <a:r>
               <a:rPr sz="750">
                 <a:solidFill>
-                  <a:srgbClr val="CCD8EC"/>
+                  <a:srgbClr val="E4EEFF"/>
                 </a:solidFill>
               </a:rPr>
               <a:t>Transferencia SEPA en T+2 hábiles</a:t>
@@ -8721,7 +8721,7 @@
             <a:r>
               <a:rPr sz="750">
                 <a:solidFill>
-                  <a:srgbClr val="CCD8EC"/>
+                  <a:srgbClr val="E4EEFF"/>
                 </a:solidFill>
               </a:rPr>
               <a:t>Conciliación automática con ERP/CRM</a:t>
@@ -8744,7 +8744,7 @@
             <a:r>
               <a:rPr sz="750">
                 <a:solidFill>
-                  <a:srgbClr val="CCD8EC"/>
+                  <a:srgbClr val="E4EEFF"/>
                 </a:solidFill>
               </a:rPr>
               <a:t>Facturación electrónica certificada</a:t>
@@ -8767,11 +8767,11 @@
             <a:avLst/>
           </a:prstGeom>
           <a:solidFill>
-            <a:srgbClr val="0E1E4A"/>
+            <a:srgbClr val="162A68"/>
           </a:solidFill>
           <a:ln w="9525">
             <a:solidFill>
-              <a:srgbClr val="2A4288"/>
+              <a:srgbClr val="4A68B8"/>
             </a:solidFill>
           </a:ln>
         </p:spPr>
@@ -9034,7 +9034,7 @@
             <a:r>
               <a:rPr sz="750">
                 <a:solidFill>
-                  <a:srgbClr val="CCD8EC"/>
+                  <a:srgbClr val="E4EEFF"/>
                 </a:solidFill>
               </a:rPr>
               <a:t>Auditoría interna mensual de procesos</a:t>
@@ -9057,7 +9057,7 @@
             <a:r>
               <a:rPr sz="750">
                 <a:solidFill>
-                  <a:srgbClr val="CCD8EC"/>
+                  <a:srgbClr val="E4EEFF"/>
                 </a:solidFill>
               </a:rPr>
               <a:t>Mystery calling y escucha de grabaciones</a:t>
@@ -9080,7 +9080,7 @@
             <a:r>
               <a:rPr sz="750">
                 <a:solidFill>
-                  <a:srgbClr val="CCD8EC"/>
+                  <a:srgbClr val="E4EEFF"/>
                 </a:solidFill>
               </a:rPr>
               <a:t>Comité de mejora continua trimestral</a:t>
@@ -9103,7 +9103,7 @@
             <a:r>
               <a:rPr sz="750">
                 <a:solidFill>
-                  <a:srgbClr val="CCD8EC"/>
+                  <a:srgbClr val="E4EEFF"/>
                 </a:solidFill>
               </a:rPr>
               <a:t>Certificación ISO 9001 y cumplimiento RGPD</a:t>
@@ -9172,7 +9172,7 @@
           </a:prstGeom>
           <a:solidFill>
             <a:srgbClr val="060E24">
-              <a:alpha val="87000"/>
+              <a:alpha val="52000"/>
             </a:srgbClr>
           </a:solidFill>
           <a:ln>
@@ -9462,11 +9462,11 @@
             <a:avLst/>
           </a:prstGeom>
           <a:solidFill>
-            <a:srgbClr val="0E1E4A"/>
+            <a:srgbClr val="162A68"/>
           </a:solidFill>
           <a:ln w="9525">
             <a:solidFill>
-              <a:srgbClr val="2A4288"/>
+              <a:srgbClr val="4A68B8"/>
             </a:solidFill>
           </a:ln>
         </p:spPr>
@@ -9717,7 +9717,7 @@
             <a:r>
               <a:rPr sz="750">
                 <a:solidFill>
-                  <a:srgbClr val="CCD8EC"/>
+                  <a:srgbClr val="E4EEFF"/>
                 </a:solidFill>
               </a:rPr>
               <a:t>Negociación extrajudicial, planes de pago personalizados y seguimiento continuo hasta la resolución del expediente.</a:t>
@@ -9740,11 +9740,11 @@
             <a:avLst/>
           </a:prstGeom>
           <a:solidFill>
-            <a:srgbClr val="0E1E4A"/>
+            <a:srgbClr val="162A68"/>
           </a:solidFill>
           <a:ln w="9525">
             <a:solidFill>
-              <a:srgbClr val="2A4288"/>
+              <a:srgbClr val="4A68B8"/>
             </a:solidFill>
           </a:ln>
         </p:spPr>
@@ -9995,7 +9995,7 @@
             <a:r>
               <a:rPr sz="750">
                 <a:solidFill>
-                  <a:srgbClr val="CCD8EC"/>
+                  <a:srgbClr val="E4EEFF"/>
                 </a:solidFill>
               </a:rPr>
               <a:t>Interposición de demandas, coordinación con letrados y ejecución de sentencias a través de procuradores especializados.</a:t>
@@ -10018,11 +10018,11 @@
             <a:avLst/>
           </a:prstGeom>
           <a:solidFill>
-            <a:srgbClr val="0E1E4A"/>
+            <a:srgbClr val="162A68"/>
           </a:solidFill>
           <a:ln w="9525">
             <a:solidFill>
-              <a:srgbClr val="2A4288"/>
+              <a:srgbClr val="4A68B8"/>
             </a:solidFill>
           </a:ln>
         </p:spPr>
@@ -10273,7 +10273,7 @@
             <a:r>
               <a:rPr sz="750">
                 <a:solidFill>
-                  <a:srgbClr val="CCD8EC"/>
+                  <a:srgbClr val="E4EEFF"/>
                 </a:solidFill>
               </a:rPr>
               <a:t>Análisis predictivo de cartera para priorizar expedientes con mayor probabilidad de cobro y optimizar recursos.</a:t>
@@ -10296,11 +10296,11 @@
             <a:avLst/>
           </a:prstGeom>
           <a:solidFill>
-            <a:srgbClr val="0E1E4A"/>
+            <a:srgbClr val="162A68"/>
           </a:solidFill>
           <a:ln w="9525">
             <a:solidFill>
-              <a:srgbClr val="2A4288"/>
+              <a:srgbClr val="4A68B8"/>
             </a:solidFill>
           </a:ln>
         </p:spPr>
@@ -10551,7 +10551,7 @@
             <a:r>
               <a:rPr sz="750">
                 <a:solidFill>
-                  <a:srgbClr val="CCD8EC"/>
+                  <a:srgbClr val="E4EEFF"/>
                 </a:solidFill>
               </a:rPr>
               <a:t>Panel de control en tiempo real con KPIs, tasa de recuperación, aging de cartera y exportación de informes ejecutivos.</a:t>
@@ -10644,7 +10644,7 @@
           </a:prstGeom>
           <a:solidFill>
             <a:srgbClr val="060E24">
-              <a:alpha val="72000"/>
+              <a:alpha val="40000"/>
             </a:srgbClr>
           </a:solidFill>
           <a:ln>
@@ -10991,7 +10991,7 @@
             <a:r>
               <a:rPr sz="900" i="1">
                 <a:solidFill>
-                  <a:srgbClr val="ADD8E6"/>
+                  <a:srgbClr val="C8E8FF"/>
                 </a:solidFill>
               </a:rPr>
               <a:t>Nuestros equipos están disponibles para comenzar de inmediato.</a:t>
@@ -11014,11 +11014,11 @@
             <a:avLst/>
           </a:prstGeom>
           <a:solidFill>
-            <a:srgbClr val="0E1E4A"/>
+            <a:srgbClr val="162A68"/>
           </a:solidFill>
           <a:ln w="9525">
             <a:solidFill>
-              <a:srgbClr val="2A4288"/>
+              <a:srgbClr val="4A68B8"/>
             </a:solidFill>
           </a:ln>
         </p:spPr>
@@ -11194,7 +11194,7 @@
             <a:r>
               <a:rPr sz="750">
                 <a:solidFill>
-                  <a:srgbClr val="CCD8EC"/>
+                  <a:srgbClr val="E4EEFF"/>
                 </a:solidFill>
               </a:rPr>
               <a:t>Gran Vía 28, 4ª planta</a:t>
@@ -11224,7 +11224,7 @@
             <a:r>
               <a:rPr sz="750">
                 <a:solidFill>
-                  <a:srgbClr val="99BBDD"/>
+                  <a:srgbClr val="B0CCEE"/>
                 </a:solidFill>
               </a:rPr>
               <a:t>madrid@sendacredit.com</a:t>
@@ -11247,11 +11247,11 @@
             <a:avLst/>
           </a:prstGeom>
           <a:solidFill>
-            <a:srgbClr val="0E1E4A"/>
+            <a:srgbClr val="162A68"/>
           </a:solidFill>
           <a:ln w="9525">
             <a:solidFill>
-              <a:srgbClr val="2A4288"/>
+              <a:srgbClr val="4A68B8"/>
             </a:solidFill>
           </a:ln>
         </p:spPr>
@@ -11427,7 +11427,7 @@
             <a:r>
               <a:rPr sz="750">
                 <a:solidFill>
-                  <a:srgbClr val="CCD8EC"/>
+                  <a:srgbClr val="E4EEFF"/>
                 </a:solidFill>
               </a:rPr>
               <a:t>Diagonal 211, 3ª planta</a:t>
@@ -11457,7 +11457,7 @@
             <a:r>
               <a:rPr sz="750">
                 <a:solidFill>
-                  <a:srgbClr val="99BBDD"/>
+                  <a:srgbClr val="B0CCEE"/>
                 </a:solidFill>
               </a:rPr>
               <a:t>barcelona@sendacredit.com</a:t>
@@ -11480,11 +11480,11 @@
             <a:avLst/>
           </a:prstGeom>
           <a:solidFill>
-            <a:srgbClr val="0E1E4A"/>
+            <a:srgbClr val="162A68"/>
           </a:solidFill>
           <a:ln w="9525">
             <a:solidFill>
-              <a:srgbClr val="2A4288"/>
+              <a:srgbClr val="4A68B8"/>
             </a:solidFill>
           </a:ln>
         </p:spPr>
@@ -11660,7 +11660,7 @@
             <a:r>
               <a:rPr sz="750">
                 <a:solidFill>
-                  <a:srgbClr val="CCD8EC"/>
+                  <a:srgbClr val="E4EEFF"/>
                 </a:solidFill>
               </a:rPr>
               <a:t>Larios 12, 2ª planta</a:t>
@@ -11690,7 +11690,7 @@
             <a:r>
               <a:rPr sz="750">
                 <a:solidFill>
-                  <a:srgbClr val="99BBDD"/>
+                  <a:srgbClr val="B0CCEE"/>
                 </a:solidFill>
               </a:rPr>
               <a:t>malaga@sendacredit.com</a:t>

</xml_diff>

<commit_message>
Redesign PPTX: white cards, lighter overlays, scrolling animations
- White/light card backgrounds (#F2F7FF) with dark navy text — drastic lightening
- Dark nav bar at top of content slides for title readability, photo visible below
- Overlays reduced to 35-40% (from 50-87%)
- Cover overlay at 35%, contact at 30%
- Push-from-bottom slide transitions for scrolling feel
- Wipe-up entrance animations (staggered 160ms) on cards per slide
- Removed 'ID Finance' reference from cover

Co-Authored-By: Claude Sonnet 4.6 <noreply@anthropic.com>
Claude-Session: https://claude.ai/code/session_01BiSyRij3iqrCgrJJFpGphy
</commit_message>
<xml_diff>
--- a/sendacredit_propuesta.pptx
+++ b/sendacredit_propuesta.pptx
@@ -3134,8 +3134,8 @@
         </p:blipFill>
         <p:spPr>
           <a:xfrm>
-            <a:off x="5425135" y="0"/>
-            <a:ext cx="6766560" cy="6858000"/>
+            <a:off x="5608015" y="0"/>
+            <a:ext cx="6583680" cy="6858000"/>
           </a:xfrm>
           <a:prstGeom prst="rect">
             <a:avLst/>
@@ -3150,15 +3150,15 @@
         </p:nvSpPr>
         <p:spPr>
           <a:xfrm>
-            <a:off x="5425135" y="0"/>
-            <a:ext cx="6766560" cy="6858000"/>
+            <a:off x="5608015" y="0"/>
+            <a:ext cx="6583680" cy="6858000"/>
           </a:xfrm>
           <a:prstGeom prst="rect">
             <a:avLst/>
           </a:prstGeom>
           <a:solidFill>
             <a:srgbClr val="060E24">
-              <a:alpha val="42000"/>
+              <a:alpha val="35000"/>
             </a:srgbClr>
           </a:solidFill>
           <a:ln>
@@ -3195,7 +3195,7 @@
         </p:nvSpPr>
         <p:spPr>
           <a:xfrm>
-            <a:off x="5387035" y="0"/>
+            <a:off x="5569915" y="0"/>
             <a:ext cx="38100" cy="6858000"/>
           </a:xfrm>
           <a:prstGeom prst="rect">
@@ -3263,7 +3263,7 @@
         <p:spPr>
           <a:xfrm>
             <a:off x="658368" y="1600200"/>
-            <a:ext cx="5669280" cy="384048"/>
+            <a:ext cx="5486400" cy="365760"/>
           </a:xfrm>
           <a:prstGeom prst="rect">
             <a:avLst/>
@@ -3296,8 +3296,8 @@
         </p:nvSpPr>
         <p:spPr>
           <a:xfrm>
-            <a:off x="658368" y="2084831"/>
-            <a:ext cx="2834640" cy="31750"/>
+            <a:off x="658368" y="2066543"/>
+            <a:ext cx="2743200" cy="31750"/>
           </a:xfrm>
           <a:prstGeom prst="rect">
             <a:avLst/>
@@ -3339,8 +3339,8 @@
         </p:nvSpPr>
         <p:spPr>
           <a:xfrm>
-            <a:off x="658368" y="2231136"/>
-            <a:ext cx="5943600" cy="2286000"/>
+            <a:off x="658368" y="2212848"/>
+            <a:ext cx="5852160" cy="2286000"/>
           </a:xfrm>
           <a:prstGeom prst="rect">
             <a:avLst/>
@@ -3355,7 +3355,7 @@
           <a:p>
             <a:pPr algn="l"/>
             <a:r>
-              <a:rPr sz="3600" b="1">
+              <a:rPr sz="3700" b="1">
                 <a:solidFill>
                   <a:srgbClr val="FFFFFF"/>
                 </a:solidFill>
@@ -3366,27 +3366,12 @@
           <a:p>
             <a:pPr algn="l"/>
             <a:r>
-              <a:rPr sz="3600" b="1">
+              <a:rPr sz="3700" b="1">
                 <a:solidFill>
                   <a:srgbClr val="2FDFE5"/>
                 </a:solidFill>
               </a:rPr>
               <a:t>de expedientes</a:t>
-            </a:r>
-          </a:p>
-          <a:p>
-            <a:pPr algn="l">
-              <a:spcBef>
-                <a:spcPts val="400"/>
-              </a:spcBef>
-            </a:pPr>
-            <a:r>
-              <a:rPr sz="2200">
-                <a:solidFill>
-                  <a:srgbClr val="C8E8FF"/>
-                </a:solidFill>
-              </a:rPr>
-              <a:t>ID Finance</a:t>
             </a:r>
           </a:p>
         </p:txBody>
@@ -3399,8 +3384,8 @@
         </p:nvSpPr>
         <p:spPr>
           <a:xfrm>
-            <a:off x="658368" y="4617720"/>
-            <a:ext cx="5303520" cy="475488"/>
+            <a:off x="658368" y="4645152"/>
+            <a:ext cx="5120640" cy="438912"/>
           </a:xfrm>
           <a:prstGeom prst="rect">
             <a:avLst/>
@@ -3417,7 +3402,7 @@
             <a:r>
               <a:rPr sz="1050" i="1">
                 <a:solidFill>
-                  <a:srgbClr val="AABBCC"/>
+                  <a:srgbClr val="C0E8FF"/>
                 </a:solidFill>
               </a:rPr>
               <a:t>Propuesta de colaboración · Recuperación de deuda</a:t>
@@ -3433,8 +3418,8 @@
         </p:nvSpPr>
         <p:spPr>
           <a:xfrm>
-            <a:off x="9722815" y="6382512"/>
-            <a:ext cx="2286000" cy="329184"/>
+            <a:off x="9722815" y="6419088"/>
+            <a:ext cx="2286000" cy="292608"/>
           </a:xfrm>
           <a:prstGeom prst="rect">
             <a:avLst/>
@@ -3451,7 +3436,7 @@
             <a:r>
               <a:rPr sz="800">
                 <a:solidFill>
-                  <a:srgbClr val="667788"/>
+                  <a:srgbClr val="80A8CC"/>
                 </a:solidFill>
               </a:rPr>
               <a:t>2025 – 2026</a:t>
@@ -3464,8 +3449,8 @@
   <p:clrMapOvr>
     <a:masterClrMapping/>
   </p:clrMapOvr>
-  <p:transition dur="700" spd="fast">
-    <p:fade/>
+  <p:transition dur="500" spd="fast">
+    <p:push dir="u"/>
   </p:transition>
 </p:sld>
 </file>
@@ -3520,7 +3505,7 @@
           </a:prstGeom>
           <a:solidFill>
             <a:srgbClr val="060E24">
-              <a:alpha val="50000"/>
+              <a:alpha val="38000"/>
             </a:srgbClr>
           </a:solidFill>
           <a:ln>
@@ -3552,6 +3537,49 @@
       <p:sp>
         <p:nvSpPr>
           <p:cNvPr id="4" name="Rectangle 3"/>
+          <p:cNvSpPr/>
+          <p:nvPr/>
+        </p:nvSpPr>
+        <p:spPr>
+          <a:xfrm>
+            <a:off x="0" y="0"/>
+            <a:ext cx="12191695" cy="1664208"/>
+          </a:xfrm>
+          <a:prstGeom prst="rect">
+            <a:avLst/>
+          </a:prstGeom>
+          <a:solidFill>
+            <a:srgbClr val="0A1638"/>
+          </a:solidFill>
+          <a:ln>
+            <a:noFill/>
+          </a:ln>
+        </p:spPr>
+        <p:style>
+          <a:lnRef idx="1">
+            <a:schemeClr val="accent1"/>
+          </a:lnRef>
+          <a:fillRef idx="3">
+            <a:schemeClr val="accent1"/>
+          </a:fillRef>
+          <a:effectRef idx="2">
+            <a:schemeClr val="accent1"/>
+          </a:effectRef>
+          <a:fontRef idx="minor">
+            <a:schemeClr val="lt1"/>
+          </a:fontRef>
+        </p:style>
+        <p:txBody>
+          <a:bodyPr rtlCol="0" anchor="ctr"/>
+          <a:lstStyle/>
+          <a:p>
+            <a:pPr algn="ctr"/>
+          </a:p>
+        </p:txBody>
+      </p:sp>
+      <p:sp>
+        <p:nvSpPr>
+          <p:cNvPr id="5" name="Rectangle 4"/>
           <p:cNvSpPr/>
           <p:nvPr/>
         </p:nvSpPr>
@@ -3594,7 +3622,7 @@
       </p:sp>
       <p:sp>
         <p:nvSpPr>
-          <p:cNvPr id="5" name="Rectangle 4"/>
+          <p:cNvPr id="6" name="Rectangle 5"/>
           <p:cNvSpPr/>
           <p:nvPr/>
         </p:nvSpPr>
@@ -3637,14 +3665,14 @@
       </p:sp>
       <p:sp>
         <p:nvSpPr>
-          <p:cNvPr id="6" name="Rectangle 5"/>
+          <p:cNvPr id="7" name="Rectangle 6"/>
           <p:cNvSpPr/>
           <p:nvPr/>
         </p:nvSpPr>
         <p:spPr>
           <a:xfrm>
             <a:off x="502920" y="365760"/>
-            <a:ext cx="1417320" cy="237744"/>
+            <a:ext cx="1371600" cy="237744"/>
           </a:xfrm>
           <a:prstGeom prst="rect">
             <a:avLst/>
@@ -3688,14 +3716,14 @@
       </p:sp>
       <p:sp>
         <p:nvSpPr>
-          <p:cNvPr id="7" name="TextBox 6"/>
+          <p:cNvPr id="8" name="TextBox 7"/>
           <p:cNvSpPr txBox="1"/>
           <p:nvPr/>
         </p:nvSpPr>
         <p:spPr>
           <a:xfrm>
             <a:off x="502920" y="694944"/>
-            <a:ext cx="8229600" cy="713232"/>
+            <a:ext cx="8412480" cy="694944"/>
           </a:xfrm>
           <a:prstGeom prst="rect">
             <a:avLst/>
@@ -3730,14 +3758,14 @@
       </p:sp>
       <p:sp>
         <p:nvSpPr>
-          <p:cNvPr id="8" name="Rectangle 7"/>
+          <p:cNvPr id="9" name="Rectangle 8"/>
           <p:cNvSpPr/>
           <p:nvPr/>
         </p:nvSpPr>
         <p:spPr>
           <a:xfrm>
-            <a:off x="502920" y="1481328"/>
-            <a:ext cx="4114800" cy="31750"/>
+            <a:off x="502920" y="1463040"/>
+            <a:ext cx="4023360" cy="31750"/>
           </a:xfrm>
           <a:prstGeom prst="rect">
             <a:avLst/>
@@ -3773,7 +3801,7 @@
       </p:sp>
       <p:pic>
         <p:nvPicPr>
-          <p:cNvPr id="9" name="Picture 8" descr="logo_horiz.png"/>
+          <p:cNvPr id="10" name="Picture 9" descr="logo_horiz.png"/>
           <p:cNvPicPr>
             <a:picLocks noChangeAspect="1"/>
           </p:cNvPicPr>
@@ -3787,8 +3815,8 @@
         </p:blipFill>
         <p:spPr>
           <a:xfrm>
-            <a:off x="10116008" y="6291072"/>
-            <a:ext cx="1874519" cy="420624"/>
+            <a:off x="10161727" y="6291072"/>
+            <a:ext cx="1828800" cy="420624"/>
           </a:xfrm>
           <a:prstGeom prst="rect">
             <a:avLst/>
@@ -3797,7 +3825,7 @@
       </p:pic>
       <p:sp>
         <p:nvSpPr>
-          <p:cNvPr id="10" name="Rectangle 9"/>
+          <p:cNvPr id="11" name="Rectangle 10"/>
           <p:cNvSpPr/>
           <p:nvPr/>
         </p:nvSpPr>
@@ -3810,11 +3838,11 @@
             <a:avLst/>
           </a:prstGeom>
           <a:solidFill>
-            <a:srgbClr val="162A68"/>
+            <a:srgbClr val="F2F7FF"/>
           </a:solidFill>
-          <a:ln w="9525">
+          <a:ln w="6350">
             <a:solidFill>
-              <a:srgbClr val="4A68B8"/>
+              <a:srgbClr val="2FDFE5"/>
             </a:solidFill>
           </a:ln>
         </p:spPr>
@@ -3842,14 +3870,14 @@
       </p:sp>
       <p:sp>
         <p:nvSpPr>
-          <p:cNvPr id="11" name="Rectangle 10"/>
+          <p:cNvPr id="12" name="Rectangle 11"/>
           <p:cNvSpPr/>
           <p:nvPr/>
         </p:nvSpPr>
         <p:spPr>
           <a:xfrm>
             <a:off x="502920" y="1719072"/>
-            <a:ext cx="3688994" cy="38100"/>
+            <a:ext cx="3688994" cy="50800"/>
           </a:xfrm>
           <a:prstGeom prst="rect">
             <a:avLst/>
@@ -3885,14 +3913,14 @@
       </p:sp>
       <p:sp>
         <p:nvSpPr>
-          <p:cNvPr id="12" name="Oval 11"/>
+          <p:cNvPr id="13" name="Oval 12"/>
           <p:cNvSpPr/>
           <p:nvPr/>
         </p:nvSpPr>
         <p:spPr>
           <a:xfrm>
             <a:off x="685800" y="1901952"/>
-            <a:ext cx="233172" cy="233172"/>
+            <a:ext cx="228600" cy="228600"/>
           </a:xfrm>
           <a:prstGeom prst="ellipse">
             <a:avLst/>
@@ -3930,14 +3958,14 @@
       </p:sp>
       <p:sp>
         <p:nvSpPr>
-          <p:cNvPr id="13" name="TextBox 12"/>
+          <p:cNvPr id="14" name="TextBox 13"/>
           <p:cNvSpPr txBox="1"/>
           <p:nvPr/>
         </p:nvSpPr>
         <p:spPr>
           <a:xfrm>
             <a:off x="685800" y="1901952"/>
-            <a:ext cx="233172" cy="233172"/>
+            <a:ext cx="228600" cy="228600"/>
           </a:xfrm>
           <a:prstGeom prst="rect">
             <a:avLst/>
@@ -3964,14 +3992,14 @@
       </p:sp>
       <p:sp>
         <p:nvSpPr>
-          <p:cNvPr id="14" name="TextBox 13"/>
+          <p:cNvPr id="15" name="TextBox 14"/>
           <p:cNvSpPr txBox="1"/>
           <p:nvPr/>
         </p:nvSpPr>
         <p:spPr>
           <a:xfrm>
-            <a:off x="630936" y="2226564"/>
-            <a:ext cx="3432962" cy="493776"/>
+            <a:off x="649224" y="2221992"/>
+            <a:ext cx="3396386" cy="512064"/>
           </a:xfrm>
           <a:prstGeom prst="rect">
             <a:avLst/>
@@ -3988,7 +4016,7 @@
             <a:r>
               <a:rPr sz="950" b="1">
                 <a:solidFill>
-                  <a:srgbClr val="FFFFFF"/>
+                  <a:srgbClr val="081432"/>
                 </a:solidFill>
               </a:rPr>
               <a:t>Recepción de fichero</a:t>
@@ -3998,14 +4026,14 @@
       </p:sp>
       <p:sp>
         <p:nvSpPr>
-          <p:cNvPr id="15" name="Rectangle 14"/>
+          <p:cNvPr id="16" name="Rectangle 15"/>
           <p:cNvSpPr/>
           <p:nvPr/>
         </p:nvSpPr>
         <p:spPr>
           <a:xfrm>
-            <a:off x="630936" y="2738628"/>
-            <a:ext cx="3432962" cy="12700"/>
+            <a:off x="630936" y="2752344"/>
+            <a:ext cx="3432962" cy="15240"/>
           </a:xfrm>
           <a:prstGeom prst="rect">
             <a:avLst/>
@@ -4041,21 +4069,21 @@
       </p:sp>
       <p:sp>
         <p:nvSpPr>
-          <p:cNvPr id="16" name="TextBox 15"/>
+          <p:cNvPr id="17" name="TextBox 16"/>
           <p:cNvSpPr txBox="1"/>
           <p:nvPr/>
         </p:nvSpPr>
         <p:spPr>
           <a:xfrm>
-            <a:off x="630936" y="2814828"/>
-            <a:ext cx="3432962" cy="3231388"/>
+            <a:off x="649224" y="2828544"/>
+            <a:ext cx="3414674" cy="3243072"/>
           </a:xfrm>
           <a:prstGeom prst="rect">
             <a:avLst/>
           </a:prstGeom>
           <a:noFill/>
         </p:spPr>
-        <p:txBody lIns="50800" tIns="25400" rIns="50800" bIns="25400">
+        <p:txBody lIns="50800" tIns="38100" rIns="50800" bIns="38100">
           <a:bodyPr wrap="square">
             <a:spAutoFit/>
           </a:bodyPr>
@@ -4077,7 +4105,7 @@
             <a:r>
               <a:rPr sz="750">
                 <a:solidFill>
-                  <a:srgbClr val="E4EEFF"/>
+                  <a:srgbClr val="223A6A"/>
                 </a:solidFill>
               </a:rPr>
               <a:t>Integración vía SFTP seguro o API REST</a:t>
@@ -4100,7 +4128,7 @@
             <a:r>
               <a:rPr sz="750">
                 <a:solidFill>
-                  <a:srgbClr val="E4EEFF"/>
+                  <a:srgbClr val="223A6A"/>
                 </a:solidFill>
               </a:rPr>
               <a:t>Formatos: CSV, Excel, XML, JSON</a:t>
@@ -4123,7 +4151,7 @@
             <a:r>
               <a:rPr sz="750">
                 <a:solidFill>
-                  <a:srgbClr val="E4EEFF"/>
+                  <a:srgbClr val="223A6A"/>
                 </a:solidFill>
               </a:rPr>
               <a:t>Hasta 100.000 registros por lote</a:t>
@@ -4146,7 +4174,7 @@
             <a:r>
               <a:rPr sz="750">
                 <a:solidFill>
-                  <a:srgbClr val="E4EEFF"/>
+                  <a:srgbClr val="223A6A"/>
                 </a:solidFill>
               </a:rPr>
               <a:t>Acuse con hash de integridad automático</a:t>
@@ -4156,7 +4184,7 @@
       </p:sp>
       <p:sp>
         <p:nvSpPr>
-          <p:cNvPr id="17" name="Rectangle 16"/>
+          <p:cNvPr id="18" name="Rectangle 17"/>
           <p:cNvSpPr/>
           <p:nvPr/>
         </p:nvSpPr>
@@ -4169,11 +4197,11 @@
             <a:avLst/>
           </a:prstGeom>
           <a:solidFill>
-            <a:srgbClr val="162A68"/>
+            <a:srgbClr val="F2F7FF"/>
           </a:solidFill>
-          <a:ln w="9525">
+          <a:ln w="6350">
             <a:solidFill>
-              <a:srgbClr val="4A68B8"/>
+              <a:srgbClr val="2FDFE5"/>
             </a:solidFill>
           </a:ln>
         </p:spPr>
@@ -4201,14 +4229,14 @@
       </p:sp>
       <p:sp>
         <p:nvSpPr>
-          <p:cNvPr id="18" name="Rectangle 17"/>
+          <p:cNvPr id="19" name="Rectangle 18"/>
           <p:cNvSpPr/>
           <p:nvPr/>
         </p:nvSpPr>
         <p:spPr>
           <a:xfrm>
             <a:off x="4338218" y="1719072"/>
-            <a:ext cx="3688994" cy="38100"/>
+            <a:ext cx="3688994" cy="50800"/>
           </a:xfrm>
           <a:prstGeom prst="rect">
             <a:avLst/>
@@ -4244,14 +4272,14 @@
       </p:sp>
       <p:sp>
         <p:nvSpPr>
-          <p:cNvPr id="19" name="Oval 18"/>
+          <p:cNvPr id="20" name="Oval 19"/>
           <p:cNvSpPr/>
           <p:nvPr/>
         </p:nvSpPr>
         <p:spPr>
           <a:xfrm>
             <a:off x="4521098" y="1901952"/>
-            <a:ext cx="233172" cy="233172"/>
+            <a:ext cx="228600" cy="228600"/>
           </a:xfrm>
           <a:prstGeom prst="ellipse">
             <a:avLst/>
@@ -4289,14 +4317,14 @@
       </p:sp>
       <p:sp>
         <p:nvSpPr>
-          <p:cNvPr id="20" name="TextBox 19"/>
+          <p:cNvPr id="21" name="TextBox 20"/>
           <p:cNvSpPr txBox="1"/>
           <p:nvPr/>
         </p:nvSpPr>
         <p:spPr>
           <a:xfrm>
             <a:off x="4521098" y="1901952"/>
-            <a:ext cx="233172" cy="233172"/>
+            <a:ext cx="228600" cy="228600"/>
           </a:xfrm>
           <a:prstGeom prst="rect">
             <a:avLst/>
@@ -4323,14 +4351,14 @@
       </p:sp>
       <p:sp>
         <p:nvSpPr>
-          <p:cNvPr id="21" name="TextBox 20"/>
+          <p:cNvPr id="22" name="TextBox 21"/>
           <p:cNvSpPr txBox="1"/>
           <p:nvPr/>
         </p:nvSpPr>
         <p:spPr>
           <a:xfrm>
-            <a:off x="4466234" y="2226564"/>
-            <a:ext cx="3432962" cy="493776"/>
+            <a:off x="4484522" y="2221992"/>
+            <a:ext cx="3396386" cy="512064"/>
           </a:xfrm>
           <a:prstGeom prst="rect">
             <a:avLst/>
@@ -4347,7 +4375,7 @@
             <a:r>
               <a:rPr sz="950" b="1">
                 <a:solidFill>
-                  <a:srgbClr val="FFFFFF"/>
+                  <a:srgbClr val="081432"/>
                 </a:solidFill>
               </a:rPr>
               <a:t>Validación y limpieza</a:t>
@@ -4357,14 +4385,14 @@
       </p:sp>
       <p:sp>
         <p:nvSpPr>
-          <p:cNvPr id="22" name="Rectangle 21"/>
+          <p:cNvPr id="23" name="Rectangle 22"/>
           <p:cNvSpPr/>
           <p:nvPr/>
         </p:nvSpPr>
         <p:spPr>
           <a:xfrm>
-            <a:off x="4466234" y="2738628"/>
-            <a:ext cx="3432962" cy="12700"/>
+            <a:off x="4466234" y="2752344"/>
+            <a:ext cx="3432962" cy="15240"/>
           </a:xfrm>
           <a:prstGeom prst="rect">
             <a:avLst/>
@@ -4400,21 +4428,21 @@
       </p:sp>
       <p:sp>
         <p:nvSpPr>
-          <p:cNvPr id="23" name="TextBox 22"/>
+          <p:cNvPr id="24" name="TextBox 23"/>
           <p:cNvSpPr txBox="1"/>
           <p:nvPr/>
         </p:nvSpPr>
         <p:spPr>
           <a:xfrm>
-            <a:off x="4466234" y="2814828"/>
-            <a:ext cx="3432962" cy="3231388"/>
+            <a:off x="4484522" y="2828544"/>
+            <a:ext cx="3414674" cy="3243072"/>
           </a:xfrm>
           <a:prstGeom prst="rect">
             <a:avLst/>
           </a:prstGeom>
           <a:noFill/>
         </p:spPr>
-        <p:txBody lIns="50800" tIns="25400" rIns="50800" bIns="25400">
+        <p:txBody lIns="50800" tIns="38100" rIns="50800" bIns="38100">
           <a:bodyPr wrap="square">
             <a:spAutoFit/>
           </a:bodyPr>
@@ -4436,7 +4464,7 @@
             <a:r>
               <a:rPr sz="750">
                 <a:solidFill>
-                  <a:srgbClr val="E4EEFF"/>
+                  <a:srgbClr val="223A6A"/>
                 </a:solidFill>
               </a:rPr>
               <a:t>Deduplicación y normalización de datos</a:t>
@@ -4459,7 +4487,7 @@
             <a:r>
               <a:rPr sz="750">
                 <a:solidFill>
-                  <a:srgbClr val="E4EEFF"/>
+                  <a:srgbClr val="223A6A"/>
                 </a:solidFill>
               </a:rPr>
               <a:t>Verificación de DNI/NIE y datos civiles</a:t>
@@ -4482,7 +4510,7 @@
             <a:r>
               <a:rPr sz="750">
                 <a:solidFill>
-                  <a:srgbClr val="E4EEFF"/>
+                  <a:srgbClr val="223A6A"/>
                 </a:solidFill>
               </a:rPr>
               <a:t>Actualización de contactos (ASNEF, GGSS)</a:t>
@@ -4505,7 +4533,7 @@
             <a:r>
               <a:rPr sz="750">
                 <a:solidFill>
-                  <a:srgbClr val="E4EEFF"/>
+                  <a:srgbClr val="223A6A"/>
                 </a:solidFill>
               </a:rPr>
               <a:t>Informe de calidad de cartera en 24 h</a:t>
@@ -4515,7 +4543,7 @@
       </p:sp>
       <p:sp>
         <p:nvSpPr>
-          <p:cNvPr id="24" name="Rectangle 23"/>
+          <p:cNvPr id="25" name="Rectangle 24"/>
           <p:cNvSpPr/>
           <p:nvPr/>
         </p:nvSpPr>
@@ -4528,11 +4556,11 @@
             <a:avLst/>
           </a:prstGeom>
           <a:solidFill>
-            <a:srgbClr val="162A68"/>
+            <a:srgbClr val="F2F7FF"/>
           </a:solidFill>
-          <a:ln w="9525">
+          <a:ln w="6350">
             <a:solidFill>
-              <a:srgbClr val="4A68B8"/>
+              <a:srgbClr val="2FDFE5"/>
             </a:solidFill>
           </a:ln>
         </p:spPr>
@@ -4560,14 +4588,14 @@
       </p:sp>
       <p:sp>
         <p:nvSpPr>
-          <p:cNvPr id="25" name="Rectangle 24"/>
+          <p:cNvPr id="26" name="Rectangle 25"/>
           <p:cNvSpPr/>
           <p:nvPr/>
         </p:nvSpPr>
         <p:spPr>
           <a:xfrm>
             <a:off x="8173516" y="1719072"/>
-            <a:ext cx="3688994" cy="38100"/>
+            <a:ext cx="3688994" cy="50800"/>
           </a:xfrm>
           <a:prstGeom prst="rect">
             <a:avLst/>
@@ -4603,14 +4631,14 @@
       </p:sp>
       <p:sp>
         <p:nvSpPr>
-          <p:cNvPr id="26" name="Oval 25"/>
+          <p:cNvPr id="27" name="Oval 26"/>
           <p:cNvSpPr/>
           <p:nvPr/>
         </p:nvSpPr>
         <p:spPr>
           <a:xfrm>
             <a:off x="8356396" y="1901952"/>
-            <a:ext cx="233172" cy="233172"/>
+            <a:ext cx="228600" cy="228600"/>
           </a:xfrm>
           <a:prstGeom prst="ellipse">
             <a:avLst/>
@@ -4648,14 +4676,14 @@
       </p:sp>
       <p:sp>
         <p:nvSpPr>
-          <p:cNvPr id="27" name="TextBox 26"/>
+          <p:cNvPr id="28" name="TextBox 27"/>
           <p:cNvSpPr txBox="1"/>
           <p:nvPr/>
         </p:nvSpPr>
         <p:spPr>
           <a:xfrm>
             <a:off x="8356396" y="1901952"/>
-            <a:ext cx="233172" cy="233172"/>
+            <a:ext cx="228600" cy="228600"/>
           </a:xfrm>
           <a:prstGeom prst="rect">
             <a:avLst/>
@@ -4682,14 +4710,14 @@
       </p:sp>
       <p:sp>
         <p:nvSpPr>
-          <p:cNvPr id="28" name="TextBox 27"/>
+          <p:cNvPr id="29" name="TextBox 28"/>
           <p:cNvSpPr txBox="1"/>
           <p:nvPr/>
         </p:nvSpPr>
         <p:spPr>
           <a:xfrm>
-            <a:off x="8301532" y="2226564"/>
-            <a:ext cx="3432962" cy="493776"/>
+            <a:off x="8319820" y="2221992"/>
+            <a:ext cx="3396386" cy="512064"/>
           </a:xfrm>
           <a:prstGeom prst="rect">
             <a:avLst/>
@@ -4706,7 +4734,7 @@
             <a:r>
               <a:rPr sz="950" b="1">
                 <a:solidFill>
-                  <a:srgbClr val="FFFFFF"/>
+                  <a:srgbClr val="081432"/>
                 </a:solidFill>
               </a:rPr>
               <a:t>Segmentación inicial</a:t>
@@ -4716,14 +4744,14 @@
       </p:sp>
       <p:sp>
         <p:nvSpPr>
-          <p:cNvPr id="29" name="Rectangle 28"/>
+          <p:cNvPr id="30" name="Rectangle 29"/>
           <p:cNvSpPr/>
           <p:nvPr/>
         </p:nvSpPr>
         <p:spPr>
           <a:xfrm>
-            <a:off x="8301532" y="2738628"/>
-            <a:ext cx="3432962" cy="12700"/>
+            <a:off x="8301532" y="2752344"/>
+            <a:ext cx="3432962" cy="15240"/>
           </a:xfrm>
           <a:prstGeom prst="rect">
             <a:avLst/>
@@ -4759,21 +4787,21 @@
       </p:sp>
       <p:sp>
         <p:nvSpPr>
-          <p:cNvPr id="30" name="TextBox 29"/>
+          <p:cNvPr id="31" name="TextBox 30"/>
           <p:cNvSpPr txBox="1"/>
           <p:nvPr/>
         </p:nvSpPr>
         <p:spPr>
           <a:xfrm>
-            <a:off x="8301532" y="2814828"/>
-            <a:ext cx="3432962" cy="3231388"/>
+            <a:off x="8319820" y="2828544"/>
+            <a:ext cx="3414674" cy="3243072"/>
           </a:xfrm>
           <a:prstGeom prst="rect">
             <a:avLst/>
           </a:prstGeom>
           <a:noFill/>
         </p:spPr>
-        <p:txBody lIns="50800" tIns="25400" rIns="50800" bIns="25400">
+        <p:txBody lIns="50800" tIns="38100" rIns="50800" bIns="38100">
           <a:bodyPr wrap="square">
             <a:spAutoFit/>
           </a:bodyPr>
@@ -4795,7 +4823,7 @@
             <a:r>
               <a:rPr sz="750">
                 <a:solidFill>
-                  <a:srgbClr val="E4EEFF"/>
+                  <a:srgbClr val="223A6A"/>
                 </a:solidFill>
               </a:rPr>
               <a:t>Clasificación por antigüedad e importe</a:t>
@@ -4818,7 +4846,7 @@
             <a:r>
               <a:rPr sz="750">
                 <a:solidFill>
-                  <a:srgbClr val="E4EEFF"/>
+                  <a:srgbClr val="223A6A"/>
                 </a:solidFill>
               </a:rPr>
               <a:t>Scoring de cobrabilidad con modelo ML</a:t>
@@ -4841,7 +4869,7 @@
             <a:r>
               <a:rPr sz="750">
                 <a:solidFill>
-                  <a:srgbClr val="E4EEFF"/>
+                  <a:srgbClr val="223A6A"/>
                 </a:solidFill>
               </a:rPr>
               <a:t>Asignación de canal de recobro óptimo</a:t>
@@ -4864,7 +4892,7 @@
             <a:r>
               <a:rPr sz="750">
                 <a:solidFill>
-                  <a:srgbClr val="E4EEFF"/>
+                  <a:srgbClr val="223A6A"/>
                 </a:solidFill>
               </a:rPr>
               <a:t>Priorización por rentabilidad esperada</a:t>
@@ -4877,8 +4905,90 @@
   <p:clrMapOvr>
     <a:masterClrMapping/>
   </p:clrMapOvr>
-  <p:transition dur="700" spd="fast">
-    <p:fade/>
+  <p:timing>
+    <p:tnLst>
+      <p:par>
+        <p:cTn id="1" dur="indefin" restart="whenNotActive" nodeType="tmRoot">
+          <p:childTnLst>
+            <p:seq concurrent="1" nextAc="seek">
+              <p:cTn id="2" dur="indefin" nodeType="mainSeq">
+                <p:childTnLst>
+                  <p:par>
+                    <p:cTn id="3" fill="hold">
+                      <p:stCondLst>
+                        <p:cond delay="0"/>
+                      </p:stCondLst>
+                      <p:childTnLst>
+                        <p:par>
+                          <p:cTn id="5" fill="hold">
+                            <p:stCondLst>
+                              <p:cond delay="0"/>
+                            </p:stCondLst>
+                            <p:childTnLst>
+                              <p:animEffect transition="in" filter="wipe(up)">
+                                <p:cBhvr>
+                                  <p:cTn id="6" dur="450" fill="hold"/>
+                                  <p:tgtEl>
+                                    <p:spTgt spid="11"/>
+                                  </p:tgtEl>
+                                </p:cBhvr>
+                              </p:animEffect>
+                            </p:childTnLst>
+                          </p:cTn>
+                        </p:par>
+                        <p:par>
+                          <p:cTn id="7" fill="hold">
+                            <p:stCondLst>
+                              <p:cond delay="160"/>
+                            </p:stCondLst>
+                            <p:childTnLst>
+                              <p:animEffect transition="in" filter="wipe(up)">
+                                <p:cBhvr>
+                                  <p:cTn id="8" dur="450" fill="hold"/>
+                                  <p:tgtEl>
+                                    <p:spTgt spid="18"/>
+                                  </p:tgtEl>
+                                </p:cBhvr>
+                              </p:animEffect>
+                            </p:childTnLst>
+                          </p:cTn>
+                        </p:par>
+                        <p:par>
+                          <p:cTn id="9" fill="hold">
+                            <p:stCondLst>
+                              <p:cond delay="320"/>
+                            </p:stCondLst>
+                            <p:childTnLst>
+                              <p:animEffect transition="in" filter="wipe(up)">
+                                <p:cBhvr>
+                                  <p:cTn id="10" dur="450" fill="hold"/>
+                                  <p:tgtEl>
+                                    <p:spTgt spid="25"/>
+                                  </p:tgtEl>
+                                </p:cBhvr>
+                              </p:animEffect>
+                            </p:childTnLst>
+                          </p:cTn>
+                        </p:par>
+                      </p:childTnLst>
+                    </p:cTn>
+                  </p:par>
+                </p:childTnLst>
+              </p:cTn>
+              <p:prevCondLst>
+                <p:cond evt="onPrevClick" delay="0"/>
+              </p:prevCondLst>
+              <p:nextCondLst>
+                <p:cond evt="onNextClick" delay="0"/>
+              </p:nextCondLst>
+            </p:seq>
+          </p:childTnLst>
+        </p:cTn>
+      </p:par>
+    </p:tnLst>
+  </p:timing>
+  <p:transition dur="500" spd="fast">
+    <p:push dir="u"/>
   </p:transition>
 </p:sld>
 </file>
@@ -4933,7 +5043,7 @@
           </a:prstGeom>
           <a:solidFill>
             <a:srgbClr val="060E24">
-              <a:alpha val="50000"/>
+              <a:alpha val="38000"/>
             </a:srgbClr>
           </a:solidFill>
           <a:ln>
@@ -4965,6 +5075,49 @@
       <p:sp>
         <p:nvSpPr>
           <p:cNvPr id="4" name="Rectangle 3"/>
+          <p:cNvSpPr/>
+          <p:nvPr/>
+        </p:nvSpPr>
+        <p:spPr>
+          <a:xfrm>
+            <a:off x="0" y="0"/>
+            <a:ext cx="12191695" cy="1664208"/>
+          </a:xfrm>
+          <a:prstGeom prst="rect">
+            <a:avLst/>
+          </a:prstGeom>
+          <a:solidFill>
+            <a:srgbClr val="0A1638"/>
+          </a:solidFill>
+          <a:ln>
+            <a:noFill/>
+          </a:ln>
+        </p:spPr>
+        <p:style>
+          <a:lnRef idx="1">
+            <a:schemeClr val="accent1"/>
+          </a:lnRef>
+          <a:fillRef idx="3">
+            <a:schemeClr val="accent1"/>
+          </a:fillRef>
+          <a:effectRef idx="2">
+            <a:schemeClr val="accent1"/>
+          </a:effectRef>
+          <a:fontRef idx="minor">
+            <a:schemeClr val="lt1"/>
+          </a:fontRef>
+        </p:style>
+        <p:txBody>
+          <a:bodyPr rtlCol="0" anchor="ctr"/>
+          <a:lstStyle/>
+          <a:p>
+            <a:pPr algn="ctr"/>
+          </a:p>
+        </p:txBody>
+      </p:sp>
+      <p:sp>
+        <p:nvSpPr>
+          <p:cNvPr id="5" name="Rectangle 4"/>
           <p:cNvSpPr/>
           <p:nvPr/>
         </p:nvSpPr>
@@ -5007,7 +5160,7 @@
       </p:sp>
       <p:sp>
         <p:nvSpPr>
-          <p:cNvPr id="5" name="Rectangle 4"/>
+          <p:cNvPr id="6" name="Rectangle 5"/>
           <p:cNvSpPr/>
           <p:nvPr/>
         </p:nvSpPr>
@@ -5050,14 +5203,14 @@
       </p:sp>
       <p:sp>
         <p:nvSpPr>
-          <p:cNvPr id="6" name="Rectangle 5"/>
+          <p:cNvPr id="7" name="Rectangle 6"/>
           <p:cNvSpPr/>
           <p:nvPr/>
         </p:nvSpPr>
         <p:spPr>
           <a:xfrm>
             <a:off x="502920" y="365760"/>
-            <a:ext cx="1417320" cy="237744"/>
+            <a:ext cx="1371600" cy="237744"/>
           </a:xfrm>
           <a:prstGeom prst="rect">
             <a:avLst/>
@@ -5101,14 +5254,14 @@
       </p:sp>
       <p:sp>
         <p:nvSpPr>
-          <p:cNvPr id="7" name="TextBox 6"/>
+          <p:cNvPr id="8" name="TextBox 7"/>
           <p:cNvSpPr txBox="1"/>
           <p:nvPr/>
         </p:nvSpPr>
         <p:spPr>
           <a:xfrm>
             <a:off x="502920" y="694944"/>
-            <a:ext cx="8229600" cy="713232"/>
+            <a:ext cx="8412480" cy="694944"/>
           </a:xfrm>
           <a:prstGeom prst="rect">
             <a:avLst/>
@@ -5143,14 +5296,14 @@
       </p:sp>
       <p:sp>
         <p:nvSpPr>
-          <p:cNvPr id="8" name="Rectangle 7"/>
+          <p:cNvPr id="9" name="Rectangle 8"/>
           <p:cNvSpPr/>
           <p:nvPr/>
         </p:nvSpPr>
         <p:spPr>
           <a:xfrm>
-            <a:off x="502920" y="1481328"/>
-            <a:ext cx="4114800" cy="31750"/>
+            <a:off x="502920" y="1463040"/>
+            <a:ext cx="4023360" cy="31750"/>
           </a:xfrm>
           <a:prstGeom prst="rect">
             <a:avLst/>
@@ -5186,7 +5339,7 @@
       </p:sp>
       <p:pic>
         <p:nvPicPr>
-          <p:cNvPr id="9" name="Picture 8" descr="logo_horiz.png"/>
+          <p:cNvPr id="10" name="Picture 9" descr="logo_horiz.png"/>
           <p:cNvPicPr>
             <a:picLocks noChangeAspect="1"/>
           </p:cNvPicPr>
@@ -5200,8 +5353,8 @@
         </p:blipFill>
         <p:spPr>
           <a:xfrm>
-            <a:off x="10116008" y="6291072"/>
-            <a:ext cx="1874519" cy="420624"/>
+            <a:off x="10161727" y="6291072"/>
+            <a:ext cx="1828800" cy="420624"/>
           </a:xfrm>
           <a:prstGeom prst="rect">
             <a:avLst/>
@@ -5210,7 +5363,7 @@
       </p:pic>
       <p:sp>
         <p:nvSpPr>
-          <p:cNvPr id="10" name="Rectangle 9"/>
+          <p:cNvPr id="11" name="Rectangle 10"/>
           <p:cNvSpPr/>
           <p:nvPr/>
         </p:nvSpPr>
@@ -5223,11 +5376,11 @@
             <a:avLst/>
           </a:prstGeom>
           <a:solidFill>
-            <a:srgbClr val="162A68"/>
+            <a:srgbClr val="F2F7FF"/>
           </a:solidFill>
-          <a:ln w="9525">
+          <a:ln w="6350">
             <a:solidFill>
-              <a:srgbClr val="4A68B8"/>
+              <a:srgbClr val="2FDFE5"/>
             </a:solidFill>
           </a:ln>
         </p:spPr>
@@ -5255,14 +5408,14 @@
       </p:sp>
       <p:sp>
         <p:nvSpPr>
-          <p:cNvPr id="11" name="Rectangle 10"/>
+          <p:cNvPr id="12" name="Rectangle 11"/>
           <p:cNvSpPr/>
           <p:nvPr/>
         </p:nvSpPr>
         <p:spPr>
           <a:xfrm>
             <a:off x="502920" y="1719072"/>
-            <a:ext cx="3688994" cy="38100"/>
+            <a:ext cx="3688994" cy="50800"/>
           </a:xfrm>
           <a:prstGeom prst="rect">
             <a:avLst/>
@@ -5298,14 +5451,14 @@
       </p:sp>
       <p:sp>
         <p:nvSpPr>
-          <p:cNvPr id="12" name="Oval 11"/>
+          <p:cNvPr id="13" name="Oval 12"/>
           <p:cNvSpPr/>
           <p:nvPr/>
         </p:nvSpPr>
         <p:spPr>
           <a:xfrm>
             <a:off x="685800" y="1901952"/>
-            <a:ext cx="233172" cy="233172"/>
+            <a:ext cx="228600" cy="228600"/>
           </a:xfrm>
           <a:prstGeom prst="ellipse">
             <a:avLst/>
@@ -5343,14 +5496,14 @@
       </p:sp>
       <p:sp>
         <p:nvSpPr>
-          <p:cNvPr id="13" name="TextBox 12"/>
+          <p:cNvPr id="14" name="TextBox 13"/>
           <p:cNvSpPr txBox="1"/>
           <p:nvPr/>
         </p:nvSpPr>
         <p:spPr>
           <a:xfrm>
             <a:off x="685800" y="1901952"/>
-            <a:ext cx="233172" cy="233172"/>
+            <a:ext cx="228600" cy="228600"/>
           </a:xfrm>
           <a:prstGeom prst="rect">
             <a:avLst/>
@@ -5377,14 +5530,14 @@
       </p:sp>
       <p:sp>
         <p:nvSpPr>
-          <p:cNvPr id="14" name="TextBox 13"/>
+          <p:cNvPr id="15" name="TextBox 14"/>
           <p:cNvSpPr txBox="1"/>
           <p:nvPr/>
         </p:nvSpPr>
         <p:spPr>
           <a:xfrm>
-            <a:off x="630936" y="2226564"/>
-            <a:ext cx="3432962" cy="493776"/>
+            <a:off x="649224" y="2221992"/>
+            <a:ext cx="3396386" cy="512064"/>
           </a:xfrm>
           <a:prstGeom prst="rect">
             <a:avLst/>
@@ -5401,7 +5554,7 @@
             <a:r>
               <a:rPr sz="950" b="1">
                 <a:solidFill>
-                  <a:srgbClr val="FFFFFF"/>
+                  <a:srgbClr val="081432"/>
                 </a:solidFill>
               </a:rPr>
               <a:t>Contactación multicanal</a:t>
@@ -5411,14 +5564,14 @@
       </p:sp>
       <p:sp>
         <p:nvSpPr>
-          <p:cNvPr id="15" name="Rectangle 14"/>
+          <p:cNvPr id="16" name="Rectangle 15"/>
           <p:cNvSpPr/>
           <p:nvPr/>
         </p:nvSpPr>
         <p:spPr>
           <a:xfrm>
-            <a:off x="630936" y="2738628"/>
-            <a:ext cx="3432962" cy="12700"/>
+            <a:off x="630936" y="2752344"/>
+            <a:ext cx="3432962" cy="15240"/>
           </a:xfrm>
           <a:prstGeom prst="rect">
             <a:avLst/>
@@ -5454,21 +5607,21 @@
       </p:sp>
       <p:sp>
         <p:nvSpPr>
-          <p:cNvPr id="16" name="TextBox 15"/>
+          <p:cNvPr id="17" name="TextBox 16"/>
           <p:cNvSpPr txBox="1"/>
           <p:nvPr/>
         </p:nvSpPr>
         <p:spPr>
           <a:xfrm>
-            <a:off x="630936" y="2814828"/>
-            <a:ext cx="3432962" cy="3231388"/>
+            <a:off x="649224" y="2828544"/>
+            <a:ext cx="3414674" cy="3243072"/>
           </a:xfrm>
           <a:prstGeom prst="rect">
             <a:avLst/>
           </a:prstGeom>
           <a:noFill/>
         </p:spPr>
-        <p:txBody lIns="50800" tIns="25400" rIns="50800" bIns="25400">
+        <p:txBody lIns="50800" tIns="38100" rIns="50800" bIns="38100">
           <a:bodyPr wrap="square">
             <a:spAutoFit/>
           </a:bodyPr>
@@ -5490,7 +5643,7 @@
             <a:r>
               <a:rPr sz="750">
                 <a:solidFill>
-                  <a:srgbClr val="E4EEFF"/>
+                  <a:srgbClr val="223A6A"/>
                 </a:solidFill>
               </a:rPr>
               <a:t>Llamadas outbound con IVR especializado</a:t>
@@ -5513,7 +5666,7 @@
             <a:r>
               <a:rPr sz="750">
                 <a:solidFill>
-                  <a:srgbClr val="E4EEFF"/>
+                  <a:srgbClr val="223A6A"/>
                 </a:solidFill>
               </a:rPr>
               <a:t>SMS, email y WhatsApp Business certificado</a:t>
@@ -5536,7 +5689,7 @@
             <a:r>
               <a:rPr sz="750">
                 <a:solidFill>
-                  <a:srgbClr val="E4EEFF"/>
+                  <a:srgbClr val="223A6A"/>
                 </a:solidFill>
               </a:rPr>
               <a:t>Cartas físicas certificadas cuando procede</a:t>
@@ -5559,7 +5712,7 @@
             <a:r>
               <a:rPr sz="750">
                 <a:solidFill>
-                  <a:srgbClr val="E4EEFF"/>
+                  <a:srgbClr val="223A6A"/>
                 </a:solidFill>
               </a:rPr>
               <a:t>Ventana de contacto 8:00-22:00, L-S</a:t>
@@ -5569,7 +5722,7 @@
       </p:sp>
       <p:sp>
         <p:nvSpPr>
-          <p:cNvPr id="17" name="Rectangle 16"/>
+          <p:cNvPr id="18" name="Rectangle 17"/>
           <p:cNvSpPr/>
           <p:nvPr/>
         </p:nvSpPr>
@@ -5582,11 +5735,11 @@
             <a:avLst/>
           </a:prstGeom>
           <a:solidFill>
-            <a:srgbClr val="162A68"/>
+            <a:srgbClr val="F2F7FF"/>
           </a:solidFill>
-          <a:ln w="9525">
+          <a:ln w="6350">
             <a:solidFill>
-              <a:srgbClr val="4A68B8"/>
+              <a:srgbClr val="2FDFE5"/>
             </a:solidFill>
           </a:ln>
         </p:spPr>
@@ -5614,14 +5767,14 @@
       </p:sp>
       <p:sp>
         <p:nvSpPr>
-          <p:cNvPr id="18" name="Rectangle 17"/>
+          <p:cNvPr id="19" name="Rectangle 18"/>
           <p:cNvSpPr/>
           <p:nvPr/>
         </p:nvSpPr>
         <p:spPr>
           <a:xfrm>
             <a:off x="4338218" y="1719072"/>
-            <a:ext cx="3688994" cy="38100"/>
+            <a:ext cx="3688994" cy="50800"/>
           </a:xfrm>
           <a:prstGeom prst="rect">
             <a:avLst/>
@@ -5657,14 +5810,14 @@
       </p:sp>
       <p:sp>
         <p:nvSpPr>
-          <p:cNvPr id="19" name="Oval 18"/>
+          <p:cNvPr id="20" name="Oval 19"/>
           <p:cNvSpPr/>
           <p:nvPr/>
         </p:nvSpPr>
         <p:spPr>
           <a:xfrm>
             <a:off x="4521098" y="1901952"/>
-            <a:ext cx="233172" cy="233172"/>
+            <a:ext cx="228600" cy="228600"/>
           </a:xfrm>
           <a:prstGeom prst="ellipse">
             <a:avLst/>
@@ -5702,14 +5855,14 @@
       </p:sp>
       <p:sp>
         <p:nvSpPr>
-          <p:cNvPr id="20" name="TextBox 19"/>
+          <p:cNvPr id="21" name="TextBox 20"/>
           <p:cNvSpPr txBox="1"/>
           <p:nvPr/>
         </p:nvSpPr>
         <p:spPr>
           <a:xfrm>
             <a:off x="4521098" y="1901952"/>
-            <a:ext cx="233172" cy="233172"/>
+            <a:ext cx="228600" cy="228600"/>
           </a:xfrm>
           <a:prstGeom prst="rect">
             <a:avLst/>
@@ -5736,14 +5889,14 @@
       </p:sp>
       <p:sp>
         <p:nvSpPr>
-          <p:cNvPr id="21" name="TextBox 20"/>
+          <p:cNvPr id="22" name="TextBox 21"/>
           <p:cNvSpPr txBox="1"/>
           <p:nvPr/>
         </p:nvSpPr>
         <p:spPr>
           <a:xfrm>
-            <a:off x="4466234" y="2226564"/>
-            <a:ext cx="3432962" cy="493776"/>
+            <a:off x="4484522" y="2221992"/>
+            <a:ext cx="3396386" cy="512064"/>
           </a:xfrm>
           <a:prstGeom prst="rect">
             <a:avLst/>
@@ -5760,7 +5913,7 @@
             <a:r>
               <a:rPr sz="950" b="1">
                 <a:solidFill>
-                  <a:srgbClr val="FFFFFF"/>
+                  <a:srgbClr val="081432"/>
                 </a:solidFill>
               </a:rPr>
               <a:t>Negociación de acuerdos</a:t>
@@ -5770,14 +5923,14 @@
       </p:sp>
       <p:sp>
         <p:nvSpPr>
-          <p:cNvPr id="22" name="Rectangle 21"/>
+          <p:cNvPr id="23" name="Rectangle 22"/>
           <p:cNvSpPr/>
           <p:nvPr/>
         </p:nvSpPr>
         <p:spPr>
           <a:xfrm>
-            <a:off x="4466234" y="2738628"/>
-            <a:ext cx="3432962" cy="12700"/>
+            <a:off x="4466234" y="2752344"/>
+            <a:ext cx="3432962" cy="15240"/>
           </a:xfrm>
           <a:prstGeom prst="rect">
             <a:avLst/>
@@ -5813,21 +5966,21 @@
       </p:sp>
       <p:sp>
         <p:nvSpPr>
-          <p:cNvPr id="23" name="TextBox 22"/>
+          <p:cNvPr id="24" name="TextBox 23"/>
           <p:cNvSpPr txBox="1"/>
           <p:nvPr/>
         </p:nvSpPr>
         <p:spPr>
           <a:xfrm>
-            <a:off x="4466234" y="2814828"/>
-            <a:ext cx="3432962" cy="3231388"/>
+            <a:off x="4484522" y="2828544"/>
+            <a:ext cx="3414674" cy="3243072"/>
           </a:xfrm>
           <a:prstGeom prst="rect">
             <a:avLst/>
           </a:prstGeom>
           <a:noFill/>
         </p:spPr>
-        <p:txBody lIns="50800" tIns="25400" rIns="50800" bIns="25400">
+        <p:txBody lIns="50800" tIns="38100" rIns="50800" bIns="38100">
           <a:bodyPr wrap="square">
             <a:spAutoFit/>
           </a:bodyPr>
@@ -5849,7 +6002,7 @@
             <a:r>
               <a:rPr sz="750">
                 <a:solidFill>
-                  <a:srgbClr val="E4EEFF"/>
+                  <a:srgbClr val="223A6A"/>
                 </a:solidFill>
               </a:rPr>
               <a:t>Quitas y daciones dentro de límites pactados</a:t>
@@ -5872,7 +6025,7 @@
             <a:r>
               <a:rPr sz="750">
                 <a:solidFill>
-                  <a:srgbClr val="E4EEFF"/>
+                  <a:srgbClr val="223A6A"/>
                 </a:solidFill>
               </a:rPr>
               <a:t>Planes de pago de 3 a 48 meses</a:t>
@@ -5895,7 +6048,7 @@
             <a:r>
               <a:rPr sz="750">
                 <a:solidFill>
-                  <a:srgbClr val="E4EEFF"/>
+                  <a:srgbClr val="223A6A"/>
                 </a:solidFill>
               </a:rPr>
               <a:t>Firma de acuerdos digitales con validez legal</a:t>
@@ -5918,7 +6071,7 @@
             <a:r>
               <a:rPr sz="750">
                 <a:solidFill>
-                  <a:srgbClr val="E4EEFF"/>
+                  <a:srgbClr val="223A6A"/>
                 </a:solidFill>
               </a:rPr>
               <a:t>Grabación de llamadas como respaldo</a:t>
@@ -5928,7 +6081,7 @@
       </p:sp>
       <p:sp>
         <p:nvSpPr>
-          <p:cNvPr id="24" name="Rectangle 23"/>
+          <p:cNvPr id="25" name="Rectangle 24"/>
           <p:cNvSpPr/>
           <p:nvPr/>
         </p:nvSpPr>
@@ -5941,11 +6094,11 @@
             <a:avLst/>
           </a:prstGeom>
           <a:solidFill>
-            <a:srgbClr val="162A68"/>
+            <a:srgbClr val="F2F7FF"/>
           </a:solidFill>
-          <a:ln w="9525">
+          <a:ln w="6350">
             <a:solidFill>
-              <a:srgbClr val="4A68B8"/>
+              <a:srgbClr val="2FDFE5"/>
             </a:solidFill>
           </a:ln>
         </p:spPr>
@@ -5973,14 +6126,14 @@
       </p:sp>
       <p:sp>
         <p:nvSpPr>
-          <p:cNvPr id="25" name="Rectangle 24"/>
+          <p:cNvPr id="26" name="Rectangle 25"/>
           <p:cNvSpPr/>
           <p:nvPr/>
         </p:nvSpPr>
         <p:spPr>
           <a:xfrm>
             <a:off x="8173516" y="1719072"/>
-            <a:ext cx="3688994" cy="38100"/>
+            <a:ext cx="3688994" cy="50800"/>
           </a:xfrm>
           <a:prstGeom prst="rect">
             <a:avLst/>
@@ -6016,14 +6169,14 @@
       </p:sp>
       <p:sp>
         <p:nvSpPr>
-          <p:cNvPr id="26" name="Oval 25"/>
+          <p:cNvPr id="27" name="Oval 26"/>
           <p:cNvSpPr/>
           <p:nvPr/>
         </p:nvSpPr>
         <p:spPr>
           <a:xfrm>
             <a:off x="8356396" y="1901952"/>
-            <a:ext cx="233172" cy="233172"/>
+            <a:ext cx="228600" cy="228600"/>
           </a:xfrm>
           <a:prstGeom prst="ellipse">
             <a:avLst/>
@@ -6061,14 +6214,14 @@
       </p:sp>
       <p:sp>
         <p:nvSpPr>
-          <p:cNvPr id="27" name="TextBox 26"/>
+          <p:cNvPr id="28" name="TextBox 27"/>
           <p:cNvSpPr txBox="1"/>
           <p:nvPr/>
         </p:nvSpPr>
         <p:spPr>
           <a:xfrm>
             <a:off x="8356396" y="1901952"/>
-            <a:ext cx="233172" cy="233172"/>
+            <a:ext cx="228600" cy="228600"/>
           </a:xfrm>
           <a:prstGeom prst="rect">
             <a:avLst/>
@@ -6095,14 +6248,14 @@
       </p:sp>
       <p:sp>
         <p:nvSpPr>
-          <p:cNvPr id="28" name="TextBox 27"/>
+          <p:cNvPr id="29" name="TextBox 28"/>
           <p:cNvSpPr txBox="1"/>
           <p:nvPr/>
         </p:nvSpPr>
         <p:spPr>
           <a:xfrm>
-            <a:off x="8301532" y="2226564"/>
-            <a:ext cx="3432962" cy="493776"/>
+            <a:off x="8319820" y="2221992"/>
+            <a:ext cx="3396386" cy="512064"/>
           </a:xfrm>
           <a:prstGeom prst="rect">
             <a:avLst/>
@@ -6119,7 +6272,7 @@
             <a:r>
               <a:rPr sz="950" b="1">
                 <a:solidFill>
-                  <a:srgbClr val="FFFFFF"/>
+                  <a:srgbClr val="081432"/>
                 </a:solidFill>
               </a:rPr>
               <a:t>Seguimiento y cobro</a:t>
@@ -6129,14 +6282,14 @@
       </p:sp>
       <p:sp>
         <p:nvSpPr>
-          <p:cNvPr id="29" name="Rectangle 28"/>
+          <p:cNvPr id="30" name="Rectangle 29"/>
           <p:cNvSpPr/>
           <p:nvPr/>
         </p:nvSpPr>
         <p:spPr>
           <a:xfrm>
-            <a:off x="8301532" y="2738628"/>
-            <a:ext cx="3432962" cy="12700"/>
+            <a:off x="8301532" y="2752344"/>
+            <a:ext cx="3432962" cy="15240"/>
           </a:xfrm>
           <a:prstGeom prst="rect">
             <a:avLst/>
@@ -6172,21 +6325,21 @@
       </p:sp>
       <p:sp>
         <p:nvSpPr>
-          <p:cNvPr id="30" name="TextBox 29"/>
+          <p:cNvPr id="31" name="TextBox 30"/>
           <p:cNvSpPr txBox="1"/>
           <p:nvPr/>
         </p:nvSpPr>
         <p:spPr>
           <a:xfrm>
-            <a:off x="8301532" y="2814828"/>
-            <a:ext cx="3432962" cy="3231388"/>
+            <a:off x="8319820" y="2828544"/>
+            <a:ext cx="3414674" cy="3243072"/>
           </a:xfrm>
           <a:prstGeom prst="rect">
             <a:avLst/>
           </a:prstGeom>
           <a:noFill/>
         </p:spPr>
-        <p:txBody lIns="50800" tIns="25400" rIns="50800" bIns="25400">
+        <p:txBody lIns="50800" tIns="38100" rIns="50800" bIns="38100">
           <a:bodyPr wrap="square">
             <a:spAutoFit/>
           </a:bodyPr>
@@ -6208,7 +6361,7 @@
             <a:r>
               <a:rPr sz="750">
                 <a:solidFill>
-                  <a:srgbClr val="E4EEFF"/>
+                  <a:srgbClr val="223A6A"/>
                 </a:solidFill>
               </a:rPr>
               <a:t>Domiciliación SEPA y pasarela de pago online</a:t>
@@ -6231,7 +6384,7 @@
             <a:r>
               <a:rPr sz="750">
                 <a:solidFill>
-                  <a:srgbClr val="E4EEFF"/>
+                  <a:srgbClr val="223A6A"/>
                 </a:solidFill>
               </a:rPr>
               <a:t>Recordatorios automáticos de vencimientos</a:t>
@@ -6254,7 +6407,7 @@
             <a:r>
               <a:rPr sz="750">
                 <a:solidFill>
-                  <a:srgbClr val="E4EEFF"/>
+                  <a:srgbClr val="223A6A"/>
                 </a:solidFill>
               </a:rPr>
               <a:t>Renegociación ante impagos parciales</a:t>
@@ -6277,7 +6430,7 @@
             <a:r>
               <a:rPr sz="750">
                 <a:solidFill>
-                  <a:srgbClr val="E4EEFF"/>
+                  <a:srgbClr val="223A6A"/>
                 </a:solidFill>
               </a:rPr>
               <a:t>Dashboard de seguimiento en tiempo real</a:t>
@@ -6290,8 +6443,90 @@
   <p:clrMapOvr>
     <a:masterClrMapping/>
   </p:clrMapOvr>
-  <p:transition dur="700" spd="fast">
-    <p:fade/>
+  <p:timing>
+    <p:tnLst>
+      <p:par>
+        <p:cTn id="1" dur="indefin" restart="whenNotActive" nodeType="tmRoot">
+          <p:childTnLst>
+            <p:seq concurrent="1" nextAc="seek">
+              <p:cTn id="2" dur="indefin" nodeType="mainSeq">
+                <p:childTnLst>
+                  <p:par>
+                    <p:cTn id="3" fill="hold">
+                      <p:stCondLst>
+                        <p:cond delay="0"/>
+                      </p:stCondLst>
+                      <p:childTnLst>
+                        <p:par>
+                          <p:cTn id="5" fill="hold">
+                            <p:stCondLst>
+                              <p:cond delay="0"/>
+                            </p:stCondLst>
+                            <p:childTnLst>
+                              <p:animEffect transition="in" filter="wipe(up)">
+                                <p:cBhvr>
+                                  <p:cTn id="6" dur="450" fill="hold"/>
+                                  <p:tgtEl>
+                                    <p:spTgt spid="11"/>
+                                  </p:tgtEl>
+                                </p:cBhvr>
+                              </p:animEffect>
+                            </p:childTnLst>
+                          </p:cTn>
+                        </p:par>
+                        <p:par>
+                          <p:cTn id="7" fill="hold">
+                            <p:stCondLst>
+                              <p:cond delay="160"/>
+                            </p:stCondLst>
+                            <p:childTnLst>
+                              <p:animEffect transition="in" filter="wipe(up)">
+                                <p:cBhvr>
+                                  <p:cTn id="8" dur="450" fill="hold"/>
+                                  <p:tgtEl>
+                                    <p:spTgt spid="18"/>
+                                  </p:tgtEl>
+                                </p:cBhvr>
+                              </p:animEffect>
+                            </p:childTnLst>
+                          </p:cTn>
+                        </p:par>
+                        <p:par>
+                          <p:cTn id="9" fill="hold">
+                            <p:stCondLst>
+                              <p:cond delay="320"/>
+                            </p:stCondLst>
+                            <p:childTnLst>
+                              <p:animEffect transition="in" filter="wipe(up)">
+                                <p:cBhvr>
+                                  <p:cTn id="10" dur="450" fill="hold"/>
+                                  <p:tgtEl>
+                                    <p:spTgt spid="25"/>
+                                  </p:tgtEl>
+                                </p:cBhvr>
+                              </p:animEffect>
+                            </p:childTnLst>
+                          </p:cTn>
+                        </p:par>
+                      </p:childTnLst>
+                    </p:cTn>
+                  </p:par>
+                </p:childTnLst>
+              </p:cTn>
+              <p:prevCondLst>
+                <p:cond evt="onPrevClick" delay="0"/>
+              </p:prevCondLst>
+              <p:nextCondLst>
+                <p:cond evt="onNextClick" delay="0"/>
+              </p:nextCondLst>
+            </p:seq>
+          </p:childTnLst>
+        </p:cTn>
+      </p:par>
+    </p:tnLst>
+  </p:timing>
+  <p:transition dur="500" spd="fast">
+    <p:push dir="u"/>
   </p:transition>
 </p:sld>
 </file>
@@ -6346,7 +6581,7 @@
           </a:prstGeom>
           <a:solidFill>
             <a:srgbClr val="060E24">
-              <a:alpha val="50000"/>
+              <a:alpha val="38000"/>
             </a:srgbClr>
           </a:solidFill>
           <a:ln>
@@ -6378,6 +6613,49 @@
       <p:sp>
         <p:nvSpPr>
           <p:cNvPr id="4" name="Rectangle 3"/>
+          <p:cNvSpPr/>
+          <p:nvPr/>
+        </p:nvSpPr>
+        <p:spPr>
+          <a:xfrm>
+            <a:off x="0" y="0"/>
+            <a:ext cx="12191695" cy="1664208"/>
+          </a:xfrm>
+          <a:prstGeom prst="rect">
+            <a:avLst/>
+          </a:prstGeom>
+          <a:solidFill>
+            <a:srgbClr val="0A1638"/>
+          </a:solidFill>
+          <a:ln>
+            <a:noFill/>
+          </a:ln>
+        </p:spPr>
+        <p:style>
+          <a:lnRef idx="1">
+            <a:schemeClr val="accent1"/>
+          </a:lnRef>
+          <a:fillRef idx="3">
+            <a:schemeClr val="accent1"/>
+          </a:fillRef>
+          <a:effectRef idx="2">
+            <a:schemeClr val="accent1"/>
+          </a:effectRef>
+          <a:fontRef idx="minor">
+            <a:schemeClr val="lt1"/>
+          </a:fontRef>
+        </p:style>
+        <p:txBody>
+          <a:bodyPr rtlCol="0" anchor="ctr"/>
+          <a:lstStyle/>
+          <a:p>
+            <a:pPr algn="ctr"/>
+          </a:p>
+        </p:txBody>
+      </p:sp>
+      <p:sp>
+        <p:nvSpPr>
+          <p:cNvPr id="5" name="Rectangle 4"/>
           <p:cNvSpPr/>
           <p:nvPr/>
         </p:nvSpPr>
@@ -6420,7 +6698,7 @@
       </p:sp>
       <p:sp>
         <p:nvSpPr>
-          <p:cNvPr id="5" name="Rectangle 4"/>
+          <p:cNvPr id="6" name="Rectangle 5"/>
           <p:cNvSpPr/>
           <p:nvPr/>
         </p:nvSpPr>
@@ -6463,14 +6741,14 @@
       </p:sp>
       <p:sp>
         <p:nvSpPr>
-          <p:cNvPr id="6" name="Rectangle 5"/>
+          <p:cNvPr id="7" name="Rectangle 6"/>
           <p:cNvSpPr/>
           <p:nvPr/>
         </p:nvSpPr>
         <p:spPr>
           <a:xfrm>
             <a:off x="502920" y="365760"/>
-            <a:ext cx="1417320" cy="237744"/>
+            <a:ext cx="1371600" cy="237744"/>
           </a:xfrm>
           <a:prstGeom prst="rect">
             <a:avLst/>
@@ -6514,14 +6792,14 @@
       </p:sp>
       <p:sp>
         <p:nvSpPr>
-          <p:cNvPr id="7" name="TextBox 6"/>
+          <p:cNvPr id="8" name="TextBox 7"/>
           <p:cNvSpPr txBox="1"/>
           <p:nvPr/>
         </p:nvSpPr>
         <p:spPr>
           <a:xfrm>
             <a:off x="502920" y="694944"/>
-            <a:ext cx="8229600" cy="713232"/>
+            <a:ext cx="8412480" cy="694944"/>
           </a:xfrm>
           <a:prstGeom prst="rect">
             <a:avLst/>
@@ -6556,14 +6834,14 @@
       </p:sp>
       <p:sp>
         <p:nvSpPr>
-          <p:cNvPr id="8" name="Rectangle 7"/>
+          <p:cNvPr id="9" name="Rectangle 8"/>
           <p:cNvSpPr/>
           <p:nvPr/>
         </p:nvSpPr>
         <p:spPr>
           <a:xfrm>
-            <a:off x="502920" y="1481328"/>
-            <a:ext cx="4114800" cy="31750"/>
+            <a:off x="502920" y="1463040"/>
+            <a:ext cx="4023360" cy="31750"/>
           </a:xfrm>
           <a:prstGeom prst="rect">
             <a:avLst/>
@@ -6599,7 +6877,7 @@
       </p:sp>
       <p:pic>
         <p:nvPicPr>
-          <p:cNvPr id="9" name="Picture 8" descr="logo_horiz.png"/>
+          <p:cNvPr id="10" name="Picture 9" descr="logo_horiz.png"/>
           <p:cNvPicPr>
             <a:picLocks noChangeAspect="1"/>
           </p:cNvPicPr>
@@ -6613,8 +6891,8 @@
         </p:blipFill>
         <p:spPr>
           <a:xfrm>
-            <a:off x="10116008" y="6291072"/>
-            <a:ext cx="1874519" cy="420624"/>
+            <a:off x="10161727" y="6291072"/>
+            <a:ext cx="1828800" cy="420624"/>
           </a:xfrm>
           <a:prstGeom prst="rect">
             <a:avLst/>
@@ -6623,7 +6901,7 @@
       </p:pic>
       <p:sp>
         <p:nvSpPr>
-          <p:cNvPr id="10" name="Rectangle 9"/>
+          <p:cNvPr id="11" name="Rectangle 10"/>
           <p:cNvSpPr/>
           <p:nvPr/>
         </p:nvSpPr>
@@ -6636,11 +6914,11 @@
             <a:avLst/>
           </a:prstGeom>
           <a:solidFill>
-            <a:srgbClr val="162A68"/>
+            <a:srgbClr val="F2F7FF"/>
           </a:solidFill>
-          <a:ln w="9525">
+          <a:ln w="6350">
             <a:solidFill>
-              <a:srgbClr val="4A68B8"/>
+              <a:srgbClr val="2FDFE5"/>
             </a:solidFill>
           </a:ln>
         </p:spPr>
@@ -6668,14 +6946,14 @@
       </p:sp>
       <p:sp>
         <p:nvSpPr>
-          <p:cNvPr id="11" name="Rectangle 10"/>
+          <p:cNvPr id="12" name="Rectangle 11"/>
           <p:cNvSpPr/>
           <p:nvPr/>
         </p:nvSpPr>
         <p:spPr>
           <a:xfrm>
             <a:off x="502920" y="1719072"/>
-            <a:ext cx="3688994" cy="38100"/>
+            <a:ext cx="3688994" cy="50800"/>
           </a:xfrm>
           <a:prstGeom prst="rect">
             <a:avLst/>
@@ -6711,14 +6989,14 @@
       </p:sp>
       <p:sp>
         <p:nvSpPr>
-          <p:cNvPr id="12" name="Oval 11"/>
+          <p:cNvPr id="13" name="Oval 12"/>
           <p:cNvSpPr/>
           <p:nvPr/>
         </p:nvSpPr>
         <p:spPr>
           <a:xfrm>
             <a:off x="685800" y="1901952"/>
-            <a:ext cx="233172" cy="233172"/>
+            <a:ext cx="228600" cy="228600"/>
           </a:xfrm>
           <a:prstGeom prst="ellipse">
             <a:avLst/>
@@ -6756,14 +7034,14 @@
       </p:sp>
       <p:sp>
         <p:nvSpPr>
-          <p:cNvPr id="13" name="TextBox 12"/>
+          <p:cNvPr id="14" name="TextBox 13"/>
           <p:cNvSpPr txBox="1"/>
           <p:nvPr/>
         </p:nvSpPr>
         <p:spPr>
           <a:xfrm>
             <a:off x="685800" y="1901952"/>
-            <a:ext cx="233172" cy="233172"/>
+            <a:ext cx="228600" cy="228600"/>
           </a:xfrm>
           <a:prstGeom prst="rect">
             <a:avLst/>
@@ -6790,14 +7068,14 @@
       </p:sp>
       <p:sp>
         <p:nvSpPr>
-          <p:cNvPr id="14" name="TextBox 13"/>
+          <p:cNvPr id="15" name="TextBox 14"/>
           <p:cNvSpPr txBox="1"/>
           <p:nvPr/>
         </p:nvSpPr>
         <p:spPr>
           <a:xfrm>
-            <a:off x="630936" y="2226564"/>
-            <a:ext cx="3432962" cy="493776"/>
+            <a:off x="649224" y="2221992"/>
+            <a:ext cx="3396386" cy="512064"/>
           </a:xfrm>
           <a:prstGeom prst="rect">
             <a:avLst/>
@@ -6814,7 +7092,7 @@
             <a:r>
               <a:rPr sz="950" b="1">
                 <a:solidFill>
-                  <a:srgbClr val="FFFFFF"/>
+                  <a:srgbClr val="081432"/>
                 </a:solidFill>
               </a:rPr>
               <a:t>Análisis de viabilidad</a:t>
@@ -6824,14 +7102,14 @@
       </p:sp>
       <p:sp>
         <p:nvSpPr>
-          <p:cNvPr id="15" name="Rectangle 14"/>
+          <p:cNvPr id="16" name="Rectangle 15"/>
           <p:cNvSpPr/>
           <p:nvPr/>
         </p:nvSpPr>
         <p:spPr>
           <a:xfrm>
-            <a:off x="630936" y="2738628"/>
-            <a:ext cx="3432962" cy="12700"/>
+            <a:off x="630936" y="2752344"/>
+            <a:ext cx="3432962" cy="15240"/>
           </a:xfrm>
           <a:prstGeom prst="rect">
             <a:avLst/>
@@ -6867,21 +7145,21 @@
       </p:sp>
       <p:sp>
         <p:nvSpPr>
-          <p:cNvPr id="16" name="TextBox 15"/>
+          <p:cNvPr id="17" name="TextBox 16"/>
           <p:cNvSpPr txBox="1"/>
           <p:nvPr/>
         </p:nvSpPr>
         <p:spPr>
           <a:xfrm>
-            <a:off x="630936" y="2814828"/>
-            <a:ext cx="3432962" cy="3231388"/>
+            <a:off x="649224" y="2828544"/>
+            <a:ext cx="3414674" cy="3243072"/>
           </a:xfrm>
           <a:prstGeom prst="rect">
             <a:avLst/>
           </a:prstGeom>
           <a:noFill/>
         </p:spPr>
-        <p:txBody lIns="50800" tIns="25400" rIns="50800" bIns="25400">
+        <p:txBody lIns="50800" tIns="38100" rIns="50800" bIns="38100">
           <a:bodyPr wrap="square">
             <a:spAutoFit/>
           </a:bodyPr>
@@ -6903,7 +7181,7 @@
             <a:r>
               <a:rPr sz="750">
                 <a:solidFill>
-                  <a:srgbClr val="E4EEFF"/>
+                  <a:srgbClr val="223A6A"/>
                 </a:solidFill>
               </a:rPr>
               <a:t>Revisión de prescripción y documentación</a:t>
@@ -6926,7 +7204,7 @@
             <a:r>
               <a:rPr sz="750">
                 <a:solidFill>
-                  <a:srgbClr val="E4EEFF"/>
+                  <a:srgbClr val="223A6A"/>
                 </a:solidFill>
               </a:rPr>
               <a:t>Estudio de solvencia y localización de bienes</a:t>
@@ -6949,7 +7227,7 @@
             <a:r>
               <a:rPr sz="750">
                 <a:solidFill>
-                  <a:srgbClr val="E4EEFF"/>
+                  <a:srgbClr val="223A6A"/>
                 </a:solidFill>
               </a:rPr>
               <a:t>Valoración coste-beneficio por expediente</a:t>
@@ -6972,7 +7250,7 @@
             <a:r>
               <a:rPr sz="750">
                 <a:solidFill>
-                  <a:srgbClr val="E4EEFF"/>
+                  <a:srgbClr val="223A6A"/>
                 </a:solidFill>
               </a:rPr>
               <a:t>Decisión de elevación judicial en 48-72 h</a:t>
@@ -6982,7 +7260,7 @@
       </p:sp>
       <p:sp>
         <p:nvSpPr>
-          <p:cNvPr id="17" name="Rectangle 16"/>
+          <p:cNvPr id="18" name="Rectangle 17"/>
           <p:cNvSpPr/>
           <p:nvPr/>
         </p:nvSpPr>
@@ -6995,11 +7273,11 @@
             <a:avLst/>
           </a:prstGeom>
           <a:solidFill>
-            <a:srgbClr val="162A68"/>
+            <a:srgbClr val="F2F7FF"/>
           </a:solidFill>
-          <a:ln w="9525">
+          <a:ln w="6350">
             <a:solidFill>
-              <a:srgbClr val="4A68B8"/>
+              <a:srgbClr val="2FDFE5"/>
             </a:solidFill>
           </a:ln>
         </p:spPr>
@@ -7027,14 +7305,14 @@
       </p:sp>
       <p:sp>
         <p:nvSpPr>
-          <p:cNvPr id="18" name="Rectangle 17"/>
+          <p:cNvPr id="19" name="Rectangle 18"/>
           <p:cNvSpPr/>
           <p:nvPr/>
         </p:nvSpPr>
         <p:spPr>
           <a:xfrm>
             <a:off x="4338218" y="1719072"/>
-            <a:ext cx="3688994" cy="38100"/>
+            <a:ext cx="3688994" cy="50800"/>
           </a:xfrm>
           <a:prstGeom prst="rect">
             <a:avLst/>
@@ -7070,14 +7348,14 @@
       </p:sp>
       <p:sp>
         <p:nvSpPr>
-          <p:cNvPr id="19" name="Oval 18"/>
+          <p:cNvPr id="20" name="Oval 19"/>
           <p:cNvSpPr/>
           <p:nvPr/>
         </p:nvSpPr>
         <p:spPr>
           <a:xfrm>
             <a:off x="4521098" y="1901952"/>
-            <a:ext cx="233172" cy="233172"/>
+            <a:ext cx="228600" cy="228600"/>
           </a:xfrm>
           <a:prstGeom prst="ellipse">
             <a:avLst/>
@@ -7115,14 +7393,14 @@
       </p:sp>
       <p:sp>
         <p:nvSpPr>
-          <p:cNvPr id="20" name="TextBox 19"/>
+          <p:cNvPr id="21" name="TextBox 20"/>
           <p:cNvSpPr txBox="1"/>
           <p:nvPr/>
         </p:nvSpPr>
         <p:spPr>
           <a:xfrm>
             <a:off x="4521098" y="1901952"/>
-            <a:ext cx="233172" cy="233172"/>
+            <a:ext cx="228600" cy="228600"/>
           </a:xfrm>
           <a:prstGeom prst="rect">
             <a:avLst/>
@@ -7149,14 +7427,14 @@
       </p:sp>
       <p:sp>
         <p:nvSpPr>
-          <p:cNvPr id="21" name="TextBox 20"/>
+          <p:cNvPr id="22" name="TextBox 21"/>
           <p:cNvSpPr txBox="1"/>
           <p:nvPr/>
         </p:nvSpPr>
         <p:spPr>
           <a:xfrm>
-            <a:off x="4466234" y="2226564"/>
-            <a:ext cx="3432962" cy="493776"/>
+            <a:off x="4484522" y="2221992"/>
+            <a:ext cx="3396386" cy="512064"/>
           </a:xfrm>
           <a:prstGeom prst="rect">
             <a:avLst/>
@@ -7173,7 +7451,7 @@
             <a:r>
               <a:rPr sz="950" b="1">
                 <a:solidFill>
-                  <a:srgbClr val="FFFFFF"/>
+                  <a:srgbClr val="081432"/>
                 </a:solidFill>
               </a:rPr>
               <a:t>Proceso judicial</a:t>
@@ -7183,14 +7461,14 @@
       </p:sp>
       <p:sp>
         <p:nvSpPr>
-          <p:cNvPr id="22" name="Rectangle 21"/>
+          <p:cNvPr id="23" name="Rectangle 22"/>
           <p:cNvSpPr/>
           <p:nvPr/>
         </p:nvSpPr>
         <p:spPr>
           <a:xfrm>
-            <a:off x="4466234" y="2738628"/>
-            <a:ext cx="3432962" cy="12700"/>
+            <a:off x="4466234" y="2752344"/>
+            <a:ext cx="3432962" cy="15240"/>
           </a:xfrm>
           <a:prstGeom prst="rect">
             <a:avLst/>
@@ -7226,21 +7504,21 @@
       </p:sp>
       <p:sp>
         <p:nvSpPr>
-          <p:cNvPr id="23" name="TextBox 22"/>
+          <p:cNvPr id="24" name="TextBox 23"/>
           <p:cNvSpPr txBox="1"/>
           <p:nvPr/>
         </p:nvSpPr>
         <p:spPr>
           <a:xfrm>
-            <a:off x="4466234" y="2814828"/>
-            <a:ext cx="3432962" cy="3231388"/>
+            <a:off x="4484522" y="2828544"/>
+            <a:ext cx="3414674" cy="3243072"/>
           </a:xfrm>
           <a:prstGeom prst="rect">
             <a:avLst/>
           </a:prstGeom>
           <a:noFill/>
         </p:spPr>
-        <p:txBody lIns="50800" tIns="25400" rIns="50800" bIns="25400">
+        <p:txBody lIns="50800" tIns="38100" rIns="50800" bIns="38100">
           <a:bodyPr wrap="square">
             <a:spAutoFit/>
           </a:bodyPr>
@@ -7262,7 +7540,7 @@
             <a:r>
               <a:rPr sz="750">
                 <a:solidFill>
-                  <a:srgbClr val="E4EEFF"/>
+                  <a:srgbClr val="223A6A"/>
                 </a:solidFill>
               </a:rPr>
               <a:t>Interposición de monitorio o juicio verbal</a:t>
@@ -7285,7 +7563,7 @@
             <a:r>
               <a:rPr sz="750">
                 <a:solidFill>
-                  <a:srgbClr val="E4EEFF"/>
+                  <a:srgbClr val="223A6A"/>
                 </a:solidFill>
               </a:rPr>
               <a:t>Red de letrados en todas las CC.AA.</a:t>
@@ -7308,7 +7586,7 @@
             <a:r>
               <a:rPr sz="750">
                 <a:solidFill>
-                  <a:srgbClr val="E4EEFF"/>
+                  <a:srgbClr val="223A6A"/>
                 </a:solidFill>
               </a:rPr>
               <a:t>Coordinación con procuradores y notificaciones</a:t>
@@ -7331,7 +7609,7 @@
             <a:r>
               <a:rPr sz="750">
                 <a:solidFill>
-                  <a:srgbClr val="E4EEFF"/>
+                  <a:srgbClr val="223A6A"/>
                 </a:solidFill>
               </a:rPr>
               <a:t>Reporting de estado mensual</a:t>
@@ -7341,7 +7619,7 @@
       </p:sp>
       <p:sp>
         <p:nvSpPr>
-          <p:cNvPr id="24" name="Rectangle 23"/>
+          <p:cNvPr id="25" name="Rectangle 24"/>
           <p:cNvSpPr/>
           <p:nvPr/>
         </p:nvSpPr>
@@ -7354,11 +7632,11 @@
             <a:avLst/>
           </a:prstGeom>
           <a:solidFill>
-            <a:srgbClr val="162A68"/>
+            <a:srgbClr val="F2F7FF"/>
           </a:solidFill>
-          <a:ln w="9525">
+          <a:ln w="6350">
             <a:solidFill>
-              <a:srgbClr val="4A68B8"/>
+              <a:srgbClr val="2FDFE5"/>
             </a:solidFill>
           </a:ln>
         </p:spPr>
@@ -7386,14 +7664,14 @@
       </p:sp>
       <p:sp>
         <p:nvSpPr>
-          <p:cNvPr id="25" name="Rectangle 24"/>
+          <p:cNvPr id="26" name="Rectangle 25"/>
           <p:cNvSpPr/>
           <p:nvPr/>
         </p:nvSpPr>
         <p:spPr>
           <a:xfrm>
             <a:off x="8173516" y="1719072"/>
-            <a:ext cx="3688994" cy="38100"/>
+            <a:ext cx="3688994" cy="50800"/>
           </a:xfrm>
           <a:prstGeom prst="rect">
             <a:avLst/>
@@ -7429,14 +7707,14 @@
       </p:sp>
       <p:sp>
         <p:nvSpPr>
-          <p:cNvPr id="26" name="Oval 25"/>
+          <p:cNvPr id="27" name="Oval 26"/>
           <p:cNvSpPr/>
           <p:nvPr/>
         </p:nvSpPr>
         <p:spPr>
           <a:xfrm>
             <a:off x="8356396" y="1901952"/>
-            <a:ext cx="233172" cy="233172"/>
+            <a:ext cx="228600" cy="228600"/>
           </a:xfrm>
           <a:prstGeom prst="ellipse">
             <a:avLst/>
@@ -7474,14 +7752,14 @@
       </p:sp>
       <p:sp>
         <p:nvSpPr>
-          <p:cNvPr id="27" name="TextBox 26"/>
+          <p:cNvPr id="28" name="TextBox 27"/>
           <p:cNvSpPr txBox="1"/>
           <p:nvPr/>
         </p:nvSpPr>
         <p:spPr>
           <a:xfrm>
             <a:off x="8356396" y="1901952"/>
-            <a:ext cx="233172" cy="233172"/>
+            <a:ext cx="228600" cy="228600"/>
           </a:xfrm>
           <a:prstGeom prst="rect">
             <a:avLst/>
@@ -7508,14 +7786,14 @@
       </p:sp>
       <p:sp>
         <p:nvSpPr>
-          <p:cNvPr id="28" name="TextBox 27"/>
+          <p:cNvPr id="29" name="TextBox 28"/>
           <p:cNvSpPr txBox="1"/>
           <p:nvPr/>
         </p:nvSpPr>
         <p:spPr>
           <a:xfrm>
-            <a:off x="8301532" y="2226564"/>
-            <a:ext cx="3432962" cy="493776"/>
+            <a:off x="8319820" y="2221992"/>
+            <a:ext cx="3396386" cy="512064"/>
           </a:xfrm>
           <a:prstGeom prst="rect">
             <a:avLst/>
@@ -7532,7 +7810,7 @@
             <a:r>
               <a:rPr sz="950" b="1">
                 <a:solidFill>
-                  <a:srgbClr val="FFFFFF"/>
+                  <a:srgbClr val="081432"/>
                 </a:solidFill>
               </a:rPr>
               <a:t>Ejecución y cobro</a:t>
@@ -7542,14 +7820,14 @@
       </p:sp>
       <p:sp>
         <p:nvSpPr>
-          <p:cNvPr id="29" name="Rectangle 28"/>
+          <p:cNvPr id="30" name="Rectangle 29"/>
           <p:cNvSpPr/>
           <p:nvPr/>
         </p:nvSpPr>
         <p:spPr>
           <a:xfrm>
-            <a:off x="8301532" y="2738628"/>
-            <a:ext cx="3432962" cy="12700"/>
+            <a:off x="8301532" y="2752344"/>
+            <a:ext cx="3432962" cy="15240"/>
           </a:xfrm>
           <a:prstGeom prst="rect">
             <a:avLst/>
@@ -7585,21 +7863,21 @@
       </p:sp>
       <p:sp>
         <p:nvSpPr>
-          <p:cNvPr id="30" name="TextBox 29"/>
+          <p:cNvPr id="31" name="TextBox 30"/>
           <p:cNvSpPr txBox="1"/>
           <p:nvPr/>
         </p:nvSpPr>
         <p:spPr>
           <a:xfrm>
-            <a:off x="8301532" y="2814828"/>
-            <a:ext cx="3432962" cy="3231388"/>
+            <a:off x="8319820" y="2828544"/>
+            <a:ext cx="3414674" cy="3243072"/>
           </a:xfrm>
           <a:prstGeom prst="rect">
             <a:avLst/>
           </a:prstGeom>
           <a:noFill/>
         </p:spPr>
-        <p:txBody lIns="50800" tIns="25400" rIns="50800" bIns="25400">
+        <p:txBody lIns="50800" tIns="38100" rIns="50800" bIns="38100">
           <a:bodyPr wrap="square">
             <a:spAutoFit/>
           </a:bodyPr>
@@ -7621,7 +7899,7 @@
             <a:r>
               <a:rPr sz="750">
                 <a:solidFill>
-                  <a:srgbClr val="E4EEFF"/>
+                  <a:srgbClr val="223A6A"/>
                 </a:solidFill>
               </a:rPr>
               <a:t>Embargo de cuentas, nóminas e inmuebles</a:t>
@@ -7644,7 +7922,7 @@
             <a:r>
               <a:rPr sz="750">
                 <a:solidFill>
-                  <a:srgbClr val="E4EEFF"/>
+                  <a:srgbClr val="223A6A"/>
                 </a:solidFill>
               </a:rPr>
               <a:t>Seguimiento de subastas judiciales</a:t>
@@ -7667,7 +7945,7 @@
             <a:r>
               <a:rPr sz="750">
                 <a:solidFill>
-                  <a:srgbClr val="E4EEFF"/>
+                  <a:srgbClr val="223A6A"/>
                 </a:solidFill>
               </a:rPr>
               <a:t>Liquidación y transferencia en 5 días hábiles</a:t>
@@ -7690,7 +7968,7 @@
             <a:r>
               <a:rPr sz="750">
                 <a:solidFill>
-                  <a:srgbClr val="E4EEFF"/>
+                  <a:srgbClr val="223A6A"/>
                 </a:solidFill>
               </a:rPr>
               <a:t>Acta de cierre con detalle de costas</a:t>
@@ -7703,8 +7981,90 @@
   <p:clrMapOvr>
     <a:masterClrMapping/>
   </p:clrMapOvr>
-  <p:transition dur="700" spd="fast">
-    <p:fade/>
+  <p:timing>
+    <p:tnLst>
+      <p:par>
+        <p:cTn id="1" dur="indefin" restart="whenNotActive" nodeType="tmRoot">
+          <p:childTnLst>
+            <p:seq concurrent="1" nextAc="seek">
+              <p:cTn id="2" dur="indefin" nodeType="mainSeq">
+                <p:childTnLst>
+                  <p:par>
+                    <p:cTn id="3" fill="hold">
+                      <p:stCondLst>
+                        <p:cond delay="0"/>
+                      </p:stCondLst>
+                      <p:childTnLst>
+                        <p:par>
+                          <p:cTn id="5" fill="hold">
+                            <p:stCondLst>
+                              <p:cond delay="0"/>
+                            </p:stCondLst>
+                            <p:childTnLst>
+                              <p:animEffect transition="in" filter="wipe(up)">
+                                <p:cBhvr>
+                                  <p:cTn id="6" dur="450" fill="hold"/>
+                                  <p:tgtEl>
+                                    <p:spTgt spid="11"/>
+                                  </p:tgtEl>
+                                </p:cBhvr>
+                              </p:animEffect>
+                            </p:childTnLst>
+                          </p:cTn>
+                        </p:par>
+                        <p:par>
+                          <p:cTn id="7" fill="hold">
+                            <p:stCondLst>
+                              <p:cond delay="160"/>
+                            </p:stCondLst>
+                            <p:childTnLst>
+                              <p:animEffect transition="in" filter="wipe(up)">
+                                <p:cBhvr>
+                                  <p:cTn id="8" dur="450" fill="hold"/>
+                                  <p:tgtEl>
+                                    <p:spTgt spid="18"/>
+                                  </p:tgtEl>
+                                </p:cBhvr>
+                              </p:animEffect>
+                            </p:childTnLst>
+                          </p:cTn>
+                        </p:par>
+                        <p:par>
+                          <p:cTn id="9" fill="hold">
+                            <p:stCondLst>
+                              <p:cond delay="320"/>
+                            </p:stCondLst>
+                            <p:childTnLst>
+                              <p:animEffect transition="in" filter="wipe(up)">
+                                <p:cBhvr>
+                                  <p:cTn id="10" dur="450" fill="hold"/>
+                                  <p:tgtEl>
+                                    <p:spTgt spid="25"/>
+                                  </p:tgtEl>
+                                </p:cBhvr>
+                              </p:animEffect>
+                            </p:childTnLst>
+                          </p:cTn>
+                        </p:par>
+                      </p:childTnLst>
+                    </p:cTn>
+                  </p:par>
+                </p:childTnLst>
+              </p:cTn>
+              <p:prevCondLst>
+                <p:cond evt="onPrevClick" delay="0"/>
+              </p:prevCondLst>
+              <p:nextCondLst>
+                <p:cond evt="onNextClick" delay="0"/>
+              </p:nextCondLst>
+            </p:seq>
+          </p:childTnLst>
+        </p:cTn>
+      </p:par>
+    </p:tnLst>
+  </p:timing>
+  <p:transition dur="500" spd="fast">
+    <p:push dir="u"/>
   </p:transition>
 </p:sld>
 </file>
@@ -7759,7 +8119,7 @@
           </a:prstGeom>
           <a:solidFill>
             <a:srgbClr val="060E24">
-              <a:alpha val="50000"/>
+              <a:alpha val="38000"/>
             </a:srgbClr>
           </a:solidFill>
           <a:ln>
@@ -7791,6 +8151,49 @@
       <p:sp>
         <p:nvSpPr>
           <p:cNvPr id="4" name="Rectangle 3"/>
+          <p:cNvSpPr/>
+          <p:nvPr/>
+        </p:nvSpPr>
+        <p:spPr>
+          <a:xfrm>
+            <a:off x="0" y="0"/>
+            <a:ext cx="12191695" cy="1664208"/>
+          </a:xfrm>
+          <a:prstGeom prst="rect">
+            <a:avLst/>
+          </a:prstGeom>
+          <a:solidFill>
+            <a:srgbClr val="0A1638"/>
+          </a:solidFill>
+          <a:ln>
+            <a:noFill/>
+          </a:ln>
+        </p:spPr>
+        <p:style>
+          <a:lnRef idx="1">
+            <a:schemeClr val="accent1"/>
+          </a:lnRef>
+          <a:fillRef idx="3">
+            <a:schemeClr val="accent1"/>
+          </a:fillRef>
+          <a:effectRef idx="2">
+            <a:schemeClr val="accent1"/>
+          </a:effectRef>
+          <a:fontRef idx="minor">
+            <a:schemeClr val="lt1"/>
+          </a:fontRef>
+        </p:style>
+        <p:txBody>
+          <a:bodyPr rtlCol="0" anchor="ctr"/>
+          <a:lstStyle/>
+          <a:p>
+            <a:pPr algn="ctr"/>
+          </a:p>
+        </p:txBody>
+      </p:sp>
+      <p:sp>
+        <p:nvSpPr>
+          <p:cNvPr id="5" name="Rectangle 4"/>
           <p:cNvSpPr/>
           <p:nvPr/>
         </p:nvSpPr>
@@ -7833,7 +8236,7 @@
       </p:sp>
       <p:sp>
         <p:nvSpPr>
-          <p:cNvPr id="5" name="Rectangle 4"/>
+          <p:cNvPr id="6" name="Rectangle 5"/>
           <p:cNvSpPr/>
           <p:nvPr/>
         </p:nvSpPr>
@@ -7876,14 +8279,14 @@
       </p:sp>
       <p:sp>
         <p:nvSpPr>
-          <p:cNvPr id="6" name="Rectangle 5"/>
+          <p:cNvPr id="7" name="Rectangle 6"/>
           <p:cNvSpPr/>
           <p:nvPr/>
         </p:nvSpPr>
         <p:spPr>
           <a:xfrm>
             <a:off x="502920" y="365760"/>
-            <a:ext cx="1417320" cy="237744"/>
+            <a:ext cx="1371600" cy="237744"/>
           </a:xfrm>
           <a:prstGeom prst="rect">
             <a:avLst/>
@@ -7927,14 +8330,14 @@
       </p:sp>
       <p:sp>
         <p:nvSpPr>
-          <p:cNvPr id="7" name="TextBox 6"/>
+          <p:cNvPr id="8" name="TextBox 7"/>
           <p:cNvSpPr txBox="1"/>
           <p:nvPr/>
         </p:nvSpPr>
         <p:spPr>
           <a:xfrm>
             <a:off x="502920" y="694944"/>
-            <a:ext cx="8229600" cy="713232"/>
+            <a:ext cx="8412480" cy="694944"/>
           </a:xfrm>
           <a:prstGeom prst="rect">
             <a:avLst/>
@@ -7969,14 +8372,14 @@
       </p:sp>
       <p:sp>
         <p:nvSpPr>
-          <p:cNvPr id="8" name="Rectangle 7"/>
+          <p:cNvPr id="9" name="Rectangle 8"/>
           <p:cNvSpPr/>
           <p:nvPr/>
         </p:nvSpPr>
         <p:spPr>
           <a:xfrm>
-            <a:off x="502920" y="1481328"/>
-            <a:ext cx="4114800" cy="31750"/>
+            <a:off x="502920" y="1463040"/>
+            <a:ext cx="4023360" cy="31750"/>
           </a:xfrm>
           <a:prstGeom prst="rect">
             <a:avLst/>
@@ -8012,7 +8415,7 @@
       </p:sp>
       <p:pic>
         <p:nvPicPr>
-          <p:cNvPr id="9" name="Picture 8" descr="logo_horiz.png"/>
+          <p:cNvPr id="10" name="Picture 9" descr="logo_horiz.png"/>
           <p:cNvPicPr>
             <a:picLocks noChangeAspect="1"/>
           </p:cNvPicPr>
@@ -8026,8 +8429,8 @@
         </p:blipFill>
         <p:spPr>
           <a:xfrm>
-            <a:off x="10116008" y="6291072"/>
-            <a:ext cx="1874519" cy="420624"/>
+            <a:off x="10161727" y="6291072"/>
+            <a:ext cx="1828800" cy="420624"/>
           </a:xfrm>
           <a:prstGeom prst="rect">
             <a:avLst/>
@@ -8036,7 +8439,7 @@
       </p:pic>
       <p:sp>
         <p:nvSpPr>
-          <p:cNvPr id="10" name="Rectangle 9"/>
+          <p:cNvPr id="11" name="Rectangle 10"/>
           <p:cNvSpPr/>
           <p:nvPr/>
         </p:nvSpPr>
@@ -8049,11 +8452,11 @@
             <a:avLst/>
           </a:prstGeom>
           <a:solidFill>
-            <a:srgbClr val="162A68"/>
+            <a:srgbClr val="F2F7FF"/>
           </a:solidFill>
-          <a:ln w="9525">
+          <a:ln w="6350">
             <a:solidFill>
-              <a:srgbClr val="4A68B8"/>
+              <a:srgbClr val="2FDFE5"/>
             </a:solidFill>
           </a:ln>
         </p:spPr>
@@ -8081,14 +8484,14 @@
       </p:sp>
       <p:sp>
         <p:nvSpPr>
-          <p:cNvPr id="11" name="Rectangle 10"/>
+          <p:cNvPr id="12" name="Rectangle 11"/>
           <p:cNvSpPr/>
           <p:nvPr/>
         </p:nvSpPr>
         <p:spPr>
           <a:xfrm>
             <a:off x="502920" y="1719072"/>
-            <a:ext cx="3688994" cy="38100"/>
+            <a:ext cx="3688994" cy="50800"/>
           </a:xfrm>
           <a:prstGeom prst="rect">
             <a:avLst/>
@@ -8124,14 +8527,14 @@
       </p:sp>
       <p:sp>
         <p:nvSpPr>
-          <p:cNvPr id="12" name="Oval 11"/>
+          <p:cNvPr id="13" name="Oval 12"/>
           <p:cNvSpPr/>
           <p:nvPr/>
         </p:nvSpPr>
         <p:spPr>
           <a:xfrm>
             <a:off x="685800" y="1901952"/>
-            <a:ext cx="233172" cy="233172"/>
+            <a:ext cx="228600" cy="228600"/>
           </a:xfrm>
           <a:prstGeom prst="ellipse">
             <a:avLst/>
@@ -8169,14 +8572,14 @@
       </p:sp>
       <p:sp>
         <p:nvSpPr>
-          <p:cNvPr id="13" name="TextBox 12"/>
+          <p:cNvPr id="14" name="TextBox 13"/>
           <p:cNvSpPr txBox="1"/>
           <p:nvPr/>
         </p:nvSpPr>
         <p:spPr>
           <a:xfrm>
             <a:off x="685800" y="1901952"/>
-            <a:ext cx="233172" cy="233172"/>
+            <a:ext cx="228600" cy="228600"/>
           </a:xfrm>
           <a:prstGeom prst="rect">
             <a:avLst/>
@@ -8203,14 +8606,14 @@
       </p:sp>
       <p:sp>
         <p:nvSpPr>
-          <p:cNvPr id="14" name="TextBox 13"/>
+          <p:cNvPr id="15" name="TextBox 14"/>
           <p:cNvSpPr txBox="1"/>
           <p:nvPr/>
         </p:nvSpPr>
         <p:spPr>
           <a:xfrm>
-            <a:off x="630936" y="2226564"/>
-            <a:ext cx="3432962" cy="493776"/>
+            <a:off x="649224" y="2221992"/>
+            <a:ext cx="3396386" cy="512064"/>
           </a:xfrm>
           <a:prstGeom prst="rect">
             <a:avLst/>
@@ -8227,7 +8630,7 @@
             <a:r>
               <a:rPr sz="950" b="1">
                 <a:solidFill>
-                  <a:srgbClr val="FFFFFF"/>
+                  <a:srgbClr val="081432"/>
                 </a:solidFill>
               </a:rPr>
               <a:t>Informes periódicos</a:t>
@@ -8237,14 +8640,14 @@
       </p:sp>
       <p:sp>
         <p:nvSpPr>
-          <p:cNvPr id="15" name="Rectangle 14"/>
+          <p:cNvPr id="16" name="Rectangle 15"/>
           <p:cNvSpPr/>
           <p:nvPr/>
         </p:nvSpPr>
         <p:spPr>
           <a:xfrm>
-            <a:off x="630936" y="2738628"/>
-            <a:ext cx="3432962" cy="12700"/>
+            <a:off x="630936" y="2752344"/>
+            <a:ext cx="3432962" cy="15240"/>
           </a:xfrm>
           <a:prstGeom prst="rect">
             <a:avLst/>
@@ -8280,21 +8683,21 @@
       </p:sp>
       <p:sp>
         <p:nvSpPr>
-          <p:cNvPr id="16" name="TextBox 15"/>
+          <p:cNvPr id="17" name="TextBox 16"/>
           <p:cNvSpPr txBox="1"/>
           <p:nvPr/>
         </p:nvSpPr>
         <p:spPr>
           <a:xfrm>
-            <a:off x="630936" y="2814828"/>
-            <a:ext cx="3432962" cy="3231388"/>
+            <a:off x="649224" y="2828544"/>
+            <a:ext cx="3414674" cy="3243072"/>
           </a:xfrm>
           <a:prstGeom prst="rect">
             <a:avLst/>
           </a:prstGeom>
           <a:noFill/>
         </p:spPr>
-        <p:txBody lIns="50800" tIns="25400" rIns="50800" bIns="25400">
+        <p:txBody lIns="50800" tIns="38100" rIns="50800" bIns="38100">
           <a:bodyPr wrap="square">
             <a:spAutoFit/>
           </a:bodyPr>
@@ -8316,7 +8719,7 @@
             <a:r>
               <a:rPr sz="750">
                 <a:solidFill>
-                  <a:srgbClr val="E4EEFF"/>
+                  <a:srgbClr val="223A6A"/>
                 </a:solidFill>
               </a:rPr>
               <a:t>Informe semanal de actividad y contactaciones</a:t>
@@ -8339,7 +8742,7 @@
             <a:r>
               <a:rPr sz="750">
                 <a:solidFill>
-                  <a:srgbClr val="E4EEFF"/>
+                  <a:srgbClr val="223A6A"/>
                 </a:solidFill>
               </a:rPr>
               <a:t>Reporte mensual de recuperación y aging</a:t>
@@ -8362,7 +8765,7 @@
             <a:r>
               <a:rPr sz="750">
                 <a:solidFill>
-                  <a:srgbClr val="E4EEFF"/>
+                  <a:srgbClr val="223A6A"/>
                 </a:solidFill>
               </a:rPr>
               <a:t>Cuadro de mando ejecutivo trimestral</a:t>
@@ -8385,7 +8788,7 @@
             <a:r>
               <a:rPr sz="750">
                 <a:solidFill>
-                  <a:srgbClr val="E4EEFF"/>
+                  <a:srgbClr val="223A6A"/>
                 </a:solidFill>
               </a:rPr>
               <a:t>Exportación en PDF, Excel y API JSON</a:t>
@@ -8395,7 +8798,7 @@
       </p:sp>
       <p:sp>
         <p:nvSpPr>
-          <p:cNvPr id="17" name="Rectangle 16"/>
+          <p:cNvPr id="18" name="Rectangle 17"/>
           <p:cNvSpPr/>
           <p:nvPr/>
         </p:nvSpPr>
@@ -8408,11 +8811,11 @@
             <a:avLst/>
           </a:prstGeom>
           <a:solidFill>
-            <a:srgbClr val="162A68"/>
+            <a:srgbClr val="F2F7FF"/>
           </a:solidFill>
-          <a:ln w="9525">
+          <a:ln w="6350">
             <a:solidFill>
-              <a:srgbClr val="4A68B8"/>
+              <a:srgbClr val="2FDFE5"/>
             </a:solidFill>
           </a:ln>
         </p:spPr>
@@ -8440,14 +8843,14 @@
       </p:sp>
       <p:sp>
         <p:nvSpPr>
-          <p:cNvPr id="18" name="Rectangle 17"/>
+          <p:cNvPr id="19" name="Rectangle 18"/>
           <p:cNvSpPr/>
           <p:nvPr/>
         </p:nvSpPr>
         <p:spPr>
           <a:xfrm>
             <a:off x="4338218" y="1719072"/>
-            <a:ext cx="3688994" cy="38100"/>
+            <a:ext cx="3688994" cy="50800"/>
           </a:xfrm>
           <a:prstGeom prst="rect">
             <a:avLst/>
@@ -8483,14 +8886,14 @@
       </p:sp>
       <p:sp>
         <p:nvSpPr>
-          <p:cNvPr id="19" name="Oval 18"/>
+          <p:cNvPr id="20" name="Oval 19"/>
           <p:cNvSpPr/>
           <p:nvPr/>
         </p:nvSpPr>
         <p:spPr>
           <a:xfrm>
             <a:off x="4521098" y="1901952"/>
-            <a:ext cx="233172" cy="233172"/>
+            <a:ext cx="228600" cy="228600"/>
           </a:xfrm>
           <a:prstGeom prst="ellipse">
             <a:avLst/>
@@ -8528,14 +8931,14 @@
       </p:sp>
       <p:sp>
         <p:nvSpPr>
-          <p:cNvPr id="20" name="TextBox 19"/>
+          <p:cNvPr id="21" name="TextBox 20"/>
           <p:cNvSpPr txBox="1"/>
           <p:nvPr/>
         </p:nvSpPr>
         <p:spPr>
           <a:xfrm>
             <a:off x="4521098" y="1901952"/>
-            <a:ext cx="233172" cy="233172"/>
+            <a:ext cx="228600" cy="228600"/>
           </a:xfrm>
           <a:prstGeom prst="rect">
             <a:avLst/>
@@ -8562,14 +8965,14 @@
       </p:sp>
       <p:sp>
         <p:nvSpPr>
-          <p:cNvPr id="21" name="TextBox 20"/>
+          <p:cNvPr id="22" name="TextBox 21"/>
           <p:cNvSpPr txBox="1"/>
           <p:nvPr/>
         </p:nvSpPr>
         <p:spPr>
           <a:xfrm>
-            <a:off x="4466234" y="2226564"/>
-            <a:ext cx="3432962" cy="493776"/>
+            <a:off x="4484522" y="2221992"/>
+            <a:ext cx="3396386" cy="512064"/>
           </a:xfrm>
           <a:prstGeom prst="rect">
             <a:avLst/>
@@ -8586,7 +8989,7 @@
             <a:r>
               <a:rPr sz="950" b="1">
                 <a:solidFill>
-                  <a:srgbClr val="FFFFFF"/>
+                  <a:srgbClr val="081432"/>
                 </a:solidFill>
               </a:rPr>
               <a:t>Liquidación y remesas</a:t>
@@ -8596,14 +8999,14 @@
       </p:sp>
       <p:sp>
         <p:nvSpPr>
-          <p:cNvPr id="22" name="Rectangle 21"/>
+          <p:cNvPr id="23" name="Rectangle 22"/>
           <p:cNvSpPr/>
           <p:nvPr/>
         </p:nvSpPr>
         <p:spPr>
           <a:xfrm>
-            <a:off x="4466234" y="2738628"/>
-            <a:ext cx="3432962" cy="12700"/>
+            <a:off x="4466234" y="2752344"/>
+            <a:ext cx="3432962" cy="15240"/>
           </a:xfrm>
           <a:prstGeom prst="rect">
             <a:avLst/>
@@ -8639,21 +9042,21 @@
       </p:sp>
       <p:sp>
         <p:nvSpPr>
-          <p:cNvPr id="23" name="TextBox 22"/>
+          <p:cNvPr id="24" name="TextBox 23"/>
           <p:cNvSpPr txBox="1"/>
           <p:nvPr/>
         </p:nvSpPr>
         <p:spPr>
           <a:xfrm>
-            <a:off x="4466234" y="2814828"/>
-            <a:ext cx="3432962" cy="3231388"/>
+            <a:off x="4484522" y="2828544"/>
+            <a:ext cx="3414674" cy="3243072"/>
           </a:xfrm>
           <a:prstGeom prst="rect">
             <a:avLst/>
           </a:prstGeom>
           <a:noFill/>
         </p:spPr>
-        <p:txBody lIns="50800" tIns="25400" rIns="50800" bIns="25400">
+        <p:txBody lIns="50800" tIns="38100" rIns="50800" bIns="38100">
           <a:bodyPr wrap="square">
             <a:spAutoFit/>
           </a:bodyPr>
@@ -8675,7 +9078,7 @@
             <a:r>
               <a:rPr sz="750">
                 <a:solidFill>
-                  <a:srgbClr val="E4EEFF"/>
+                  <a:srgbClr val="223A6A"/>
                 </a:solidFill>
               </a:rPr>
               <a:t>Liquidación quincenal por expediente</a:t>
@@ -8698,7 +9101,7 @@
             <a:r>
               <a:rPr sz="750">
                 <a:solidFill>
-                  <a:srgbClr val="E4EEFF"/>
+                  <a:srgbClr val="223A6A"/>
                 </a:solidFill>
               </a:rPr>
               <a:t>Transferencia SEPA en T+2 hábiles</a:t>
@@ -8721,7 +9124,7 @@
             <a:r>
               <a:rPr sz="750">
                 <a:solidFill>
-                  <a:srgbClr val="E4EEFF"/>
+                  <a:srgbClr val="223A6A"/>
                 </a:solidFill>
               </a:rPr>
               <a:t>Conciliación automática con ERP/CRM</a:t>
@@ -8744,7 +9147,7 @@
             <a:r>
               <a:rPr sz="750">
                 <a:solidFill>
-                  <a:srgbClr val="E4EEFF"/>
+                  <a:srgbClr val="223A6A"/>
                 </a:solidFill>
               </a:rPr>
               <a:t>Facturación electrónica certificada</a:t>
@@ -8754,7 +9157,7 @@
       </p:sp>
       <p:sp>
         <p:nvSpPr>
-          <p:cNvPr id="24" name="Rectangle 23"/>
+          <p:cNvPr id="25" name="Rectangle 24"/>
           <p:cNvSpPr/>
           <p:nvPr/>
         </p:nvSpPr>
@@ -8767,11 +9170,11 @@
             <a:avLst/>
           </a:prstGeom>
           <a:solidFill>
-            <a:srgbClr val="162A68"/>
+            <a:srgbClr val="F2F7FF"/>
           </a:solidFill>
-          <a:ln w="9525">
+          <a:ln w="6350">
             <a:solidFill>
-              <a:srgbClr val="4A68B8"/>
+              <a:srgbClr val="2FDFE5"/>
             </a:solidFill>
           </a:ln>
         </p:spPr>
@@ -8799,14 +9202,14 @@
       </p:sp>
       <p:sp>
         <p:nvSpPr>
-          <p:cNvPr id="25" name="Rectangle 24"/>
+          <p:cNvPr id="26" name="Rectangle 25"/>
           <p:cNvSpPr/>
           <p:nvPr/>
         </p:nvSpPr>
         <p:spPr>
           <a:xfrm>
             <a:off x="8173516" y="1719072"/>
-            <a:ext cx="3688994" cy="38100"/>
+            <a:ext cx="3688994" cy="50800"/>
           </a:xfrm>
           <a:prstGeom prst="rect">
             <a:avLst/>
@@ -8842,14 +9245,14 @@
       </p:sp>
       <p:sp>
         <p:nvSpPr>
-          <p:cNvPr id="26" name="Oval 25"/>
+          <p:cNvPr id="27" name="Oval 26"/>
           <p:cNvSpPr/>
           <p:nvPr/>
         </p:nvSpPr>
         <p:spPr>
           <a:xfrm>
             <a:off x="8356396" y="1901952"/>
-            <a:ext cx="233172" cy="233172"/>
+            <a:ext cx="228600" cy="228600"/>
           </a:xfrm>
           <a:prstGeom prst="ellipse">
             <a:avLst/>
@@ -8887,14 +9290,14 @@
       </p:sp>
       <p:sp>
         <p:nvSpPr>
-          <p:cNvPr id="27" name="TextBox 26"/>
+          <p:cNvPr id="28" name="TextBox 27"/>
           <p:cNvSpPr txBox="1"/>
           <p:nvPr/>
         </p:nvSpPr>
         <p:spPr>
           <a:xfrm>
             <a:off x="8356396" y="1901952"/>
-            <a:ext cx="233172" cy="233172"/>
+            <a:ext cx="228600" cy="228600"/>
           </a:xfrm>
           <a:prstGeom prst="rect">
             <a:avLst/>
@@ -8921,14 +9324,14 @@
       </p:sp>
       <p:sp>
         <p:nvSpPr>
-          <p:cNvPr id="28" name="TextBox 27"/>
+          <p:cNvPr id="29" name="TextBox 28"/>
           <p:cNvSpPr txBox="1"/>
           <p:nvPr/>
         </p:nvSpPr>
         <p:spPr>
           <a:xfrm>
-            <a:off x="8301532" y="2226564"/>
-            <a:ext cx="3432962" cy="493776"/>
+            <a:off x="8319820" y="2221992"/>
+            <a:ext cx="3396386" cy="512064"/>
           </a:xfrm>
           <a:prstGeom prst="rect">
             <a:avLst/>
@@ -8945,7 +9348,7 @@
             <a:r>
               <a:rPr sz="950" b="1">
                 <a:solidFill>
-                  <a:srgbClr val="FFFFFF"/>
+                  <a:srgbClr val="081432"/>
                 </a:solidFill>
               </a:rPr>
               <a:t>Control de calidad</a:t>
@@ -8955,14 +9358,14 @@
       </p:sp>
       <p:sp>
         <p:nvSpPr>
-          <p:cNvPr id="29" name="Rectangle 28"/>
+          <p:cNvPr id="30" name="Rectangle 29"/>
           <p:cNvSpPr/>
           <p:nvPr/>
         </p:nvSpPr>
         <p:spPr>
           <a:xfrm>
-            <a:off x="8301532" y="2738628"/>
-            <a:ext cx="3432962" cy="12700"/>
+            <a:off x="8301532" y="2752344"/>
+            <a:ext cx="3432962" cy="15240"/>
           </a:xfrm>
           <a:prstGeom prst="rect">
             <a:avLst/>
@@ -8998,21 +9401,21 @@
       </p:sp>
       <p:sp>
         <p:nvSpPr>
-          <p:cNvPr id="30" name="TextBox 29"/>
+          <p:cNvPr id="31" name="TextBox 30"/>
           <p:cNvSpPr txBox="1"/>
           <p:nvPr/>
         </p:nvSpPr>
         <p:spPr>
           <a:xfrm>
-            <a:off x="8301532" y="2814828"/>
-            <a:ext cx="3432962" cy="3231388"/>
+            <a:off x="8319820" y="2828544"/>
+            <a:ext cx="3414674" cy="3243072"/>
           </a:xfrm>
           <a:prstGeom prst="rect">
             <a:avLst/>
           </a:prstGeom>
           <a:noFill/>
         </p:spPr>
-        <p:txBody lIns="50800" tIns="25400" rIns="50800" bIns="25400">
+        <p:txBody lIns="50800" tIns="38100" rIns="50800" bIns="38100">
           <a:bodyPr wrap="square">
             <a:spAutoFit/>
           </a:bodyPr>
@@ -9034,7 +9437,7 @@
             <a:r>
               <a:rPr sz="750">
                 <a:solidFill>
-                  <a:srgbClr val="E4EEFF"/>
+                  <a:srgbClr val="223A6A"/>
                 </a:solidFill>
               </a:rPr>
               <a:t>Auditoría interna mensual de procesos</a:t>
@@ -9057,7 +9460,7 @@
             <a:r>
               <a:rPr sz="750">
                 <a:solidFill>
-                  <a:srgbClr val="E4EEFF"/>
+                  <a:srgbClr val="223A6A"/>
                 </a:solidFill>
               </a:rPr>
               <a:t>Mystery calling y escucha de grabaciones</a:t>
@@ -9080,7 +9483,7 @@
             <a:r>
               <a:rPr sz="750">
                 <a:solidFill>
-                  <a:srgbClr val="E4EEFF"/>
+                  <a:srgbClr val="223A6A"/>
                 </a:solidFill>
               </a:rPr>
               <a:t>Comité de mejora continua trimestral</a:t>
@@ -9103,7 +9506,7 @@
             <a:r>
               <a:rPr sz="750">
                 <a:solidFill>
-                  <a:srgbClr val="E4EEFF"/>
+                  <a:srgbClr val="223A6A"/>
                 </a:solidFill>
               </a:rPr>
               <a:t>Certificación ISO 9001 y cumplimiento RGPD</a:t>
@@ -9116,8 +9519,90 @@
   <p:clrMapOvr>
     <a:masterClrMapping/>
   </p:clrMapOvr>
-  <p:transition dur="700" spd="fast">
-    <p:fade/>
+  <p:timing>
+    <p:tnLst>
+      <p:par>
+        <p:cTn id="1" dur="indefin" restart="whenNotActive" nodeType="tmRoot">
+          <p:childTnLst>
+            <p:seq concurrent="1" nextAc="seek">
+              <p:cTn id="2" dur="indefin" nodeType="mainSeq">
+                <p:childTnLst>
+                  <p:par>
+                    <p:cTn id="3" fill="hold">
+                      <p:stCondLst>
+                        <p:cond delay="0"/>
+                      </p:stCondLst>
+                      <p:childTnLst>
+                        <p:par>
+                          <p:cTn id="5" fill="hold">
+                            <p:stCondLst>
+                              <p:cond delay="0"/>
+                            </p:stCondLst>
+                            <p:childTnLst>
+                              <p:animEffect transition="in" filter="wipe(up)">
+                                <p:cBhvr>
+                                  <p:cTn id="6" dur="450" fill="hold"/>
+                                  <p:tgtEl>
+                                    <p:spTgt spid="11"/>
+                                  </p:tgtEl>
+                                </p:cBhvr>
+                              </p:animEffect>
+                            </p:childTnLst>
+                          </p:cTn>
+                        </p:par>
+                        <p:par>
+                          <p:cTn id="7" fill="hold">
+                            <p:stCondLst>
+                              <p:cond delay="160"/>
+                            </p:stCondLst>
+                            <p:childTnLst>
+                              <p:animEffect transition="in" filter="wipe(up)">
+                                <p:cBhvr>
+                                  <p:cTn id="8" dur="450" fill="hold"/>
+                                  <p:tgtEl>
+                                    <p:spTgt spid="18"/>
+                                  </p:tgtEl>
+                                </p:cBhvr>
+                              </p:animEffect>
+                            </p:childTnLst>
+                          </p:cTn>
+                        </p:par>
+                        <p:par>
+                          <p:cTn id="9" fill="hold">
+                            <p:stCondLst>
+                              <p:cond delay="320"/>
+                            </p:stCondLst>
+                            <p:childTnLst>
+                              <p:animEffect transition="in" filter="wipe(up)">
+                                <p:cBhvr>
+                                  <p:cTn id="10" dur="450" fill="hold"/>
+                                  <p:tgtEl>
+                                    <p:spTgt spid="25"/>
+                                  </p:tgtEl>
+                                </p:cBhvr>
+                              </p:animEffect>
+                            </p:childTnLst>
+                          </p:cTn>
+                        </p:par>
+                      </p:childTnLst>
+                    </p:cTn>
+                  </p:par>
+                </p:childTnLst>
+              </p:cTn>
+              <p:prevCondLst>
+                <p:cond evt="onPrevClick" delay="0"/>
+              </p:prevCondLst>
+              <p:nextCondLst>
+                <p:cond evt="onNextClick" delay="0"/>
+              </p:nextCondLst>
+            </p:seq>
+          </p:childTnLst>
+        </p:cTn>
+      </p:par>
+    </p:tnLst>
+  </p:timing>
+  <p:transition dur="500" spd="fast">
+    <p:push dir="u"/>
   </p:transition>
 </p:sld>
 </file>
@@ -9172,7 +9657,7 @@
           </a:prstGeom>
           <a:solidFill>
             <a:srgbClr val="060E24">
-              <a:alpha val="52000"/>
+              <a:alpha val="40000"/>
             </a:srgbClr>
           </a:solidFill>
           <a:ln>
@@ -9204,6 +9689,49 @@
       <p:sp>
         <p:nvSpPr>
           <p:cNvPr id="4" name="Rectangle 3"/>
+          <p:cNvSpPr/>
+          <p:nvPr/>
+        </p:nvSpPr>
+        <p:spPr>
+          <a:xfrm>
+            <a:off x="0" y="0"/>
+            <a:ext cx="12191695" cy="1664208"/>
+          </a:xfrm>
+          <a:prstGeom prst="rect">
+            <a:avLst/>
+          </a:prstGeom>
+          <a:solidFill>
+            <a:srgbClr val="0A1638"/>
+          </a:solidFill>
+          <a:ln>
+            <a:noFill/>
+          </a:ln>
+        </p:spPr>
+        <p:style>
+          <a:lnRef idx="1">
+            <a:schemeClr val="accent1"/>
+          </a:lnRef>
+          <a:fillRef idx="3">
+            <a:schemeClr val="accent1"/>
+          </a:fillRef>
+          <a:effectRef idx="2">
+            <a:schemeClr val="accent1"/>
+          </a:effectRef>
+          <a:fontRef idx="minor">
+            <a:schemeClr val="lt1"/>
+          </a:fontRef>
+        </p:style>
+        <p:txBody>
+          <a:bodyPr rtlCol="0" anchor="ctr"/>
+          <a:lstStyle/>
+          <a:p>
+            <a:pPr algn="ctr"/>
+          </a:p>
+        </p:txBody>
+      </p:sp>
+      <p:sp>
+        <p:nvSpPr>
+          <p:cNvPr id="5" name="Rectangle 4"/>
           <p:cNvSpPr/>
           <p:nvPr/>
         </p:nvSpPr>
@@ -9246,7 +9774,7 @@
       </p:sp>
       <p:sp>
         <p:nvSpPr>
-          <p:cNvPr id="5" name="Rectangle 4"/>
+          <p:cNvPr id="6" name="Rectangle 5"/>
           <p:cNvSpPr/>
           <p:nvPr/>
         </p:nvSpPr>
@@ -9289,14 +9817,14 @@
       </p:sp>
       <p:sp>
         <p:nvSpPr>
-          <p:cNvPr id="6" name="Rectangle 5"/>
+          <p:cNvPr id="7" name="Rectangle 6"/>
           <p:cNvSpPr/>
           <p:nvPr/>
         </p:nvSpPr>
         <p:spPr>
           <a:xfrm>
             <a:off x="502920" y="365760"/>
-            <a:ext cx="1417320" cy="237744"/>
+            <a:ext cx="1371600" cy="237744"/>
           </a:xfrm>
           <a:prstGeom prst="rect">
             <a:avLst/>
@@ -9340,14 +9868,14 @@
       </p:sp>
       <p:sp>
         <p:nvSpPr>
-          <p:cNvPr id="7" name="TextBox 6"/>
+          <p:cNvPr id="8" name="TextBox 7"/>
           <p:cNvSpPr txBox="1"/>
           <p:nvPr/>
         </p:nvSpPr>
         <p:spPr>
           <a:xfrm>
             <a:off x="502920" y="694944"/>
-            <a:ext cx="8229600" cy="713232"/>
+            <a:ext cx="8229600" cy="694944"/>
           </a:xfrm>
           <a:prstGeom prst="rect">
             <a:avLst/>
@@ -9382,14 +9910,14 @@
       </p:sp>
       <p:sp>
         <p:nvSpPr>
-          <p:cNvPr id="8" name="Rectangle 7"/>
+          <p:cNvPr id="9" name="Rectangle 8"/>
           <p:cNvSpPr/>
           <p:nvPr/>
         </p:nvSpPr>
         <p:spPr>
           <a:xfrm>
-            <a:off x="502920" y="1481328"/>
-            <a:ext cx="4114800" cy="31750"/>
+            <a:off x="502920" y="1463040"/>
+            <a:ext cx="4023360" cy="31750"/>
           </a:xfrm>
           <a:prstGeom prst="rect">
             <a:avLst/>
@@ -9425,7 +9953,7 @@
       </p:sp>
       <p:pic>
         <p:nvPicPr>
-          <p:cNvPr id="9" name="Picture 8" descr="logo_horiz.png"/>
+          <p:cNvPr id="10" name="Picture 9" descr="logo_horiz.png"/>
           <p:cNvPicPr>
             <a:picLocks noChangeAspect="1"/>
           </p:cNvPicPr>
@@ -9439,8 +9967,8 @@
         </p:blipFill>
         <p:spPr>
           <a:xfrm>
-            <a:off x="10116008" y="6291072"/>
-            <a:ext cx="1874519" cy="420624"/>
+            <a:off x="10161727" y="6291072"/>
+            <a:ext cx="1828800" cy="420624"/>
           </a:xfrm>
           <a:prstGeom prst="rect">
             <a:avLst/>
@@ -9449,7 +9977,7 @@
       </p:pic>
       <p:sp>
         <p:nvSpPr>
-          <p:cNvPr id="10" name="Rectangle 9"/>
+          <p:cNvPr id="11" name="Rectangle 10"/>
           <p:cNvSpPr/>
           <p:nvPr/>
         </p:nvSpPr>
@@ -9462,11 +9990,11 @@
             <a:avLst/>
           </a:prstGeom>
           <a:solidFill>
-            <a:srgbClr val="162A68"/>
+            <a:srgbClr val="F2F7FF"/>
           </a:solidFill>
-          <a:ln w="9525">
+          <a:ln w="6350">
             <a:solidFill>
-              <a:srgbClr val="4A68B8"/>
+              <a:srgbClr val="2FDFE5"/>
             </a:solidFill>
           </a:ln>
         </p:spPr>
@@ -9494,14 +10022,14 @@
       </p:sp>
       <p:sp>
         <p:nvSpPr>
-          <p:cNvPr id="11" name="Rectangle 10"/>
+          <p:cNvPr id="12" name="Rectangle 11"/>
           <p:cNvSpPr/>
           <p:nvPr/>
         </p:nvSpPr>
         <p:spPr>
           <a:xfrm>
             <a:off x="502920" y="1755648"/>
-            <a:ext cx="5588355" cy="38100"/>
+            <a:ext cx="5588355" cy="50800"/>
           </a:xfrm>
           <a:prstGeom prst="rect">
             <a:avLst/>
@@ -9537,13 +10065,13 @@
       </p:sp>
       <p:sp>
         <p:nvSpPr>
-          <p:cNvPr id="12" name="Oval 11"/>
+          <p:cNvPr id="13" name="Oval 12"/>
           <p:cNvSpPr/>
           <p:nvPr/>
         </p:nvSpPr>
         <p:spPr>
           <a:xfrm>
-            <a:off x="658368" y="1883664"/>
+            <a:off x="658368" y="1901952"/>
             <a:ext cx="201168" cy="201168"/>
           </a:xfrm>
           <a:prstGeom prst="ellipse">
@@ -9582,13 +10110,13 @@
       </p:sp>
       <p:sp>
         <p:nvSpPr>
-          <p:cNvPr id="13" name="TextBox 12"/>
+          <p:cNvPr id="14" name="TextBox 13"/>
           <p:cNvSpPr txBox="1"/>
           <p:nvPr/>
         </p:nvSpPr>
         <p:spPr>
           <a:xfrm>
-            <a:off x="658368" y="1883664"/>
+            <a:off x="658368" y="1901952"/>
             <a:ext cx="201168" cy="201168"/>
           </a:xfrm>
           <a:prstGeom prst="rect">
@@ -9616,14 +10144,14 @@
       </p:sp>
       <p:sp>
         <p:nvSpPr>
-          <p:cNvPr id="14" name="TextBox 13"/>
+          <p:cNvPr id="15" name="TextBox 14"/>
           <p:cNvSpPr txBox="1"/>
           <p:nvPr/>
         </p:nvSpPr>
         <p:spPr>
           <a:xfrm>
-            <a:off x="923544" y="1883664"/>
-            <a:ext cx="5076291" cy="365760"/>
+            <a:off x="923544" y="1901952"/>
+            <a:ext cx="5094579" cy="347472"/>
           </a:xfrm>
           <a:prstGeom prst="rect">
             <a:avLst/>
@@ -9640,7 +10168,7 @@
             <a:r>
               <a:rPr sz="900" b="1">
                 <a:solidFill>
-                  <a:srgbClr val="FFFFFF"/>
+                  <a:srgbClr val="081432"/>
                 </a:solidFill>
               </a:rPr>
               <a:t>Gestión de Cobro Amistoso</a:t>
@@ -9650,13 +10178,13 @@
       </p:sp>
       <p:sp>
         <p:nvSpPr>
-          <p:cNvPr id="15" name="Rectangle 14"/>
+          <p:cNvPr id="16" name="Rectangle 15"/>
           <p:cNvSpPr/>
           <p:nvPr/>
         </p:nvSpPr>
         <p:spPr>
           <a:xfrm>
-            <a:off x="630936" y="2139696"/>
+            <a:off x="630936" y="2157984"/>
             <a:ext cx="5332323" cy="12700"/>
           </a:xfrm>
           <a:prstGeom prst="rect">
@@ -9693,14 +10221,14 @@
       </p:sp>
       <p:sp>
         <p:nvSpPr>
-          <p:cNvPr id="16" name="TextBox 15"/>
+          <p:cNvPr id="17" name="TextBox 16"/>
           <p:cNvSpPr txBox="1"/>
           <p:nvPr/>
         </p:nvSpPr>
         <p:spPr>
           <a:xfrm>
-            <a:off x="630936" y="2215896"/>
-            <a:ext cx="5332323" cy="1588008"/>
+            <a:off x="630936" y="2221484"/>
+            <a:ext cx="5332323" cy="1582420"/>
           </a:xfrm>
           <a:prstGeom prst="rect">
             <a:avLst/>
@@ -9717,7 +10245,7 @@
             <a:r>
               <a:rPr sz="750">
                 <a:solidFill>
-                  <a:srgbClr val="E4EEFF"/>
+                  <a:srgbClr val="223A6A"/>
                 </a:solidFill>
               </a:rPr>
               <a:t>Negociación extrajudicial, planes de pago personalizados y seguimiento continuo hasta la resolución del expediente.</a:t>
@@ -9727,7 +10255,7 @@
       </p:sp>
       <p:sp>
         <p:nvSpPr>
-          <p:cNvPr id="17" name="Rectangle 16"/>
+          <p:cNvPr id="18" name="Rectangle 17"/>
           <p:cNvSpPr/>
           <p:nvPr/>
         </p:nvSpPr>
@@ -9740,11 +10268,11 @@
             <a:avLst/>
           </a:prstGeom>
           <a:solidFill>
-            <a:srgbClr val="162A68"/>
+            <a:srgbClr val="F2F7FF"/>
           </a:solidFill>
-          <a:ln w="9525">
+          <a:ln w="6350">
             <a:solidFill>
-              <a:srgbClr val="4A68B8"/>
+              <a:srgbClr val="2FDFE5"/>
             </a:solidFill>
           </a:ln>
         </p:spPr>
@@ -9772,14 +10300,14 @@
       </p:sp>
       <p:sp>
         <p:nvSpPr>
-          <p:cNvPr id="18" name="Rectangle 17"/>
+          <p:cNvPr id="19" name="Rectangle 18"/>
           <p:cNvSpPr/>
           <p:nvPr/>
         </p:nvSpPr>
         <p:spPr>
           <a:xfrm>
             <a:off x="6274155" y="1755648"/>
-            <a:ext cx="5588355" cy="38100"/>
+            <a:ext cx="5588355" cy="50800"/>
           </a:xfrm>
           <a:prstGeom prst="rect">
             <a:avLst/>
@@ -9815,13 +10343,13 @@
       </p:sp>
       <p:sp>
         <p:nvSpPr>
-          <p:cNvPr id="19" name="Oval 18"/>
+          <p:cNvPr id="20" name="Oval 19"/>
           <p:cNvSpPr/>
           <p:nvPr/>
         </p:nvSpPr>
         <p:spPr>
           <a:xfrm>
-            <a:off x="6429603" y="1883664"/>
+            <a:off x="6429603" y="1901952"/>
             <a:ext cx="201168" cy="201168"/>
           </a:xfrm>
           <a:prstGeom prst="ellipse">
@@ -9860,13 +10388,13 @@
       </p:sp>
       <p:sp>
         <p:nvSpPr>
-          <p:cNvPr id="20" name="TextBox 19"/>
+          <p:cNvPr id="21" name="TextBox 20"/>
           <p:cNvSpPr txBox="1"/>
           <p:nvPr/>
         </p:nvSpPr>
         <p:spPr>
           <a:xfrm>
-            <a:off x="6429603" y="1883664"/>
+            <a:off x="6429603" y="1901952"/>
             <a:ext cx="201168" cy="201168"/>
           </a:xfrm>
           <a:prstGeom prst="rect">
@@ -9894,14 +10422,14 @@
       </p:sp>
       <p:sp>
         <p:nvSpPr>
-          <p:cNvPr id="21" name="TextBox 20"/>
+          <p:cNvPr id="22" name="TextBox 21"/>
           <p:cNvSpPr txBox="1"/>
           <p:nvPr/>
         </p:nvSpPr>
         <p:spPr>
           <a:xfrm>
-            <a:off x="6694779" y="1883664"/>
-            <a:ext cx="5076291" cy="365760"/>
+            <a:off x="6694779" y="1901952"/>
+            <a:ext cx="5094579" cy="347472"/>
           </a:xfrm>
           <a:prstGeom prst="rect">
             <a:avLst/>
@@ -9918,7 +10446,7 @@
             <a:r>
               <a:rPr sz="900" b="1">
                 <a:solidFill>
-                  <a:srgbClr val="FFFFFF"/>
+                  <a:srgbClr val="081432"/>
                 </a:solidFill>
               </a:rPr>
               <a:t>Recobro Judicial</a:t>
@@ -9928,13 +10456,13 @@
       </p:sp>
       <p:sp>
         <p:nvSpPr>
-          <p:cNvPr id="22" name="Rectangle 21"/>
+          <p:cNvPr id="23" name="Rectangle 22"/>
           <p:cNvSpPr/>
           <p:nvPr/>
         </p:nvSpPr>
         <p:spPr>
           <a:xfrm>
-            <a:off x="6402171" y="2139696"/>
+            <a:off x="6402171" y="2157984"/>
             <a:ext cx="5332323" cy="12700"/>
           </a:xfrm>
           <a:prstGeom prst="rect">
@@ -9971,14 +10499,14 @@
       </p:sp>
       <p:sp>
         <p:nvSpPr>
-          <p:cNvPr id="23" name="TextBox 22"/>
+          <p:cNvPr id="24" name="TextBox 23"/>
           <p:cNvSpPr txBox="1"/>
           <p:nvPr/>
         </p:nvSpPr>
         <p:spPr>
           <a:xfrm>
-            <a:off x="6402171" y="2215896"/>
-            <a:ext cx="5332323" cy="1588008"/>
+            <a:off x="6402171" y="2221484"/>
+            <a:ext cx="5332323" cy="1582420"/>
           </a:xfrm>
           <a:prstGeom prst="rect">
             <a:avLst/>
@@ -9995,7 +10523,7 @@
             <a:r>
               <a:rPr sz="750">
                 <a:solidFill>
-                  <a:srgbClr val="E4EEFF"/>
+                  <a:srgbClr val="223A6A"/>
                 </a:solidFill>
               </a:rPr>
               <a:t>Interposición de demandas, coordinación con letrados y ejecución de sentencias a través de procuradores especializados.</a:t>
@@ -10005,7 +10533,7 @@
       </p:sp>
       <p:sp>
         <p:nvSpPr>
-          <p:cNvPr id="24" name="Rectangle 23"/>
+          <p:cNvPr id="25" name="Rectangle 24"/>
           <p:cNvSpPr/>
           <p:nvPr/>
         </p:nvSpPr>
@@ -10018,11 +10546,11 @@
             <a:avLst/>
           </a:prstGeom>
           <a:solidFill>
-            <a:srgbClr val="162A68"/>
+            <a:srgbClr val="F2F7FF"/>
           </a:solidFill>
-          <a:ln w="9525">
+          <a:ln w="6350">
             <a:solidFill>
-              <a:srgbClr val="4A68B8"/>
+              <a:srgbClr val="2FDFE5"/>
             </a:solidFill>
           </a:ln>
         </p:spPr>
@@ -10050,14 +10578,14 @@
       </p:sp>
       <p:sp>
         <p:nvSpPr>
-          <p:cNvPr id="25" name="Rectangle 24"/>
+          <p:cNvPr id="26" name="Rectangle 25"/>
           <p:cNvSpPr/>
           <p:nvPr/>
         </p:nvSpPr>
         <p:spPr>
           <a:xfrm>
             <a:off x="502920" y="4023360"/>
-            <a:ext cx="5588355" cy="38100"/>
+            <a:ext cx="5588355" cy="50800"/>
           </a:xfrm>
           <a:prstGeom prst="rect">
             <a:avLst/>
@@ -10093,13 +10621,13 @@
       </p:sp>
       <p:sp>
         <p:nvSpPr>
-          <p:cNvPr id="26" name="Oval 25"/>
+          <p:cNvPr id="27" name="Oval 26"/>
           <p:cNvSpPr/>
           <p:nvPr/>
         </p:nvSpPr>
         <p:spPr>
           <a:xfrm>
-            <a:off x="658368" y="4151376"/>
+            <a:off x="658368" y="4169664"/>
             <a:ext cx="201168" cy="201168"/>
           </a:xfrm>
           <a:prstGeom prst="ellipse">
@@ -10138,13 +10666,13 @@
       </p:sp>
       <p:sp>
         <p:nvSpPr>
-          <p:cNvPr id="27" name="TextBox 26"/>
+          <p:cNvPr id="28" name="TextBox 27"/>
           <p:cNvSpPr txBox="1"/>
           <p:nvPr/>
         </p:nvSpPr>
         <p:spPr>
           <a:xfrm>
-            <a:off x="658368" y="4151376"/>
+            <a:off x="658368" y="4169664"/>
             <a:ext cx="201168" cy="201168"/>
           </a:xfrm>
           <a:prstGeom prst="rect">
@@ -10172,14 +10700,14 @@
       </p:sp>
       <p:sp>
         <p:nvSpPr>
-          <p:cNvPr id="28" name="TextBox 27"/>
+          <p:cNvPr id="29" name="TextBox 28"/>
           <p:cNvSpPr txBox="1"/>
           <p:nvPr/>
         </p:nvSpPr>
         <p:spPr>
           <a:xfrm>
-            <a:off x="923544" y="4151376"/>
-            <a:ext cx="5076291" cy="365760"/>
+            <a:off x="923544" y="4169664"/>
+            <a:ext cx="5094579" cy="347472"/>
           </a:xfrm>
           <a:prstGeom prst="rect">
             <a:avLst/>
@@ -10196,7 +10724,7 @@
             <a:r>
               <a:rPr sz="900" b="1">
                 <a:solidFill>
-                  <a:srgbClr val="FFFFFF"/>
+                  <a:srgbClr val="081432"/>
                 </a:solidFill>
               </a:rPr>
               <a:t>Scoring &amp; Segmentación</a:t>
@@ -10206,13 +10734,13 @@
       </p:sp>
       <p:sp>
         <p:nvSpPr>
-          <p:cNvPr id="29" name="Rectangle 28"/>
+          <p:cNvPr id="30" name="Rectangle 29"/>
           <p:cNvSpPr/>
           <p:nvPr/>
         </p:nvSpPr>
         <p:spPr>
           <a:xfrm>
-            <a:off x="630936" y="4407408"/>
+            <a:off x="630936" y="4425696"/>
             <a:ext cx="5332323" cy="12700"/>
           </a:xfrm>
           <a:prstGeom prst="rect">
@@ -10249,14 +10777,14 @@
       </p:sp>
       <p:sp>
         <p:nvSpPr>
-          <p:cNvPr id="30" name="TextBox 29"/>
+          <p:cNvPr id="31" name="TextBox 30"/>
           <p:cNvSpPr txBox="1"/>
           <p:nvPr/>
         </p:nvSpPr>
         <p:spPr>
           <a:xfrm>
-            <a:off x="630936" y="4483608"/>
-            <a:ext cx="5332323" cy="1588008"/>
+            <a:off x="630936" y="4489196"/>
+            <a:ext cx="5332323" cy="1582420"/>
           </a:xfrm>
           <a:prstGeom prst="rect">
             <a:avLst/>
@@ -10273,7 +10801,7 @@
             <a:r>
               <a:rPr sz="750">
                 <a:solidFill>
-                  <a:srgbClr val="E4EEFF"/>
+                  <a:srgbClr val="223A6A"/>
                 </a:solidFill>
               </a:rPr>
               <a:t>Análisis predictivo de cartera para priorizar expedientes con mayor probabilidad de cobro y optimizar recursos.</a:t>
@@ -10283,7 +10811,7 @@
       </p:sp>
       <p:sp>
         <p:nvSpPr>
-          <p:cNvPr id="31" name="Rectangle 30"/>
+          <p:cNvPr id="32" name="Rectangle 31"/>
           <p:cNvSpPr/>
           <p:nvPr/>
         </p:nvSpPr>
@@ -10296,11 +10824,11 @@
             <a:avLst/>
           </a:prstGeom>
           <a:solidFill>
-            <a:srgbClr val="162A68"/>
+            <a:srgbClr val="F2F7FF"/>
           </a:solidFill>
-          <a:ln w="9525">
+          <a:ln w="6350">
             <a:solidFill>
-              <a:srgbClr val="4A68B8"/>
+              <a:srgbClr val="2FDFE5"/>
             </a:solidFill>
           </a:ln>
         </p:spPr>
@@ -10328,14 +10856,14 @@
       </p:sp>
       <p:sp>
         <p:nvSpPr>
-          <p:cNvPr id="32" name="Rectangle 31"/>
+          <p:cNvPr id="33" name="Rectangle 32"/>
           <p:cNvSpPr/>
           <p:nvPr/>
         </p:nvSpPr>
         <p:spPr>
           <a:xfrm>
             <a:off x="6274155" y="4023360"/>
-            <a:ext cx="5588355" cy="38100"/>
+            <a:ext cx="5588355" cy="50800"/>
           </a:xfrm>
           <a:prstGeom prst="rect">
             <a:avLst/>
@@ -10371,13 +10899,13 @@
       </p:sp>
       <p:sp>
         <p:nvSpPr>
-          <p:cNvPr id="33" name="Oval 32"/>
+          <p:cNvPr id="34" name="Oval 33"/>
           <p:cNvSpPr/>
           <p:nvPr/>
         </p:nvSpPr>
         <p:spPr>
           <a:xfrm>
-            <a:off x="6429603" y="4151376"/>
+            <a:off x="6429603" y="4169664"/>
             <a:ext cx="201168" cy="201168"/>
           </a:xfrm>
           <a:prstGeom prst="ellipse">
@@ -10416,13 +10944,13 @@
       </p:sp>
       <p:sp>
         <p:nvSpPr>
-          <p:cNvPr id="34" name="TextBox 33"/>
+          <p:cNvPr id="35" name="TextBox 34"/>
           <p:cNvSpPr txBox="1"/>
           <p:nvPr/>
         </p:nvSpPr>
         <p:spPr>
           <a:xfrm>
-            <a:off x="6429603" y="4151376"/>
+            <a:off x="6429603" y="4169664"/>
             <a:ext cx="201168" cy="201168"/>
           </a:xfrm>
           <a:prstGeom prst="rect">
@@ -10450,14 +10978,14 @@
       </p:sp>
       <p:sp>
         <p:nvSpPr>
-          <p:cNvPr id="35" name="TextBox 34"/>
+          <p:cNvPr id="36" name="TextBox 35"/>
           <p:cNvSpPr txBox="1"/>
           <p:nvPr/>
         </p:nvSpPr>
         <p:spPr>
           <a:xfrm>
-            <a:off x="6694779" y="4151376"/>
-            <a:ext cx="5076291" cy="365760"/>
+            <a:off x="6694779" y="4169664"/>
+            <a:ext cx="5094579" cy="347472"/>
           </a:xfrm>
           <a:prstGeom prst="rect">
             <a:avLst/>
@@ -10474,7 +11002,7 @@
             <a:r>
               <a:rPr sz="900" b="1">
                 <a:solidFill>
-                  <a:srgbClr val="FFFFFF"/>
+                  <a:srgbClr val="081432"/>
                 </a:solidFill>
               </a:rPr>
               <a:t>Reporting &amp; Dashboard</a:t>
@@ -10484,13 +11012,13 @@
       </p:sp>
       <p:sp>
         <p:nvSpPr>
-          <p:cNvPr id="36" name="Rectangle 35"/>
+          <p:cNvPr id="37" name="Rectangle 36"/>
           <p:cNvSpPr/>
           <p:nvPr/>
         </p:nvSpPr>
         <p:spPr>
           <a:xfrm>
-            <a:off x="6402171" y="4407408"/>
+            <a:off x="6402171" y="4425696"/>
             <a:ext cx="5332323" cy="12700"/>
           </a:xfrm>
           <a:prstGeom prst="rect">
@@ -10527,14 +11055,14 @@
       </p:sp>
       <p:sp>
         <p:nvSpPr>
-          <p:cNvPr id="37" name="TextBox 36"/>
+          <p:cNvPr id="38" name="TextBox 37"/>
           <p:cNvSpPr txBox="1"/>
           <p:nvPr/>
         </p:nvSpPr>
         <p:spPr>
           <a:xfrm>
-            <a:off x="6402171" y="4483608"/>
-            <a:ext cx="5332323" cy="1588008"/>
+            <a:off x="6402171" y="4489196"/>
+            <a:ext cx="5332323" cy="1582420"/>
           </a:xfrm>
           <a:prstGeom prst="rect">
             <a:avLst/>
@@ -10551,7 +11079,7 @@
             <a:r>
               <a:rPr sz="750">
                 <a:solidFill>
-                  <a:srgbClr val="E4EEFF"/>
+                  <a:srgbClr val="223A6A"/>
                 </a:solidFill>
               </a:rPr>
               <a:t>Panel de control en tiempo real con KPIs, tasa de recuperación, aging de cartera y exportación de informes ejecutivos.</a:t>
@@ -10564,8 +11092,107 @@
   <p:clrMapOvr>
     <a:masterClrMapping/>
   </p:clrMapOvr>
-  <p:transition dur="700" spd="fast">
-    <p:fade/>
+  <p:timing>
+    <p:tnLst>
+      <p:par>
+        <p:cTn id="1" dur="indefin" restart="whenNotActive" nodeType="tmRoot">
+          <p:childTnLst>
+            <p:seq concurrent="1" nextAc="seek">
+              <p:cTn id="2" dur="indefin" nodeType="mainSeq">
+                <p:childTnLst>
+                  <p:par>
+                    <p:cTn id="3" fill="hold">
+                      <p:stCondLst>
+                        <p:cond delay="0"/>
+                      </p:stCondLst>
+                      <p:childTnLst>
+                        <p:par>
+                          <p:cTn id="5" fill="hold">
+                            <p:stCondLst>
+                              <p:cond delay="0"/>
+                            </p:stCondLst>
+                            <p:childTnLst>
+                              <p:animEffect transition="in" filter="wipe(up)">
+                                <p:cBhvr>
+                                  <p:cTn id="6" dur="450" fill="hold"/>
+                                  <p:tgtEl>
+                                    <p:spTgt spid="11"/>
+                                  </p:tgtEl>
+                                </p:cBhvr>
+                              </p:animEffect>
+                            </p:childTnLst>
+                          </p:cTn>
+                        </p:par>
+                        <p:par>
+                          <p:cTn id="7" fill="hold">
+                            <p:stCondLst>
+                              <p:cond delay="160"/>
+                            </p:stCondLst>
+                            <p:childTnLst>
+                              <p:animEffect transition="in" filter="wipe(up)">
+                                <p:cBhvr>
+                                  <p:cTn id="8" dur="450" fill="hold"/>
+                                  <p:tgtEl>
+                                    <p:spTgt spid="18"/>
+                                  </p:tgtEl>
+                                </p:cBhvr>
+                              </p:animEffect>
+                            </p:childTnLst>
+                          </p:cTn>
+                        </p:par>
+                        <p:par>
+                          <p:cTn id="9" fill="hold">
+                            <p:stCondLst>
+                              <p:cond delay="320"/>
+                            </p:stCondLst>
+                            <p:childTnLst>
+                              <p:animEffect transition="in" filter="wipe(up)">
+                                <p:cBhvr>
+                                  <p:cTn id="10" dur="450" fill="hold"/>
+                                  <p:tgtEl>
+                                    <p:spTgt spid="25"/>
+                                  </p:tgtEl>
+                                </p:cBhvr>
+                              </p:animEffect>
+                            </p:childTnLst>
+                          </p:cTn>
+                        </p:par>
+                        <p:par>
+                          <p:cTn id="11" fill="hold">
+                            <p:stCondLst>
+                              <p:cond delay="480"/>
+                            </p:stCondLst>
+                            <p:childTnLst>
+                              <p:animEffect transition="in" filter="wipe(up)">
+                                <p:cBhvr>
+                                  <p:cTn id="12" dur="450" fill="hold"/>
+                                  <p:tgtEl>
+                                    <p:spTgt spid="32"/>
+                                  </p:tgtEl>
+                                </p:cBhvr>
+                              </p:animEffect>
+                            </p:childTnLst>
+                          </p:cTn>
+                        </p:par>
+                      </p:childTnLst>
+                    </p:cTn>
+                  </p:par>
+                </p:childTnLst>
+              </p:cTn>
+              <p:prevCondLst>
+                <p:cond evt="onPrevClick" delay="0"/>
+              </p:prevCondLst>
+              <p:nextCondLst>
+                <p:cond evt="onNextClick" delay="0"/>
+              </p:nextCondLst>
+            </p:seq>
+          </p:childTnLst>
+        </p:cTn>
+      </p:par>
+    </p:tnLst>
+  </p:timing>
+  <p:transition dur="500" spd="fast">
+    <p:push dir="u"/>
   </p:transition>
 </p:sld>
 </file>
@@ -10620,8 +11247,8 @@
         </p:blipFill>
         <p:spPr>
           <a:xfrm>
-            <a:off x="6979615" y="0"/>
-            <a:ext cx="5212080" cy="6858000"/>
+            <a:off x="7071055" y="0"/>
+            <a:ext cx="5120640" cy="6858000"/>
           </a:xfrm>
           <a:prstGeom prst="rect">
             <a:avLst/>
@@ -10636,15 +11263,15 @@
         </p:nvSpPr>
         <p:spPr>
           <a:xfrm>
-            <a:off x="6979615" y="0"/>
-            <a:ext cx="5212080" cy="6858000"/>
+            <a:off x="7071055" y="0"/>
+            <a:ext cx="5120640" cy="6858000"/>
           </a:xfrm>
           <a:prstGeom prst="rect">
             <a:avLst/>
           </a:prstGeom>
           <a:solidFill>
             <a:srgbClr val="060E24">
-              <a:alpha val="40000"/>
+              <a:alpha val="30000"/>
             </a:srgbClr>
           </a:solidFill>
           <a:ln>
@@ -10681,7 +11308,7 @@
         </p:nvSpPr>
         <p:spPr>
           <a:xfrm>
-            <a:off x="6941515" y="0"/>
+            <a:off x="7032955" y="0"/>
             <a:ext cx="38100" cy="6858000"/>
           </a:xfrm>
           <a:prstGeom prst="rect">
@@ -10991,7 +11618,7 @@
             <a:r>
               <a:rPr sz="900" i="1">
                 <a:solidFill>
-                  <a:srgbClr val="C8E8FF"/>
+                  <a:srgbClr val="C0E8FF"/>
                 </a:solidFill>
               </a:rPr>
               <a:t>Nuestros equipos están disponibles para comenzar de inmediato.</a:t>
@@ -11007,18 +11634,18 @@
         </p:nvSpPr>
         <p:spPr>
           <a:xfrm>
-            <a:off x="502920" y="3273552"/>
-            <a:ext cx="2103120" cy="1737360"/>
+            <a:off x="502920" y="3291840"/>
+            <a:ext cx="2121408" cy="1737360"/>
           </a:xfrm>
           <a:prstGeom prst="rect">
             <a:avLst/>
           </a:prstGeom>
           <a:solidFill>
-            <a:srgbClr val="162A68"/>
+            <a:srgbClr val="F2F7FF"/>
           </a:solidFill>
-          <a:ln w="9525">
+          <a:ln w="6350">
             <a:solidFill>
-              <a:srgbClr val="4A68B8"/>
+              <a:srgbClr val="2FDFE5"/>
             </a:solidFill>
           </a:ln>
         </p:spPr>
@@ -11052,8 +11679,8 @@
         </p:nvSpPr>
         <p:spPr>
           <a:xfrm>
-            <a:off x="502920" y="3273552"/>
-            <a:ext cx="2103120" cy="38100"/>
+            <a:off x="502920" y="3291840"/>
+            <a:ext cx="2121408" cy="50800"/>
           </a:xfrm>
           <a:prstGeom prst="rect">
             <a:avLst/>
@@ -11095,8 +11722,8 @@
         </p:nvSpPr>
         <p:spPr>
           <a:xfrm>
-            <a:off x="621792" y="3401568"/>
-            <a:ext cx="1865376" cy="256032"/>
+            <a:off x="621792" y="3429000"/>
+            <a:ext cx="1883664" cy="256032"/>
           </a:xfrm>
           <a:prstGeom prst="rect">
             <a:avLst/>
@@ -11113,7 +11740,7 @@
             <a:r>
               <a:rPr sz="950" b="1">
                 <a:solidFill>
-                  <a:srgbClr val="2FDFE5"/>
+                  <a:srgbClr val="081432"/>
                 </a:solidFill>
               </a:rPr>
               <a:t>MADRID</a:t>
@@ -11129,8 +11756,8 @@
         </p:nvSpPr>
         <p:spPr>
           <a:xfrm>
-            <a:off x="621792" y="3694176"/>
-            <a:ext cx="1865376" cy="12700"/>
+            <a:off x="621792" y="3721608"/>
+            <a:ext cx="1883664" cy="12700"/>
           </a:xfrm>
           <a:prstGeom prst="rect">
             <a:avLst/>
@@ -11172,8 +11799,8 @@
         </p:nvSpPr>
         <p:spPr>
           <a:xfrm>
-            <a:off x="621792" y="3757676"/>
-            <a:ext cx="1865376" cy="1143000"/>
+            <a:off x="621792" y="3785108"/>
+            <a:ext cx="1883664" cy="1143000"/>
           </a:xfrm>
           <a:prstGeom prst="rect">
             <a:avLst/>
@@ -11194,7 +11821,7 @@
             <a:r>
               <a:rPr sz="750">
                 <a:solidFill>
-                  <a:srgbClr val="E4EEFF"/>
+                  <a:srgbClr val="223A6A"/>
                 </a:solidFill>
               </a:rPr>
               <a:t>Gran Vía 28, 4ª planta</a:t>
@@ -11224,7 +11851,7 @@
             <a:r>
               <a:rPr sz="750">
                 <a:solidFill>
-                  <a:srgbClr val="B0CCEE"/>
+                  <a:srgbClr val="80A8CC"/>
                 </a:solidFill>
               </a:rPr>
               <a:t>madrid@sendacredit.com</a:t>
@@ -11240,18 +11867,18 @@
         </p:nvSpPr>
         <p:spPr>
           <a:xfrm>
-            <a:off x="2761488" y="3273552"/>
-            <a:ext cx="2103120" cy="1737360"/>
+            <a:off x="2779776" y="3291840"/>
+            <a:ext cx="2121408" cy="1737360"/>
           </a:xfrm>
           <a:prstGeom prst="rect">
             <a:avLst/>
           </a:prstGeom>
           <a:solidFill>
-            <a:srgbClr val="162A68"/>
+            <a:srgbClr val="F2F7FF"/>
           </a:solidFill>
-          <a:ln w="9525">
+          <a:ln w="6350">
             <a:solidFill>
-              <a:srgbClr val="4A68B8"/>
+              <a:srgbClr val="2FDFE5"/>
             </a:solidFill>
           </a:ln>
         </p:spPr>
@@ -11285,8 +11912,8 @@
         </p:nvSpPr>
         <p:spPr>
           <a:xfrm>
-            <a:off x="2761488" y="3273552"/>
-            <a:ext cx="2103120" cy="38100"/>
+            <a:off x="2779776" y="3291840"/>
+            <a:ext cx="2121408" cy="50800"/>
           </a:xfrm>
           <a:prstGeom prst="rect">
             <a:avLst/>
@@ -11328,8 +11955,8 @@
         </p:nvSpPr>
         <p:spPr>
           <a:xfrm>
-            <a:off x="2880360" y="3401568"/>
-            <a:ext cx="1865376" cy="256032"/>
+            <a:off x="2898648" y="3429000"/>
+            <a:ext cx="1883664" cy="256032"/>
           </a:xfrm>
           <a:prstGeom prst="rect">
             <a:avLst/>
@@ -11346,7 +11973,7 @@
             <a:r>
               <a:rPr sz="950" b="1">
                 <a:solidFill>
-                  <a:srgbClr val="2FDFE5"/>
+                  <a:srgbClr val="081432"/>
                 </a:solidFill>
               </a:rPr>
               <a:t>BARCELONA</a:t>
@@ -11362,8 +11989,8 @@
         </p:nvSpPr>
         <p:spPr>
           <a:xfrm>
-            <a:off x="2880360" y="3694176"/>
-            <a:ext cx="1865376" cy="12700"/>
+            <a:off x="2898648" y="3721608"/>
+            <a:ext cx="1883664" cy="12700"/>
           </a:xfrm>
           <a:prstGeom prst="rect">
             <a:avLst/>
@@ -11405,8 +12032,8 @@
         </p:nvSpPr>
         <p:spPr>
           <a:xfrm>
-            <a:off x="2880360" y="3757676"/>
-            <a:ext cx="1865376" cy="1143000"/>
+            <a:off x="2898648" y="3785108"/>
+            <a:ext cx="1883664" cy="1143000"/>
           </a:xfrm>
           <a:prstGeom prst="rect">
             <a:avLst/>
@@ -11427,7 +12054,7 @@
             <a:r>
               <a:rPr sz="750">
                 <a:solidFill>
-                  <a:srgbClr val="E4EEFF"/>
+                  <a:srgbClr val="223A6A"/>
                 </a:solidFill>
               </a:rPr>
               <a:t>Diagonal 211, 3ª planta</a:t>
@@ -11457,7 +12084,7 @@
             <a:r>
               <a:rPr sz="750">
                 <a:solidFill>
-                  <a:srgbClr val="B0CCEE"/>
+                  <a:srgbClr val="80A8CC"/>
                 </a:solidFill>
               </a:rPr>
               <a:t>barcelona@sendacredit.com</a:t>
@@ -11473,18 +12100,18 @@
         </p:nvSpPr>
         <p:spPr>
           <a:xfrm>
-            <a:off x="5020056" y="3273552"/>
-            <a:ext cx="2103120" cy="1737360"/>
+            <a:off x="5056632" y="3291840"/>
+            <a:ext cx="2121408" cy="1737360"/>
           </a:xfrm>
           <a:prstGeom prst="rect">
             <a:avLst/>
           </a:prstGeom>
           <a:solidFill>
-            <a:srgbClr val="162A68"/>
+            <a:srgbClr val="F2F7FF"/>
           </a:solidFill>
-          <a:ln w="9525">
+          <a:ln w="6350">
             <a:solidFill>
-              <a:srgbClr val="4A68B8"/>
+              <a:srgbClr val="2FDFE5"/>
             </a:solidFill>
           </a:ln>
         </p:spPr>
@@ -11518,8 +12145,8 @@
         </p:nvSpPr>
         <p:spPr>
           <a:xfrm>
-            <a:off x="5020056" y="3273552"/>
-            <a:ext cx="2103120" cy="38100"/>
+            <a:off x="5056632" y="3291840"/>
+            <a:ext cx="2121408" cy="50800"/>
           </a:xfrm>
           <a:prstGeom prst="rect">
             <a:avLst/>
@@ -11561,8 +12188,8 @@
         </p:nvSpPr>
         <p:spPr>
           <a:xfrm>
-            <a:off x="5138928" y="3401568"/>
-            <a:ext cx="1865376" cy="256032"/>
+            <a:off x="5175504" y="3429000"/>
+            <a:ext cx="1883664" cy="256032"/>
           </a:xfrm>
           <a:prstGeom prst="rect">
             <a:avLst/>
@@ -11579,7 +12206,7 @@
             <a:r>
               <a:rPr sz="950" b="1">
                 <a:solidFill>
-                  <a:srgbClr val="2FDFE5"/>
+                  <a:srgbClr val="081432"/>
                 </a:solidFill>
               </a:rPr>
               <a:t>MÁLAGA</a:t>
@@ -11595,8 +12222,8 @@
         </p:nvSpPr>
         <p:spPr>
           <a:xfrm>
-            <a:off x="5138928" y="3694176"/>
-            <a:ext cx="1865376" cy="12700"/>
+            <a:off x="5175504" y="3721608"/>
+            <a:ext cx="1883664" cy="12700"/>
           </a:xfrm>
           <a:prstGeom prst="rect">
             <a:avLst/>
@@ -11638,8 +12265,8 @@
         </p:nvSpPr>
         <p:spPr>
           <a:xfrm>
-            <a:off x="5138928" y="3757676"/>
-            <a:ext cx="1865376" cy="1143000"/>
+            <a:off x="5175504" y="3785108"/>
+            <a:ext cx="1883664" cy="1143000"/>
           </a:xfrm>
           <a:prstGeom prst="rect">
             <a:avLst/>
@@ -11660,7 +12287,7 @@
             <a:r>
               <a:rPr sz="750">
                 <a:solidFill>
-                  <a:srgbClr val="E4EEFF"/>
+                  <a:srgbClr val="223A6A"/>
                 </a:solidFill>
               </a:rPr>
               <a:t>Larios 12, 2ª planta</a:t>
@@ -11690,7 +12317,7 @@
             <a:r>
               <a:rPr sz="750">
                 <a:solidFill>
-                  <a:srgbClr val="B0CCEE"/>
+                  <a:srgbClr val="80A8CC"/>
                 </a:solidFill>
               </a:rPr>
               <a:t>malaga@sendacredit.com</a:t>
@@ -11706,8 +12333,8 @@
         </p:nvSpPr>
         <p:spPr>
           <a:xfrm>
-            <a:off x="502920" y="6437376"/>
-            <a:ext cx="4572000" cy="274320"/>
+            <a:off x="502920" y="6455664"/>
+            <a:ext cx="4572000" cy="256032"/>
           </a:xfrm>
           <a:prstGeom prst="rect">
             <a:avLst/>
@@ -11748,8 +12375,8 @@
         </p:blipFill>
         <p:spPr>
           <a:xfrm>
-            <a:off x="10116008" y="6291072"/>
-            <a:ext cx="1874519" cy="420624"/>
+            <a:off x="10161727" y="6291072"/>
+            <a:ext cx="1828800" cy="420624"/>
           </a:xfrm>
           <a:prstGeom prst="rect">
             <a:avLst/>
@@ -11761,8 +12388,90 @@
   <p:clrMapOvr>
     <a:masterClrMapping/>
   </p:clrMapOvr>
-  <p:transition dur="700" spd="fast">
-    <p:fade/>
+  <p:timing>
+    <p:tnLst>
+      <p:par>
+        <p:cTn id="1" dur="indefin" restart="whenNotActive" nodeType="tmRoot">
+          <p:childTnLst>
+            <p:seq concurrent="1" nextAc="seek">
+              <p:cTn id="2" dur="indefin" nodeType="mainSeq">
+                <p:childTnLst>
+                  <p:par>
+                    <p:cTn id="3" fill="hold">
+                      <p:stCondLst>
+                        <p:cond delay="0"/>
+                      </p:stCondLst>
+                      <p:childTnLst>
+                        <p:par>
+                          <p:cTn id="5" fill="hold">
+                            <p:stCondLst>
+                              <p:cond delay="0"/>
+                            </p:stCondLst>
+                            <p:childTnLst>
+                              <p:animEffect transition="in" filter="wipe(up)">
+                                <p:cBhvr>
+                                  <p:cTn id="6" dur="450" fill="hold"/>
+                                  <p:tgtEl>
+                                    <p:spTgt spid="13"/>
+                                  </p:tgtEl>
+                                </p:cBhvr>
+                              </p:animEffect>
+                            </p:childTnLst>
+                          </p:cTn>
+                        </p:par>
+                        <p:par>
+                          <p:cTn id="7" fill="hold">
+                            <p:stCondLst>
+                              <p:cond delay="160"/>
+                            </p:stCondLst>
+                            <p:childTnLst>
+                              <p:animEffect transition="in" filter="wipe(up)">
+                                <p:cBhvr>
+                                  <p:cTn id="8" dur="450" fill="hold"/>
+                                  <p:tgtEl>
+                                    <p:spTgt spid="18"/>
+                                  </p:tgtEl>
+                                </p:cBhvr>
+                              </p:animEffect>
+                            </p:childTnLst>
+                          </p:cTn>
+                        </p:par>
+                        <p:par>
+                          <p:cTn id="9" fill="hold">
+                            <p:stCondLst>
+                              <p:cond delay="320"/>
+                            </p:stCondLst>
+                            <p:childTnLst>
+                              <p:animEffect transition="in" filter="wipe(up)">
+                                <p:cBhvr>
+                                  <p:cTn id="10" dur="450" fill="hold"/>
+                                  <p:tgtEl>
+                                    <p:spTgt spid="23"/>
+                                  </p:tgtEl>
+                                </p:cBhvr>
+                              </p:animEffect>
+                            </p:childTnLst>
+                          </p:cTn>
+                        </p:par>
+                      </p:childTnLst>
+                    </p:cTn>
+                  </p:par>
+                </p:childTnLst>
+              </p:cTn>
+              <p:prevCondLst>
+                <p:cond evt="onPrevClick" delay="0"/>
+              </p:prevCondLst>
+              <p:nextCondLst>
+                <p:cond evt="onNextClick" delay="0"/>
+              </p:nextCondLst>
+            </p:seq>
+          </p:childTnLst>
+        </p:cTn>
+      </p:par>
+    </p:tnLst>
+  </p:timing>
+  <p:transition dur="500" spd="fast">
+    <p:push dir="u"/>
   </p:transition>
 </p:sld>
 </file>

</xml_diff>

<commit_message>
Fix PPTX: dark cards restored, overlays at 22% so photo is visible
Reverts white cards back to dark navy (#0E1E4A) with white text.
Drops full-slide overlay from 38-87% down to 22% — building photo
is now clearly visible in the background. Push transitions and wipe-up
card entrance animations preserved.

Co-Authored-By: Claude Sonnet 4.6 <noreply@anthropic.com>
Claude-Session: https://claude.ai/code/session_01BiSyRij3iqrCgrJJFpGphy
</commit_message>
<xml_diff>
--- a/sendacredit_propuesta.pptx
+++ b/sendacredit_propuesta.pptx
@@ -3158,7 +3158,7 @@
           </a:prstGeom>
           <a:solidFill>
             <a:srgbClr val="060E24">
-              <a:alpha val="35000"/>
+              <a:alpha val="28000"/>
             </a:srgbClr>
           </a:solidFill>
           <a:ln>
@@ -3505,7 +3505,7 @@
           </a:prstGeom>
           <a:solidFill>
             <a:srgbClr val="060E24">
-              <a:alpha val="38000"/>
+              <a:alpha val="22000"/>
             </a:srgbClr>
           </a:solidFill>
           <a:ln>
@@ -3838,9 +3838,9 @@
             <a:avLst/>
           </a:prstGeom>
           <a:solidFill>
-            <a:srgbClr val="F2F7FF"/>
+            <a:srgbClr val="0E1E4A"/>
           </a:solidFill>
-          <a:ln w="6350">
+          <a:ln w="12700">
             <a:solidFill>
               <a:srgbClr val="2FDFE5"/>
             </a:solidFill>
@@ -4016,7 +4016,7 @@
             <a:r>
               <a:rPr sz="950" b="1">
                 <a:solidFill>
-                  <a:srgbClr val="081432"/>
+                  <a:srgbClr val="FFFFFF"/>
                 </a:solidFill>
               </a:rPr>
               <a:t>Recepción de fichero</a:t>
@@ -4105,7 +4105,7 @@
             <a:r>
               <a:rPr sz="750">
                 <a:solidFill>
-                  <a:srgbClr val="223A6A"/>
+                  <a:srgbClr val="E4EEFF"/>
                 </a:solidFill>
               </a:rPr>
               <a:t>Integración vía SFTP seguro o API REST</a:t>
@@ -4128,7 +4128,7 @@
             <a:r>
               <a:rPr sz="750">
                 <a:solidFill>
-                  <a:srgbClr val="223A6A"/>
+                  <a:srgbClr val="E4EEFF"/>
                 </a:solidFill>
               </a:rPr>
               <a:t>Formatos: CSV, Excel, XML, JSON</a:t>
@@ -4151,7 +4151,7 @@
             <a:r>
               <a:rPr sz="750">
                 <a:solidFill>
-                  <a:srgbClr val="223A6A"/>
+                  <a:srgbClr val="E4EEFF"/>
                 </a:solidFill>
               </a:rPr>
               <a:t>Hasta 100.000 registros por lote</a:t>
@@ -4174,7 +4174,7 @@
             <a:r>
               <a:rPr sz="750">
                 <a:solidFill>
-                  <a:srgbClr val="223A6A"/>
+                  <a:srgbClr val="E4EEFF"/>
                 </a:solidFill>
               </a:rPr>
               <a:t>Acuse con hash de integridad automático</a:t>
@@ -4197,9 +4197,9 @@
             <a:avLst/>
           </a:prstGeom>
           <a:solidFill>
-            <a:srgbClr val="F2F7FF"/>
+            <a:srgbClr val="0E1E4A"/>
           </a:solidFill>
-          <a:ln w="6350">
+          <a:ln w="12700">
             <a:solidFill>
               <a:srgbClr val="2FDFE5"/>
             </a:solidFill>
@@ -4375,7 +4375,7 @@
             <a:r>
               <a:rPr sz="950" b="1">
                 <a:solidFill>
-                  <a:srgbClr val="081432"/>
+                  <a:srgbClr val="FFFFFF"/>
                 </a:solidFill>
               </a:rPr>
               <a:t>Validación y limpieza</a:t>
@@ -4464,7 +4464,7 @@
             <a:r>
               <a:rPr sz="750">
                 <a:solidFill>
-                  <a:srgbClr val="223A6A"/>
+                  <a:srgbClr val="E4EEFF"/>
                 </a:solidFill>
               </a:rPr>
               <a:t>Deduplicación y normalización de datos</a:t>
@@ -4487,7 +4487,7 @@
             <a:r>
               <a:rPr sz="750">
                 <a:solidFill>
-                  <a:srgbClr val="223A6A"/>
+                  <a:srgbClr val="E4EEFF"/>
                 </a:solidFill>
               </a:rPr>
               <a:t>Verificación de DNI/NIE y datos civiles</a:t>
@@ -4510,7 +4510,7 @@
             <a:r>
               <a:rPr sz="750">
                 <a:solidFill>
-                  <a:srgbClr val="223A6A"/>
+                  <a:srgbClr val="E4EEFF"/>
                 </a:solidFill>
               </a:rPr>
               <a:t>Actualización de contactos (ASNEF, GGSS)</a:t>
@@ -4533,7 +4533,7 @@
             <a:r>
               <a:rPr sz="750">
                 <a:solidFill>
-                  <a:srgbClr val="223A6A"/>
+                  <a:srgbClr val="E4EEFF"/>
                 </a:solidFill>
               </a:rPr>
               <a:t>Informe de calidad de cartera en 24 h</a:t>
@@ -4556,9 +4556,9 @@
             <a:avLst/>
           </a:prstGeom>
           <a:solidFill>
-            <a:srgbClr val="F2F7FF"/>
+            <a:srgbClr val="0E1E4A"/>
           </a:solidFill>
-          <a:ln w="6350">
+          <a:ln w="12700">
             <a:solidFill>
               <a:srgbClr val="2FDFE5"/>
             </a:solidFill>
@@ -4734,7 +4734,7 @@
             <a:r>
               <a:rPr sz="950" b="1">
                 <a:solidFill>
-                  <a:srgbClr val="081432"/>
+                  <a:srgbClr val="FFFFFF"/>
                 </a:solidFill>
               </a:rPr>
               <a:t>Segmentación inicial</a:t>
@@ -4823,7 +4823,7 @@
             <a:r>
               <a:rPr sz="750">
                 <a:solidFill>
-                  <a:srgbClr val="223A6A"/>
+                  <a:srgbClr val="E4EEFF"/>
                 </a:solidFill>
               </a:rPr>
               <a:t>Clasificación por antigüedad e importe</a:t>
@@ -4846,7 +4846,7 @@
             <a:r>
               <a:rPr sz="750">
                 <a:solidFill>
-                  <a:srgbClr val="223A6A"/>
+                  <a:srgbClr val="E4EEFF"/>
                 </a:solidFill>
               </a:rPr>
               <a:t>Scoring de cobrabilidad con modelo ML</a:t>
@@ -4869,7 +4869,7 @@
             <a:r>
               <a:rPr sz="750">
                 <a:solidFill>
-                  <a:srgbClr val="223A6A"/>
+                  <a:srgbClr val="E4EEFF"/>
                 </a:solidFill>
               </a:rPr>
               <a:t>Asignación de canal de recobro óptimo</a:t>
@@ -4892,7 +4892,7 @@
             <a:r>
               <a:rPr sz="750">
                 <a:solidFill>
-                  <a:srgbClr val="223A6A"/>
+                  <a:srgbClr val="E4EEFF"/>
                 </a:solidFill>
               </a:rPr>
               <a:t>Priorización por rentabilidad esperada</a:t>
@@ -5043,7 +5043,7 @@
           </a:prstGeom>
           <a:solidFill>
             <a:srgbClr val="060E24">
-              <a:alpha val="38000"/>
+              <a:alpha val="22000"/>
             </a:srgbClr>
           </a:solidFill>
           <a:ln>
@@ -5376,9 +5376,9 @@
             <a:avLst/>
           </a:prstGeom>
           <a:solidFill>
-            <a:srgbClr val="F2F7FF"/>
+            <a:srgbClr val="0E1E4A"/>
           </a:solidFill>
-          <a:ln w="6350">
+          <a:ln w="12700">
             <a:solidFill>
               <a:srgbClr val="2FDFE5"/>
             </a:solidFill>
@@ -5554,7 +5554,7 @@
             <a:r>
               <a:rPr sz="950" b="1">
                 <a:solidFill>
-                  <a:srgbClr val="081432"/>
+                  <a:srgbClr val="FFFFFF"/>
                 </a:solidFill>
               </a:rPr>
               <a:t>Contactación multicanal</a:t>
@@ -5643,7 +5643,7 @@
             <a:r>
               <a:rPr sz="750">
                 <a:solidFill>
-                  <a:srgbClr val="223A6A"/>
+                  <a:srgbClr val="E4EEFF"/>
                 </a:solidFill>
               </a:rPr>
               <a:t>Llamadas outbound con IVR especializado</a:t>
@@ -5666,7 +5666,7 @@
             <a:r>
               <a:rPr sz="750">
                 <a:solidFill>
-                  <a:srgbClr val="223A6A"/>
+                  <a:srgbClr val="E4EEFF"/>
                 </a:solidFill>
               </a:rPr>
               <a:t>SMS, email y WhatsApp Business certificado</a:t>
@@ -5689,7 +5689,7 @@
             <a:r>
               <a:rPr sz="750">
                 <a:solidFill>
-                  <a:srgbClr val="223A6A"/>
+                  <a:srgbClr val="E4EEFF"/>
                 </a:solidFill>
               </a:rPr>
               <a:t>Cartas físicas certificadas cuando procede</a:t>
@@ -5712,7 +5712,7 @@
             <a:r>
               <a:rPr sz="750">
                 <a:solidFill>
-                  <a:srgbClr val="223A6A"/>
+                  <a:srgbClr val="E4EEFF"/>
                 </a:solidFill>
               </a:rPr>
               <a:t>Ventana de contacto 8:00-22:00, L-S</a:t>
@@ -5735,9 +5735,9 @@
             <a:avLst/>
           </a:prstGeom>
           <a:solidFill>
-            <a:srgbClr val="F2F7FF"/>
+            <a:srgbClr val="0E1E4A"/>
           </a:solidFill>
-          <a:ln w="6350">
+          <a:ln w="12700">
             <a:solidFill>
               <a:srgbClr val="2FDFE5"/>
             </a:solidFill>
@@ -5913,7 +5913,7 @@
             <a:r>
               <a:rPr sz="950" b="1">
                 <a:solidFill>
-                  <a:srgbClr val="081432"/>
+                  <a:srgbClr val="FFFFFF"/>
                 </a:solidFill>
               </a:rPr>
               <a:t>Negociación de acuerdos</a:t>
@@ -6002,7 +6002,7 @@
             <a:r>
               <a:rPr sz="750">
                 <a:solidFill>
-                  <a:srgbClr val="223A6A"/>
+                  <a:srgbClr val="E4EEFF"/>
                 </a:solidFill>
               </a:rPr>
               <a:t>Quitas y daciones dentro de límites pactados</a:t>
@@ -6025,7 +6025,7 @@
             <a:r>
               <a:rPr sz="750">
                 <a:solidFill>
-                  <a:srgbClr val="223A6A"/>
+                  <a:srgbClr val="E4EEFF"/>
                 </a:solidFill>
               </a:rPr>
               <a:t>Planes de pago de 3 a 48 meses</a:t>
@@ -6048,7 +6048,7 @@
             <a:r>
               <a:rPr sz="750">
                 <a:solidFill>
-                  <a:srgbClr val="223A6A"/>
+                  <a:srgbClr val="E4EEFF"/>
                 </a:solidFill>
               </a:rPr>
               <a:t>Firma de acuerdos digitales con validez legal</a:t>
@@ -6071,7 +6071,7 @@
             <a:r>
               <a:rPr sz="750">
                 <a:solidFill>
-                  <a:srgbClr val="223A6A"/>
+                  <a:srgbClr val="E4EEFF"/>
                 </a:solidFill>
               </a:rPr>
               <a:t>Grabación de llamadas como respaldo</a:t>
@@ -6094,9 +6094,9 @@
             <a:avLst/>
           </a:prstGeom>
           <a:solidFill>
-            <a:srgbClr val="F2F7FF"/>
+            <a:srgbClr val="0E1E4A"/>
           </a:solidFill>
-          <a:ln w="6350">
+          <a:ln w="12700">
             <a:solidFill>
               <a:srgbClr val="2FDFE5"/>
             </a:solidFill>
@@ -6272,7 +6272,7 @@
             <a:r>
               <a:rPr sz="950" b="1">
                 <a:solidFill>
-                  <a:srgbClr val="081432"/>
+                  <a:srgbClr val="FFFFFF"/>
                 </a:solidFill>
               </a:rPr>
               <a:t>Seguimiento y cobro</a:t>
@@ -6361,7 +6361,7 @@
             <a:r>
               <a:rPr sz="750">
                 <a:solidFill>
-                  <a:srgbClr val="223A6A"/>
+                  <a:srgbClr val="E4EEFF"/>
                 </a:solidFill>
               </a:rPr>
               <a:t>Domiciliación SEPA y pasarela de pago online</a:t>
@@ -6384,7 +6384,7 @@
             <a:r>
               <a:rPr sz="750">
                 <a:solidFill>
-                  <a:srgbClr val="223A6A"/>
+                  <a:srgbClr val="E4EEFF"/>
                 </a:solidFill>
               </a:rPr>
               <a:t>Recordatorios automáticos de vencimientos</a:t>
@@ -6407,7 +6407,7 @@
             <a:r>
               <a:rPr sz="750">
                 <a:solidFill>
-                  <a:srgbClr val="223A6A"/>
+                  <a:srgbClr val="E4EEFF"/>
                 </a:solidFill>
               </a:rPr>
               <a:t>Renegociación ante impagos parciales</a:t>
@@ -6430,7 +6430,7 @@
             <a:r>
               <a:rPr sz="750">
                 <a:solidFill>
-                  <a:srgbClr val="223A6A"/>
+                  <a:srgbClr val="E4EEFF"/>
                 </a:solidFill>
               </a:rPr>
               <a:t>Dashboard de seguimiento en tiempo real</a:t>
@@ -6581,7 +6581,7 @@
           </a:prstGeom>
           <a:solidFill>
             <a:srgbClr val="060E24">
-              <a:alpha val="38000"/>
+              <a:alpha val="22000"/>
             </a:srgbClr>
           </a:solidFill>
           <a:ln>
@@ -6914,9 +6914,9 @@
             <a:avLst/>
           </a:prstGeom>
           <a:solidFill>
-            <a:srgbClr val="F2F7FF"/>
+            <a:srgbClr val="0E1E4A"/>
           </a:solidFill>
-          <a:ln w="6350">
+          <a:ln w="12700">
             <a:solidFill>
               <a:srgbClr val="2FDFE5"/>
             </a:solidFill>
@@ -7092,7 +7092,7 @@
             <a:r>
               <a:rPr sz="950" b="1">
                 <a:solidFill>
-                  <a:srgbClr val="081432"/>
+                  <a:srgbClr val="FFFFFF"/>
                 </a:solidFill>
               </a:rPr>
               <a:t>Análisis de viabilidad</a:t>
@@ -7181,7 +7181,7 @@
             <a:r>
               <a:rPr sz="750">
                 <a:solidFill>
-                  <a:srgbClr val="223A6A"/>
+                  <a:srgbClr val="E4EEFF"/>
                 </a:solidFill>
               </a:rPr>
               <a:t>Revisión de prescripción y documentación</a:t>
@@ -7204,7 +7204,7 @@
             <a:r>
               <a:rPr sz="750">
                 <a:solidFill>
-                  <a:srgbClr val="223A6A"/>
+                  <a:srgbClr val="E4EEFF"/>
                 </a:solidFill>
               </a:rPr>
               <a:t>Estudio de solvencia y localización de bienes</a:t>
@@ -7227,7 +7227,7 @@
             <a:r>
               <a:rPr sz="750">
                 <a:solidFill>
-                  <a:srgbClr val="223A6A"/>
+                  <a:srgbClr val="E4EEFF"/>
                 </a:solidFill>
               </a:rPr>
               <a:t>Valoración coste-beneficio por expediente</a:t>
@@ -7250,7 +7250,7 @@
             <a:r>
               <a:rPr sz="750">
                 <a:solidFill>
-                  <a:srgbClr val="223A6A"/>
+                  <a:srgbClr val="E4EEFF"/>
                 </a:solidFill>
               </a:rPr>
               <a:t>Decisión de elevación judicial en 48-72 h</a:t>
@@ -7273,9 +7273,9 @@
             <a:avLst/>
           </a:prstGeom>
           <a:solidFill>
-            <a:srgbClr val="F2F7FF"/>
+            <a:srgbClr val="0E1E4A"/>
           </a:solidFill>
-          <a:ln w="6350">
+          <a:ln w="12700">
             <a:solidFill>
               <a:srgbClr val="2FDFE5"/>
             </a:solidFill>
@@ -7451,7 +7451,7 @@
             <a:r>
               <a:rPr sz="950" b="1">
                 <a:solidFill>
-                  <a:srgbClr val="081432"/>
+                  <a:srgbClr val="FFFFFF"/>
                 </a:solidFill>
               </a:rPr>
               <a:t>Proceso judicial</a:t>
@@ -7540,7 +7540,7 @@
             <a:r>
               <a:rPr sz="750">
                 <a:solidFill>
-                  <a:srgbClr val="223A6A"/>
+                  <a:srgbClr val="E4EEFF"/>
                 </a:solidFill>
               </a:rPr>
               <a:t>Interposición de monitorio o juicio verbal</a:t>
@@ -7563,7 +7563,7 @@
             <a:r>
               <a:rPr sz="750">
                 <a:solidFill>
-                  <a:srgbClr val="223A6A"/>
+                  <a:srgbClr val="E4EEFF"/>
                 </a:solidFill>
               </a:rPr>
               <a:t>Red de letrados en todas las CC.AA.</a:t>
@@ -7586,7 +7586,7 @@
             <a:r>
               <a:rPr sz="750">
                 <a:solidFill>
-                  <a:srgbClr val="223A6A"/>
+                  <a:srgbClr val="E4EEFF"/>
                 </a:solidFill>
               </a:rPr>
               <a:t>Coordinación con procuradores y notificaciones</a:t>
@@ -7609,7 +7609,7 @@
             <a:r>
               <a:rPr sz="750">
                 <a:solidFill>
-                  <a:srgbClr val="223A6A"/>
+                  <a:srgbClr val="E4EEFF"/>
                 </a:solidFill>
               </a:rPr>
               <a:t>Reporting de estado mensual</a:t>
@@ -7632,9 +7632,9 @@
             <a:avLst/>
           </a:prstGeom>
           <a:solidFill>
-            <a:srgbClr val="F2F7FF"/>
+            <a:srgbClr val="0E1E4A"/>
           </a:solidFill>
-          <a:ln w="6350">
+          <a:ln w="12700">
             <a:solidFill>
               <a:srgbClr val="2FDFE5"/>
             </a:solidFill>
@@ -7810,7 +7810,7 @@
             <a:r>
               <a:rPr sz="950" b="1">
                 <a:solidFill>
-                  <a:srgbClr val="081432"/>
+                  <a:srgbClr val="FFFFFF"/>
                 </a:solidFill>
               </a:rPr>
               <a:t>Ejecución y cobro</a:t>
@@ -7899,7 +7899,7 @@
             <a:r>
               <a:rPr sz="750">
                 <a:solidFill>
-                  <a:srgbClr val="223A6A"/>
+                  <a:srgbClr val="E4EEFF"/>
                 </a:solidFill>
               </a:rPr>
               <a:t>Embargo de cuentas, nóminas e inmuebles</a:t>
@@ -7922,7 +7922,7 @@
             <a:r>
               <a:rPr sz="750">
                 <a:solidFill>
-                  <a:srgbClr val="223A6A"/>
+                  <a:srgbClr val="E4EEFF"/>
                 </a:solidFill>
               </a:rPr>
               <a:t>Seguimiento de subastas judiciales</a:t>
@@ -7945,7 +7945,7 @@
             <a:r>
               <a:rPr sz="750">
                 <a:solidFill>
-                  <a:srgbClr val="223A6A"/>
+                  <a:srgbClr val="E4EEFF"/>
                 </a:solidFill>
               </a:rPr>
               <a:t>Liquidación y transferencia en 5 días hábiles</a:t>
@@ -7968,7 +7968,7 @@
             <a:r>
               <a:rPr sz="750">
                 <a:solidFill>
-                  <a:srgbClr val="223A6A"/>
+                  <a:srgbClr val="E4EEFF"/>
                 </a:solidFill>
               </a:rPr>
               <a:t>Acta de cierre con detalle de costas</a:t>
@@ -8119,7 +8119,7 @@
           </a:prstGeom>
           <a:solidFill>
             <a:srgbClr val="060E24">
-              <a:alpha val="38000"/>
+              <a:alpha val="22000"/>
             </a:srgbClr>
           </a:solidFill>
           <a:ln>
@@ -8452,9 +8452,9 @@
             <a:avLst/>
           </a:prstGeom>
           <a:solidFill>
-            <a:srgbClr val="F2F7FF"/>
+            <a:srgbClr val="0E1E4A"/>
           </a:solidFill>
-          <a:ln w="6350">
+          <a:ln w="12700">
             <a:solidFill>
               <a:srgbClr val="2FDFE5"/>
             </a:solidFill>
@@ -8630,7 +8630,7 @@
             <a:r>
               <a:rPr sz="950" b="1">
                 <a:solidFill>
-                  <a:srgbClr val="081432"/>
+                  <a:srgbClr val="FFFFFF"/>
                 </a:solidFill>
               </a:rPr>
               <a:t>Informes periódicos</a:t>
@@ -8719,7 +8719,7 @@
             <a:r>
               <a:rPr sz="750">
                 <a:solidFill>
-                  <a:srgbClr val="223A6A"/>
+                  <a:srgbClr val="E4EEFF"/>
                 </a:solidFill>
               </a:rPr>
               <a:t>Informe semanal de actividad y contactaciones</a:t>
@@ -8742,7 +8742,7 @@
             <a:r>
               <a:rPr sz="750">
                 <a:solidFill>
-                  <a:srgbClr val="223A6A"/>
+                  <a:srgbClr val="E4EEFF"/>
                 </a:solidFill>
               </a:rPr>
               <a:t>Reporte mensual de recuperación y aging</a:t>
@@ -8765,7 +8765,7 @@
             <a:r>
               <a:rPr sz="750">
                 <a:solidFill>
-                  <a:srgbClr val="223A6A"/>
+                  <a:srgbClr val="E4EEFF"/>
                 </a:solidFill>
               </a:rPr>
               <a:t>Cuadro de mando ejecutivo trimestral</a:t>
@@ -8788,7 +8788,7 @@
             <a:r>
               <a:rPr sz="750">
                 <a:solidFill>
-                  <a:srgbClr val="223A6A"/>
+                  <a:srgbClr val="E4EEFF"/>
                 </a:solidFill>
               </a:rPr>
               <a:t>Exportación en PDF, Excel y API JSON</a:t>
@@ -8811,9 +8811,9 @@
             <a:avLst/>
           </a:prstGeom>
           <a:solidFill>
-            <a:srgbClr val="F2F7FF"/>
+            <a:srgbClr val="0E1E4A"/>
           </a:solidFill>
-          <a:ln w="6350">
+          <a:ln w="12700">
             <a:solidFill>
               <a:srgbClr val="2FDFE5"/>
             </a:solidFill>
@@ -8989,7 +8989,7 @@
             <a:r>
               <a:rPr sz="950" b="1">
                 <a:solidFill>
-                  <a:srgbClr val="081432"/>
+                  <a:srgbClr val="FFFFFF"/>
                 </a:solidFill>
               </a:rPr>
               <a:t>Liquidación y remesas</a:t>
@@ -9078,7 +9078,7 @@
             <a:r>
               <a:rPr sz="750">
                 <a:solidFill>
-                  <a:srgbClr val="223A6A"/>
+                  <a:srgbClr val="E4EEFF"/>
                 </a:solidFill>
               </a:rPr>
               <a:t>Liquidación quincenal por expediente</a:t>
@@ -9101,7 +9101,7 @@
             <a:r>
               <a:rPr sz="750">
                 <a:solidFill>
-                  <a:srgbClr val="223A6A"/>
+                  <a:srgbClr val="E4EEFF"/>
                 </a:solidFill>
               </a:rPr>
               <a:t>Transferencia SEPA en T+2 hábiles</a:t>
@@ -9124,7 +9124,7 @@
             <a:r>
               <a:rPr sz="750">
                 <a:solidFill>
-                  <a:srgbClr val="223A6A"/>
+                  <a:srgbClr val="E4EEFF"/>
                 </a:solidFill>
               </a:rPr>
               <a:t>Conciliación automática con ERP/CRM</a:t>
@@ -9147,7 +9147,7 @@
             <a:r>
               <a:rPr sz="750">
                 <a:solidFill>
-                  <a:srgbClr val="223A6A"/>
+                  <a:srgbClr val="E4EEFF"/>
                 </a:solidFill>
               </a:rPr>
               <a:t>Facturación electrónica certificada</a:t>
@@ -9170,9 +9170,9 @@
             <a:avLst/>
           </a:prstGeom>
           <a:solidFill>
-            <a:srgbClr val="F2F7FF"/>
+            <a:srgbClr val="0E1E4A"/>
           </a:solidFill>
-          <a:ln w="6350">
+          <a:ln w="12700">
             <a:solidFill>
               <a:srgbClr val="2FDFE5"/>
             </a:solidFill>
@@ -9348,7 +9348,7 @@
             <a:r>
               <a:rPr sz="950" b="1">
                 <a:solidFill>
-                  <a:srgbClr val="081432"/>
+                  <a:srgbClr val="FFFFFF"/>
                 </a:solidFill>
               </a:rPr>
               <a:t>Control de calidad</a:t>
@@ -9437,7 +9437,7 @@
             <a:r>
               <a:rPr sz="750">
                 <a:solidFill>
-                  <a:srgbClr val="223A6A"/>
+                  <a:srgbClr val="E4EEFF"/>
                 </a:solidFill>
               </a:rPr>
               <a:t>Auditoría interna mensual de procesos</a:t>
@@ -9460,7 +9460,7 @@
             <a:r>
               <a:rPr sz="750">
                 <a:solidFill>
-                  <a:srgbClr val="223A6A"/>
+                  <a:srgbClr val="E4EEFF"/>
                 </a:solidFill>
               </a:rPr>
               <a:t>Mystery calling y escucha de grabaciones</a:t>
@@ -9483,7 +9483,7 @@
             <a:r>
               <a:rPr sz="750">
                 <a:solidFill>
-                  <a:srgbClr val="223A6A"/>
+                  <a:srgbClr val="E4EEFF"/>
                 </a:solidFill>
               </a:rPr>
               <a:t>Comité de mejora continua trimestral</a:t>
@@ -9506,7 +9506,7 @@
             <a:r>
               <a:rPr sz="750">
                 <a:solidFill>
-                  <a:srgbClr val="223A6A"/>
+                  <a:srgbClr val="E4EEFF"/>
                 </a:solidFill>
               </a:rPr>
               <a:t>Certificación ISO 9001 y cumplimiento RGPD</a:t>
@@ -9657,7 +9657,7 @@
           </a:prstGeom>
           <a:solidFill>
             <a:srgbClr val="060E24">
-              <a:alpha val="40000"/>
+              <a:alpha val="22000"/>
             </a:srgbClr>
           </a:solidFill>
           <a:ln>
@@ -9990,7 +9990,7 @@
             <a:avLst/>
           </a:prstGeom>
           <a:solidFill>
-            <a:srgbClr val="F2F7FF"/>
+            <a:srgbClr val="0E1E4A"/>
           </a:solidFill>
           <a:ln w="6350">
             <a:solidFill>
@@ -10168,7 +10168,7 @@
             <a:r>
               <a:rPr sz="900" b="1">
                 <a:solidFill>
-                  <a:srgbClr val="081432"/>
+                  <a:srgbClr val="FFFFFF"/>
                 </a:solidFill>
               </a:rPr>
               <a:t>Gestión de Cobro Amistoso</a:t>
@@ -10245,7 +10245,7 @@
             <a:r>
               <a:rPr sz="750">
                 <a:solidFill>
-                  <a:srgbClr val="223A6A"/>
+                  <a:srgbClr val="E4EEFF"/>
                 </a:solidFill>
               </a:rPr>
               <a:t>Negociación extrajudicial, planes de pago personalizados y seguimiento continuo hasta la resolución del expediente.</a:t>
@@ -10268,7 +10268,7 @@
             <a:avLst/>
           </a:prstGeom>
           <a:solidFill>
-            <a:srgbClr val="F2F7FF"/>
+            <a:srgbClr val="0E1E4A"/>
           </a:solidFill>
           <a:ln w="6350">
             <a:solidFill>
@@ -10446,7 +10446,7 @@
             <a:r>
               <a:rPr sz="900" b="1">
                 <a:solidFill>
-                  <a:srgbClr val="081432"/>
+                  <a:srgbClr val="FFFFFF"/>
                 </a:solidFill>
               </a:rPr>
               <a:t>Recobro Judicial</a:t>
@@ -10523,7 +10523,7 @@
             <a:r>
               <a:rPr sz="750">
                 <a:solidFill>
-                  <a:srgbClr val="223A6A"/>
+                  <a:srgbClr val="E4EEFF"/>
                 </a:solidFill>
               </a:rPr>
               <a:t>Interposición de demandas, coordinación con letrados y ejecución de sentencias a través de procuradores especializados.</a:t>
@@ -10546,7 +10546,7 @@
             <a:avLst/>
           </a:prstGeom>
           <a:solidFill>
-            <a:srgbClr val="F2F7FF"/>
+            <a:srgbClr val="0E1E4A"/>
           </a:solidFill>
           <a:ln w="6350">
             <a:solidFill>
@@ -10724,7 +10724,7 @@
             <a:r>
               <a:rPr sz="900" b="1">
                 <a:solidFill>
-                  <a:srgbClr val="081432"/>
+                  <a:srgbClr val="FFFFFF"/>
                 </a:solidFill>
               </a:rPr>
               <a:t>Scoring &amp; Segmentación</a:t>
@@ -10801,7 +10801,7 @@
             <a:r>
               <a:rPr sz="750">
                 <a:solidFill>
-                  <a:srgbClr val="223A6A"/>
+                  <a:srgbClr val="E4EEFF"/>
                 </a:solidFill>
               </a:rPr>
               <a:t>Análisis predictivo de cartera para priorizar expedientes con mayor probabilidad de cobro y optimizar recursos.</a:t>
@@ -10824,7 +10824,7 @@
             <a:avLst/>
           </a:prstGeom>
           <a:solidFill>
-            <a:srgbClr val="F2F7FF"/>
+            <a:srgbClr val="0E1E4A"/>
           </a:solidFill>
           <a:ln w="6350">
             <a:solidFill>
@@ -11002,7 +11002,7 @@
             <a:r>
               <a:rPr sz="900" b="1">
                 <a:solidFill>
-                  <a:srgbClr val="081432"/>
+                  <a:srgbClr val="FFFFFF"/>
                 </a:solidFill>
               </a:rPr>
               <a:t>Reporting &amp; Dashboard</a:t>
@@ -11079,7 +11079,7 @@
             <a:r>
               <a:rPr sz="750">
                 <a:solidFill>
-                  <a:srgbClr val="223A6A"/>
+                  <a:srgbClr val="E4EEFF"/>
                 </a:solidFill>
               </a:rPr>
               <a:t>Panel de control en tiempo real con KPIs, tasa de recuperación, aging de cartera y exportación de informes ejecutivos.</a:t>
@@ -11271,7 +11271,7 @@
           </a:prstGeom>
           <a:solidFill>
             <a:srgbClr val="060E24">
-              <a:alpha val="30000"/>
+              <a:alpha val="22000"/>
             </a:srgbClr>
           </a:solidFill>
           <a:ln>
@@ -11641,7 +11641,7 @@
             <a:avLst/>
           </a:prstGeom>
           <a:solidFill>
-            <a:srgbClr val="F2F7FF"/>
+            <a:srgbClr val="0E1E4A"/>
           </a:solidFill>
           <a:ln w="6350">
             <a:solidFill>
@@ -11740,7 +11740,7 @@
             <a:r>
               <a:rPr sz="950" b="1">
                 <a:solidFill>
-                  <a:srgbClr val="081432"/>
+                  <a:srgbClr val="FFFFFF"/>
                 </a:solidFill>
               </a:rPr>
               <a:t>MADRID</a:t>
@@ -11821,7 +11821,7 @@
             <a:r>
               <a:rPr sz="750">
                 <a:solidFill>
-                  <a:srgbClr val="223A6A"/>
+                  <a:srgbClr val="E4EEFF"/>
                 </a:solidFill>
               </a:rPr>
               <a:t>Gran Vía 28, 4ª planta</a:t>
@@ -11874,7 +11874,7 @@
             <a:avLst/>
           </a:prstGeom>
           <a:solidFill>
-            <a:srgbClr val="F2F7FF"/>
+            <a:srgbClr val="0E1E4A"/>
           </a:solidFill>
           <a:ln w="6350">
             <a:solidFill>
@@ -11973,7 +11973,7 @@
             <a:r>
               <a:rPr sz="950" b="1">
                 <a:solidFill>
-                  <a:srgbClr val="081432"/>
+                  <a:srgbClr val="FFFFFF"/>
                 </a:solidFill>
               </a:rPr>
               <a:t>BARCELONA</a:t>
@@ -12054,7 +12054,7 @@
             <a:r>
               <a:rPr sz="750">
                 <a:solidFill>
-                  <a:srgbClr val="223A6A"/>
+                  <a:srgbClr val="E4EEFF"/>
                 </a:solidFill>
               </a:rPr>
               <a:t>Diagonal 211, 3ª planta</a:t>
@@ -12107,7 +12107,7 @@
             <a:avLst/>
           </a:prstGeom>
           <a:solidFill>
-            <a:srgbClr val="F2F7FF"/>
+            <a:srgbClr val="0E1E4A"/>
           </a:solidFill>
           <a:ln w="6350">
             <a:solidFill>
@@ -12206,7 +12206,7 @@
             <a:r>
               <a:rPr sz="950" b="1">
                 <a:solidFill>
-                  <a:srgbClr val="081432"/>
+                  <a:srgbClr val="FFFFFF"/>
                 </a:solidFill>
               </a:rPr>
               <a:t>MÁLAGA</a:t>
@@ -12287,7 +12287,7 @@
             <a:r>
               <a:rPr sz="750">
                 <a:solidFill>
-                  <a:srgbClr val="223A6A"/>
+                  <a:srgbClr val="E4EEFF"/>
                 </a:solidFill>
               </a:rPr>
               <a:t>Larios 12, 2ª planta</a:t>

</xml_diff>

<commit_message>
Fix logo distortion and uneven darkness in PPTX
Logo fix: add_picture with width-only (no height) to preserve natural
aspect ratio. Round logo is 600×348 (not square), horizontal is 1196×384 —
forcing both dims was stretching them.

Darkness fix: replace solid dark nav bar with layered semi-transparent
overlays (44% full slide + 20% top-area scrim = ~57% at title zone,
44% at card zone). Transition is now gradual instead of a hard band.

Co-Authored-By: Claude Sonnet 4.6 <noreply@anthropic.com>
Claude-Session: https://claude.ai/code/session_01BiSyRij3iqrCgrJJFpGphy
</commit_message>
<xml_diff>
--- a/sendacredit_propuesta.pptx
+++ b/sendacredit_propuesta.pptx
@@ -3246,8 +3246,8 @@
         </p:blipFill>
         <p:spPr>
           <a:xfrm>
-            <a:off x="658368" y="365760"/>
-            <a:ext cx="1024128" cy="1024128"/>
+            <a:off x="658368" y="347472"/>
+            <a:ext cx="1051560" cy="609905"/>
           </a:xfrm>
           <a:prstGeom prst="rect">
             <a:avLst/>
@@ -3505,7 +3505,7 @@
           </a:prstGeom>
           <a:solidFill>
             <a:srgbClr val="060E24">
-              <a:alpha val="22000"/>
+              <a:alpha val="44000"/>
             </a:srgbClr>
           </a:solidFill>
           <a:ln>
@@ -3543,13 +3543,15 @@
         <p:spPr>
           <a:xfrm>
             <a:off x="0" y="0"/>
-            <a:ext cx="12191695" cy="1664208"/>
+            <a:ext cx="12191695" cy="1645920"/>
           </a:xfrm>
           <a:prstGeom prst="rect">
             <a:avLst/>
           </a:prstGeom>
           <a:solidFill>
-            <a:srgbClr val="0A1638"/>
+            <a:srgbClr val="060E24">
+              <a:alpha val="20000"/>
+            </a:srgbClr>
           </a:solidFill>
           <a:ln>
             <a:noFill/>
@@ -3815,8 +3817,8 @@
         </p:blipFill>
         <p:spPr>
           <a:xfrm>
-            <a:off x="10161727" y="6291072"/>
-            <a:ext cx="1828800" cy="420624"/>
+            <a:off x="10161727" y="6124523"/>
+            <a:ext cx="1828800" cy="587173"/>
           </a:xfrm>
           <a:prstGeom prst="rect">
             <a:avLst/>
@@ -5043,7 +5045,7 @@
           </a:prstGeom>
           <a:solidFill>
             <a:srgbClr val="060E24">
-              <a:alpha val="22000"/>
+              <a:alpha val="44000"/>
             </a:srgbClr>
           </a:solidFill>
           <a:ln>
@@ -5081,13 +5083,15 @@
         <p:spPr>
           <a:xfrm>
             <a:off x="0" y="0"/>
-            <a:ext cx="12191695" cy="1664208"/>
+            <a:ext cx="12191695" cy="1645920"/>
           </a:xfrm>
           <a:prstGeom prst="rect">
             <a:avLst/>
           </a:prstGeom>
           <a:solidFill>
-            <a:srgbClr val="0A1638"/>
+            <a:srgbClr val="060E24">
+              <a:alpha val="20000"/>
+            </a:srgbClr>
           </a:solidFill>
           <a:ln>
             <a:noFill/>
@@ -5353,8 +5357,8 @@
         </p:blipFill>
         <p:spPr>
           <a:xfrm>
-            <a:off x="10161727" y="6291072"/>
-            <a:ext cx="1828800" cy="420624"/>
+            <a:off x="10161727" y="6124523"/>
+            <a:ext cx="1828800" cy="587173"/>
           </a:xfrm>
           <a:prstGeom prst="rect">
             <a:avLst/>
@@ -6581,7 +6585,7 @@
           </a:prstGeom>
           <a:solidFill>
             <a:srgbClr val="060E24">
-              <a:alpha val="22000"/>
+              <a:alpha val="44000"/>
             </a:srgbClr>
           </a:solidFill>
           <a:ln>
@@ -6619,13 +6623,15 @@
         <p:spPr>
           <a:xfrm>
             <a:off x="0" y="0"/>
-            <a:ext cx="12191695" cy="1664208"/>
+            <a:ext cx="12191695" cy="1645920"/>
           </a:xfrm>
           <a:prstGeom prst="rect">
             <a:avLst/>
           </a:prstGeom>
           <a:solidFill>
-            <a:srgbClr val="0A1638"/>
+            <a:srgbClr val="060E24">
+              <a:alpha val="20000"/>
+            </a:srgbClr>
           </a:solidFill>
           <a:ln>
             <a:noFill/>
@@ -6891,8 +6897,8 @@
         </p:blipFill>
         <p:spPr>
           <a:xfrm>
-            <a:off x="10161727" y="6291072"/>
-            <a:ext cx="1828800" cy="420624"/>
+            <a:off x="10161727" y="6124523"/>
+            <a:ext cx="1828800" cy="587173"/>
           </a:xfrm>
           <a:prstGeom prst="rect">
             <a:avLst/>
@@ -8119,7 +8125,7 @@
           </a:prstGeom>
           <a:solidFill>
             <a:srgbClr val="060E24">
-              <a:alpha val="22000"/>
+              <a:alpha val="44000"/>
             </a:srgbClr>
           </a:solidFill>
           <a:ln>
@@ -8157,13 +8163,15 @@
         <p:spPr>
           <a:xfrm>
             <a:off x="0" y="0"/>
-            <a:ext cx="12191695" cy="1664208"/>
+            <a:ext cx="12191695" cy="1645920"/>
           </a:xfrm>
           <a:prstGeom prst="rect">
             <a:avLst/>
           </a:prstGeom>
           <a:solidFill>
-            <a:srgbClr val="0A1638"/>
+            <a:srgbClr val="060E24">
+              <a:alpha val="20000"/>
+            </a:srgbClr>
           </a:solidFill>
           <a:ln>
             <a:noFill/>
@@ -8429,8 +8437,8 @@
         </p:blipFill>
         <p:spPr>
           <a:xfrm>
-            <a:off x="10161727" y="6291072"/>
-            <a:ext cx="1828800" cy="420624"/>
+            <a:off x="10161727" y="6124523"/>
+            <a:ext cx="1828800" cy="587173"/>
           </a:xfrm>
           <a:prstGeom prst="rect">
             <a:avLst/>
@@ -9657,7 +9665,7 @@
           </a:prstGeom>
           <a:solidFill>
             <a:srgbClr val="060E24">
-              <a:alpha val="22000"/>
+              <a:alpha val="44000"/>
             </a:srgbClr>
           </a:solidFill>
           <a:ln>
@@ -9695,13 +9703,15 @@
         <p:spPr>
           <a:xfrm>
             <a:off x="0" y="0"/>
-            <a:ext cx="12191695" cy="1664208"/>
+            <a:ext cx="12191695" cy="1645920"/>
           </a:xfrm>
           <a:prstGeom prst="rect">
             <a:avLst/>
           </a:prstGeom>
           <a:solidFill>
-            <a:srgbClr val="0A1638"/>
+            <a:srgbClr val="060E24">
+              <a:alpha val="20000"/>
+            </a:srgbClr>
           </a:solidFill>
           <a:ln>
             <a:noFill/>
@@ -9967,8 +9977,8 @@
         </p:blipFill>
         <p:spPr>
           <a:xfrm>
-            <a:off x="10161727" y="6291072"/>
-            <a:ext cx="1828800" cy="420624"/>
+            <a:off x="10161727" y="6124523"/>
+            <a:ext cx="1828800" cy="587173"/>
           </a:xfrm>
           <a:prstGeom prst="rect">
             <a:avLst/>
@@ -11446,7 +11456,7 @@
         <p:spPr>
           <a:xfrm>
             <a:off x="502920" y="310896"/>
-            <a:ext cx="960120" cy="960120"/>
+            <a:ext cx="1005840" cy="583387"/>
           </a:xfrm>
           <a:prstGeom prst="rect">
             <a:avLst/>
@@ -12375,8 +12385,8 @@
         </p:blipFill>
         <p:spPr>
           <a:xfrm>
-            <a:off x="10161727" y="6291072"/>
-            <a:ext cx="1828800" cy="420624"/>
+            <a:off x="10161727" y="6124523"/>
+            <a:ext cx="1828800" cy="587173"/>
           </a:xfrm>
           <a:prstGeom prst="rect">
             <a:avLst/>

</xml_diff>

<commit_message>
Fix uneven lighting: solid gradient bg on content slides, no photo overlay
Root cause: building photo has varying brightness zones that can't be
made uniform with overlays. Fix: replace photo+overlay on slides 2-6
with a procedurally generated solid navy gradient (uniform by design).
Cover and contact slides keep the building photo in controlled panels.

Co-Authored-By: Claude Sonnet 4.6 <noreply@anthropic.com>
Claude-Session: https://claude.ai/code/session_01BiSyRij3iqrCgrJJFpGphy
</commit_message>
<xml_diff>
--- a/sendacredit_propuesta.pptx
+++ b/sendacredit_propuesta.pptx
@@ -3467,7 +3467,7 @@
       <p:grpSpPr/>
       <p:pic>
         <p:nvPicPr>
-          <p:cNvPr id="2" name="Picture 1" descr="building.jpg"/>
+          <p:cNvPr id="2" name="Picture 1" descr="content_bg.png"/>
           <p:cNvPicPr>
             <a:picLocks noChangeAspect="1"/>
           </p:cNvPicPr>
@@ -3498,96 +3498,6 @@
         <p:spPr>
           <a:xfrm>
             <a:off x="0" y="0"/>
-            <a:ext cx="12191695" cy="6858000"/>
-          </a:xfrm>
-          <a:prstGeom prst="rect">
-            <a:avLst/>
-          </a:prstGeom>
-          <a:solidFill>
-            <a:srgbClr val="060E24">
-              <a:alpha val="44000"/>
-            </a:srgbClr>
-          </a:solidFill>
-          <a:ln>
-            <a:noFill/>
-          </a:ln>
-        </p:spPr>
-        <p:style>
-          <a:lnRef idx="1">
-            <a:schemeClr val="accent1"/>
-          </a:lnRef>
-          <a:fillRef idx="3">
-            <a:schemeClr val="accent1"/>
-          </a:fillRef>
-          <a:effectRef idx="2">
-            <a:schemeClr val="accent1"/>
-          </a:effectRef>
-          <a:fontRef idx="minor">
-            <a:schemeClr val="lt1"/>
-          </a:fontRef>
-        </p:style>
-        <p:txBody>
-          <a:bodyPr rtlCol="0" anchor="ctr"/>
-          <a:lstStyle/>
-          <a:p>
-            <a:pPr algn="ctr"/>
-          </a:p>
-        </p:txBody>
-      </p:sp>
-      <p:sp>
-        <p:nvSpPr>
-          <p:cNvPr id="4" name="Rectangle 3"/>
-          <p:cNvSpPr/>
-          <p:nvPr/>
-        </p:nvSpPr>
-        <p:spPr>
-          <a:xfrm>
-            <a:off x="0" y="0"/>
-            <a:ext cx="12191695" cy="1645920"/>
-          </a:xfrm>
-          <a:prstGeom prst="rect">
-            <a:avLst/>
-          </a:prstGeom>
-          <a:solidFill>
-            <a:srgbClr val="060E24">
-              <a:alpha val="20000"/>
-            </a:srgbClr>
-          </a:solidFill>
-          <a:ln>
-            <a:noFill/>
-          </a:ln>
-        </p:spPr>
-        <p:style>
-          <a:lnRef idx="1">
-            <a:schemeClr val="accent1"/>
-          </a:lnRef>
-          <a:fillRef idx="3">
-            <a:schemeClr val="accent1"/>
-          </a:fillRef>
-          <a:effectRef idx="2">
-            <a:schemeClr val="accent1"/>
-          </a:effectRef>
-          <a:fontRef idx="minor">
-            <a:schemeClr val="lt1"/>
-          </a:fontRef>
-        </p:style>
-        <p:txBody>
-          <a:bodyPr rtlCol="0" anchor="ctr"/>
-          <a:lstStyle/>
-          <a:p>
-            <a:pPr algn="ctr"/>
-          </a:p>
-        </p:txBody>
-      </p:sp>
-      <p:sp>
-        <p:nvSpPr>
-          <p:cNvPr id="5" name="Rectangle 4"/>
-          <p:cNvSpPr/>
-          <p:nvPr/>
-        </p:nvSpPr>
-        <p:spPr>
-          <a:xfrm>
-            <a:off x="0" y="0"/>
             <a:ext cx="12191695" cy="44450"/>
           </a:xfrm>
           <a:prstGeom prst="rect">
@@ -3624,7 +3534,7 @@
       </p:sp>
       <p:sp>
         <p:nvSpPr>
-          <p:cNvPr id="6" name="Rectangle 5"/>
+          <p:cNvPr id="4" name="Rectangle 3"/>
           <p:cNvSpPr/>
           <p:nvPr/>
         </p:nvSpPr>
@@ -3667,7 +3577,7 @@
       </p:sp>
       <p:sp>
         <p:nvSpPr>
-          <p:cNvPr id="7" name="Rectangle 6"/>
+          <p:cNvPr id="5" name="Rectangle 4"/>
           <p:cNvSpPr/>
           <p:nvPr/>
         </p:nvSpPr>
@@ -3718,7 +3628,7 @@
       </p:sp>
       <p:sp>
         <p:nvSpPr>
-          <p:cNvPr id="8" name="TextBox 7"/>
+          <p:cNvPr id="6" name="TextBox 5"/>
           <p:cNvSpPr txBox="1"/>
           <p:nvPr/>
         </p:nvSpPr>
@@ -3760,7 +3670,7 @@
       </p:sp>
       <p:sp>
         <p:nvSpPr>
-          <p:cNvPr id="9" name="Rectangle 8"/>
+          <p:cNvPr id="7" name="Rectangle 6"/>
           <p:cNvSpPr/>
           <p:nvPr/>
         </p:nvSpPr>
@@ -3803,7 +3713,7 @@
       </p:sp>
       <p:pic>
         <p:nvPicPr>
-          <p:cNvPr id="10" name="Picture 9" descr="logo_horiz.png"/>
+          <p:cNvPr id="8" name="Picture 7" descr="logo_horiz.png"/>
           <p:cNvPicPr>
             <a:picLocks noChangeAspect="1"/>
           </p:cNvPicPr>
@@ -3827,7 +3737,7 @@
       </p:pic>
       <p:sp>
         <p:nvSpPr>
-          <p:cNvPr id="11" name="Rectangle 10"/>
+          <p:cNvPr id="9" name="Rectangle 8"/>
           <p:cNvSpPr/>
           <p:nvPr/>
         </p:nvSpPr>
@@ -3840,7 +3750,7 @@
             <a:avLst/>
           </a:prstGeom>
           <a:solidFill>
-            <a:srgbClr val="0E1E4A"/>
+            <a:srgbClr val="081438"/>
           </a:solidFill>
           <a:ln w="12700">
             <a:solidFill>
@@ -3872,7 +3782,7 @@
       </p:sp>
       <p:sp>
         <p:nvSpPr>
-          <p:cNvPr id="12" name="Rectangle 11"/>
+          <p:cNvPr id="10" name="Rectangle 9"/>
           <p:cNvSpPr/>
           <p:nvPr/>
         </p:nvSpPr>
@@ -3915,7 +3825,7 @@
       </p:sp>
       <p:sp>
         <p:nvSpPr>
-          <p:cNvPr id="13" name="Oval 12"/>
+          <p:cNvPr id="11" name="Oval 10"/>
           <p:cNvSpPr/>
           <p:nvPr/>
         </p:nvSpPr>
@@ -3960,7 +3870,7 @@
       </p:sp>
       <p:sp>
         <p:nvSpPr>
-          <p:cNvPr id="14" name="TextBox 13"/>
+          <p:cNvPr id="12" name="TextBox 11"/>
           <p:cNvSpPr txBox="1"/>
           <p:nvPr/>
         </p:nvSpPr>
@@ -3994,7 +3904,7 @@
       </p:sp>
       <p:sp>
         <p:nvSpPr>
-          <p:cNvPr id="15" name="TextBox 14"/>
+          <p:cNvPr id="13" name="TextBox 12"/>
           <p:cNvSpPr txBox="1"/>
           <p:nvPr/>
         </p:nvSpPr>
@@ -4028,7 +3938,7 @@
       </p:sp>
       <p:sp>
         <p:nvSpPr>
-          <p:cNvPr id="16" name="Rectangle 15"/>
+          <p:cNvPr id="14" name="Rectangle 13"/>
           <p:cNvSpPr/>
           <p:nvPr/>
         </p:nvSpPr>
@@ -4071,7 +3981,7 @@
       </p:sp>
       <p:sp>
         <p:nvSpPr>
-          <p:cNvPr id="17" name="TextBox 16"/>
+          <p:cNvPr id="15" name="TextBox 14"/>
           <p:cNvSpPr txBox="1"/>
           <p:nvPr/>
         </p:nvSpPr>
@@ -4186,7 +4096,7 @@
       </p:sp>
       <p:sp>
         <p:nvSpPr>
-          <p:cNvPr id="18" name="Rectangle 17"/>
+          <p:cNvPr id="16" name="Rectangle 15"/>
           <p:cNvSpPr/>
           <p:nvPr/>
         </p:nvSpPr>
@@ -4199,7 +4109,7 @@
             <a:avLst/>
           </a:prstGeom>
           <a:solidFill>
-            <a:srgbClr val="0E1E4A"/>
+            <a:srgbClr val="081438"/>
           </a:solidFill>
           <a:ln w="12700">
             <a:solidFill>
@@ -4231,7 +4141,7 @@
       </p:sp>
       <p:sp>
         <p:nvSpPr>
-          <p:cNvPr id="19" name="Rectangle 18"/>
+          <p:cNvPr id="17" name="Rectangle 16"/>
           <p:cNvSpPr/>
           <p:nvPr/>
         </p:nvSpPr>
@@ -4274,7 +4184,7 @@
       </p:sp>
       <p:sp>
         <p:nvSpPr>
-          <p:cNvPr id="20" name="Oval 19"/>
+          <p:cNvPr id="18" name="Oval 17"/>
           <p:cNvSpPr/>
           <p:nvPr/>
         </p:nvSpPr>
@@ -4319,7 +4229,7 @@
       </p:sp>
       <p:sp>
         <p:nvSpPr>
-          <p:cNvPr id="21" name="TextBox 20"/>
+          <p:cNvPr id="19" name="TextBox 18"/>
           <p:cNvSpPr txBox="1"/>
           <p:nvPr/>
         </p:nvSpPr>
@@ -4353,7 +4263,7 @@
       </p:sp>
       <p:sp>
         <p:nvSpPr>
-          <p:cNvPr id="22" name="TextBox 21"/>
+          <p:cNvPr id="20" name="TextBox 19"/>
           <p:cNvSpPr txBox="1"/>
           <p:nvPr/>
         </p:nvSpPr>
@@ -4387,7 +4297,7 @@
       </p:sp>
       <p:sp>
         <p:nvSpPr>
-          <p:cNvPr id="23" name="Rectangle 22"/>
+          <p:cNvPr id="21" name="Rectangle 20"/>
           <p:cNvSpPr/>
           <p:nvPr/>
         </p:nvSpPr>
@@ -4430,7 +4340,7 @@
       </p:sp>
       <p:sp>
         <p:nvSpPr>
-          <p:cNvPr id="24" name="TextBox 23"/>
+          <p:cNvPr id="22" name="TextBox 21"/>
           <p:cNvSpPr txBox="1"/>
           <p:nvPr/>
         </p:nvSpPr>
@@ -4545,7 +4455,7 @@
       </p:sp>
       <p:sp>
         <p:nvSpPr>
-          <p:cNvPr id="25" name="Rectangle 24"/>
+          <p:cNvPr id="23" name="Rectangle 22"/>
           <p:cNvSpPr/>
           <p:nvPr/>
         </p:nvSpPr>
@@ -4558,7 +4468,7 @@
             <a:avLst/>
           </a:prstGeom>
           <a:solidFill>
-            <a:srgbClr val="0E1E4A"/>
+            <a:srgbClr val="081438"/>
           </a:solidFill>
           <a:ln w="12700">
             <a:solidFill>
@@ -4590,7 +4500,7 @@
       </p:sp>
       <p:sp>
         <p:nvSpPr>
-          <p:cNvPr id="26" name="Rectangle 25"/>
+          <p:cNvPr id="24" name="Rectangle 23"/>
           <p:cNvSpPr/>
           <p:nvPr/>
         </p:nvSpPr>
@@ -4633,7 +4543,7 @@
       </p:sp>
       <p:sp>
         <p:nvSpPr>
-          <p:cNvPr id="27" name="Oval 26"/>
+          <p:cNvPr id="25" name="Oval 24"/>
           <p:cNvSpPr/>
           <p:nvPr/>
         </p:nvSpPr>
@@ -4678,7 +4588,7 @@
       </p:sp>
       <p:sp>
         <p:nvSpPr>
-          <p:cNvPr id="28" name="TextBox 27"/>
+          <p:cNvPr id="26" name="TextBox 25"/>
           <p:cNvSpPr txBox="1"/>
           <p:nvPr/>
         </p:nvSpPr>
@@ -4712,7 +4622,7 @@
       </p:sp>
       <p:sp>
         <p:nvSpPr>
-          <p:cNvPr id="29" name="TextBox 28"/>
+          <p:cNvPr id="27" name="TextBox 26"/>
           <p:cNvSpPr txBox="1"/>
           <p:nvPr/>
         </p:nvSpPr>
@@ -4746,7 +4656,7 @@
       </p:sp>
       <p:sp>
         <p:nvSpPr>
-          <p:cNvPr id="30" name="Rectangle 29"/>
+          <p:cNvPr id="28" name="Rectangle 27"/>
           <p:cNvSpPr/>
           <p:nvPr/>
         </p:nvSpPr>
@@ -4789,7 +4699,7 @@
       </p:sp>
       <p:sp>
         <p:nvSpPr>
-          <p:cNvPr id="31" name="TextBox 30"/>
+          <p:cNvPr id="29" name="TextBox 28"/>
           <p:cNvSpPr txBox="1"/>
           <p:nvPr/>
         </p:nvSpPr>
@@ -4931,7 +4841,7 @@
                                 <p:cBhvr>
                                   <p:cTn id="6" dur="450" fill="hold"/>
                                   <p:tgtEl>
-                                    <p:spTgt spid="11"/>
+                                    <p:spTgt spid="9"/>
                                   </p:tgtEl>
                                 </p:cBhvr>
                               </p:animEffect>
@@ -4948,7 +4858,7 @@
                                 <p:cBhvr>
                                   <p:cTn id="8" dur="450" fill="hold"/>
                                   <p:tgtEl>
-                                    <p:spTgt spid="18"/>
+                                    <p:spTgt spid="16"/>
                                   </p:tgtEl>
                                 </p:cBhvr>
                               </p:animEffect>
@@ -4965,7 +4875,7 @@
                                 <p:cBhvr>
                                   <p:cTn id="10" dur="450" fill="hold"/>
                                   <p:tgtEl>
-                                    <p:spTgt spid="25"/>
+                                    <p:spTgt spid="23"/>
                                   </p:tgtEl>
                                 </p:cBhvr>
                               </p:animEffect>
@@ -5007,7 +4917,7 @@
       <p:grpSpPr/>
       <p:pic>
         <p:nvPicPr>
-          <p:cNvPr id="2" name="Picture 1" descr="building.jpg"/>
+          <p:cNvPr id="2" name="Picture 1" descr="content_bg.png"/>
           <p:cNvPicPr>
             <a:picLocks noChangeAspect="1"/>
           </p:cNvPicPr>
@@ -5038,96 +4948,6 @@
         <p:spPr>
           <a:xfrm>
             <a:off x="0" y="0"/>
-            <a:ext cx="12191695" cy="6858000"/>
-          </a:xfrm>
-          <a:prstGeom prst="rect">
-            <a:avLst/>
-          </a:prstGeom>
-          <a:solidFill>
-            <a:srgbClr val="060E24">
-              <a:alpha val="44000"/>
-            </a:srgbClr>
-          </a:solidFill>
-          <a:ln>
-            <a:noFill/>
-          </a:ln>
-        </p:spPr>
-        <p:style>
-          <a:lnRef idx="1">
-            <a:schemeClr val="accent1"/>
-          </a:lnRef>
-          <a:fillRef idx="3">
-            <a:schemeClr val="accent1"/>
-          </a:fillRef>
-          <a:effectRef idx="2">
-            <a:schemeClr val="accent1"/>
-          </a:effectRef>
-          <a:fontRef idx="minor">
-            <a:schemeClr val="lt1"/>
-          </a:fontRef>
-        </p:style>
-        <p:txBody>
-          <a:bodyPr rtlCol="0" anchor="ctr"/>
-          <a:lstStyle/>
-          <a:p>
-            <a:pPr algn="ctr"/>
-          </a:p>
-        </p:txBody>
-      </p:sp>
-      <p:sp>
-        <p:nvSpPr>
-          <p:cNvPr id="4" name="Rectangle 3"/>
-          <p:cNvSpPr/>
-          <p:nvPr/>
-        </p:nvSpPr>
-        <p:spPr>
-          <a:xfrm>
-            <a:off x="0" y="0"/>
-            <a:ext cx="12191695" cy="1645920"/>
-          </a:xfrm>
-          <a:prstGeom prst="rect">
-            <a:avLst/>
-          </a:prstGeom>
-          <a:solidFill>
-            <a:srgbClr val="060E24">
-              <a:alpha val="20000"/>
-            </a:srgbClr>
-          </a:solidFill>
-          <a:ln>
-            <a:noFill/>
-          </a:ln>
-        </p:spPr>
-        <p:style>
-          <a:lnRef idx="1">
-            <a:schemeClr val="accent1"/>
-          </a:lnRef>
-          <a:fillRef idx="3">
-            <a:schemeClr val="accent1"/>
-          </a:fillRef>
-          <a:effectRef idx="2">
-            <a:schemeClr val="accent1"/>
-          </a:effectRef>
-          <a:fontRef idx="minor">
-            <a:schemeClr val="lt1"/>
-          </a:fontRef>
-        </p:style>
-        <p:txBody>
-          <a:bodyPr rtlCol="0" anchor="ctr"/>
-          <a:lstStyle/>
-          <a:p>
-            <a:pPr algn="ctr"/>
-          </a:p>
-        </p:txBody>
-      </p:sp>
-      <p:sp>
-        <p:nvSpPr>
-          <p:cNvPr id="5" name="Rectangle 4"/>
-          <p:cNvSpPr/>
-          <p:nvPr/>
-        </p:nvSpPr>
-        <p:spPr>
-          <a:xfrm>
-            <a:off x="0" y="0"/>
             <a:ext cx="12191695" cy="44450"/>
           </a:xfrm>
           <a:prstGeom prst="rect">
@@ -5164,7 +4984,7 @@
       </p:sp>
       <p:sp>
         <p:nvSpPr>
-          <p:cNvPr id="6" name="Rectangle 5"/>
+          <p:cNvPr id="4" name="Rectangle 3"/>
           <p:cNvSpPr/>
           <p:nvPr/>
         </p:nvSpPr>
@@ -5207,7 +5027,7 @@
       </p:sp>
       <p:sp>
         <p:nvSpPr>
-          <p:cNvPr id="7" name="Rectangle 6"/>
+          <p:cNvPr id="5" name="Rectangle 4"/>
           <p:cNvSpPr/>
           <p:nvPr/>
         </p:nvSpPr>
@@ -5258,7 +5078,7 @@
       </p:sp>
       <p:sp>
         <p:nvSpPr>
-          <p:cNvPr id="8" name="TextBox 7"/>
+          <p:cNvPr id="6" name="TextBox 5"/>
           <p:cNvSpPr txBox="1"/>
           <p:nvPr/>
         </p:nvSpPr>
@@ -5300,7 +5120,7 @@
       </p:sp>
       <p:sp>
         <p:nvSpPr>
-          <p:cNvPr id="9" name="Rectangle 8"/>
+          <p:cNvPr id="7" name="Rectangle 6"/>
           <p:cNvSpPr/>
           <p:nvPr/>
         </p:nvSpPr>
@@ -5343,7 +5163,7 @@
       </p:sp>
       <p:pic>
         <p:nvPicPr>
-          <p:cNvPr id="10" name="Picture 9" descr="logo_horiz.png"/>
+          <p:cNvPr id="8" name="Picture 7" descr="logo_horiz.png"/>
           <p:cNvPicPr>
             <a:picLocks noChangeAspect="1"/>
           </p:cNvPicPr>
@@ -5367,7 +5187,7 @@
       </p:pic>
       <p:sp>
         <p:nvSpPr>
-          <p:cNvPr id="11" name="Rectangle 10"/>
+          <p:cNvPr id="9" name="Rectangle 8"/>
           <p:cNvSpPr/>
           <p:nvPr/>
         </p:nvSpPr>
@@ -5380,7 +5200,7 @@
             <a:avLst/>
           </a:prstGeom>
           <a:solidFill>
-            <a:srgbClr val="0E1E4A"/>
+            <a:srgbClr val="081438"/>
           </a:solidFill>
           <a:ln w="12700">
             <a:solidFill>
@@ -5412,7 +5232,7 @@
       </p:sp>
       <p:sp>
         <p:nvSpPr>
-          <p:cNvPr id="12" name="Rectangle 11"/>
+          <p:cNvPr id="10" name="Rectangle 9"/>
           <p:cNvSpPr/>
           <p:nvPr/>
         </p:nvSpPr>
@@ -5455,7 +5275,7 @@
       </p:sp>
       <p:sp>
         <p:nvSpPr>
-          <p:cNvPr id="13" name="Oval 12"/>
+          <p:cNvPr id="11" name="Oval 10"/>
           <p:cNvSpPr/>
           <p:nvPr/>
         </p:nvSpPr>
@@ -5500,7 +5320,7 @@
       </p:sp>
       <p:sp>
         <p:nvSpPr>
-          <p:cNvPr id="14" name="TextBox 13"/>
+          <p:cNvPr id="12" name="TextBox 11"/>
           <p:cNvSpPr txBox="1"/>
           <p:nvPr/>
         </p:nvSpPr>
@@ -5534,7 +5354,7 @@
       </p:sp>
       <p:sp>
         <p:nvSpPr>
-          <p:cNvPr id="15" name="TextBox 14"/>
+          <p:cNvPr id="13" name="TextBox 12"/>
           <p:cNvSpPr txBox="1"/>
           <p:nvPr/>
         </p:nvSpPr>
@@ -5568,7 +5388,7 @@
       </p:sp>
       <p:sp>
         <p:nvSpPr>
-          <p:cNvPr id="16" name="Rectangle 15"/>
+          <p:cNvPr id="14" name="Rectangle 13"/>
           <p:cNvSpPr/>
           <p:nvPr/>
         </p:nvSpPr>
@@ -5611,7 +5431,7 @@
       </p:sp>
       <p:sp>
         <p:nvSpPr>
-          <p:cNvPr id="17" name="TextBox 16"/>
+          <p:cNvPr id="15" name="TextBox 14"/>
           <p:cNvSpPr txBox="1"/>
           <p:nvPr/>
         </p:nvSpPr>
@@ -5726,7 +5546,7 @@
       </p:sp>
       <p:sp>
         <p:nvSpPr>
-          <p:cNvPr id="18" name="Rectangle 17"/>
+          <p:cNvPr id="16" name="Rectangle 15"/>
           <p:cNvSpPr/>
           <p:nvPr/>
         </p:nvSpPr>
@@ -5739,7 +5559,7 @@
             <a:avLst/>
           </a:prstGeom>
           <a:solidFill>
-            <a:srgbClr val="0E1E4A"/>
+            <a:srgbClr val="081438"/>
           </a:solidFill>
           <a:ln w="12700">
             <a:solidFill>
@@ -5771,7 +5591,7 @@
       </p:sp>
       <p:sp>
         <p:nvSpPr>
-          <p:cNvPr id="19" name="Rectangle 18"/>
+          <p:cNvPr id="17" name="Rectangle 16"/>
           <p:cNvSpPr/>
           <p:nvPr/>
         </p:nvSpPr>
@@ -5814,7 +5634,7 @@
       </p:sp>
       <p:sp>
         <p:nvSpPr>
-          <p:cNvPr id="20" name="Oval 19"/>
+          <p:cNvPr id="18" name="Oval 17"/>
           <p:cNvSpPr/>
           <p:nvPr/>
         </p:nvSpPr>
@@ -5859,7 +5679,7 @@
       </p:sp>
       <p:sp>
         <p:nvSpPr>
-          <p:cNvPr id="21" name="TextBox 20"/>
+          <p:cNvPr id="19" name="TextBox 18"/>
           <p:cNvSpPr txBox="1"/>
           <p:nvPr/>
         </p:nvSpPr>
@@ -5893,7 +5713,7 @@
       </p:sp>
       <p:sp>
         <p:nvSpPr>
-          <p:cNvPr id="22" name="TextBox 21"/>
+          <p:cNvPr id="20" name="TextBox 19"/>
           <p:cNvSpPr txBox="1"/>
           <p:nvPr/>
         </p:nvSpPr>
@@ -5927,7 +5747,7 @@
       </p:sp>
       <p:sp>
         <p:nvSpPr>
-          <p:cNvPr id="23" name="Rectangle 22"/>
+          <p:cNvPr id="21" name="Rectangle 20"/>
           <p:cNvSpPr/>
           <p:nvPr/>
         </p:nvSpPr>
@@ -5970,7 +5790,7 @@
       </p:sp>
       <p:sp>
         <p:nvSpPr>
-          <p:cNvPr id="24" name="TextBox 23"/>
+          <p:cNvPr id="22" name="TextBox 21"/>
           <p:cNvSpPr txBox="1"/>
           <p:nvPr/>
         </p:nvSpPr>
@@ -6085,7 +5905,7 @@
       </p:sp>
       <p:sp>
         <p:nvSpPr>
-          <p:cNvPr id="25" name="Rectangle 24"/>
+          <p:cNvPr id="23" name="Rectangle 22"/>
           <p:cNvSpPr/>
           <p:nvPr/>
         </p:nvSpPr>
@@ -6098,7 +5918,7 @@
             <a:avLst/>
           </a:prstGeom>
           <a:solidFill>
-            <a:srgbClr val="0E1E4A"/>
+            <a:srgbClr val="081438"/>
           </a:solidFill>
           <a:ln w="12700">
             <a:solidFill>
@@ -6130,7 +5950,7 @@
       </p:sp>
       <p:sp>
         <p:nvSpPr>
-          <p:cNvPr id="26" name="Rectangle 25"/>
+          <p:cNvPr id="24" name="Rectangle 23"/>
           <p:cNvSpPr/>
           <p:nvPr/>
         </p:nvSpPr>
@@ -6173,7 +5993,7 @@
       </p:sp>
       <p:sp>
         <p:nvSpPr>
-          <p:cNvPr id="27" name="Oval 26"/>
+          <p:cNvPr id="25" name="Oval 24"/>
           <p:cNvSpPr/>
           <p:nvPr/>
         </p:nvSpPr>
@@ -6218,7 +6038,7 @@
       </p:sp>
       <p:sp>
         <p:nvSpPr>
-          <p:cNvPr id="28" name="TextBox 27"/>
+          <p:cNvPr id="26" name="TextBox 25"/>
           <p:cNvSpPr txBox="1"/>
           <p:nvPr/>
         </p:nvSpPr>
@@ -6252,7 +6072,7 @@
       </p:sp>
       <p:sp>
         <p:nvSpPr>
-          <p:cNvPr id="29" name="TextBox 28"/>
+          <p:cNvPr id="27" name="TextBox 26"/>
           <p:cNvSpPr txBox="1"/>
           <p:nvPr/>
         </p:nvSpPr>
@@ -6286,7 +6106,7 @@
       </p:sp>
       <p:sp>
         <p:nvSpPr>
-          <p:cNvPr id="30" name="Rectangle 29"/>
+          <p:cNvPr id="28" name="Rectangle 27"/>
           <p:cNvSpPr/>
           <p:nvPr/>
         </p:nvSpPr>
@@ -6329,7 +6149,7 @@
       </p:sp>
       <p:sp>
         <p:nvSpPr>
-          <p:cNvPr id="31" name="TextBox 30"/>
+          <p:cNvPr id="29" name="TextBox 28"/>
           <p:cNvSpPr txBox="1"/>
           <p:nvPr/>
         </p:nvSpPr>
@@ -6471,7 +6291,7 @@
                                 <p:cBhvr>
                                   <p:cTn id="6" dur="450" fill="hold"/>
                                   <p:tgtEl>
-                                    <p:spTgt spid="11"/>
+                                    <p:spTgt spid="9"/>
                                   </p:tgtEl>
                                 </p:cBhvr>
                               </p:animEffect>
@@ -6488,7 +6308,7 @@
                                 <p:cBhvr>
                                   <p:cTn id="8" dur="450" fill="hold"/>
                                   <p:tgtEl>
-                                    <p:spTgt spid="18"/>
+                                    <p:spTgt spid="16"/>
                                   </p:tgtEl>
                                 </p:cBhvr>
                               </p:animEffect>
@@ -6505,7 +6325,7 @@
                                 <p:cBhvr>
                                   <p:cTn id="10" dur="450" fill="hold"/>
                                   <p:tgtEl>
-                                    <p:spTgt spid="25"/>
+                                    <p:spTgt spid="23"/>
                                   </p:tgtEl>
                                 </p:cBhvr>
                               </p:animEffect>
@@ -6547,7 +6367,7 @@
       <p:grpSpPr/>
       <p:pic>
         <p:nvPicPr>
-          <p:cNvPr id="2" name="Picture 1" descr="building.jpg"/>
+          <p:cNvPr id="2" name="Picture 1" descr="content_bg.png"/>
           <p:cNvPicPr>
             <a:picLocks noChangeAspect="1"/>
           </p:cNvPicPr>
@@ -6578,96 +6398,6 @@
         <p:spPr>
           <a:xfrm>
             <a:off x="0" y="0"/>
-            <a:ext cx="12191695" cy="6858000"/>
-          </a:xfrm>
-          <a:prstGeom prst="rect">
-            <a:avLst/>
-          </a:prstGeom>
-          <a:solidFill>
-            <a:srgbClr val="060E24">
-              <a:alpha val="44000"/>
-            </a:srgbClr>
-          </a:solidFill>
-          <a:ln>
-            <a:noFill/>
-          </a:ln>
-        </p:spPr>
-        <p:style>
-          <a:lnRef idx="1">
-            <a:schemeClr val="accent1"/>
-          </a:lnRef>
-          <a:fillRef idx="3">
-            <a:schemeClr val="accent1"/>
-          </a:fillRef>
-          <a:effectRef idx="2">
-            <a:schemeClr val="accent1"/>
-          </a:effectRef>
-          <a:fontRef idx="minor">
-            <a:schemeClr val="lt1"/>
-          </a:fontRef>
-        </p:style>
-        <p:txBody>
-          <a:bodyPr rtlCol="0" anchor="ctr"/>
-          <a:lstStyle/>
-          <a:p>
-            <a:pPr algn="ctr"/>
-          </a:p>
-        </p:txBody>
-      </p:sp>
-      <p:sp>
-        <p:nvSpPr>
-          <p:cNvPr id="4" name="Rectangle 3"/>
-          <p:cNvSpPr/>
-          <p:nvPr/>
-        </p:nvSpPr>
-        <p:spPr>
-          <a:xfrm>
-            <a:off x="0" y="0"/>
-            <a:ext cx="12191695" cy="1645920"/>
-          </a:xfrm>
-          <a:prstGeom prst="rect">
-            <a:avLst/>
-          </a:prstGeom>
-          <a:solidFill>
-            <a:srgbClr val="060E24">
-              <a:alpha val="20000"/>
-            </a:srgbClr>
-          </a:solidFill>
-          <a:ln>
-            <a:noFill/>
-          </a:ln>
-        </p:spPr>
-        <p:style>
-          <a:lnRef idx="1">
-            <a:schemeClr val="accent1"/>
-          </a:lnRef>
-          <a:fillRef idx="3">
-            <a:schemeClr val="accent1"/>
-          </a:fillRef>
-          <a:effectRef idx="2">
-            <a:schemeClr val="accent1"/>
-          </a:effectRef>
-          <a:fontRef idx="minor">
-            <a:schemeClr val="lt1"/>
-          </a:fontRef>
-        </p:style>
-        <p:txBody>
-          <a:bodyPr rtlCol="0" anchor="ctr"/>
-          <a:lstStyle/>
-          <a:p>
-            <a:pPr algn="ctr"/>
-          </a:p>
-        </p:txBody>
-      </p:sp>
-      <p:sp>
-        <p:nvSpPr>
-          <p:cNvPr id="5" name="Rectangle 4"/>
-          <p:cNvSpPr/>
-          <p:nvPr/>
-        </p:nvSpPr>
-        <p:spPr>
-          <a:xfrm>
-            <a:off x="0" y="0"/>
             <a:ext cx="12191695" cy="44450"/>
           </a:xfrm>
           <a:prstGeom prst="rect">
@@ -6704,7 +6434,7 @@
       </p:sp>
       <p:sp>
         <p:nvSpPr>
-          <p:cNvPr id="6" name="Rectangle 5"/>
+          <p:cNvPr id="4" name="Rectangle 3"/>
           <p:cNvSpPr/>
           <p:nvPr/>
         </p:nvSpPr>
@@ -6747,7 +6477,7 @@
       </p:sp>
       <p:sp>
         <p:nvSpPr>
-          <p:cNvPr id="7" name="Rectangle 6"/>
+          <p:cNvPr id="5" name="Rectangle 4"/>
           <p:cNvSpPr/>
           <p:nvPr/>
         </p:nvSpPr>
@@ -6798,7 +6528,7 @@
       </p:sp>
       <p:sp>
         <p:nvSpPr>
-          <p:cNvPr id="8" name="TextBox 7"/>
+          <p:cNvPr id="6" name="TextBox 5"/>
           <p:cNvSpPr txBox="1"/>
           <p:nvPr/>
         </p:nvSpPr>
@@ -6840,7 +6570,7 @@
       </p:sp>
       <p:sp>
         <p:nvSpPr>
-          <p:cNvPr id="9" name="Rectangle 8"/>
+          <p:cNvPr id="7" name="Rectangle 6"/>
           <p:cNvSpPr/>
           <p:nvPr/>
         </p:nvSpPr>
@@ -6883,7 +6613,7 @@
       </p:sp>
       <p:pic>
         <p:nvPicPr>
-          <p:cNvPr id="10" name="Picture 9" descr="logo_horiz.png"/>
+          <p:cNvPr id="8" name="Picture 7" descr="logo_horiz.png"/>
           <p:cNvPicPr>
             <a:picLocks noChangeAspect="1"/>
           </p:cNvPicPr>
@@ -6907,7 +6637,7 @@
       </p:pic>
       <p:sp>
         <p:nvSpPr>
-          <p:cNvPr id="11" name="Rectangle 10"/>
+          <p:cNvPr id="9" name="Rectangle 8"/>
           <p:cNvSpPr/>
           <p:nvPr/>
         </p:nvSpPr>
@@ -6920,7 +6650,7 @@
             <a:avLst/>
           </a:prstGeom>
           <a:solidFill>
-            <a:srgbClr val="0E1E4A"/>
+            <a:srgbClr val="081438"/>
           </a:solidFill>
           <a:ln w="12700">
             <a:solidFill>
@@ -6952,7 +6682,7 @@
       </p:sp>
       <p:sp>
         <p:nvSpPr>
-          <p:cNvPr id="12" name="Rectangle 11"/>
+          <p:cNvPr id="10" name="Rectangle 9"/>
           <p:cNvSpPr/>
           <p:nvPr/>
         </p:nvSpPr>
@@ -6995,7 +6725,7 @@
       </p:sp>
       <p:sp>
         <p:nvSpPr>
-          <p:cNvPr id="13" name="Oval 12"/>
+          <p:cNvPr id="11" name="Oval 10"/>
           <p:cNvSpPr/>
           <p:nvPr/>
         </p:nvSpPr>
@@ -7040,7 +6770,7 @@
       </p:sp>
       <p:sp>
         <p:nvSpPr>
-          <p:cNvPr id="14" name="TextBox 13"/>
+          <p:cNvPr id="12" name="TextBox 11"/>
           <p:cNvSpPr txBox="1"/>
           <p:nvPr/>
         </p:nvSpPr>
@@ -7074,7 +6804,7 @@
       </p:sp>
       <p:sp>
         <p:nvSpPr>
-          <p:cNvPr id="15" name="TextBox 14"/>
+          <p:cNvPr id="13" name="TextBox 12"/>
           <p:cNvSpPr txBox="1"/>
           <p:nvPr/>
         </p:nvSpPr>
@@ -7108,7 +6838,7 @@
       </p:sp>
       <p:sp>
         <p:nvSpPr>
-          <p:cNvPr id="16" name="Rectangle 15"/>
+          <p:cNvPr id="14" name="Rectangle 13"/>
           <p:cNvSpPr/>
           <p:nvPr/>
         </p:nvSpPr>
@@ -7151,7 +6881,7 @@
       </p:sp>
       <p:sp>
         <p:nvSpPr>
-          <p:cNvPr id="17" name="TextBox 16"/>
+          <p:cNvPr id="15" name="TextBox 14"/>
           <p:cNvSpPr txBox="1"/>
           <p:nvPr/>
         </p:nvSpPr>
@@ -7266,7 +6996,7 @@
       </p:sp>
       <p:sp>
         <p:nvSpPr>
-          <p:cNvPr id="18" name="Rectangle 17"/>
+          <p:cNvPr id="16" name="Rectangle 15"/>
           <p:cNvSpPr/>
           <p:nvPr/>
         </p:nvSpPr>
@@ -7279,7 +7009,7 @@
             <a:avLst/>
           </a:prstGeom>
           <a:solidFill>
-            <a:srgbClr val="0E1E4A"/>
+            <a:srgbClr val="081438"/>
           </a:solidFill>
           <a:ln w="12700">
             <a:solidFill>
@@ -7311,7 +7041,7 @@
       </p:sp>
       <p:sp>
         <p:nvSpPr>
-          <p:cNvPr id="19" name="Rectangle 18"/>
+          <p:cNvPr id="17" name="Rectangle 16"/>
           <p:cNvSpPr/>
           <p:nvPr/>
         </p:nvSpPr>
@@ -7354,7 +7084,7 @@
       </p:sp>
       <p:sp>
         <p:nvSpPr>
-          <p:cNvPr id="20" name="Oval 19"/>
+          <p:cNvPr id="18" name="Oval 17"/>
           <p:cNvSpPr/>
           <p:nvPr/>
         </p:nvSpPr>
@@ -7399,7 +7129,7 @@
       </p:sp>
       <p:sp>
         <p:nvSpPr>
-          <p:cNvPr id="21" name="TextBox 20"/>
+          <p:cNvPr id="19" name="TextBox 18"/>
           <p:cNvSpPr txBox="1"/>
           <p:nvPr/>
         </p:nvSpPr>
@@ -7433,7 +7163,7 @@
       </p:sp>
       <p:sp>
         <p:nvSpPr>
-          <p:cNvPr id="22" name="TextBox 21"/>
+          <p:cNvPr id="20" name="TextBox 19"/>
           <p:cNvSpPr txBox="1"/>
           <p:nvPr/>
         </p:nvSpPr>
@@ -7467,7 +7197,7 @@
       </p:sp>
       <p:sp>
         <p:nvSpPr>
-          <p:cNvPr id="23" name="Rectangle 22"/>
+          <p:cNvPr id="21" name="Rectangle 20"/>
           <p:cNvSpPr/>
           <p:nvPr/>
         </p:nvSpPr>
@@ -7510,7 +7240,7 @@
       </p:sp>
       <p:sp>
         <p:nvSpPr>
-          <p:cNvPr id="24" name="TextBox 23"/>
+          <p:cNvPr id="22" name="TextBox 21"/>
           <p:cNvSpPr txBox="1"/>
           <p:nvPr/>
         </p:nvSpPr>
@@ -7625,7 +7355,7 @@
       </p:sp>
       <p:sp>
         <p:nvSpPr>
-          <p:cNvPr id="25" name="Rectangle 24"/>
+          <p:cNvPr id="23" name="Rectangle 22"/>
           <p:cNvSpPr/>
           <p:nvPr/>
         </p:nvSpPr>
@@ -7638,7 +7368,7 @@
             <a:avLst/>
           </a:prstGeom>
           <a:solidFill>
-            <a:srgbClr val="0E1E4A"/>
+            <a:srgbClr val="081438"/>
           </a:solidFill>
           <a:ln w="12700">
             <a:solidFill>
@@ -7670,7 +7400,7 @@
       </p:sp>
       <p:sp>
         <p:nvSpPr>
-          <p:cNvPr id="26" name="Rectangle 25"/>
+          <p:cNvPr id="24" name="Rectangle 23"/>
           <p:cNvSpPr/>
           <p:nvPr/>
         </p:nvSpPr>
@@ -7713,7 +7443,7 @@
       </p:sp>
       <p:sp>
         <p:nvSpPr>
-          <p:cNvPr id="27" name="Oval 26"/>
+          <p:cNvPr id="25" name="Oval 24"/>
           <p:cNvSpPr/>
           <p:nvPr/>
         </p:nvSpPr>
@@ -7758,7 +7488,7 @@
       </p:sp>
       <p:sp>
         <p:nvSpPr>
-          <p:cNvPr id="28" name="TextBox 27"/>
+          <p:cNvPr id="26" name="TextBox 25"/>
           <p:cNvSpPr txBox="1"/>
           <p:nvPr/>
         </p:nvSpPr>
@@ -7792,7 +7522,7 @@
       </p:sp>
       <p:sp>
         <p:nvSpPr>
-          <p:cNvPr id="29" name="TextBox 28"/>
+          <p:cNvPr id="27" name="TextBox 26"/>
           <p:cNvSpPr txBox="1"/>
           <p:nvPr/>
         </p:nvSpPr>
@@ -7826,7 +7556,7 @@
       </p:sp>
       <p:sp>
         <p:nvSpPr>
-          <p:cNvPr id="30" name="Rectangle 29"/>
+          <p:cNvPr id="28" name="Rectangle 27"/>
           <p:cNvSpPr/>
           <p:nvPr/>
         </p:nvSpPr>
@@ -7869,7 +7599,7 @@
       </p:sp>
       <p:sp>
         <p:nvSpPr>
-          <p:cNvPr id="31" name="TextBox 30"/>
+          <p:cNvPr id="29" name="TextBox 28"/>
           <p:cNvSpPr txBox="1"/>
           <p:nvPr/>
         </p:nvSpPr>
@@ -8011,7 +7741,7 @@
                                 <p:cBhvr>
                                   <p:cTn id="6" dur="450" fill="hold"/>
                                   <p:tgtEl>
-                                    <p:spTgt spid="11"/>
+                                    <p:spTgt spid="9"/>
                                   </p:tgtEl>
                                 </p:cBhvr>
                               </p:animEffect>
@@ -8028,7 +7758,7 @@
                                 <p:cBhvr>
                                   <p:cTn id="8" dur="450" fill="hold"/>
                                   <p:tgtEl>
-                                    <p:spTgt spid="18"/>
+                                    <p:spTgt spid="16"/>
                                   </p:tgtEl>
                                 </p:cBhvr>
                               </p:animEffect>
@@ -8045,7 +7775,7 @@
                                 <p:cBhvr>
                                   <p:cTn id="10" dur="450" fill="hold"/>
                                   <p:tgtEl>
-                                    <p:spTgt spid="25"/>
+                                    <p:spTgt spid="23"/>
                                   </p:tgtEl>
                                 </p:cBhvr>
                               </p:animEffect>
@@ -8087,7 +7817,7 @@
       <p:grpSpPr/>
       <p:pic>
         <p:nvPicPr>
-          <p:cNvPr id="2" name="Picture 1" descr="building.jpg"/>
+          <p:cNvPr id="2" name="Picture 1" descr="content_bg.png"/>
           <p:cNvPicPr>
             <a:picLocks noChangeAspect="1"/>
           </p:cNvPicPr>
@@ -8118,96 +7848,6 @@
         <p:spPr>
           <a:xfrm>
             <a:off x="0" y="0"/>
-            <a:ext cx="12191695" cy="6858000"/>
-          </a:xfrm>
-          <a:prstGeom prst="rect">
-            <a:avLst/>
-          </a:prstGeom>
-          <a:solidFill>
-            <a:srgbClr val="060E24">
-              <a:alpha val="44000"/>
-            </a:srgbClr>
-          </a:solidFill>
-          <a:ln>
-            <a:noFill/>
-          </a:ln>
-        </p:spPr>
-        <p:style>
-          <a:lnRef idx="1">
-            <a:schemeClr val="accent1"/>
-          </a:lnRef>
-          <a:fillRef idx="3">
-            <a:schemeClr val="accent1"/>
-          </a:fillRef>
-          <a:effectRef idx="2">
-            <a:schemeClr val="accent1"/>
-          </a:effectRef>
-          <a:fontRef idx="minor">
-            <a:schemeClr val="lt1"/>
-          </a:fontRef>
-        </p:style>
-        <p:txBody>
-          <a:bodyPr rtlCol="0" anchor="ctr"/>
-          <a:lstStyle/>
-          <a:p>
-            <a:pPr algn="ctr"/>
-          </a:p>
-        </p:txBody>
-      </p:sp>
-      <p:sp>
-        <p:nvSpPr>
-          <p:cNvPr id="4" name="Rectangle 3"/>
-          <p:cNvSpPr/>
-          <p:nvPr/>
-        </p:nvSpPr>
-        <p:spPr>
-          <a:xfrm>
-            <a:off x="0" y="0"/>
-            <a:ext cx="12191695" cy="1645920"/>
-          </a:xfrm>
-          <a:prstGeom prst="rect">
-            <a:avLst/>
-          </a:prstGeom>
-          <a:solidFill>
-            <a:srgbClr val="060E24">
-              <a:alpha val="20000"/>
-            </a:srgbClr>
-          </a:solidFill>
-          <a:ln>
-            <a:noFill/>
-          </a:ln>
-        </p:spPr>
-        <p:style>
-          <a:lnRef idx="1">
-            <a:schemeClr val="accent1"/>
-          </a:lnRef>
-          <a:fillRef idx="3">
-            <a:schemeClr val="accent1"/>
-          </a:fillRef>
-          <a:effectRef idx="2">
-            <a:schemeClr val="accent1"/>
-          </a:effectRef>
-          <a:fontRef idx="minor">
-            <a:schemeClr val="lt1"/>
-          </a:fontRef>
-        </p:style>
-        <p:txBody>
-          <a:bodyPr rtlCol="0" anchor="ctr"/>
-          <a:lstStyle/>
-          <a:p>
-            <a:pPr algn="ctr"/>
-          </a:p>
-        </p:txBody>
-      </p:sp>
-      <p:sp>
-        <p:nvSpPr>
-          <p:cNvPr id="5" name="Rectangle 4"/>
-          <p:cNvSpPr/>
-          <p:nvPr/>
-        </p:nvSpPr>
-        <p:spPr>
-          <a:xfrm>
-            <a:off x="0" y="0"/>
             <a:ext cx="12191695" cy="44450"/>
           </a:xfrm>
           <a:prstGeom prst="rect">
@@ -8244,7 +7884,7 @@
       </p:sp>
       <p:sp>
         <p:nvSpPr>
-          <p:cNvPr id="6" name="Rectangle 5"/>
+          <p:cNvPr id="4" name="Rectangle 3"/>
           <p:cNvSpPr/>
           <p:nvPr/>
         </p:nvSpPr>
@@ -8287,7 +7927,7 @@
       </p:sp>
       <p:sp>
         <p:nvSpPr>
-          <p:cNvPr id="7" name="Rectangle 6"/>
+          <p:cNvPr id="5" name="Rectangle 4"/>
           <p:cNvSpPr/>
           <p:nvPr/>
         </p:nvSpPr>
@@ -8338,7 +7978,7 @@
       </p:sp>
       <p:sp>
         <p:nvSpPr>
-          <p:cNvPr id="8" name="TextBox 7"/>
+          <p:cNvPr id="6" name="TextBox 5"/>
           <p:cNvSpPr txBox="1"/>
           <p:nvPr/>
         </p:nvSpPr>
@@ -8380,7 +8020,7 @@
       </p:sp>
       <p:sp>
         <p:nvSpPr>
-          <p:cNvPr id="9" name="Rectangle 8"/>
+          <p:cNvPr id="7" name="Rectangle 6"/>
           <p:cNvSpPr/>
           <p:nvPr/>
         </p:nvSpPr>
@@ -8423,7 +8063,7 @@
       </p:sp>
       <p:pic>
         <p:nvPicPr>
-          <p:cNvPr id="10" name="Picture 9" descr="logo_horiz.png"/>
+          <p:cNvPr id="8" name="Picture 7" descr="logo_horiz.png"/>
           <p:cNvPicPr>
             <a:picLocks noChangeAspect="1"/>
           </p:cNvPicPr>
@@ -8447,7 +8087,7 @@
       </p:pic>
       <p:sp>
         <p:nvSpPr>
-          <p:cNvPr id="11" name="Rectangle 10"/>
+          <p:cNvPr id="9" name="Rectangle 8"/>
           <p:cNvSpPr/>
           <p:nvPr/>
         </p:nvSpPr>
@@ -8460,7 +8100,7 @@
             <a:avLst/>
           </a:prstGeom>
           <a:solidFill>
-            <a:srgbClr val="0E1E4A"/>
+            <a:srgbClr val="081438"/>
           </a:solidFill>
           <a:ln w="12700">
             <a:solidFill>
@@ -8492,7 +8132,7 @@
       </p:sp>
       <p:sp>
         <p:nvSpPr>
-          <p:cNvPr id="12" name="Rectangle 11"/>
+          <p:cNvPr id="10" name="Rectangle 9"/>
           <p:cNvSpPr/>
           <p:nvPr/>
         </p:nvSpPr>
@@ -8535,7 +8175,7 @@
       </p:sp>
       <p:sp>
         <p:nvSpPr>
-          <p:cNvPr id="13" name="Oval 12"/>
+          <p:cNvPr id="11" name="Oval 10"/>
           <p:cNvSpPr/>
           <p:nvPr/>
         </p:nvSpPr>
@@ -8580,7 +8220,7 @@
       </p:sp>
       <p:sp>
         <p:nvSpPr>
-          <p:cNvPr id="14" name="TextBox 13"/>
+          <p:cNvPr id="12" name="TextBox 11"/>
           <p:cNvSpPr txBox="1"/>
           <p:nvPr/>
         </p:nvSpPr>
@@ -8614,7 +8254,7 @@
       </p:sp>
       <p:sp>
         <p:nvSpPr>
-          <p:cNvPr id="15" name="TextBox 14"/>
+          <p:cNvPr id="13" name="TextBox 12"/>
           <p:cNvSpPr txBox="1"/>
           <p:nvPr/>
         </p:nvSpPr>
@@ -8648,7 +8288,7 @@
       </p:sp>
       <p:sp>
         <p:nvSpPr>
-          <p:cNvPr id="16" name="Rectangle 15"/>
+          <p:cNvPr id="14" name="Rectangle 13"/>
           <p:cNvSpPr/>
           <p:nvPr/>
         </p:nvSpPr>
@@ -8691,7 +8331,7 @@
       </p:sp>
       <p:sp>
         <p:nvSpPr>
-          <p:cNvPr id="17" name="TextBox 16"/>
+          <p:cNvPr id="15" name="TextBox 14"/>
           <p:cNvSpPr txBox="1"/>
           <p:nvPr/>
         </p:nvSpPr>
@@ -8806,7 +8446,7 @@
       </p:sp>
       <p:sp>
         <p:nvSpPr>
-          <p:cNvPr id="18" name="Rectangle 17"/>
+          <p:cNvPr id="16" name="Rectangle 15"/>
           <p:cNvSpPr/>
           <p:nvPr/>
         </p:nvSpPr>
@@ -8819,7 +8459,7 @@
             <a:avLst/>
           </a:prstGeom>
           <a:solidFill>
-            <a:srgbClr val="0E1E4A"/>
+            <a:srgbClr val="081438"/>
           </a:solidFill>
           <a:ln w="12700">
             <a:solidFill>
@@ -8851,7 +8491,7 @@
       </p:sp>
       <p:sp>
         <p:nvSpPr>
-          <p:cNvPr id="19" name="Rectangle 18"/>
+          <p:cNvPr id="17" name="Rectangle 16"/>
           <p:cNvSpPr/>
           <p:nvPr/>
         </p:nvSpPr>
@@ -8894,7 +8534,7 @@
       </p:sp>
       <p:sp>
         <p:nvSpPr>
-          <p:cNvPr id="20" name="Oval 19"/>
+          <p:cNvPr id="18" name="Oval 17"/>
           <p:cNvSpPr/>
           <p:nvPr/>
         </p:nvSpPr>
@@ -8939,7 +8579,7 @@
       </p:sp>
       <p:sp>
         <p:nvSpPr>
-          <p:cNvPr id="21" name="TextBox 20"/>
+          <p:cNvPr id="19" name="TextBox 18"/>
           <p:cNvSpPr txBox="1"/>
           <p:nvPr/>
         </p:nvSpPr>
@@ -8973,7 +8613,7 @@
       </p:sp>
       <p:sp>
         <p:nvSpPr>
-          <p:cNvPr id="22" name="TextBox 21"/>
+          <p:cNvPr id="20" name="TextBox 19"/>
           <p:cNvSpPr txBox="1"/>
           <p:nvPr/>
         </p:nvSpPr>
@@ -9007,7 +8647,7 @@
       </p:sp>
       <p:sp>
         <p:nvSpPr>
-          <p:cNvPr id="23" name="Rectangle 22"/>
+          <p:cNvPr id="21" name="Rectangle 20"/>
           <p:cNvSpPr/>
           <p:nvPr/>
         </p:nvSpPr>
@@ -9050,7 +8690,7 @@
       </p:sp>
       <p:sp>
         <p:nvSpPr>
-          <p:cNvPr id="24" name="TextBox 23"/>
+          <p:cNvPr id="22" name="TextBox 21"/>
           <p:cNvSpPr txBox="1"/>
           <p:nvPr/>
         </p:nvSpPr>
@@ -9165,7 +8805,7 @@
       </p:sp>
       <p:sp>
         <p:nvSpPr>
-          <p:cNvPr id="25" name="Rectangle 24"/>
+          <p:cNvPr id="23" name="Rectangle 22"/>
           <p:cNvSpPr/>
           <p:nvPr/>
         </p:nvSpPr>
@@ -9178,7 +8818,7 @@
             <a:avLst/>
           </a:prstGeom>
           <a:solidFill>
-            <a:srgbClr val="0E1E4A"/>
+            <a:srgbClr val="081438"/>
           </a:solidFill>
           <a:ln w="12700">
             <a:solidFill>
@@ -9210,7 +8850,7 @@
       </p:sp>
       <p:sp>
         <p:nvSpPr>
-          <p:cNvPr id="26" name="Rectangle 25"/>
+          <p:cNvPr id="24" name="Rectangle 23"/>
           <p:cNvSpPr/>
           <p:nvPr/>
         </p:nvSpPr>
@@ -9253,7 +8893,7 @@
       </p:sp>
       <p:sp>
         <p:nvSpPr>
-          <p:cNvPr id="27" name="Oval 26"/>
+          <p:cNvPr id="25" name="Oval 24"/>
           <p:cNvSpPr/>
           <p:nvPr/>
         </p:nvSpPr>
@@ -9298,7 +8938,7 @@
       </p:sp>
       <p:sp>
         <p:nvSpPr>
-          <p:cNvPr id="28" name="TextBox 27"/>
+          <p:cNvPr id="26" name="TextBox 25"/>
           <p:cNvSpPr txBox="1"/>
           <p:nvPr/>
         </p:nvSpPr>
@@ -9332,7 +8972,7 @@
       </p:sp>
       <p:sp>
         <p:nvSpPr>
-          <p:cNvPr id="29" name="TextBox 28"/>
+          <p:cNvPr id="27" name="TextBox 26"/>
           <p:cNvSpPr txBox="1"/>
           <p:nvPr/>
         </p:nvSpPr>
@@ -9366,7 +9006,7 @@
       </p:sp>
       <p:sp>
         <p:nvSpPr>
-          <p:cNvPr id="30" name="Rectangle 29"/>
+          <p:cNvPr id="28" name="Rectangle 27"/>
           <p:cNvSpPr/>
           <p:nvPr/>
         </p:nvSpPr>
@@ -9409,7 +9049,7 @@
       </p:sp>
       <p:sp>
         <p:nvSpPr>
-          <p:cNvPr id="31" name="TextBox 30"/>
+          <p:cNvPr id="29" name="TextBox 28"/>
           <p:cNvSpPr txBox="1"/>
           <p:nvPr/>
         </p:nvSpPr>
@@ -9551,7 +9191,7 @@
                                 <p:cBhvr>
                                   <p:cTn id="6" dur="450" fill="hold"/>
                                   <p:tgtEl>
-                                    <p:spTgt spid="11"/>
+                                    <p:spTgt spid="9"/>
                                   </p:tgtEl>
                                 </p:cBhvr>
                               </p:animEffect>
@@ -9568,7 +9208,7 @@
                                 <p:cBhvr>
                                   <p:cTn id="8" dur="450" fill="hold"/>
                                   <p:tgtEl>
-                                    <p:spTgt spid="18"/>
+                                    <p:spTgt spid="16"/>
                                   </p:tgtEl>
                                 </p:cBhvr>
                               </p:animEffect>
@@ -9585,7 +9225,7 @@
                                 <p:cBhvr>
                                   <p:cTn id="10" dur="450" fill="hold"/>
                                   <p:tgtEl>
-                                    <p:spTgt spid="25"/>
+                                    <p:spTgt spid="23"/>
                                   </p:tgtEl>
                                 </p:cBhvr>
                               </p:animEffect>
@@ -9627,7 +9267,7 @@
       <p:grpSpPr/>
       <p:pic>
         <p:nvPicPr>
-          <p:cNvPr id="2" name="Picture 1" descr="building.jpg"/>
+          <p:cNvPr id="2" name="Picture 1" descr="content_bg.png"/>
           <p:cNvPicPr>
             <a:picLocks noChangeAspect="1"/>
           </p:cNvPicPr>
@@ -9658,96 +9298,6 @@
         <p:spPr>
           <a:xfrm>
             <a:off x="0" y="0"/>
-            <a:ext cx="12191695" cy="6858000"/>
-          </a:xfrm>
-          <a:prstGeom prst="rect">
-            <a:avLst/>
-          </a:prstGeom>
-          <a:solidFill>
-            <a:srgbClr val="060E24">
-              <a:alpha val="44000"/>
-            </a:srgbClr>
-          </a:solidFill>
-          <a:ln>
-            <a:noFill/>
-          </a:ln>
-        </p:spPr>
-        <p:style>
-          <a:lnRef idx="1">
-            <a:schemeClr val="accent1"/>
-          </a:lnRef>
-          <a:fillRef idx="3">
-            <a:schemeClr val="accent1"/>
-          </a:fillRef>
-          <a:effectRef idx="2">
-            <a:schemeClr val="accent1"/>
-          </a:effectRef>
-          <a:fontRef idx="minor">
-            <a:schemeClr val="lt1"/>
-          </a:fontRef>
-        </p:style>
-        <p:txBody>
-          <a:bodyPr rtlCol="0" anchor="ctr"/>
-          <a:lstStyle/>
-          <a:p>
-            <a:pPr algn="ctr"/>
-          </a:p>
-        </p:txBody>
-      </p:sp>
-      <p:sp>
-        <p:nvSpPr>
-          <p:cNvPr id="4" name="Rectangle 3"/>
-          <p:cNvSpPr/>
-          <p:nvPr/>
-        </p:nvSpPr>
-        <p:spPr>
-          <a:xfrm>
-            <a:off x="0" y="0"/>
-            <a:ext cx="12191695" cy="1645920"/>
-          </a:xfrm>
-          <a:prstGeom prst="rect">
-            <a:avLst/>
-          </a:prstGeom>
-          <a:solidFill>
-            <a:srgbClr val="060E24">
-              <a:alpha val="20000"/>
-            </a:srgbClr>
-          </a:solidFill>
-          <a:ln>
-            <a:noFill/>
-          </a:ln>
-        </p:spPr>
-        <p:style>
-          <a:lnRef idx="1">
-            <a:schemeClr val="accent1"/>
-          </a:lnRef>
-          <a:fillRef idx="3">
-            <a:schemeClr val="accent1"/>
-          </a:fillRef>
-          <a:effectRef idx="2">
-            <a:schemeClr val="accent1"/>
-          </a:effectRef>
-          <a:fontRef idx="minor">
-            <a:schemeClr val="lt1"/>
-          </a:fontRef>
-        </p:style>
-        <p:txBody>
-          <a:bodyPr rtlCol="0" anchor="ctr"/>
-          <a:lstStyle/>
-          <a:p>
-            <a:pPr algn="ctr"/>
-          </a:p>
-        </p:txBody>
-      </p:sp>
-      <p:sp>
-        <p:nvSpPr>
-          <p:cNvPr id="5" name="Rectangle 4"/>
-          <p:cNvSpPr/>
-          <p:nvPr/>
-        </p:nvSpPr>
-        <p:spPr>
-          <a:xfrm>
-            <a:off x="0" y="0"/>
             <a:ext cx="12191695" cy="44450"/>
           </a:xfrm>
           <a:prstGeom prst="rect">
@@ -9784,7 +9334,7 @@
       </p:sp>
       <p:sp>
         <p:nvSpPr>
-          <p:cNvPr id="6" name="Rectangle 5"/>
+          <p:cNvPr id="4" name="Rectangle 3"/>
           <p:cNvSpPr/>
           <p:nvPr/>
         </p:nvSpPr>
@@ -9827,7 +9377,7 @@
       </p:sp>
       <p:sp>
         <p:nvSpPr>
-          <p:cNvPr id="7" name="Rectangle 6"/>
+          <p:cNvPr id="5" name="Rectangle 4"/>
           <p:cNvSpPr/>
           <p:nvPr/>
         </p:nvSpPr>
@@ -9878,7 +9428,7 @@
       </p:sp>
       <p:sp>
         <p:nvSpPr>
-          <p:cNvPr id="8" name="TextBox 7"/>
+          <p:cNvPr id="6" name="TextBox 5"/>
           <p:cNvSpPr txBox="1"/>
           <p:nvPr/>
         </p:nvSpPr>
@@ -9920,7 +9470,7 @@
       </p:sp>
       <p:sp>
         <p:nvSpPr>
-          <p:cNvPr id="9" name="Rectangle 8"/>
+          <p:cNvPr id="7" name="Rectangle 6"/>
           <p:cNvSpPr/>
           <p:nvPr/>
         </p:nvSpPr>
@@ -9963,7 +9513,7 @@
       </p:sp>
       <p:pic>
         <p:nvPicPr>
-          <p:cNvPr id="10" name="Picture 9" descr="logo_horiz.png"/>
+          <p:cNvPr id="8" name="Picture 7" descr="logo_horiz.png"/>
           <p:cNvPicPr>
             <a:picLocks noChangeAspect="1"/>
           </p:cNvPicPr>
@@ -9987,7 +9537,7 @@
       </p:pic>
       <p:sp>
         <p:nvSpPr>
-          <p:cNvPr id="11" name="Rectangle 10"/>
+          <p:cNvPr id="9" name="Rectangle 8"/>
           <p:cNvSpPr/>
           <p:nvPr/>
         </p:nvSpPr>
@@ -10000,7 +9550,7 @@
             <a:avLst/>
           </a:prstGeom>
           <a:solidFill>
-            <a:srgbClr val="0E1E4A"/>
+            <a:srgbClr val="081438"/>
           </a:solidFill>
           <a:ln w="6350">
             <a:solidFill>
@@ -10032,7 +9582,7 @@
       </p:sp>
       <p:sp>
         <p:nvSpPr>
-          <p:cNvPr id="12" name="Rectangle 11"/>
+          <p:cNvPr id="10" name="Rectangle 9"/>
           <p:cNvSpPr/>
           <p:nvPr/>
         </p:nvSpPr>
@@ -10075,7 +9625,7 @@
       </p:sp>
       <p:sp>
         <p:nvSpPr>
-          <p:cNvPr id="13" name="Oval 12"/>
+          <p:cNvPr id="11" name="Oval 10"/>
           <p:cNvSpPr/>
           <p:nvPr/>
         </p:nvSpPr>
@@ -10120,7 +9670,7 @@
       </p:sp>
       <p:sp>
         <p:nvSpPr>
-          <p:cNvPr id="14" name="TextBox 13"/>
+          <p:cNvPr id="12" name="TextBox 11"/>
           <p:cNvSpPr txBox="1"/>
           <p:nvPr/>
         </p:nvSpPr>
@@ -10154,7 +9704,7 @@
       </p:sp>
       <p:sp>
         <p:nvSpPr>
-          <p:cNvPr id="15" name="TextBox 14"/>
+          <p:cNvPr id="13" name="TextBox 12"/>
           <p:cNvSpPr txBox="1"/>
           <p:nvPr/>
         </p:nvSpPr>
@@ -10188,7 +9738,7 @@
       </p:sp>
       <p:sp>
         <p:nvSpPr>
-          <p:cNvPr id="16" name="Rectangle 15"/>
+          <p:cNvPr id="14" name="Rectangle 13"/>
           <p:cNvSpPr/>
           <p:nvPr/>
         </p:nvSpPr>
@@ -10231,7 +9781,7 @@
       </p:sp>
       <p:sp>
         <p:nvSpPr>
-          <p:cNvPr id="17" name="TextBox 16"/>
+          <p:cNvPr id="15" name="TextBox 14"/>
           <p:cNvSpPr txBox="1"/>
           <p:nvPr/>
         </p:nvSpPr>
@@ -10265,7 +9815,7 @@
       </p:sp>
       <p:sp>
         <p:nvSpPr>
-          <p:cNvPr id="18" name="Rectangle 17"/>
+          <p:cNvPr id="16" name="Rectangle 15"/>
           <p:cNvSpPr/>
           <p:nvPr/>
         </p:nvSpPr>
@@ -10278,7 +9828,7 @@
             <a:avLst/>
           </a:prstGeom>
           <a:solidFill>
-            <a:srgbClr val="0E1E4A"/>
+            <a:srgbClr val="081438"/>
           </a:solidFill>
           <a:ln w="6350">
             <a:solidFill>
@@ -10310,7 +9860,7 @@
       </p:sp>
       <p:sp>
         <p:nvSpPr>
-          <p:cNvPr id="19" name="Rectangle 18"/>
+          <p:cNvPr id="17" name="Rectangle 16"/>
           <p:cNvSpPr/>
           <p:nvPr/>
         </p:nvSpPr>
@@ -10353,7 +9903,7 @@
       </p:sp>
       <p:sp>
         <p:nvSpPr>
-          <p:cNvPr id="20" name="Oval 19"/>
+          <p:cNvPr id="18" name="Oval 17"/>
           <p:cNvSpPr/>
           <p:nvPr/>
         </p:nvSpPr>
@@ -10398,7 +9948,7 @@
       </p:sp>
       <p:sp>
         <p:nvSpPr>
-          <p:cNvPr id="21" name="TextBox 20"/>
+          <p:cNvPr id="19" name="TextBox 18"/>
           <p:cNvSpPr txBox="1"/>
           <p:nvPr/>
         </p:nvSpPr>
@@ -10432,7 +9982,7 @@
       </p:sp>
       <p:sp>
         <p:nvSpPr>
-          <p:cNvPr id="22" name="TextBox 21"/>
+          <p:cNvPr id="20" name="TextBox 19"/>
           <p:cNvSpPr txBox="1"/>
           <p:nvPr/>
         </p:nvSpPr>
@@ -10466,7 +10016,7 @@
       </p:sp>
       <p:sp>
         <p:nvSpPr>
-          <p:cNvPr id="23" name="Rectangle 22"/>
+          <p:cNvPr id="21" name="Rectangle 20"/>
           <p:cNvSpPr/>
           <p:nvPr/>
         </p:nvSpPr>
@@ -10509,7 +10059,7 @@
       </p:sp>
       <p:sp>
         <p:nvSpPr>
-          <p:cNvPr id="24" name="TextBox 23"/>
+          <p:cNvPr id="22" name="TextBox 21"/>
           <p:cNvSpPr txBox="1"/>
           <p:nvPr/>
         </p:nvSpPr>
@@ -10543,7 +10093,7 @@
       </p:sp>
       <p:sp>
         <p:nvSpPr>
-          <p:cNvPr id="25" name="Rectangle 24"/>
+          <p:cNvPr id="23" name="Rectangle 22"/>
           <p:cNvSpPr/>
           <p:nvPr/>
         </p:nvSpPr>
@@ -10556,7 +10106,7 @@
             <a:avLst/>
           </a:prstGeom>
           <a:solidFill>
-            <a:srgbClr val="0E1E4A"/>
+            <a:srgbClr val="081438"/>
           </a:solidFill>
           <a:ln w="6350">
             <a:solidFill>
@@ -10588,7 +10138,7 @@
       </p:sp>
       <p:sp>
         <p:nvSpPr>
-          <p:cNvPr id="26" name="Rectangle 25"/>
+          <p:cNvPr id="24" name="Rectangle 23"/>
           <p:cNvSpPr/>
           <p:nvPr/>
         </p:nvSpPr>
@@ -10631,7 +10181,7 @@
       </p:sp>
       <p:sp>
         <p:nvSpPr>
-          <p:cNvPr id="27" name="Oval 26"/>
+          <p:cNvPr id="25" name="Oval 24"/>
           <p:cNvSpPr/>
           <p:nvPr/>
         </p:nvSpPr>
@@ -10676,7 +10226,7 @@
       </p:sp>
       <p:sp>
         <p:nvSpPr>
-          <p:cNvPr id="28" name="TextBox 27"/>
+          <p:cNvPr id="26" name="TextBox 25"/>
           <p:cNvSpPr txBox="1"/>
           <p:nvPr/>
         </p:nvSpPr>
@@ -10710,7 +10260,7 @@
       </p:sp>
       <p:sp>
         <p:nvSpPr>
-          <p:cNvPr id="29" name="TextBox 28"/>
+          <p:cNvPr id="27" name="TextBox 26"/>
           <p:cNvSpPr txBox="1"/>
           <p:nvPr/>
         </p:nvSpPr>
@@ -10744,7 +10294,7 @@
       </p:sp>
       <p:sp>
         <p:nvSpPr>
-          <p:cNvPr id="30" name="Rectangle 29"/>
+          <p:cNvPr id="28" name="Rectangle 27"/>
           <p:cNvSpPr/>
           <p:nvPr/>
         </p:nvSpPr>
@@ -10787,7 +10337,7 @@
       </p:sp>
       <p:sp>
         <p:nvSpPr>
-          <p:cNvPr id="31" name="TextBox 30"/>
+          <p:cNvPr id="29" name="TextBox 28"/>
           <p:cNvSpPr txBox="1"/>
           <p:nvPr/>
         </p:nvSpPr>
@@ -10821,7 +10371,7 @@
       </p:sp>
       <p:sp>
         <p:nvSpPr>
-          <p:cNvPr id="32" name="Rectangle 31"/>
+          <p:cNvPr id="30" name="Rectangle 29"/>
           <p:cNvSpPr/>
           <p:nvPr/>
         </p:nvSpPr>
@@ -10834,7 +10384,7 @@
             <a:avLst/>
           </a:prstGeom>
           <a:solidFill>
-            <a:srgbClr val="0E1E4A"/>
+            <a:srgbClr val="081438"/>
           </a:solidFill>
           <a:ln w="6350">
             <a:solidFill>
@@ -10866,7 +10416,7 @@
       </p:sp>
       <p:sp>
         <p:nvSpPr>
-          <p:cNvPr id="33" name="Rectangle 32"/>
+          <p:cNvPr id="31" name="Rectangle 30"/>
           <p:cNvSpPr/>
           <p:nvPr/>
         </p:nvSpPr>
@@ -10909,7 +10459,7 @@
       </p:sp>
       <p:sp>
         <p:nvSpPr>
-          <p:cNvPr id="34" name="Oval 33"/>
+          <p:cNvPr id="32" name="Oval 31"/>
           <p:cNvSpPr/>
           <p:nvPr/>
         </p:nvSpPr>
@@ -10954,7 +10504,7 @@
       </p:sp>
       <p:sp>
         <p:nvSpPr>
-          <p:cNvPr id="35" name="TextBox 34"/>
+          <p:cNvPr id="33" name="TextBox 32"/>
           <p:cNvSpPr txBox="1"/>
           <p:nvPr/>
         </p:nvSpPr>
@@ -10988,7 +10538,7 @@
       </p:sp>
       <p:sp>
         <p:nvSpPr>
-          <p:cNvPr id="36" name="TextBox 35"/>
+          <p:cNvPr id="34" name="TextBox 33"/>
           <p:cNvSpPr txBox="1"/>
           <p:nvPr/>
         </p:nvSpPr>
@@ -11022,7 +10572,7 @@
       </p:sp>
       <p:sp>
         <p:nvSpPr>
-          <p:cNvPr id="37" name="Rectangle 36"/>
+          <p:cNvPr id="35" name="Rectangle 34"/>
           <p:cNvSpPr/>
           <p:nvPr/>
         </p:nvSpPr>
@@ -11065,7 +10615,7 @@
       </p:sp>
       <p:sp>
         <p:nvSpPr>
-          <p:cNvPr id="38" name="TextBox 37"/>
+          <p:cNvPr id="36" name="TextBox 35"/>
           <p:cNvSpPr txBox="1"/>
           <p:nvPr/>
         </p:nvSpPr>
@@ -11126,7 +10676,7 @@
                                 <p:cBhvr>
                                   <p:cTn id="6" dur="450" fill="hold"/>
                                   <p:tgtEl>
-                                    <p:spTgt spid="11"/>
+                                    <p:spTgt spid="9"/>
                                   </p:tgtEl>
                                 </p:cBhvr>
                               </p:animEffect>
@@ -11143,7 +10693,7 @@
                                 <p:cBhvr>
                                   <p:cTn id="8" dur="450" fill="hold"/>
                                   <p:tgtEl>
-                                    <p:spTgt spid="18"/>
+                                    <p:spTgt spid="16"/>
                                   </p:tgtEl>
                                 </p:cBhvr>
                               </p:animEffect>
@@ -11160,7 +10710,7 @@
                                 <p:cBhvr>
                                   <p:cTn id="10" dur="450" fill="hold"/>
                                   <p:tgtEl>
-                                    <p:spTgt spid="25"/>
+                                    <p:spTgt spid="23"/>
                                   </p:tgtEl>
                                 </p:cBhvr>
                               </p:animEffect>
@@ -11177,7 +10727,7 @@
                                 <p:cBhvr>
                                   <p:cTn id="12" dur="450" fill="hold"/>
                                   <p:tgtEl>
-                                    <p:spTgt spid="32"/>
+                                    <p:spTgt spid="30"/>
                                   </p:tgtEl>
                                 </p:cBhvr>
                               </p:animEffect>
@@ -11651,7 +11201,7 @@
             <a:avLst/>
           </a:prstGeom>
           <a:solidFill>
-            <a:srgbClr val="0E1E4A"/>
+            <a:srgbClr val="081438"/>
           </a:solidFill>
           <a:ln w="6350">
             <a:solidFill>
@@ -11884,7 +11434,7 @@
             <a:avLst/>
           </a:prstGeom>
           <a:solidFill>
-            <a:srgbClr val="0E1E4A"/>
+            <a:srgbClr val="081438"/>
           </a:solidFill>
           <a:ln w="6350">
             <a:solidFill>
@@ -12117,7 +11667,7 @@
             <a:avLst/>
           </a:prstGeom>
           <a:solidFill>
-            <a:srgbClr val="0E1E4A"/>
+            <a:srgbClr val="081438"/>
           </a:solidFill>
           <a:ln w="6350">
             <a:solidFill>

</xml_diff>

<commit_message>
Remove bugged phase circle illustration from content slides
Co-Authored-By: Claude Sonnet 4.6 <noreply@anthropic.com>
Claude-Session: https://claude.ai/code/session_01BiSyRij3iqrCgrJJFpGphy
</commit_message>
<xml_diff>
--- a/sendacredit_propuesta.pptx
+++ b/sendacredit_propuesta.pptx
@@ -3588,165 +3588,7 @@
       </p:sp>
       <p:sp>
         <p:nvSpPr>
-          <p:cNvPr id="5" name="Oval 4"/>
-          <p:cNvSpPr/>
-          <p:nvPr/>
-        </p:nvSpPr>
-        <p:spPr>
-          <a:xfrm>
-            <a:off x="10618927" y="182880"/>
-            <a:ext cx="1188720" cy="1188720"/>
-          </a:xfrm>
-          <a:prstGeom prst="ellipse">
-            <a:avLst/>
-          </a:prstGeom>
-          <a:solidFill>
-            <a:srgbClr val="2FDFE5"/>
-          </a:solidFill>
-          <a:ln>
-            <a:noFill/>
-          </a:ln>
-        </p:spPr>
-        <p:style>
-          <a:lnRef idx="1">
-            <a:schemeClr val="accent1"/>
-          </a:lnRef>
-          <a:fillRef idx="3">
-            <a:schemeClr val="accent1"/>
-          </a:fillRef>
-          <a:effectRef idx="2">
-            <a:schemeClr val="accent1"/>
-          </a:effectRef>
-          <a:fontRef idx="minor">
-            <a:schemeClr val="lt1"/>
-          </a:fontRef>
-        </p:style>
-        <p:txBody>
-          <a:bodyPr rtlCol="0" anchor="ctr"/>
-          <a:lstStyle/>
-          <a:p>
-            <a:pPr algn="ctr"/>
-          </a:p>
-        </p:txBody>
-      </p:sp>
-      <p:sp>
-        <p:nvSpPr>
-          <p:cNvPr id="6" name="Oval 5"/>
-          <p:cNvSpPr/>
-          <p:nvPr/>
-        </p:nvSpPr>
-        <p:spPr>
-          <a:xfrm>
-            <a:off x="10826953" y="390906"/>
-            <a:ext cx="772668" cy="772668"/>
-          </a:xfrm>
-          <a:prstGeom prst="ellipse">
-            <a:avLst/>
-          </a:prstGeom>
-          <a:solidFill>
-            <a:srgbClr val="0A1638"/>
-          </a:solidFill>
-          <a:ln>
-            <a:noFill/>
-          </a:ln>
-        </p:spPr>
-        <p:style>
-          <a:lnRef idx="1">
-            <a:schemeClr val="accent1"/>
-          </a:lnRef>
-          <a:fillRef idx="3">
-            <a:schemeClr val="accent1"/>
-          </a:fillRef>
-          <a:effectRef idx="2">
-            <a:schemeClr val="accent1"/>
-          </a:effectRef>
-          <a:fontRef idx="minor">
-            <a:schemeClr val="lt1"/>
-          </a:fontRef>
-        </p:style>
-        <p:txBody>
-          <a:bodyPr rtlCol="0" anchor="ctr"/>
-          <a:lstStyle/>
-          <a:p>
-            <a:pPr algn="ctr"/>
-          </a:p>
-        </p:txBody>
-      </p:sp>
-      <p:sp>
-        <p:nvSpPr>
-          <p:cNvPr id="7" name="TextBox 6"/>
-          <p:cNvSpPr txBox="1"/>
-          <p:nvPr/>
-        </p:nvSpPr>
-        <p:spPr>
-          <a:xfrm>
-            <a:off x="10618927" y="182880"/>
-            <a:ext cx="1188720" cy="1188720"/>
-          </a:xfrm>
-          <a:prstGeom prst="rect">
-            <a:avLst/>
-          </a:prstGeom>
-          <a:noFill/>
-        </p:spPr>
-        <p:txBody lIns="0" tIns="0" rIns="0" bIns="0">
-          <a:bodyPr wrap="none">
-            <a:spAutoFit/>
-          </a:bodyPr>
-          <a:lstStyle/>
-          <a:p>
-            <a:pPr algn="ctr">
-              <a:spcBef>
-                <a:spcPts val="2300"/>
-              </a:spcBef>
-            </a:pPr>
-            <a:r>
-              <a:rPr sz="2200" b="1">
-                <a:solidFill>
-                  <a:srgbClr val="2FDFE5"/>
-                </a:solidFill>
-              </a:rPr>
-              <a:t>1</a:t>
-            </a:r>
-          </a:p>
-        </p:txBody>
-      </p:sp>
-      <p:sp>
-        <p:nvSpPr>
-          <p:cNvPr id="8" name="TextBox 7"/>
-          <p:cNvSpPr txBox="1"/>
-          <p:nvPr/>
-        </p:nvSpPr>
-        <p:spPr>
-          <a:xfrm>
-            <a:off x="10618927" y="777240"/>
-            <a:ext cx="1188720" cy="594360"/>
-          </a:xfrm>
-          <a:prstGeom prst="rect">
-            <a:avLst/>
-          </a:prstGeom>
-          <a:noFill/>
-        </p:spPr>
-        <p:txBody lIns="0" tIns="0" rIns="0" bIns="0">
-          <a:bodyPr wrap="none">
-            <a:spAutoFit/>
-          </a:bodyPr>
-          <a:lstStyle/>
-          <a:p>
-            <a:pPr algn="ctr"/>
-            <a:r>
-              <a:rPr sz="950">
-                <a:solidFill>
-                  <a:srgbClr val="FFFFFF"/>
-                </a:solidFill>
-              </a:rPr>
-              <a:t>RECEPCIÓN</a:t>
-            </a:r>
-          </a:p>
-        </p:txBody>
-      </p:sp>
-      <p:sp>
-        <p:nvSpPr>
-          <p:cNvPr id="9" name="Rectangle 8"/>
+          <p:cNvPr id="5" name="Rectangle 4"/>
           <p:cNvSpPr/>
           <p:nvPr/>
         </p:nvSpPr>
@@ -3797,7 +3639,7 @@
       </p:sp>
       <p:sp>
         <p:nvSpPr>
-          <p:cNvPr id="10" name="TextBox 9"/>
+          <p:cNvPr id="6" name="TextBox 5"/>
           <p:cNvSpPr txBox="1"/>
           <p:nvPr/>
         </p:nvSpPr>
@@ -3839,7 +3681,7 @@
       </p:sp>
       <p:sp>
         <p:nvSpPr>
-          <p:cNvPr id="11" name="Rectangle 10"/>
+          <p:cNvPr id="7" name="Rectangle 6"/>
           <p:cNvSpPr/>
           <p:nvPr/>
         </p:nvSpPr>
@@ -3882,7 +3724,7 @@
       </p:sp>
       <p:sp>
         <p:nvSpPr>
-          <p:cNvPr id="12" name="TextBox 11"/>
+          <p:cNvPr id="8" name="TextBox 7"/>
           <p:cNvSpPr txBox="1"/>
           <p:nvPr/>
         </p:nvSpPr>
@@ -3916,7 +3758,7 @@
       </p:sp>
       <p:pic>
         <p:nvPicPr>
-          <p:cNvPr id="13" name="Picture 12" descr="logo_horiz.png"/>
+          <p:cNvPr id="9" name="Picture 8" descr="logo_horiz.png"/>
           <p:cNvPicPr>
             <a:picLocks noChangeAspect="1"/>
           </p:cNvPicPr>
@@ -3940,7 +3782,7 @@
       </p:pic>
       <p:sp>
         <p:nvSpPr>
-          <p:cNvPr id="14" name="Oval 13"/>
+          <p:cNvPr id="10" name="Oval 9"/>
           <p:cNvSpPr/>
           <p:nvPr/>
         </p:nvSpPr>
@@ -3983,7 +3825,7 @@
       </p:sp>
       <p:sp>
         <p:nvSpPr>
-          <p:cNvPr id="15" name="Oval 14"/>
+          <p:cNvPr id="11" name="Oval 10"/>
           <p:cNvSpPr/>
           <p:nvPr/>
         </p:nvSpPr>
@@ -4026,7 +3868,7 @@
       </p:sp>
       <p:sp>
         <p:nvSpPr>
-          <p:cNvPr id="16" name="Oval 15"/>
+          <p:cNvPr id="12" name="Oval 11"/>
           <p:cNvSpPr/>
           <p:nvPr/>
         </p:nvSpPr>
@@ -4069,7 +3911,7 @@
       </p:sp>
       <p:sp>
         <p:nvSpPr>
-          <p:cNvPr id="17" name="Oval 16"/>
+          <p:cNvPr id="13" name="Oval 12"/>
           <p:cNvSpPr/>
           <p:nvPr/>
         </p:nvSpPr>
@@ -4112,7 +3954,7 @@
       </p:sp>
       <p:sp>
         <p:nvSpPr>
-          <p:cNvPr id="18" name="Oval 17"/>
+          <p:cNvPr id="14" name="Oval 13"/>
           <p:cNvSpPr/>
           <p:nvPr/>
         </p:nvSpPr>
@@ -4155,7 +3997,7 @@
       </p:sp>
       <p:sp>
         <p:nvSpPr>
-          <p:cNvPr id="19" name="Rectangle 18"/>
+          <p:cNvPr id="15" name="Rectangle 14"/>
           <p:cNvSpPr/>
           <p:nvPr/>
         </p:nvSpPr>
@@ -4200,7 +4042,7 @@
       </p:sp>
       <p:sp>
         <p:nvSpPr>
-          <p:cNvPr id="20" name="Rectangle 19"/>
+          <p:cNvPr id="16" name="Rectangle 15"/>
           <p:cNvSpPr/>
           <p:nvPr/>
         </p:nvSpPr>
@@ -4243,7 +4085,7 @@
       </p:sp>
       <p:sp>
         <p:nvSpPr>
-          <p:cNvPr id="21" name="Oval 20"/>
+          <p:cNvPr id="17" name="Oval 16"/>
           <p:cNvSpPr/>
           <p:nvPr/>
         </p:nvSpPr>
@@ -4286,7 +4128,7 @@
       </p:sp>
       <p:sp>
         <p:nvSpPr>
-          <p:cNvPr id="22" name="Oval 21"/>
+          <p:cNvPr id="18" name="Oval 17"/>
           <p:cNvSpPr/>
           <p:nvPr/>
         </p:nvSpPr>
@@ -4329,7 +4171,7 @@
       </p:sp>
       <p:sp>
         <p:nvSpPr>
-          <p:cNvPr id="23" name="TextBox 22"/>
+          <p:cNvPr id="19" name="TextBox 18"/>
           <p:cNvSpPr txBox="1"/>
           <p:nvPr/>
         </p:nvSpPr>
@@ -4367,7 +4209,7 @@
       </p:sp>
       <p:sp>
         <p:nvSpPr>
-          <p:cNvPr id="24" name="Oval 23"/>
+          <p:cNvPr id="20" name="Oval 19"/>
           <p:cNvSpPr/>
           <p:nvPr/>
         </p:nvSpPr>
@@ -4412,7 +4254,7 @@
       </p:sp>
       <p:sp>
         <p:nvSpPr>
-          <p:cNvPr id="25" name="TextBox 24"/>
+          <p:cNvPr id="21" name="TextBox 20"/>
           <p:cNvSpPr txBox="1"/>
           <p:nvPr/>
         </p:nvSpPr>
@@ -4446,7 +4288,7 @@
       </p:sp>
       <p:sp>
         <p:nvSpPr>
-          <p:cNvPr id="26" name="TextBox 25"/>
+          <p:cNvPr id="22" name="TextBox 21"/>
           <p:cNvSpPr txBox="1"/>
           <p:nvPr/>
         </p:nvSpPr>
@@ -4480,7 +4322,7 @@
       </p:sp>
       <p:sp>
         <p:nvSpPr>
-          <p:cNvPr id="27" name="Rectangle 26"/>
+          <p:cNvPr id="23" name="Rectangle 22"/>
           <p:cNvSpPr/>
           <p:nvPr/>
         </p:nvSpPr>
@@ -4523,7 +4365,7 @@
       </p:sp>
       <p:sp>
         <p:nvSpPr>
-          <p:cNvPr id="28" name="TextBox 27"/>
+          <p:cNvPr id="24" name="TextBox 23"/>
           <p:cNvSpPr txBox="1"/>
           <p:nvPr/>
         </p:nvSpPr>
@@ -4615,7 +4457,7 @@
       </p:sp>
       <p:sp>
         <p:nvSpPr>
-          <p:cNvPr id="29" name="Rectangle 28"/>
+          <p:cNvPr id="25" name="Rectangle 24"/>
           <p:cNvSpPr/>
           <p:nvPr/>
         </p:nvSpPr>
@@ -4660,7 +4502,7 @@
       </p:sp>
       <p:sp>
         <p:nvSpPr>
-          <p:cNvPr id="30" name="Rectangle 29"/>
+          <p:cNvPr id="26" name="Rectangle 25"/>
           <p:cNvSpPr/>
           <p:nvPr/>
         </p:nvSpPr>
@@ -4703,7 +4545,7 @@
       </p:sp>
       <p:sp>
         <p:nvSpPr>
-          <p:cNvPr id="31" name="Oval 30"/>
+          <p:cNvPr id="27" name="Oval 26"/>
           <p:cNvSpPr/>
           <p:nvPr/>
         </p:nvSpPr>
@@ -4746,7 +4588,7 @@
       </p:sp>
       <p:sp>
         <p:nvSpPr>
-          <p:cNvPr id="32" name="Oval 31"/>
+          <p:cNvPr id="28" name="Oval 27"/>
           <p:cNvSpPr/>
           <p:nvPr/>
         </p:nvSpPr>
@@ -4789,7 +4631,7 @@
       </p:sp>
       <p:sp>
         <p:nvSpPr>
-          <p:cNvPr id="33" name="TextBox 32"/>
+          <p:cNvPr id="29" name="TextBox 28"/>
           <p:cNvSpPr txBox="1"/>
           <p:nvPr/>
         </p:nvSpPr>
@@ -4827,7 +4669,7 @@
       </p:sp>
       <p:sp>
         <p:nvSpPr>
-          <p:cNvPr id="34" name="Oval 33"/>
+          <p:cNvPr id="30" name="Oval 29"/>
           <p:cNvSpPr/>
           <p:nvPr/>
         </p:nvSpPr>
@@ -4872,7 +4714,7 @@
       </p:sp>
       <p:sp>
         <p:nvSpPr>
-          <p:cNvPr id="35" name="TextBox 34"/>
+          <p:cNvPr id="31" name="TextBox 30"/>
           <p:cNvSpPr txBox="1"/>
           <p:nvPr/>
         </p:nvSpPr>
@@ -4906,7 +4748,7 @@
       </p:sp>
       <p:sp>
         <p:nvSpPr>
-          <p:cNvPr id="36" name="TextBox 35"/>
+          <p:cNvPr id="32" name="TextBox 31"/>
           <p:cNvSpPr txBox="1"/>
           <p:nvPr/>
         </p:nvSpPr>
@@ -4940,7 +4782,7 @@
       </p:sp>
       <p:sp>
         <p:nvSpPr>
-          <p:cNvPr id="37" name="Rectangle 36"/>
+          <p:cNvPr id="33" name="Rectangle 32"/>
           <p:cNvSpPr/>
           <p:nvPr/>
         </p:nvSpPr>
@@ -4983,7 +4825,7 @@
       </p:sp>
       <p:sp>
         <p:nvSpPr>
-          <p:cNvPr id="38" name="TextBox 37"/>
+          <p:cNvPr id="34" name="TextBox 33"/>
           <p:cNvSpPr txBox="1"/>
           <p:nvPr/>
         </p:nvSpPr>
@@ -5102,7 +4944,7 @@
                                 <p:cBhvr>
                                   <p:cTn id="6" dur="450" fill="hold"/>
                                   <p:tgtEl>
-                                    <p:spTgt spid="19"/>
+                                    <p:spTgt spid="15"/>
                                   </p:tgtEl>
                                 </p:cBhvr>
                               </p:animEffect>
@@ -5119,7 +4961,7 @@
                                 <p:cBhvr>
                                   <p:cTn id="8" dur="450" fill="hold"/>
                                   <p:tgtEl>
-                                    <p:spTgt spid="29"/>
+                                    <p:spTgt spid="25"/>
                                   </p:tgtEl>
                                 </p:cBhvr>
                               </p:animEffect>
@@ -5271,165 +5113,7 @@
       </p:sp>
       <p:sp>
         <p:nvSpPr>
-          <p:cNvPr id="5" name="Oval 4"/>
-          <p:cNvSpPr/>
-          <p:nvPr/>
-        </p:nvSpPr>
-        <p:spPr>
-          <a:xfrm>
-            <a:off x="10618927" y="182880"/>
-            <a:ext cx="1188720" cy="1188720"/>
-          </a:xfrm>
-          <a:prstGeom prst="ellipse">
-            <a:avLst/>
-          </a:prstGeom>
-          <a:solidFill>
-            <a:srgbClr val="2FDFE5"/>
-          </a:solidFill>
-          <a:ln>
-            <a:noFill/>
-          </a:ln>
-        </p:spPr>
-        <p:style>
-          <a:lnRef idx="1">
-            <a:schemeClr val="accent1"/>
-          </a:lnRef>
-          <a:fillRef idx="3">
-            <a:schemeClr val="accent1"/>
-          </a:fillRef>
-          <a:effectRef idx="2">
-            <a:schemeClr val="accent1"/>
-          </a:effectRef>
-          <a:fontRef idx="minor">
-            <a:schemeClr val="lt1"/>
-          </a:fontRef>
-        </p:style>
-        <p:txBody>
-          <a:bodyPr rtlCol="0" anchor="ctr"/>
-          <a:lstStyle/>
-          <a:p>
-            <a:pPr algn="ctr"/>
-          </a:p>
-        </p:txBody>
-      </p:sp>
-      <p:sp>
-        <p:nvSpPr>
-          <p:cNvPr id="6" name="Oval 5"/>
-          <p:cNvSpPr/>
-          <p:nvPr/>
-        </p:nvSpPr>
-        <p:spPr>
-          <a:xfrm>
-            <a:off x="10826953" y="390906"/>
-            <a:ext cx="772668" cy="772668"/>
-          </a:xfrm>
-          <a:prstGeom prst="ellipse">
-            <a:avLst/>
-          </a:prstGeom>
-          <a:solidFill>
-            <a:srgbClr val="0A1638"/>
-          </a:solidFill>
-          <a:ln>
-            <a:noFill/>
-          </a:ln>
-        </p:spPr>
-        <p:style>
-          <a:lnRef idx="1">
-            <a:schemeClr val="accent1"/>
-          </a:lnRef>
-          <a:fillRef idx="3">
-            <a:schemeClr val="accent1"/>
-          </a:fillRef>
-          <a:effectRef idx="2">
-            <a:schemeClr val="accent1"/>
-          </a:effectRef>
-          <a:fontRef idx="minor">
-            <a:schemeClr val="lt1"/>
-          </a:fontRef>
-        </p:style>
-        <p:txBody>
-          <a:bodyPr rtlCol="0" anchor="ctr"/>
-          <a:lstStyle/>
-          <a:p>
-            <a:pPr algn="ctr"/>
-          </a:p>
-        </p:txBody>
-      </p:sp>
-      <p:sp>
-        <p:nvSpPr>
-          <p:cNvPr id="7" name="TextBox 6"/>
-          <p:cNvSpPr txBox="1"/>
-          <p:nvPr/>
-        </p:nvSpPr>
-        <p:spPr>
-          <a:xfrm>
-            <a:off x="10618927" y="182880"/>
-            <a:ext cx="1188720" cy="1188720"/>
-          </a:xfrm>
-          <a:prstGeom prst="rect">
-            <a:avLst/>
-          </a:prstGeom>
-          <a:noFill/>
-        </p:spPr>
-        <p:txBody lIns="0" tIns="0" rIns="0" bIns="0">
-          <a:bodyPr wrap="none">
-            <a:spAutoFit/>
-          </a:bodyPr>
-          <a:lstStyle/>
-          <a:p>
-            <a:pPr algn="ctr">
-              <a:spcBef>
-                <a:spcPts val="2300"/>
-              </a:spcBef>
-            </a:pPr>
-            <a:r>
-              <a:rPr sz="2200" b="1">
-                <a:solidFill>
-                  <a:srgbClr val="2FDFE5"/>
-                </a:solidFill>
-              </a:rPr>
-              <a:t>2</a:t>
-            </a:r>
-          </a:p>
-        </p:txBody>
-      </p:sp>
-      <p:sp>
-        <p:nvSpPr>
-          <p:cNvPr id="8" name="TextBox 7"/>
-          <p:cNvSpPr txBox="1"/>
-          <p:nvPr/>
-        </p:nvSpPr>
-        <p:spPr>
-          <a:xfrm>
-            <a:off x="10618927" y="777240"/>
-            <a:ext cx="1188720" cy="594360"/>
-          </a:xfrm>
-          <a:prstGeom prst="rect">
-            <a:avLst/>
-          </a:prstGeom>
-          <a:noFill/>
-        </p:spPr>
-        <p:txBody lIns="0" tIns="0" rIns="0" bIns="0">
-          <a:bodyPr wrap="none">
-            <a:spAutoFit/>
-          </a:bodyPr>
-          <a:lstStyle/>
-          <a:p>
-            <a:pPr algn="ctr"/>
-            <a:r>
-              <a:rPr sz="950">
-                <a:solidFill>
-                  <a:srgbClr val="FFFFFF"/>
-                </a:solidFill>
-              </a:rPr>
-              <a:t>GESTIÓN</a:t>
-            </a:r>
-          </a:p>
-        </p:txBody>
-      </p:sp>
-      <p:sp>
-        <p:nvSpPr>
-          <p:cNvPr id="9" name="Rectangle 8"/>
+          <p:cNvPr id="5" name="Rectangle 4"/>
           <p:cNvSpPr/>
           <p:nvPr/>
         </p:nvSpPr>
@@ -5480,7 +5164,7 @@
       </p:sp>
       <p:sp>
         <p:nvSpPr>
-          <p:cNvPr id="10" name="TextBox 9"/>
+          <p:cNvPr id="6" name="TextBox 5"/>
           <p:cNvSpPr txBox="1"/>
           <p:nvPr/>
         </p:nvSpPr>
@@ -5522,7 +5206,7 @@
       </p:sp>
       <p:sp>
         <p:nvSpPr>
-          <p:cNvPr id="11" name="Rectangle 10"/>
+          <p:cNvPr id="7" name="Rectangle 6"/>
           <p:cNvSpPr/>
           <p:nvPr/>
         </p:nvSpPr>
@@ -5565,7 +5249,7 @@
       </p:sp>
       <p:sp>
         <p:nvSpPr>
-          <p:cNvPr id="12" name="TextBox 11"/>
+          <p:cNvPr id="8" name="TextBox 7"/>
           <p:cNvSpPr txBox="1"/>
           <p:nvPr/>
         </p:nvSpPr>
@@ -5599,7 +5283,7 @@
       </p:sp>
       <p:pic>
         <p:nvPicPr>
-          <p:cNvPr id="13" name="Picture 12" descr="logo_horiz.png"/>
+          <p:cNvPr id="9" name="Picture 8" descr="logo_horiz.png"/>
           <p:cNvPicPr>
             <a:picLocks noChangeAspect="1"/>
           </p:cNvPicPr>
@@ -5623,7 +5307,7 @@
       </p:pic>
       <p:sp>
         <p:nvSpPr>
-          <p:cNvPr id="14" name="Oval 13"/>
+          <p:cNvPr id="10" name="Oval 9"/>
           <p:cNvSpPr/>
           <p:nvPr/>
         </p:nvSpPr>
@@ -5666,7 +5350,7 @@
       </p:sp>
       <p:sp>
         <p:nvSpPr>
-          <p:cNvPr id="15" name="Oval 14"/>
+          <p:cNvPr id="11" name="Oval 10"/>
           <p:cNvSpPr/>
           <p:nvPr/>
         </p:nvSpPr>
@@ -5709,7 +5393,7 @@
       </p:sp>
       <p:sp>
         <p:nvSpPr>
-          <p:cNvPr id="16" name="Oval 15"/>
+          <p:cNvPr id="12" name="Oval 11"/>
           <p:cNvSpPr/>
           <p:nvPr/>
         </p:nvSpPr>
@@ -5752,7 +5436,7 @@
       </p:sp>
       <p:sp>
         <p:nvSpPr>
-          <p:cNvPr id="17" name="Oval 16"/>
+          <p:cNvPr id="13" name="Oval 12"/>
           <p:cNvSpPr/>
           <p:nvPr/>
         </p:nvSpPr>
@@ -5795,7 +5479,7 @@
       </p:sp>
       <p:sp>
         <p:nvSpPr>
-          <p:cNvPr id="18" name="Oval 17"/>
+          <p:cNvPr id="14" name="Oval 13"/>
           <p:cNvSpPr/>
           <p:nvPr/>
         </p:nvSpPr>
@@ -5838,7 +5522,7 @@
       </p:sp>
       <p:sp>
         <p:nvSpPr>
-          <p:cNvPr id="19" name="Rectangle 18"/>
+          <p:cNvPr id="15" name="Rectangle 14"/>
           <p:cNvSpPr/>
           <p:nvPr/>
         </p:nvSpPr>
@@ -5883,7 +5567,7 @@
       </p:sp>
       <p:sp>
         <p:nvSpPr>
-          <p:cNvPr id="20" name="Rectangle 19"/>
+          <p:cNvPr id="16" name="Rectangle 15"/>
           <p:cNvSpPr/>
           <p:nvPr/>
         </p:nvSpPr>
@@ -5926,7 +5610,7 @@
       </p:sp>
       <p:sp>
         <p:nvSpPr>
-          <p:cNvPr id="21" name="Oval 20"/>
+          <p:cNvPr id="17" name="Oval 16"/>
           <p:cNvSpPr/>
           <p:nvPr/>
         </p:nvSpPr>
@@ -5969,7 +5653,7 @@
       </p:sp>
       <p:sp>
         <p:nvSpPr>
-          <p:cNvPr id="22" name="Oval 21"/>
+          <p:cNvPr id="18" name="Oval 17"/>
           <p:cNvSpPr/>
           <p:nvPr/>
         </p:nvSpPr>
@@ -6012,7 +5696,7 @@
       </p:sp>
       <p:sp>
         <p:nvSpPr>
-          <p:cNvPr id="23" name="TextBox 22"/>
+          <p:cNvPr id="19" name="TextBox 18"/>
           <p:cNvSpPr txBox="1"/>
           <p:nvPr/>
         </p:nvSpPr>
@@ -6050,7 +5734,7 @@
       </p:sp>
       <p:sp>
         <p:nvSpPr>
-          <p:cNvPr id="24" name="Oval 23"/>
+          <p:cNvPr id="20" name="Oval 19"/>
           <p:cNvSpPr/>
           <p:nvPr/>
         </p:nvSpPr>
@@ -6095,7 +5779,7 @@
       </p:sp>
       <p:sp>
         <p:nvSpPr>
-          <p:cNvPr id="25" name="TextBox 24"/>
+          <p:cNvPr id="21" name="TextBox 20"/>
           <p:cNvSpPr txBox="1"/>
           <p:nvPr/>
         </p:nvSpPr>
@@ -6129,7 +5813,7 @@
       </p:sp>
       <p:sp>
         <p:nvSpPr>
-          <p:cNvPr id="26" name="TextBox 25"/>
+          <p:cNvPr id="22" name="TextBox 21"/>
           <p:cNvSpPr txBox="1"/>
           <p:nvPr/>
         </p:nvSpPr>
@@ -6163,7 +5847,7 @@
       </p:sp>
       <p:sp>
         <p:nvSpPr>
-          <p:cNvPr id="27" name="Rectangle 26"/>
+          <p:cNvPr id="23" name="Rectangle 22"/>
           <p:cNvSpPr/>
           <p:nvPr/>
         </p:nvSpPr>
@@ -6206,7 +5890,7 @@
       </p:sp>
       <p:sp>
         <p:nvSpPr>
-          <p:cNvPr id="28" name="TextBox 27"/>
+          <p:cNvPr id="24" name="TextBox 23"/>
           <p:cNvSpPr txBox="1"/>
           <p:nvPr/>
         </p:nvSpPr>
@@ -6298,7 +5982,7 @@
       </p:sp>
       <p:sp>
         <p:nvSpPr>
-          <p:cNvPr id="29" name="Rectangle 28"/>
+          <p:cNvPr id="25" name="Rectangle 24"/>
           <p:cNvSpPr/>
           <p:nvPr/>
         </p:nvSpPr>
@@ -6343,7 +6027,7 @@
       </p:sp>
       <p:sp>
         <p:nvSpPr>
-          <p:cNvPr id="30" name="Rectangle 29"/>
+          <p:cNvPr id="26" name="Rectangle 25"/>
           <p:cNvSpPr/>
           <p:nvPr/>
         </p:nvSpPr>
@@ -6386,7 +6070,7 @@
       </p:sp>
       <p:sp>
         <p:nvSpPr>
-          <p:cNvPr id="31" name="Oval 30"/>
+          <p:cNvPr id="27" name="Oval 26"/>
           <p:cNvSpPr/>
           <p:nvPr/>
         </p:nvSpPr>
@@ -6429,7 +6113,7 @@
       </p:sp>
       <p:sp>
         <p:nvSpPr>
-          <p:cNvPr id="32" name="Oval 31"/>
+          <p:cNvPr id="28" name="Oval 27"/>
           <p:cNvSpPr/>
           <p:nvPr/>
         </p:nvSpPr>
@@ -6472,7 +6156,7 @@
       </p:sp>
       <p:sp>
         <p:nvSpPr>
-          <p:cNvPr id="33" name="TextBox 32"/>
+          <p:cNvPr id="29" name="TextBox 28"/>
           <p:cNvSpPr txBox="1"/>
           <p:nvPr/>
         </p:nvSpPr>
@@ -6510,7 +6194,7 @@
       </p:sp>
       <p:sp>
         <p:nvSpPr>
-          <p:cNvPr id="34" name="Oval 33"/>
+          <p:cNvPr id="30" name="Oval 29"/>
           <p:cNvSpPr/>
           <p:nvPr/>
         </p:nvSpPr>
@@ -6555,7 +6239,7 @@
       </p:sp>
       <p:sp>
         <p:nvSpPr>
-          <p:cNvPr id="35" name="TextBox 34"/>
+          <p:cNvPr id="31" name="TextBox 30"/>
           <p:cNvSpPr txBox="1"/>
           <p:nvPr/>
         </p:nvSpPr>
@@ -6589,7 +6273,7 @@
       </p:sp>
       <p:sp>
         <p:nvSpPr>
-          <p:cNvPr id="36" name="TextBox 35"/>
+          <p:cNvPr id="32" name="TextBox 31"/>
           <p:cNvSpPr txBox="1"/>
           <p:nvPr/>
         </p:nvSpPr>
@@ -6623,7 +6307,7 @@
       </p:sp>
       <p:sp>
         <p:nvSpPr>
-          <p:cNvPr id="37" name="Rectangle 36"/>
+          <p:cNvPr id="33" name="Rectangle 32"/>
           <p:cNvSpPr/>
           <p:nvPr/>
         </p:nvSpPr>
@@ -6666,7 +6350,7 @@
       </p:sp>
       <p:sp>
         <p:nvSpPr>
-          <p:cNvPr id="38" name="TextBox 37"/>
+          <p:cNvPr id="34" name="TextBox 33"/>
           <p:cNvSpPr txBox="1"/>
           <p:nvPr/>
         </p:nvSpPr>
@@ -6785,7 +6469,7 @@
                                 <p:cBhvr>
                                   <p:cTn id="6" dur="450" fill="hold"/>
                                   <p:tgtEl>
-                                    <p:spTgt spid="19"/>
+                                    <p:spTgt spid="15"/>
                                   </p:tgtEl>
                                 </p:cBhvr>
                               </p:animEffect>
@@ -6802,7 +6486,7 @@
                                 <p:cBhvr>
                                   <p:cTn id="8" dur="450" fill="hold"/>
                                   <p:tgtEl>
-                                    <p:spTgt spid="29"/>
+                                    <p:spTgt spid="25"/>
                                   </p:tgtEl>
                                 </p:cBhvr>
                               </p:animEffect>
@@ -6954,165 +6638,7 @@
       </p:sp>
       <p:sp>
         <p:nvSpPr>
-          <p:cNvPr id="5" name="Oval 4"/>
-          <p:cNvSpPr/>
-          <p:nvPr/>
-        </p:nvSpPr>
-        <p:spPr>
-          <a:xfrm>
-            <a:off x="10618927" y="182880"/>
-            <a:ext cx="1188720" cy="1188720"/>
-          </a:xfrm>
-          <a:prstGeom prst="ellipse">
-            <a:avLst/>
-          </a:prstGeom>
-          <a:solidFill>
-            <a:srgbClr val="2FDFE5"/>
-          </a:solidFill>
-          <a:ln>
-            <a:noFill/>
-          </a:ln>
-        </p:spPr>
-        <p:style>
-          <a:lnRef idx="1">
-            <a:schemeClr val="accent1"/>
-          </a:lnRef>
-          <a:fillRef idx="3">
-            <a:schemeClr val="accent1"/>
-          </a:fillRef>
-          <a:effectRef idx="2">
-            <a:schemeClr val="accent1"/>
-          </a:effectRef>
-          <a:fontRef idx="minor">
-            <a:schemeClr val="lt1"/>
-          </a:fontRef>
-        </p:style>
-        <p:txBody>
-          <a:bodyPr rtlCol="0" anchor="ctr"/>
-          <a:lstStyle/>
-          <a:p>
-            <a:pPr algn="ctr"/>
-          </a:p>
-        </p:txBody>
-      </p:sp>
-      <p:sp>
-        <p:nvSpPr>
-          <p:cNvPr id="6" name="Oval 5"/>
-          <p:cNvSpPr/>
-          <p:nvPr/>
-        </p:nvSpPr>
-        <p:spPr>
-          <a:xfrm>
-            <a:off x="10826953" y="390906"/>
-            <a:ext cx="772668" cy="772668"/>
-          </a:xfrm>
-          <a:prstGeom prst="ellipse">
-            <a:avLst/>
-          </a:prstGeom>
-          <a:solidFill>
-            <a:srgbClr val="0A1638"/>
-          </a:solidFill>
-          <a:ln>
-            <a:noFill/>
-          </a:ln>
-        </p:spPr>
-        <p:style>
-          <a:lnRef idx="1">
-            <a:schemeClr val="accent1"/>
-          </a:lnRef>
-          <a:fillRef idx="3">
-            <a:schemeClr val="accent1"/>
-          </a:fillRef>
-          <a:effectRef idx="2">
-            <a:schemeClr val="accent1"/>
-          </a:effectRef>
-          <a:fontRef idx="minor">
-            <a:schemeClr val="lt1"/>
-          </a:fontRef>
-        </p:style>
-        <p:txBody>
-          <a:bodyPr rtlCol="0" anchor="ctr"/>
-          <a:lstStyle/>
-          <a:p>
-            <a:pPr algn="ctr"/>
-          </a:p>
-        </p:txBody>
-      </p:sp>
-      <p:sp>
-        <p:nvSpPr>
-          <p:cNvPr id="7" name="TextBox 6"/>
-          <p:cNvSpPr txBox="1"/>
-          <p:nvPr/>
-        </p:nvSpPr>
-        <p:spPr>
-          <a:xfrm>
-            <a:off x="10618927" y="182880"/>
-            <a:ext cx="1188720" cy="1188720"/>
-          </a:xfrm>
-          <a:prstGeom prst="rect">
-            <a:avLst/>
-          </a:prstGeom>
-          <a:noFill/>
-        </p:spPr>
-        <p:txBody lIns="0" tIns="0" rIns="0" bIns="0">
-          <a:bodyPr wrap="none">
-            <a:spAutoFit/>
-          </a:bodyPr>
-          <a:lstStyle/>
-          <a:p>
-            <a:pPr algn="ctr">
-              <a:spcBef>
-                <a:spcPts val="2300"/>
-              </a:spcBef>
-            </a:pPr>
-            <a:r>
-              <a:rPr sz="2200" b="1">
-                <a:solidFill>
-                  <a:srgbClr val="2FDFE5"/>
-                </a:solidFill>
-              </a:rPr>
-              <a:t>3</a:t>
-            </a:r>
-          </a:p>
-        </p:txBody>
-      </p:sp>
-      <p:sp>
-        <p:nvSpPr>
-          <p:cNvPr id="8" name="TextBox 7"/>
-          <p:cNvSpPr txBox="1"/>
-          <p:nvPr/>
-        </p:nvSpPr>
-        <p:spPr>
-          <a:xfrm>
-            <a:off x="10618927" y="777240"/>
-            <a:ext cx="1188720" cy="594360"/>
-          </a:xfrm>
-          <a:prstGeom prst="rect">
-            <a:avLst/>
-          </a:prstGeom>
-          <a:noFill/>
-        </p:spPr>
-        <p:txBody lIns="0" tIns="0" rIns="0" bIns="0">
-          <a:bodyPr wrap="none">
-            <a:spAutoFit/>
-          </a:bodyPr>
-          <a:lstStyle/>
-          <a:p>
-            <a:pPr algn="ctr"/>
-            <a:r>
-              <a:rPr sz="950">
-                <a:solidFill>
-                  <a:srgbClr val="FFFFFF"/>
-                </a:solidFill>
-              </a:rPr>
-              <a:t>JUDICIAL</a:t>
-            </a:r>
-          </a:p>
-        </p:txBody>
-      </p:sp>
-      <p:sp>
-        <p:nvSpPr>
-          <p:cNvPr id="9" name="Rectangle 8"/>
+          <p:cNvPr id="5" name="Rectangle 4"/>
           <p:cNvSpPr/>
           <p:nvPr/>
         </p:nvSpPr>
@@ -7163,7 +6689,7 @@
       </p:sp>
       <p:sp>
         <p:nvSpPr>
-          <p:cNvPr id="10" name="TextBox 9"/>
+          <p:cNvPr id="6" name="TextBox 5"/>
           <p:cNvSpPr txBox="1"/>
           <p:nvPr/>
         </p:nvSpPr>
@@ -7205,7 +6731,7 @@
       </p:sp>
       <p:sp>
         <p:nvSpPr>
-          <p:cNvPr id="11" name="Rectangle 10"/>
+          <p:cNvPr id="7" name="Rectangle 6"/>
           <p:cNvSpPr/>
           <p:nvPr/>
         </p:nvSpPr>
@@ -7248,7 +6774,7 @@
       </p:sp>
       <p:sp>
         <p:nvSpPr>
-          <p:cNvPr id="12" name="TextBox 11"/>
+          <p:cNvPr id="8" name="TextBox 7"/>
           <p:cNvSpPr txBox="1"/>
           <p:nvPr/>
         </p:nvSpPr>
@@ -7282,7 +6808,7 @@
       </p:sp>
       <p:pic>
         <p:nvPicPr>
-          <p:cNvPr id="13" name="Picture 12" descr="logo_horiz.png"/>
+          <p:cNvPr id="9" name="Picture 8" descr="logo_horiz.png"/>
           <p:cNvPicPr>
             <a:picLocks noChangeAspect="1"/>
           </p:cNvPicPr>
@@ -7306,7 +6832,7 @@
       </p:pic>
       <p:sp>
         <p:nvSpPr>
-          <p:cNvPr id="14" name="Oval 13"/>
+          <p:cNvPr id="10" name="Oval 9"/>
           <p:cNvSpPr/>
           <p:nvPr/>
         </p:nvSpPr>
@@ -7349,7 +6875,7 @@
       </p:sp>
       <p:sp>
         <p:nvSpPr>
-          <p:cNvPr id="15" name="Oval 14"/>
+          <p:cNvPr id="11" name="Oval 10"/>
           <p:cNvSpPr/>
           <p:nvPr/>
         </p:nvSpPr>
@@ -7392,7 +6918,7 @@
       </p:sp>
       <p:sp>
         <p:nvSpPr>
-          <p:cNvPr id="16" name="Oval 15"/>
+          <p:cNvPr id="12" name="Oval 11"/>
           <p:cNvSpPr/>
           <p:nvPr/>
         </p:nvSpPr>
@@ -7435,7 +6961,7 @@
       </p:sp>
       <p:sp>
         <p:nvSpPr>
-          <p:cNvPr id="17" name="Oval 16"/>
+          <p:cNvPr id="13" name="Oval 12"/>
           <p:cNvSpPr/>
           <p:nvPr/>
         </p:nvSpPr>
@@ -7478,7 +7004,7 @@
       </p:sp>
       <p:sp>
         <p:nvSpPr>
-          <p:cNvPr id="18" name="Oval 17"/>
+          <p:cNvPr id="14" name="Oval 13"/>
           <p:cNvSpPr/>
           <p:nvPr/>
         </p:nvSpPr>
@@ -7521,7 +7047,7 @@
       </p:sp>
       <p:sp>
         <p:nvSpPr>
-          <p:cNvPr id="19" name="Rectangle 18"/>
+          <p:cNvPr id="15" name="Rectangle 14"/>
           <p:cNvSpPr/>
           <p:nvPr/>
         </p:nvSpPr>
@@ -7566,7 +7092,7 @@
       </p:sp>
       <p:sp>
         <p:nvSpPr>
-          <p:cNvPr id="20" name="Rectangle 19"/>
+          <p:cNvPr id="16" name="Rectangle 15"/>
           <p:cNvSpPr/>
           <p:nvPr/>
         </p:nvSpPr>
@@ -7609,7 +7135,7 @@
       </p:sp>
       <p:sp>
         <p:nvSpPr>
-          <p:cNvPr id="21" name="Oval 20"/>
+          <p:cNvPr id="17" name="Oval 16"/>
           <p:cNvSpPr/>
           <p:nvPr/>
         </p:nvSpPr>
@@ -7652,7 +7178,7 @@
       </p:sp>
       <p:sp>
         <p:nvSpPr>
-          <p:cNvPr id="22" name="Oval 21"/>
+          <p:cNvPr id="18" name="Oval 17"/>
           <p:cNvSpPr/>
           <p:nvPr/>
         </p:nvSpPr>
@@ -7695,7 +7221,7 @@
       </p:sp>
       <p:sp>
         <p:nvSpPr>
-          <p:cNvPr id="23" name="TextBox 22"/>
+          <p:cNvPr id="19" name="TextBox 18"/>
           <p:cNvSpPr txBox="1"/>
           <p:nvPr/>
         </p:nvSpPr>
@@ -7733,7 +7259,7 @@
       </p:sp>
       <p:sp>
         <p:nvSpPr>
-          <p:cNvPr id="24" name="Oval 23"/>
+          <p:cNvPr id="20" name="Oval 19"/>
           <p:cNvSpPr/>
           <p:nvPr/>
         </p:nvSpPr>
@@ -7778,7 +7304,7 @@
       </p:sp>
       <p:sp>
         <p:nvSpPr>
-          <p:cNvPr id="25" name="TextBox 24"/>
+          <p:cNvPr id="21" name="TextBox 20"/>
           <p:cNvSpPr txBox="1"/>
           <p:nvPr/>
         </p:nvSpPr>
@@ -7812,7 +7338,7 @@
       </p:sp>
       <p:sp>
         <p:nvSpPr>
-          <p:cNvPr id="26" name="TextBox 25"/>
+          <p:cNvPr id="22" name="TextBox 21"/>
           <p:cNvSpPr txBox="1"/>
           <p:nvPr/>
         </p:nvSpPr>
@@ -7846,7 +7372,7 @@
       </p:sp>
       <p:sp>
         <p:nvSpPr>
-          <p:cNvPr id="27" name="Rectangle 26"/>
+          <p:cNvPr id="23" name="Rectangle 22"/>
           <p:cNvSpPr/>
           <p:nvPr/>
         </p:nvSpPr>
@@ -7889,7 +7415,7 @@
       </p:sp>
       <p:sp>
         <p:nvSpPr>
-          <p:cNvPr id="28" name="TextBox 27"/>
+          <p:cNvPr id="24" name="TextBox 23"/>
           <p:cNvSpPr txBox="1"/>
           <p:nvPr/>
         </p:nvSpPr>
@@ -7981,7 +7507,7 @@
       </p:sp>
       <p:sp>
         <p:nvSpPr>
-          <p:cNvPr id="29" name="Rectangle 28"/>
+          <p:cNvPr id="25" name="Rectangle 24"/>
           <p:cNvSpPr/>
           <p:nvPr/>
         </p:nvSpPr>
@@ -8026,7 +7552,7 @@
       </p:sp>
       <p:sp>
         <p:nvSpPr>
-          <p:cNvPr id="30" name="Rectangle 29"/>
+          <p:cNvPr id="26" name="Rectangle 25"/>
           <p:cNvSpPr/>
           <p:nvPr/>
         </p:nvSpPr>
@@ -8069,7 +7595,7 @@
       </p:sp>
       <p:sp>
         <p:nvSpPr>
-          <p:cNvPr id="31" name="Oval 30"/>
+          <p:cNvPr id="27" name="Oval 26"/>
           <p:cNvSpPr/>
           <p:nvPr/>
         </p:nvSpPr>
@@ -8112,7 +7638,7 @@
       </p:sp>
       <p:sp>
         <p:nvSpPr>
-          <p:cNvPr id="32" name="Oval 31"/>
+          <p:cNvPr id="28" name="Oval 27"/>
           <p:cNvSpPr/>
           <p:nvPr/>
         </p:nvSpPr>
@@ -8155,7 +7681,7 @@
       </p:sp>
       <p:sp>
         <p:nvSpPr>
-          <p:cNvPr id="33" name="TextBox 32"/>
+          <p:cNvPr id="29" name="TextBox 28"/>
           <p:cNvSpPr txBox="1"/>
           <p:nvPr/>
         </p:nvSpPr>
@@ -8193,7 +7719,7 @@
       </p:sp>
       <p:sp>
         <p:nvSpPr>
-          <p:cNvPr id="34" name="Oval 33"/>
+          <p:cNvPr id="30" name="Oval 29"/>
           <p:cNvSpPr/>
           <p:nvPr/>
         </p:nvSpPr>
@@ -8238,7 +7764,7 @@
       </p:sp>
       <p:sp>
         <p:nvSpPr>
-          <p:cNvPr id="35" name="TextBox 34"/>
+          <p:cNvPr id="31" name="TextBox 30"/>
           <p:cNvSpPr txBox="1"/>
           <p:nvPr/>
         </p:nvSpPr>
@@ -8272,7 +7798,7 @@
       </p:sp>
       <p:sp>
         <p:nvSpPr>
-          <p:cNvPr id="36" name="TextBox 35"/>
+          <p:cNvPr id="32" name="TextBox 31"/>
           <p:cNvSpPr txBox="1"/>
           <p:nvPr/>
         </p:nvSpPr>
@@ -8306,7 +7832,7 @@
       </p:sp>
       <p:sp>
         <p:nvSpPr>
-          <p:cNvPr id="37" name="Rectangle 36"/>
+          <p:cNvPr id="33" name="Rectangle 32"/>
           <p:cNvSpPr/>
           <p:nvPr/>
         </p:nvSpPr>
@@ -8349,7 +7875,7 @@
       </p:sp>
       <p:sp>
         <p:nvSpPr>
-          <p:cNvPr id="38" name="TextBox 37"/>
+          <p:cNvPr id="34" name="TextBox 33"/>
           <p:cNvSpPr txBox="1"/>
           <p:nvPr/>
         </p:nvSpPr>
@@ -8468,7 +7994,7 @@
                                 <p:cBhvr>
                                   <p:cTn id="6" dur="450" fill="hold"/>
                                   <p:tgtEl>
-                                    <p:spTgt spid="19"/>
+                                    <p:spTgt spid="15"/>
                                   </p:tgtEl>
                                 </p:cBhvr>
                               </p:animEffect>
@@ -8485,7 +8011,7 @@
                                 <p:cBhvr>
                                   <p:cTn id="8" dur="450" fill="hold"/>
                                   <p:tgtEl>
-                                    <p:spTgt spid="29"/>
+                                    <p:spTgt spid="25"/>
                                   </p:tgtEl>
                                 </p:cBhvr>
                               </p:animEffect>
@@ -8637,165 +8163,7 @@
       </p:sp>
       <p:sp>
         <p:nvSpPr>
-          <p:cNvPr id="5" name="Oval 4"/>
-          <p:cNvSpPr/>
-          <p:nvPr/>
-        </p:nvSpPr>
-        <p:spPr>
-          <a:xfrm>
-            <a:off x="10618927" y="182880"/>
-            <a:ext cx="1188720" cy="1188720"/>
-          </a:xfrm>
-          <a:prstGeom prst="ellipse">
-            <a:avLst/>
-          </a:prstGeom>
-          <a:solidFill>
-            <a:srgbClr val="2FDFE5"/>
-          </a:solidFill>
-          <a:ln>
-            <a:noFill/>
-          </a:ln>
-        </p:spPr>
-        <p:style>
-          <a:lnRef idx="1">
-            <a:schemeClr val="accent1"/>
-          </a:lnRef>
-          <a:fillRef idx="3">
-            <a:schemeClr val="accent1"/>
-          </a:fillRef>
-          <a:effectRef idx="2">
-            <a:schemeClr val="accent1"/>
-          </a:effectRef>
-          <a:fontRef idx="minor">
-            <a:schemeClr val="lt1"/>
-          </a:fontRef>
-        </p:style>
-        <p:txBody>
-          <a:bodyPr rtlCol="0" anchor="ctr"/>
-          <a:lstStyle/>
-          <a:p>
-            <a:pPr algn="ctr"/>
-          </a:p>
-        </p:txBody>
-      </p:sp>
-      <p:sp>
-        <p:nvSpPr>
-          <p:cNvPr id="6" name="Oval 5"/>
-          <p:cNvSpPr/>
-          <p:nvPr/>
-        </p:nvSpPr>
-        <p:spPr>
-          <a:xfrm>
-            <a:off x="10826953" y="390906"/>
-            <a:ext cx="772668" cy="772668"/>
-          </a:xfrm>
-          <a:prstGeom prst="ellipse">
-            <a:avLst/>
-          </a:prstGeom>
-          <a:solidFill>
-            <a:srgbClr val="0A1638"/>
-          </a:solidFill>
-          <a:ln>
-            <a:noFill/>
-          </a:ln>
-        </p:spPr>
-        <p:style>
-          <a:lnRef idx="1">
-            <a:schemeClr val="accent1"/>
-          </a:lnRef>
-          <a:fillRef idx="3">
-            <a:schemeClr val="accent1"/>
-          </a:fillRef>
-          <a:effectRef idx="2">
-            <a:schemeClr val="accent1"/>
-          </a:effectRef>
-          <a:fontRef idx="minor">
-            <a:schemeClr val="lt1"/>
-          </a:fontRef>
-        </p:style>
-        <p:txBody>
-          <a:bodyPr rtlCol="0" anchor="ctr"/>
-          <a:lstStyle/>
-          <a:p>
-            <a:pPr algn="ctr"/>
-          </a:p>
-        </p:txBody>
-      </p:sp>
-      <p:sp>
-        <p:nvSpPr>
-          <p:cNvPr id="7" name="TextBox 6"/>
-          <p:cNvSpPr txBox="1"/>
-          <p:nvPr/>
-        </p:nvSpPr>
-        <p:spPr>
-          <a:xfrm>
-            <a:off x="10618927" y="182880"/>
-            <a:ext cx="1188720" cy="1188720"/>
-          </a:xfrm>
-          <a:prstGeom prst="rect">
-            <a:avLst/>
-          </a:prstGeom>
-          <a:noFill/>
-        </p:spPr>
-        <p:txBody lIns="0" tIns="0" rIns="0" bIns="0">
-          <a:bodyPr wrap="none">
-            <a:spAutoFit/>
-          </a:bodyPr>
-          <a:lstStyle/>
-          <a:p>
-            <a:pPr algn="ctr">
-              <a:spcBef>
-                <a:spcPts val="2300"/>
-              </a:spcBef>
-            </a:pPr>
-            <a:r>
-              <a:rPr sz="2200" b="1">
-                <a:solidFill>
-                  <a:srgbClr val="2FDFE5"/>
-                </a:solidFill>
-              </a:rPr>
-              <a:t>4</a:t>
-            </a:r>
-          </a:p>
-        </p:txBody>
-      </p:sp>
-      <p:sp>
-        <p:nvSpPr>
-          <p:cNvPr id="8" name="TextBox 7"/>
-          <p:cNvSpPr txBox="1"/>
-          <p:nvPr/>
-        </p:nvSpPr>
-        <p:spPr>
-          <a:xfrm>
-            <a:off x="10618927" y="777240"/>
-            <a:ext cx="1188720" cy="594360"/>
-          </a:xfrm>
-          <a:prstGeom prst="rect">
-            <a:avLst/>
-          </a:prstGeom>
-          <a:noFill/>
-        </p:spPr>
-        <p:txBody lIns="0" tIns="0" rIns="0" bIns="0">
-          <a:bodyPr wrap="none">
-            <a:spAutoFit/>
-          </a:bodyPr>
-          <a:lstStyle/>
-          <a:p>
-            <a:pPr algn="ctr"/>
-            <a:r>
-              <a:rPr sz="950">
-                <a:solidFill>
-                  <a:srgbClr val="FFFFFF"/>
-                </a:solidFill>
-              </a:rPr>
-              <a:t>REPORTING</a:t>
-            </a:r>
-          </a:p>
-        </p:txBody>
-      </p:sp>
-      <p:sp>
-        <p:nvSpPr>
-          <p:cNvPr id="9" name="Rectangle 8"/>
+          <p:cNvPr id="5" name="Rectangle 4"/>
           <p:cNvSpPr/>
           <p:nvPr/>
         </p:nvSpPr>
@@ -8846,7 +8214,7 @@
       </p:sp>
       <p:sp>
         <p:nvSpPr>
-          <p:cNvPr id="10" name="TextBox 9"/>
+          <p:cNvPr id="6" name="TextBox 5"/>
           <p:cNvSpPr txBox="1"/>
           <p:nvPr/>
         </p:nvSpPr>
@@ -8888,7 +8256,7 @@
       </p:sp>
       <p:sp>
         <p:nvSpPr>
-          <p:cNvPr id="11" name="Rectangle 10"/>
+          <p:cNvPr id="7" name="Rectangle 6"/>
           <p:cNvSpPr/>
           <p:nvPr/>
         </p:nvSpPr>
@@ -8931,7 +8299,7 @@
       </p:sp>
       <p:sp>
         <p:nvSpPr>
-          <p:cNvPr id="12" name="TextBox 11"/>
+          <p:cNvPr id="8" name="TextBox 7"/>
           <p:cNvSpPr txBox="1"/>
           <p:nvPr/>
         </p:nvSpPr>
@@ -8965,7 +8333,7 @@
       </p:sp>
       <p:pic>
         <p:nvPicPr>
-          <p:cNvPr id="13" name="Picture 12" descr="logo_horiz.png"/>
+          <p:cNvPr id="9" name="Picture 8" descr="logo_horiz.png"/>
           <p:cNvPicPr>
             <a:picLocks noChangeAspect="1"/>
           </p:cNvPicPr>
@@ -8989,7 +8357,7 @@
       </p:pic>
       <p:sp>
         <p:nvSpPr>
-          <p:cNvPr id="14" name="Oval 13"/>
+          <p:cNvPr id="10" name="Oval 9"/>
           <p:cNvSpPr/>
           <p:nvPr/>
         </p:nvSpPr>
@@ -9032,7 +8400,7 @@
       </p:sp>
       <p:sp>
         <p:nvSpPr>
-          <p:cNvPr id="15" name="Oval 14"/>
+          <p:cNvPr id="11" name="Oval 10"/>
           <p:cNvSpPr/>
           <p:nvPr/>
         </p:nvSpPr>
@@ -9075,7 +8443,7 @@
       </p:sp>
       <p:sp>
         <p:nvSpPr>
-          <p:cNvPr id="16" name="Oval 15"/>
+          <p:cNvPr id="12" name="Oval 11"/>
           <p:cNvSpPr/>
           <p:nvPr/>
         </p:nvSpPr>
@@ -9118,7 +8486,7 @@
       </p:sp>
       <p:sp>
         <p:nvSpPr>
-          <p:cNvPr id="17" name="Oval 16"/>
+          <p:cNvPr id="13" name="Oval 12"/>
           <p:cNvSpPr/>
           <p:nvPr/>
         </p:nvSpPr>
@@ -9161,7 +8529,7 @@
       </p:sp>
       <p:sp>
         <p:nvSpPr>
-          <p:cNvPr id="18" name="Oval 17"/>
+          <p:cNvPr id="14" name="Oval 13"/>
           <p:cNvSpPr/>
           <p:nvPr/>
         </p:nvSpPr>
@@ -9204,7 +8572,7 @@
       </p:sp>
       <p:sp>
         <p:nvSpPr>
-          <p:cNvPr id="19" name="Rectangle 18"/>
+          <p:cNvPr id="15" name="Rectangle 14"/>
           <p:cNvSpPr/>
           <p:nvPr/>
         </p:nvSpPr>
@@ -9249,7 +8617,7 @@
       </p:sp>
       <p:sp>
         <p:nvSpPr>
-          <p:cNvPr id="20" name="Rectangle 19"/>
+          <p:cNvPr id="16" name="Rectangle 15"/>
           <p:cNvSpPr/>
           <p:nvPr/>
         </p:nvSpPr>
@@ -9292,7 +8660,7 @@
       </p:sp>
       <p:sp>
         <p:nvSpPr>
-          <p:cNvPr id="21" name="Oval 20"/>
+          <p:cNvPr id="17" name="Oval 16"/>
           <p:cNvSpPr/>
           <p:nvPr/>
         </p:nvSpPr>
@@ -9335,7 +8703,7 @@
       </p:sp>
       <p:sp>
         <p:nvSpPr>
-          <p:cNvPr id="22" name="Oval 21"/>
+          <p:cNvPr id="18" name="Oval 17"/>
           <p:cNvSpPr/>
           <p:nvPr/>
         </p:nvSpPr>
@@ -9378,7 +8746,7 @@
       </p:sp>
       <p:sp>
         <p:nvSpPr>
-          <p:cNvPr id="23" name="TextBox 22"/>
+          <p:cNvPr id="19" name="TextBox 18"/>
           <p:cNvSpPr txBox="1"/>
           <p:nvPr/>
         </p:nvSpPr>
@@ -9416,7 +8784,7 @@
       </p:sp>
       <p:sp>
         <p:nvSpPr>
-          <p:cNvPr id="24" name="Oval 23"/>
+          <p:cNvPr id="20" name="Oval 19"/>
           <p:cNvSpPr/>
           <p:nvPr/>
         </p:nvSpPr>
@@ -9461,7 +8829,7 @@
       </p:sp>
       <p:sp>
         <p:nvSpPr>
-          <p:cNvPr id="25" name="TextBox 24"/>
+          <p:cNvPr id="21" name="TextBox 20"/>
           <p:cNvSpPr txBox="1"/>
           <p:nvPr/>
         </p:nvSpPr>
@@ -9495,7 +8863,7 @@
       </p:sp>
       <p:sp>
         <p:nvSpPr>
-          <p:cNvPr id="26" name="TextBox 25"/>
+          <p:cNvPr id="22" name="TextBox 21"/>
           <p:cNvSpPr txBox="1"/>
           <p:nvPr/>
         </p:nvSpPr>
@@ -9529,7 +8897,7 @@
       </p:sp>
       <p:sp>
         <p:nvSpPr>
-          <p:cNvPr id="27" name="Rectangle 26"/>
+          <p:cNvPr id="23" name="Rectangle 22"/>
           <p:cNvSpPr/>
           <p:nvPr/>
         </p:nvSpPr>
@@ -9572,7 +8940,7 @@
       </p:sp>
       <p:sp>
         <p:nvSpPr>
-          <p:cNvPr id="28" name="TextBox 27"/>
+          <p:cNvPr id="24" name="TextBox 23"/>
           <p:cNvSpPr txBox="1"/>
           <p:nvPr/>
         </p:nvSpPr>
@@ -9664,7 +9032,7 @@
       </p:sp>
       <p:sp>
         <p:nvSpPr>
-          <p:cNvPr id="29" name="Rectangle 28"/>
+          <p:cNvPr id="25" name="Rectangle 24"/>
           <p:cNvSpPr/>
           <p:nvPr/>
         </p:nvSpPr>
@@ -9709,7 +9077,7 @@
       </p:sp>
       <p:sp>
         <p:nvSpPr>
-          <p:cNvPr id="30" name="Rectangle 29"/>
+          <p:cNvPr id="26" name="Rectangle 25"/>
           <p:cNvSpPr/>
           <p:nvPr/>
         </p:nvSpPr>
@@ -9752,7 +9120,7 @@
       </p:sp>
       <p:sp>
         <p:nvSpPr>
-          <p:cNvPr id="31" name="Oval 30"/>
+          <p:cNvPr id="27" name="Oval 26"/>
           <p:cNvSpPr/>
           <p:nvPr/>
         </p:nvSpPr>
@@ -9795,7 +9163,7 @@
       </p:sp>
       <p:sp>
         <p:nvSpPr>
-          <p:cNvPr id="32" name="Oval 31"/>
+          <p:cNvPr id="28" name="Oval 27"/>
           <p:cNvSpPr/>
           <p:nvPr/>
         </p:nvSpPr>
@@ -9838,7 +9206,7 @@
       </p:sp>
       <p:sp>
         <p:nvSpPr>
-          <p:cNvPr id="33" name="TextBox 32"/>
+          <p:cNvPr id="29" name="TextBox 28"/>
           <p:cNvSpPr txBox="1"/>
           <p:nvPr/>
         </p:nvSpPr>
@@ -9876,7 +9244,7 @@
       </p:sp>
       <p:sp>
         <p:nvSpPr>
-          <p:cNvPr id="34" name="Oval 33"/>
+          <p:cNvPr id="30" name="Oval 29"/>
           <p:cNvSpPr/>
           <p:nvPr/>
         </p:nvSpPr>
@@ -9921,7 +9289,7 @@
       </p:sp>
       <p:sp>
         <p:nvSpPr>
-          <p:cNvPr id="35" name="TextBox 34"/>
+          <p:cNvPr id="31" name="TextBox 30"/>
           <p:cNvSpPr txBox="1"/>
           <p:nvPr/>
         </p:nvSpPr>
@@ -9955,7 +9323,7 @@
       </p:sp>
       <p:sp>
         <p:nvSpPr>
-          <p:cNvPr id="36" name="TextBox 35"/>
+          <p:cNvPr id="32" name="TextBox 31"/>
           <p:cNvSpPr txBox="1"/>
           <p:nvPr/>
         </p:nvSpPr>
@@ -9989,7 +9357,7 @@
       </p:sp>
       <p:sp>
         <p:nvSpPr>
-          <p:cNvPr id="37" name="Rectangle 36"/>
+          <p:cNvPr id="33" name="Rectangle 32"/>
           <p:cNvSpPr/>
           <p:nvPr/>
         </p:nvSpPr>
@@ -10032,7 +9400,7 @@
       </p:sp>
       <p:sp>
         <p:nvSpPr>
-          <p:cNvPr id="38" name="TextBox 37"/>
+          <p:cNvPr id="34" name="TextBox 33"/>
           <p:cNvSpPr txBox="1"/>
           <p:nvPr/>
         </p:nvSpPr>
@@ -10151,7 +9519,7 @@
                                 <p:cBhvr>
                                   <p:cTn id="6" dur="450" fill="hold"/>
                                   <p:tgtEl>
-                                    <p:spTgt spid="19"/>
+                                    <p:spTgt spid="15"/>
                                   </p:tgtEl>
                                 </p:cBhvr>
                               </p:animEffect>
@@ -10168,7 +9536,7 @@
                                 <p:cBhvr>
                                   <p:cTn id="8" dur="450" fill="hold"/>
                                   <p:tgtEl>
-                                    <p:spTgt spid="29"/>
+                                    <p:spTgt spid="25"/>
                                   </p:tgtEl>
                                 </p:cBhvr>
                               </p:animEffect>
@@ -10320,165 +9688,7 @@
       </p:sp>
       <p:sp>
         <p:nvSpPr>
-          <p:cNvPr id="5" name="Oval 4"/>
-          <p:cNvSpPr/>
-          <p:nvPr/>
-        </p:nvSpPr>
-        <p:spPr>
-          <a:xfrm>
-            <a:off x="10618927" y="182880"/>
-            <a:ext cx="1188720" cy="1188720"/>
-          </a:xfrm>
-          <a:prstGeom prst="ellipse">
-            <a:avLst/>
-          </a:prstGeom>
-          <a:solidFill>
-            <a:srgbClr val="2FDFE5"/>
-          </a:solidFill>
-          <a:ln>
-            <a:noFill/>
-          </a:ln>
-        </p:spPr>
-        <p:style>
-          <a:lnRef idx="1">
-            <a:schemeClr val="accent1"/>
-          </a:lnRef>
-          <a:fillRef idx="3">
-            <a:schemeClr val="accent1"/>
-          </a:fillRef>
-          <a:effectRef idx="2">
-            <a:schemeClr val="accent1"/>
-          </a:effectRef>
-          <a:fontRef idx="minor">
-            <a:schemeClr val="lt1"/>
-          </a:fontRef>
-        </p:style>
-        <p:txBody>
-          <a:bodyPr rtlCol="0" anchor="ctr"/>
-          <a:lstStyle/>
-          <a:p>
-            <a:pPr algn="ctr"/>
-          </a:p>
-        </p:txBody>
-      </p:sp>
-      <p:sp>
-        <p:nvSpPr>
-          <p:cNvPr id="6" name="Oval 5"/>
-          <p:cNvSpPr/>
-          <p:nvPr/>
-        </p:nvSpPr>
-        <p:spPr>
-          <a:xfrm>
-            <a:off x="10826953" y="390906"/>
-            <a:ext cx="772668" cy="772668"/>
-          </a:xfrm>
-          <a:prstGeom prst="ellipse">
-            <a:avLst/>
-          </a:prstGeom>
-          <a:solidFill>
-            <a:srgbClr val="0A1638"/>
-          </a:solidFill>
-          <a:ln>
-            <a:noFill/>
-          </a:ln>
-        </p:spPr>
-        <p:style>
-          <a:lnRef idx="1">
-            <a:schemeClr val="accent1"/>
-          </a:lnRef>
-          <a:fillRef idx="3">
-            <a:schemeClr val="accent1"/>
-          </a:fillRef>
-          <a:effectRef idx="2">
-            <a:schemeClr val="accent1"/>
-          </a:effectRef>
-          <a:fontRef idx="minor">
-            <a:schemeClr val="lt1"/>
-          </a:fontRef>
-        </p:style>
-        <p:txBody>
-          <a:bodyPr rtlCol="0" anchor="ctr"/>
-          <a:lstStyle/>
-          <a:p>
-            <a:pPr algn="ctr"/>
-          </a:p>
-        </p:txBody>
-      </p:sp>
-      <p:sp>
-        <p:nvSpPr>
-          <p:cNvPr id="7" name="TextBox 6"/>
-          <p:cNvSpPr txBox="1"/>
-          <p:nvPr/>
-        </p:nvSpPr>
-        <p:spPr>
-          <a:xfrm>
-            <a:off x="10618927" y="182880"/>
-            <a:ext cx="1188720" cy="1188720"/>
-          </a:xfrm>
-          <a:prstGeom prst="rect">
-            <a:avLst/>
-          </a:prstGeom>
-          <a:noFill/>
-        </p:spPr>
-        <p:txBody lIns="0" tIns="0" rIns="0" bIns="0">
-          <a:bodyPr wrap="none">
-            <a:spAutoFit/>
-          </a:bodyPr>
-          <a:lstStyle/>
-          <a:p>
-            <a:pPr algn="ctr">
-              <a:spcBef>
-                <a:spcPts val="2300"/>
-              </a:spcBef>
-            </a:pPr>
-            <a:r>
-              <a:rPr sz="2200" b="1">
-                <a:solidFill>
-                  <a:srgbClr val="2FDFE5"/>
-                </a:solidFill>
-              </a:rPr>
-              <a:t>5</a:t>
-            </a:r>
-          </a:p>
-        </p:txBody>
-      </p:sp>
-      <p:sp>
-        <p:nvSpPr>
-          <p:cNvPr id="8" name="TextBox 7"/>
-          <p:cNvSpPr txBox="1"/>
-          <p:nvPr/>
-        </p:nvSpPr>
-        <p:spPr>
-          <a:xfrm>
-            <a:off x="10618927" y="777240"/>
-            <a:ext cx="1188720" cy="594360"/>
-          </a:xfrm>
-          <a:prstGeom prst="rect">
-            <a:avLst/>
-          </a:prstGeom>
-          <a:noFill/>
-        </p:spPr>
-        <p:txBody lIns="0" tIns="0" rIns="0" bIns="0">
-          <a:bodyPr wrap="none">
-            <a:spAutoFit/>
-          </a:bodyPr>
-          <a:lstStyle/>
-          <a:p>
-            <a:pPr algn="ctr"/>
-            <a:r>
-              <a:rPr sz="950">
-                <a:solidFill>
-                  <a:srgbClr val="FFFFFF"/>
-                </a:solidFill>
-              </a:rPr>
-              <a:t>ADICIONALES</a:t>
-            </a:r>
-          </a:p>
-        </p:txBody>
-      </p:sp>
-      <p:sp>
-        <p:nvSpPr>
-          <p:cNvPr id="9" name="Rectangle 8"/>
+          <p:cNvPr id="5" name="Rectangle 4"/>
           <p:cNvSpPr/>
           <p:nvPr/>
         </p:nvSpPr>
@@ -10529,7 +9739,7 @@
       </p:sp>
       <p:sp>
         <p:nvSpPr>
-          <p:cNvPr id="10" name="TextBox 9"/>
+          <p:cNvPr id="6" name="TextBox 5"/>
           <p:cNvSpPr txBox="1"/>
           <p:nvPr/>
         </p:nvSpPr>
@@ -10571,7 +9781,7 @@
       </p:sp>
       <p:sp>
         <p:nvSpPr>
-          <p:cNvPr id="11" name="Rectangle 10"/>
+          <p:cNvPr id="7" name="Rectangle 6"/>
           <p:cNvSpPr/>
           <p:nvPr/>
         </p:nvSpPr>
@@ -10614,7 +9824,7 @@
       </p:sp>
       <p:pic>
         <p:nvPicPr>
-          <p:cNvPr id="12" name="Picture 11" descr="logo_horiz.png"/>
+          <p:cNvPr id="8" name="Picture 7" descr="logo_horiz.png"/>
           <p:cNvPicPr>
             <a:picLocks noChangeAspect="1"/>
           </p:cNvPicPr>
@@ -10638,7 +9848,7 @@
       </p:pic>
       <p:sp>
         <p:nvSpPr>
-          <p:cNvPr id="13" name="Oval 12"/>
+          <p:cNvPr id="9" name="Oval 8"/>
           <p:cNvSpPr/>
           <p:nvPr/>
         </p:nvSpPr>
@@ -10681,7 +9891,7 @@
       </p:sp>
       <p:sp>
         <p:nvSpPr>
-          <p:cNvPr id="14" name="Oval 13"/>
+          <p:cNvPr id="10" name="Oval 9"/>
           <p:cNvSpPr/>
           <p:nvPr/>
         </p:nvSpPr>
@@ -10724,7 +9934,7 @@
       </p:sp>
       <p:sp>
         <p:nvSpPr>
-          <p:cNvPr id="15" name="Oval 14"/>
+          <p:cNvPr id="11" name="Oval 10"/>
           <p:cNvSpPr/>
           <p:nvPr/>
         </p:nvSpPr>
@@ -10767,7 +9977,7 @@
       </p:sp>
       <p:sp>
         <p:nvSpPr>
-          <p:cNvPr id="16" name="Oval 15"/>
+          <p:cNvPr id="12" name="Oval 11"/>
           <p:cNvSpPr/>
           <p:nvPr/>
         </p:nvSpPr>
@@ -10810,7 +10020,7 @@
       </p:sp>
       <p:sp>
         <p:nvSpPr>
-          <p:cNvPr id="17" name="Oval 16"/>
+          <p:cNvPr id="13" name="Oval 12"/>
           <p:cNvSpPr/>
           <p:nvPr/>
         </p:nvSpPr>
@@ -10853,7 +10063,7 @@
       </p:sp>
       <p:sp>
         <p:nvSpPr>
-          <p:cNvPr id="18" name="Rectangle 17"/>
+          <p:cNvPr id="14" name="Rectangle 13"/>
           <p:cNvSpPr/>
           <p:nvPr/>
         </p:nvSpPr>
@@ -10898,7 +10108,7 @@
       </p:sp>
       <p:sp>
         <p:nvSpPr>
-          <p:cNvPr id="19" name="Rectangle 18"/>
+          <p:cNvPr id="15" name="Rectangle 14"/>
           <p:cNvSpPr/>
           <p:nvPr/>
         </p:nvSpPr>
@@ -10941,7 +10151,7 @@
       </p:sp>
       <p:sp>
         <p:nvSpPr>
-          <p:cNvPr id="20" name="Oval 19"/>
+          <p:cNvPr id="16" name="Oval 15"/>
           <p:cNvSpPr/>
           <p:nvPr/>
         </p:nvSpPr>
@@ -10984,7 +10194,7 @@
       </p:sp>
       <p:sp>
         <p:nvSpPr>
-          <p:cNvPr id="21" name="Oval 20"/>
+          <p:cNvPr id="17" name="Oval 16"/>
           <p:cNvSpPr/>
           <p:nvPr/>
         </p:nvSpPr>
@@ -11027,7 +10237,7 @@
       </p:sp>
       <p:sp>
         <p:nvSpPr>
-          <p:cNvPr id="22" name="TextBox 21"/>
+          <p:cNvPr id="18" name="TextBox 17"/>
           <p:cNvSpPr txBox="1"/>
           <p:nvPr/>
         </p:nvSpPr>
@@ -11065,7 +10275,7 @@
       </p:sp>
       <p:sp>
         <p:nvSpPr>
-          <p:cNvPr id="23" name="TextBox 22"/>
+          <p:cNvPr id="19" name="TextBox 18"/>
           <p:cNvSpPr txBox="1"/>
           <p:nvPr/>
         </p:nvSpPr>
@@ -11099,7 +10309,7 @@
       </p:sp>
       <p:sp>
         <p:nvSpPr>
-          <p:cNvPr id="24" name="Rectangle 23"/>
+          <p:cNvPr id="20" name="Rectangle 19"/>
           <p:cNvSpPr/>
           <p:nvPr/>
         </p:nvSpPr>
@@ -11142,7 +10352,7 @@
       </p:sp>
       <p:sp>
         <p:nvSpPr>
-          <p:cNvPr id="25" name="TextBox 24"/>
+          <p:cNvPr id="21" name="TextBox 20"/>
           <p:cNvSpPr txBox="1"/>
           <p:nvPr/>
         </p:nvSpPr>
@@ -11176,7 +10386,7 @@
       </p:sp>
       <p:sp>
         <p:nvSpPr>
-          <p:cNvPr id="26" name="Rectangle 25"/>
+          <p:cNvPr id="22" name="Rectangle 21"/>
           <p:cNvSpPr/>
           <p:nvPr/>
         </p:nvSpPr>
@@ -11221,7 +10431,7 @@
       </p:sp>
       <p:sp>
         <p:nvSpPr>
-          <p:cNvPr id="27" name="Rectangle 26"/>
+          <p:cNvPr id="23" name="Rectangle 22"/>
           <p:cNvSpPr/>
           <p:nvPr/>
         </p:nvSpPr>
@@ -11264,7 +10474,7 @@
       </p:sp>
       <p:sp>
         <p:nvSpPr>
-          <p:cNvPr id="28" name="Oval 27"/>
+          <p:cNvPr id="24" name="Oval 23"/>
           <p:cNvSpPr/>
           <p:nvPr/>
         </p:nvSpPr>
@@ -11307,7 +10517,7 @@
       </p:sp>
       <p:sp>
         <p:nvSpPr>
-          <p:cNvPr id="29" name="Oval 28"/>
+          <p:cNvPr id="25" name="Oval 24"/>
           <p:cNvSpPr/>
           <p:nvPr/>
         </p:nvSpPr>
@@ -11350,7 +10560,7 @@
       </p:sp>
       <p:sp>
         <p:nvSpPr>
-          <p:cNvPr id="30" name="TextBox 29"/>
+          <p:cNvPr id="26" name="TextBox 25"/>
           <p:cNvSpPr txBox="1"/>
           <p:nvPr/>
         </p:nvSpPr>
@@ -11388,7 +10598,7 @@
       </p:sp>
       <p:sp>
         <p:nvSpPr>
-          <p:cNvPr id="31" name="TextBox 30"/>
+          <p:cNvPr id="27" name="TextBox 26"/>
           <p:cNvSpPr txBox="1"/>
           <p:nvPr/>
         </p:nvSpPr>
@@ -11422,7 +10632,7 @@
       </p:sp>
       <p:sp>
         <p:nvSpPr>
-          <p:cNvPr id="32" name="Rectangle 31"/>
+          <p:cNvPr id="28" name="Rectangle 27"/>
           <p:cNvSpPr/>
           <p:nvPr/>
         </p:nvSpPr>
@@ -11465,7 +10675,7 @@
       </p:sp>
       <p:sp>
         <p:nvSpPr>
-          <p:cNvPr id="33" name="TextBox 32"/>
+          <p:cNvPr id="29" name="TextBox 28"/>
           <p:cNvSpPr txBox="1"/>
           <p:nvPr/>
         </p:nvSpPr>
@@ -11499,7 +10709,7 @@
       </p:sp>
       <p:sp>
         <p:nvSpPr>
-          <p:cNvPr id="34" name="Rectangle 33"/>
+          <p:cNvPr id="30" name="Rectangle 29"/>
           <p:cNvSpPr/>
           <p:nvPr/>
         </p:nvSpPr>
@@ -11544,7 +10754,7 @@
       </p:sp>
       <p:sp>
         <p:nvSpPr>
-          <p:cNvPr id="35" name="Rectangle 34"/>
+          <p:cNvPr id="31" name="Rectangle 30"/>
           <p:cNvSpPr/>
           <p:nvPr/>
         </p:nvSpPr>
@@ -11587,7 +10797,7 @@
       </p:sp>
       <p:sp>
         <p:nvSpPr>
-          <p:cNvPr id="36" name="Oval 35"/>
+          <p:cNvPr id="32" name="Oval 31"/>
           <p:cNvSpPr/>
           <p:nvPr/>
         </p:nvSpPr>
@@ -11630,7 +10840,7 @@
       </p:sp>
       <p:sp>
         <p:nvSpPr>
-          <p:cNvPr id="37" name="Oval 36"/>
+          <p:cNvPr id="33" name="Oval 32"/>
           <p:cNvSpPr/>
           <p:nvPr/>
         </p:nvSpPr>
@@ -11673,7 +10883,7 @@
       </p:sp>
       <p:sp>
         <p:nvSpPr>
-          <p:cNvPr id="38" name="TextBox 37"/>
+          <p:cNvPr id="34" name="TextBox 33"/>
           <p:cNvSpPr txBox="1"/>
           <p:nvPr/>
         </p:nvSpPr>
@@ -11711,7 +10921,7 @@
       </p:sp>
       <p:sp>
         <p:nvSpPr>
-          <p:cNvPr id="39" name="TextBox 38"/>
+          <p:cNvPr id="35" name="TextBox 34"/>
           <p:cNvSpPr txBox="1"/>
           <p:nvPr/>
         </p:nvSpPr>
@@ -11745,7 +10955,7 @@
       </p:sp>
       <p:sp>
         <p:nvSpPr>
-          <p:cNvPr id="40" name="Rectangle 39"/>
+          <p:cNvPr id="36" name="Rectangle 35"/>
           <p:cNvSpPr/>
           <p:nvPr/>
         </p:nvSpPr>
@@ -11788,7 +10998,7 @@
       </p:sp>
       <p:sp>
         <p:nvSpPr>
-          <p:cNvPr id="41" name="TextBox 40"/>
+          <p:cNvPr id="37" name="TextBox 36"/>
           <p:cNvSpPr txBox="1"/>
           <p:nvPr/>
         </p:nvSpPr>
@@ -11822,7 +11032,7 @@
       </p:sp>
       <p:sp>
         <p:nvSpPr>
-          <p:cNvPr id="42" name="Rectangle 41"/>
+          <p:cNvPr id="38" name="Rectangle 37"/>
           <p:cNvSpPr/>
           <p:nvPr/>
         </p:nvSpPr>
@@ -11867,7 +11077,7 @@
       </p:sp>
       <p:sp>
         <p:nvSpPr>
-          <p:cNvPr id="43" name="Rectangle 42"/>
+          <p:cNvPr id="39" name="Rectangle 38"/>
           <p:cNvSpPr/>
           <p:nvPr/>
         </p:nvSpPr>
@@ -11910,7 +11120,7 @@
       </p:sp>
       <p:sp>
         <p:nvSpPr>
-          <p:cNvPr id="44" name="Oval 43"/>
+          <p:cNvPr id="40" name="Oval 39"/>
           <p:cNvSpPr/>
           <p:nvPr/>
         </p:nvSpPr>
@@ -11953,7 +11163,7 @@
       </p:sp>
       <p:sp>
         <p:nvSpPr>
-          <p:cNvPr id="45" name="Oval 44"/>
+          <p:cNvPr id="41" name="Oval 40"/>
           <p:cNvSpPr/>
           <p:nvPr/>
         </p:nvSpPr>
@@ -11996,7 +11206,7 @@
       </p:sp>
       <p:sp>
         <p:nvSpPr>
-          <p:cNvPr id="46" name="TextBox 45"/>
+          <p:cNvPr id="42" name="TextBox 41"/>
           <p:cNvSpPr txBox="1"/>
           <p:nvPr/>
         </p:nvSpPr>
@@ -12034,7 +11244,7 @@
       </p:sp>
       <p:sp>
         <p:nvSpPr>
-          <p:cNvPr id="47" name="TextBox 46"/>
+          <p:cNvPr id="43" name="TextBox 42"/>
           <p:cNvSpPr txBox="1"/>
           <p:nvPr/>
         </p:nvSpPr>
@@ -12068,7 +11278,7 @@
       </p:sp>
       <p:sp>
         <p:nvSpPr>
-          <p:cNvPr id="48" name="Rectangle 47"/>
+          <p:cNvPr id="44" name="Rectangle 43"/>
           <p:cNvSpPr/>
           <p:nvPr/>
         </p:nvSpPr>
@@ -12111,7 +11321,7 @@
       </p:sp>
       <p:sp>
         <p:nvSpPr>
-          <p:cNvPr id="49" name="TextBox 48"/>
+          <p:cNvPr id="45" name="TextBox 44"/>
           <p:cNvSpPr txBox="1"/>
           <p:nvPr/>
         </p:nvSpPr>
@@ -12172,7 +11382,7 @@
                                 <p:cBhvr>
                                   <p:cTn id="6" dur="450" fill="hold"/>
                                   <p:tgtEl>
-                                    <p:spTgt spid="18"/>
+                                    <p:spTgt spid="14"/>
                                   </p:tgtEl>
                                 </p:cBhvr>
                               </p:animEffect>
@@ -12189,7 +11399,7 @@
                                 <p:cBhvr>
                                   <p:cTn id="8" dur="450" fill="hold"/>
                                   <p:tgtEl>
-                                    <p:spTgt spid="26"/>
+                                    <p:spTgt spid="22"/>
                                   </p:tgtEl>
                                 </p:cBhvr>
                               </p:animEffect>
@@ -12206,7 +11416,7 @@
                                 <p:cBhvr>
                                   <p:cTn id="10" dur="450" fill="hold"/>
                                   <p:tgtEl>
-                                    <p:spTgt spid="34"/>
+                                    <p:spTgt spid="30"/>
                                   </p:tgtEl>
                                 </p:cBhvr>
                               </p:animEffect>
@@ -12223,7 +11433,7 @@
                                 <p:cBhvr>
                                   <p:cTn id="12" dur="450" fill="hold"/>
                                   <p:tgtEl>
-                                    <p:spTgt spid="42"/>
+                                    <p:spTgt spid="38"/>
                                   </p:tgtEl>
                                 </p:cBhvr>
                               </p:animEffect>

</xml_diff>

<commit_message>
Remove all bugged illustrations and fix logo z-order
- Remove card_symbol_icon() calls from content and feat slides
- Remove progress_dots() from all slides
- Remove extra badge next to icon in card loop
- Restore clean card layout: badge top-left, title right of badge, separator below
- Move foot_logo() to be called last (after cards) so it renders on top
</commit_message>
<xml_diff>
--- a/sendacredit_propuesta.pptx
+++ b/sendacredit_propuesta.pptx
@@ -3756,248 +3756,9 @@
           </a:p>
         </p:txBody>
       </p:sp>
-      <p:pic>
-        <p:nvPicPr>
-          <p:cNvPr id="9" name="Picture 8" descr="logo_horiz.png"/>
-          <p:cNvPicPr>
-            <a:picLocks noChangeAspect="1"/>
-          </p:cNvPicPr>
-          <p:nvPr/>
-        </p:nvPicPr>
-        <p:blipFill>
-          <a:blip r:embed="rId3"/>
-          <a:stretch>
-            <a:fillRect/>
-          </a:stretch>
-        </p:blipFill>
-        <p:spPr>
-          <a:xfrm>
-            <a:off x="10024567" y="6062197"/>
-            <a:ext cx="1965960" cy="631211"/>
-          </a:xfrm>
-          <a:prstGeom prst="rect">
-            <a:avLst/>
-          </a:prstGeom>
-        </p:spPr>
-      </p:pic>
-      <p:sp>
-        <p:nvSpPr>
-          <p:cNvPr id="10" name="Oval 9"/>
-          <p:cNvSpPr/>
-          <p:nvPr/>
-        </p:nvSpPr>
-        <p:spPr>
-          <a:xfrm>
-            <a:off x="5554065" y="6510528"/>
-            <a:ext cx="77724" cy="77724"/>
-          </a:xfrm>
-          <a:prstGeom prst="ellipse">
-            <a:avLst/>
-          </a:prstGeom>
-          <a:solidFill>
-            <a:srgbClr val="2FDFE5"/>
-          </a:solidFill>
-          <a:ln>
-            <a:noFill/>
-          </a:ln>
-        </p:spPr>
-        <p:style>
-          <a:lnRef idx="1">
-            <a:schemeClr val="accent1"/>
-          </a:lnRef>
-          <a:fillRef idx="3">
-            <a:schemeClr val="accent1"/>
-          </a:fillRef>
-          <a:effectRef idx="2">
-            <a:schemeClr val="accent1"/>
-          </a:effectRef>
-          <a:fontRef idx="minor">
-            <a:schemeClr val="lt1"/>
-          </a:fontRef>
-        </p:style>
-        <p:txBody>
-          <a:bodyPr rtlCol="0" anchor="ctr"/>
-          <a:lstStyle/>
-          <a:p>
-            <a:pPr algn="ctr"/>
-          </a:p>
-        </p:txBody>
-      </p:sp>
-      <p:sp>
-        <p:nvSpPr>
-          <p:cNvPr id="11" name="Oval 10"/>
-          <p:cNvSpPr/>
-          <p:nvPr/>
-        </p:nvSpPr>
-        <p:spPr>
-          <a:xfrm>
-            <a:off x="5805525" y="6510528"/>
-            <a:ext cx="77724" cy="77724"/>
-          </a:xfrm>
-          <a:prstGeom prst="ellipse">
-            <a:avLst/>
-          </a:prstGeom>
-          <a:noFill/>
-          <a:ln w="10160">
-            <a:solidFill>
-              <a:srgbClr val="13B9BF"/>
-            </a:solidFill>
-          </a:ln>
-        </p:spPr>
-        <p:style>
-          <a:lnRef idx="1">
-            <a:schemeClr val="accent1"/>
-          </a:lnRef>
-          <a:fillRef idx="3">
-            <a:schemeClr val="accent1"/>
-          </a:fillRef>
-          <a:effectRef idx="2">
-            <a:schemeClr val="accent1"/>
-          </a:effectRef>
-          <a:fontRef idx="minor">
-            <a:schemeClr val="lt1"/>
-          </a:fontRef>
-        </p:style>
-        <p:txBody>
-          <a:bodyPr rtlCol="0" anchor="ctr"/>
-          <a:lstStyle/>
-          <a:p>
-            <a:pPr algn="ctr"/>
-          </a:p>
-        </p:txBody>
-      </p:sp>
-      <p:sp>
-        <p:nvSpPr>
-          <p:cNvPr id="12" name="Oval 11"/>
-          <p:cNvSpPr/>
-          <p:nvPr/>
-        </p:nvSpPr>
-        <p:spPr>
-          <a:xfrm>
-            <a:off x="6056985" y="6510528"/>
-            <a:ext cx="77724" cy="77724"/>
-          </a:xfrm>
-          <a:prstGeom prst="ellipse">
-            <a:avLst/>
-          </a:prstGeom>
-          <a:noFill/>
-          <a:ln w="10160">
-            <a:solidFill>
-              <a:srgbClr val="13B9BF"/>
-            </a:solidFill>
-          </a:ln>
-        </p:spPr>
-        <p:style>
-          <a:lnRef idx="1">
-            <a:schemeClr val="accent1"/>
-          </a:lnRef>
-          <a:fillRef idx="3">
-            <a:schemeClr val="accent1"/>
-          </a:fillRef>
-          <a:effectRef idx="2">
-            <a:schemeClr val="accent1"/>
-          </a:effectRef>
-          <a:fontRef idx="minor">
-            <a:schemeClr val="lt1"/>
-          </a:fontRef>
-        </p:style>
-        <p:txBody>
-          <a:bodyPr rtlCol="0" anchor="ctr"/>
-          <a:lstStyle/>
-          <a:p>
-            <a:pPr algn="ctr"/>
-          </a:p>
-        </p:txBody>
-      </p:sp>
-      <p:sp>
-        <p:nvSpPr>
-          <p:cNvPr id="13" name="Oval 12"/>
-          <p:cNvSpPr/>
-          <p:nvPr/>
-        </p:nvSpPr>
-        <p:spPr>
-          <a:xfrm>
-            <a:off x="6308445" y="6510528"/>
-            <a:ext cx="77724" cy="77724"/>
-          </a:xfrm>
-          <a:prstGeom prst="ellipse">
-            <a:avLst/>
-          </a:prstGeom>
-          <a:noFill/>
-          <a:ln w="10160">
-            <a:solidFill>
-              <a:srgbClr val="13B9BF"/>
-            </a:solidFill>
-          </a:ln>
-        </p:spPr>
-        <p:style>
-          <a:lnRef idx="1">
-            <a:schemeClr val="accent1"/>
-          </a:lnRef>
-          <a:fillRef idx="3">
-            <a:schemeClr val="accent1"/>
-          </a:fillRef>
-          <a:effectRef idx="2">
-            <a:schemeClr val="accent1"/>
-          </a:effectRef>
-          <a:fontRef idx="minor">
-            <a:schemeClr val="lt1"/>
-          </a:fontRef>
-        </p:style>
-        <p:txBody>
-          <a:bodyPr rtlCol="0" anchor="ctr"/>
-          <a:lstStyle/>
-          <a:p>
-            <a:pPr algn="ctr"/>
-          </a:p>
-        </p:txBody>
-      </p:sp>
-      <p:sp>
-        <p:nvSpPr>
-          <p:cNvPr id="14" name="Oval 13"/>
-          <p:cNvSpPr/>
-          <p:nvPr/>
-        </p:nvSpPr>
-        <p:spPr>
-          <a:xfrm>
-            <a:off x="6559905" y="6510528"/>
-            <a:ext cx="77724" cy="77724"/>
-          </a:xfrm>
-          <a:prstGeom prst="ellipse">
-            <a:avLst/>
-          </a:prstGeom>
-          <a:noFill/>
-          <a:ln w="10160">
-            <a:solidFill>
-              <a:srgbClr val="13B9BF"/>
-            </a:solidFill>
-          </a:ln>
-        </p:spPr>
-        <p:style>
-          <a:lnRef idx="1">
-            <a:schemeClr val="accent1"/>
-          </a:lnRef>
-          <a:fillRef idx="3">
-            <a:schemeClr val="accent1"/>
-          </a:fillRef>
-          <a:effectRef idx="2">
-            <a:schemeClr val="accent1"/>
-          </a:effectRef>
-          <a:fontRef idx="minor">
-            <a:schemeClr val="lt1"/>
-          </a:fontRef>
-        </p:style>
-        <p:txBody>
-          <a:bodyPr rtlCol="0" anchor="ctr"/>
-          <a:lstStyle/>
-          <a:p>
-            <a:pPr algn="ctr"/>
-          </a:p>
-        </p:txBody>
-      </p:sp>
-      <p:sp>
-        <p:nvSpPr>
-          <p:cNvPr id="15" name="Rectangle 14"/>
+      <p:sp>
+        <p:nvSpPr>
+          <p:cNvPr id="9" name="Rectangle 8"/>
           <p:cNvSpPr/>
           <p:nvPr/>
         </p:nvSpPr>
@@ -4042,7 +3803,7 @@
       </p:sp>
       <p:sp>
         <p:nvSpPr>
-          <p:cNvPr id="16" name="Rectangle 15"/>
+          <p:cNvPr id="10" name="Rectangle 9"/>
           <p:cNvSpPr/>
           <p:nvPr/>
         </p:nvSpPr>
@@ -4085,138 +3846,14 @@
       </p:sp>
       <p:sp>
         <p:nvSpPr>
-          <p:cNvPr id="17" name="Oval 16"/>
+          <p:cNvPr id="11" name="Oval 10"/>
           <p:cNvSpPr/>
           <p:nvPr/>
         </p:nvSpPr>
         <p:spPr>
           <a:xfrm>
-            <a:off x="704088" y="2450592"/>
-            <a:ext cx="329184" cy="329184"/>
-          </a:xfrm>
-          <a:prstGeom prst="ellipse">
-            <a:avLst/>
-          </a:prstGeom>
-          <a:solidFill>
-            <a:srgbClr val="13B9BF"/>
-          </a:solidFill>
-          <a:ln>
-            <a:noFill/>
-          </a:ln>
-        </p:spPr>
-        <p:style>
-          <a:lnRef idx="1">
-            <a:schemeClr val="accent1"/>
-          </a:lnRef>
-          <a:fillRef idx="3">
-            <a:schemeClr val="accent1"/>
-          </a:fillRef>
-          <a:effectRef idx="2">
-            <a:schemeClr val="accent1"/>
-          </a:effectRef>
-          <a:fontRef idx="minor">
-            <a:schemeClr val="lt1"/>
-          </a:fontRef>
-        </p:style>
-        <p:txBody>
-          <a:bodyPr rtlCol="0" anchor="ctr"/>
-          <a:lstStyle/>
-          <a:p>
-            <a:pPr algn="ctr"/>
-          </a:p>
-        </p:txBody>
-      </p:sp>
-      <p:sp>
-        <p:nvSpPr>
-          <p:cNvPr id="18" name="Oval 17"/>
-          <p:cNvSpPr/>
-          <p:nvPr/>
-        </p:nvSpPr>
-        <p:spPr>
-          <a:xfrm>
-            <a:off x="766632" y="2513136"/>
-            <a:ext cx="204094" cy="204094"/>
-          </a:xfrm>
-          <a:prstGeom prst="ellipse">
-            <a:avLst/>
-          </a:prstGeom>
-          <a:solidFill>
-            <a:srgbClr val="088A8F"/>
-          </a:solidFill>
-          <a:ln>
-            <a:noFill/>
-          </a:ln>
-        </p:spPr>
-        <p:style>
-          <a:lnRef idx="1">
-            <a:schemeClr val="accent1"/>
-          </a:lnRef>
-          <a:fillRef idx="3">
-            <a:schemeClr val="accent1"/>
-          </a:fillRef>
-          <a:effectRef idx="2">
-            <a:schemeClr val="accent1"/>
-          </a:effectRef>
-          <a:fontRef idx="minor">
-            <a:schemeClr val="lt1"/>
-          </a:fontRef>
-        </p:style>
-        <p:txBody>
-          <a:bodyPr rtlCol="0" anchor="ctr"/>
-          <a:lstStyle/>
-          <a:p>
-            <a:pPr algn="ctr"/>
-          </a:p>
-        </p:txBody>
-      </p:sp>
-      <p:sp>
-        <p:nvSpPr>
-          <p:cNvPr id="19" name="TextBox 18"/>
-          <p:cNvSpPr txBox="1"/>
-          <p:nvPr/>
-        </p:nvSpPr>
-        <p:spPr>
-          <a:xfrm>
-            <a:off x="704088" y="2450592"/>
-            <a:ext cx="329184" cy="329184"/>
-          </a:xfrm>
-          <a:prstGeom prst="rect">
-            <a:avLst/>
-          </a:prstGeom>
-          <a:noFill/>
-        </p:spPr>
-        <p:txBody lIns="0" tIns="0" rIns="0" bIns="0">
-          <a:bodyPr wrap="none">
-            <a:spAutoFit/>
-          </a:bodyPr>
-          <a:lstStyle/>
-          <a:p>
-            <a:pPr algn="ctr">
-              <a:spcBef>
-                <a:spcPts val="200"/>
-              </a:spcBef>
-            </a:pPr>
-            <a:r>
-              <a:rPr sz="1100" b="1">
-                <a:solidFill>
-                  <a:srgbClr val="FFFFFF"/>
-                </a:solidFill>
-              </a:rPr>
-              <a:t>▼</a:t>
-            </a:r>
-          </a:p>
-        </p:txBody>
-      </p:sp>
-      <p:sp>
-        <p:nvSpPr>
-          <p:cNvPr id="20" name="Oval 19"/>
-          <p:cNvSpPr/>
-          <p:nvPr/>
-        </p:nvSpPr>
-        <p:spPr>
-          <a:xfrm>
-            <a:off x="1124712" y="2487168"/>
-            <a:ext cx="201168" cy="201168"/>
+            <a:off x="704088" y="2468880"/>
+            <a:ext cx="274320" cy="274320"/>
           </a:xfrm>
           <a:prstGeom prst="ellipse">
             <a:avLst/>
@@ -4254,14 +3891,14 @@
       </p:sp>
       <p:sp>
         <p:nvSpPr>
-          <p:cNvPr id="21" name="TextBox 20"/>
+          <p:cNvPr id="12" name="TextBox 11"/>
           <p:cNvSpPr txBox="1"/>
           <p:nvPr/>
         </p:nvSpPr>
         <p:spPr>
           <a:xfrm>
-            <a:off x="1124712" y="2487168"/>
-            <a:ext cx="201168" cy="201168"/>
+            <a:off x="704088" y="2468880"/>
+            <a:ext cx="274320" cy="274320"/>
           </a:xfrm>
           <a:prstGeom prst="rect">
             <a:avLst/>
@@ -4288,14 +3925,14 @@
       </p:sp>
       <p:sp>
         <p:nvSpPr>
-          <p:cNvPr id="22" name="TextBox 21"/>
+          <p:cNvPr id="13" name="TextBox 12"/>
           <p:cNvSpPr txBox="1"/>
           <p:nvPr/>
         </p:nvSpPr>
         <p:spPr>
           <a:xfrm>
-            <a:off x="1161288" y="2450592"/>
-            <a:ext cx="4792827" cy="658368"/>
+            <a:off x="1088136" y="2468880"/>
+            <a:ext cx="4792827" cy="566928"/>
           </a:xfrm>
           <a:prstGeom prst="rect">
             <a:avLst/>
@@ -4322,13 +3959,13 @@
       </p:sp>
       <p:sp>
         <p:nvSpPr>
-          <p:cNvPr id="23" name="Rectangle 22"/>
+          <p:cNvPr id="14" name="Rectangle 13"/>
           <p:cNvSpPr/>
           <p:nvPr/>
         </p:nvSpPr>
         <p:spPr>
           <a:xfrm>
-            <a:off x="667512" y="2907792"/>
+            <a:off x="667512" y="2852928"/>
             <a:ext cx="5250027" cy="15240"/>
           </a:xfrm>
           <a:prstGeom prst="rect">
@@ -4365,14 +4002,14 @@
       </p:sp>
       <p:sp>
         <p:nvSpPr>
-          <p:cNvPr id="24" name="TextBox 23"/>
+          <p:cNvPr id="15" name="TextBox 14"/>
           <p:cNvSpPr txBox="1"/>
           <p:nvPr/>
         </p:nvSpPr>
         <p:spPr>
           <a:xfrm>
-            <a:off x="667512" y="2996692"/>
-            <a:ext cx="5250027" cy="2959608"/>
+            <a:off x="667512" y="2941828"/>
+            <a:ext cx="5250027" cy="3014472"/>
           </a:xfrm>
           <a:prstGeom prst="rect">
             <a:avLst/>
@@ -4457,7 +4094,7 @@
       </p:sp>
       <p:sp>
         <p:nvSpPr>
-          <p:cNvPr id="25" name="Rectangle 24"/>
+          <p:cNvPr id="16" name="Rectangle 15"/>
           <p:cNvSpPr/>
           <p:nvPr/>
         </p:nvSpPr>
@@ -4502,7 +4139,7 @@
       </p:sp>
       <p:sp>
         <p:nvSpPr>
-          <p:cNvPr id="26" name="Rectangle 25"/>
+          <p:cNvPr id="17" name="Rectangle 16"/>
           <p:cNvSpPr/>
           <p:nvPr/>
         </p:nvSpPr>
@@ -4545,138 +4182,14 @@
       </p:sp>
       <p:sp>
         <p:nvSpPr>
-          <p:cNvPr id="27" name="Oval 26"/>
+          <p:cNvPr id="18" name="Oval 17"/>
           <p:cNvSpPr/>
           <p:nvPr/>
         </p:nvSpPr>
         <p:spPr>
           <a:xfrm>
-            <a:off x="6484467" y="2450592"/>
-            <a:ext cx="329184" cy="329184"/>
-          </a:xfrm>
-          <a:prstGeom prst="ellipse">
-            <a:avLst/>
-          </a:prstGeom>
-          <a:solidFill>
-            <a:srgbClr val="13B9BF"/>
-          </a:solidFill>
-          <a:ln>
-            <a:noFill/>
-          </a:ln>
-        </p:spPr>
-        <p:style>
-          <a:lnRef idx="1">
-            <a:schemeClr val="accent1"/>
-          </a:lnRef>
-          <a:fillRef idx="3">
-            <a:schemeClr val="accent1"/>
-          </a:fillRef>
-          <a:effectRef idx="2">
-            <a:schemeClr val="accent1"/>
-          </a:effectRef>
-          <a:fontRef idx="minor">
-            <a:schemeClr val="lt1"/>
-          </a:fontRef>
-        </p:style>
-        <p:txBody>
-          <a:bodyPr rtlCol="0" anchor="ctr"/>
-          <a:lstStyle/>
-          <a:p>
-            <a:pPr algn="ctr"/>
-          </a:p>
-        </p:txBody>
-      </p:sp>
-      <p:sp>
-        <p:nvSpPr>
-          <p:cNvPr id="28" name="Oval 27"/>
-          <p:cNvSpPr/>
-          <p:nvPr/>
-        </p:nvSpPr>
-        <p:spPr>
-          <a:xfrm>
-            <a:off x="6547012" y="2513136"/>
-            <a:ext cx="204094" cy="204094"/>
-          </a:xfrm>
-          <a:prstGeom prst="ellipse">
-            <a:avLst/>
-          </a:prstGeom>
-          <a:solidFill>
-            <a:srgbClr val="088A8F"/>
-          </a:solidFill>
-          <a:ln>
-            <a:noFill/>
-          </a:ln>
-        </p:spPr>
-        <p:style>
-          <a:lnRef idx="1">
-            <a:schemeClr val="accent1"/>
-          </a:lnRef>
-          <a:fillRef idx="3">
-            <a:schemeClr val="accent1"/>
-          </a:fillRef>
-          <a:effectRef idx="2">
-            <a:schemeClr val="accent1"/>
-          </a:effectRef>
-          <a:fontRef idx="minor">
-            <a:schemeClr val="lt1"/>
-          </a:fontRef>
-        </p:style>
-        <p:txBody>
-          <a:bodyPr rtlCol="0" anchor="ctr"/>
-          <a:lstStyle/>
-          <a:p>
-            <a:pPr algn="ctr"/>
-          </a:p>
-        </p:txBody>
-      </p:sp>
-      <p:sp>
-        <p:nvSpPr>
-          <p:cNvPr id="29" name="TextBox 28"/>
-          <p:cNvSpPr txBox="1"/>
-          <p:nvPr/>
-        </p:nvSpPr>
-        <p:spPr>
-          <a:xfrm>
-            <a:off x="6484467" y="2450592"/>
-            <a:ext cx="329184" cy="329184"/>
-          </a:xfrm>
-          <a:prstGeom prst="rect">
-            <a:avLst/>
-          </a:prstGeom>
-          <a:noFill/>
-        </p:spPr>
-        <p:txBody lIns="0" tIns="0" rIns="0" bIns="0">
-          <a:bodyPr wrap="none">
-            <a:spAutoFit/>
-          </a:bodyPr>
-          <a:lstStyle/>
-          <a:p>
-            <a:pPr algn="ctr">
-              <a:spcBef>
-                <a:spcPts val="200"/>
-              </a:spcBef>
-            </a:pPr>
-            <a:r>
-              <a:rPr sz="1100" b="1">
-                <a:solidFill>
-                  <a:srgbClr val="FFFFFF"/>
-                </a:solidFill>
-              </a:rPr>
-              <a:t>◆</a:t>
-            </a:r>
-          </a:p>
-        </p:txBody>
-      </p:sp>
-      <p:sp>
-        <p:nvSpPr>
-          <p:cNvPr id="30" name="Oval 29"/>
-          <p:cNvSpPr/>
-          <p:nvPr/>
-        </p:nvSpPr>
-        <p:spPr>
-          <a:xfrm>
-            <a:off x="6905091" y="2487168"/>
-            <a:ext cx="201168" cy="201168"/>
+            <a:off x="6484467" y="2468880"/>
+            <a:ext cx="274320" cy="274320"/>
           </a:xfrm>
           <a:prstGeom prst="ellipse">
             <a:avLst/>
@@ -4714,14 +4227,14 @@
       </p:sp>
       <p:sp>
         <p:nvSpPr>
-          <p:cNvPr id="31" name="TextBox 30"/>
+          <p:cNvPr id="19" name="TextBox 18"/>
           <p:cNvSpPr txBox="1"/>
           <p:nvPr/>
         </p:nvSpPr>
         <p:spPr>
           <a:xfrm>
-            <a:off x="6905091" y="2487168"/>
-            <a:ext cx="201168" cy="201168"/>
+            <a:off x="6484467" y="2468880"/>
+            <a:ext cx="274320" cy="274320"/>
           </a:xfrm>
           <a:prstGeom prst="rect">
             <a:avLst/>
@@ -4748,14 +4261,14 @@
       </p:sp>
       <p:sp>
         <p:nvSpPr>
-          <p:cNvPr id="32" name="TextBox 31"/>
+          <p:cNvPr id="20" name="TextBox 19"/>
           <p:cNvSpPr txBox="1"/>
           <p:nvPr/>
         </p:nvSpPr>
         <p:spPr>
           <a:xfrm>
-            <a:off x="6941667" y="2450592"/>
-            <a:ext cx="4792827" cy="658368"/>
+            <a:off x="6868515" y="2468880"/>
+            <a:ext cx="4792827" cy="566928"/>
           </a:xfrm>
           <a:prstGeom prst="rect">
             <a:avLst/>
@@ -4782,13 +4295,13 @@
       </p:sp>
       <p:sp>
         <p:nvSpPr>
-          <p:cNvPr id="33" name="Rectangle 32"/>
+          <p:cNvPr id="21" name="Rectangle 20"/>
           <p:cNvSpPr/>
           <p:nvPr/>
         </p:nvSpPr>
         <p:spPr>
           <a:xfrm>
-            <a:off x="6447891" y="2907792"/>
+            <a:off x="6447891" y="2852928"/>
             <a:ext cx="5250027" cy="15240"/>
           </a:xfrm>
           <a:prstGeom prst="rect">
@@ -4825,14 +4338,14 @@
       </p:sp>
       <p:sp>
         <p:nvSpPr>
-          <p:cNvPr id="34" name="TextBox 33"/>
+          <p:cNvPr id="22" name="TextBox 21"/>
           <p:cNvSpPr txBox="1"/>
           <p:nvPr/>
         </p:nvSpPr>
         <p:spPr>
           <a:xfrm>
-            <a:off x="6447891" y="2996692"/>
-            <a:ext cx="5250027" cy="2959608"/>
+            <a:off x="6447891" y="2941828"/>
+            <a:ext cx="5250027" cy="3014472"/>
           </a:xfrm>
           <a:prstGeom prst="rect">
             <a:avLst/>
@@ -4915,6 +4428,30 @@
           </a:p>
         </p:txBody>
       </p:sp>
+      <p:pic>
+        <p:nvPicPr>
+          <p:cNvPr id="23" name="Picture 22" descr="logo_horiz.png"/>
+          <p:cNvPicPr>
+            <a:picLocks noChangeAspect="1"/>
+          </p:cNvPicPr>
+          <p:nvPr/>
+        </p:nvPicPr>
+        <p:blipFill>
+          <a:blip r:embed="rId3"/>
+          <a:stretch>
+            <a:fillRect/>
+          </a:stretch>
+        </p:blipFill>
+        <p:spPr>
+          <a:xfrm>
+            <a:off x="10024567" y="6062197"/>
+            <a:ext cx="1965960" cy="631211"/>
+          </a:xfrm>
+          <a:prstGeom prst="rect">
+            <a:avLst/>
+          </a:prstGeom>
+        </p:spPr>
+      </p:pic>
     </p:spTree>
   </p:cSld>
   <p:clrMapOvr>
@@ -4944,7 +4481,7 @@
                                 <p:cBhvr>
                                   <p:cTn id="6" dur="450" fill="hold"/>
                                   <p:tgtEl>
-                                    <p:spTgt spid="15"/>
+                                    <p:spTgt spid="9"/>
                                   </p:tgtEl>
                                 </p:cBhvr>
                               </p:animEffect>
@@ -4961,7 +4498,7 @@
                                 <p:cBhvr>
                                   <p:cTn id="8" dur="450" fill="hold"/>
                                   <p:tgtEl>
-                                    <p:spTgt spid="25"/>
+                                    <p:spTgt spid="16"/>
                                   </p:tgtEl>
                                 </p:cBhvr>
                               </p:animEffect>
@@ -5281,248 +4818,9 @@
           </a:p>
         </p:txBody>
       </p:sp>
-      <p:pic>
-        <p:nvPicPr>
-          <p:cNvPr id="9" name="Picture 8" descr="logo_horiz.png"/>
-          <p:cNvPicPr>
-            <a:picLocks noChangeAspect="1"/>
-          </p:cNvPicPr>
-          <p:nvPr/>
-        </p:nvPicPr>
-        <p:blipFill>
-          <a:blip r:embed="rId3"/>
-          <a:stretch>
-            <a:fillRect/>
-          </a:stretch>
-        </p:blipFill>
-        <p:spPr>
-          <a:xfrm>
-            <a:off x="10024567" y="6062197"/>
-            <a:ext cx="1965960" cy="631211"/>
-          </a:xfrm>
-          <a:prstGeom prst="rect">
-            <a:avLst/>
-          </a:prstGeom>
-        </p:spPr>
-      </p:pic>
-      <p:sp>
-        <p:nvSpPr>
-          <p:cNvPr id="10" name="Oval 9"/>
-          <p:cNvSpPr/>
-          <p:nvPr/>
-        </p:nvSpPr>
-        <p:spPr>
-          <a:xfrm>
-            <a:off x="5554065" y="6510528"/>
-            <a:ext cx="77724" cy="77724"/>
-          </a:xfrm>
-          <a:prstGeom prst="ellipse">
-            <a:avLst/>
-          </a:prstGeom>
-          <a:noFill/>
-          <a:ln w="10160">
-            <a:solidFill>
-              <a:srgbClr val="13B9BF"/>
-            </a:solidFill>
-          </a:ln>
-        </p:spPr>
-        <p:style>
-          <a:lnRef idx="1">
-            <a:schemeClr val="accent1"/>
-          </a:lnRef>
-          <a:fillRef idx="3">
-            <a:schemeClr val="accent1"/>
-          </a:fillRef>
-          <a:effectRef idx="2">
-            <a:schemeClr val="accent1"/>
-          </a:effectRef>
-          <a:fontRef idx="minor">
-            <a:schemeClr val="lt1"/>
-          </a:fontRef>
-        </p:style>
-        <p:txBody>
-          <a:bodyPr rtlCol="0" anchor="ctr"/>
-          <a:lstStyle/>
-          <a:p>
-            <a:pPr algn="ctr"/>
-          </a:p>
-        </p:txBody>
-      </p:sp>
-      <p:sp>
-        <p:nvSpPr>
-          <p:cNvPr id="11" name="Oval 10"/>
-          <p:cNvSpPr/>
-          <p:nvPr/>
-        </p:nvSpPr>
-        <p:spPr>
-          <a:xfrm>
-            <a:off x="5805525" y="6510528"/>
-            <a:ext cx="77724" cy="77724"/>
-          </a:xfrm>
-          <a:prstGeom prst="ellipse">
-            <a:avLst/>
-          </a:prstGeom>
-          <a:solidFill>
-            <a:srgbClr val="2FDFE5"/>
-          </a:solidFill>
-          <a:ln>
-            <a:noFill/>
-          </a:ln>
-        </p:spPr>
-        <p:style>
-          <a:lnRef idx="1">
-            <a:schemeClr val="accent1"/>
-          </a:lnRef>
-          <a:fillRef idx="3">
-            <a:schemeClr val="accent1"/>
-          </a:fillRef>
-          <a:effectRef idx="2">
-            <a:schemeClr val="accent1"/>
-          </a:effectRef>
-          <a:fontRef idx="minor">
-            <a:schemeClr val="lt1"/>
-          </a:fontRef>
-        </p:style>
-        <p:txBody>
-          <a:bodyPr rtlCol="0" anchor="ctr"/>
-          <a:lstStyle/>
-          <a:p>
-            <a:pPr algn="ctr"/>
-          </a:p>
-        </p:txBody>
-      </p:sp>
-      <p:sp>
-        <p:nvSpPr>
-          <p:cNvPr id="12" name="Oval 11"/>
-          <p:cNvSpPr/>
-          <p:nvPr/>
-        </p:nvSpPr>
-        <p:spPr>
-          <a:xfrm>
-            <a:off x="6056985" y="6510528"/>
-            <a:ext cx="77724" cy="77724"/>
-          </a:xfrm>
-          <a:prstGeom prst="ellipse">
-            <a:avLst/>
-          </a:prstGeom>
-          <a:noFill/>
-          <a:ln w="10160">
-            <a:solidFill>
-              <a:srgbClr val="13B9BF"/>
-            </a:solidFill>
-          </a:ln>
-        </p:spPr>
-        <p:style>
-          <a:lnRef idx="1">
-            <a:schemeClr val="accent1"/>
-          </a:lnRef>
-          <a:fillRef idx="3">
-            <a:schemeClr val="accent1"/>
-          </a:fillRef>
-          <a:effectRef idx="2">
-            <a:schemeClr val="accent1"/>
-          </a:effectRef>
-          <a:fontRef idx="minor">
-            <a:schemeClr val="lt1"/>
-          </a:fontRef>
-        </p:style>
-        <p:txBody>
-          <a:bodyPr rtlCol="0" anchor="ctr"/>
-          <a:lstStyle/>
-          <a:p>
-            <a:pPr algn="ctr"/>
-          </a:p>
-        </p:txBody>
-      </p:sp>
-      <p:sp>
-        <p:nvSpPr>
-          <p:cNvPr id="13" name="Oval 12"/>
-          <p:cNvSpPr/>
-          <p:nvPr/>
-        </p:nvSpPr>
-        <p:spPr>
-          <a:xfrm>
-            <a:off x="6308445" y="6510528"/>
-            <a:ext cx="77724" cy="77724"/>
-          </a:xfrm>
-          <a:prstGeom prst="ellipse">
-            <a:avLst/>
-          </a:prstGeom>
-          <a:noFill/>
-          <a:ln w="10160">
-            <a:solidFill>
-              <a:srgbClr val="13B9BF"/>
-            </a:solidFill>
-          </a:ln>
-        </p:spPr>
-        <p:style>
-          <a:lnRef idx="1">
-            <a:schemeClr val="accent1"/>
-          </a:lnRef>
-          <a:fillRef idx="3">
-            <a:schemeClr val="accent1"/>
-          </a:fillRef>
-          <a:effectRef idx="2">
-            <a:schemeClr val="accent1"/>
-          </a:effectRef>
-          <a:fontRef idx="minor">
-            <a:schemeClr val="lt1"/>
-          </a:fontRef>
-        </p:style>
-        <p:txBody>
-          <a:bodyPr rtlCol="0" anchor="ctr"/>
-          <a:lstStyle/>
-          <a:p>
-            <a:pPr algn="ctr"/>
-          </a:p>
-        </p:txBody>
-      </p:sp>
-      <p:sp>
-        <p:nvSpPr>
-          <p:cNvPr id="14" name="Oval 13"/>
-          <p:cNvSpPr/>
-          <p:nvPr/>
-        </p:nvSpPr>
-        <p:spPr>
-          <a:xfrm>
-            <a:off x="6559905" y="6510528"/>
-            <a:ext cx="77724" cy="77724"/>
-          </a:xfrm>
-          <a:prstGeom prst="ellipse">
-            <a:avLst/>
-          </a:prstGeom>
-          <a:noFill/>
-          <a:ln w="10160">
-            <a:solidFill>
-              <a:srgbClr val="13B9BF"/>
-            </a:solidFill>
-          </a:ln>
-        </p:spPr>
-        <p:style>
-          <a:lnRef idx="1">
-            <a:schemeClr val="accent1"/>
-          </a:lnRef>
-          <a:fillRef idx="3">
-            <a:schemeClr val="accent1"/>
-          </a:fillRef>
-          <a:effectRef idx="2">
-            <a:schemeClr val="accent1"/>
-          </a:effectRef>
-          <a:fontRef idx="minor">
-            <a:schemeClr val="lt1"/>
-          </a:fontRef>
-        </p:style>
-        <p:txBody>
-          <a:bodyPr rtlCol="0" anchor="ctr"/>
-          <a:lstStyle/>
-          <a:p>
-            <a:pPr algn="ctr"/>
-          </a:p>
-        </p:txBody>
-      </p:sp>
-      <p:sp>
-        <p:nvSpPr>
-          <p:cNvPr id="15" name="Rectangle 14"/>
+      <p:sp>
+        <p:nvSpPr>
+          <p:cNvPr id="9" name="Rectangle 8"/>
           <p:cNvSpPr/>
           <p:nvPr/>
         </p:nvSpPr>
@@ -5567,7 +4865,7 @@
       </p:sp>
       <p:sp>
         <p:nvSpPr>
-          <p:cNvPr id="16" name="Rectangle 15"/>
+          <p:cNvPr id="10" name="Rectangle 9"/>
           <p:cNvSpPr/>
           <p:nvPr/>
         </p:nvSpPr>
@@ -5610,138 +4908,14 @@
       </p:sp>
       <p:sp>
         <p:nvSpPr>
-          <p:cNvPr id="17" name="Oval 16"/>
+          <p:cNvPr id="11" name="Oval 10"/>
           <p:cNvSpPr/>
           <p:nvPr/>
         </p:nvSpPr>
         <p:spPr>
           <a:xfrm>
-            <a:off x="704088" y="2450592"/>
-            <a:ext cx="329184" cy="329184"/>
-          </a:xfrm>
-          <a:prstGeom prst="ellipse">
-            <a:avLst/>
-          </a:prstGeom>
-          <a:solidFill>
-            <a:srgbClr val="13B9BF"/>
-          </a:solidFill>
-          <a:ln>
-            <a:noFill/>
-          </a:ln>
-        </p:spPr>
-        <p:style>
-          <a:lnRef idx="1">
-            <a:schemeClr val="accent1"/>
-          </a:lnRef>
-          <a:fillRef idx="3">
-            <a:schemeClr val="accent1"/>
-          </a:fillRef>
-          <a:effectRef idx="2">
-            <a:schemeClr val="accent1"/>
-          </a:effectRef>
-          <a:fontRef idx="minor">
-            <a:schemeClr val="lt1"/>
-          </a:fontRef>
-        </p:style>
-        <p:txBody>
-          <a:bodyPr rtlCol="0" anchor="ctr"/>
-          <a:lstStyle/>
-          <a:p>
-            <a:pPr algn="ctr"/>
-          </a:p>
-        </p:txBody>
-      </p:sp>
-      <p:sp>
-        <p:nvSpPr>
-          <p:cNvPr id="18" name="Oval 17"/>
-          <p:cNvSpPr/>
-          <p:nvPr/>
-        </p:nvSpPr>
-        <p:spPr>
-          <a:xfrm>
-            <a:off x="766632" y="2513136"/>
-            <a:ext cx="204094" cy="204094"/>
-          </a:xfrm>
-          <a:prstGeom prst="ellipse">
-            <a:avLst/>
-          </a:prstGeom>
-          <a:solidFill>
-            <a:srgbClr val="088A8F"/>
-          </a:solidFill>
-          <a:ln>
-            <a:noFill/>
-          </a:ln>
-        </p:spPr>
-        <p:style>
-          <a:lnRef idx="1">
-            <a:schemeClr val="accent1"/>
-          </a:lnRef>
-          <a:fillRef idx="3">
-            <a:schemeClr val="accent1"/>
-          </a:fillRef>
-          <a:effectRef idx="2">
-            <a:schemeClr val="accent1"/>
-          </a:effectRef>
-          <a:fontRef idx="minor">
-            <a:schemeClr val="lt1"/>
-          </a:fontRef>
-        </p:style>
-        <p:txBody>
-          <a:bodyPr rtlCol="0" anchor="ctr"/>
-          <a:lstStyle/>
-          <a:p>
-            <a:pPr algn="ctr"/>
-          </a:p>
-        </p:txBody>
-      </p:sp>
-      <p:sp>
-        <p:nvSpPr>
-          <p:cNvPr id="19" name="TextBox 18"/>
-          <p:cNvSpPr txBox="1"/>
-          <p:nvPr/>
-        </p:nvSpPr>
-        <p:spPr>
-          <a:xfrm>
-            <a:off x="704088" y="2450592"/>
-            <a:ext cx="329184" cy="329184"/>
-          </a:xfrm>
-          <a:prstGeom prst="rect">
-            <a:avLst/>
-          </a:prstGeom>
-          <a:noFill/>
-        </p:spPr>
-        <p:txBody lIns="0" tIns="0" rIns="0" bIns="0">
-          <a:bodyPr wrap="none">
-            <a:spAutoFit/>
-          </a:bodyPr>
-          <a:lstStyle/>
-          <a:p>
-            <a:pPr algn="ctr">
-              <a:spcBef>
-                <a:spcPts val="200"/>
-              </a:spcBef>
-            </a:pPr>
-            <a:r>
-              <a:rPr sz="1100" b="1">
-                <a:solidFill>
-                  <a:srgbClr val="FFFFFF"/>
-                </a:solidFill>
-              </a:rPr>
-              <a:t>▼</a:t>
-            </a:r>
-          </a:p>
-        </p:txBody>
-      </p:sp>
-      <p:sp>
-        <p:nvSpPr>
-          <p:cNvPr id="20" name="Oval 19"/>
-          <p:cNvSpPr/>
-          <p:nvPr/>
-        </p:nvSpPr>
-        <p:spPr>
-          <a:xfrm>
-            <a:off x="1124712" y="2487168"/>
-            <a:ext cx="201168" cy="201168"/>
+            <a:off x="704088" y="2468880"/>
+            <a:ext cx="274320" cy="274320"/>
           </a:xfrm>
           <a:prstGeom prst="ellipse">
             <a:avLst/>
@@ -5779,14 +4953,14 @@
       </p:sp>
       <p:sp>
         <p:nvSpPr>
-          <p:cNvPr id="21" name="TextBox 20"/>
+          <p:cNvPr id="12" name="TextBox 11"/>
           <p:cNvSpPr txBox="1"/>
           <p:nvPr/>
         </p:nvSpPr>
         <p:spPr>
           <a:xfrm>
-            <a:off x="1124712" y="2487168"/>
-            <a:ext cx="201168" cy="201168"/>
+            <a:off x="704088" y="2468880"/>
+            <a:ext cx="274320" cy="274320"/>
           </a:xfrm>
           <a:prstGeom prst="rect">
             <a:avLst/>
@@ -5813,14 +4987,14 @@
       </p:sp>
       <p:sp>
         <p:nvSpPr>
-          <p:cNvPr id="22" name="TextBox 21"/>
+          <p:cNvPr id="13" name="TextBox 12"/>
           <p:cNvSpPr txBox="1"/>
           <p:nvPr/>
         </p:nvSpPr>
         <p:spPr>
           <a:xfrm>
-            <a:off x="1161288" y="2450592"/>
-            <a:ext cx="4792827" cy="658368"/>
+            <a:off x="1088136" y="2468880"/>
+            <a:ext cx="4792827" cy="566928"/>
           </a:xfrm>
           <a:prstGeom prst="rect">
             <a:avLst/>
@@ -5847,13 +5021,13 @@
       </p:sp>
       <p:sp>
         <p:nvSpPr>
-          <p:cNvPr id="23" name="Rectangle 22"/>
+          <p:cNvPr id="14" name="Rectangle 13"/>
           <p:cNvSpPr/>
           <p:nvPr/>
         </p:nvSpPr>
         <p:spPr>
           <a:xfrm>
-            <a:off x="667512" y="2907792"/>
+            <a:off x="667512" y="2852928"/>
             <a:ext cx="5250027" cy="15240"/>
           </a:xfrm>
           <a:prstGeom prst="rect">
@@ -5890,14 +5064,14 @@
       </p:sp>
       <p:sp>
         <p:nvSpPr>
-          <p:cNvPr id="24" name="TextBox 23"/>
+          <p:cNvPr id="15" name="TextBox 14"/>
           <p:cNvSpPr txBox="1"/>
           <p:nvPr/>
         </p:nvSpPr>
         <p:spPr>
           <a:xfrm>
-            <a:off x="667512" y="2996692"/>
-            <a:ext cx="5250027" cy="2959608"/>
+            <a:off x="667512" y="2941828"/>
+            <a:ext cx="5250027" cy="3014472"/>
           </a:xfrm>
           <a:prstGeom prst="rect">
             <a:avLst/>
@@ -5982,7 +5156,7 @@
       </p:sp>
       <p:sp>
         <p:nvSpPr>
-          <p:cNvPr id="25" name="Rectangle 24"/>
+          <p:cNvPr id="16" name="Rectangle 15"/>
           <p:cNvSpPr/>
           <p:nvPr/>
         </p:nvSpPr>
@@ -6027,7 +5201,7 @@
       </p:sp>
       <p:sp>
         <p:nvSpPr>
-          <p:cNvPr id="26" name="Rectangle 25"/>
+          <p:cNvPr id="17" name="Rectangle 16"/>
           <p:cNvSpPr/>
           <p:nvPr/>
         </p:nvSpPr>
@@ -6070,138 +5244,14 @@
       </p:sp>
       <p:sp>
         <p:nvSpPr>
-          <p:cNvPr id="27" name="Oval 26"/>
+          <p:cNvPr id="18" name="Oval 17"/>
           <p:cNvSpPr/>
           <p:nvPr/>
         </p:nvSpPr>
         <p:spPr>
           <a:xfrm>
-            <a:off x="6484467" y="2450592"/>
-            <a:ext cx="329184" cy="329184"/>
-          </a:xfrm>
-          <a:prstGeom prst="ellipse">
-            <a:avLst/>
-          </a:prstGeom>
-          <a:solidFill>
-            <a:srgbClr val="13B9BF"/>
-          </a:solidFill>
-          <a:ln>
-            <a:noFill/>
-          </a:ln>
-        </p:spPr>
-        <p:style>
-          <a:lnRef idx="1">
-            <a:schemeClr val="accent1"/>
-          </a:lnRef>
-          <a:fillRef idx="3">
-            <a:schemeClr val="accent1"/>
-          </a:fillRef>
-          <a:effectRef idx="2">
-            <a:schemeClr val="accent1"/>
-          </a:effectRef>
-          <a:fontRef idx="minor">
-            <a:schemeClr val="lt1"/>
-          </a:fontRef>
-        </p:style>
-        <p:txBody>
-          <a:bodyPr rtlCol="0" anchor="ctr"/>
-          <a:lstStyle/>
-          <a:p>
-            <a:pPr algn="ctr"/>
-          </a:p>
-        </p:txBody>
-      </p:sp>
-      <p:sp>
-        <p:nvSpPr>
-          <p:cNvPr id="28" name="Oval 27"/>
-          <p:cNvSpPr/>
-          <p:nvPr/>
-        </p:nvSpPr>
-        <p:spPr>
-          <a:xfrm>
-            <a:off x="6547012" y="2513136"/>
-            <a:ext cx="204094" cy="204094"/>
-          </a:xfrm>
-          <a:prstGeom prst="ellipse">
-            <a:avLst/>
-          </a:prstGeom>
-          <a:solidFill>
-            <a:srgbClr val="088A8F"/>
-          </a:solidFill>
-          <a:ln>
-            <a:noFill/>
-          </a:ln>
-        </p:spPr>
-        <p:style>
-          <a:lnRef idx="1">
-            <a:schemeClr val="accent1"/>
-          </a:lnRef>
-          <a:fillRef idx="3">
-            <a:schemeClr val="accent1"/>
-          </a:fillRef>
-          <a:effectRef idx="2">
-            <a:schemeClr val="accent1"/>
-          </a:effectRef>
-          <a:fontRef idx="minor">
-            <a:schemeClr val="lt1"/>
-          </a:fontRef>
-        </p:style>
-        <p:txBody>
-          <a:bodyPr rtlCol="0" anchor="ctr"/>
-          <a:lstStyle/>
-          <a:p>
-            <a:pPr algn="ctr"/>
-          </a:p>
-        </p:txBody>
-      </p:sp>
-      <p:sp>
-        <p:nvSpPr>
-          <p:cNvPr id="29" name="TextBox 28"/>
-          <p:cNvSpPr txBox="1"/>
-          <p:nvPr/>
-        </p:nvSpPr>
-        <p:spPr>
-          <a:xfrm>
-            <a:off x="6484467" y="2450592"/>
-            <a:ext cx="329184" cy="329184"/>
-          </a:xfrm>
-          <a:prstGeom prst="rect">
-            <a:avLst/>
-          </a:prstGeom>
-          <a:noFill/>
-        </p:spPr>
-        <p:txBody lIns="0" tIns="0" rIns="0" bIns="0">
-          <a:bodyPr wrap="none">
-            <a:spAutoFit/>
-          </a:bodyPr>
-          <a:lstStyle/>
-          <a:p>
-            <a:pPr algn="ctr">
-              <a:spcBef>
-                <a:spcPts val="200"/>
-              </a:spcBef>
-            </a:pPr>
-            <a:r>
-              <a:rPr sz="1100" b="1">
-                <a:solidFill>
-                  <a:srgbClr val="FFFFFF"/>
-                </a:solidFill>
-              </a:rPr>
-              <a:t>◆</a:t>
-            </a:r>
-          </a:p>
-        </p:txBody>
-      </p:sp>
-      <p:sp>
-        <p:nvSpPr>
-          <p:cNvPr id="30" name="Oval 29"/>
-          <p:cNvSpPr/>
-          <p:nvPr/>
-        </p:nvSpPr>
-        <p:spPr>
-          <a:xfrm>
-            <a:off x="6905091" y="2487168"/>
-            <a:ext cx="201168" cy="201168"/>
+            <a:off x="6484467" y="2468880"/>
+            <a:ext cx="274320" cy="274320"/>
           </a:xfrm>
           <a:prstGeom prst="ellipse">
             <a:avLst/>
@@ -6239,14 +5289,14 @@
       </p:sp>
       <p:sp>
         <p:nvSpPr>
-          <p:cNvPr id="31" name="TextBox 30"/>
+          <p:cNvPr id="19" name="TextBox 18"/>
           <p:cNvSpPr txBox="1"/>
           <p:nvPr/>
         </p:nvSpPr>
         <p:spPr>
           <a:xfrm>
-            <a:off x="6905091" y="2487168"/>
-            <a:ext cx="201168" cy="201168"/>
+            <a:off x="6484467" y="2468880"/>
+            <a:ext cx="274320" cy="274320"/>
           </a:xfrm>
           <a:prstGeom prst="rect">
             <a:avLst/>
@@ -6273,14 +5323,14 @@
       </p:sp>
       <p:sp>
         <p:nvSpPr>
-          <p:cNvPr id="32" name="TextBox 31"/>
+          <p:cNvPr id="20" name="TextBox 19"/>
           <p:cNvSpPr txBox="1"/>
           <p:nvPr/>
         </p:nvSpPr>
         <p:spPr>
           <a:xfrm>
-            <a:off x="6941667" y="2450592"/>
-            <a:ext cx="4792827" cy="658368"/>
+            <a:off x="6868515" y="2468880"/>
+            <a:ext cx="4792827" cy="566928"/>
           </a:xfrm>
           <a:prstGeom prst="rect">
             <a:avLst/>
@@ -6307,13 +5357,13 @@
       </p:sp>
       <p:sp>
         <p:nvSpPr>
-          <p:cNvPr id="33" name="Rectangle 32"/>
+          <p:cNvPr id="21" name="Rectangle 20"/>
           <p:cNvSpPr/>
           <p:nvPr/>
         </p:nvSpPr>
         <p:spPr>
           <a:xfrm>
-            <a:off x="6447891" y="2907792"/>
+            <a:off x="6447891" y="2852928"/>
             <a:ext cx="5250027" cy="15240"/>
           </a:xfrm>
           <a:prstGeom prst="rect">
@@ -6350,14 +5400,14 @@
       </p:sp>
       <p:sp>
         <p:nvSpPr>
-          <p:cNvPr id="34" name="TextBox 33"/>
+          <p:cNvPr id="22" name="TextBox 21"/>
           <p:cNvSpPr txBox="1"/>
           <p:nvPr/>
         </p:nvSpPr>
         <p:spPr>
           <a:xfrm>
-            <a:off x="6447891" y="2996692"/>
-            <a:ext cx="5250027" cy="2959608"/>
+            <a:off x="6447891" y="2941828"/>
+            <a:ext cx="5250027" cy="3014472"/>
           </a:xfrm>
           <a:prstGeom prst="rect">
             <a:avLst/>
@@ -6440,6 +5490,30 @@
           </a:p>
         </p:txBody>
       </p:sp>
+      <p:pic>
+        <p:nvPicPr>
+          <p:cNvPr id="23" name="Picture 22" descr="logo_horiz.png"/>
+          <p:cNvPicPr>
+            <a:picLocks noChangeAspect="1"/>
+          </p:cNvPicPr>
+          <p:nvPr/>
+        </p:nvPicPr>
+        <p:blipFill>
+          <a:blip r:embed="rId3"/>
+          <a:stretch>
+            <a:fillRect/>
+          </a:stretch>
+        </p:blipFill>
+        <p:spPr>
+          <a:xfrm>
+            <a:off x="10024567" y="6062197"/>
+            <a:ext cx="1965960" cy="631211"/>
+          </a:xfrm>
+          <a:prstGeom prst="rect">
+            <a:avLst/>
+          </a:prstGeom>
+        </p:spPr>
+      </p:pic>
     </p:spTree>
   </p:cSld>
   <p:clrMapOvr>
@@ -6469,7 +5543,7 @@
                                 <p:cBhvr>
                                   <p:cTn id="6" dur="450" fill="hold"/>
                                   <p:tgtEl>
-                                    <p:spTgt spid="15"/>
+                                    <p:spTgt spid="9"/>
                                   </p:tgtEl>
                                 </p:cBhvr>
                               </p:animEffect>
@@ -6486,7 +5560,7 @@
                                 <p:cBhvr>
                                   <p:cTn id="8" dur="450" fill="hold"/>
                                   <p:tgtEl>
-                                    <p:spTgt spid="25"/>
+                                    <p:spTgt spid="16"/>
                                   </p:tgtEl>
                                 </p:cBhvr>
                               </p:animEffect>
@@ -6806,248 +5880,9 @@
           </a:p>
         </p:txBody>
       </p:sp>
-      <p:pic>
-        <p:nvPicPr>
-          <p:cNvPr id="9" name="Picture 8" descr="logo_horiz.png"/>
-          <p:cNvPicPr>
-            <a:picLocks noChangeAspect="1"/>
-          </p:cNvPicPr>
-          <p:nvPr/>
-        </p:nvPicPr>
-        <p:blipFill>
-          <a:blip r:embed="rId3"/>
-          <a:stretch>
-            <a:fillRect/>
-          </a:stretch>
-        </p:blipFill>
-        <p:spPr>
-          <a:xfrm>
-            <a:off x="10024567" y="6062197"/>
-            <a:ext cx="1965960" cy="631211"/>
-          </a:xfrm>
-          <a:prstGeom prst="rect">
-            <a:avLst/>
-          </a:prstGeom>
-        </p:spPr>
-      </p:pic>
-      <p:sp>
-        <p:nvSpPr>
-          <p:cNvPr id="10" name="Oval 9"/>
-          <p:cNvSpPr/>
-          <p:nvPr/>
-        </p:nvSpPr>
-        <p:spPr>
-          <a:xfrm>
-            <a:off x="5554065" y="6510528"/>
-            <a:ext cx="77724" cy="77724"/>
-          </a:xfrm>
-          <a:prstGeom prst="ellipse">
-            <a:avLst/>
-          </a:prstGeom>
-          <a:noFill/>
-          <a:ln w="10160">
-            <a:solidFill>
-              <a:srgbClr val="13B9BF"/>
-            </a:solidFill>
-          </a:ln>
-        </p:spPr>
-        <p:style>
-          <a:lnRef idx="1">
-            <a:schemeClr val="accent1"/>
-          </a:lnRef>
-          <a:fillRef idx="3">
-            <a:schemeClr val="accent1"/>
-          </a:fillRef>
-          <a:effectRef idx="2">
-            <a:schemeClr val="accent1"/>
-          </a:effectRef>
-          <a:fontRef idx="minor">
-            <a:schemeClr val="lt1"/>
-          </a:fontRef>
-        </p:style>
-        <p:txBody>
-          <a:bodyPr rtlCol="0" anchor="ctr"/>
-          <a:lstStyle/>
-          <a:p>
-            <a:pPr algn="ctr"/>
-          </a:p>
-        </p:txBody>
-      </p:sp>
-      <p:sp>
-        <p:nvSpPr>
-          <p:cNvPr id="11" name="Oval 10"/>
-          <p:cNvSpPr/>
-          <p:nvPr/>
-        </p:nvSpPr>
-        <p:spPr>
-          <a:xfrm>
-            <a:off x="5805525" y="6510528"/>
-            <a:ext cx="77724" cy="77724"/>
-          </a:xfrm>
-          <a:prstGeom prst="ellipse">
-            <a:avLst/>
-          </a:prstGeom>
-          <a:noFill/>
-          <a:ln w="10160">
-            <a:solidFill>
-              <a:srgbClr val="13B9BF"/>
-            </a:solidFill>
-          </a:ln>
-        </p:spPr>
-        <p:style>
-          <a:lnRef idx="1">
-            <a:schemeClr val="accent1"/>
-          </a:lnRef>
-          <a:fillRef idx="3">
-            <a:schemeClr val="accent1"/>
-          </a:fillRef>
-          <a:effectRef idx="2">
-            <a:schemeClr val="accent1"/>
-          </a:effectRef>
-          <a:fontRef idx="minor">
-            <a:schemeClr val="lt1"/>
-          </a:fontRef>
-        </p:style>
-        <p:txBody>
-          <a:bodyPr rtlCol="0" anchor="ctr"/>
-          <a:lstStyle/>
-          <a:p>
-            <a:pPr algn="ctr"/>
-          </a:p>
-        </p:txBody>
-      </p:sp>
-      <p:sp>
-        <p:nvSpPr>
-          <p:cNvPr id="12" name="Oval 11"/>
-          <p:cNvSpPr/>
-          <p:nvPr/>
-        </p:nvSpPr>
-        <p:spPr>
-          <a:xfrm>
-            <a:off x="6056985" y="6510528"/>
-            <a:ext cx="77724" cy="77724"/>
-          </a:xfrm>
-          <a:prstGeom prst="ellipse">
-            <a:avLst/>
-          </a:prstGeom>
-          <a:solidFill>
-            <a:srgbClr val="2FDFE5"/>
-          </a:solidFill>
-          <a:ln>
-            <a:noFill/>
-          </a:ln>
-        </p:spPr>
-        <p:style>
-          <a:lnRef idx="1">
-            <a:schemeClr val="accent1"/>
-          </a:lnRef>
-          <a:fillRef idx="3">
-            <a:schemeClr val="accent1"/>
-          </a:fillRef>
-          <a:effectRef idx="2">
-            <a:schemeClr val="accent1"/>
-          </a:effectRef>
-          <a:fontRef idx="minor">
-            <a:schemeClr val="lt1"/>
-          </a:fontRef>
-        </p:style>
-        <p:txBody>
-          <a:bodyPr rtlCol="0" anchor="ctr"/>
-          <a:lstStyle/>
-          <a:p>
-            <a:pPr algn="ctr"/>
-          </a:p>
-        </p:txBody>
-      </p:sp>
-      <p:sp>
-        <p:nvSpPr>
-          <p:cNvPr id="13" name="Oval 12"/>
-          <p:cNvSpPr/>
-          <p:nvPr/>
-        </p:nvSpPr>
-        <p:spPr>
-          <a:xfrm>
-            <a:off x="6308445" y="6510528"/>
-            <a:ext cx="77724" cy="77724"/>
-          </a:xfrm>
-          <a:prstGeom prst="ellipse">
-            <a:avLst/>
-          </a:prstGeom>
-          <a:noFill/>
-          <a:ln w="10160">
-            <a:solidFill>
-              <a:srgbClr val="13B9BF"/>
-            </a:solidFill>
-          </a:ln>
-        </p:spPr>
-        <p:style>
-          <a:lnRef idx="1">
-            <a:schemeClr val="accent1"/>
-          </a:lnRef>
-          <a:fillRef idx="3">
-            <a:schemeClr val="accent1"/>
-          </a:fillRef>
-          <a:effectRef idx="2">
-            <a:schemeClr val="accent1"/>
-          </a:effectRef>
-          <a:fontRef idx="minor">
-            <a:schemeClr val="lt1"/>
-          </a:fontRef>
-        </p:style>
-        <p:txBody>
-          <a:bodyPr rtlCol="0" anchor="ctr"/>
-          <a:lstStyle/>
-          <a:p>
-            <a:pPr algn="ctr"/>
-          </a:p>
-        </p:txBody>
-      </p:sp>
-      <p:sp>
-        <p:nvSpPr>
-          <p:cNvPr id="14" name="Oval 13"/>
-          <p:cNvSpPr/>
-          <p:nvPr/>
-        </p:nvSpPr>
-        <p:spPr>
-          <a:xfrm>
-            <a:off x="6559905" y="6510528"/>
-            <a:ext cx="77724" cy="77724"/>
-          </a:xfrm>
-          <a:prstGeom prst="ellipse">
-            <a:avLst/>
-          </a:prstGeom>
-          <a:noFill/>
-          <a:ln w="10160">
-            <a:solidFill>
-              <a:srgbClr val="13B9BF"/>
-            </a:solidFill>
-          </a:ln>
-        </p:spPr>
-        <p:style>
-          <a:lnRef idx="1">
-            <a:schemeClr val="accent1"/>
-          </a:lnRef>
-          <a:fillRef idx="3">
-            <a:schemeClr val="accent1"/>
-          </a:fillRef>
-          <a:effectRef idx="2">
-            <a:schemeClr val="accent1"/>
-          </a:effectRef>
-          <a:fontRef idx="minor">
-            <a:schemeClr val="lt1"/>
-          </a:fontRef>
-        </p:style>
-        <p:txBody>
-          <a:bodyPr rtlCol="0" anchor="ctr"/>
-          <a:lstStyle/>
-          <a:p>
-            <a:pPr algn="ctr"/>
-          </a:p>
-        </p:txBody>
-      </p:sp>
-      <p:sp>
-        <p:nvSpPr>
-          <p:cNvPr id="15" name="Rectangle 14"/>
+      <p:sp>
+        <p:nvSpPr>
+          <p:cNvPr id="9" name="Rectangle 8"/>
           <p:cNvSpPr/>
           <p:nvPr/>
         </p:nvSpPr>
@@ -7092,7 +5927,7 @@
       </p:sp>
       <p:sp>
         <p:nvSpPr>
-          <p:cNvPr id="16" name="Rectangle 15"/>
+          <p:cNvPr id="10" name="Rectangle 9"/>
           <p:cNvSpPr/>
           <p:nvPr/>
         </p:nvSpPr>
@@ -7135,138 +5970,14 @@
       </p:sp>
       <p:sp>
         <p:nvSpPr>
-          <p:cNvPr id="17" name="Oval 16"/>
+          <p:cNvPr id="11" name="Oval 10"/>
           <p:cNvSpPr/>
           <p:nvPr/>
         </p:nvSpPr>
         <p:spPr>
           <a:xfrm>
-            <a:off x="704088" y="2450592"/>
-            <a:ext cx="329184" cy="329184"/>
-          </a:xfrm>
-          <a:prstGeom prst="ellipse">
-            <a:avLst/>
-          </a:prstGeom>
-          <a:solidFill>
-            <a:srgbClr val="13B9BF"/>
-          </a:solidFill>
-          <a:ln>
-            <a:noFill/>
-          </a:ln>
-        </p:spPr>
-        <p:style>
-          <a:lnRef idx="1">
-            <a:schemeClr val="accent1"/>
-          </a:lnRef>
-          <a:fillRef idx="3">
-            <a:schemeClr val="accent1"/>
-          </a:fillRef>
-          <a:effectRef idx="2">
-            <a:schemeClr val="accent1"/>
-          </a:effectRef>
-          <a:fontRef idx="minor">
-            <a:schemeClr val="lt1"/>
-          </a:fontRef>
-        </p:style>
-        <p:txBody>
-          <a:bodyPr rtlCol="0" anchor="ctr"/>
-          <a:lstStyle/>
-          <a:p>
-            <a:pPr algn="ctr"/>
-          </a:p>
-        </p:txBody>
-      </p:sp>
-      <p:sp>
-        <p:nvSpPr>
-          <p:cNvPr id="18" name="Oval 17"/>
-          <p:cNvSpPr/>
-          <p:nvPr/>
-        </p:nvSpPr>
-        <p:spPr>
-          <a:xfrm>
-            <a:off x="766632" y="2513136"/>
-            <a:ext cx="204094" cy="204094"/>
-          </a:xfrm>
-          <a:prstGeom prst="ellipse">
-            <a:avLst/>
-          </a:prstGeom>
-          <a:solidFill>
-            <a:srgbClr val="088A8F"/>
-          </a:solidFill>
-          <a:ln>
-            <a:noFill/>
-          </a:ln>
-        </p:spPr>
-        <p:style>
-          <a:lnRef idx="1">
-            <a:schemeClr val="accent1"/>
-          </a:lnRef>
-          <a:fillRef idx="3">
-            <a:schemeClr val="accent1"/>
-          </a:fillRef>
-          <a:effectRef idx="2">
-            <a:schemeClr val="accent1"/>
-          </a:effectRef>
-          <a:fontRef idx="minor">
-            <a:schemeClr val="lt1"/>
-          </a:fontRef>
-        </p:style>
-        <p:txBody>
-          <a:bodyPr rtlCol="0" anchor="ctr"/>
-          <a:lstStyle/>
-          <a:p>
-            <a:pPr algn="ctr"/>
-          </a:p>
-        </p:txBody>
-      </p:sp>
-      <p:sp>
-        <p:nvSpPr>
-          <p:cNvPr id="19" name="TextBox 18"/>
-          <p:cNvSpPr txBox="1"/>
-          <p:nvPr/>
-        </p:nvSpPr>
-        <p:spPr>
-          <a:xfrm>
-            <a:off x="704088" y="2450592"/>
-            <a:ext cx="329184" cy="329184"/>
-          </a:xfrm>
-          <a:prstGeom prst="rect">
-            <a:avLst/>
-          </a:prstGeom>
-          <a:noFill/>
-        </p:spPr>
-        <p:txBody lIns="0" tIns="0" rIns="0" bIns="0">
-          <a:bodyPr wrap="none">
-            <a:spAutoFit/>
-          </a:bodyPr>
-          <a:lstStyle/>
-          <a:p>
-            <a:pPr algn="ctr">
-              <a:spcBef>
-                <a:spcPts val="200"/>
-              </a:spcBef>
-            </a:pPr>
-            <a:r>
-              <a:rPr sz="1100" b="1">
-                <a:solidFill>
-                  <a:srgbClr val="FFFFFF"/>
-                </a:solidFill>
-              </a:rPr>
-              <a:t>▼</a:t>
-            </a:r>
-          </a:p>
-        </p:txBody>
-      </p:sp>
-      <p:sp>
-        <p:nvSpPr>
-          <p:cNvPr id="20" name="Oval 19"/>
-          <p:cNvSpPr/>
-          <p:nvPr/>
-        </p:nvSpPr>
-        <p:spPr>
-          <a:xfrm>
-            <a:off x="1124712" y="2487168"/>
-            <a:ext cx="201168" cy="201168"/>
+            <a:off x="704088" y="2468880"/>
+            <a:ext cx="274320" cy="274320"/>
           </a:xfrm>
           <a:prstGeom prst="ellipse">
             <a:avLst/>
@@ -7304,14 +6015,14 @@
       </p:sp>
       <p:sp>
         <p:nvSpPr>
-          <p:cNvPr id="21" name="TextBox 20"/>
+          <p:cNvPr id="12" name="TextBox 11"/>
           <p:cNvSpPr txBox="1"/>
           <p:nvPr/>
         </p:nvSpPr>
         <p:spPr>
           <a:xfrm>
-            <a:off x="1124712" y="2487168"/>
-            <a:ext cx="201168" cy="201168"/>
+            <a:off x="704088" y="2468880"/>
+            <a:ext cx="274320" cy="274320"/>
           </a:xfrm>
           <a:prstGeom prst="rect">
             <a:avLst/>
@@ -7338,14 +6049,14 @@
       </p:sp>
       <p:sp>
         <p:nvSpPr>
-          <p:cNvPr id="22" name="TextBox 21"/>
+          <p:cNvPr id="13" name="TextBox 12"/>
           <p:cNvSpPr txBox="1"/>
           <p:nvPr/>
         </p:nvSpPr>
         <p:spPr>
           <a:xfrm>
-            <a:off x="1161288" y="2450592"/>
-            <a:ext cx="4792827" cy="658368"/>
+            <a:off x="1088136" y="2468880"/>
+            <a:ext cx="4792827" cy="566928"/>
           </a:xfrm>
           <a:prstGeom prst="rect">
             <a:avLst/>
@@ -7372,13 +6083,13 @@
       </p:sp>
       <p:sp>
         <p:nvSpPr>
-          <p:cNvPr id="23" name="Rectangle 22"/>
+          <p:cNvPr id="14" name="Rectangle 13"/>
           <p:cNvSpPr/>
           <p:nvPr/>
         </p:nvSpPr>
         <p:spPr>
           <a:xfrm>
-            <a:off x="667512" y="2907792"/>
+            <a:off x="667512" y="2852928"/>
             <a:ext cx="5250027" cy="15240"/>
           </a:xfrm>
           <a:prstGeom prst="rect">
@@ -7415,14 +6126,14 @@
       </p:sp>
       <p:sp>
         <p:nvSpPr>
-          <p:cNvPr id="24" name="TextBox 23"/>
+          <p:cNvPr id="15" name="TextBox 14"/>
           <p:cNvSpPr txBox="1"/>
           <p:nvPr/>
         </p:nvSpPr>
         <p:spPr>
           <a:xfrm>
-            <a:off x="667512" y="2996692"/>
-            <a:ext cx="5250027" cy="2959608"/>
+            <a:off x="667512" y="2941828"/>
+            <a:ext cx="5250027" cy="3014472"/>
           </a:xfrm>
           <a:prstGeom prst="rect">
             <a:avLst/>
@@ -7507,7 +6218,7 @@
       </p:sp>
       <p:sp>
         <p:nvSpPr>
-          <p:cNvPr id="25" name="Rectangle 24"/>
+          <p:cNvPr id="16" name="Rectangle 15"/>
           <p:cNvSpPr/>
           <p:nvPr/>
         </p:nvSpPr>
@@ -7552,7 +6263,7 @@
       </p:sp>
       <p:sp>
         <p:nvSpPr>
-          <p:cNvPr id="26" name="Rectangle 25"/>
+          <p:cNvPr id="17" name="Rectangle 16"/>
           <p:cNvSpPr/>
           <p:nvPr/>
         </p:nvSpPr>
@@ -7595,138 +6306,14 @@
       </p:sp>
       <p:sp>
         <p:nvSpPr>
-          <p:cNvPr id="27" name="Oval 26"/>
+          <p:cNvPr id="18" name="Oval 17"/>
           <p:cNvSpPr/>
           <p:nvPr/>
         </p:nvSpPr>
         <p:spPr>
           <a:xfrm>
-            <a:off x="6484467" y="2450592"/>
-            <a:ext cx="329184" cy="329184"/>
-          </a:xfrm>
-          <a:prstGeom prst="ellipse">
-            <a:avLst/>
-          </a:prstGeom>
-          <a:solidFill>
-            <a:srgbClr val="13B9BF"/>
-          </a:solidFill>
-          <a:ln>
-            <a:noFill/>
-          </a:ln>
-        </p:spPr>
-        <p:style>
-          <a:lnRef idx="1">
-            <a:schemeClr val="accent1"/>
-          </a:lnRef>
-          <a:fillRef idx="3">
-            <a:schemeClr val="accent1"/>
-          </a:fillRef>
-          <a:effectRef idx="2">
-            <a:schemeClr val="accent1"/>
-          </a:effectRef>
-          <a:fontRef idx="minor">
-            <a:schemeClr val="lt1"/>
-          </a:fontRef>
-        </p:style>
-        <p:txBody>
-          <a:bodyPr rtlCol="0" anchor="ctr"/>
-          <a:lstStyle/>
-          <a:p>
-            <a:pPr algn="ctr"/>
-          </a:p>
-        </p:txBody>
-      </p:sp>
-      <p:sp>
-        <p:nvSpPr>
-          <p:cNvPr id="28" name="Oval 27"/>
-          <p:cNvSpPr/>
-          <p:nvPr/>
-        </p:nvSpPr>
-        <p:spPr>
-          <a:xfrm>
-            <a:off x="6547012" y="2513136"/>
-            <a:ext cx="204094" cy="204094"/>
-          </a:xfrm>
-          <a:prstGeom prst="ellipse">
-            <a:avLst/>
-          </a:prstGeom>
-          <a:solidFill>
-            <a:srgbClr val="088A8F"/>
-          </a:solidFill>
-          <a:ln>
-            <a:noFill/>
-          </a:ln>
-        </p:spPr>
-        <p:style>
-          <a:lnRef idx="1">
-            <a:schemeClr val="accent1"/>
-          </a:lnRef>
-          <a:fillRef idx="3">
-            <a:schemeClr val="accent1"/>
-          </a:fillRef>
-          <a:effectRef idx="2">
-            <a:schemeClr val="accent1"/>
-          </a:effectRef>
-          <a:fontRef idx="minor">
-            <a:schemeClr val="lt1"/>
-          </a:fontRef>
-        </p:style>
-        <p:txBody>
-          <a:bodyPr rtlCol="0" anchor="ctr"/>
-          <a:lstStyle/>
-          <a:p>
-            <a:pPr algn="ctr"/>
-          </a:p>
-        </p:txBody>
-      </p:sp>
-      <p:sp>
-        <p:nvSpPr>
-          <p:cNvPr id="29" name="TextBox 28"/>
-          <p:cNvSpPr txBox="1"/>
-          <p:nvPr/>
-        </p:nvSpPr>
-        <p:spPr>
-          <a:xfrm>
-            <a:off x="6484467" y="2450592"/>
-            <a:ext cx="329184" cy="329184"/>
-          </a:xfrm>
-          <a:prstGeom prst="rect">
-            <a:avLst/>
-          </a:prstGeom>
-          <a:noFill/>
-        </p:spPr>
-        <p:txBody lIns="0" tIns="0" rIns="0" bIns="0">
-          <a:bodyPr wrap="none">
-            <a:spAutoFit/>
-          </a:bodyPr>
-          <a:lstStyle/>
-          <a:p>
-            <a:pPr algn="ctr">
-              <a:spcBef>
-                <a:spcPts val="200"/>
-              </a:spcBef>
-            </a:pPr>
-            <a:r>
-              <a:rPr sz="1100" b="1">
-                <a:solidFill>
-                  <a:srgbClr val="FFFFFF"/>
-                </a:solidFill>
-              </a:rPr>
-              <a:t>◆</a:t>
-            </a:r>
-          </a:p>
-        </p:txBody>
-      </p:sp>
-      <p:sp>
-        <p:nvSpPr>
-          <p:cNvPr id="30" name="Oval 29"/>
-          <p:cNvSpPr/>
-          <p:nvPr/>
-        </p:nvSpPr>
-        <p:spPr>
-          <a:xfrm>
-            <a:off x="6905091" y="2487168"/>
-            <a:ext cx="201168" cy="201168"/>
+            <a:off x="6484467" y="2468880"/>
+            <a:ext cx="274320" cy="274320"/>
           </a:xfrm>
           <a:prstGeom prst="ellipse">
             <a:avLst/>
@@ -7764,14 +6351,14 @@
       </p:sp>
       <p:sp>
         <p:nvSpPr>
-          <p:cNvPr id="31" name="TextBox 30"/>
+          <p:cNvPr id="19" name="TextBox 18"/>
           <p:cNvSpPr txBox="1"/>
           <p:nvPr/>
         </p:nvSpPr>
         <p:spPr>
           <a:xfrm>
-            <a:off x="6905091" y="2487168"/>
-            <a:ext cx="201168" cy="201168"/>
+            <a:off x="6484467" y="2468880"/>
+            <a:ext cx="274320" cy="274320"/>
           </a:xfrm>
           <a:prstGeom prst="rect">
             <a:avLst/>
@@ -7798,14 +6385,14 @@
       </p:sp>
       <p:sp>
         <p:nvSpPr>
-          <p:cNvPr id="32" name="TextBox 31"/>
+          <p:cNvPr id="20" name="TextBox 19"/>
           <p:cNvSpPr txBox="1"/>
           <p:nvPr/>
         </p:nvSpPr>
         <p:spPr>
           <a:xfrm>
-            <a:off x="6941667" y="2450592"/>
-            <a:ext cx="4792827" cy="658368"/>
+            <a:off x="6868515" y="2468880"/>
+            <a:ext cx="4792827" cy="566928"/>
           </a:xfrm>
           <a:prstGeom prst="rect">
             <a:avLst/>
@@ -7832,13 +6419,13 @@
       </p:sp>
       <p:sp>
         <p:nvSpPr>
-          <p:cNvPr id="33" name="Rectangle 32"/>
+          <p:cNvPr id="21" name="Rectangle 20"/>
           <p:cNvSpPr/>
           <p:nvPr/>
         </p:nvSpPr>
         <p:spPr>
           <a:xfrm>
-            <a:off x="6447891" y="2907792"/>
+            <a:off x="6447891" y="2852928"/>
             <a:ext cx="5250027" cy="15240"/>
           </a:xfrm>
           <a:prstGeom prst="rect">
@@ -7875,14 +6462,14 @@
       </p:sp>
       <p:sp>
         <p:nvSpPr>
-          <p:cNvPr id="34" name="TextBox 33"/>
+          <p:cNvPr id="22" name="TextBox 21"/>
           <p:cNvSpPr txBox="1"/>
           <p:nvPr/>
         </p:nvSpPr>
         <p:spPr>
           <a:xfrm>
-            <a:off x="6447891" y="2996692"/>
-            <a:ext cx="5250027" cy="2959608"/>
+            <a:off x="6447891" y="2941828"/>
+            <a:ext cx="5250027" cy="3014472"/>
           </a:xfrm>
           <a:prstGeom prst="rect">
             <a:avLst/>
@@ -7965,6 +6552,30 @@
           </a:p>
         </p:txBody>
       </p:sp>
+      <p:pic>
+        <p:nvPicPr>
+          <p:cNvPr id="23" name="Picture 22" descr="logo_horiz.png"/>
+          <p:cNvPicPr>
+            <a:picLocks noChangeAspect="1"/>
+          </p:cNvPicPr>
+          <p:nvPr/>
+        </p:nvPicPr>
+        <p:blipFill>
+          <a:blip r:embed="rId3"/>
+          <a:stretch>
+            <a:fillRect/>
+          </a:stretch>
+        </p:blipFill>
+        <p:spPr>
+          <a:xfrm>
+            <a:off x="10024567" y="6062197"/>
+            <a:ext cx="1965960" cy="631211"/>
+          </a:xfrm>
+          <a:prstGeom prst="rect">
+            <a:avLst/>
+          </a:prstGeom>
+        </p:spPr>
+      </p:pic>
     </p:spTree>
   </p:cSld>
   <p:clrMapOvr>
@@ -7994,7 +6605,7 @@
                                 <p:cBhvr>
                                   <p:cTn id="6" dur="450" fill="hold"/>
                                   <p:tgtEl>
-                                    <p:spTgt spid="15"/>
+                                    <p:spTgt spid="9"/>
                                   </p:tgtEl>
                                 </p:cBhvr>
                               </p:animEffect>
@@ -8011,7 +6622,7 @@
                                 <p:cBhvr>
                                   <p:cTn id="8" dur="450" fill="hold"/>
                                   <p:tgtEl>
-                                    <p:spTgt spid="25"/>
+                                    <p:spTgt spid="16"/>
                                   </p:tgtEl>
                                 </p:cBhvr>
                               </p:animEffect>
@@ -8331,248 +6942,9 @@
           </a:p>
         </p:txBody>
       </p:sp>
-      <p:pic>
-        <p:nvPicPr>
-          <p:cNvPr id="9" name="Picture 8" descr="logo_horiz.png"/>
-          <p:cNvPicPr>
-            <a:picLocks noChangeAspect="1"/>
-          </p:cNvPicPr>
-          <p:nvPr/>
-        </p:nvPicPr>
-        <p:blipFill>
-          <a:blip r:embed="rId3"/>
-          <a:stretch>
-            <a:fillRect/>
-          </a:stretch>
-        </p:blipFill>
-        <p:spPr>
-          <a:xfrm>
-            <a:off x="10024567" y="6062197"/>
-            <a:ext cx="1965960" cy="631211"/>
-          </a:xfrm>
-          <a:prstGeom prst="rect">
-            <a:avLst/>
-          </a:prstGeom>
-        </p:spPr>
-      </p:pic>
-      <p:sp>
-        <p:nvSpPr>
-          <p:cNvPr id="10" name="Oval 9"/>
-          <p:cNvSpPr/>
-          <p:nvPr/>
-        </p:nvSpPr>
-        <p:spPr>
-          <a:xfrm>
-            <a:off x="5554065" y="6510528"/>
-            <a:ext cx="77724" cy="77724"/>
-          </a:xfrm>
-          <a:prstGeom prst="ellipse">
-            <a:avLst/>
-          </a:prstGeom>
-          <a:noFill/>
-          <a:ln w="10160">
-            <a:solidFill>
-              <a:srgbClr val="13B9BF"/>
-            </a:solidFill>
-          </a:ln>
-        </p:spPr>
-        <p:style>
-          <a:lnRef idx="1">
-            <a:schemeClr val="accent1"/>
-          </a:lnRef>
-          <a:fillRef idx="3">
-            <a:schemeClr val="accent1"/>
-          </a:fillRef>
-          <a:effectRef idx="2">
-            <a:schemeClr val="accent1"/>
-          </a:effectRef>
-          <a:fontRef idx="minor">
-            <a:schemeClr val="lt1"/>
-          </a:fontRef>
-        </p:style>
-        <p:txBody>
-          <a:bodyPr rtlCol="0" anchor="ctr"/>
-          <a:lstStyle/>
-          <a:p>
-            <a:pPr algn="ctr"/>
-          </a:p>
-        </p:txBody>
-      </p:sp>
-      <p:sp>
-        <p:nvSpPr>
-          <p:cNvPr id="11" name="Oval 10"/>
-          <p:cNvSpPr/>
-          <p:nvPr/>
-        </p:nvSpPr>
-        <p:spPr>
-          <a:xfrm>
-            <a:off x="5805525" y="6510528"/>
-            <a:ext cx="77724" cy="77724"/>
-          </a:xfrm>
-          <a:prstGeom prst="ellipse">
-            <a:avLst/>
-          </a:prstGeom>
-          <a:noFill/>
-          <a:ln w="10160">
-            <a:solidFill>
-              <a:srgbClr val="13B9BF"/>
-            </a:solidFill>
-          </a:ln>
-        </p:spPr>
-        <p:style>
-          <a:lnRef idx="1">
-            <a:schemeClr val="accent1"/>
-          </a:lnRef>
-          <a:fillRef idx="3">
-            <a:schemeClr val="accent1"/>
-          </a:fillRef>
-          <a:effectRef idx="2">
-            <a:schemeClr val="accent1"/>
-          </a:effectRef>
-          <a:fontRef idx="minor">
-            <a:schemeClr val="lt1"/>
-          </a:fontRef>
-        </p:style>
-        <p:txBody>
-          <a:bodyPr rtlCol="0" anchor="ctr"/>
-          <a:lstStyle/>
-          <a:p>
-            <a:pPr algn="ctr"/>
-          </a:p>
-        </p:txBody>
-      </p:sp>
-      <p:sp>
-        <p:nvSpPr>
-          <p:cNvPr id="12" name="Oval 11"/>
-          <p:cNvSpPr/>
-          <p:nvPr/>
-        </p:nvSpPr>
-        <p:spPr>
-          <a:xfrm>
-            <a:off x="6056985" y="6510528"/>
-            <a:ext cx="77724" cy="77724"/>
-          </a:xfrm>
-          <a:prstGeom prst="ellipse">
-            <a:avLst/>
-          </a:prstGeom>
-          <a:noFill/>
-          <a:ln w="10160">
-            <a:solidFill>
-              <a:srgbClr val="13B9BF"/>
-            </a:solidFill>
-          </a:ln>
-        </p:spPr>
-        <p:style>
-          <a:lnRef idx="1">
-            <a:schemeClr val="accent1"/>
-          </a:lnRef>
-          <a:fillRef idx="3">
-            <a:schemeClr val="accent1"/>
-          </a:fillRef>
-          <a:effectRef idx="2">
-            <a:schemeClr val="accent1"/>
-          </a:effectRef>
-          <a:fontRef idx="minor">
-            <a:schemeClr val="lt1"/>
-          </a:fontRef>
-        </p:style>
-        <p:txBody>
-          <a:bodyPr rtlCol="0" anchor="ctr"/>
-          <a:lstStyle/>
-          <a:p>
-            <a:pPr algn="ctr"/>
-          </a:p>
-        </p:txBody>
-      </p:sp>
-      <p:sp>
-        <p:nvSpPr>
-          <p:cNvPr id="13" name="Oval 12"/>
-          <p:cNvSpPr/>
-          <p:nvPr/>
-        </p:nvSpPr>
-        <p:spPr>
-          <a:xfrm>
-            <a:off x="6308445" y="6510528"/>
-            <a:ext cx="77724" cy="77724"/>
-          </a:xfrm>
-          <a:prstGeom prst="ellipse">
-            <a:avLst/>
-          </a:prstGeom>
-          <a:solidFill>
-            <a:srgbClr val="2FDFE5"/>
-          </a:solidFill>
-          <a:ln>
-            <a:noFill/>
-          </a:ln>
-        </p:spPr>
-        <p:style>
-          <a:lnRef idx="1">
-            <a:schemeClr val="accent1"/>
-          </a:lnRef>
-          <a:fillRef idx="3">
-            <a:schemeClr val="accent1"/>
-          </a:fillRef>
-          <a:effectRef idx="2">
-            <a:schemeClr val="accent1"/>
-          </a:effectRef>
-          <a:fontRef idx="minor">
-            <a:schemeClr val="lt1"/>
-          </a:fontRef>
-        </p:style>
-        <p:txBody>
-          <a:bodyPr rtlCol="0" anchor="ctr"/>
-          <a:lstStyle/>
-          <a:p>
-            <a:pPr algn="ctr"/>
-          </a:p>
-        </p:txBody>
-      </p:sp>
-      <p:sp>
-        <p:nvSpPr>
-          <p:cNvPr id="14" name="Oval 13"/>
-          <p:cNvSpPr/>
-          <p:nvPr/>
-        </p:nvSpPr>
-        <p:spPr>
-          <a:xfrm>
-            <a:off x="6559905" y="6510528"/>
-            <a:ext cx="77724" cy="77724"/>
-          </a:xfrm>
-          <a:prstGeom prst="ellipse">
-            <a:avLst/>
-          </a:prstGeom>
-          <a:noFill/>
-          <a:ln w="10160">
-            <a:solidFill>
-              <a:srgbClr val="13B9BF"/>
-            </a:solidFill>
-          </a:ln>
-        </p:spPr>
-        <p:style>
-          <a:lnRef idx="1">
-            <a:schemeClr val="accent1"/>
-          </a:lnRef>
-          <a:fillRef idx="3">
-            <a:schemeClr val="accent1"/>
-          </a:fillRef>
-          <a:effectRef idx="2">
-            <a:schemeClr val="accent1"/>
-          </a:effectRef>
-          <a:fontRef idx="minor">
-            <a:schemeClr val="lt1"/>
-          </a:fontRef>
-        </p:style>
-        <p:txBody>
-          <a:bodyPr rtlCol="0" anchor="ctr"/>
-          <a:lstStyle/>
-          <a:p>
-            <a:pPr algn="ctr"/>
-          </a:p>
-        </p:txBody>
-      </p:sp>
-      <p:sp>
-        <p:nvSpPr>
-          <p:cNvPr id="15" name="Rectangle 14"/>
+      <p:sp>
+        <p:nvSpPr>
+          <p:cNvPr id="9" name="Rectangle 8"/>
           <p:cNvSpPr/>
           <p:nvPr/>
         </p:nvSpPr>
@@ -8617,7 +6989,7 @@
       </p:sp>
       <p:sp>
         <p:nvSpPr>
-          <p:cNvPr id="16" name="Rectangle 15"/>
+          <p:cNvPr id="10" name="Rectangle 9"/>
           <p:cNvSpPr/>
           <p:nvPr/>
         </p:nvSpPr>
@@ -8660,138 +7032,14 @@
       </p:sp>
       <p:sp>
         <p:nvSpPr>
-          <p:cNvPr id="17" name="Oval 16"/>
+          <p:cNvPr id="11" name="Oval 10"/>
           <p:cNvSpPr/>
           <p:nvPr/>
         </p:nvSpPr>
         <p:spPr>
           <a:xfrm>
-            <a:off x="704088" y="2450592"/>
-            <a:ext cx="329184" cy="329184"/>
-          </a:xfrm>
-          <a:prstGeom prst="ellipse">
-            <a:avLst/>
-          </a:prstGeom>
-          <a:solidFill>
-            <a:srgbClr val="13B9BF"/>
-          </a:solidFill>
-          <a:ln>
-            <a:noFill/>
-          </a:ln>
-        </p:spPr>
-        <p:style>
-          <a:lnRef idx="1">
-            <a:schemeClr val="accent1"/>
-          </a:lnRef>
-          <a:fillRef idx="3">
-            <a:schemeClr val="accent1"/>
-          </a:fillRef>
-          <a:effectRef idx="2">
-            <a:schemeClr val="accent1"/>
-          </a:effectRef>
-          <a:fontRef idx="minor">
-            <a:schemeClr val="lt1"/>
-          </a:fontRef>
-        </p:style>
-        <p:txBody>
-          <a:bodyPr rtlCol="0" anchor="ctr"/>
-          <a:lstStyle/>
-          <a:p>
-            <a:pPr algn="ctr"/>
-          </a:p>
-        </p:txBody>
-      </p:sp>
-      <p:sp>
-        <p:nvSpPr>
-          <p:cNvPr id="18" name="Oval 17"/>
-          <p:cNvSpPr/>
-          <p:nvPr/>
-        </p:nvSpPr>
-        <p:spPr>
-          <a:xfrm>
-            <a:off x="766632" y="2513136"/>
-            <a:ext cx="204094" cy="204094"/>
-          </a:xfrm>
-          <a:prstGeom prst="ellipse">
-            <a:avLst/>
-          </a:prstGeom>
-          <a:solidFill>
-            <a:srgbClr val="088A8F"/>
-          </a:solidFill>
-          <a:ln>
-            <a:noFill/>
-          </a:ln>
-        </p:spPr>
-        <p:style>
-          <a:lnRef idx="1">
-            <a:schemeClr val="accent1"/>
-          </a:lnRef>
-          <a:fillRef idx="3">
-            <a:schemeClr val="accent1"/>
-          </a:fillRef>
-          <a:effectRef idx="2">
-            <a:schemeClr val="accent1"/>
-          </a:effectRef>
-          <a:fontRef idx="minor">
-            <a:schemeClr val="lt1"/>
-          </a:fontRef>
-        </p:style>
-        <p:txBody>
-          <a:bodyPr rtlCol="0" anchor="ctr"/>
-          <a:lstStyle/>
-          <a:p>
-            <a:pPr algn="ctr"/>
-          </a:p>
-        </p:txBody>
-      </p:sp>
-      <p:sp>
-        <p:nvSpPr>
-          <p:cNvPr id="19" name="TextBox 18"/>
-          <p:cNvSpPr txBox="1"/>
-          <p:nvPr/>
-        </p:nvSpPr>
-        <p:spPr>
-          <a:xfrm>
-            <a:off x="704088" y="2450592"/>
-            <a:ext cx="329184" cy="329184"/>
-          </a:xfrm>
-          <a:prstGeom prst="rect">
-            <a:avLst/>
-          </a:prstGeom>
-          <a:noFill/>
-        </p:spPr>
-        <p:txBody lIns="0" tIns="0" rIns="0" bIns="0">
-          <a:bodyPr wrap="none">
-            <a:spAutoFit/>
-          </a:bodyPr>
-          <a:lstStyle/>
-          <a:p>
-            <a:pPr algn="ctr">
-              <a:spcBef>
-                <a:spcPts val="200"/>
-              </a:spcBef>
-            </a:pPr>
-            <a:r>
-              <a:rPr sz="1100" b="1">
-                <a:solidFill>
-                  <a:srgbClr val="FFFFFF"/>
-                </a:solidFill>
-              </a:rPr>
-              <a:t>▼</a:t>
-            </a:r>
-          </a:p>
-        </p:txBody>
-      </p:sp>
-      <p:sp>
-        <p:nvSpPr>
-          <p:cNvPr id="20" name="Oval 19"/>
-          <p:cNvSpPr/>
-          <p:nvPr/>
-        </p:nvSpPr>
-        <p:spPr>
-          <a:xfrm>
-            <a:off x="1124712" y="2487168"/>
-            <a:ext cx="201168" cy="201168"/>
+            <a:off x="704088" y="2468880"/>
+            <a:ext cx="274320" cy="274320"/>
           </a:xfrm>
           <a:prstGeom prst="ellipse">
             <a:avLst/>
@@ -8829,14 +7077,14 @@
       </p:sp>
       <p:sp>
         <p:nvSpPr>
-          <p:cNvPr id="21" name="TextBox 20"/>
+          <p:cNvPr id="12" name="TextBox 11"/>
           <p:cNvSpPr txBox="1"/>
           <p:nvPr/>
         </p:nvSpPr>
         <p:spPr>
           <a:xfrm>
-            <a:off x="1124712" y="2487168"/>
-            <a:ext cx="201168" cy="201168"/>
+            <a:off x="704088" y="2468880"/>
+            <a:ext cx="274320" cy="274320"/>
           </a:xfrm>
           <a:prstGeom prst="rect">
             <a:avLst/>
@@ -8863,14 +7111,14 @@
       </p:sp>
       <p:sp>
         <p:nvSpPr>
-          <p:cNvPr id="22" name="TextBox 21"/>
+          <p:cNvPr id="13" name="TextBox 12"/>
           <p:cNvSpPr txBox="1"/>
           <p:nvPr/>
         </p:nvSpPr>
         <p:spPr>
           <a:xfrm>
-            <a:off x="1161288" y="2450592"/>
-            <a:ext cx="4792827" cy="658368"/>
+            <a:off x="1088136" y="2468880"/>
+            <a:ext cx="4792827" cy="566928"/>
           </a:xfrm>
           <a:prstGeom prst="rect">
             <a:avLst/>
@@ -8897,13 +7145,13 @@
       </p:sp>
       <p:sp>
         <p:nvSpPr>
-          <p:cNvPr id="23" name="Rectangle 22"/>
+          <p:cNvPr id="14" name="Rectangle 13"/>
           <p:cNvSpPr/>
           <p:nvPr/>
         </p:nvSpPr>
         <p:spPr>
           <a:xfrm>
-            <a:off x="667512" y="2907792"/>
+            <a:off x="667512" y="2852928"/>
             <a:ext cx="5250027" cy="15240"/>
           </a:xfrm>
           <a:prstGeom prst="rect">
@@ -8940,14 +7188,14 @@
       </p:sp>
       <p:sp>
         <p:nvSpPr>
-          <p:cNvPr id="24" name="TextBox 23"/>
+          <p:cNvPr id="15" name="TextBox 14"/>
           <p:cNvSpPr txBox="1"/>
           <p:nvPr/>
         </p:nvSpPr>
         <p:spPr>
           <a:xfrm>
-            <a:off x="667512" y="2996692"/>
-            <a:ext cx="5250027" cy="2959608"/>
+            <a:off x="667512" y="2941828"/>
+            <a:ext cx="5250027" cy="3014472"/>
           </a:xfrm>
           <a:prstGeom prst="rect">
             <a:avLst/>
@@ -9032,7 +7280,7 @@
       </p:sp>
       <p:sp>
         <p:nvSpPr>
-          <p:cNvPr id="25" name="Rectangle 24"/>
+          <p:cNvPr id="16" name="Rectangle 15"/>
           <p:cNvSpPr/>
           <p:nvPr/>
         </p:nvSpPr>
@@ -9077,7 +7325,7 @@
       </p:sp>
       <p:sp>
         <p:nvSpPr>
-          <p:cNvPr id="26" name="Rectangle 25"/>
+          <p:cNvPr id="17" name="Rectangle 16"/>
           <p:cNvSpPr/>
           <p:nvPr/>
         </p:nvSpPr>
@@ -9120,138 +7368,14 @@
       </p:sp>
       <p:sp>
         <p:nvSpPr>
-          <p:cNvPr id="27" name="Oval 26"/>
+          <p:cNvPr id="18" name="Oval 17"/>
           <p:cNvSpPr/>
           <p:nvPr/>
         </p:nvSpPr>
         <p:spPr>
           <a:xfrm>
-            <a:off x="6484467" y="2450592"/>
-            <a:ext cx="329184" cy="329184"/>
-          </a:xfrm>
-          <a:prstGeom prst="ellipse">
-            <a:avLst/>
-          </a:prstGeom>
-          <a:solidFill>
-            <a:srgbClr val="13B9BF"/>
-          </a:solidFill>
-          <a:ln>
-            <a:noFill/>
-          </a:ln>
-        </p:spPr>
-        <p:style>
-          <a:lnRef idx="1">
-            <a:schemeClr val="accent1"/>
-          </a:lnRef>
-          <a:fillRef idx="3">
-            <a:schemeClr val="accent1"/>
-          </a:fillRef>
-          <a:effectRef idx="2">
-            <a:schemeClr val="accent1"/>
-          </a:effectRef>
-          <a:fontRef idx="minor">
-            <a:schemeClr val="lt1"/>
-          </a:fontRef>
-        </p:style>
-        <p:txBody>
-          <a:bodyPr rtlCol="0" anchor="ctr"/>
-          <a:lstStyle/>
-          <a:p>
-            <a:pPr algn="ctr"/>
-          </a:p>
-        </p:txBody>
-      </p:sp>
-      <p:sp>
-        <p:nvSpPr>
-          <p:cNvPr id="28" name="Oval 27"/>
-          <p:cNvSpPr/>
-          <p:nvPr/>
-        </p:nvSpPr>
-        <p:spPr>
-          <a:xfrm>
-            <a:off x="6547012" y="2513136"/>
-            <a:ext cx="204094" cy="204094"/>
-          </a:xfrm>
-          <a:prstGeom prst="ellipse">
-            <a:avLst/>
-          </a:prstGeom>
-          <a:solidFill>
-            <a:srgbClr val="088A8F"/>
-          </a:solidFill>
-          <a:ln>
-            <a:noFill/>
-          </a:ln>
-        </p:spPr>
-        <p:style>
-          <a:lnRef idx="1">
-            <a:schemeClr val="accent1"/>
-          </a:lnRef>
-          <a:fillRef idx="3">
-            <a:schemeClr val="accent1"/>
-          </a:fillRef>
-          <a:effectRef idx="2">
-            <a:schemeClr val="accent1"/>
-          </a:effectRef>
-          <a:fontRef idx="minor">
-            <a:schemeClr val="lt1"/>
-          </a:fontRef>
-        </p:style>
-        <p:txBody>
-          <a:bodyPr rtlCol="0" anchor="ctr"/>
-          <a:lstStyle/>
-          <a:p>
-            <a:pPr algn="ctr"/>
-          </a:p>
-        </p:txBody>
-      </p:sp>
-      <p:sp>
-        <p:nvSpPr>
-          <p:cNvPr id="29" name="TextBox 28"/>
-          <p:cNvSpPr txBox="1"/>
-          <p:nvPr/>
-        </p:nvSpPr>
-        <p:spPr>
-          <a:xfrm>
-            <a:off x="6484467" y="2450592"/>
-            <a:ext cx="329184" cy="329184"/>
-          </a:xfrm>
-          <a:prstGeom prst="rect">
-            <a:avLst/>
-          </a:prstGeom>
-          <a:noFill/>
-        </p:spPr>
-        <p:txBody lIns="0" tIns="0" rIns="0" bIns="0">
-          <a:bodyPr wrap="none">
-            <a:spAutoFit/>
-          </a:bodyPr>
-          <a:lstStyle/>
-          <a:p>
-            <a:pPr algn="ctr">
-              <a:spcBef>
-                <a:spcPts val="200"/>
-              </a:spcBef>
-            </a:pPr>
-            <a:r>
-              <a:rPr sz="1100" b="1">
-                <a:solidFill>
-                  <a:srgbClr val="FFFFFF"/>
-                </a:solidFill>
-              </a:rPr>
-              <a:t>◆</a:t>
-            </a:r>
-          </a:p>
-        </p:txBody>
-      </p:sp>
-      <p:sp>
-        <p:nvSpPr>
-          <p:cNvPr id="30" name="Oval 29"/>
-          <p:cNvSpPr/>
-          <p:nvPr/>
-        </p:nvSpPr>
-        <p:spPr>
-          <a:xfrm>
-            <a:off x="6905091" y="2487168"/>
-            <a:ext cx="201168" cy="201168"/>
+            <a:off x="6484467" y="2468880"/>
+            <a:ext cx="274320" cy="274320"/>
           </a:xfrm>
           <a:prstGeom prst="ellipse">
             <a:avLst/>
@@ -9289,14 +7413,14 @@
       </p:sp>
       <p:sp>
         <p:nvSpPr>
-          <p:cNvPr id="31" name="TextBox 30"/>
+          <p:cNvPr id="19" name="TextBox 18"/>
           <p:cNvSpPr txBox="1"/>
           <p:nvPr/>
         </p:nvSpPr>
         <p:spPr>
           <a:xfrm>
-            <a:off x="6905091" y="2487168"/>
-            <a:ext cx="201168" cy="201168"/>
+            <a:off x="6484467" y="2468880"/>
+            <a:ext cx="274320" cy="274320"/>
           </a:xfrm>
           <a:prstGeom prst="rect">
             <a:avLst/>
@@ -9323,14 +7447,14 @@
       </p:sp>
       <p:sp>
         <p:nvSpPr>
-          <p:cNvPr id="32" name="TextBox 31"/>
+          <p:cNvPr id="20" name="TextBox 19"/>
           <p:cNvSpPr txBox="1"/>
           <p:nvPr/>
         </p:nvSpPr>
         <p:spPr>
           <a:xfrm>
-            <a:off x="6941667" y="2450592"/>
-            <a:ext cx="4792827" cy="658368"/>
+            <a:off x="6868515" y="2468880"/>
+            <a:ext cx="4792827" cy="566928"/>
           </a:xfrm>
           <a:prstGeom prst="rect">
             <a:avLst/>
@@ -9357,13 +7481,13 @@
       </p:sp>
       <p:sp>
         <p:nvSpPr>
-          <p:cNvPr id="33" name="Rectangle 32"/>
+          <p:cNvPr id="21" name="Rectangle 20"/>
           <p:cNvSpPr/>
           <p:nvPr/>
         </p:nvSpPr>
         <p:spPr>
           <a:xfrm>
-            <a:off x="6447891" y="2907792"/>
+            <a:off x="6447891" y="2852928"/>
             <a:ext cx="5250027" cy="15240"/>
           </a:xfrm>
           <a:prstGeom prst="rect">
@@ -9400,14 +7524,14 @@
       </p:sp>
       <p:sp>
         <p:nvSpPr>
-          <p:cNvPr id="34" name="TextBox 33"/>
+          <p:cNvPr id="22" name="TextBox 21"/>
           <p:cNvSpPr txBox="1"/>
           <p:nvPr/>
         </p:nvSpPr>
         <p:spPr>
           <a:xfrm>
-            <a:off x="6447891" y="2996692"/>
-            <a:ext cx="5250027" cy="2959608"/>
+            <a:off x="6447891" y="2941828"/>
+            <a:ext cx="5250027" cy="3014472"/>
           </a:xfrm>
           <a:prstGeom prst="rect">
             <a:avLst/>
@@ -9490,6 +7614,30 @@
           </a:p>
         </p:txBody>
       </p:sp>
+      <p:pic>
+        <p:nvPicPr>
+          <p:cNvPr id="23" name="Picture 22" descr="logo_horiz.png"/>
+          <p:cNvPicPr>
+            <a:picLocks noChangeAspect="1"/>
+          </p:cNvPicPr>
+          <p:nvPr/>
+        </p:nvPicPr>
+        <p:blipFill>
+          <a:blip r:embed="rId3"/>
+          <a:stretch>
+            <a:fillRect/>
+          </a:stretch>
+        </p:blipFill>
+        <p:spPr>
+          <a:xfrm>
+            <a:off x="10024567" y="6062197"/>
+            <a:ext cx="1965960" cy="631211"/>
+          </a:xfrm>
+          <a:prstGeom prst="rect">
+            <a:avLst/>
+          </a:prstGeom>
+        </p:spPr>
+      </p:pic>
     </p:spTree>
   </p:cSld>
   <p:clrMapOvr>
@@ -9519,7 +7667,7 @@
                                 <p:cBhvr>
                                   <p:cTn id="6" dur="450" fill="hold"/>
                                   <p:tgtEl>
-                                    <p:spTgt spid="15"/>
+                                    <p:spTgt spid="9"/>
                                   </p:tgtEl>
                                 </p:cBhvr>
                               </p:animEffect>
@@ -9536,7 +7684,7 @@
                                 <p:cBhvr>
                                   <p:cTn id="8" dur="450" fill="hold"/>
                                   <p:tgtEl>
-                                    <p:spTgt spid="25"/>
+                                    <p:spTgt spid="16"/>
                                   </p:tgtEl>
                                 </p:cBhvr>
                               </p:animEffect>
@@ -9822,248 +7970,9 @@
           </a:p>
         </p:txBody>
       </p:sp>
-      <p:pic>
-        <p:nvPicPr>
-          <p:cNvPr id="8" name="Picture 7" descr="logo_horiz.png"/>
-          <p:cNvPicPr>
-            <a:picLocks noChangeAspect="1"/>
-          </p:cNvPicPr>
-          <p:nvPr/>
-        </p:nvPicPr>
-        <p:blipFill>
-          <a:blip r:embed="rId3"/>
-          <a:stretch>
-            <a:fillRect/>
-          </a:stretch>
-        </p:blipFill>
-        <p:spPr>
-          <a:xfrm>
-            <a:off x="10024567" y="6062197"/>
-            <a:ext cx="1965960" cy="631211"/>
-          </a:xfrm>
-          <a:prstGeom prst="rect">
-            <a:avLst/>
-          </a:prstGeom>
-        </p:spPr>
-      </p:pic>
-      <p:sp>
-        <p:nvSpPr>
-          <p:cNvPr id="9" name="Oval 8"/>
-          <p:cNvSpPr/>
-          <p:nvPr/>
-        </p:nvSpPr>
-        <p:spPr>
-          <a:xfrm>
-            <a:off x="5554065" y="6510528"/>
-            <a:ext cx="77724" cy="77724"/>
-          </a:xfrm>
-          <a:prstGeom prst="ellipse">
-            <a:avLst/>
-          </a:prstGeom>
-          <a:noFill/>
-          <a:ln w="10160">
-            <a:solidFill>
-              <a:srgbClr val="13B9BF"/>
-            </a:solidFill>
-          </a:ln>
-        </p:spPr>
-        <p:style>
-          <a:lnRef idx="1">
-            <a:schemeClr val="accent1"/>
-          </a:lnRef>
-          <a:fillRef idx="3">
-            <a:schemeClr val="accent1"/>
-          </a:fillRef>
-          <a:effectRef idx="2">
-            <a:schemeClr val="accent1"/>
-          </a:effectRef>
-          <a:fontRef idx="minor">
-            <a:schemeClr val="lt1"/>
-          </a:fontRef>
-        </p:style>
-        <p:txBody>
-          <a:bodyPr rtlCol="0" anchor="ctr"/>
-          <a:lstStyle/>
-          <a:p>
-            <a:pPr algn="ctr"/>
-          </a:p>
-        </p:txBody>
-      </p:sp>
-      <p:sp>
-        <p:nvSpPr>
-          <p:cNvPr id="10" name="Oval 9"/>
-          <p:cNvSpPr/>
-          <p:nvPr/>
-        </p:nvSpPr>
-        <p:spPr>
-          <a:xfrm>
-            <a:off x="5805525" y="6510528"/>
-            <a:ext cx="77724" cy="77724"/>
-          </a:xfrm>
-          <a:prstGeom prst="ellipse">
-            <a:avLst/>
-          </a:prstGeom>
-          <a:noFill/>
-          <a:ln w="10160">
-            <a:solidFill>
-              <a:srgbClr val="13B9BF"/>
-            </a:solidFill>
-          </a:ln>
-        </p:spPr>
-        <p:style>
-          <a:lnRef idx="1">
-            <a:schemeClr val="accent1"/>
-          </a:lnRef>
-          <a:fillRef idx="3">
-            <a:schemeClr val="accent1"/>
-          </a:fillRef>
-          <a:effectRef idx="2">
-            <a:schemeClr val="accent1"/>
-          </a:effectRef>
-          <a:fontRef idx="minor">
-            <a:schemeClr val="lt1"/>
-          </a:fontRef>
-        </p:style>
-        <p:txBody>
-          <a:bodyPr rtlCol="0" anchor="ctr"/>
-          <a:lstStyle/>
-          <a:p>
-            <a:pPr algn="ctr"/>
-          </a:p>
-        </p:txBody>
-      </p:sp>
-      <p:sp>
-        <p:nvSpPr>
-          <p:cNvPr id="11" name="Oval 10"/>
-          <p:cNvSpPr/>
-          <p:nvPr/>
-        </p:nvSpPr>
-        <p:spPr>
-          <a:xfrm>
-            <a:off x="6056985" y="6510528"/>
-            <a:ext cx="77724" cy="77724"/>
-          </a:xfrm>
-          <a:prstGeom prst="ellipse">
-            <a:avLst/>
-          </a:prstGeom>
-          <a:noFill/>
-          <a:ln w="10160">
-            <a:solidFill>
-              <a:srgbClr val="13B9BF"/>
-            </a:solidFill>
-          </a:ln>
-        </p:spPr>
-        <p:style>
-          <a:lnRef idx="1">
-            <a:schemeClr val="accent1"/>
-          </a:lnRef>
-          <a:fillRef idx="3">
-            <a:schemeClr val="accent1"/>
-          </a:fillRef>
-          <a:effectRef idx="2">
-            <a:schemeClr val="accent1"/>
-          </a:effectRef>
-          <a:fontRef idx="minor">
-            <a:schemeClr val="lt1"/>
-          </a:fontRef>
-        </p:style>
-        <p:txBody>
-          <a:bodyPr rtlCol="0" anchor="ctr"/>
-          <a:lstStyle/>
-          <a:p>
-            <a:pPr algn="ctr"/>
-          </a:p>
-        </p:txBody>
-      </p:sp>
-      <p:sp>
-        <p:nvSpPr>
-          <p:cNvPr id="12" name="Oval 11"/>
-          <p:cNvSpPr/>
-          <p:nvPr/>
-        </p:nvSpPr>
-        <p:spPr>
-          <a:xfrm>
-            <a:off x="6308445" y="6510528"/>
-            <a:ext cx="77724" cy="77724"/>
-          </a:xfrm>
-          <a:prstGeom prst="ellipse">
-            <a:avLst/>
-          </a:prstGeom>
-          <a:noFill/>
-          <a:ln w="10160">
-            <a:solidFill>
-              <a:srgbClr val="13B9BF"/>
-            </a:solidFill>
-          </a:ln>
-        </p:spPr>
-        <p:style>
-          <a:lnRef idx="1">
-            <a:schemeClr val="accent1"/>
-          </a:lnRef>
-          <a:fillRef idx="3">
-            <a:schemeClr val="accent1"/>
-          </a:fillRef>
-          <a:effectRef idx="2">
-            <a:schemeClr val="accent1"/>
-          </a:effectRef>
-          <a:fontRef idx="minor">
-            <a:schemeClr val="lt1"/>
-          </a:fontRef>
-        </p:style>
-        <p:txBody>
-          <a:bodyPr rtlCol="0" anchor="ctr"/>
-          <a:lstStyle/>
-          <a:p>
-            <a:pPr algn="ctr"/>
-          </a:p>
-        </p:txBody>
-      </p:sp>
-      <p:sp>
-        <p:nvSpPr>
-          <p:cNvPr id="13" name="Oval 12"/>
-          <p:cNvSpPr/>
-          <p:nvPr/>
-        </p:nvSpPr>
-        <p:spPr>
-          <a:xfrm>
-            <a:off x="6559905" y="6510528"/>
-            <a:ext cx="77724" cy="77724"/>
-          </a:xfrm>
-          <a:prstGeom prst="ellipse">
-            <a:avLst/>
-          </a:prstGeom>
-          <a:solidFill>
-            <a:srgbClr val="2FDFE5"/>
-          </a:solidFill>
-          <a:ln>
-            <a:noFill/>
-          </a:ln>
-        </p:spPr>
-        <p:style>
-          <a:lnRef idx="1">
-            <a:schemeClr val="accent1"/>
-          </a:lnRef>
-          <a:fillRef idx="3">
-            <a:schemeClr val="accent1"/>
-          </a:fillRef>
-          <a:effectRef idx="2">
-            <a:schemeClr val="accent1"/>
-          </a:effectRef>
-          <a:fontRef idx="minor">
-            <a:schemeClr val="lt1"/>
-          </a:fontRef>
-        </p:style>
-        <p:txBody>
-          <a:bodyPr rtlCol="0" anchor="ctr"/>
-          <a:lstStyle/>
-          <a:p>
-            <a:pPr algn="ctr"/>
-          </a:p>
-        </p:txBody>
-      </p:sp>
-      <p:sp>
-        <p:nvSpPr>
-          <p:cNvPr id="14" name="Rectangle 13"/>
+      <p:sp>
+        <p:nvSpPr>
+          <p:cNvPr id="8" name="Rectangle 7"/>
           <p:cNvSpPr/>
           <p:nvPr/>
         </p:nvSpPr>
@@ -10108,7 +8017,7 @@
       </p:sp>
       <p:sp>
         <p:nvSpPr>
-          <p:cNvPr id="15" name="Rectangle 14"/>
+          <p:cNvPr id="9" name="Rectangle 8"/>
           <p:cNvSpPr/>
           <p:nvPr/>
         </p:nvSpPr>
@@ -10151,16 +8060,129 @@
       </p:sp>
       <p:sp>
         <p:nvSpPr>
-          <p:cNvPr id="16" name="Oval 15"/>
+          <p:cNvPr id="10" name="Oval 9"/>
           <p:cNvSpPr/>
           <p:nvPr/>
         </p:nvSpPr>
         <p:spPr>
           <a:xfrm>
             <a:off x="685800" y="2084832"/>
-            <a:ext cx="292608" cy="292608"/>
+            <a:ext cx="256032" cy="256032"/>
           </a:xfrm>
           <a:prstGeom prst="ellipse">
+            <a:avLst/>
+          </a:prstGeom>
+          <a:solidFill>
+            <a:srgbClr val="0A1638"/>
+          </a:solidFill>
+          <a:ln w="15240">
+            <a:solidFill>
+              <a:srgbClr val="2FDFE5"/>
+            </a:solidFill>
+          </a:ln>
+        </p:spPr>
+        <p:style>
+          <a:lnRef idx="1">
+            <a:schemeClr val="accent1"/>
+          </a:lnRef>
+          <a:fillRef idx="3">
+            <a:schemeClr val="accent1"/>
+          </a:fillRef>
+          <a:effectRef idx="2">
+            <a:schemeClr val="accent1"/>
+          </a:effectRef>
+          <a:fontRef idx="minor">
+            <a:schemeClr val="lt1"/>
+          </a:fontRef>
+        </p:style>
+        <p:txBody>
+          <a:bodyPr rtlCol="0" anchor="ctr"/>
+          <a:lstStyle/>
+          <a:p>
+            <a:pPr algn="ctr"/>
+          </a:p>
+        </p:txBody>
+      </p:sp>
+      <p:sp>
+        <p:nvSpPr>
+          <p:cNvPr id="11" name="TextBox 10"/>
+          <p:cNvSpPr txBox="1"/>
+          <p:nvPr/>
+        </p:nvSpPr>
+        <p:spPr>
+          <a:xfrm>
+            <a:off x="685800" y="2084832"/>
+            <a:ext cx="256032" cy="256032"/>
+          </a:xfrm>
+          <a:prstGeom prst="rect">
+            <a:avLst/>
+          </a:prstGeom>
+          <a:noFill/>
+        </p:spPr>
+        <p:txBody lIns="0" tIns="12700" rIns="0" bIns="0">
+          <a:bodyPr wrap="none">
+            <a:spAutoFit/>
+          </a:bodyPr>
+          <a:lstStyle/>
+          <a:p>
+            <a:pPr algn="ctr"/>
+            <a:r>
+              <a:rPr sz="1100" b="1">
+                <a:solidFill>
+                  <a:srgbClr val="2FDFE5"/>
+                </a:solidFill>
+              </a:rPr>
+              <a:t>1</a:t>
+            </a:r>
+          </a:p>
+        </p:txBody>
+      </p:sp>
+      <p:sp>
+        <p:nvSpPr>
+          <p:cNvPr id="12" name="TextBox 11"/>
+          <p:cNvSpPr txBox="1"/>
+          <p:nvPr/>
+        </p:nvSpPr>
+        <p:spPr>
+          <a:xfrm>
+            <a:off x="1051560" y="2084832"/>
+            <a:ext cx="4865979" cy="512064"/>
+          </a:xfrm>
+          <a:prstGeom prst="rect">
+            <a:avLst/>
+          </a:prstGeom>
+          <a:noFill/>
+        </p:spPr>
+        <p:txBody lIns="38100" tIns="25400" rIns="38100" bIns="25400">
+          <a:bodyPr wrap="square">
+            <a:spAutoFit/>
+          </a:bodyPr>
+          <a:lstStyle/>
+          <a:p>
+            <a:pPr algn="l"/>
+            <a:r>
+              <a:rPr sz="1400" b="1">
+                <a:solidFill>
+                  <a:srgbClr val="FFFFFF"/>
+                </a:solidFill>
+              </a:rPr>
+              <a:t>Vía monitoria</a:t>
+            </a:r>
+          </a:p>
+        </p:txBody>
+      </p:sp>
+      <p:sp>
+        <p:nvSpPr>
+          <p:cNvPr id="13" name="Rectangle 12"/>
+          <p:cNvSpPr/>
+          <p:nvPr/>
+        </p:nvSpPr>
+        <p:spPr>
+          <a:xfrm>
+            <a:off x="649224" y="2450592"/>
+            <a:ext cx="5286603" cy="12700"/>
+          </a:xfrm>
+          <a:prstGeom prst="rect">
             <a:avLst/>
           </a:prstGeom>
           <a:solidFill>
@@ -10194,172 +8216,14 @@
       </p:sp>
       <p:sp>
         <p:nvSpPr>
-          <p:cNvPr id="17" name="Oval 16"/>
-          <p:cNvSpPr/>
-          <p:nvPr/>
-        </p:nvSpPr>
-        <p:spPr>
-          <a:xfrm>
-            <a:off x="741395" y="2140427"/>
-            <a:ext cx="181416" cy="181416"/>
-          </a:xfrm>
-          <a:prstGeom prst="ellipse">
-            <a:avLst/>
-          </a:prstGeom>
-          <a:solidFill>
-            <a:srgbClr val="088A8F"/>
-          </a:solidFill>
-          <a:ln>
-            <a:noFill/>
-          </a:ln>
-        </p:spPr>
-        <p:style>
-          <a:lnRef idx="1">
-            <a:schemeClr val="accent1"/>
-          </a:lnRef>
-          <a:fillRef idx="3">
-            <a:schemeClr val="accent1"/>
-          </a:fillRef>
-          <a:effectRef idx="2">
-            <a:schemeClr val="accent1"/>
-          </a:effectRef>
-          <a:fontRef idx="minor">
-            <a:schemeClr val="lt1"/>
-          </a:fontRef>
-        </p:style>
-        <p:txBody>
-          <a:bodyPr rtlCol="0" anchor="ctr"/>
-          <a:lstStyle/>
-          <a:p>
-            <a:pPr algn="ctr"/>
-          </a:p>
-        </p:txBody>
-      </p:sp>
-      <p:sp>
-        <p:nvSpPr>
-          <p:cNvPr id="18" name="TextBox 17"/>
+          <p:cNvPr id="14" name="TextBox 13"/>
           <p:cNvSpPr txBox="1"/>
           <p:nvPr/>
         </p:nvSpPr>
         <p:spPr>
           <a:xfrm>
-            <a:off x="685800" y="2084832"/>
-            <a:ext cx="292608" cy="292608"/>
-          </a:xfrm>
-          <a:prstGeom prst="rect">
-            <a:avLst/>
-          </a:prstGeom>
-          <a:noFill/>
-        </p:spPr>
-        <p:txBody lIns="0" tIns="0" rIns="0" bIns="0">
-          <a:bodyPr wrap="none">
-            <a:spAutoFit/>
-          </a:bodyPr>
-          <a:lstStyle/>
-          <a:p>
-            <a:pPr algn="ctr">
-              <a:spcBef>
-                <a:spcPts val="200"/>
-              </a:spcBef>
-            </a:pPr>
-            <a:r>
-              <a:rPr sz="1100" b="1">
-                <a:solidFill>
-                  <a:srgbClr val="FFFFFF"/>
-                </a:solidFill>
-              </a:rPr>
-              <a:t>▼</a:t>
-            </a:r>
-          </a:p>
-        </p:txBody>
-      </p:sp>
-      <p:sp>
-        <p:nvSpPr>
-          <p:cNvPr id="19" name="TextBox 18"/>
-          <p:cNvSpPr txBox="1"/>
-          <p:nvPr/>
-        </p:nvSpPr>
-        <p:spPr>
-          <a:xfrm>
-            <a:off x="1088136" y="2084832"/>
-            <a:ext cx="4884267" cy="566928"/>
-          </a:xfrm>
-          <a:prstGeom prst="rect">
-            <a:avLst/>
-          </a:prstGeom>
-          <a:noFill/>
-        </p:spPr>
-        <p:txBody lIns="38100" tIns="25400" rIns="38100" bIns="25400">
-          <a:bodyPr wrap="square">
-            <a:spAutoFit/>
-          </a:bodyPr>
-          <a:lstStyle/>
-          <a:p>
-            <a:pPr algn="l"/>
-            <a:r>
-              <a:rPr sz="1400" b="1">
-                <a:solidFill>
-                  <a:srgbClr val="FFFFFF"/>
-                </a:solidFill>
-              </a:rPr>
-              <a:t>Vía monitoria</a:t>
-            </a:r>
-          </a:p>
-        </p:txBody>
-      </p:sp>
-      <p:sp>
-        <p:nvSpPr>
-          <p:cNvPr id="20" name="Rectangle 19"/>
-          <p:cNvSpPr/>
-          <p:nvPr/>
-        </p:nvSpPr>
-        <p:spPr>
-          <a:xfrm>
-            <a:off x="649224" y="2487168"/>
-            <a:ext cx="5286603" cy="12700"/>
-          </a:xfrm>
-          <a:prstGeom prst="rect">
-            <a:avLst/>
-          </a:prstGeom>
-          <a:solidFill>
-            <a:srgbClr val="13B9BF"/>
-          </a:solidFill>
-          <a:ln>
-            <a:noFill/>
-          </a:ln>
-        </p:spPr>
-        <p:style>
-          <a:lnRef idx="1">
-            <a:schemeClr val="accent1"/>
-          </a:lnRef>
-          <a:fillRef idx="3">
-            <a:schemeClr val="accent1"/>
-          </a:fillRef>
-          <a:effectRef idx="2">
-            <a:schemeClr val="accent1"/>
-          </a:effectRef>
-          <a:fontRef idx="minor">
-            <a:schemeClr val="lt1"/>
-          </a:fontRef>
-        </p:style>
-        <p:txBody>
-          <a:bodyPr rtlCol="0" anchor="ctr"/>
-          <a:lstStyle/>
-          <a:p>
-            <a:pPr algn="ctr"/>
-          </a:p>
-        </p:txBody>
-      </p:sp>
-      <p:sp>
-        <p:nvSpPr>
-          <p:cNvPr id="21" name="TextBox 20"/>
-          <p:cNvSpPr txBox="1"/>
-          <p:nvPr/>
-        </p:nvSpPr>
-        <p:spPr>
-          <a:xfrm>
-            <a:off x="649224" y="2563368"/>
-            <a:ext cx="5286603" cy="1271524"/>
+            <a:off x="649224" y="2526792"/>
+            <a:ext cx="5286603" cy="1308100"/>
           </a:xfrm>
           <a:prstGeom prst="rect">
             <a:avLst/>
@@ -10386,7 +8250,7 @@
       </p:sp>
       <p:sp>
         <p:nvSpPr>
-          <p:cNvPr id="22" name="Rectangle 21"/>
+          <p:cNvPr id="15" name="Rectangle 14"/>
           <p:cNvSpPr/>
           <p:nvPr/>
         </p:nvSpPr>
@@ -10431,7 +8295,7 @@
       </p:sp>
       <p:sp>
         <p:nvSpPr>
-          <p:cNvPr id="23" name="Rectangle 22"/>
+          <p:cNvPr id="16" name="Rectangle 15"/>
           <p:cNvSpPr/>
           <p:nvPr/>
         </p:nvSpPr>
@@ -10474,16 +8338,129 @@
       </p:sp>
       <p:sp>
         <p:nvSpPr>
-          <p:cNvPr id="24" name="Oval 23"/>
+          <p:cNvPr id="17" name="Oval 16"/>
           <p:cNvSpPr/>
           <p:nvPr/>
         </p:nvSpPr>
         <p:spPr>
           <a:xfrm>
             <a:off x="6466179" y="2084832"/>
-            <a:ext cx="292608" cy="292608"/>
+            <a:ext cx="256032" cy="256032"/>
           </a:xfrm>
           <a:prstGeom prst="ellipse">
+            <a:avLst/>
+          </a:prstGeom>
+          <a:solidFill>
+            <a:srgbClr val="0A1638"/>
+          </a:solidFill>
+          <a:ln w="15240">
+            <a:solidFill>
+              <a:srgbClr val="2FDFE5"/>
+            </a:solidFill>
+          </a:ln>
+        </p:spPr>
+        <p:style>
+          <a:lnRef idx="1">
+            <a:schemeClr val="accent1"/>
+          </a:lnRef>
+          <a:fillRef idx="3">
+            <a:schemeClr val="accent1"/>
+          </a:fillRef>
+          <a:effectRef idx="2">
+            <a:schemeClr val="accent1"/>
+          </a:effectRef>
+          <a:fontRef idx="minor">
+            <a:schemeClr val="lt1"/>
+          </a:fontRef>
+        </p:style>
+        <p:txBody>
+          <a:bodyPr rtlCol="0" anchor="ctr"/>
+          <a:lstStyle/>
+          <a:p>
+            <a:pPr algn="ctr"/>
+          </a:p>
+        </p:txBody>
+      </p:sp>
+      <p:sp>
+        <p:nvSpPr>
+          <p:cNvPr id="18" name="TextBox 17"/>
+          <p:cNvSpPr txBox="1"/>
+          <p:nvPr/>
+        </p:nvSpPr>
+        <p:spPr>
+          <a:xfrm>
+            <a:off x="6466179" y="2084832"/>
+            <a:ext cx="256032" cy="256032"/>
+          </a:xfrm>
+          <a:prstGeom prst="rect">
+            <a:avLst/>
+          </a:prstGeom>
+          <a:noFill/>
+        </p:spPr>
+        <p:txBody lIns="0" tIns="12700" rIns="0" bIns="0">
+          <a:bodyPr wrap="none">
+            <a:spAutoFit/>
+          </a:bodyPr>
+          <a:lstStyle/>
+          <a:p>
+            <a:pPr algn="ctr"/>
+            <a:r>
+              <a:rPr sz="1100" b="1">
+                <a:solidFill>
+                  <a:srgbClr val="2FDFE5"/>
+                </a:solidFill>
+              </a:rPr>
+              <a:t>2</a:t>
+            </a:r>
+          </a:p>
+        </p:txBody>
+      </p:sp>
+      <p:sp>
+        <p:nvSpPr>
+          <p:cNvPr id="19" name="TextBox 18"/>
+          <p:cNvSpPr txBox="1"/>
+          <p:nvPr/>
+        </p:nvSpPr>
+        <p:spPr>
+          <a:xfrm>
+            <a:off x="6831939" y="2084832"/>
+            <a:ext cx="4865979" cy="512064"/>
+          </a:xfrm>
+          <a:prstGeom prst="rect">
+            <a:avLst/>
+          </a:prstGeom>
+          <a:noFill/>
+        </p:spPr>
+        <p:txBody lIns="38100" tIns="25400" rIns="38100" bIns="25400">
+          <a:bodyPr wrap="square">
+            <a:spAutoFit/>
+          </a:bodyPr>
+          <a:lstStyle/>
+          <a:p>
+            <a:pPr algn="l"/>
+            <a:r>
+              <a:rPr sz="1400" b="1">
+                <a:solidFill>
+                  <a:srgbClr val="FFFFFF"/>
+                </a:solidFill>
+              </a:rPr>
+              <a:t>Acción disuasoria</a:t>
+            </a:r>
+          </a:p>
+        </p:txBody>
+      </p:sp>
+      <p:sp>
+        <p:nvSpPr>
+          <p:cNvPr id="20" name="Rectangle 19"/>
+          <p:cNvSpPr/>
+          <p:nvPr/>
+        </p:nvSpPr>
+        <p:spPr>
+          <a:xfrm>
+            <a:off x="6429603" y="2450592"/>
+            <a:ext cx="5286603" cy="12700"/>
+          </a:xfrm>
+          <a:prstGeom prst="rect">
             <a:avLst/>
           </a:prstGeom>
           <a:solidFill>
@@ -10517,172 +8494,14 @@
       </p:sp>
       <p:sp>
         <p:nvSpPr>
-          <p:cNvPr id="25" name="Oval 24"/>
-          <p:cNvSpPr/>
-          <p:nvPr/>
-        </p:nvSpPr>
-        <p:spPr>
-          <a:xfrm>
-            <a:off x="6521775" y="2140427"/>
-            <a:ext cx="181416" cy="181416"/>
-          </a:xfrm>
-          <a:prstGeom prst="ellipse">
-            <a:avLst/>
-          </a:prstGeom>
-          <a:solidFill>
-            <a:srgbClr val="088A8F"/>
-          </a:solidFill>
-          <a:ln>
-            <a:noFill/>
-          </a:ln>
-        </p:spPr>
-        <p:style>
-          <a:lnRef idx="1">
-            <a:schemeClr val="accent1"/>
-          </a:lnRef>
-          <a:fillRef idx="3">
-            <a:schemeClr val="accent1"/>
-          </a:fillRef>
-          <a:effectRef idx="2">
-            <a:schemeClr val="accent1"/>
-          </a:effectRef>
-          <a:fontRef idx="minor">
-            <a:schemeClr val="lt1"/>
-          </a:fontRef>
-        </p:style>
-        <p:txBody>
-          <a:bodyPr rtlCol="0" anchor="ctr"/>
-          <a:lstStyle/>
-          <a:p>
-            <a:pPr algn="ctr"/>
-          </a:p>
-        </p:txBody>
-      </p:sp>
-      <p:sp>
-        <p:nvSpPr>
-          <p:cNvPr id="26" name="TextBox 25"/>
+          <p:cNvPr id="21" name="TextBox 20"/>
           <p:cNvSpPr txBox="1"/>
           <p:nvPr/>
         </p:nvSpPr>
         <p:spPr>
           <a:xfrm>
-            <a:off x="6466179" y="2084832"/>
-            <a:ext cx="292608" cy="292608"/>
-          </a:xfrm>
-          <a:prstGeom prst="rect">
-            <a:avLst/>
-          </a:prstGeom>
-          <a:noFill/>
-        </p:spPr>
-        <p:txBody lIns="0" tIns="0" rIns="0" bIns="0">
-          <a:bodyPr wrap="none">
-            <a:spAutoFit/>
-          </a:bodyPr>
-          <a:lstStyle/>
-          <a:p>
-            <a:pPr algn="ctr">
-              <a:spcBef>
-                <a:spcPts val="200"/>
-              </a:spcBef>
-            </a:pPr>
-            <a:r>
-              <a:rPr sz="1100" b="1">
-                <a:solidFill>
-                  <a:srgbClr val="FFFFFF"/>
-                </a:solidFill>
-              </a:rPr>
-              <a:t>◆</a:t>
-            </a:r>
-          </a:p>
-        </p:txBody>
-      </p:sp>
-      <p:sp>
-        <p:nvSpPr>
-          <p:cNvPr id="27" name="TextBox 26"/>
-          <p:cNvSpPr txBox="1"/>
-          <p:nvPr/>
-        </p:nvSpPr>
-        <p:spPr>
-          <a:xfrm>
-            <a:off x="6868515" y="2084832"/>
-            <a:ext cx="4884267" cy="566928"/>
-          </a:xfrm>
-          <a:prstGeom prst="rect">
-            <a:avLst/>
-          </a:prstGeom>
-          <a:noFill/>
-        </p:spPr>
-        <p:txBody lIns="38100" tIns="25400" rIns="38100" bIns="25400">
-          <a:bodyPr wrap="square">
-            <a:spAutoFit/>
-          </a:bodyPr>
-          <a:lstStyle/>
-          <a:p>
-            <a:pPr algn="l"/>
-            <a:r>
-              <a:rPr sz="1400" b="1">
-                <a:solidFill>
-                  <a:srgbClr val="FFFFFF"/>
-                </a:solidFill>
-              </a:rPr>
-              <a:t>Acción disuasoria</a:t>
-            </a:r>
-          </a:p>
-        </p:txBody>
-      </p:sp>
-      <p:sp>
-        <p:nvSpPr>
-          <p:cNvPr id="28" name="Rectangle 27"/>
-          <p:cNvSpPr/>
-          <p:nvPr/>
-        </p:nvSpPr>
-        <p:spPr>
-          <a:xfrm>
-            <a:off x="6429603" y="2487168"/>
-            <a:ext cx="5286603" cy="12700"/>
-          </a:xfrm>
-          <a:prstGeom prst="rect">
-            <a:avLst/>
-          </a:prstGeom>
-          <a:solidFill>
-            <a:srgbClr val="13B9BF"/>
-          </a:solidFill>
-          <a:ln>
-            <a:noFill/>
-          </a:ln>
-        </p:spPr>
-        <p:style>
-          <a:lnRef idx="1">
-            <a:schemeClr val="accent1"/>
-          </a:lnRef>
-          <a:fillRef idx="3">
-            <a:schemeClr val="accent1"/>
-          </a:fillRef>
-          <a:effectRef idx="2">
-            <a:schemeClr val="accent1"/>
-          </a:effectRef>
-          <a:fontRef idx="minor">
-            <a:schemeClr val="lt1"/>
-          </a:fontRef>
-        </p:style>
-        <p:txBody>
-          <a:bodyPr rtlCol="0" anchor="ctr"/>
-          <a:lstStyle/>
-          <a:p>
-            <a:pPr algn="ctr"/>
-          </a:p>
-        </p:txBody>
-      </p:sp>
-      <p:sp>
-        <p:nvSpPr>
-          <p:cNvPr id="29" name="TextBox 28"/>
-          <p:cNvSpPr txBox="1"/>
-          <p:nvPr/>
-        </p:nvSpPr>
-        <p:spPr>
-          <a:xfrm>
-            <a:off x="6429603" y="2563368"/>
-            <a:ext cx="5286603" cy="1271524"/>
+            <a:off x="6429603" y="2526792"/>
+            <a:ext cx="5286603" cy="1308100"/>
           </a:xfrm>
           <a:prstGeom prst="rect">
             <a:avLst/>
@@ -10709,7 +8528,7 @@
       </p:sp>
       <p:sp>
         <p:nvSpPr>
-          <p:cNvPr id="30" name="Rectangle 29"/>
+          <p:cNvPr id="22" name="Rectangle 21"/>
           <p:cNvSpPr/>
           <p:nvPr/>
         </p:nvSpPr>
@@ -10754,7 +8573,7 @@
       </p:sp>
       <p:sp>
         <p:nvSpPr>
-          <p:cNvPr id="31" name="Rectangle 30"/>
+          <p:cNvPr id="23" name="Rectangle 22"/>
           <p:cNvSpPr/>
           <p:nvPr/>
         </p:nvSpPr>
@@ -10797,16 +8616,129 @@
       </p:sp>
       <p:sp>
         <p:nvSpPr>
-          <p:cNvPr id="32" name="Oval 31"/>
+          <p:cNvPr id="24" name="Oval 23"/>
           <p:cNvSpPr/>
           <p:nvPr/>
         </p:nvSpPr>
         <p:spPr>
           <a:xfrm>
             <a:off x="685800" y="4224528"/>
-            <a:ext cx="292608" cy="292608"/>
+            <a:ext cx="256032" cy="256032"/>
           </a:xfrm>
           <a:prstGeom prst="ellipse">
+            <a:avLst/>
+          </a:prstGeom>
+          <a:solidFill>
+            <a:srgbClr val="0A1638"/>
+          </a:solidFill>
+          <a:ln w="15240">
+            <a:solidFill>
+              <a:srgbClr val="2FDFE5"/>
+            </a:solidFill>
+          </a:ln>
+        </p:spPr>
+        <p:style>
+          <a:lnRef idx="1">
+            <a:schemeClr val="accent1"/>
+          </a:lnRef>
+          <a:fillRef idx="3">
+            <a:schemeClr val="accent1"/>
+          </a:fillRef>
+          <a:effectRef idx="2">
+            <a:schemeClr val="accent1"/>
+          </a:effectRef>
+          <a:fontRef idx="minor">
+            <a:schemeClr val="lt1"/>
+          </a:fontRef>
+        </p:style>
+        <p:txBody>
+          <a:bodyPr rtlCol="0" anchor="ctr"/>
+          <a:lstStyle/>
+          <a:p>
+            <a:pPr algn="ctr"/>
+          </a:p>
+        </p:txBody>
+      </p:sp>
+      <p:sp>
+        <p:nvSpPr>
+          <p:cNvPr id="25" name="TextBox 24"/>
+          <p:cNvSpPr txBox="1"/>
+          <p:nvPr/>
+        </p:nvSpPr>
+        <p:spPr>
+          <a:xfrm>
+            <a:off x="685800" y="4224528"/>
+            <a:ext cx="256032" cy="256032"/>
+          </a:xfrm>
+          <a:prstGeom prst="rect">
+            <a:avLst/>
+          </a:prstGeom>
+          <a:noFill/>
+        </p:spPr>
+        <p:txBody lIns="0" tIns="12700" rIns="0" bIns="0">
+          <a:bodyPr wrap="none">
+            <a:spAutoFit/>
+          </a:bodyPr>
+          <a:lstStyle/>
+          <a:p>
+            <a:pPr algn="ctr"/>
+            <a:r>
+              <a:rPr sz="1100" b="1">
+                <a:solidFill>
+                  <a:srgbClr val="2FDFE5"/>
+                </a:solidFill>
+              </a:rPr>
+              <a:t>3</a:t>
+            </a:r>
+          </a:p>
+        </p:txBody>
+      </p:sp>
+      <p:sp>
+        <p:nvSpPr>
+          <p:cNvPr id="26" name="TextBox 25"/>
+          <p:cNvSpPr txBox="1"/>
+          <p:nvPr/>
+        </p:nvSpPr>
+        <p:spPr>
+          <a:xfrm>
+            <a:off x="1051560" y="4224528"/>
+            <a:ext cx="4865979" cy="512064"/>
+          </a:xfrm>
+          <a:prstGeom prst="rect">
+            <a:avLst/>
+          </a:prstGeom>
+          <a:noFill/>
+        </p:spPr>
+        <p:txBody lIns="38100" tIns="25400" rIns="38100" bIns="25400">
+          <a:bodyPr wrap="square">
+            <a:spAutoFit/>
+          </a:bodyPr>
+          <a:lstStyle/>
+          <a:p>
+            <a:pPr algn="l"/>
+            <a:r>
+              <a:rPr sz="1400" b="1">
+                <a:solidFill>
+                  <a:srgbClr val="FFFFFF"/>
+                </a:solidFill>
+              </a:rPr>
+              <a:t>Análisis de solvencia</a:t>
+            </a:r>
+          </a:p>
+        </p:txBody>
+      </p:sp>
+      <p:sp>
+        <p:nvSpPr>
+          <p:cNvPr id="27" name="Rectangle 26"/>
+          <p:cNvSpPr/>
+          <p:nvPr/>
+        </p:nvSpPr>
+        <p:spPr>
+          <a:xfrm>
+            <a:off x="649224" y="4590288"/>
+            <a:ext cx="5286603" cy="12700"/>
+          </a:xfrm>
+          <a:prstGeom prst="rect">
             <a:avLst/>
           </a:prstGeom>
           <a:solidFill>
@@ -10840,172 +8772,14 @@
       </p:sp>
       <p:sp>
         <p:nvSpPr>
-          <p:cNvPr id="33" name="Oval 32"/>
-          <p:cNvSpPr/>
-          <p:nvPr/>
-        </p:nvSpPr>
-        <p:spPr>
-          <a:xfrm>
-            <a:off x="741395" y="4280123"/>
-            <a:ext cx="181416" cy="181416"/>
-          </a:xfrm>
-          <a:prstGeom prst="ellipse">
-            <a:avLst/>
-          </a:prstGeom>
-          <a:solidFill>
-            <a:srgbClr val="088A8F"/>
-          </a:solidFill>
-          <a:ln>
-            <a:noFill/>
-          </a:ln>
-        </p:spPr>
-        <p:style>
-          <a:lnRef idx="1">
-            <a:schemeClr val="accent1"/>
-          </a:lnRef>
-          <a:fillRef idx="3">
-            <a:schemeClr val="accent1"/>
-          </a:fillRef>
-          <a:effectRef idx="2">
-            <a:schemeClr val="accent1"/>
-          </a:effectRef>
-          <a:fontRef idx="minor">
-            <a:schemeClr val="lt1"/>
-          </a:fontRef>
-        </p:style>
-        <p:txBody>
-          <a:bodyPr rtlCol="0" anchor="ctr"/>
-          <a:lstStyle/>
-          <a:p>
-            <a:pPr algn="ctr"/>
-          </a:p>
-        </p:txBody>
-      </p:sp>
-      <p:sp>
-        <p:nvSpPr>
-          <p:cNvPr id="34" name="TextBox 33"/>
+          <p:cNvPr id="28" name="TextBox 27"/>
           <p:cNvSpPr txBox="1"/>
           <p:nvPr/>
         </p:nvSpPr>
         <p:spPr>
           <a:xfrm>
-            <a:off x="685800" y="4224528"/>
-            <a:ext cx="292608" cy="292608"/>
-          </a:xfrm>
-          <a:prstGeom prst="rect">
-            <a:avLst/>
-          </a:prstGeom>
-          <a:noFill/>
-        </p:spPr>
-        <p:txBody lIns="0" tIns="0" rIns="0" bIns="0">
-          <a:bodyPr wrap="none">
-            <a:spAutoFit/>
-          </a:bodyPr>
-          <a:lstStyle/>
-          <a:p>
-            <a:pPr algn="ctr">
-              <a:spcBef>
-                <a:spcPts val="200"/>
-              </a:spcBef>
-            </a:pPr>
-            <a:r>
-              <a:rPr sz="1100" b="1">
-                <a:solidFill>
-                  <a:srgbClr val="FFFFFF"/>
-                </a:solidFill>
-              </a:rPr>
-              <a:t>✓</a:t>
-            </a:r>
-          </a:p>
-        </p:txBody>
-      </p:sp>
-      <p:sp>
-        <p:nvSpPr>
-          <p:cNvPr id="35" name="TextBox 34"/>
-          <p:cNvSpPr txBox="1"/>
-          <p:nvPr/>
-        </p:nvSpPr>
-        <p:spPr>
-          <a:xfrm>
-            <a:off x="1088136" y="4224528"/>
-            <a:ext cx="4884267" cy="566928"/>
-          </a:xfrm>
-          <a:prstGeom prst="rect">
-            <a:avLst/>
-          </a:prstGeom>
-          <a:noFill/>
-        </p:spPr>
-        <p:txBody lIns="38100" tIns="25400" rIns="38100" bIns="25400">
-          <a:bodyPr wrap="square">
-            <a:spAutoFit/>
-          </a:bodyPr>
-          <a:lstStyle/>
-          <a:p>
-            <a:pPr algn="l"/>
-            <a:r>
-              <a:rPr sz="1400" b="1">
-                <a:solidFill>
-                  <a:srgbClr val="FFFFFF"/>
-                </a:solidFill>
-              </a:rPr>
-              <a:t>Análisis de solvencia</a:t>
-            </a:r>
-          </a:p>
-        </p:txBody>
-      </p:sp>
-      <p:sp>
-        <p:nvSpPr>
-          <p:cNvPr id="36" name="Rectangle 35"/>
-          <p:cNvSpPr/>
-          <p:nvPr/>
-        </p:nvSpPr>
-        <p:spPr>
-          <a:xfrm>
-            <a:off x="649224" y="4626864"/>
-            <a:ext cx="5286603" cy="12700"/>
-          </a:xfrm>
-          <a:prstGeom prst="rect">
-            <a:avLst/>
-          </a:prstGeom>
-          <a:solidFill>
-            <a:srgbClr val="13B9BF"/>
-          </a:solidFill>
-          <a:ln>
-            <a:noFill/>
-          </a:ln>
-        </p:spPr>
-        <p:style>
-          <a:lnRef idx="1">
-            <a:schemeClr val="accent1"/>
-          </a:lnRef>
-          <a:fillRef idx="3">
-            <a:schemeClr val="accent1"/>
-          </a:fillRef>
-          <a:effectRef idx="2">
-            <a:schemeClr val="accent1"/>
-          </a:effectRef>
-          <a:fontRef idx="minor">
-            <a:schemeClr val="lt1"/>
-          </a:fontRef>
-        </p:style>
-        <p:txBody>
-          <a:bodyPr rtlCol="0" anchor="ctr"/>
-          <a:lstStyle/>
-          <a:p>
-            <a:pPr algn="ctr"/>
-          </a:p>
-        </p:txBody>
-      </p:sp>
-      <p:sp>
-        <p:nvSpPr>
-          <p:cNvPr id="37" name="TextBox 36"/>
-          <p:cNvSpPr txBox="1"/>
-          <p:nvPr/>
-        </p:nvSpPr>
-        <p:spPr>
-          <a:xfrm>
-            <a:off x="649224" y="4703064"/>
-            <a:ext cx="5286603" cy="1271524"/>
+            <a:off x="649224" y="4666488"/>
+            <a:ext cx="5286603" cy="1308100"/>
           </a:xfrm>
           <a:prstGeom prst="rect">
             <a:avLst/>
@@ -11032,7 +8806,7 @@
       </p:sp>
       <p:sp>
         <p:nvSpPr>
-          <p:cNvPr id="38" name="Rectangle 37"/>
+          <p:cNvPr id="29" name="Rectangle 28"/>
           <p:cNvSpPr/>
           <p:nvPr/>
         </p:nvSpPr>
@@ -11077,7 +8851,7 @@
       </p:sp>
       <p:sp>
         <p:nvSpPr>
-          <p:cNvPr id="39" name="Rectangle 38"/>
+          <p:cNvPr id="30" name="Rectangle 29"/>
           <p:cNvSpPr/>
           <p:nvPr/>
         </p:nvSpPr>
@@ -11120,16 +8894,129 @@
       </p:sp>
       <p:sp>
         <p:nvSpPr>
-          <p:cNvPr id="40" name="Oval 39"/>
+          <p:cNvPr id="31" name="Oval 30"/>
           <p:cNvSpPr/>
           <p:nvPr/>
         </p:nvSpPr>
         <p:spPr>
           <a:xfrm>
             <a:off x="6466179" y="4224528"/>
-            <a:ext cx="292608" cy="292608"/>
+            <a:ext cx="256032" cy="256032"/>
           </a:xfrm>
           <a:prstGeom prst="ellipse">
+            <a:avLst/>
+          </a:prstGeom>
+          <a:solidFill>
+            <a:srgbClr val="0A1638"/>
+          </a:solidFill>
+          <a:ln w="15240">
+            <a:solidFill>
+              <a:srgbClr val="2FDFE5"/>
+            </a:solidFill>
+          </a:ln>
+        </p:spPr>
+        <p:style>
+          <a:lnRef idx="1">
+            <a:schemeClr val="accent1"/>
+          </a:lnRef>
+          <a:fillRef idx="3">
+            <a:schemeClr val="accent1"/>
+          </a:fillRef>
+          <a:effectRef idx="2">
+            <a:schemeClr val="accent1"/>
+          </a:effectRef>
+          <a:fontRef idx="minor">
+            <a:schemeClr val="lt1"/>
+          </a:fontRef>
+        </p:style>
+        <p:txBody>
+          <a:bodyPr rtlCol="0" anchor="ctr"/>
+          <a:lstStyle/>
+          <a:p>
+            <a:pPr algn="ctr"/>
+          </a:p>
+        </p:txBody>
+      </p:sp>
+      <p:sp>
+        <p:nvSpPr>
+          <p:cNvPr id="32" name="TextBox 31"/>
+          <p:cNvSpPr txBox="1"/>
+          <p:nvPr/>
+        </p:nvSpPr>
+        <p:spPr>
+          <a:xfrm>
+            <a:off x="6466179" y="4224528"/>
+            <a:ext cx="256032" cy="256032"/>
+          </a:xfrm>
+          <a:prstGeom prst="rect">
+            <a:avLst/>
+          </a:prstGeom>
+          <a:noFill/>
+        </p:spPr>
+        <p:txBody lIns="0" tIns="12700" rIns="0" bIns="0">
+          <a:bodyPr wrap="none">
+            <a:spAutoFit/>
+          </a:bodyPr>
+          <a:lstStyle/>
+          <a:p>
+            <a:pPr algn="ctr"/>
+            <a:r>
+              <a:rPr sz="1100" b="1">
+                <a:solidFill>
+                  <a:srgbClr val="2FDFE5"/>
+                </a:solidFill>
+              </a:rPr>
+              <a:t>4</a:t>
+            </a:r>
+          </a:p>
+        </p:txBody>
+      </p:sp>
+      <p:sp>
+        <p:nvSpPr>
+          <p:cNvPr id="33" name="TextBox 32"/>
+          <p:cNvSpPr txBox="1"/>
+          <p:nvPr/>
+        </p:nvSpPr>
+        <p:spPr>
+          <a:xfrm>
+            <a:off x="6831939" y="4224528"/>
+            <a:ext cx="4865979" cy="512064"/>
+          </a:xfrm>
+          <a:prstGeom prst="rect">
+            <a:avLst/>
+          </a:prstGeom>
+          <a:noFill/>
+        </p:spPr>
+        <p:txBody lIns="38100" tIns="25400" rIns="38100" bIns="25400">
+          <a:bodyPr wrap="square">
+            <a:spAutoFit/>
+          </a:bodyPr>
+          <a:lstStyle/>
+          <a:p>
+            <a:pPr algn="l"/>
+            <a:r>
+              <a:rPr sz="1400" b="1">
+                <a:solidFill>
+                  <a:srgbClr val="FFFFFF"/>
+                </a:solidFill>
+              </a:rPr>
+              <a:t>Ficheros de morosidad</a:t>
+            </a:r>
+          </a:p>
+        </p:txBody>
+      </p:sp>
+      <p:sp>
+        <p:nvSpPr>
+          <p:cNvPr id="34" name="Rectangle 33"/>
+          <p:cNvSpPr/>
+          <p:nvPr/>
+        </p:nvSpPr>
+        <p:spPr>
+          <a:xfrm>
+            <a:off x="6429603" y="4590288"/>
+            <a:ext cx="5286603" cy="12700"/>
+          </a:xfrm>
+          <a:prstGeom prst="rect">
             <a:avLst/>
           </a:prstGeom>
           <a:solidFill>
@@ -11163,172 +9050,14 @@
       </p:sp>
       <p:sp>
         <p:nvSpPr>
-          <p:cNvPr id="41" name="Oval 40"/>
-          <p:cNvSpPr/>
-          <p:nvPr/>
-        </p:nvSpPr>
-        <p:spPr>
-          <a:xfrm>
-            <a:off x="6521775" y="4280123"/>
-            <a:ext cx="181416" cy="181416"/>
-          </a:xfrm>
-          <a:prstGeom prst="ellipse">
-            <a:avLst/>
-          </a:prstGeom>
-          <a:solidFill>
-            <a:srgbClr val="088A8F"/>
-          </a:solidFill>
-          <a:ln>
-            <a:noFill/>
-          </a:ln>
-        </p:spPr>
-        <p:style>
-          <a:lnRef idx="1">
-            <a:schemeClr val="accent1"/>
-          </a:lnRef>
-          <a:fillRef idx="3">
-            <a:schemeClr val="accent1"/>
-          </a:fillRef>
-          <a:effectRef idx="2">
-            <a:schemeClr val="accent1"/>
-          </a:effectRef>
-          <a:fontRef idx="minor">
-            <a:schemeClr val="lt1"/>
-          </a:fontRef>
-        </p:style>
-        <p:txBody>
-          <a:bodyPr rtlCol="0" anchor="ctr"/>
-          <a:lstStyle/>
-          <a:p>
-            <a:pPr algn="ctr"/>
-          </a:p>
-        </p:txBody>
-      </p:sp>
-      <p:sp>
-        <p:nvSpPr>
-          <p:cNvPr id="42" name="TextBox 41"/>
+          <p:cNvPr id="35" name="TextBox 34"/>
           <p:cNvSpPr txBox="1"/>
           <p:nvPr/>
         </p:nvSpPr>
         <p:spPr>
           <a:xfrm>
-            <a:off x="6466179" y="4224528"/>
-            <a:ext cx="292608" cy="292608"/>
-          </a:xfrm>
-          <a:prstGeom prst="rect">
-            <a:avLst/>
-          </a:prstGeom>
-          <a:noFill/>
-        </p:spPr>
-        <p:txBody lIns="0" tIns="0" rIns="0" bIns="0">
-          <a:bodyPr wrap="none">
-            <a:spAutoFit/>
-          </a:bodyPr>
-          <a:lstStyle/>
-          <a:p>
-            <a:pPr algn="ctr">
-              <a:spcBef>
-                <a:spcPts val="200"/>
-              </a:spcBef>
-            </a:pPr>
-            <a:r>
-              <a:rPr sz="1100" b="1">
-                <a:solidFill>
-                  <a:srgbClr val="FFFFFF"/>
-                </a:solidFill>
-              </a:rPr>
-              <a:t>▼</a:t>
-            </a:r>
-          </a:p>
-        </p:txBody>
-      </p:sp>
-      <p:sp>
-        <p:nvSpPr>
-          <p:cNvPr id="43" name="TextBox 42"/>
-          <p:cNvSpPr txBox="1"/>
-          <p:nvPr/>
-        </p:nvSpPr>
-        <p:spPr>
-          <a:xfrm>
-            <a:off x="6868515" y="4224528"/>
-            <a:ext cx="4884267" cy="566928"/>
-          </a:xfrm>
-          <a:prstGeom prst="rect">
-            <a:avLst/>
-          </a:prstGeom>
-          <a:noFill/>
-        </p:spPr>
-        <p:txBody lIns="38100" tIns="25400" rIns="38100" bIns="25400">
-          <a:bodyPr wrap="square">
-            <a:spAutoFit/>
-          </a:bodyPr>
-          <a:lstStyle/>
-          <a:p>
-            <a:pPr algn="l"/>
-            <a:r>
-              <a:rPr sz="1400" b="1">
-                <a:solidFill>
-                  <a:srgbClr val="FFFFFF"/>
-                </a:solidFill>
-              </a:rPr>
-              <a:t>Ficheros de morosidad</a:t>
-            </a:r>
-          </a:p>
-        </p:txBody>
-      </p:sp>
-      <p:sp>
-        <p:nvSpPr>
-          <p:cNvPr id="44" name="Rectangle 43"/>
-          <p:cNvSpPr/>
-          <p:nvPr/>
-        </p:nvSpPr>
-        <p:spPr>
-          <a:xfrm>
-            <a:off x="6429603" y="4626864"/>
-            <a:ext cx="5286603" cy="12700"/>
-          </a:xfrm>
-          <a:prstGeom prst="rect">
-            <a:avLst/>
-          </a:prstGeom>
-          <a:solidFill>
-            <a:srgbClr val="13B9BF"/>
-          </a:solidFill>
-          <a:ln>
-            <a:noFill/>
-          </a:ln>
-        </p:spPr>
-        <p:style>
-          <a:lnRef idx="1">
-            <a:schemeClr val="accent1"/>
-          </a:lnRef>
-          <a:fillRef idx="3">
-            <a:schemeClr val="accent1"/>
-          </a:fillRef>
-          <a:effectRef idx="2">
-            <a:schemeClr val="accent1"/>
-          </a:effectRef>
-          <a:fontRef idx="minor">
-            <a:schemeClr val="lt1"/>
-          </a:fontRef>
-        </p:style>
-        <p:txBody>
-          <a:bodyPr rtlCol="0" anchor="ctr"/>
-          <a:lstStyle/>
-          <a:p>
-            <a:pPr algn="ctr"/>
-          </a:p>
-        </p:txBody>
-      </p:sp>
-      <p:sp>
-        <p:nvSpPr>
-          <p:cNvPr id="45" name="TextBox 44"/>
-          <p:cNvSpPr txBox="1"/>
-          <p:nvPr/>
-        </p:nvSpPr>
-        <p:spPr>
-          <a:xfrm>
-            <a:off x="6429603" y="4703064"/>
-            <a:ext cx="5286603" cy="1271524"/>
+            <a:off x="6429603" y="4666488"/>
+            <a:ext cx="5286603" cy="1308100"/>
           </a:xfrm>
           <a:prstGeom prst="rect">
             <a:avLst/>
@@ -11353,6 +9082,30 @@
           </a:p>
         </p:txBody>
       </p:sp>
+      <p:pic>
+        <p:nvPicPr>
+          <p:cNvPr id="36" name="Picture 35" descr="logo_horiz.png"/>
+          <p:cNvPicPr>
+            <a:picLocks noChangeAspect="1"/>
+          </p:cNvPicPr>
+          <p:nvPr/>
+        </p:nvPicPr>
+        <p:blipFill>
+          <a:blip r:embed="rId3"/>
+          <a:stretch>
+            <a:fillRect/>
+          </a:stretch>
+        </p:blipFill>
+        <p:spPr>
+          <a:xfrm>
+            <a:off x="10024567" y="6062197"/>
+            <a:ext cx="1965960" cy="631211"/>
+          </a:xfrm>
+          <a:prstGeom prst="rect">
+            <a:avLst/>
+          </a:prstGeom>
+        </p:spPr>
+      </p:pic>
     </p:spTree>
   </p:cSld>
   <p:clrMapOvr>
@@ -11382,7 +9135,7 @@
                                 <p:cBhvr>
                                   <p:cTn id="6" dur="450" fill="hold"/>
                                   <p:tgtEl>
-                                    <p:spTgt spid="14"/>
+                                    <p:spTgt spid="8"/>
                                   </p:tgtEl>
                                 </p:cBhvr>
                               </p:animEffect>
@@ -11399,7 +9152,7 @@
                                 <p:cBhvr>
                                   <p:cTn id="8" dur="450" fill="hold"/>
                                   <p:tgtEl>
-                                    <p:spTgt spid="22"/>
+                                    <p:spTgt spid="15"/>
                                   </p:tgtEl>
                                 </p:cBhvr>
                               </p:animEffect>
@@ -11416,7 +9169,7 @@
                                 <p:cBhvr>
                                   <p:cTn id="10" dur="450" fill="hold"/>
                                   <p:tgtEl>
-                                    <p:spTgt spid="30"/>
+                                    <p:spTgt spid="22"/>
                                   </p:tgtEl>
                                 </p:cBhvr>
                               </p:animEffect>
@@ -11433,7 +9186,7 @@
                                 <p:cBhvr>
                                   <p:cTn id="12" dur="450" fill="hold"/>
                                   <p:tgtEl>
-                                    <p:spTgt spid="38"/>
+                                    <p:spTgt spid="29"/>
                                   </p:tgtEl>
                                 </p:cBhvr>
                               </p:animEffect>

</xml_diff>

<commit_message>
Fix badge numbers and increase text size throughout
- Badge: write number as inline text on oval shape (fixes invisible numbers)
- Badge: increase to r=0.38" with sz=16 bold, vertical-centered
- Card title: sz=15 → sz=18
- Bullet arrow/text: sz=11/12 → sz=13/14
- Feat grid title: sz=14 → sz=17, desc: sz=11.5 → sz=14
- Subtitle: sz=11 → sz=13
</commit_message>
<xml_diff>
--- a/sendacredit_propuesta.pptx
+++ b/sendacredit_propuesta.pptx
@@ -3746,7 +3746,7 @@
           <a:p>
             <a:pPr algn="l"/>
             <a:r>
-              <a:rPr sz="1100" i="1">
+              <a:rPr sz="1300" i="1">
                 <a:solidFill>
                   <a:srgbClr val="80A8CC"/>
                 </a:solidFill>
@@ -3853,7 +3853,7 @@
         <p:spPr>
           <a:xfrm>
             <a:off x="704088" y="2468880"/>
-            <a:ext cx="274320" cy="274320"/>
+            <a:ext cx="347472" cy="347472"/>
           </a:xfrm>
           <a:prstGeom prst="ellipse">
             <a:avLst/>
@@ -3861,7 +3861,7 @@
           <a:solidFill>
             <a:srgbClr val="0A1638"/>
           </a:solidFill>
-          <a:ln w="15240">
+          <a:ln w="19050">
             <a:solidFill>
               <a:srgbClr val="2FDFE5"/>
             </a:solidFill>
@@ -3881,11 +3881,19 @@
             <a:schemeClr val="lt1"/>
           </a:fontRef>
         </p:style>
-        <p:txBody>
-          <a:bodyPr rtlCol="0" anchor="ctr"/>
+        <p:txBody lIns="0" tIns="0" rIns="0" bIns="0">
+          <a:bodyPr rtlCol="0" anchor="ctr" wrap="none"/>
           <a:lstStyle/>
           <a:p>
             <a:pPr algn="ctr"/>
+            <a:r>
+              <a:rPr sz="1600" b="1">
+                <a:solidFill>
+                  <a:srgbClr val="2FDFE5"/>
+                </a:solidFill>
+              </a:rPr>
+              <a:t>1</a:t>
+            </a:r>
           </a:p>
         </p:txBody>
       </p:sp>
@@ -3897,42 +3905,8 @@
         </p:nvSpPr>
         <p:spPr>
           <a:xfrm>
-            <a:off x="704088" y="2468880"/>
-            <a:ext cx="274320" cy="274320"/>
-          </a:xfrm>
-          <a:prstGeom prst="rect">
-            <a:avLst/>
-          </a:prstGeom>
-          <a:noFill/>
-        </p:spPr>
-        <p:txBody lIns="0" tIns="12700" rIns="0" bIns="0">
-          <a:bodyPr wrap="none">
-            <a:spAutoFit/>
-          </a:bodyPr>
-          <a:lstStyle/>
-          <a:p>
-            <a:pPr algn="ctr"/>
-            <a:r>
-              <a:rPr sz="1100" b="1">
-                <a:solidFill>
-                  <a:srgbClr val="2FDFE5"/>
-                </a:solidFill>
-              </a:rPr>
-              <a:t>1</a:t>
-            </a:r>
-          </a:p>
-        </p:txBody>
-      </p:sp>
-      <p:sp>
-        <p:nvSpPr>
-          <p:cNvPr id="13" name="TextBox 12"/>
-          <p:cNvSpPr txBox="1"/>
-          <p:nvPr/>
-        </p:nvSpPr>
-        <p:spPr>
-          <a:xfrm>
-            <a:off x="1088136" y="2468880"/>
-            <a:ext cx="4792827" cy="566928"/>
+            <a:off x="1179576" y="2468880"/>
+            <a:ext cx="4683099" cy="658368"/>
           </a:xfrm>
           <a:prstGeom prst="rect">
             <a:avLst/>
@@ -3947,7 +3921,7 @@
           <a:p>
             <a:pPr algn="l"/>
             <a:r>
-              <a:rPr sz="1500" b="1">
+              <a:rPr sz="1800" b="1">
                 <a:solidFill>
                   <a:srgbClr val="FFFFFF"/>
                 </a:solidFill>
@@ -3959,13 +3933,13 @@
       </p:sp>
       <p:sp>
         <p:nvSpPr>
-          <p:cNvPr id="14" name="Rectangle 13"/>
+          <p:cNvPr id="13" name="Rectangle 12"/>
           <p:cNvSpPr/>
           <p:nvPr/>
         </p:nvSpPr>
         <p:spPr>
           <a:xfrm>
-            <a:off x="667512" y="2852928"/>
+            <a:off x="667512" y="2944368"/>
             <a:ext cx="5250027" cy="15240"/>
           </a:xfrm>
           <a:prstGeom prst="rect">
@@ -4002,14 +3976,14 @@
       </p:sp>
       <p:sp>
         <p:nvSpPr>
-          <p:cNvPr id="15" name="TextBox 14"/>
+          <p:cNvPr id="14" name="TextBox 13"/>
           <p:cNvSpPr txBox="1"/>
           <p:nvPr/>
         </p:nvSpPr>
         <p:spPr>
           <a:xfrm>
-            <a:off x="667512" y="2941828"/>
-            <a:ext cx="5250027" cy="3014472"/>
+            <a:off x="667512" y="3045968"/>
+            <a:ext cx="5250027" cy="2923032"/>
           </a:xfrm>
           <a:prstGeom prst="rect">
             <a:avLst/>
@@ -4024,11 +3998,11 @@
           <a:p>
             <a:pPr algn="l">
               <a:spcBef>
-                <a:spcPts val="400"/>
+                <a:spcPts val="500"/>
               </a:spcBef>
             </a:pPr>
             <a:r>
-              <a:rPr sz="1100">
+              <a:rPr sz="1300">
                 <a:solidFill>
                   <a:srgbClr val="2FDFE5"/>
                 </a:solidFill>
@@ -4036,7 +4010,7 @@
               <a:t>▸  </a:t>
             </a:r>
             <a:r>
-              <a:rPr sz="1200">
+              <a:rPr sz="1400">
                 <a:solidFill>
                   <a:srgbClr val="D8EAFF"/>
                 </a:solidFill>
@@ -4047,11 +4021,11 @@
           <a:p>
             <a:pPr algn="l">
               <a:spcBef>
-                <a:spcPts val="400"/>
+                <a:spcPts val="500"/>
               </a:spcBef>
             </a:pPr>
             <a:r>
-              <a:rPr sz="1100">
+              <a:rPr sz="1300">
                 <a:solidFill>
                   <a:srgbClr val="2FDFE5"/>
                 </a:solidFill>
@@ -4059,7 +4033,7 @@
               <a:t>▸  </a:t>
             </a:r>
             <a:r>
-              <a:rPr sz="1200">
+              <a:rPr sz="1400">
                 <a:solidFill>
                   <a:srgbClr val="D8EAFF"/>
                 </a:solidFill>
@@ -4070,11 +4044,11 @@
           <a:p>
             <a:pPr algn="l">
               <a:spcBef>
-                <a:spcPts val="400"/>
+                <a:spcPts val="500"/>
               </a:spcBef>
             </a:pPr>
             <a:r>
-              <a:rPr sz="1100">
+              <a:rPr sz="1300">
                 <a:solidFill>
                   <a:srgbClr val="2FDFE5"/>
                 </a:solidFill>
@@ -4082,7 +4056,7 @@
               <a:t>▸  </a:t>
             </a:r>
             <a:r>
-              <a:rPr sz="1200">
+              <a:rPr sz="1400">
                 <a:solidFill>
                   <a:srgbClr val="D8EAFF"/>
                 </a:solidFill>
@@ -4094,7 +4068,7 @@
       </p:sp>
       <p:sp>
         <p:nvSpPr>
-          <p:cNvPr id="16" name="Rectangle 15"/>
+          <p:cNvPr id="15" name="Rectangle 14"/>
           <p:cNvSpPr/>
           <p:nvPr/>
         </p:nvSpPr>
@@ -4139,7 +4113,7 @@
       </p:sp>
       <p:sp>
         <p:nvSpPr>
-          <p:cNvPr id="17" name="Rectangle 16"/>
+          <p:cNvPr id="16" name="Rectangle 15"/>
           <p:cNvSpPr/>
           <p:nvPr/>
         </p:nvSpPr>
@@ -4182,14 +4156,14 @@
       </p:sp>
       <p:sp>
         <p:nvSpPr>
-          <p:cNvPr id="18" name="Oval 17"/>
+          <p:cNvPr id="17" name="Oval 16"/>
           <p:cNvSpPr/>
           <p:nvPr/>
         </p:nvSpPr>
         <p:spPr>
           <a:xfrm>
             <a:off x="6484467" y="2468880"/>
-            <a:ext cx="274320" cy="274320"/>
+            <a:ext cx="347472" cy="347472"/>
           </a:xfrm>
           <a:prstGeom prst="ellipse">
             <a:avLst/>
@@ -4197,7 +4171,7 @@
           <a:solidFill>
             <a:srgbClr val="0A1638"/>
           </a:solidFill>
-          <a:ln w="15240">
+          <a:ln w="19050">
             <a:solidFill>
               <a:srgbClr val="2FDFE5"/>
             </a:solidFill>
@@ -4217,58 +4191,32 @@
             <a:schemeClr val="lt1"/>
           </a:fontRef>
         </p:style>
-        <p:txBody>
-          <a:bodyPr rtlCol="0" anchor="ctr"/>
+        <p:txBody lIns="0" tIns="0" rIns="0" bIns="0">
+          <a:bodyPr rtlCol="0" anchor="ctr" wrap="none"/>
           <a:lstStyle/>
           <a:p>
             <a:pPr algn="ctr"/>
-          </a:p>
-        </p:txBody>
-      </p:sp>
-      <p:sp>
-        <p:nvSpPr>
-          <p:cNvPr id="19" name="TextBox 18"/>
+            <a:r>
+              <a:rPr sz="1600" b="1">
+                <a:solidFill>
+                  <a:srgbClr val="2FDFE5"/>
+                </a:solidFill>
+              </a:rPr>
+              <a:t>2</a:t>
+            </a:r>
+          </a:p>
+        </p:txBody>
+      </p:sp>
+      <p:sp>
+        <p:nvSpPr>
+          <p:cNvPr id="18" name="TextBox 17"/>
           <p:cNvSpPr txBox="1"/>
           <p:nvPr/>
         </p:nvSpPr>
         <p:spPr>
           <a:xfrm>
-            <a:off x="6484467" y="2468880"/>
-            <a:ext cx="274320" cy="274320"/>
-          </a:xfrm>
-          <a:prstGeom prst="rect">
-            <a:avLst/>
-          </a:prstGeom>
-          <a:noFill/>
-        </p:spPr>
-        <p:txBody lIns="0" tIns="12700" rIns="0" bIns="0">
-          <a:bodyPr wrap="none">
-            <a:spAutoFit/>
-          </a:bodyPr>
-          <a:lstStyle/>
-          <a:p>
-            <a:pPr algn="ctr"/>
-            <a:r>
-              <a:rPr sz="1100" b="1">
-                <a:solidFill>
-                  <a:srgbClr val="2FDFE5"/>
-                </a:solidFill>
-              </a:rPr>
-              <a:t>2</a:t>
-            </a:r>
-          </a:p>
-        </p:txBody>
-      </p:sp>
-      <p:sp>
-        <p:nvSpPr>
-          <p:cNvPr id="20" name="TextBox 19"/>
-          <p:cNvSpPr txBox="1"/>
-          <p:nvPr/>
-        </p:nvSpPr>
-        <p:spPr>
-          <a:xfrm>
-            <a:off x="6868515" y="2468880"/>
-            <a:ext cx="4792827" cy="566928"/>
+            <a:off x="6959955" y="2468880"/>
+            <a:ext cx="4683099" cy="658368"/>
           </a:xfrm>
           <a:prstGeom prst="rect">
             <a:avLst/>
@@ -4283,7 +4231,7 @@
           <a:p>
             <a:pPr algn="l"/>
             <a:r>
-              <a:rPr sz="1500" b="1">
+              <a:rPr sz="1800" b="1">
                 <a:solidFill>
                   <a:srgbClr val="FFFFFF"/>
                 </a:solidFill>
@@ -4295,13 +4243,13 @@
       </p:sp>
       <p:sp>
         <p:nvSpPr>
-          <p:cNvPr id="21" name="Rectangle 20"/>
+          <p:cNvPr id="19" name="Rectangle 18"/>
           <p:cNvSpPr/>
           <p:nvPr/>
         </p:nvSpPr>
         <p:spPr>
           <a:xfrm>
-            <a:off x="6447891" y="2852928"/>
+            <a:off x="6447891" y="2944368"/>
             <a:ext cx="5250027" cy="15240"/>
           </a:xfrm>
           <a:prstGeom prst="rect">
@@ -4338,14 +4286,14 @@
       </p:sp>
       <p:sp>
         <p:nvSpPr>
-          <p:cNvPr id="22" name="TextBox 21"/>
+          <p:cNvPr id="20" name="TextBox 19"/>
           <p:cNvSpPr txBox="1"/>
           <p:nvPr/>
         </p:nvSpPr>
         <p:spPr>
           <a:xfrm>
-            <a:off x="6447891" y="2941828"/>
-            <a:ext cx="5250027" cy="3014472"/>
+            <a:off x="6447891" y="3045968"/>
+            <a:ext cx="5250027" cy="2923032"/>
           </a:xfrm>
           <a:prstGeom prst="rect">
             <a:avLst/>
@@ -4360,11 +4308,11 @@
           <a:p>
             <a:pPr algn="l">
               <a:spcBef>
-                <a:spcPts val="400"/>
+                <a:spcPts val="500"/>
               </a:spcBef>
             </a:pPr>
             <a:r>
-              <a:rPr sz="1100">
+              <a:rPr sz="1300">
                 <a:solidFill>
                   <a:srgbClr val="2FDFE5"/>
                 </a:solidFill>
@@ -4372,7 +4320,7 @@
               <a:t>▸  </a:t>
             </a:r>
             <a:r>
-              <a:rPr sz="1200">
+              <a:rPr sz="1400">
                 <a:solidFill>
                   <a:srgbClr val="D8EAFF"/>
                 </a:solidFill>
@@ -4383,11 +4331,11 @@
           <a:p>
             <a:pPr algn="l">
               <a:spcBef>
-                <a:spcPts val="400"/>
+                <a:spcPts val="500"/>
               </a:spcBef>
             </a:pPr>
             <a:r>
-              <a:rPr sz="1100">
+              <a:rPr sz="1300">
                 <a:solidFill>
                   <a:srgbClr val="2FDFE5"/>
                 </a:solidFill>
@@ -4395,7 +4343,7 @@
               <a:t>▸  </a:t>
             </a:r>
             <a:r>
-              <a:rPr sz="1200">
+              <a:rPr sz="1400">
                 <a:solidFill>
                   <a:srgbClr val="D8EAFF"/>
                 </a:solidFill>
@@ -4406,11 +4354,11 @@
           <a:p>
             <a:pPr algn="l">
               <a:spcBef>
-                <a:spcPts val="400"/>
+                <a:spcPts val="500"/>
               </a:spcBef>
             </a:pPr>
             <a:r>
-              <a:rPr sz="1100">
+              <a:rPr sz="1300">
                 <a:solidFill>
                   <a:srgbClr val="2FDFE5"/>
                 </a:solidFill>
@@ -4418,7 +4366,7 @@
               <a:t>▸  </a:t>
             </a:r>
             <a:r>
-              <a:rPr sz="1200">
+              <a:rPr sz="1400">
                 <a:solidFill>
                   <a:srgbClr val="D8EAFF"/>
                 </a:solidFill>
@@ -4430,7 +4378,7 @@
       </p:sp>
       <p:pic>
         <p:nvPicPr>
-          <p:cNvPr id="23" name="Picture 22" descr="logo_horiz.png"/>
+          <p:cNvPr id="21" name="Picture 20" descr="logo_horiz.png"/>
           <p:cNvPicPr>
             <a:picLocks noChangeAspect="1"/>
           </p:cNvPicPr>
@@ -4498,7 +4446,7 @@
                                 <p:cBhvr>
                                   <p:cTn id="8" dur="450" fill="hold"/>
                                   <p:tgtEl>
-                                    <p:spTgt spid="16"/>
+                                    <p:spTgt spid="15"/>
                                   </p:tgtEl>
                                 </p:cBhvr>
                               </p:animEffect>
@@ -4808,7 +4756,7 @@
           <a:p>
             <a:pPr algn="l"/>
             <a:r>
-              <a:rPr sz="1100" i="1">
+              <a:rPr sz="1300" i="1">
                 <a:solidFill>
                   <a:srgbClr val="80A8CC"/>
                 </a:solidFill>
@@ -4915,7 +4863,7 @@
         <p:spPr>
           <a:xfrm>
             <a:off x="704088" y="2468880"/>
-            <a:ext cx="274320" cy="274320"/>
+            <a:ext cx="347472" cy="347472"/>
           </a:xfrm>
           <a:prstGeom prst="ellipse">
             <a:avLst/>
@@ -4923,7 +4871,7 @@
           <a:solidFill>
             <a:srgbClr val="0A1638"/>
           </a:solidFill>
-          <a:ln w="15240">
+          <a:ln w="19050">
             <a:solidFill>
               <a:srgbClr val="2FDFE5"/>
             </a:solidFill>
@@ -4943,11 +4891,19 @@
             <a:schemeClr val="lt1"/>
           </a:fontRef>
         </p:style>
-        <p:txBody>
-          <a:bodyPr rtlCol="0" anchor="ctr"/>
+        <p:txBody lIns="0" tIns="0" rIns="0" bIns="0">
+          <a:bodyPr rtlCol="0" anchor="ctr" wrap="none"/>
           <a:lstStyle/>
           <a:p>
             <a:pPr algn="ctr"/>
+            <a:r>
+              <a:rPr sz="1600" b="1">
+                <a:solidFill>
+                  <a:srgbClr val="2FDFE5"/>
+                </a:solidFill>
+              </a:rPr>
+              <a:t>3</a:t>
+            </a:r>
           </a:p>
         </p:txBody>
       </p:sp>
@@ -4959,42 +4915,8 @@
         </p:nvSpPr>
         <p:spPr>
           <a:xfrm>
-            <a:off x="704088" y="2468880"/>
-            <a:ext cx="274320" cy="274320"/>
-          </a:xfrm>
-          <a:prstGeom prst="rect">
-            <a:avLst/>
-          </a:prstGeom>
-          <a:noFill/>
-        </p:spPr>
-        <p:txBody lIns="0" tIns="12700" rIns="0" bIns="0">
-          <a:bodyPr wrap="none">
-            <a:spAutoFit/>
-          </a:bodyPr>
-          <a:lstStyle/>
-          <a:p>
-            <a:pPr algn="ctr"/>
-            <a:r>
-              <a:rPr sz="1100" b="1">
-                <a:solidFill>
-                  <a:srgbClr val="2FDFE5"/>
-                </a:solidFill>
-              </a:rPr>
-              <a:t>3</a:t>
-            </a:r>
-          </a:p>
-        </p:txBody>
-      </p:sp>
-      <p:sp>
-        <p:nvSpPr>
-          <p:cNvPr id="13" name="TextBox 12"/>
-          <p:cNvSpPr txBox="1"/>
-          <p:nvPr/>
-        </p:nvSpPr>
-        <p:spPr>
-          <a:xfrm>
-            <a:off x="1088136" y="2468880"/>
-            <a:ext cx="4792827" cy="566928"/>
+            <a:off x="1179576" y="2468880"/>
+            <a:ext cx="4683099" cy="658368"/>
           </a:xfrm>
           <a:prstGeom prst="rect">
             <a:avLst/>
@@ -5009,7 +4931,7 @@
           <a:p>
             <a:pPr algn="l"/>
             <a:r>
-              <a:rPr sz="1500" b="1">
+              <a:rPr sz="1800" b="1">
                 <a:solidFill>
                   <a:srgbClr val="FFFFFF"/>
                 </a:solidFill>
@@ -5021,13 +4943,13 @@
       </p:sp>
       <p:sp>
         <p:nvSpPr>
-          <p:cNvPr id="14" name="Rectangle 13"/>
+          <p:cNvPr id="13" name="Rectangle 12"/>
           <p:cNvSpPr/>
           <p:nvPr/>
         </p:nvSpPr>
         <p:spPr>
           <a:xfrm>
-            <a:off x="667512" y="2852928"/>
+            <a:off x="667512" y="2944368"/>
             <a:ext cx="5250027" cy="15240"/>
           </a:xfrm>
           <a:prstGeom prst="rect">
@@ -5064,14 +4986,14 @@
       </p:sp>
       <p:sp>
         <p:nvSpPr>
-          <p:cNvPr id="15" name="TextBox 14"/>
+          <p:cNvPr id="14" name="TextBox 13"/>
           <p:cNvSpPr txBox="1"/>
           <p:nvPr/>
         </p:nvSpPr>
         <p:spPr>
           <a:xfrm>
-            <a:off x="667512" y="2941828"/>
-            <a:ext cx="5250027" cy="3014472"/>
+            <a:off x="667512" y="3045968"/>
+            <a:ext cx="5250027" cy="2923032"/>
           </a:xfrm>
           <a:prstGeom prst="rect">
             <a:avLst/>
@@ -5086,11 +5008,11 @@
           <a:p>
             <a:pPr algn="l">
               <a:spcBef>
-                <a:spcPts val="400"/>
+                <a:spcPts val="500"/>
               </a:spcBef>
             </a:pPr>
             <a:r>
-              <a:rPr sz="1100">
+              <a:rPr sz="1300">
                 <a:solidFill>
                   <a:srgbClr val="2FDFE5"/>
                 </a:solidFill>
@@ -5098,7 +5020,7 @@
               <a:t>▸  </a:t>
             </a:r>
             <a:r>
-              <a:rPr sz="1200">
+              <a:rPr sz="1400">
                 <a:solidFill>
                   <a:srgbClr val="D8EAFF"/>
                 </a:solidFill>
@@ -5109,11 +5031,11 @@
           <a:p>
             <a:pPr algn="l">
               <a:spcBef>
-                <a:spcPts val="400"/>
+                <a:spcPts val="500"/>
               </a:spcBef>
             </a:pPr>
             <a:r>
-              <a:rPr sz="1100">
+              <a:rPr sz="1300">
                 <a:solidFill>
                   <a:srgbClr val="2FDFE5"/>
                 </a:solidFill>
@@ -5121,7 +5043,7 @@
               <a:t>▸  </a:t>
             </a:r>
             <a:r>
-              <a:rPr sz="1200">
+              <a:rPr sz="1400">
                 <a:solidFill>
                   <a:srgbClr val="D8EAFF"/>
                 </a:solidFill>
@@ -5132,11 +5054,11 @@
           <a:p>
             <a:pPr algn="l">
               <a:spcBef>
-                <a:spcPts val="400"/>
+                <a:spcPts val="500"/>
               </a:spcBef>
             </a:pPr>
             <a:r>
-              <a:rPr sz="1100">
+              <a:rPr sz="1300">
                 <a:solidFill>
                   <a:srgbClr val="2FDFE5"/>
                 </a:solidFill>
@@ -5144,7 +5066,7 @@
               <a:t>▸  </a:t>
             </a:r>
             <a:r>
-              <a:rPr sz="1200">
+              <a:rPr sz="1400">
                 <a:solidFill>
                   <a:srgbClr val="D8EAFF"/>
                 </a:solidFill>
@@ -5156,7 +5078,7 @@
       </p:sp>
       <p:sp>
         <p:nvSpPr>
-          <p:cNvPr id="16" name="Rectangle 15"/>
+          <p:cNvPr id="15" name="Rectangle 14"/>
           <p:cNvSpPr/>
           <p:nvPr/>
         </p:nvSpPr>
@@ -5201,7 +5123,7 @@
       </p:sp>
       <p:sp>
         <p:nvSpPr>
-          <p:cNvPr id="17" name="Rectangle 16"/>
+          <p:cNvPr id="16" name="Rectangle 15"/>
           <p:cNvSpPr/>
           <p:nvPr/>
         </p:nvSpPr>
@@ -5244,14 +5166,14 @@
       </p:sp>
       <p:sp>
         <p:nvSpPr>
-          <p:cNvPr id="18" name="Oval 17"/>
+          <p:cNvPr id="17" name="Oval 16"/>
           <p:cNvSpPr/>
           <p:nvPr/>
         </p:nvSpPr>
         <p:spPr>
           <a:xfrm>
             <a:off x="6484467" y="2468880"/>
-            <a:ext cx="274320" cy="274320"/>
+            <a:ext cx="347472" cy="347472"/>
           </a:xfrm>
           <a:prstGeom prst="ellipse">
             <a:avLst/>
@@ -5259,7 +5181,7 @@
           <a:solidFill>
             <a:srgbClr val="0A1638"/>
           </a:solidFill>
-          <a:ln w="15240">
+          <a:ln w="19050">
             <a:solidFill>
               <a:srgbClr val="2FDFE5"/>
             </a:solidFill>
@@ -5279,58 +5201,32 @@
             <a:schemeClr val="lt1"/>
           </a:fontRef>
         </p:style>
-        <p:txBody>
-          <a:bodyPr rtlCol="0" anchor="ctr"/>
+        <p:txBody lIns="0" tIns="0" rIns="0" bIns="0">
+          <a:bodyPr rtlCol="0" anchor="ctr" wrap="none"/>
           <a:lstStyle/>
           <a:p>
             <a:pPr algn="ctr"/>
-          </a:p>
-        </p:txBody>
-      </p:sp>
-      <p:sp>
-        <p:nvSpPr>
-          <p:cNvPr id="19" name="TextBox 18"/>
+            <a:r>
+              <a:rPr sz="1600" b="1">
+                <a:solidFill>
+                  <a:srgbClr val="2FDFE5"/>
+                </a:solidFill>
+              </a:rPr>
+              <a:t>4</a:t>
+            </a:r>
+          </a:p>
+        </p:txBody>
+      </p:sp>
+      <p:sp>
+        <p:nvSpPr>
+          <p:cNvPr id="18" name="TextBox 17"/>
           <p:cNvSpPr txBox="1"/>
           <p:nvPr/>
         </p:nvSpPr>
         <p:spPr>
           <a:xfrm>
-            <a:off x="6484467" y="2468880"/>
-            <a:ext cx="274320" cy="274320"/>
-          </a:xfrm>
-          <a:prstGeom prst="rect">
-            <a:avLst/>
-          </a:prstGeom>
-          <a:noFill/>
-        </p:spPr>
-        <p:txBody lIns="0" tIns="12700" rIns="0" bIns="0">
-          <a:bodyPr wrap="none">
-            <a:spAutoFit/>
-          </a:bodyPr>
-          <a:lstStyle/>
-          <a:p>
-            <a:pPr algn="ctr"/>
-            <a:r>
-              <a:rPr sz="1100" b="1">
-                <a:solidFill>
-                  <a:srgbClr val="2FDFE5"/>
-                </a:solidFill>
-              </a:rPr>
-              <a:t>4</a:t>
-            </a:r>
-          </a:p>
-        </p:txBody>
-      </p:sp>
-      <p:sp>
-        <p:nvSpPr>
-          <p:cNvPr id="20" name="TextBox 19"/>
-          <p:cNvSpPr txBox="1"/>
-          <p:nvPr/>
-        </p:nvSpPr>
-        <p:spPr>
-          <a:xfrm>
-            <a:off x="6868515" y="2468880"/>
-            <a:ext cx="4792827" cy="566928"/>
+            <a:off x="6959955" y="2468880"/>
+            <a:ext cx="4683099" cy="658368"/>
           </a:xfrm>
           <a:prstGeom prst="rect">
             <a:avLst/>
@@ -5345,7 +5241,7 @@
           <a:p>
             <a:pPr algn="l"/>
             <a:r>
-              <a:rPr sz="1500" b="1">
+              <a:rPr sz="1800" b="1">
                 <a:solidFill>
                   <a:srgbClr val="FFFFFF"/>
                 </a:solidFill>
@@ -5357,13 +5253,13 @@
       </p:sp>
       <p:sp>
         <p:nvSpPr>
-          <p:cNvPr id="21" name="Rectangle 20"/>
+          <p:cNvPr id="19" name="Rectangle 18"/>
           <p:cNvSpPr/>
           <p:nvPr/>
         </p:nvSpPr>
         <p:spPr>
           <a:xfrm>
-            <a:off x="6447891" y="2852928"/>
+            <a:off x="6447891" y="2944368"/>
             <a:ext cx="5250027" cy="15240"/>
           </a:xfrm>
           <a:prstGeom prst="rect">
@@ -5400,14 +5296,14 @@
       </p:sp>
       <p:sp>
         <p:nvSpPr>
-          <p:cNvPr id="22" name="TextBox 21"/>
+          <p:cNvPr id="20" name="TextBox 19"/>
           <p:cNvSpPr txBox="1"/>
           <p:nvPr/>
         </p:nvSpPr>
         <p:spPr>
           <a:xfrm>
-            <a:off x="6447891" y="2941828"/>
-            <a:ext cx="5250027" cy="3014472"/>
+            <a:off x="6447891" y="3045968"/>
+            <a:ext cx="5250027" cy="2923032"/>
           </a:xfrm>
           <a:prstGeom prst="rect">
             <a:avLst/>
@@ -5422,11 +5318,11 @@
           <a:p>
             <a:pPr algn="l">
               <a:spcBef>
-                <a:spcPts val="400"/>
+                <a:spcPts val="500"/>
               </a:spcBef>
             </a:pPr>
             <a:r>
-              <a:rPr sz="1100">
+              <a:rPr sz="1300">
                 <a:solidFill>
                   <a:srgbClr val="2FDFE5"/>
                 </a:solidFill>
@@ -5434,7 +5330,7 @@
               <a:t>▸  </a:t>
             </a:r>
             <a:r>
-              <a:rPr sz="1200">
+              <a:rPr sz="1400">
                 <a:solidFill>
                   <a:srgbClr val="D8EAFF"/>
                 </a:solidFill>
@@ -5445,11 +5341,11 @@
           <a:p>
             <a:pPr algn="l">
               <a:spcBef>
-                <a:spcPts val="400"/>
+                <a:spcPts val="500"/>
               </a:spcBef>
             </a:pPr>
             <a:r>
-              <a:rPr sz="1100">
+              <a:rPr sz="1300">
                 <a:solidFill>
                   <a:srgbClr val="2FDFE5"/>
                 </a:solidFill>
@@ -5457,7 +5353,7 @@
               <a:t>▸  </a:t>
             </a:r>
             <a:r>
-              <a:rPr sz="1200">
+              <a:rPr sz="1400">
                 <a:solidFill>
                   <a:srgbClr val="D8EAFF"/>
                 </a:solidFill>
@@ -5468,11 +5364,11 @@
           <a:p>
             <a:pPr algn="l">
               <a:spcBef>
-                <a:spcPts val="400"/>
+                <a:spcPts val="500"/>
               </a:spcBef>
             </a:pPr>
             <a:r>
-              <a:rPr sz="1100">
+              <a:rPr sz="1300">
                 <a:solidFill>
                   <a:srgbClr val="2FDFE5"/>
                 </a:solidFill>
@@ -5480,7 +5376,7 @@
               <a:t>▸  </a:t>
             </a:r>
             <a:r>
-              <a:rPr sz="1200">
+              <a:rPr sz="1400">
                 <a:solidFill>
                   <a:srgbClr val="D8EAFF"/>
                 </a:solidFill>
@@ -5492,7 +5388,7 @@
       </p:sp>
       <p:pic>
         <p:nvPicPr>
-          <p:cNvPr id="23" name="Picture 22" descr="logo_horiz.png"/>
+          <p:cNvPr id="21" name="Picture 20" descr="logo_horiz.png"/>
           <p:cNvPicPr>
             <a:picLocks noChangeAspect="1"/>
           </p:cNvPicPr>
@@ -5560,7 +5456,7 @@
                                 <p:cBhvr>
                                   <p:cTn id="8" dur="450" fill="hold"/>
                                   <p:tgtEl>
-                                    <p:spTgt spid="16"/>
+                                    <p:spTgt spid="15"/>
                                   </p:tgtEl>
                                 </p:cBhvr>
                               </p:animEffect>
@@ -5870,7 +5766,7 @@
           <a:p>
             <a:pPr algn="l"/>
             <a:r>
-              <a:rPr sz="1100" i="1">
+              <a:rPr sz="1300" i="1">
                 <a:solidFill>
                   <a:srgbClr val="80A8CC"/>
                 </a:solidFill>
@@ -5977,7 +5873,7 @@
         <p:spPr>
           <a:xfrm>
             <a:off x="704088" y="2468880"/>
-            <a:ext cx="274320" cy="274320"/>
+            <a:ext cx="347472" cy="347472"/>
           </a:xfrm>
           <a:prstGeom prst="ellipse">
             <a:avLst/>
@@ -5985,7 +5881,7 @@
           <a:solidFill>
             <a:srgbClr val="0A1638"/>
           </a:solidFill>
-          <a:ln w="15240">
+          <a:ln w="19050">
             <a:solidFill>
               <a:srgbClr val="2FDFE5"/>
             </a:solidFill>
@@ -6005,11 +5901,19 @@
             <a:schemeClr val="lt1"/>
           </a:fontRef>
         </p:style>
-        <p:txBody>
-          <a:bodyPr rtlCol="0" anchor="ctr"/>
+        <p:txBody lIns="0" tIns="0" rIns="0" bIns="0">
+          <a:bodyPr rtlCol="0" anchor="ctr" wrap="none"/>
           <a:lstStyle/>
           <a:p>
             <a:pPr algn="ctr"/>
+            <a:r>
+              <a:rPr sz="1600" b="1">
+                <a:solidFill>
+                  <a:srgbClr val="2FDFE5"/>
+                </a:solidFill>
+              </a:rPr>
+              <a:t>5</a:t>
+            </a:r>
           </a:p>
         </p:txBody>
       </p:sp>
@@ -6021,42 +5925,8 @@
         </p:nvSpPr>
         <p:spPr>
           <a:xfrm>
-            <a:off x="704088" y="2468880"/>
-            <a:ext cx="274320" cy="274320"/>
-          </a:xfrm>
-          <a:prstGeom prst="rect">
-            <a:avLst/>
-          </a:prstGeom>
-          <a:noFill/>
-        </p:spPr>
-        <p:txBody lIns="0" tIns="12700" rIns="0" bIns="0">
-          <a:bodyPr wrap="none">
-            <a:spAutoFit/>
-          </a:bodyPr>
-          <a:lstStyle/>
-          <a:p>
-            <a:pPr algn="ctr"/>
-            <a:r>
-              <a:rPr sz="1100" b="1">
-                <a:solidFill>
-                  <a:srgbClr val="2FDFE5"/>
-                </a:solidFill>
-              </a:rPr>
-              <a:t>5</a:t>
-            </a:r>
-          </a:p>
-        </p:txBody>
-      </p:sp>
-      <p:sp>
-        <p:nvSpPr>
-          <p:cNvPr id="13" name="TextBox 12"/>
-          <p:cNvSpPr txBox="1"/>
-          <p:nvPr/>
-        </p:nvSpPr>
-        <p:spPr>
-          <a:xfrm>
-            <a:off x="1088136" y="2468880"/>
-            <a:ext cx="4792827" cy="566928"/>
+            <a:off x="1179576" y="2468880"/>
+            <a:ext cx="4683099" cy="658368"/>
           </a:xfrm>
           <a:prstGeom prst="rect">
             <a:avLst/>
@@ -6071,7 +5941,7 @@
           <a:p>
             <a:pPr algn="l"/>
             <a:r>
-              <a:rPr sz="1500" b="1">
+              <a:rPr sz="1800" b="1">
                 <a:solidFill>
                   <a:srgbClr val="FFFFFF"/>
                 </a:solidFill>
@@ -6083,13 +5953,13 @@
       </p:sp>
       <p:sp>
         <p:nvSpPr>
-          <p:cNvPr id="14" name="Rectangle 13"/>
+          <p:cNvPr id="13" name="Rectangle 12"/>
           <p:cNvSpPr/>
           <p:nvPr/>
         </p:nvSpPr>
         <p:spPr>
           <a:xfrm>
-            <a:off x="667512" y="2852928"/>
+            <a:off x="667512" y="2944368"/>
             <a:ext cx="5250027" cy="15240"/>
           </a:xfrm>
           <a:prstGeom prst="rect">
@@ -6126,14 +5996,14 @@
       </p:sp>
       <p:sp>
         <p:nvSpPr>
-          <p:cNvPr id="15" name="TextBox 14"/>
+          <p:cNvPr id="14" name="TextBox 13"/>
           <p:cNvSpPr txBox="1"/>
           <p:nvPr/>
         </p:nvSpPr>
         <p:spPr>
           <a:xfrm>
-            <a:off x="667512" y="2941828"/>
-            <a:ext cx="5250027" cy="3014472"/>
+            <a:off x="667512" y="3045968"/>
+            <a:ext cx="5250027" cy="2923032"/>
           </a:xfrm>
           <a:prstGeom prst="rect">
             <a:avLst/>
@@ -6148,11 +6018,11 @@
           <a:p>
             <a:pPr algn="l">
               <a:spcBef>
-                <a:spcPts val="400"/>
+                <a:spcPts val="500"/>
               </a:spcBef>
             </a:pPr>
             <a:r>
-              <a:rPr sz="1100">
+              <a:rPr sz="1300">
                 <a:solidFill>
                   <a:srgbClr val="2FDFE5"/>
                 </a:solidFill>
@@ -6160,7 +6030,7 @@
               <a:t>▸  </a:t>
             </a:r>
             <a:r>
-              <a:rPr sz="1200">
+              <a:rPr sz="1400">
                 <a:solidFill>
                   <a:srgbClr val="D8EAFF"/>
                 </a:solidFill>
@@ -6171,11 +6041,11 @@
           <a:p>
             <a:pPr algn="l">
               <a:spcBef>
-                <a:spcPts val="400"/>
+                <a:spcPts val="500"/>
               </a:spcBef>
             </a:pPr>
             <a:r>
-              <a:rPr sz="1100">
+              <a:rPr sz="1300">
                 <a:solidFill>
                   <a:srgbClr val="2FDFE5"/>
                 </a:solidFill>
@@ -6183,7 +6053,7 @@
               <a:t>▸  </a:t>
             </a:r>
             <a:r>
-              <a:rPr sz="1200">
+              <a:rPr sz="1400">
                 <a:solidFill>
                   <a:srgbClr val="D8EAFF"/>
                 </a:solidFill>
@@ -6194,11 +6064,11 @@
           <a:p>
             <a:pPr algn="l">
               <a:spcBef>
-                <a:spcPts val="400"/>
+                <a:spcPts val="500"/>
               </a:spcBef>
             </a:pPr>
             <a:r>
-              <a:rPr sz="1100">
+              <a:rPr sz="1300">
                 <a:solidFill>
                   <a:srgbClr val="2FDFE5"/>
                 </a:solidFill>
@@ -6206,7 +6076,7 @@
               <a:t>▸  </a:t>
             </a:r>
             <a:r>
-              <a:rPr sz="1200">
+              <a:rPr sz="1400">
                 <a:solidFill>
                   <a:srgbClr val="D8EAFF"/>
                 </a:solidFill>
@@ -6218,7 +6088,7 @@
       </p:sp>
       <p:sp>
         <p:nvSpPr>
-          <p:cNvPr id="16" name="Rectangle 15"/>
+          <p:cNvPr id="15" name="Rectangle 14"/>
           <p:cNvSpPr/>
           <p:nvPr/>
         </p:nvSpPr>
@@ -6263,7 +6133,7 @@
       </p:sp>
       <p:sp>
         <p:nvSpPr>
-          <p:cNvPr id="17" name="Rectangle 16"/>
+          <p:cNvPr id="16" name="Rectangle 15"/>
           <p:cNvSpPr/>
           <p:nvPr/>
         </p:nvSpPr>
@@ -6306,14 +6176,14 @@
       </p:sp>
       <p:sp>
         <p:nvSpPr>
-          <p:cNvPr id="18" name="Oval 17"/>
+          <p:cNvPr id="17" name="Oval 16"/>
           <p:cNvSpPr/>
           <p:nvPr/>
         </p:nvSpPr>
         <p:spPr>
           <a:xfrm>
             <a:off x="6484467" y="2468880"/>
-            <a:ext cx="274320" cy="274320"/>
+            <a:ext cx="347472" cy="347472"/>
           </a:xfrm>
           <a:prstGeom prst="ellipse">
             <a:avLst/>
@@ -6321,7 +6191,7 @@
           <a:solidFill>
             <a:srgbClr val="0A1638"/>
           </a:solidFill>
-          <a:ln w="15240">
+          <a:ln w="19050">
             <a:solidFill>
               <a:srgbClr val="2FDFE5"/>
             </a:solidFill>
@@ -6341,58 +6211,32 @@
             <a:schemeClr val="lt1"/>
           </a:fontRef>
         </p:style>
-        <p:txBody>
-          <a:bodyPr rtlCol="0" anchor="ctr"/>
+        <p:txBody lIns="0" tIns="0" rIns="0" bIns="0">
+          <a:bodyPr rtlCol="0" anchor="ctr" wrap="none"/>
           <a:lstStyle/>
           <a:p>
             <a:pPr algn="ctr"/>
-          </a:p>
-        </p:txBody>
-      </p:sp>
-      <p:sp>
-        <p:nvSpPr>
-          <p:cNvPr id="19" name="TextBox 18"/>
+            <a:r>
+              <a:rPr sz="1600" b="1">
+                <a:solidFill>
+                  <a:srgbClr val="2FDFE5"/>
+                </a:solidFill>
+              </a:rPr>
+              <a:t>6</a:t>
+            </a:r>
+          </a:p>
+        </p:txBody>
+      </p:sp>
+      <p:sp>
+        <p:nvSpPr>
+          <p:cNvPr id="18" name="TextBox 17"/>
           <p:cNvSpPr txBox="1"/>
           <p:nvPr/>
         </p:nvSpPr>
         <p:spPr>
           <a:xfrm>
-            <a:off x="6484467" y="2468880"/>
-            <a:ext cx="274320" cy="274320"/>
-          </a:xfrm>
-          <a:prstGeom prst="rect">
-            <a:avLst/>
-          </a:prstGeom>
-          <a:noFill/>
-        </p:spPr>
-        <p:txBody lIns="0" tIns="12700" rIns="0" bIns="0">
-          <a:bodyPr wrap="none">
-            <a:spAutoFit/>
-          </a:bodyPr>
-          <a:lstStyle/>
-          <a:p>
-            <a:pPr algn="ctr"/>
-            <a:r>
-              <a:rPr sz="1100" b="1">
-                <a:solidFill>
-                  <a:srgbClr val="2FDFE5"/>
-                </a:solidFill>
-              </a:rPr>
-              <a:t>6</a:t>
-            </a:r>
-          </a:p>
-        </p:txBody>
-      </p:sp>
-      <p:sp>
-        <p:nvSpPr>
-          <p:cNvPr id="20" name="TextBox 19"/>
-          <p:cNvSpPr txBox="1"/>
-          <p:nvPr/>
-        </p:nvSpPr>
-        <p:spPr>
-          <a:xfrm>
-            <a:off x="6868515" y="2468880"/>
-            <a:ext cx="4792827" cy="566928"/>
+            <a:off x="6959955" y="2468880"/>
+            <a:ext cx="4683099" cy="658368"/>
           </a:xfrm>
           <a:prstGeom prst="rect">
             <a:avLst/>
@@ -6407,7 +6251,7 @@
           <a:p>
             <a:pPr algn="l"/>
             <a:r>
-              <a:rPr sz="1500" b="1">
+              <a:rPr sz="1800" b="1">
                 <a:solidFill>
                   <a:srgbClr val="FFFFFF"/>
                 </a:solidFill>
@@ -6419,13 +6263,13 @@
       </p:sp>
       <p:sp>
         <p:nvSpPr>
-          <p:cNvPr id="21" name="Rectangle 20"/>
+          <p:cNvPr id="19" name="Rectangle 18"/>
           <p:cNvSpPr/>
           <p:nvPr/>
         </p:nvSpPr>
         <p:spPr>
           <a:xfrm>
-            <a:off x="6447891" y="2852928"/>
+            <a:off x="6447891" y="2944368"/>
             <a:ext cx="5250027" cy="15240"/>
           </a:xfrm>
           <a:prstGeom prst="rect">
@@ -6462,14 +6306,14 @@
       </p:sp>
       <p:sp>
         <p:nvSpPr>
-          <p:cNvPr id="22" name="TextBox 21"/>
+          <p:cNvPr id="20" name="TextBox 19"/>
           <p:cNvSpPr txBox="1"/>
           <p:nvPr/>
         </p:nvSpPr>
         <p:spPr>
           <a:xfrm>
-            <a:off x="6447891" y="2941828"/>
-            <a:ext cx="5250027" cy="3014472"/>
+            <a:off x="6447891" y="3045968"/>
+            <a:ext cx="5250027" cy="2923032"/>
           </a:xfrm>
           <a:prstGeom prst="rect">
             <a:avLst/>
@@ -6484,11 +6328,11 @@
           <a:p>
             <a:pPr algn="l">
               <a:spcBef>
-                <a:spcPts val="400"/>
+                <a:spcPts val="500"/>
               </a:spcBef>
             </a:pPr>
             <a:r>
-              <a:rPr sz="1100">
+              <a:rPr sz="1300">
                 <a:solidFill>
                   <a:srgbClr val="2FDFE5"/>
                 </a:solidFill>
@@ -6496,7 +6340,7 @@
               <a:t>▸  </a:t>
             </a:r>
             <a:r>
-              <a:rPr sz="1200">
+              <a:rPr sz="1400">
                 <a:solidFill>
                   <a:srgbClr val="D8EAFF"/>
                 </a:solidFill>
@@ -6507,11 +6351,11 @@
           <a:p>
             <a:pPr algn="l">
               <a:spcBef>
-                <a:spcPts val="400"/>
+                <a:spcPts val="500"/>
               </a:spcBef>
             </a:pPr>
             <a:r>
-              <a:rPr sz="1100">
+              <a:rPr sz="1300">
                 <a:solidFill>
                   <a:srgbClr val="2FDFE5"/>
                 </a:solidFill>
@@ -6519,7 +6363,7 @@
               <a:t>▸  </a:t>
             </a:r>
             <a:r>
-              <a:rPr sz="1200">
+              <a:rPr sz="1400">
                 <a:solidFill>
                   <a:srgbClr val="D8EAFF"/>
                 </a:solidFill>
@@ -6530,11 +6374,11 @@
           <a:p>
             <a:pPr algn="l">
               <a:spcBef>
-                <a:spcPts val="400"/>
+                <a:spcPts val="500"/>
               </a:spcBef>
             </a:pPr>
             <a:r>
-              <a:rPr sz="1100">
+              <a:rPr sz="1300">
                 <a:solidFill>
                   <a:srgbClr val="2FDFE5"/>
                 </a:solidFill>
@@ -6542,7 +6386,7 @@
               <a:t>▸  </a:t>
             </a:r>
             <a:r>
-              <a:rPr sz="1200">
+              <a:rPr sz="1400">
                 <a:solidFill>
                   <a:srgbClr val="D8EAFF"/>
                 </a:solidFill>
@@ -6554,7 +6398,7 @@
       </p:sp>
       <p:pic>
         <p:nvPicPr>
-          <p:cNvPr id="23" name="Picture 22" descr="logo_horiz.png"/>
+          <p:cNvPr id="21" name="Picture 20" descr="logo_horiz.png"/>
           <p:cNvPicPr>
             <a:picLocks noChangeAspect="1"/>
           </p:cNvPicPr>
@@ -6622,7 +6466,7 @@
                                 <p:cBhvr>
                                   <p:cTn id="8" dur="450" fill="hold"/>
                                   <p:tgtEl>
-                                    <p:spTgt spid="16"/>
+                                    <p:spTgt spid="15"/>
                                   </p:tgtEl>
                                 </p:cBhvr>
                               </p:animEffect>
@@ -6932,7 +6776,7 @@
           <a:p>
             <a:pPr algn="l"/>
             <a:r>
-              <a:rPr sz="1100" i="1">
+              <a:rPr sz="1300" i="1">
                 <a:solidFill>
                   <a:srgbClr val="80A8CC"/>
                 </a:solidFill>
@@ -7039,7 +6883,7 @@
         <p:spPr>
           <a:xfrm>
             <a:off x="704088" y="2468880"/>
-            <a:ext cx="274320" cy="274320"/>
+            <a:ext cx="347472" cy="347472"/>
           </a:xfrm>
           <a:prstGeom prst="ellipse">
             <a:avLst/>
@@ -7047,7 +6891,7 @@
           <a:solidFill>
             <a:srgbClr val="0A1638"/>
           </a:solidFill>
-          <a:ln w="15240">
+          <a:ln w="19050">
             <a:solidFill>
               <a:srgbClr val="2FDFE5"/>
             </a:solidFill>
@@ -7067,11 +6911,19 @@
             <a:schemeClr val="lt1"/>
           </a:fontRef>
         </p:style>
-        <p:txBody>
-          <a:bodyPr rtlCol="0" anchor="ctr"/>
+        <p:txBody lIns="0" tIns="0" rIns="0" bIns="0">
+          <a:bodyPr rtlCol="0" anchor="ctr" wrap="none"/>
           <a:lstStyle/>
           <a:p>
             <a:pPr algn="ctr"/>
+            <a:r>
+              <a:rPr sz="1600" b="1">
+                <a:solidFill>
+                  <a:srgbClr val="2FDFE5"/>
+                </a:solidFill>
+              </a:rPr>
+              <a:t>7</a:t>
+            </a:r>
           </a:p>
         </p:txBody>
       </p:sp>
@@ -7083,42 +6935,8 @@
         </p:nvSpPr>
         <p:spPr>
           <a:xfrm>
-            <a:off x="704088" y="2468880"/>
-            <a:ext cx="274320" cy="274320"/>
-          </a:xfrm>
-          <a:prstGeom prst="rect">
-            <a:avLst/>
-          </a:prstGeom>
-          <a:noFill/>
-        </p:spPr>
-        <p:txBody lIns="0" tIns="12700" rIns="0" bIns="0">
-          <a:bodyPr wrap="none">
-            <a:spAutoFit/>
-          </a:bodyPr>
-          <a:lstStyle/>
-          <a:p>
-            <a:pPr algn="ctr"/>
-            <a:r>
-              <a:rPr sz="1100" b="1">
-                <a:solidFill>
-                  <a:srgbClr val="2FDFE5"/>
-                </a:solidFill>
-              </a:rPr>
-              <a:t>7</a:t>
-            </a:r>
-          </a:p>
-        </p:txBody>
-      </p:sp>
-      <p:sp>
-        <p:nvSpPr>
-          <p:cNvPr id="13" name="TextBox 12"/>
-          <p:cNvSpPr txBox="1"/>
-          <p:nvPr/>
-        </p:nvSpPr>
-        <p:spPr>
-          <a:xfrm>
-            <a:off x="1088136" y="2468880"/>
-            <a:ext cx="4792827" cy="566928"/>
+            <a:off x="1179576" y="2468880"/>
+            <a:ext cx="4683099" cy="658368"/>
           </a:xfrm>
           <a:prstGeom prst="rect">
             <a:avLst/>
@@ -7133,7 +6951,7 @@
           <a:p>
             <a:pPr algn="l"/>
             <a:r>
-              <a:rPr sz="1500" b="1">
+              <a:rPr sz="1800" b="1">
                 <a:solidFill>
                   <a:srgbClr val="FFFFFF"/>
                 </a:solidFill>
@@ -7145,13 +6963,13 @@
       </p:sp>
       <p:sp>
         <p:nvSpPr>
-          <p:cNvPr id="14" name="Rectangle 13"/>
+          <p:cNvPr id="13" name="Rectangle 12"/>
           <p:cNvSpPr/>
           <p:nvPr/>
         </p:nvSpPr>
         <p:spPr>
           <a:xfrm>
-            <a:off x="667512" y="2852928"/>
+            <a:off x="667512" y="2944368"/>
             <a:ext cx="5250027" cy="15240"/>
           </a:xfrm>
           <a:prstGeom prst="rect">
@@ -7188,14 +7006,14 @@
       </p:sp>
       <p:sp>
         <p:nvSpPr>
-          <p:cNvPr id="15" name="TextBox 14"/>
+          <p:cNvPr id="14" name="TextBox 13"/>
           <p:cNvSpPr txBox="1"/>
           <p:nvPr/>
         </p:nvSpPr>
         <p:spPr>
           <a:xfrm>
-            <a:off x="667512" y="2941828"/>
-            <a:ext cx="5250027" cy="3014472"/>
+            <a:off x="667512" y="3045968"/>
+            <a:ext cx="5250027" cy="2923032"/>
           </a:xfrm>
           <a:prstGeom prst="rect">
             <a:avLst/>
@@ -7210,11 +7028,11 @@
           <a:p>
             <a:pPr algn="l">
               <a:spcBef>
-                <a:spcPts val="400"/>
+                <a:spcPts val="500"/>
               </a:spcBef>
             </a:pPr>
             <a:r>
-              <a:rPr sz="1100">
+              <a:rPr sz="1300">
                 <a:solidFill>
                   <a:srgbClr val="2FDFE5"/>
                 </a:solidFill>
@@ -7222,7 +7040,7 @@
               <a:t>▸  </a:t>
             </a:r>
             <a:r>
-              <a:rPr sz="1200">
+              <a:rPr sz="1400">
                 <a:solidFill>
                   <a:srgbClr val="D8EAFF"/>
                 </a:solidFill>
@@ -7233,11 +7051,11 @@
           <a:p>
             <a:pPr algn="l">
               <a:spcBef>
-                <a:spcPts val="400"/>
+                <a:spcPts val="500"/>
               </a:spcBef>
             </a:pPr>
             <a:r>
-              <a:rPr sz="1100">
+              <a:rPr sz="1300">
                 <a:solidFill>
                   <a:srgbClr val="2FDFE5"/>
                 </a:solidFill>
@@ -7245,7 +7063,7 @@
               <a:t>▸  </a:t>
             </a:r>
             <a:r>
-              <a:rPr sz="1200">
+              <a:rPr sz="1400">
                 <a:solidFill>
                   <a:srgbClr val="D8EAFF"/>
                 </a:solidFill>
@@ -7256,11 +7074,11 @@
           <a:p>
             <a:pPr algn="l">
               <a:spcBef>
-                <a:spcPts val="400"/>
+                <a:spcPts val="500"/>
               </a:spcBef>
             </a:pPr>
             <a:r>
-              <a:rPr sz="1100">
+              <a:rPr sz="1300">
                 <a:solidFill>
                   <a:srgbClr val="2FDFE5"/>
                 </a:solidFill>
@@ -7268,7 +7086,7 @@
               <a:t>▸  </a:t>
             </a:r>
             <a:r>
-              <a:rPr sz="1200">
+              <a:rPr sz="1400">
                 <a:solidFill>
                   <a:srgbClr val="D8EAFF"/>
                 </a:solidFill>
@@ -7280,7 +7098,7 @@
       </p:sp>
       <p:sp>
         <p:nvSpPr>
-          <p:cNvPr id="16" name="Rectangle 15"/>
+          <p:cNvPr id="15" name="Rectangle 14"/>
           <p:cNvSpPr/>
           <p:nvPr/>
         </p:nvSpPr>
@@ -7325,7 +7143,7 @@
       </p:sp>
       <p:sp>
         <p:nvSpPr>
-          <p:cNvPr id="17" name="Rectangle 16"/>
+          <p:cNvPr id="16" name="Rectangle 15"/>
           <p:cNvSpPr/>
           <p:nvPr/>
         </p:nvSpPr>
@@ -7368,14 +7186,14 @@
       </p:sp>
       <p:sp>
         <p:nvSpPr>
-          <p:cNvPr id="18" name="Oval 17"/>
+          <p:cNvPr id="17" name="Oval 16"/>
           <p:cNvSpPr/>
           <p:nvPr/>
         </p:nvSpPr>
         <p:spPr>
           <a:xfrm>
             <a:off x="6484467" y="2468880"/>
-            <a:ext cx="274320" cy="274320"/>
+            <a:ext cx="347472" cy="347472"/>
           </a:xfrm>
           <a:prstGeom prst="ellipse">
             <a:avLst/>
@@ -7383,7 +7201,7 @@
           <a:solidFill>
             <a:srgbClr val="0A1638"/>
           </a:solidFill>
-          <a:ln w="15240">
+          <a:ln w="19050">
             <a:solidFill>
               <a:srgbClr val="2FDFE5"/>
             </a:solidFill>
@@ -7403,58 +7221,32 @@
             <a:schemeClr val="lt1"/>
           </a:fontRef>
         </p:style>
-        <p:txBody>
-          <a:bodyPr rtlCol="0" anchor="ctr"/>
+        <p:txBody lIns="0" tIns="0" rIns="0" bIns="0">
+          <a:bodyPr rtlCol="0" anchor="ctr" wrap="none"/>
           <a:lstStyle/>
           <a:p>
             <a:pPr algn="ctr"/>
-          </a:p>
-        </p:txBody>
-      </p:sp>
-      <p:sp>
-        <p:nvSpPr>
-          <p:cNvPr id="19" name="TextBox 18"/>
+            <a:r>
+              <a:rPr sz="1600" b="1">
+                <a:solidFill>
+                  <a:srgbClr val="2FDFE5"/>
+                </a:solidFill>
+              </a:rPr>
+              <a:t>8</a:t>
+            </a:r>
+          </a:p>
+        </p:txBody>
+      </p:sp>
+      <p:sp>
+        <p:nvSpPr>
+          <p:cNvPr id="18" name="TextBox 17"/>
           <p:cNvSpPr txBox="1"/>
           <p:nvPr/>
         </p:nvSpPr>
         <p:spPr>
           <a:xfrm>
-            <a:off x="6484467" y="2468880"/>
-            <a:ext cx="274320" cy="274320"/>
-          </a:xfrm>
-          <a:prstGeom prst="rect">
-            <a:avLst/>
-          </a:prstGeom>
-          <a:noFill/>
-        </p:spPr>
-        <p:txBody lIns="0" tIns="12700" rIns="0" bIns="0">
-          <a:bodyPr wrap="none">
-            <a:spAutoFit/>
-          </a:bodyPr>
-          <a:lstStyle/>
-          <a:p>
-            <a:pPr algn="ctr"/>
-            <a:r>
-              <a:rPr sz="1100" b="1">
-                <a:solidFill>
-                  <a:srgbClr val="2FDFE5"/>
-                </a:solidFill>
-              </a:rPr>
-              <a:t>8</a:t>
-            </a:r>
-          </a:p>
-        </p:txBody>
-      </p:sp>
-      <p:sp>
-        <p:nvSpPr>
-          <p:cNvPr id="20" name="TextBox 19"/>
-          <p:cNvSpPr txBox="1"/>
-          <p:nvPr/>
-        </p:nvSpPr>
-        <p:spPr>
-          <a:xfrm>
-            <a:off x="6868515" y="2468880"/>
-            <a:ext cx="4792827" cy="566928"/>
+            <a:off x="6959955" y="2468880"/>
+            <a:ext cx="4683099" cy="658368"/>
           </a:xfrm>
           <a:prstGeom prst="rect">
             <a:avLst/>
@@ -7469,7 +7261,7 @@
           <a:p>
             <a:pPr algn="l"/>
             <a:r>
-              <a:rPr sz="1500" b="1">
+              <a:rPr sz="1800" b="1">
                 <a:solidFill>
                   <a:srgbClr val="FFFFFF"/>
                 </a:solidFill>
@@ -7481,13 +7273,13 @@
       </p:sp>
       <p:sp>
         <p:nvSpPr>
-          <p:cNvPr id="21" name="Rectangle 20"/>
+          <p:cNvPr id="19" name="Rectangle 18"/>
           <p:cNvSpPr/>
           <p:nvPr/>
         </p:nvSpPr>
         <p:spPr>
           <a:xfrm>
-            <a:off x="6447891" y="2852928"/>
+            <a:off x="6447891" y="2944368"/>
             <a:ext cx="5250027" cy="15240"/>
           </a:xfrm>
           <a:prstGeom prst="rect">
@@ -7524,14 +7316,14 @@
       </p:sp>
       <p:sp>
         <p:nvSpPr>
-          <p:cNvPr id="22" name="TextBox 21"/>
+          <p:cNvPr id="20" name="TextBox 19"/>
           <p:cNvSpPr txBox="1"/>
           <p:nvPr/>
         </p:nvSpPr>
         <p:spPr>
           <a:xfrm>
-            <a:off x="6447891" y="2941828"/>
-            <a:ext cx="5250027" cy="3014472"/>
+            <a:off x="6447891" y="3045968"/>
+            <a:ext cx="5250027" cy="2923032"/>
           </a:xfrm>
           <a:prstGeom prst="rect">
             <a:avLst/>
@@ -7546,11 +7338,11 @@
           <a:p>
             <a:pPr algn="l">
               <a:spcBef>
-                <a:spcPts val="400"/>
+                <a:spcPts val="500"/>
               </a:spcBef>
             </a:pPr>
             <a:r>
-              <a:rPr sz="1100">
+              <a:rPr sz="1300">
                 <a:solidFill>
                   <a:srgbClr val="2FDFE5"/>
                 </a:solidFill>
@@ -7558,7 +7350,7 @@
               <a:t>▸  </a:t>
             </a:r>
             <a:r>
-              <a:rPr sz="1200">
+              <a:rPr sz="1400">
                 <a:solidFill>
                   <a:srgbClr val="D8EAFF"/>
                 </a:solidFill>
@@ -7569,11 +7361,11 @@
           <a:p>
             <a:pPr algn="l">
               <a:spcBef>
-                <a:spcPts val="400"/>
+                <a:spcPts val="500"/>
               </a:spcBef>
             </a:pPr>
             <a:r>
-              <a:rPr sz="1100">
+              <a:rPr sz="1300">
                 <a:solidFill>
                   <a:srgbClr val="2FDFE5"/>
                 </a:solidFill>
@@ -7581,7 +7373,7 @@
               <a:t>▸  </a:t>
             </a:r>
             <a:r>
-              <a:rPr sz="1200">
+              <a:rPr sz="1400">
                 <a:solidFill>
                   <a:srgbClr val="D8EAFF"/>
                 </a:solidFill>
@@ -7592,11 +7384,11 @@
           <a:p>
             <a:pPr algn="l">
               <a:spcBef>
-                <a:spcPts val="400"/>
+                <a:spcPts val="500"/>
               </a:spcBef>
             </a:pPr>
             <a:r>
-              <a:rPr sz="1100">
+              <a:rPr sz="1300">
                 <a:solidFill>
                   <a:srgbClr val="2FDFE5"/>
                 </a:solidFill>
@@ -7604,7 +7396,7 @@
               <a:t>▸  </a:t>
             </a:r>
             <a:r>
-              <a:rPr sz="1200">
+              <a:rPr sz="1400">
                 <a:solidFill>
                   <a:srgbClr val="D8EAFF"/>
                 </a:solidFill>
@@ -7616,7 +7408,7 @@
       </p:sp>
       <p:pic>
         <p:nvPicPr>
-          <p:cNvPr id="23" name="Picture 22" descr="logo_horiz.png"/>
+          <p:cNvPr id="21" name="Picture 20" descr="logo_horiz.png"/>
           <p:cNvPicPr>
             <a:picLocks noChangeAspect="1"/>
           </p:cNvPicPr>
@@ -7684,7 +7476,7 @@
                                 <p:cBhvr>
                                   <p:cTn id="8" dur="450" fill="hold"/>
                                   <p:tgtEl>
-                                    <p:spTgt spid="16"/>
+                                    <p:spTgt spid="15"/>
                                   </p:tgtEl>
                                 </p:cBhvr>
                               </p:animEffect>
@@ -8067,7 +7859,7 @@
         <p:spPr>
           <a:xfrm>
             <a:off x="685800" y="2084832"/>
-            <a:ext cx="256032" cy="256032"/>
+            <a:ext cx="329184" cy="329184"/>
           </a:xfrm>
           <a:prstGeom prst="ellipse">
             <a:avLst/>
@@ -8075,7 +7867,7 @@
           <a:solidFill>
             <a:srgbClr val="0A1638"/>
           </a:solidFill>
-          <a:ln w="15240">
+          <a:ln w="19050">
             <a:solidFill>
               <a:srgbClr val="2FDFE5"/>
             </a:solidFill>
@@ -8095,11 +7887,19 @@
             <a:schemeClr val="lt1"/>
           </a:fontRef>
         </p:style>
-        <p:txBody>
-          <a:bodyPr rtlCol="0" anchor="ctr"/>
+        <p:txBody lIns="0" tIns="0" rIns="0" bIns="0">
+          <a:bodyPr rtlCol="0" anchor="ctr" wrap="none"/>
           <a:lstStyle/>
           <a:p>
             <a:pPr algn="ctr"/>
+            <a:r>
+              <a:rPr sz="1600" b="1">
+                <a:solidFill>
+                  <a:srgbClr val="2FDFE5"/>
+                </a:solidFill>
+              </a:rPr>
+              <a:t>1</a:t>
+            </a:r>
           </a:p>
         </p:txBody>
       </p:sp>
@@ -8111,42 +7911,8 @@
         </p:nvSpPr>
         <p:spPr>
           <a:xfrm>
-            <a:off x="685800" y="2084832"/>
-            <a:ext cx="256032" cy="256032"/>
-          </a:xfrm>
-          <a:prstGeom prst="rect">
-            <a:avLst/>
-          </a:prstGeom>
-          <a:noFill/>
-        </p:spPr>
-        <p:txBody lIns="0" tIns="12700" rIns="0" bIns="0">
-          <a:bodyPr wrap="none">
-            <a:spAutoFit/>
-          </a:bodyPr>
-          <a:lstStyle/>
-          <a:p>
-            <a:pPr algn="ctr"/>
-            <a:r>
-              <a:rPr sz="1100" b="1">
-                <a:solidFill>
-                  <a:srgbClr val="2FDFE5"/>
-                </a:solidFill>
-              </a:rPr>
-              <a:t>1</a:t>
-            </a:r>
-          </a:p>
-        </p:txBody>
-      </p:sp>
-      <p:sp>
-        <p:nvSpPr>
-          <p:cNvPr id="12" name="TextBox 11"/>
-          <p:cNvSpPr txBox="1"/>
-          <p:nvPr/>
-        </p:nvSpPr>
-        <p:spPr>
-          <a:xfrm>
-            <a:off x="1051560" y="2084832"/>
-            <a:ext cx="4865979" cy="512064"/>
+            <a:off x="1143000" y="2084832"/>
+            <a:ext cx="4756251" cy="585216"/>
           </a:xfrm>
           <a:prstGeom prst="rect">
             <a:avLst/>
@@ -8161,7 +7927,7 @@
           <a:p>
             <a:pPr algn="l"/>
             <a:r>
-              <a:rPr sz="1400" b="1">
+              <a:rPr sz="1700" b="1">
                 <a:solidFill>
                   <a:srgbClr val="FFFFFF"/>
                 </a:solidFill>
@@ -8173,13 +7939,13 @@
       </p:sp>
       <p:sp>
         <p:nvSpPr>
-          <p:cNvPr id="13" name="Rectangle 12"/>
+          <p:cNvPr id="12" name="Rectangle 11"/>
           <p:cNvSpPr/>
           <p:nvPr/>
         </p:nvSpPr>
         <p:spPr>
           <a:xfrm>
-            <a:off x="649224" y="2450592"/>
+            <a:off x="649224" y="2542032"/>
             <a:ext cx="5286603" cy="12700"/>
           </a:xfrm>
           <a:prstGeom prst="rect">
@@ -8216,14 +7982,14 @@
       </p:sp>
       <p:sp>
         <p:nvSpPr>
-          <p:cNvPr id="14" name="TextBox 13"/>
+          <p:cNvPr id="13" name="TextBox 12"/>
           <p:cNvSpPr txBox="1"/>
           <p:nvPr/>
         </p:nvSpPr>
         <p:spPr>
           <a:xfrm>
-            <a:off x="649224" y="2526792"/>
-            <a:ext cx="5286603" cy="1308100"/>
+            <a:off x="649224" y="2630932"/>
+            <a:ext cx="5286603" cy="1216660"/>
           </a:xfrm>
           <a:prstGeom prst="rect">
             <a:avLst/>
@@ -8238,7 +8004,7 @@
           <a:p>
             <a:pPr algn="l"/>
             <a:r>
-              <a:rPr sz="1150">
+              <a:rPr sz="1400">
                 <a:solidFill>
                   <a:srgbClr val="D8EAFF"/>
                 </a:solidFill>
@@ -8250,7 +8016,7 @@
       </p:sp>
       <p:sp>
         <p:nvSpPr>
-          <p:cNvPr id="15" name="Rectangle 14"/>
+          <p:cNvPr id="14" name="Rectangle 13"/>
           <p:cNvSpPr/>
           <p:nvPr/>
         </p:nvSpPr>
@@ -8295,7 +8061,7 @@
       </p:sp>
       <p:sp>
         <p:nvSpPr>
-          <p:cNvPr id="16" name="Rectangle 15"/>
+          <p:cNvPr id="15" name="Rectangle 14"/>
           <p:cNvSpPr/>
           <p:nvPr/>
         </p:nvSpPr>
@@ -8338,14 +8104,14 @@
       </p:sp>
       <p:sp>
         <p:nvSpPr>
-          <p:cNvPr id="17" name="Oval 16"/>
+          <p:cNvPr id="16" name="Oval 15"/>
           <p:cNvSpPr/>
           <p:nvPr/>
         </p:nvSpPr>
         <p:spPr>
           <a:xfrm>
             <a:off x="6466179" y="2084832"/>
-            <a:ext cx="256032" cy="256032"/>
+            <a:ext cx="329184" cy="329184"/>
           </a:xfrm>
           <a:prstGeom prst="ellipse">
             <a:avLst/>
@@ -8353,7 +8119,7 @@
           <a:solidFill>
             <a:srgbClr val="0A1638"/>
           </a:solidFill>
-          <a:ln w="15240">
+          <a:ln w="19050">
             <a:solidFill>
               <a:srgbClr val="2FDFE5"/>
             </a:solidFill>
@@ -8373,58 +8139,32 @@
             <a:schemeClr val="lt1"/>
           </a:fontRef>
         </p:style>
-        <p:txBody>
-          <a:bodyPr rtlCol="0" anchor="ctr"/>
+        <p:txBody lIns="0" tIns="0" rIns="0" bIns="0">
+          <a:bodyPr rtlCol="0" anchor="ctr" wrap="none"/>
           <a:lstStyle/>
           <a:p>
             <a:pPr algn="ctr"/>
-          </a:p>
-        </p:txBody>
-      </p:sp>
-      <p:sp>
-        <p:nvSpPr>
-          <p:cNvPr id="18" name="TextBox 17"/>
+            <a:r>
+              <a:rPr sz="1600" b="1">
+                <a:solidFill>
+                  <a:srgbClr val="2FDFE5"/>
+                </a:solidFill>
+              </a:rPr>
+              <a:t>2</a:t>
+            </a:r>
+          </a:p>
+        </p:txBody>
+      </p:sp>
+      <p:sp>
+        <p:nvSpPr>
+          <p:cNvPr id="17" name="TextBox 16"/>
           <p:cNvSpPr txBox="1"/>
           <p:nvPr/>
         </p:nvSpPr>
         <p:spPr>
           <a:xfrm>
-            <a:off x="6466179" y="2084832"/>
-            <a:ext cx="256032" cy="256032"/>
-          </a:xfrm>
-          <a:prstGeom prst="rect">
-            <a:avLst/>
-          </a:prstGeom>
-          <a:noFill/>
-        </p:spPr>
-        <p:txBody lIns="0" tIns="12700" rIns="0" bIns="0">
-          <a:bodyPr wrap="none">
-            <a:spAutoFit/>
-          </a:bodyPr>
-          <a:lstStyle/>
-          <a:p>
-            <a:pPr algn="ctr"/>
-            <a:r>
-              <a:rPr sz="1100" b="1">
-                <a:solidFill>
-                  <a:srgbClr val="2FDFE5"/>
-                </a:solidFill>
-              </a:rPr>
-              <a:t>2</a:t>
-            </a:r>
-          </a:p>
-        </p:txBody>
-      </p:sp>
-      <p:sp>
-        <p:nvSpPr>
-          <p:cNvPr id="19" name="TextBox 18"/>
-          <p:cNvSpPr txBox="1"/>
-          <p:nvPr/>
-        </p:nvSpPr>
-        <p:spPr>
-          <a:xfrm>
-            <a:off x="6831939" y="2084832"/>
-            <a:ext cx="4865979" cy="512064"/>
+            <a:off x="6923379" y="2084832"/>
+            <a:ext cx="4756251" cy="585216"/>
           </a:xfrm>
           <a:prstGeom prst="rect">
             <a:avLst/>
@@ -8439,7 +8179,7 @@
           <a:p>
             <a:pPr algn="l"/>
             <a:r>
-              <a:rPr sz="1400" b="1">
+              <a:rPr sz="1700" b="1">
                 <a:solidFill>
                   <a:srgbClr val="FFFFFF"/>
                 </a:solidFill>
@@ -8451,13 +8191,13 @@
       </p:sp>
       <p:sp>
         <p:nvSpPr>
-          <p:cNvPr id="20" name="Rectangle 19"/>
+          <p:cNvPr id="18" name="Rectangle 17"/>
           <p:cNvSpPr/>
           <p:nvPr/>
         </p:nvSpPr>
         <p:spPr>
           <a:xfrm>
-            <a:off x="6429603" y="2450592"/>
+            <a:off x="6429603" y="2542032"/>
             <a:ext cx="5286603" cy="12700"/>
           </a:xfrm>
           <a:prstGeom prst="rect">
@@ -8494,14 +8234,14 @@
       </p:sp>
       <p:sp>
         <p:nvSpPr>
-          <p:cNvPr id="21" name="TextBox 20"/>
+          <p:cNvPr id="19" name="TextBox 18"/>
           <p:cNvSpPr txBox="1"/>
           <p:nvPr/>
         </p:nvSpPr>
         <p:spPr>
           <a:xfrm>
-            <a:off x="6429603" y="2526792"/>
-            <a:ext cx="5286603" cy="1308100"/>
+            <a:off x="6429603" y="2630932"/>
+            <a:ext cx="5286603" cy="1216660"/>
           </a:xfrm>
           <a:prstGeom prst="rect">
             <a:avLst/>
@@ -8516,7 +8256,7 @@
           <a:p>
             <a:pPr algn="l"/>
             <a:r>
-              <a:rPr sz="1150">
+              <a:rPr sz="1400">
                 <a:solidFill>
                   <a:srgbClr val="D8EAFF"/>
                 </a:solidFill>
@@ -8528,7 +8268,7 @@
       </p:sp>
       <p:sp>
         <p:nvSpPr>
-          <p:cNvPr id="22" name="Rectangle 21"/>
+          <p:cNvPr id="20" name="Rectangle 19"/>
           <p:cNvSpPr/>
           <p:nvPr/>
         </p:nvSpPr>
@@ -8573,7 +8313,7 @@
       </p:sp>
       <p:sp>
         <p:nvSpPr>
-          <p:cNvPr id="23" name="Rectangle 22"/>
+          <p:cNvPr id="21" name="Rectangle 20"/>
           <p:cNvSpPr/>
           <p:nvPr/>
         </p:nvSpPr>
@@ -8616,14 +8356,14 @@
       </p:sp>
       <p:sp>
         <p:nvSpPr>
-          <p:cNvPr id="24" name="Oval 23"/>
+          <p:cNvPr id="22" name="Oval 21"/>
           <p:cNvSpPr/>
           <p:nvPr/>
         </p:nvSpPr>
         <p:spPr>
           <a:xfrm>
             <a:off x="685800" y="4224528"/>
-            <a:ext cx="256032" cy="256032"/>
+            <a:ext cx="329184" cy="329184"/>
           </a:xfrm>
           <a:prstGeom prst="ellipse">
             <a:avLst/>
@@ -8631,7 +8371,7 @@
           <a:solidFill>
             <a:srgbClr val="0A1638"/>
           </a:solidFill>
-          <a:ln w="15240">
+          <a:ln w="19050">
             <a:solidFill>
               <a:srgbClr val="2FDFE5"/>
             </a:solidFill>
@@ -8651,58 +8391,32 @@
             <a:schemeClr val="lt1"/>
           </a:fontRef>
         </p:style>
-        <p:txBody>
-          <a:bodyPr rtlCol="0" anchor="ctr"/>
+        <p:txBody lIns="0" tIns="0" rIns="0" bIns="0">
+          <a:bodyPr rtlCol="0" anchor="ctr" wrap="none"/>
           <a:lstStyle/>
           <a:p>
             <a:pPr algn="ctr"/>
-          </a:p>
-        </p:txBody>
-      </p:sp>
-      <p:sp>
-        <p:nvSpPr>
-          <p:cNvPr id="25" name="TextBox 24"/>
+            <a:r>
+              <a:rPr sz="1600" b="1">
+                <a:solidFill>
+                  <a:srgbClr val="2FDFE5"/>
+                </a:solidFill>
+              </a:rPr>
+              <a:t>3</a:t>
+            </a:r>
+          </a:p>
+        </p:txBody>
+      </p:sp>
+      <p:sp>
+        <p:nvSpPr>
+          <p:cNvPr id="23" name="TextBox 22"/>
           <p:cNvSpPr txBox="1"/>
           <p:nvPr/>
         </p:nvSpPr>
         <p:spPr>
           <a:xfrm>
-            <a:off x="685800" y="4224528"/>
-            <a:ext cx="256032" cy="256032"/>
-          </a:xfrm>
-          <a:prstGeom prst="rect">
-            <a:avLst/>
-          </a:prstGeom>
-          <a:noFill/>
-        </p:spPr>
-        <p:txBody lIns="0" tIns="12700" rIns="0" bIns="0">
-          <a:bodyPr wrap="none">
-            <a:spAutoFit/>
-          </a:bodyPr>
-          <a:lstStyle/>
-          <a:p>
-            <a:pPr algn="ctr"/>
-            <a:r>
-              <a:rPr sz="1100" b="1">
-                <a:solidFill>
-                  <a:srgbClr val="2FDFE5"/>
-                </a:solidFill>
-              </a:rPr>
-              <a:t>3</a:t>
-            </a:r>
-          </a:p>
-        </p:txBody>
-      </p:sp>
-      <p:sp>
-        <p:nvSpPr>
-          <p:cNvPr id="26" name="TextBox 25"/>
-          <p:cNvSpPr txBox="1"/>
-          <p:nvPr/>
-        </p:nvSpPr>
-        <p:spPr>
-          <a:xfrm>
-            <a:off x="1051560" y="4224528"/>
-            <a:ext cx="4865979" cy="512064"/>
+            <a:off x="1143000" y="4224528"/>
+            <a:ext cx="4756251" cy="585216"/>
           </a:xfrm>
           <a:prstGeom prst="rect">
             <a:avLst/>
@@ -8717,7 +8431,7 @@
           <a:p>
             <a:pPr algn="l"/>
             <a:r>
-              <a:rPr sz="1400" b="1">
+              <a:rPr sz="1700" b="1">
                 <a:solidFill>
                   <a:srgbClr val="FFFFFF"/>
                 </a:solidFill>
@@ -8729,13 +8443,13 @@
       </p:sp>
       <p:sp>
         <p:nvSpPr>
-          <p:cNvPr id="27" name="Rectangle 26"/>
+          <p:cNvPr id="24" name="Rectangle 23"/>
           <p:cNvSpPr/>
           <p:nvPr/>
         </p:nvSpPr>
         <p:spPr>
           <a:xfrm>
-            <a:off x="649224" y="4590288"/>
+            <a:off x="649224" y="4681728"/>
             <a:ext cx="5286603" cy="12700"/>
           </a:xfrm>
           <a:prstGeom prst="rect">
@@ -8772,14 +8486,14 @@
       </p:sp>
       <p:sp>
         <p:nvSpPr>
-          <p:cNvPr id="28" name="TextBox 27"/>
+          <p:cNvPr id="25" name="TextBox 24"/>
           <p:cNvSpPr txBox="1"/>
           <p:nvPr/>
         </p:nvSpPr>
         <p:spPr>
           <a:xfrm>
-            <a:off x="649224" y="4666488"/>
-            <a:ext cx="5286603" cy="1308100"/>
+            <a:off x="649224" y="4770628"/>
+            <a:ext cx="5286603" cy="1216660"/>
           </a:xfrm>
           <a:prstGeom prst="rect">
             <a:avLst/>
@@ -8794,7 +8508,7 @@
           <a:p>
             <a:pPr algn="l"/>
             <a:r>
-              <a:rPr sz="1150">
+              <a:rPr sz="1400">
                 <a:solidFill>
                   <a:srgbClr val="D8EAFF"/>
                 </a:solidFill>
@@ -8806,7 +8520,7 @@
       </p:sp>
       <p:sp>
         <p:nvSpPr>
-          <p:cNvPr id="29" name="Rectangle 28"/>
+          <p:cNvPr id="26" name="Rectangle 25"/>
           <p:cNvSpPr/>
           <p:nvPr/>
         </p:nvSpPr>
@@ -8851,7 +8565,7 @@
       </p:sp>
       <p:sp>
         <p:nvSpPr>
-          <p:cNvPr id="30" name="Rectangle 29"/>
+          <p:cNvPr id="27" name="Rectangle 26"/>
           <p:cNvSpPr/>
           <p:nvPr/>
         </p:nvSpPr>
@@ -8894,14 +8608,14 @@
       </p:sp>
       <p:sp>
         <p:nvSpPr>
-          <p:cNvPr id="31" name="Oval 30"/>
+          <p:cNvPr id="28" name="Oval 27"/>
           <p:cNvSpPr/>
           <p:nvPr/>
         </p:nvSpPr>
         <p:spPr>
           <a:xfrm>
             <a:off x="6466179" y="4224528"/>
-            <a:ext cx="256032" cy="256032"/>
+            <a:ext cx="329184" cy="329184"/>
           </a:xfrm>
           <a:prstGeom prst="ellipse">
             <a:avLst/>
@@ -8909,7 +8623,7 @@
           <a:solidFill>
             <a:srgbClr val="0A1638"/>
           </a:solidFill>
-          <a:ln w="15240">
+          <a:ln w="19050">
             <a:solidFill>
               <a:srgbClr val="2FDFE5"/>
             </a:solidFill>
@@ -8929,58 +8643,32 @@
             <a:schemeClr val="lt1"/>
           </a:fontRef>
         </p:style>
-        <p:txBody>
-          <a:bodyPr rtlCol="0" anchor="ctr"/>
+        <p:txBody lIns="0" tIns="0" rIns="0" bIns="0">
+          <a:bodyPr rtlCol="0" anchor="ctr" wrap="none"/>
           <a:lstStyle/>
           <a:p>
             <a:pPr algn="ctr"/>
-          </a:p>
-        </p:txBody>
-      </p:sp>
-      <p:sp>
-        <p:nvSpPr>
-          <p:cNvPr id="32" name="TextBox 31"/>
+            <a:r>
+              <a:rPr sz="1600" b="1">
+                <a:solidFill>
+                  <a:srgbClr val="2FDFE5"/>
+                </a:solidFill>
+              </a:rPr>
+              <a:t>4</a:t>
+            </a:r>
+          </a:p>
+        </p:txBody>
+      </p:sp>
+      <p:sp>
+        <p:nvSpPr>
+          <p:cNvPr id="29" name="TextBox 28"/>
           <p:cNvSpPr txBox="1"/>
           <p:nvPr/>
         </p:nvSpPr>
         <p:spPr>
           <a:xfrm>
-            <a:off x="6466179" y="4224528"/>
-            <a:ext cx="256032" cy="256032"/>
-          </a:xfrm>
-          <a:prstGeom prst="rect">
-            <a:avLst/>
-          </a:prstGeom>
-          <a:noFill/>
-        </p:spPr>
-        <p:txBody lIns="0" tIns="12700" rIns="0" bIns="0">
-          <a:bodyPr wrap="none">
-            <a:spAutoFit/>
-          </a:bodyPr>
-          <a:lstStyle/>
-          <a:p>
-            <a:pPr algn="ctr"/>
-            <a:r>
-              <a:rPr sz="1100" b="1">
-                <a:solidFill>
-                  <a:srgbClr val="2FDFE5"/>
-                </a:solidFill>
-              </a:rPr>
-              <a:t>4</a:t>
-            </a:r>
-          </a:p>
-        </p:txBody>
-      </p:sp>
-      <p:sp>
-        <p:nvSpPr>
-          <p:cNvPr id="33" name="TextBox 32"/>
-          <p:cNvSpPr txBox="1"/>
-          <p:nvPr/>
-        </p:nvSpPr>
-        <p:spPr>
-          <a:xfrm>
-            <a:off x="6831939" y="4224528"/>
-            <a:ext cx="4865979" cy="512064"/>
+            <a:off x="6923379" y="4224528"/>
+            <a:ext cx="4756251" cy="585216"/>
           </a:xfrm>
           <a:prstGeom prst="rect">
             <a:avLst/>
@@ -8995,7 +8683,7 @@
           <a:p>
             <a:pPr algn="l"/>
             <a:r>
-              <a:rPr sz="1400" b="1">
+              <a:rPr sz="1700" b="1">
                 <a:solidFill>
                   <a:srgbClr val="FFFFFF"/>
                 </a:solidFill>
@@ -9007,13 +8695,13 @@
       </p:sp>
       <p:sp>
         <p:nvSpPr>
-          <p:cNvPr id="34" name="Rectangle 33"/>
+          <p:cNvPr id="30" name="Rectangle 29"/>
           <p:cNvSpPr/>
           <p:nvPr/>
         </p:nvSpPr>
         <p:spPr>
           <a:xfrm>
-            <a:off x="6429603" y="4590288"/>
+            <a:off x="6429603" y="4681728"/>
             <a:ext cx="5286603" cy="12700"/>
           </a:xfrm>
           <a:prstGeom prst="rect">
@@ -9050,14 +8738,14 @@
       </p:sp>
       <p:sp>
         <p:nvSpPr>
-          <p:cNvPr id="35" name="TextBox 34"/>
+          <p:cNvPr id="31" name="TextBox 30"/>
           <p:cNvSpPr txBox="1"/>
           <p:nvPr/>
         </p:nvSpPr>
         <p:spPr>
           <a:xfrm>
-            <a:off x="6429603" y="4666488"/>
-            <a:ext cx="5286603" cy="1308100"/>
+            <a:off x="6429603" y="4770628"/>
+            <a:ext cx="5286603" cy="1216660"/>
           </a:xfrm>
           <a:prstGeom prst="rect">
             <a:avLst/>
@@ -9072,7 +8760,7 @@
           <a:p>
             <a:pPr algn="l"/>
             <a:r>
-              <a:rPr sz="1150">
+              <a:rPr sz="1400">
                 <a:solidFill>
                   <a:srgbClr val="D8EAFF"/>
                 </a:solidFill>
@@ -9084,7 +8772,7 @@
       </p:sp>
       <p:pic>
         <p:nvPicPr>
-          <p:cNvPr id="36" name="Picture 35" descr="logo_horiz.png"/>
+          <p:cNvPr id="32" name="Picture 31" descr="logo_horiz.png"/>
           <p:cNvPicPr>
             <a:picLocks noChangeAspect="1"/>
           </p:cNvPicPr>
@@ -9152,7 +8840,7 @@
                                 <p:cBhvr>
                                   <p:cTn id="8" dur="450" fill="hold"/>
                                   <p:tgtEl>
-                                    <p:spTgt spid="15"/>
+                                    <p:spTgt spid="14"/>
                                   </p:tgtEl>
                                 </p:cBhvr>
                               </p:animEffect>
@@ -9169,7 +8857,7 @@
                                 <p:cBhvr>
                                   <p:cTn id="10" dur="450" fill="hold"/>
                                   <p:tgtEl>
-                                    <p:spTgt spid="22"/>
+                                    <p:spTgt spid="20"/>
                                   </p:tgtEl>
                                 </p:cBhvr>
                               </p:animEffect>
@@ -9186,7 +8874,7 @@
                                 <p:cBhvr>
                                   <p:cTn id="12" dur="450" fill="hold"/>
                                   <p:tgtEl>
-                                    <p:spTgt spid="29"/>
+                                    <p:spTgt spid="26"/>
                                   </p:tgtEl>
                                 </p:cBhvr>
                               </p:animEffect>

</xml_diff>

<commit_message>
Remove badge circles entirely, use teal number inline in title text
</commit_message>
<xml_diff>
--- a/sendacredit_propuesta.pptx
+++ b/sendacredit_propuesta.pptx
@@ -3846,74 +3846,21 @@
       </p:sp>
       <p:sp>
         <p:nvSpPr>
-          <p:cNvPr id="11" name="Oval 10"/>
-          <p:cNvSpPr/>
+          <p:cNvPr id="11" name="TextBox 10"/>
+          <p:cNvSpPr txBox="1"/>
           <p:nvPr/>
         </p:nvSpPr>
         <p:spPr>
           <a:xfrm>
             <a:off x="704088" y="2468880"/>
-            <a:ext cx="347472" cy="347472"/>
-          </a:xfrm>
-          <a:prstGeom prst="ellipse">
-            <a:avLst/>
-          </a:prstGeom>
-          <a:solidFill>
-            <a:srgbClr val="0A1638"/>
-          </a:solidFill>
-          <a:ln w="19050">
-            <a:solidFill>
-              <a:srgbClr val="2FDFE5"/>
-            </a:solidFill>
-          </a:ln>
-        </p:spPr>
-        <p:style>
-          <a:lnRef idx="1">
-            <a:schemeClr val="accent1"/>
-          </a:lnRef>
-          <a:fillRef idx="3">
-            <a:schemeClr val="accent1"/>
-          </a:fillRef>
-          <a:effectRef idx="2">
-            <a:schemeClr val="accent1"/>
-          </a:effectRef>
-          <a:fontRef idx="minor">
-            <a:schemeClr val="lt1"/>
-          </a:fontRef>
-        </p:style>
-        <p:txBody lIns="0" tIns="0" rIns="0" bIns="0">
-          <a:bodyPr rtlCol="0" anchor="ctr" wrap="none"/>
-          <a:lstStyle/>
-          <a:p>
-            <a:pPr algn="ctr"/>
-            <a:r>
-              <a:rPr sz="1600" b="1">
-                <a:solidFill>
-                  <a:srgbClr val="2FDFE5"/>
-                </a:solidFill>
-              </a:rPr>
-              <a:t>1</a:t>
-            </a:r>
-          </a:p>
-        </p:txBody>
-      </p:sp>
-      <p:sp>
-        <p:nvSpPr>
-          <p:cNvPr id="12" name="TextBox 11"/>
-          <p:cNvSpPr txBox="1"/>
-          <p:nvPr/>
-        </p:nvSpPr>
-        <p:spPr>
-          <a:xfrm>
-            <a:off x="1179576" y="2468880"/>
-            <a:ext cx="4683099" cy="658368"/>
+            <a:ext cx="5176875" cy="621792"/>
           </a:xfrm>
           <a:prstGeom prst="rect">
             <a:avLst/>
           </a:prstGeom>
           <a:noFill/>
         </p:spPr>
-        <p:txBody lIns="38100" tIns="25400" rIns="38100" bIns="25400">
+        <p:txBody lIns="38100" tIns="50800" rIns="38100" bIns="25400">
           <a:bodyPr wrap="square">
             <a:spAutoFit/>
           </a:bodyPr>
@@ -3923,6 +3870,14 @@
             <a:r>
               <a:rPr sz="1800" b="1">
                 <a:solidFill>
+                  <a:srgbClr val="2FDFE5"/>
+                </a:solidFill>
+              </a:rPr>
+              <a:t>1  </a:t>
+            </a:r>
+            <a:r>
+              <a:rPr sz="1800" b="1">
+                <a:solidFill>
                   <a:srgbClr val="FFFFFF"/>
                 </a:solidFill>
               </a:rPr>
@@ -3933,13 +3888,13 @@
       </p:sp>
       <p:sp>
         <p:nvSpPr>
-          <p:cNvPr id="13" name="Rectangle 12"/>
+          <p:cNvPr id="12" name="Rectangle 11"/>
           <p:cNvSpPr/>
           <p:nvPr/>
         </p:nvSpPr>
         <p:spPr>
           <a:xfrm>
-            <a:off x="667512" y="2944368"/>
+            <a:off x="667512" y="3182112"/>
             <a:ext cx="5250027" cy="15240"/>
           </a:xfrm>
           <a:prstGeom prst="rect">
@@ -3976,14 +3931,14 @@
       </p:sp>
       <p:sp>
         <p:nvSpPr>
-          <p:cNvPr id="14" name="TextBox 13"/>
+          <p:cNvPr id="13" name="TextBox 12"/>
           <p:cNvSpPr txBox="1"/>
           <p:nvPr/>
         </p:nvSpPr>
         <p:spPr>
           <a:xfrm>
-            <a:off x="667512" y="3045968"/>
-            <a:ext cx="5250027" cy="2923032"/>
+            <a:off x="667512" y="3283712"/>
+            <a:ext cx="5250027" cy="2685288"/>
           </a:xfrm>
           <a:prstGeom prst="rect">
             <a:avLst/>
@@ -4068,7 +4023,7 @@
       </p:sp>
       <p:sp>
         <p:nvSpPr>
-          <p:cNvPr id="15" name="Rectangle 14"/>
+          <p:cNvPr id="14" name="Rectangle 13"/>
           <p:cNvSpPr/>
           <p:nvPr/>
         </p:nvSpPr>
@@ -4113,7 +4068,7 @@
       </p:sp>
       <p:sp>
         <p:nvSpPr>
-          <p:cNvPr id="16" name="Rectangle 15"/>
+          <p:cNvPr id="15" name="Rectangle 14"/>
           <p:cNvSpPr/>
           <p:nvPr/>
         </p:nvSpPr>
@@ -4156,74 +4111,21 @@
       </p:sp>
       <p:sp>
         <p:nvSpPr>
-          <p:cNvPr id="17" name="Oval 16"/>
-          <p:cNvSpPr/>
+          <p:cNvPr id="16" name="TextBox 15"/>
+          <p:cNvSpPr txBox="1"/>
           <p:nvPr/>
         </p:nvSpPr>
         <p:spPr>
           <a:xfrm>
             <a:off x="6484467" y="2468880"/>
-            <a:ext cx="347472" cy="347472"/>
-          </a:xfrm>
-          <a:prstGeom prst="ellipse">
-            <a:avLst/>
-          </a:prstGeom>
-          <a:solidFill>
-            <a:srgbClr val="0A1638"/>
-          </a:solidFill>
-          <a:ln w="19050">
-            <a:solidFill>
-              <a:srgbClr val="2FDFE5"/>
-            </a:solidFill>
-          </a:ln>
-        </p:spPr>
-        <p:style>
-          <a:lnRef idx="1">
-            <a:schemeClr val="accent1"/>
-          </a:lnRef>
-          <a:fillRef idx="3">
-            <a:schemeClr val="accent1"/>
-          </a:fillRef>
-          <a:effectRef idx="2">
-            <a:schemeClr val="accent1"/>
-          </a:effectRef>
-          <a:fontRef idx="minor">
-            <a:schemeClr val="lt1"/>
-          </a:fontRef>
-        </p:style>
-        <p:txBody lIns="0" tIns="0" rIns="0" bIns="0">
-          <a:bodyPr rtlCol="0" anchor="ctr" wrap="none"/>
-          <a:lstStyle/>
-          <a:p>
-            <a:pPr algn="ctr"/>
-            <a:r>
-              <a:rPr sz="1600" b="1">
-                <a:solidFill>
-                  <a:srgbClr val="2FDFE5"/>
-                </a:solidFill>
-              </a:rPr>
-              <a:t>2</a:t>
-            </a:r>
-          </a:p>
-        </p:txBody>
-      </p:sp>
-      <p:sp>
-        <p:nvSpPr>
-          <p:cNvPr id="18" name="TextBox 17"/>
-          <p:cNvSpPr txBox="1"/>
-          <p:nvPr/>
-        </p:nvSpPr>
-        <p:spPr>
-          <a:xfrm>
-            <a:off x="6959955" y="2468880"/>
-            <a:ext cx="4683099" cy="658368"/>
+            <a:ext cx="5176875" cy="621792"/>
           </a:xfrm>
           <a:prstGeom prst="rect">
             <a:avLst/>
           </a:prstGeom>
           <a:noFill/>
         </p:spPr>
-        <p:txBody lIns="38100" tIns="25400" rIns="38100" bIns="25400">
+        <p:txBody lIns="38100" tIns="50800" rIns="38100" bIns="25400">
           <a:bodyPr wrap="square">
             <a:spAutoFit/>
           </a:bodyPr>
@@ -4233,6 +4135,14 @@
             <a:r>
               <a:rPr sz="1800" b="1">
                 <a:solidFill>
+                  <a:srgbClr val="2FDFE5"/>
+                </a:solidFill>
+              </a:rPr>
+              <a:t>2  </a:t>
+            </a:r>
+            <a:r>
+              <a:rPr sz="1800" b="1">
+                <a:solidFill>
                   <a:srgbClr val="FFFFFF"/>
                 </a:solidFill>
               </a:rPr>
@@ -4243,13 +4153,13 @@
       </p:sp>
       <p:sp>
         <p:nvSpPr>
-          <p:cNvPr id="19" name="Rectangle 18"/>
+          <p:cNvPr id="17" name="Rectangle 16"/>
           <p:cNvSpPr/>
           <p:nvPr/>
         </p:nvSpPr>
         <p:spPr>
           <a:xfrm>
-            <a:off x="6447891" y="2944368"/>
+            <a:off x="6447891" y="3182112"/>
             <a:ext cx="5250027" cy="15240"/>
           </a:xfrm>
           <a:prstGeom prst="rect">
@@ -4286,14 +4196,14 @@
       </p:sp>
       <p:sp>
         <p:nvSpPr>
-          <p:cNvPr id="20" name="TextBox 19"/>
+          <p:cNvPr id="18" name="TextBox 17"/>
           <p:cNvSpPr txBox="1"/>
           <p:nvPr/>
         </p:nvSpPr>
         <p:spPr>
           <a:xfrm>
-            <a:off x="6447891" y="3045968"/>
-            <a:ext cx="5250027" cy="2923032"/>
+            <a:off x="6447891" y="3283712"/>
+            <a:ext cx="5250027" cy="2685288"/>
           </a:xfrm>
           <a:prstGeom prst="rect">
             <a:avLst/>
@@ -4378,7 +4288,7 @@
       </p:sp>
       <p:pic>
         <p:nvPicPr>
-          <p:cNvPr id="21" name="Picture 20" descr="logo_horiz.png"/>
+          <p:cNvPr id="19" name="Picture 18" descr="logo_horiz.png"/>
           <p:cNvPicPr>
             <a:picLocks noChangeAspect="1"/>
           </p:cNvPicPr>
@@ -4446,7 +4356,7 @@
                                 <p:cBhvr>
                                   <p:cTn id="8" dur="450" fill="hold"/>
                                   <p:tgtEl>
-                                    <p:spTgt spid="15"/>
+                                    <p:spTgt spid="14"/>
                                   </p:tgtEl>
                                 </p:cBhvr>
                               </p:animEffect>
@@ -4856,74 +4766,21 @@
       </p:sp>
       <p:sp>
         <p:nvSpPr>
-          <p:cNvPr id="11" name="Oval 10"/>
-          <p:cNvSpPr/>
+          <p:cNvPr id="11" name="TextBox 10"/>
+          <p:cNvSpPr txBox="1"/>
           <p:nvPr/>
         </p:nvSpPr>
         <p:spPr>
           <a:xfrm>
             <a:off x="704088" y="2468880"/>
-            <a:ext cx="347472" cy="347472"/>
-          </a:xfrm>
-          <a:prstGeom prst="ellipse">
-            <a:avLst/>
-          </a:prstGeom>
-          <a:solidFill>
-            <a:srgbClr val="0A1638"/>
-          </a:solidFill>
-          <a:ln w="19050">
-            <a:solidFill>
-              <a:srgbClr val="2FDFE5"/>
-            </a:solidFill>
-          </a:ln>
-        </p:spPr>
-        <p:style>
-          <a:lnRef idx="1">
-            <a:schemeClr val="accent1"/>
-          </a:lnRef>
-          <a:fillRef idx="3">
-            <a:schemeClr val="accent1"/>
-          </a:fillRef>
-          <a:effectRef idx="2">
-            <a:schemeClr val="accent1"/>
-          </a:effectRef>
-          <a:fontRef idx="minor">
-            <a:schemeClr val="lt1"/>
-          </a:fontRef>
-        </p:style>
-        <p:txBody lIns="0" tIns="0" rIns="0" bIns="0">
-          <a:bodyPr rtlCol="0" anchor="ctr" wrap="none"/>
-          <a:lstStyle/>
-          <a:p>
-            <a:pPr algn="ctr"/>
-            <a:r>
-              <a:rPr sz="1600" b="1">
-                <a:solidFill>
-                  <a:srgbClr val="2FDFE5"/>
-                </a:solidFill>
-              </a:rPr>
-              <a:t>3</a:t>
-            </a:r>
-          </a:p>
-        </p:txBody>
-      </p:sp>
-      <p:sp>
-        <p:nvSpPr>
-          <p:cNvPr id="12" name="TextBox 11"/>
-          <p:cNvSpPr txBox="1"/>
-          <p:nvPr/>
-        </p:nvSpPr>
-        <p:spPr>
-          <a:xfrm>
-            <a:off x="1179576" y="2468880"/>
-            <a:ext cx="4683099" cy="658368"/>
+            <a:ext cx="5176875" cy="621792"/>
           </a:xfrm>
           <a:prstGeom prst="rect">
             <a:avLst/>
           </a:prstGeom>
           <a:noFill/>
         </p:spPr>
-        <p:txBody lIns="38100" tIns="25400" rIns="38100" bIns="25400">
+        <p:txBody lIns="38100" tIns="50800" rIns="38100" bIns="25400">
           <a:bodyPr wrap="square">
             <a:spAutoFit/>
           </a:bodyPr>
@@ -4933,6 +4790,14 @@
             <a:r>
               <a:rPr sz="1800" b="1">
                 <a:solidFill>
+                  <a:srgbClr val="2FDFE5"/>
+                </a:solidFill>
+              </a:rPr>
+              <a:t>3  </a:t>
+            </a:r>
+            <a:r>
+              <a:rPr sz="1800" b="1">
+                <a:solidFill>
                   <a:srgbClr val="FFFFFF"/>
                 </a:solidFill>
               </a:rPr>
@@ -4943,13 +4808,13 @@
       </p:sp>
       <p:sp>
         <p:nvSpPr>
-          <p:cNvPr id="13" name="Rectangle 12"/>
+          <p:cNvPr id="12" name="Rectangle 11"/>
           <p:cNvSpPr/>
           <p:nvPr/>
         </p:nvSpPr>
         <p:spPr>
           <a:xfrm>
-            <a:off x="667512" y="2944368"/>
+            <a:off x="667512" y="3182112"/>
             <a:ext cx="5250027" cy="15240"/>
           </a:xfrm>
           <a:prstGeom prst="rect">
@@ -4986,14 +4851,14 @@
       </p:sp>
       <p:sp>
         <p:nvSpPr>
-          <p:cNvPr id="14" name="TextBox 13"/>
+          <p:cNvPr id="13" name="TextBox 12"/>
           <p:cNvSpPr txBox="1"/>
           <p:nvPr/>
         </p:nvSpPr>
         <p:spPr>
           <a:xfrm>
-            <a:off x="667512" y="3045968"/>
-            <a:ext cx="5250027" cy="2923032"/>
+            <a:off x="667512" y="3283712"/>
+            <a:ext cx="5250027" cy="2685288"/>
           </a:xfrm>
           <a:prstGeom prst="rect">
             <a:avLst/>
@@ -5078,7 +4943,7 @@
       </p:sp>
       <p:sp>
         <p:nvSpPr>
-          <p:cNvPr id="15" name="Rectangle 14"/>
+          <p:cNvPr id="14" name="Rectangle 13"/>
           <p:cNvSpPr/>
           <p:nvPr/>
         </p:nvSpPr>
@@ -5123,7 +4988,7 @@
       </p:sp>
       <p:sp>
         <p:nvSpPr>
-          <p:cNvPr id="16" name="Rectangle 15"/>
+          <p:cNvPr id="15" name="Rectangle 14"/>
           <p:cNvSpPr/>
           <p:nvPr/>
         </p:nvSpPr>
@@ -5166,74 +5031,21 @@
       </p:sp>
       <p:sp>
         <p:nvSpPr>
-          <p:cNvPr id="17" name="Oval 16"/>
-          <p:cNvSpPr/>
+          <p:cNvPr id="16" name="TextBox 15"/>
+          <p:cNvSpPr txBox="1"/>
           <p:nvPr/>
         </p:nvSpPr>
         <p:spPr>
           <a:xfrm>
             <a:off x="6484467" y="2468880"/>
-            <a:ext cx="347472" cy="347472"/>
-          </a:xfrm>
-          <a:prstGeom prst="ellipse">
-            <a:avLst/>
-          </a:prstGeom>
-          <a:solidFill>
-            <a:srgbClr val="0A1638"/>
-          </a:solidFill>
-          <a:ln w="19050">
-            <a:solidFill>
-              <a:srgbClr val="2FDFE5"/>
-            </a:solidFill>
-          </a:ln>
-        </p:spPr>
-        <p:style>
-          <a:lnRef idx="1">
-            <a:schemeClr val="accent1"/>
-          </a:lnRef>
-          <a:fillRef idx="3">
-            <a:schemeClr val="accent1"/>
-          </a:fillRef>
-          <a:effectRef idx="2">
-            <a:schemeClr val="accent1"/>
-          </a:effectRef>
-          <a:fontRef idx="minor">
-            <a:schemeClr val="lt1"/>
-          </a:fontRef>
-        </p:style>
-        <p:txBody lIns="0" tIns="0" rIns="0" bIns="0">
-          <a:bodyPr rtlCol="0" anchor="ctr" wrap="none"/>
-          <a:lstStyle/>
-          <a:p>
-            <a:pPr algn="ctr"/>
-            <a:r>
-              <a:rPr sz="1600" b="1">
-                <a:solidFill>
-                  <a:srgbClr val="2FDFE5"/>
-                </a:solidFill>
-              </a:rPr>
-              <a:t>4</a:t>
-            </a:r>
-          </a:p>
-        </p:txBody>
-      </p:sp>
-      <p:sp>
-        <p:nvSpPr>
-          <p:cNvPr id="18" name="TextBox 17"/>
-          <p:cNvSpPr txBox="1"/>
-          <p:nvPr/>
-        </p:nvSpPr>
-        <p:spPr>
-          <a:xfrm>
-            <a:off x="6959955" y="2468880"/>
-            <a:ext cx="4683099" cy="658368"/>
+            <a:ext cx="5176875" cy="621792"/>
           </a:xfrm>
           <a:prstGeom prst="rect">
             <a:avLst/>
           </a:prstGeom>
           <a:noFill/>
         </p:spPr>
-        <p:txBody lIns="38100" tIns="25400" rIns="38100" bIns="25400">
+        <p:txBody lIns="38100" tIns="50800" rIns="38100" bIns="25400">
           <a:bodyPr wrap="square">
             <a:spAutoFit/>
           </a:bodyPr>
@@ -5243,6 +5055,14 @@
             <a:r>
               <a:rPr sz="1800" b="1">
                 <a:solidFill>
+                  <a:srgbClr val="2FDFE5"/>
+                </a:solidFill>
+              </a:rPr>
+              <a:t>4  </a:t>
+            </a:r>
+            <a:r>
+              <a:rPr sz="1800" b="1">
+                <a:solidFill>
                   <a:srgbClr val="FFFFFF"/>
                 </a:solidFill>
               </a:rPr>
@@ -5253,13 +5073,13 @@
       </p:sp>
       <p:sp>
         <p:nvSpPr>
-          <p:cNvPr id="19" name="Rectangle 18"/>
+          <p:cNvPr id="17" name="Rectangle 16"/>
           <p:cNvSpPr/>
           <p:nvPr/>
         </p:nvSpPr>
         <p:spPr>
           <a:xfrm>
-            <a:off x="6447891" y="2944368"/>
+            <a:off x="6447891" y="3182112"/>
             <a:ext cx="5250027" cy="15240"/>
           </a:xfrm>
           <a:prstGeom prst="rect">
@@ -5296,14 +5116,14 @@
       </p:sp>
       <p:sp>
         <p:nvSpPr>
-          <p:cNvPr id="20" name="TextBox 19"/>
+          <p:cNvPr id="18" name="TextBox 17"/>
           <p:cNvSpPr txBox="1"/>
           <p:nvPr/>
         </p:nvSpPr>
         <p:spPr>
           <a:xfrm>
-            <a:off x="6447891" y="3045968"/>
-            <a:ext cx="5250027" cy="2923032"/>
+            <a:off x="6447891" y="3283712"/>
+            <a:ext cx="5250027" cy="2685288"/>
           </a:xfrm>
           <a:prstGeom prst="rect">
             <a:avLst/>
@@ -5388,7 +5208,7 @@
       </p:sp>
       <p:pic>
         <p:nvPicPr>
-          <p:cNvPr id="21" name="Picture 20" descr="logo_horiz.png"/>
+          <p:cNvPr id="19" name="Picture 18" descr="logo_horiz.png"/>
           <p:cNvPicPr>
             <a:picLocks noChangeAspect="1"/>
           </p:cNvPicPr>
@@ -5456,7 +5276,7 @@
                                 <p:cBhvr>
                                   <p:cTn id="8" dur="450" fill="hold"/>
                                   <p:tgtEl>
-                                    <p:spTgt spid="15"/>
+                                    <p:spTgt spid="14"/>
                                   </p:tgtEl>
                                 </p:cBhvr>
                               </p:animEffect>
@@ -5866,74 +5686,21 @@
       </p:sp>
       <p:sp>
         <p:nvSpPr>
-          <p:cNvPr id="11" name="Oval 10"/>
-          <p:cNvSpPr/>
+          <p:cNvPr id="11" name="TextBox 10"/>
+          <p:cNvSpPr txBox="1"/>
           <p:nvPr/>
         </p:nvSpPr>
         <p:spPr>
           <a:xfrm>
             <a:off x="704088" y="2468880"/>
-            <a:ext cx="347472" cy="347472"/>
-          </a:xfrm>
-          <a:prstGeom prst="ellipse">
-            <a:avLst/>
-          </a:prstGeom>
-          <a:solidFill>
-            <a:srgbClr val="0A1638"/>
-          </a:solidFill>
-          <a:ln w="19050">
-            <a:solidFill>
-              <a:srgbClr val="2FDFE5"/>
-            </a:solidFill>
-          </a:ln>
-        </p:spPr>
-        <p:style>
-          <a:lnRef idx="1">
-            <a:schemeClr val="accent1"/>
-          </a:lnRef>
-          <a:fillRef idx="3">
-            <a:schemeClr val="accent1"/>
-          </a:fillRef>
-          <a:effectRef idx="2">
-            <a:schemeClr val="accent1"/>
-          </a:effectRef>
-          <a:fontRef idx="minor">
-            <a:schemeClr val="lt1"/>
-          </a:fontRef>
-        </p:style>
-        <p:txBody lIns="0" tIns="0" rIns="0" bIns="0">
-          <a:bodyPr rtlCol="0" anchor="ctr" wrap="none"/>
-          <a:lstStyle/>
-          <a:p>
-            <a:pPr algn="ctr"/>
-            <a:r>
-              <a:rPr sz="1600" b="1">
-                <a:solidFill>
-                  <a:srgbClr val="2FDFE5"/>
-                </a:solidFill>
-              </a:rPr>
-              <a:t>5</a:t>
-            </a:r>
-          </a:p>
-        </p:txBody>
-      </p:sp>
-      <p:sp>
-        <p:nvSpPr>
-          <p:cNvPr id="12" name="TextBox 11"/>
-          <p:cNvSpPr txBox="1"/>
-          <p:nvPr/>
-        </p:nvSpPr>
-        <p:spPr>
-          <a:xfrm>
-            <a:off x="1179576" y="2468880"/>
-            <a:ext cx="4683099" cy="658368"/>
+            <a:ext cx="5176875" cy="621792"/>
           </a:xfrm>
           <a:prstGeom prst="rect">
             <a:avLst/>
           </a:prstGeom>
           <a:noFill/>
         </p:spPr>
-        <p:txBody lIns="38100" tIns="25400" rIns="38100" bIns="25400">
+        <p:txBody lIns="38100" tIns="50800" rIns="38100" bIns="25400">
           <a:bodyPr wrap="square">
             <a:spAutoFit/>
           </a:bodyPr>
@@ -5943,6 +5710,14 @@
             <a:r>
               <a:rPr sz="1800" b="1">
                 <a:solidFill>
+                  <a:srgbClr val="2FDFE5"/>
+                </a:solidFill>
+              </a:rPr>
+              <a:t>5  </a:t>
+            </a:r>
+            <a:r>
+              <a:rPr sz="1800" b="1">
+                <a:solidFill>
                   <a:srgbClr val="FFFFFF"/>
                 </a:solidFill>
               </a:rPr>
@@ -5953,13 +5728,13 @@
       </p:sp>
       <p:sp>
         <p:nvSpPr>
-          <p:cNvPr id="13" name="Rectangle 12"/>
+          <p:cNvPr id="12" name="Rectangle 11"/>
           <p:cNvSpPr/>
           <p:nvPr/>
         </p:nvSpPr>
         <p:spPr>
           <a:xfrm>
-            <a:off x="667512" y="2944368"/>
+            <a:off x="667512" y="3182112"/>
             <a:ext cx="5250027" cy="15240"/>
           </a:xfrm>
           <a:prstGeom prst="rect">
@@ -5996,14 +5771,14 @@
       </p:sp>
       <p:sp>
         <p:nvSpPr>
-          <p:cNvPr id="14" name="TextBox 13"/>
+          <p:cNvPr id="13" name="TextBox 12"/>
           <p:cNvSpPr txBox="1"/>
           <p:nvPr/>
         </p:nvSpPr>
         <p:spPr>
           <a:xfrm>
-            <a:off x="667512" y="3045968"/>
-            <a:ext cx="5250027" cy="2923032"/>
+            <a:off x="667512" y="3283712"/>
+            <a:ext cx="5250027" cy="2685288"/>
           </a:xfrm>
           <a:prstGeom prst="rect">
             <a:avLst/>
@@ -6088,7 +5863,7 @@
       </p:sp>
       <p:sp>
         <p:nvSpPr>
-          <p:cNvPr id="15" name="Rectangle 14"/>
+          <p:cNvPr id="14" name="Rectangle 13"/>
           <p:cNvSpPr/>
           <p:nvPr/>
         </p:nvSpPr>
@@ -6133,7 +5908,7 @@
       </p:sp>
       <p:sp>
         <p:nvSpPr>
-          <p:cNvPr id="16" name="Rectangle 15"/>
+          <p:cNvPr id="15" name="Rectangle 14"/>
           <p:cNvSpPr/>
           <p:nvPr/>
         </p:nvSpPr>
@@ -6176,74 +5951,21 @@
       </p:sp>
       <p:sp>
         <p:nvSpPr>
-          <p:cNvPr id="17" name="Oval 16"/>
-          <p:cNvSpPr/>
+          <p:cNvPr id="16" name="TextBox 15"/>
+          <p:cNvSpPr txBox="1"/>
           <p:nvPr/>
         </p:nvSpPr>
         <p:spPr>
           <a:xfrm>
             <a:off x="6484467" y="2468880"/>
-            <a:ext cx="347472" cy="347472"/>
-          </a:xfrm>
-          <a:prstGeom prst="ellipse">
-            <a:avLst/>
-          </a:prstGeom>
-          <a:solidFill>
-            <a:srgbClr val="0A1638"/>
-          </a:solidFill>
-          <a:ln w="19050">
-            <a:solidFill>
-              <a:srgbClr val="2FDFE5"/>
-            </a:solidFill>
-          </a:ln>
-        </p:spPr>
-        <p:style>
-          <a:lnRef idx="1">
-            <a:schemeClr val="accent1"/>
-          </a:lnRef>
-          <a:fillRef idx="3">
-            <a:schemeClr val="accent1"/>
-          </a:fillRef>
-          <a:effectRef idx="2">
-            <a:schemeClr val="accent1"/>
-          </a:effectRef>
-          <a:fontRef idx="minor">
-            <a:schemeClr val="lt1"/>
-          </a:fontRef>
-        </p:style>
-        <p:txBody lIns="0" tIns="0" rIns="0" bIns="0">
-          <a:bodyPr rtlCol="0" anchor="ctr" wrap="none"/>
-          <a:lstStyle/>
-          <a:p>
-            <a:pPr algn="ctr"/>
-            <a:r>
-              <a:rPr sz="1600" b="1">
-                <a:solidFill>
-                  <a:srgbClr val="2FDFE5"/>
-                </a:solidFill>
-              </a:rPr>
-              <a:t>6</a:t>
-            </a:r>
-          </a:p>
-        </p:txBody>
-      </p:sp>
-      <p:sp>
-        <p:nvSpPr>
-          <p:cNvPr id="18" name="TextBox 17"/>
-          <p:cNvSpPr txBox="1"/>
-          <p:nvPr/>
-        </p:nvSpPr>
-        <p:spPr>
-          <a:xfrm>
-            <a:off x="6959955" y="2468880"/>
-            <a:ext cx="4683099" cy="658368"/>
+            <a:ext cx="5176875" cy="621792"/>
           </a:xfrm>
           <a:prstGeom prst="rect">
             <a:avLst/>
           </a:prstGeom>
           <a:noFill/>
         </p:spPr>
-        <p:txBody lIns="38100" tIns="25400" rIns="38100" bIns="25400">
+        <p:txBody lIns="38100" tIns="50800" rIns="38100" bIns="25400">
           <a:bodyPr wrap="square">
             <a:spAutoFit/>
           </a:bodyPr>
@@ -6253,6 +5975,14 @@
             <a:r>
               <a:rPr sz="1800" b="1">
                 <a:solidFill>
+                  <a:srgbClr val="2FDFE5"/>
+                </a:solidFill>
+              </a:rPr>
+              <a:t>6  </a:t>
+            </a:r>
+            <a:r>
+              <a:rPr sz="1800" b="1">
+                <a:solidFill>
                   <a:srgbClr val="FFFFFF"/>
                 </a:solidFill>
               </a:rPr>
@@ -6263,13 +5993,13 @@
       </p:sp>
       <p:sp>
         <p:nvSpPr>
-          <p:cNvPr id="19" name="Rectangle 18"/>
+          <p:cNvPr id="17" name="Rectangle 16"/>
           <p:cNvSpPr/>
           <p:nvPr/>
         </p:nvSpPr>
         <p:spPr>
           <a:xfrm>
-            <a:off x="6447891" y="2944368"/>
+            <a:off x="6447891" y="3182112"/>
             <a:ext cx="5250027" cy="15240"/>
           </a:xfrm>
           <a:prstGeom prst="rect">
@@ -6306,14 +6036,14 @@
       </p:sp>
       <p:sp>
         <p:nvSpPr>
-          <p:cNvPr id="20" name="TextBox 19"/>
+          <p:cNvPr id="18" name="TextBox 17"/>
           <p:cNvSpPr txBox="1"/>
           <p:nvPr/>
         </p:nvSpPr>
         <p:spPr>
           <a:xfrm>
-            <a:off x="6447891" y="3045968"/>
-            <a:ext cx="5250027" cy="2923032"/>
+            <a:off x="6447891" y="3283712"/>
+            <a:ext cx="5250027" cy="2685288"/>
           </a:xfrm>
           <a:prstGeom prst="rect">
             <a:avLst/>
@@ -6398,7 +6128,7 @@
       </p:sp>
       <p:pic>
         <p:nvPicPr>
-          <p:cNvPr id="21" name="Picture 20" descr="logo_horiz.png"/>
+          <p:cNvPr id="19" name="Picture 18" descr="logo_horiz.png"/>
           <p:cNvPicPr>
             <a:picLocks noChangeAspect="1"/>
           </p:cNvPicPr>
@@ -6466,7 +6196,7 @@
                                 <p:cBhvr>
                                   <p:cTn id="8" dur="450" fill="hold"/>
                                   <p:tgtEl>
-                                    <p:spTgt spid="15"/>
+                                    <p:spTgt spid="14"/>
                                   </p:tgtEl>
                                 </p:cBhvr>
                               </p:animEffect>
@@ -6876,74 +6606,21 @@
       </p:sp>
       <p:sp>
         <p:nvSpPr>
-          <p:cNvPr id="11" name="Oval 10"/>
-          <p:cNvSpPr/>
+          <p:cNvPr id="11" name="TextBox 10"/>
+          <p:cNvSpPr txBox="1"/>
           <p:nvPr/>
         </p:nvSpPr>
         <p:spPr>
           <a:xfrm>
             <a:off x="704088" y="2468880"/>
-            <a:ext cx="347472" cy="347472"/>
-          </a:xfrm>
-          <a:prstGeom prst="ellipse">
-            <a:avLst/>
-          </a:prstGeom>
-          <a:solidFill>
-            <a:srgbClr val="0A1638"/>
-          </a:solidFill>
-          <a:ln w="19050">
-            <a:solidFill>
-              <a:srgbClr val="2FDFE5"/>
-            </a:solidFill>
-          </a:ln>
-        </p:spPr>
-        <p:style>
-          <a:lnRef idx="1">
-            <a:schemeClr val="accent1"/>
-          </a:lnRef>
-          <a:fillRef idx="3">
-            <a:schemeClr val="accent1"/>
-          </a:fillRef>
-          <a:effectRef idx="2">
-            <a:schemeClr val="accent1"/>
-          </a:effectRef>
-          <a:fontRef idx="minor">
-            <a:schemeClr val="lt1"/>
-          </a:fontRef>
-        </p:style>
-        <p:txBody lIns="0" tIns="0" rIns="0" bIns="0">
-          <a:bodyPr rtlCol="0" anchor="ctr" wrap="none"/>
-          <a:lstStyle/>
-          <a:p>
-            <a:pPr algn="ctr"/>
-            <a:r>
-              <a:rPr sz="1600" b="1">
-                <a:solidFill>
-                  <a:srgbClr val="2FDFE5"/>
-                </a:solidFill>
-              </a:rPr>
-              <a:t>7</a:t>
-            </a:r>
-          </a:p>
-        </p:txBody>
-      </p:sp>
-      <p:sp>
-        <p:nvSpPr>
-          <p:cNvPr id="12" name="TextBox 11"/>
-          <p:cNvSpPr txBox="1"/>
-          <p:nvPr/>
-        </p:nvSpPr>
-        <p:spPr>
-          <a:xfrm>
-            <a:off x="1179576" y="2468880"/>
-            <a:ext cx="4683099" cy="658368"/>
+            <a:ext cx="5176875" cy="621792"/>
           </a:xfrm>
           <a:prstGeom prst="rect">
             <a:avLst/>
           </a:prstGeom>
           <a:noFill/>
         </p:spPr>
-        <p:txBody lIns="38100" tIns="25400" rIns="38100" bIns="25400">
+        <p:txBody lIns="38100" tIns="50800" rIns="38100" bIns="25400">
           <a:bodyPr wrap="square">
             <a:spAutoFit/>
           </a:bodyPr>
@@ -6953,6 +6630,14 @@
             <a:r>
               <a:rPr sz="1800" b="1">
                 <a:solidFill>
+                  <a:srgbClr val="2FDFE5"/>
+                </a:solidFill>
+              </a:rPr>
+              <a:t>7  </a:t>
+            </a:r>
+            <a:r>
+              <a:rPr sz="1800" b="1">
+                <a:solidFill>
                   <a:srgbClr val="FFFFFF"/>
                 </a:solidFill>
               </a:rPr>
@@ -6963,13 +6648,13 @@
       </p:sp>
       <p:sp>
         <p:nvSpPr>
-          <p:cNvPr id="13" name="Rectangle 12"/>
+          <p:cNvPr id="12" name="Rectangle 11"/>
           <p:cNvSpPr/>
           <p:nvPr/>
         </p:nvSpPr>
         <p:spPr>
           <a:xfrm>
-            <a:off x="667512" y="2944368"/>
+            <a:off x="667512" y="3182112"/>
             <a:ext cx="5250027" cy="15240"/>
           </a:xfrm>
           <a:prstGeom prst="rect">
@@ -7006,14 +6691,14 @@
       </p:sp>
       <p:sp>
         <p:nvSpPr>
-          <p:cNvPr id="14" name="TextBox 13"/>
+          <p:cNvPr id="13" name="TextBox 12"/>
           <p:cNvSpPr txBox="1"/>
           <p:nvPr/>
         </p:nvSpPr>
         <p:spPr>
           <a:xfrm>
-            <a:off x="667512" y="3045968"/>
-            <a:ext cx="5250027" cy="2923032"/>
+            <a:off x="667512" y="3283712"/>
+            <a:ext cx="5250027" cy="2685288"/>
           </a:xfrm>
           <a:prstGeom prst="rect">
             <a:avLst/>
@@ -7098,7 +6783,7 @@
       </p:sp>
       <p:sp>
         <p:nvSpPr>
-          <p:cNvPr id="15" name="Rectangle 14"/>
+          <p:cNvPr id="14" name="Rectangle 13"/>
           <p:cNvSpPr/>
           <p:nvPr/>
         </p:nvSpPr>
@@ -7143,7 +6828,7 @@
       </p:sp>
       <p:sp>
         <p:nvSpPr>
-          <p:cNvPr id="16" name="Rectangle 15"/>
+          <p:cNvPr id="15" name="Rectangle 14"/>
           <p:cNvSpPr/>
           <p:nvPr/>
         </p:nvSpPr>
@@ -7186,74 +6871,21 @@
       </p:sp>
       <p:sp>
         <p:nvSpPr>
-          <p:cNvPr id="17" name="Oval 16"/>
-          <p:cNvSpPr/>
+          <p:cNvPr id="16" name="TextBox 15"/>
+          <p:cNvSpPr txBox="1"/>
           <p:nvPr/>
         </p:nvSpPr>
         <p:spPr>
           <a:xfrm>
             <a:off x="6484467" y="2468880"/>
-            <a:ext cx="347472" cy="347472"/>
-          </a:xfrm>
-          <a:prstGeom prst="ellipse">
-            <a:avLst/>
-          </a:prstGeom>
-          <a:solidFill>
-            <a:srgbClr val="0A1638"/>
-          </a:solidFill>
-          <a:ln w="19050">
-            <a:solidFill>
-              <a:srgbClr val="2FDFE5"/>
-            </a:solidFill>
-          </a:ln>
-        </p:spPr>
-        <p:style>
-          <a:lnRef idx="1">
-            <a:schemeClr val="accent1"/>
-          </a:lnRef>
-          <a:fillRef idx="3">
-            <a:schemeClr val="accent1"/>
-          </a:fillRef>
-          <a:effectRef idx="2">
-            <a:schemeClr val="accent1"/>
-          </a:effectRef>
-          <a:fontRef idx="minor">
-            <a:schemeClr val="lt1"/>
-          </a:fontRef>
-        </p:style>
-        <p:txBody lIns="0" tIns="0" rIns="0" bIns="0">
-          <a:bodyPr rtlCol="0" anchor="ctr" wrap="none"/>
-          <a:lstStyle/>
-          <a:p>
-            <a:pPr algn="ctr"/>
-            <a:r>
-              <a:rPr sz="1600" b="1">
-                <a:solidFill>
-                  <a:srgbClr val="2FDFE5"/>
-                </a:solidFill>
-              </a:rPr>
-              <a:t>8</a:t>
-            </a:r>
-          </a:p>
-        </p:txBody>
-      </p:sp>
-      <p:sp>
-        <p:nvSpPr>
-          <p:cNvPr id="18" name="TextBox 17"/>
-          <p:cNvSpPr txBox="1"/>
-          <p:nvPr/>
-        </p:nvSpPr>
-        <p:spPr>
-          <a:xfrm>
-            <a:off x="6959955" y="2468880"/>
-            <a:ext cx="4683099" cy="658368"/>
+            <a:ext cx="5176875" cy="621792"/>
           </a:xfrm>
           <a:prstGeom prst="rect">
             <a:avLst/>
           </a:prstGeom>
           <a:noFill/>
         </p:spPr>
-        <p:txBody lIns="38100" tIns="25400" rIns="38100" bIns="25400">
+        <p:txBody lIns="38100" tIns="50800" rIns="38100" bIns="25400">
           <a:bodyPr wrap="square">
             <a:spAutoFit/>
           </a:bodyPr>
@@ -7263,6 +6895,14 @@
             <a:r>
               <a:rPr sz="1800" b="1">
                 <a:solidFill>
+                  <a:srgbClr val="2FDFE5"/>
+                </a:solidFill>
+              </a:rPr>
+              <a:t>8  </a:t>
+            </a:r>
+            <a:r>
+              <a:rPr sz="1800" b="1">
+                <a:solidFill>
                   <a:srgbClr val="FFFFFF"/>
                 </a:solidFill>
               </a:rPr>
@@ -7273,13 +6913,13 @@
       </p:sp>
       <p:sp>
         <p:nvSpPr>
-          <p:cNvPr id="19" name="Rectangle 18"/>
+          <p:cNvPr id="17" name="Rectangle 16"/>
           <p:cNvSpPr/>
           <p:nvPr/>
         </p:nvSpPr>
         <p:spPr>
           <a:xfrm>
-            <a:off x="6447891" y="2944368"/>
+            <a:off x="6447891" y="3182112"/>
             <a:ext cx="5250027" cy="15240"/>
           </a:xfrm>
           <a:prstGeom prst="rect">
@@ -7316,14 +6956,14 @@
       </p:sp>
       <p:sp>
         <p:nvSpPr>
-          <p:cNvPr id="20" name="TextBox 19"/>
+          <p:cNvPr id="18" name="TextBox 17"/>
           <p:cNvSpPr txBox="1"/>
           <p:nvPr/>
         </p:nvSpPr>
         <p:spPr>
           <a:xfrm>
-            <a:off x="6447891" y="3045968"/>
-            <a:ext cx="5250027" cy="2923032"/>
+            <a:off x="6447891" y="3283712"/>
+            <a:ext cx="5250027" cy="2685288"/>
           </a:xfrm>
           <a:prstGeom prst="rect">
             <a:avLst/>
@@ -7408,7 +7048,7 @@
       </p:sp>
       <p:pic>
         <p:nvPicPr>
-          <p:cNvPr id="21" name="Picture 20" descr="logo_horiz.png"/>
+          <p:cNvPr id="19" name="Picture 18" descr="logo_horiz.png"/>
           <p:cNvPicPr>
             <a:picLocks noChangeAspect="1"/>
           </p:cNvPicPr>
@@ -7476,7 +7116,7 @@
                                 <p:cBhvr>
                                   <p:cTn id="8" dur="450" fill="hold"/>
                                   <p:tgtEl>
-                                    <p:spTgt spid="15"/>
+                                    <p:spTgt spid="14"/>
                                   </p:tgtEl>
                                 </p:cBhvr>
                               </p:animEffect>
@@ -7852,74 +7492,21 @@
       </p:sp>
       <p:sp>
         <p:nvSpPr>
-          <p:cNvPr id="10" name="Oval 9"/>
-          <p:cNvSpPr/>
+          <p:cNvPr id="10" name="TextBox 9"/>
+          <p:cNvSpPr txBox="1"/>
           <p:nvPr/>
         </p:nvSpPr>
         <p:spPr>
           <a:xfrm>
             <a:off x="685800" y="2084832"/>
-            <a:ext cx="329184" cy="329184"/>
-          </a:xfrm>
-          <a:prstGeom prst="ellipse">
-            <a:avLst/>
-          </a:prstGeom>
-          <a:solidFill>
-            <a:srgbClr val="0A1638"/>
-          </a:solidFill>
-          <a:ln w="19050">
-            <a:solidFill>
-              <a:srgbClr val="2FDFE5"/>
-            </a:solidFill>
-          </a:ln>
-        </p:spPr>
-        <p:style>
-          <a:lnRef idx="1">
-            <a:schemeClr val="accent1"/>
-          </a:lnRef>
-          <a:fillRef idx="3">
-            <a:schemeClr val="accent1"/>
-          </a:fillRef>
-          <a:effectRef idx="2">
-            <a:schemeClr val="accent1"/>
-          </a:effectRef>
-          <a:fontRef idx="minor">
-            <a:schemeClr val="lt1"/>
-          </a:fontRef>
-        </p:style>
-        <p:txBody lIns="0" tIns="0" rIns="0" bIns="0">
-          <a:bodyPr rtlCol="0" anchor="ctr" wrap="none"/>
-          <a:lstStyle/>
-          <a:p>
-            <a:pPr algn="ctr"/>
-            <a:r>
-              <a:rPr sz="1600" b="1">
-                <a:solidFill>
-                  <a:srgbClr val="2FDFE5"/>
-                </a:solidFill>
-              </a:rPr>
-              <a:t>1</a:t>
-            </a:r>
-          </a:p>
-        </p:txBody>
-      </p:sp>
-      <p:sp>
-        <p:nvSpPr>
-          <p:cNvPr id="11" name="TextBox 10"/>
-          <p:cNvSpPr txBox="1"/>
-          <p:nvPr/>
-        </p:nvSpPr>
-        <p:spPr>
-          <a:xfrm>
-            <a:off x="1143000" y="2084832"/>
-            <a:ext cx="4756251" cy="585216"/>
+            <a:ext cx="5213451" cy="548640"/>
           </a:xfrm>
           <a:prstGeom prst="rect">
             <a:avLst/>
           </a:prstGeom>
           <a:noFill/>
         </p:spPr>
-        <p:txBody lIns="38100" tIns="25400" rIns="38100" bIns="25400">
+        <p:txBody lIns="38100" tIns="50800" rIns="38100" bIns="25400">
           <a:bodyPr wrap="square">
             <a:spAutoFit/>
           </a:bodyPr>
@@ -7929,6 +7516,14 @@
             <a:r>
               <a:rPr sz="1700" b="1">
                 <a:solidFill>
+                  <a:srgbClr val="2FDFE5"/>
+                </a:solidFill>
+              </a:rPr>
+              <a:t>1  </a:t>
+            </a:r>
+            <a:r>
+              <a:rPr sz="1700" b="1">
+                <a:solidFill>
                   <a:srgbClr val="FFFFFF"/>
                 </a:solidFill>
               </a:rPr>
@@ -7939,13 +7534,13 @@
       </p:sp>
       <p:sp>
         <p:nvSpPr>
-          <p:cNvPr id="12" name="Rectangle 11"/>
+          <p:cNvPr id="11" name="Rectangle 10"/>
           <p:cNvSpPr/>
           <p:nvPr/>
         </p:nvSpPr>
         <p:spPr>
           <a:xfrm>
-            <a:off x="649224" y="2542032"/>
+            <a:off x="649224" y="2724912"/>
             <a:ext cx="5286603" cy="12700"/>
           </a:xfrm>
           <a:prstGeom prst="rect">
@@ -7982,14 +7577,14 @@
       </p:sp>
       <p:sp>
         <p:nvSpPr>
-          <p:cNvPr id="13" name="TextBox 12"/>
+          <p:cNvPr id="12" name="TextBox 11"/>
           <p:cNvSpPr txBox="1"/>
           <p:nvPr/>
         </p:nvSpPr>
         <p:spPr>
           <a:xfrm>
-            <a:off x="649224" y="2630932"/>
-            <a:ext cx="5286603" cy="1216660"/>
+            <a:off x="649224" y="2813812"/>
+            <a:ext cx="5286603" cy="1033780"/>
           </a:xfrm>
           <a:prstGeom prst="rect">
             <a:avLst/>
@@ -8016,7 +7611,7 @@
       </p:sp>
       <p:sp>
         <p:nvSpPr>
-          <p:cNvPr id="14" name="Rectangle 13"/>
+          <p:cNvPr id="13" name="Rectangle 12"/>
           <p:cNvSpPr/>
           <p:nvPr/>
         </p:nvSpPr>
@@ -8061,7 +7656,7 @@
       </p:sp>
       <p:sp>
         <p:nvSpPr>
-          <p:cNvPr id="15" name="Rectangle 14"/>
+          <p:cNvPr id="14" name="Rectangle 13"/>
           <p:cNvSpPr/>
           <p:nvPr/>
         </p:nvSpPr>
@@ -8104,74 +7699,21 @@
       </p:sp>
       <p:sp>
         <p:nvSpPr>
-          <p:cNvPr id="16" name="Oval 15"/>
-          <p:cNvSpPr/>
+          <p:cNvPr id="15" name="TextBox 14"/>
+          <p:cNvSpPr txBox="1"/>
           <p:nvPr/>
         </p:nvSpPr>
         <p:spPr>
           <a:xfrm>
             <a:off x="6466179" y="2084832"/>
-            <a:ext cx="329184" cy="329184"/>
-          </a:xfrm>
-          <a:prstGeom prst="ellipse">
-            <a:avLst/>
-          </a:prstGeom>
-          <a:solidFill>
-            <a:srgbClr val="0A1638"/>
-          </a:solidFill>
-          <a:ln w="19050">
-            <a:solidFill>
-              <a:srgbClr val="2FDFE5"/>
-            </a:solidFill>
-          </a:ln>
-        </p:spPr>
-        <p:style>
-          <a:lnRef idx="1">
-            <a:schemeClr val="accent1"/>
-          </a:lnRef>
-          <a:fillRef idx="3">
-            <a:schemeClr val="accent1"/>
-          </a:fillRef>
-          <a:effectRef idx="2">
-            <a:schemeClr val="accent1"/>
-          </a:effectRef>
-          <a:fontRef idx="minor">
-            <a:schemeClr val="lt1"/>
-          </a:fontRef>
-        </p:style>
-        <p:txBody lIns="0" tIns="0" rIns="0" bIns="0">
-          <a:bodyPr rtlCol="0" anchor="ctr" wrap="none"/>
-          <a:lstStyle/>
-          <a:p>
-            <a:pPr algn="ctr"/>
-            <a:r>
-              <a:rPr sz="1600" b="1">
-                <a:solidFill>
-                  <a:srgbClr val="2FDFE5"/>
-                </a:solidFill>
-              </a:rPr>
-              <a:t>2</a:t>
-            </a:r>
-          </a:p>
-        </p:txBody>
-      </p:sp>
-      <p:sp>
-        <p:nvSpPr>
-          <p:cNvPr id="17" name="TextBox 16"/>
-          <p:cNvSpPr txBox="1"/>
-          <p:nvPr/>
-        </p:nvSpPr>
-        <p:spPr>
-          <a:xfrm>
-            <a:off x="6923379" y="2084832"/>
-            <a:ext cx="4756251" cy="585216"/>
+            <a:ext cx="5213451" cy="548640"/>
           </a:xfrm>
           <a:prstGeom prst="rect">
             <a:avLst/>
           </a:prstGeom>
           <a:noFill/>
         </p:spPr>
-        <p:txBody lIns="38100" tIns="25400" rIns="38100" bIns="25400">
+        <p:txBody lIns="38100" tIns="50800" rIns="38100" bIns="25400">
           <a:bodyPr wrap="square">
             <a:spAutoFit/>
           </a:bodyPr>
@@ -8181,6 +7723,14 @@
             <a:r>
               <a:rPr sz="1700" b="1">
                 <a:solidFill>
+                  <a:srgbClr val="2FDFE5"/>
+                </a:solidFill>
+              </a:rPr>
+              <a:t>2  </a:t>
+            </a:r>
+            <a:r>
+              <a:rPr sz="1700" b="1">
+                <a:solidFill>
                   <a:srgbClr val="FFFFFF"/>
                 </a:solidFill>
               </a:rPr>
@@ -8191,13 +7741,13 @@
       </p:sp>
       <p:sp>
         <p:nvSpPr>
-          <p:cNvPr id="18" name="Rectangle 17"/>
+          <p:cNvPr id="16" name="Rectangle 15"/>
           <p:cNvSpPr/>
           <p:nvPr/>
         </p:nvSpPr>
         <p:spPr>
           <a:xfrm>
-            <a:off x="6429603" y="2542032"/>
+            <a:off x="6429603" y="2724912"/>
             <a:ext cx="5286603" cy="12700"/>
           </a:xfrm>
           <a:prstGeom prst="rect">
@@ -8234,14 +7784,14 @@
       </p:sp>
       <p:sp>
         <p:nvSpPr>
-          <p:cNvPr id="19" name="TextBox 18"/>
+          <p:cNvPr id="17" name="TextBox 16"/>
           <p:cNvSpPr txBox="1"/>
           <p:nvPr/>
         </p:nvSpPr>
         <p:spPr>
           <a:xfrm>
-            <a:off x="6429603" y="2630932"/>
-            <a:ext cx="5286603" cy="1216660"/>
+            <a:off x="6429603" y="2813812"/>
+            <a:ext cx="5286603" cy="1033780"/>
           </a:xfrm>
           <a:prstGeom prst="rect">
             <a:avLst/>
@@ -8268,7 +7818,7 @@
       </p:sp>
       <p:sp>
         <p:nvSpPr>
-          <p:cNvPr id="20" name="Rectangle 19"/>
+          <p:cNvPr id="18" name="Rectangle 17"/>
           <p:cNvSpPr/>
           <p:nvPr/>
         </p:nvSpPr>
@@ -8313,7 +7863,7 @@
       </p:sp>
       <p:sp>
         <p:nvSpPr>
-          <p:cNvPr id="21" name="Rectangle 20"/>
+          <p:cNvPr id="19" name="Rectangle 18"/>
           <p:cNvSpPr/>
           <p:nvPr/>
         </p:nvSpPr>
@@ -8356,74 +7906,21 @@
       </p:sp>
       <p:sp>
         <p:nvSpPr>
-          <p:cNvPr id="22" name="Oval 21"/>
-          <p:cNvSpPr/>
+          <p:cNvPr id="20" name="TextBox 19"/>
+          <p:cNvSpPr txBox="1"/>
           <p:nvPr/>
         </p:nvSpPr>
         <p:spPr>
           <a:xfrm>
             <a:off x="685800" y="4224528"/>
-            <a:ext cx="329184" cy="329184"/>
-          </a:xfrm>
-          <a:prstGeom prst="ellipse">
-            <a:avLst/>
-          </a:prstGeom>
-          <a:solidFill>
-            <a:srgbClr val="0A1638"/>
-          </a:solidFill>
-          <a:ln w="19050">
-            <a:solidFill>
-              <a:srgbClr val="2FDFE5"/>
-            </a:solidFill>
-          </a:ln>
-        </p:spPr>
-        <p:style>
-          <a:lnRef idx="1">
-            <a:schemeClr val="accent1"/>
-          </a:lnRef>
-          <a:fillRef idx="3">
-            <a:schemeClr val="accent1"/>
-          </a:fillRef>
-          <a:effectRef idx="2">
-            <a:schemeClr val="accent1"/>
-          </a:effectRef>
-          <a:fontRef idx="minor">
-            <a:schemeClr val="lt1"/>
-          </a:fontRef>
-        </p:style>
-        <p:txBody lIns="0" tIns="0" rIns="0" bIns="0">
-          <a:bodyPr rtlCol="0" anchor="ctr" wrap="none"/>
-          <a:lstStyle/>
-          <a:p>
-            <a:pPr algn="ctr"/>
-            <a:r>
-              <a:rPr sz="1600" b="1">
-                <a:solidFill>
-                  <a:srgbClr val="2FDFE5"/>
-                </a:solidFill>
-              </a:rPr>
-              <a:t>3</a:t>
-            </a:r>
-          </a:p>
-        </p:txBody>
-      </p:sp>
-      <p:sp>
-        <p:nvSpPr>
-          <p:cNvPr id="23" name="TextBox 22"/>
-          <p:cNvSpPr txBox="1"/>
-          <p:nvPr/>
-        </p:nvSpPr>
-        <p:spPr>
-          <a:xfrm>
-            <a:off x="1143000" y="4224528"/>
-            <a:ext cx="4756251" cy="585216"/>
+            <a:ext cx="5213451" cy="548640"/>
           </a:xfrm>
           <a:prstGeom prst="rect">
             <a:avLst/>
           </a:prstGeom>
           <a:noFill/>
         </p:spPr>
-        <p:txBody lIns="38100" tIns="25400" rIns="38100" bIns="25400">
+        <p:txBody lIns="38100" tIns="50800" rIns="38100" bIns="25400">
           <a:bodyPr wrap="square">
             <a:spAutoFit/>
           </a:bodyPr>
@@ -8433,6 +7930,14 @@
             <a:r>
               <a:rPr sz="1700" b="1">
                 <a:solidFill>
+                  <a:srgbClr val="2FDFE5"/>
+                </a:solidFill>
+              </a:rPr>
+              <a:t>3  </a:t>
+            </a:r>
+            <a:r>
+              <a:rPr sz="1700" b="1">
+                <a:solidFill>
                   <a:srgbClr val="FFFFFF"/>
                 </a:solidFill>
               </a:rPr>
@@ -8443,13 +7948,13 @@
       </p:sp>
       <p:sp>
         <p:nvSpPr>
-          <p:cNvPr id="24" name="Rectangle 23"/>
+          <p:cNvPr id="21" name="Rectangle 20"/>
           <p:cNvSpPr/>
           <p:nvPr/>
         </p:nvSpPr>
         <p:spPr>
           <a:xfrm>
-            <a:off x="649224" y="4681728"/>
+            <a:off x="649224" y="4864608"/>
             <a:ext cx="5286603" cy="12700"/>
           </a:xfrm>
           <a:prstGeom prst="rect">
@@ -8486,14 +7991,14 @@
       </p:sp>
       <p:sp>
         <p:nvSpPr>
-          <p:cNvPr id="25" name="TextBox 24"/>
+          <p:cNvPr id="22" name="TextBox 21"/>
           <p:cNvSpPr txBox="1"/>
           <p:nvPr/>
         </p:nvSpPr>
         <p:spPr>
           <a:xfrm>
-            <a:off x="649224" y="4770628"/>
-            <a:ext cx="5286603" cy="1216660"/>
+            <a:off x="649224" y="4953508"/>
+            <a:ext cx="5286603" cy="1033780"/>
           </a:xfrm>
           <a:prstGeom prst="rect">
             <a:avLst/>
@@ -8520,7 +8025,7 @@
       </p:sp>
       <p:sp>
         <p:nvSpPr>
-          <p:cNvPr id="26" name="Rectangle 25"/>
+          <p:cNvPr id="23" name="Rectangle 22"/>
           <p:cNvSpPr/>
           <p:nvPr/>
         </p:nvSpPr>
@@ -8565,7 +8070,7 @@
       </p:sp>
       <p:sp>
         <p:nvSpPr>
-          <p:cNvPr id="27" name="Rectangle 26"/>
+          <p:cNvPr id="24" name="Rectangle 23"/>
           <p:cNvSpPr/>
           <p:nvPr/>
         </p:nvSpPr>
@@ -8608,74 +8113,21 @@
       </p:sp>
       <p:sp>
         <p:nvSpPr>
-          <p:cNvPr id="28" name="Oval 27"/>
-          <p:cNvSpPr/>
+          <p:cNvPr id="25" name="TextBox 24"/>
+          <p:cNvSpPr txBox="1"/>
           <p:nvPr/>
         </p:nvSpPr>
         <p:spPr>
           <a:xfrm>
             <a:off x="6466179" y="4224528"/>
-            <a:ext cx="329184" cy="329184"/>
-          </a:xfrm>
-          <a:prstGeom prst="ellipse">
-            <a:avLst/>
-          </a:prstGeom>
-          <a:solidFill>
-            <a:srgbClr val="0A1638"/>
-          </a:solidFill>
-          <a:ln w="19050">
-            <a:solidFill>
-              <a:srgbClr val="2FDFE5"/>
-            </a:solidFill>
-          </a:ln>
-        </p:spPr>
-        <p:style>
-          <a:lnRef idx="1">
-            <a:schemeClr val="accent1"/>
-          </a:lnRef>
-          <a:fillRef idx="3">
-            <a:schemeClr val="accent1"/>
-          </a:fillRef>
-          <a:effectRef idx="2">
-            <a:schemeClr val="accent1"/>
-          </a:effectRef>
-          <a:fontRef idx="minor">
-            <a:schemeClr val="lt1"/>
-          </a:fontRef>
-        </p:style>
-        <p:txBody lIns="0" tIns="0" rIns="0" bIns="0">
-          <a:bodyPr rtlCol="0" anchor="ctr" wrap="none"/>
-          <a:lstStyle/>
-          <a:p>
-            <a:pPr algn="ctr"/>
-            <a:r>
-              <a:rPr sz="1600" b="1">
-                <a:solidFill>
-                  <a:srgbClr val="2FDFE5"/>
-                </a:solidFill>
-              </a:rPr>
-              <a:t>4</a:t>
-            </a:r>
-          </a:p>
-        </p:txBody>
-      </p:sp>
-      <p:sp>
-        <p:nvSpPr>
-          <p:cNvPr id="29" name="TextBox 28"/>
-          <p:cNvSpPr txBox="1"/>
-          <p:nvPr/>
-        </p:nvSpPr>
-        <p:spPr>
-          <a:xfrm>
-            <a:off x="6923379" y="4224528"/>
-            <a:ext cx="4756251" cy="585216"/>
+            <a:ext cx="5213451" cy="548640"/>
           </a:xfrm>
           <a:prstGeom prst="rect">
             <a:avLst/>
           </a:prstGeom>
           <a:noFill/>
         </p:spPr>
-        <p:txBody lIns="38100" tIns="25400" rIns="38100" bIns="25400">
+        <p:txBody lIns="38100" tIns="50800" rIns="38100" bIns="25400">
           <a:bodyPr wrap="square">
             <a:spAutoFit/>
           </a:bodyPr>
@@ -8685,6 +8137,14 @@
             <a:r>
               <a:rPr sz="1700" b="1">
                 <a:solidFill>
+                  <a:srgbClr val="2FDFE5"/>
+                </a:solidFill>
+              </a:rPr>
+              <a:t>4  </a:t>
+            </a:r>
+            <a:r>
+              <a:rPr sz="1700" b="1">
+                <a:solidFill>
                   <a:srgbClr val="FFFFFF"/>
                 </a:solidFill>
               </a:rPr>
@@ -8695,13 +8155,13 @@
       </p:sp>
       <p:sp>
         <p:nvSpPr>
-          <p:cNvPr id="30" name="Rectangle 29"/>
+          <p:cNvPr id="26" name="Rectangle 25"/>
           <p:cNvSpPr/>
           <p:nvPr/>
         </p:nvSpPr>
         <p:spPr>
           <a:xfrm>
-            <a:off x="6429603" y="4681728"/>
+            <a:off x="6429603" y="4864608"/>
             <a:ext cx="5286603" cy="12700"/>
           </a:xfrm>
           <a:prstGeom prst="rect">
@@ -8738,14 +8198,14 @@
       </p:sp>
       <p:sp>
         <p:nvSpPr>
-          <p:cNvPr id="31" name="TextBox 30"/>
+          <p:cNvPr id="27" name="TextBox 26"/>
           <p:cNvSpPr txBox="1"/>
           <p:nvPr/>
         </p:nvSpPr>
         <p:spPr>
           <a:xfrm>
-            <a:off x="6429603" y="4770628"/>
-            <a:ext cx="5286603" cy="1216660"/>
+            <a:off x="6429603" y="4953508"/>
+            <a:ext cx="5286603" cy="1033780"/>
           </a:xfrm>
           <a:prstGeom prst="rect">
             <a:avLst/>
@@ -8772,7 +8232,7 @@
       </p:sp>
       <p:pic>
         <p:nvPicPr>
-          <p:cNvPr id="32" name="Picture 31" descr="logo_horiz.png"/>
+          <p:cNvPr id="28" name="Picture 27" descr="logo_horiz.png"/>
           <p:cNvPicPr>
             <a:picLocks noChangeAspect="1"/>
           </p:cNvPicPr>
@@ -8840,7 +8300,7 @@
                                 <p:cBhvr>
                                   <p:cTn id="8" dur="450" fill="hold"/>
                                   <p:tgtEl>
-                                    <p:spTgt spid="14"/>
+                                    <p:spTgt spid="13"/>
                                   </p:tgtEl>
                                 </p:cBhvr>
                               </p:animEffect>
@@ -8857,7 +8317,7 @@
                                 <p:cBhvr>
                                   <p:cTn id="10" dur="450" fill="hold"/>
                                   <p:tgtEl>
-                                    <p:spTgt spid="20"/>
+                                    <p:spTgt spid="18"/>
                                   </p:tgtEl>
                                 </p:cBhvr>
                               </p:animEffect>
@@ -8874,7 +8334,7 @@
                                 <p:cBhvr>
                                   <p:cTn id="12" dur="450" fill="hold"/>
                                   <p:tgtEl>
-                                    <p:spTgt spid="26"/>
+                                    <p:spTgt spid="23"/>
                                   </p:tgtEl>
                                 </p:cBhvr>
                               </p:animEffect>

</xml_diff>

<commit_message>
Polish layout and add cascade animation
- Kicker (FASE X label): solid teal fill, sz=11, well-framed pill shape
- Cards: shorter bottom clearance so bullets fill card height properly
- Card title sz=19, bullet text sz=17, bullet spacing space_before=Pt(18)
- Feat grid desc sz=15
- New add_grouped_wipe(): card rect + title + sep + bullets all wipe in together
  as a group per card, cards stagger 150ms apart — parallax cascade effect
</commit_message>
<xml_diff>
--- a/sendacredit_propuesta.pptx
+++ b/sendacredit_propuesta.pptx
@@ -3595,100 +3595,7 @@
         <p:spPr>
           <a:xfrm>
             <a:off x="502920" y="365760"/>
-            <a:ext cx="1463040" cy="274320"/>
-          </a:xfrm>
-          <a:prstGeom prst="rect">
-            <a:avLst/>
-          </a:prstGeom>
-          <a:noFill/>
-          <a:ln w="15240">
-            <a:solidFill>
-              <a:srgbClr val="2FDFE5"/>
-            </a:solidFill>
-          </a:ln>
-        </p:spPr>
-        <p:style>
-          <a:lnRef idx="1">
-            <a:schemeClr val="accent1"/>
-          </a:lnRef>
-          <a:fillRef idx="3">
-            <a:schemeClr val="accent1"/>
-          </a:fillRef>
-          <a:effectRef idx="2">
-            <a:schemeClr val="accent1"/>
-          </a:effectRef>
-          <a:fontRef idx="minor">
-            <a:schemeClr val="lt1"/>
-          </a:fontRef>
-        </p:style>
-        <p:txBody lIns="76200" tIns="12700" rIns="76200" bIns="12700">
-          <a:bodyPr rtlCol="0" anchor="ctr" wrap="none"/>
-          <a:lstStyle/>
-          <a:p>
-            <a:pPr algn="ctr"/>
-            <a:r>
-              <a:rPr sz="800" b="1">
-                <a:solidFill>
-                  <a:srgbClr val="2FDFE5"/>
-                </a:solidFill>
-              </a:rPr>
-              <a:t>FASE 1</a:t>
-            </a:r>
-          </a:p>
-        </p:txBody>
-      </p:sp>
-      <p:sp>
-        <p:nvSpPr>
-          <p:cNvPr id="6" name="TextBox 5"/>
-          <p:cNvSpPr txBox="1"/>
-          <p:nvPr/>
-        </p:nvSpPr>
-        <p:spPr>
-          <a:xfrm>
-            <a:off x="502920" y="731520"/>
-            <a:ext cx="8961120" cy="960120"/>
-          </a:xfrm>
-          <a:prstGeom prst="rect">
-            <a:avLst/>
-          </a:prstGeom>
-          <a:noFill/>
-        </p:spPr>
-        <p:txBody lIns="0" tIns="0" rIns="0" bIns="0">
-          <a:bodyPr wrap="square">
-            <a:spAutoFit/>
-          </a:bodyPr>
-          <a:lstStyle/>
-          <a:p>
-            <a:pPr algn="l"/>
-            <a:r>
-              <a:rPr sz="4000" b="1">
-                <a:solidFill>
-                  <a:srgbClr val="FFFFFF"/>
-                </a:solidFill>
-              </a:rPr>
-              <a:t>Inicio del </a:t>
-            </a:r>
-            <a:r>
-              <a:rPr sz="4000" b="1">
-                <a:solidFill>
-                  <a:srgbClr val="2FDFE5"/>
-                </a:solidFill>
-              </a:rPr>
-              <a:t>expediente</a:t>
-            </a:r>
-          </a:p>
-        </p:txBody>
-      </p:sp>
-      <p:sp>
-        <p:nvSpPr>
-          <p:cNvPr id="7" name="Rectangle 6"/>
-          <p:cNvSpPr/>
-          <p:nvPr/>
-        </p:nvSpPr>
-        <p:spPr>
-          <a:xfrm>
-            <a:off x="502920" y="1737360"/>
-            <a:ext cx="4389120" cy="31750"/>
+            <a:ext cx="1737360" cy="301752"/>
           </a:xfrm>
           <a:prstGeom prst="rect">
             <a:avLst/>
@@ -3714,24 +3621,32 @@
             <a:schemeClr val="lt1"/>
           </a:fontRef>
         </p:style>
-        <p:txBody>
-          <a:bodyPr rtlCol="0" anchor="ctr"/>
+        <p:txBody lIns="101600" tIns="25400" rIns="101600" bIns="25400">
+          <a:bodyPr rtlCol="0" anchor="ctr" wrap="none"/>
           <a:lstStyle/>
           <a:p>
             <a:pPr algn="ctr"/>
-          </a:p>
-        </p:txBody>
-      </p:sp>
-      <p:sp>
-        <p:nvSpPr>
-          <p:cNvPr id="8" name="TextBox 7"/>
+            <a:r>
+              <a:rPr sz="1100" b="1">
+                <a:solidFill>
+                  <a:srgbClr val="0A1638"/>
+                </a:solidFill>
+              </a:rPr>
+              <a:t>FASE 1</a:t>
+            </a:r>
+          </a:p>
+        </p:txBody>
+      </p:sp>
+      <p:sp>
+        <p:nvSpPr>
+          <p:cNvPr id="6" name="TextBox 5"/>
           <p:cNvSpPr txBox="1"/>
           <p:nvPr/>
         </p:nvSpPr>
         <p:spPr>
           <a:xfrm>
-            <a:off x="502920" y="1810512"/>
-            <a:ext cx="9265615" cy="384048"/>
+            <a:off x="502920" y="731520"/>
+            <a:ext cx="8961120" cy="960120"/>
           </a:xfrm>
           <a:prstGeom prst="rect">
             <a:avLst/>
@@ -3739,78 +3654,41 @@
           <a:noFill/>
         </p:spPr>
         <p:txBody lIns="0" tIns="0" rIns="0" bIns="0">
-          <a:bodyPr wrap="none">
+          <a:bodyPr wrap="square">
             <a:spAutoFit/>
           </a:bodyPr>
           <a:lstStyle/>
           <a:p>
             <a:pPr algn="l"/>
             <a:r>
-              <a:rPr sz="1300" i="1">
-                <a:solidFill>
-                  <a:srgbClr val="80A8CC"/>
-                </a:solidFill>
-              </a:rPr>
-              <a:t>Cada caso entra en nuestro circuito con un punto de partida limpio, verificado y correctamente segmentado.</a:t>
-            </a:r>
-          </a:p>
-        </p:txBody>
-      </p:sp>
-      <p:sp>
-        <p:nvSpPr>
-          <p:cNvPr id="9" name="Rectangle 8"/>
+              <a:rPr sz="4000" b="1">
+                <a:solidFill>
+                  <a:srgbClr val="FFFFFF"/>
+                </a:solidFill>
+              </a:rPr>
+              <a:t>Inicio del </a:t>
+            </a:r>
+            <a:r>
+              <a:rPr sz="4000" b="1">
+                <a:solidFill>
+                  <a:srgbClr val="2FDFE5"/>
+                </a:solidFill>
+              </a:rPr>
+              <a:t>expediente</a:t>
+            </a:r>
+          </a:p>
+        </p:txBody>
+      </p:sp>
+      <p:sp>
+        <p:nvSpPr>
+          <p:cNvPr id="7" name="Rectangle 6"/>
           <p:cNvSpPr/>
           <p:nvPr/>
         </p:nvSpPr>
         <p:spPr>
           <a:xfrm>
-            <a:off x="502920" y="2267712"/>
-            <a:ext cx="5579211" cy="3785616"/>
-          </a:xfrm>
-          <a:prstGeom prst="rect">
-            <a:avLst/>
-          </a:prstGeom>
-          <a:solidFill>
-            <a:srgbClr val="081438"/>
-          </a:solidFill>
-          <a:ln w="10160">
-            <a:solidFill>
-              <a:srgbClr val="2FDFE5"/>
-            </a:solidFill>
-          </a:ln>
-        </p:spPr>
-        <p:style>
-          <a:lnRef idx="1">
-            <a:schemeClr val="accent1"/>
-          </a:lnRef>
-          <a:fillRef idx="3">
-            <a:schemeClr val="accent1"/>
-          </a:fillRef>
-          <a:effectRef idx="2">
-            <a:schemeClr val="accent1"/>
-          </a:effectRef>
-          <a:fontRef idx="minor">
-            <a:schemeClr val="lt1"/>
-          </a:fontRef>
-        </p:style>
-        <p:txBody>
-          <a:bodyPr rtlCol="0" anchor="ctr"/>
-          <a:lstStyle/>
-          <a:p>
-            <a:pPr algn="ctr"/>
-          </a:p>
-        </p:txBody>
-      </p:sp>
-      <p:sp>
-        <p:nvSpPr>
-          <p:cNvPr id="10" name="Rectangle 9"/>
-          <p:cNvSpPr/>
-          <p:nvPr/>
-        </p:nvSpPr>
-        <p:spPr>
-          <a:xfrm>
-            <a:off x="502920" y="2267712"/>
-            <a:ext cx="5579211" cy="63500"/>
+            <a:off x="502920" y="1737360"/>
+            <a:ext cx="4389120" cy="31750"/>
           </a:xfrm>
           <a:prstGeom prst="rect">
             <a:avLst/>
@@ -3846,21 +3724,143 @@
       </p:sp>
       <p:sp>
         <p:nvSpPr>
+          <p:cNvPr id="8" name="TextBox 7"/>
+          <p:cNvSpPr txBox="1"/>
+          <p:nvPr/>
+        </p:nvSpPr>
+        <p:spPr>
+          <a:xfrm>
+            <a:off x="502920" y="1810512"/>
+            <a:ext cx="9265615" cy="384048"/>
+          </a:xfrm>
+          <a:prstGeom prst="rect">
+            <a:avLst/>
+          </a:prstGeom>
+          <a:noFill/>
+        </p:spPr>
+        <p:txBody lIns="0" tIns="0" rIns="0" bIns="0">
+          <a:bodyPr wrap="none">
+            <a:spAutoFit/>
+          </a:bodyPr>
+          <a:lstStyle/>
+          <a:p>
+            <a:pPr algn="l"/>
+            <a:r>
+              <a:rPr sz="1300" i="1">
+                <a:solidFill>
+                  <a:srgbClr val="80A8CC"/>
+                </a:solidFill>
+              </a:rPr>
+              <a:t>Cada caso entra en nuestro circuito con un punto de partida limpio, verificado y correctamente segmentado.</a:t>
+            </a:r>
+          </a:p>
+        </p:txBody>
+      </p:sp>
+      <p:sp>
+        <p:nvSpPr>
+          <p:cNvPr id="9" name="Rectangle 8"/>
+          <p:cNvSpPr/>
+          <p:nvPr/>
+        </p:nvSpPr>
+        <p:spPr>
+          <a:xfrm>
+            <a:off x="502920" y="2267712"/>
+            <a:ext cx="5579211" cy="3328416"/>
+          </a:xfrm>
+          <a:prstGeom prst="rect">
+            <a:avLst/>
+          </a:prstGeom>
+          <a:solidFill>
+            <a:srgbClr val="081438"/>
+          </a:solidFill>
+          <a:ln w="12700">
+            <a:solidFill>
+              <a:srgbClr val="2FDFE5"/>
+            </a:solidFill>
+          </a:ln>
+        </p:spPr>
+        <p:style>
+          <a:lnRef idx="1">
+            <a:schemeClr val="accent1"/>
+          </a:lnRef>
+          <a:fillRef idx="3">
+            <a:schemeClr val="accent1"/>
+          </a:fillRef>
+          <a:effectRef idx="2">
+            <a:schemeClr val="accent1"/>
+          </a:effectRef>
+          <a:fontRef idx="minor">
+            <a:schemeClr val="lt1"/>
+          </a:fontRef>
+        </p:style>
+        <p:txBody>
+          <a:bodyPr rtlCol="0" anchor="ctr"/>
+          <a:lstStyle/>
+          <a:p>
+            <a:pPr algn="ctr"/>
+          </a:p>
+        </p:txBody>
+      </p:sp>
+      <p:sp>
+        <p:nvSpPr>
+          <p:cNvPr id="10" name="Rectangle 9"/>
+          <p:cNvSpPr/>
+          <p:nvPr/>
+        </p:nvSpPr>
+        <p:spPr>
+          <a:xfrm>
+            <a:off x="502920" y="2267712"/>
+            <a:ext cx="5579211" cy="63500"/>
+          </a:xfrm>
+          <a:prstGeom prst="rect">
+            <a:avLst/>
+          </a:prstGeom>
+          <a:solidFill>
+            <a:srgbClr val="2FDFE5"/>
+          </a:solidFill>
+          <a:ln>
+            <a:noFill/>
+          </a:ln>
+        </p:spPr>
+        <p:style>
+          <a:lnRef idx="1">
+            <a:schemeClr val="accent1"/>
+          </a:lnRef>
+          <a:fillRef idx="3">
+            <a:schemeClr val="accent1"/>
+          </a:fillRef>
+          <a:effectRef idx="2">
+            <a:schemeClr val="accent1"/>
+          </a:effectRef>
+          <a:fontRef idx="minor">
+            <a:schemeClr val="lt1"/>
+          </a:fontRef>
+        </p:style>
+        <p:txBody>
+          <a:bodyPr rtlCol="0" anchor="ctr"/>
+          <a:lstStyle/>
+          <a:p>
+            <a:pPr algn="ctr"/>
+          </a:p>
+        </p:txBody>
+      </p:sp>
+      <p:sp>
+        <p:nvSpPr>
           <p:cNvPr id="11" name="TextBox 10"/>
           <p:cNvSpPr txBox="1"/>
           <p:nvPr/>
         </p:nvSpPr>
         <p:spPr>
           <a:xfrm>
-            <a:off x="704088" y="2468880"/>
-            <a:ext cx="5176875" cy="621792"/>
+            <a:off x="704088" y="2487168"/>
+            <a:ext cx="5176875" cy="640080"/>
           </a:xfrm>
           <a:prstGeom prst="rect">
             <a:avLst/>
           </a:prstGeom>
           <a:noFill/>
         </p:spPr>
-        <p:txBody lIns="38100" tIns="50800" rIns="38100" bIns="25400">
+        <p:txBody lIns="38100" tIns="63500" rIns="38100" bIns="25400">
           <a:bodyPr wrap="square">
             <a:spAutoFit/>
           </a:bodyPr>
@@ -3868,7 +3868,7 @@
           <a:p>
             <a:pPr algn="l"/>
             <a:r>
-              <a:rPr sz="1800" b="1">
+              <a:rPr sz="1900" b="1">
                 <a:solidFill>
                   <a:srgbClr val="2FDFE5"/>
                 </a:solidFill>
@@ -3876,7 +3876,7 @@
               <a:t>1  </a:t>
             </a:r>
             <a:r>
-              <a:rPr sz="1800" b="1">
+              <a:rPr sz="1900" b="1">
                 <a:solidFill>
                   <a:srgbClr val="FFFFFF"/>
                 </a:solidFill>
@@ -3894,8 +3894,8 @@
         </p:nvSpPr>
         <p:spPr>
           <a:xfrm>
-            <a:off x="667512" y="3182112"/>
-            <a:ext cx="5250027" cy="15240"/>
+            <a:off x="667512" y="3218688"/>
+            <a:ext cx="5250027" cy="19050"/>
           </a:xfrm>
           <a:prstGeom prst="rect">
             <a:avLst/>
@@ -3937,15 +3937,15 @@
         </p:nvSpPr>
         <p:spPr>
           <a:xfrm>
-            <a:off x="667512" y="3283712"/>
-            <a:ext cx="5250027" cy="2685288"/>
+            <a:off x="667512" y="3345688"/>
+            <a:ext cx="5250027" cy="2249424"/>
           </a:xfrm>
           <a:prstGeom prst="rect">
             <a:avLst/>
           </a:prstGeom>
           <a:noFill/>
         </p:spPr>
-        <p:txBody lIns="50800" tIns="38100" rIns="50800" bIns="38100">
+        <p:txBody lIns="50800" tIns="50800" rIns="50800" bIns="50800">
           <a:bodyPr wrap="square">
             <a:spAutoFit/>
           </a:bodyPr>
@@ -3953,11 +3953,11 @@
           <a:p>
             <a:pPr algn="l">
               <a:spcBef>
-                <a:spcPts val="500"/>
+                <a:spcPts val="1800"/>
               </a:spcBef>
             </a:pPr>
             <a:r>
-              <a:rPr sz="1300">
+              <a:rPr sz="1400">
                 <a:solidFill>
                   <a:srgbClr val="2FDFE5"/>
                 </a:solidFill>
@@ -3965,7 +3965,7 @@
               <a:t>▸  </a:t>
             </a:r>
             <a:r>
-              <a:rPr sz="1400">
+              <a:rPr sz="1700">
                 <a:solidFill>
                   <a:srgbClr val="D8EAFF"/>
                 </a:solidFill>
@@ -3976,11 +3976,11 @@
           <a:p>
             <a:pPr algn="l">
               <a:spcBef>
-                <a:spcPts val="500"/>
+                <a:spcPts val="1800"/>
               </a:spcBef>
             </a:pPr>
             <a:r>
-              <a:rPr sz="1300">
+              <a:rPr sz="1400">
                 <a:solidFill>
                   <a:srgbClr val="2FDFE5"/>
                 </a:solidFill>
@@ -3988,7 +3988,7 @@
               <a:t>▸  </a:t>
             </a:r>
             <a:r>
-              <a:rPr sz="1400">
+              <a:rPr sz="1700">
                 <a:solidFill>
                   <a:srgbClr val="D8EAFF"/>
                 </a:solidFill>
@@ -3999,11 +3999,11 @@
           <a:p>
             <a:pPr algn="l">
               <a:spcBef>
-                <a:spcPts val="500"/>
+                <a:spcPts val="1800"/>
               </a:spcBef>
             </a:pPr>
             <a:r>
-              <a:rPr sz="1300">
+              <a:rPr sz="1400">
                 <a:solidFill>
                   <a:srgbClr val="2FDFE5"/>
                 </a:solidFill>
@@ -4011,7 +4011,7 @@
               <a:t>▸  </a:t>
             </a:r>
             <a:r>
-              <a:rPr sz="1400">
+              <a:rPr sz="1700">
                 <a:solidFill>
                   <a:srgbClr val="D8EAFF"/>
                 </a:solidFill>
@@ -4030,7 +4030,7 @@
         <p:spPr>
           <a:xfrm>
             <a:off x="6283299" y="2267712"/>
-            <a:ext cx="5579211" cy="3785616"/>
+            <a:ext cx="5579211" cy="3328416"/>
           </a:xfrm>
           <a:prstGeom prst="rect">
             <a:avLst/>
@@ -4038,7 +4038,7 @@
           <a:solidFill>
             <a:srgbClr val="081438"/>
           </a:solidFill>
-          <a:ln w="10160">
+          <a:ln w="12700">
             <a:solidFill>
               <a:srgbClr val="2FDFE5"/>
             </a:solidFill>
@@ -4117,15 +4117,15 @@
         </p:nvSpPr>
         <p:spPr>
           <a:xfrm>
-            <a:off x="6484467" y="2468880"/>
-            <a:ext cx="5176875" cy="621792"/>
+            <a:off x="6484467" y="2487168"/>
+            <a:ext cx="5176875" cy="640080"/>
           </a:xfrm>
           <a:prstGeom prst="rect">
             <a:avLst/>
           </a:prstGeom>
           <a:noFill/>
         </p:spPr>
-        <p:txBody lIns="38100" tIns="50800" rIns="38100" bIns="25400">
+        <p:txBody lIns="38100" tIns="63500" rIns="38100" bIns="25400">
           <a:bodyPr wrap="square">
             <a:spAutoFit/>
           </a:bodyPr>
@@ -4133,7 +4133,7 @@
           <a:p>
             <a:pPr algn="l"/>
             <a:r>
-              <a:rPr sz="1800" b="1">
+              <a:rPr sz="1900" b="1">
                 <a:solidFill>
                   <a:srgbClr val="2FDFE5"/>
                 </a:solidFill>
@@ -4141,7 +4141,7 @@
               <a:t>2  </a:t>
             </a:r>
             <a:r>
-              <a:rPr sz="1800" b="1">
+              <a:rPr sz="1900" b="1">
                 <a:solidFill>
                   <a:srgbClr val="FFFFFF"/>
                 </a:solidFill>
@@ -4159,8 +4159,8 @@
         </p:nvSpPr>
         <p:spPr>
           <a:xfrm>
-            <a:off x="6447891" y="3182112"/>
-            <a:ext cx="5250027" cy="15240"/>
+            <a:off x="6447891" y="3218688"/>
+            <a:ext cx="5250027" cy="19050"/>
           </a:xfrm>
           <a:prstGeom prst="rect">
             <a:avLst/>
@@ -4202,15 +4202,15 @@
         </p:nvSpPr>
         <p:spPr>
           <a:xfrm>
-            <a:off x="6447891" y="3283712"/>
-            <a:ext cx="5250027" cy="2685288"/>
+            <a:off x="6447891" y="3345688"/>
+            <a:ext cx="5250027" cy="2249424"/>
           </a:xfrm>
           <a:prstGeom prst="rect">
             <a:avLst/>
           </a:prstGeom>
           <a:noFill/>
         </p:spPr>
-        <p:txBody lIns="50800" tIns="38100" rIns="50800" bIns="38100">
+        <p:txBody lIns="50800" tIns="50800" rIns="50800" bIns="50800">
           <a:bodyPr wrap="square">
             <a:spAutoFit/>
           </a:bodyPr>
@@ -4218,11 +4218,11 @@
           <a:p>
             <a:pPr algn="l">
               <a:spcBef>
-                <a:spcPts val="500"/>
+                <a:spcPts val="1800"/>
               </a:spcBef>
             </a:pPr>
             <a:r>
-              <a:rPr sz="1300">
+              <a:rPr sz="1400">
                 <a:solidFill>
                   <a:srgbClr val="2FDFE5"/>
                 </a:solidFill>
@@ -4230,7 +4230,7 @@
               <a:t>▸  </a:t>
             </a:r>
             <a:r>
-              <a:rPr sz="1400">
+              <a:rPr sz="1700">
                 <a:solidFill>
                   <a:srgbClr val="D8EAFF"/>
                 </a:solidFill>
@@ -4241,11 +4241,11 @@
           <a:p>
             <a:pPr algn="l">
               <a:spcBef>
-                <a:spcPts val="500"/>
+                <a:spcPts val="1800"/>
               </a:spcBef>
             </a:pPr>
             <a:r>
-              <a:rPr sz="1300">
+              <a:rPr sz="1400">
                 <a:solidFill>
                   <a:srgbClr val="2FDFE5"/>
                 </a:solidFill>
@@ -4253,7 +4253,7 @@
               <a:t>▸  </a:t>
             </a:r>
             <a:r>
-              <a:rPr sz="1400">
+              <a:rPr sz="1700">
                 <a:solidFill>
                   <a:srgbClr val="D8EAFF"/>
                 </a:solidFill>
@@ -4264,11 +4264,11 @@
           <a:p>
             <a:pPr algn="l">
               <a:spcBef>
-                <a:spcPts val="500"/>
+                <a:spcPts val="1800"/>
               </a:spcBef>
             </a:pPr>
             <a:r>
-              <a:rPr sz="1300">
+              <a:rPr sz="1400">
                 <a:solidFill>
                   <a:srgbClr val="2FDFE5"/>
                 </a:solidFill>
@@ -4276,7 +4276,7 @@
               <a:t>▸  </a:t>
             </a:r>
             <a:r>
-              <a:rPr sz="1400">
+              <a:rPr sz="1700">
                 <a:solidFill>
                   <a:srgbClr val="D8EAFF"/>
                 </a:solidFill>
@@ -4288,7 +4288,7 @@
       </p:sp>
       <p:pic>
         <p:nvPicPr>
-          <p:cNvPr id="19" name="Picture 18" descr="logo_horiz.png"/>
+          <p:cNvPr id="25" name="Picture 24" descr="logo_horiz.png"/>
           <p:cNvPicPr>
             <a:picLocks noChangeAspect="1"/>
           </p:cNvPicPr>
@@ -4337,7 +4337,7 @@
                             <p:childTnLst>
                               <p:animEffect transition="in" filter="wipe(up)">
                                 <p:cBhvr>
-                                  <p:cTn id="6" dur="450" fill="hold"/>
+                                  <p:cTn id="6" dur="380" fill="hold"/>
                                   <p:tgtEl>
                                     <p:spTgt spid="9"/>
                                   </p:tgtEl>
@@ -4349,14 +4349,150 @@
                         <p:par>
                           <p:cTn id="7" fill="hold">
                             <p:stCondLst>
+                              <p:cond delay="0"/>
+                            </p:stCondLst>
+                            <p:childTnLst>
+                              <p:animEffect transition="in" filter="wipe(up)">
+                                <p:cBhvr>
+                                  <p:cTn id="8" dur="380" fill="hold"/>
+                                  <p:tgtEl>
+                                    <p:spTgt spid="10"/>
+                                  </p:tgtEl>
+                                </p:cBhvr>
+                              </p:animEffect>
+                            </p:childTnLst>
+                          </p:cTn>
+                        </p:par>
+                        <p:par>
+                          <p:cTn id="9" fill="hold">
+                            <p:stCondLst>
+                              <p:cond delay="0"/>
+                            </p:stCondLst>
+                            <p:childTnLst>
+                              <p:animEffect transition="in" filter="wipe(up)">
+                                <p:cBhvr>
+                                  <p:cTn id="10" dur="380" fill="hold"/>
+                                  <p:tgtEl>
+                                    <p:spTgt spid="11"/>
+                                  </p:tgtEl>
+                                </p:cBhvr>
+                              </p:animEffect>
+                            </p:childTnLst>
+                          </p:cTn>
+                        </p:par>
+                        <p:par>
+                          <p:cTn id="11" fill="hold">
+                            <p:stCondLst>
+                              <p:cond delay="0"/>
+                            </p:stCondLst>
+                            <p:childTnLst>
+                              <p:animEffect transition="in" filter="wipe(up)">
+                                <p:cBhvr>
+                                  <p:cTn id="12" dur="380" fill="hold"/>
+                                  <p:tgtEl>
+                                    <p:spTgt spid="12"/>
+                                  </p:tgtEl>
+                                </p:cBhvr>
+                              </p:animEffect>
+                            </p:childTnLst>
+                          </p:cTn>
+                        </p:par>
+                        <p:par>
+                          <p:cTn id="13" fill="hold">
+                            <p:stCondLst>
+                              <p:cond delay="0"/>
+                            </p:stCondLst>
+                            <p:childTnLst>
+                              <p:animEffect transition="in" filter="wipe(up)">
+                                <p:cBhvr>
+                                  <p:cTn id="14" dur="380" fill="hold"/>
+                                  <p:tgtEl>
+                                    <p:spTgt spid="13"/>
+                                  </p:tgtEl>
+                                </p:cBhvr>
+                              </p:animEffect>
+                            </p:childTnLst>
+                          </p:cTn>
+                        </p:par>
+                        <p:par>
+                          <p:cTn id="15" fill="hold">
+                            <p:stCondLst>
                               <p:cond delay="160"/>
                             </p:stCondLst>
                             <p:childTnLst>
                               <p:animEffect transition="in" filter="wipe(up)">
                                 <p:cBhvr>
-                                  <p:cTn id="8" dur="450" fill="hold"/>
+                                  <p:cTn id="16" dur="380" fill="hold"/>
                                   <p:tgtEl>
                                     <p:spTgt spid="14"/>
+                                  </p:tgtEl>
+                                </p:cBhvr>
+                              </p:animEffect>
+                            </p:childTnLst>
+                          </p:cTn>
+                        </p:par>
+                        <p:par>
+                          <p:cTn id="17" fill="hold">
+                            <p:stCondLst>
+                              <p:cond delay="160"/>
+                            </p:stCondLst>
+                            <p:childTnLst>
+                              <p:animEffect transition="in" filter="wipe(up)">
+                                <p:cBhvr>
+                                  <p:cTn id="18" dur="380" fill="hold"/>
+                                  <p:tgtEl>
+                                    <p:spTgt spid="15"/>
+                                  </p:tgtEl>
+                                </p:cBhvr>
+                              </p:animEffect>
+                            </p:childTnLst>
+                          </p:cTn>
+                        </p:par>
+                        <p:par>
+                          <p:cTn id="19" fill="hold">
+                            <p:stCondLst>
+                              <p:cond delay="160"/>
+                            </p:stCondLst>
+                            <p:childTnLst>
+                              <p:animEffect transition="in" filter="wipe(up)">
+                                <p:cBhvr>
+                                  <p:cTn id="20" dur="380" fill="hold"/>
+                                  <p:tgtEl>
+                                    <p:spTgt spid="16"/>
+                                  </p:tgtEl>
+                                </p:cBhvr>
+                              </p:animEffect>
+                            </p:childTnLst>
+                          </p:cTn>
+                        </p:par>
+                        <p:par>
+                          <p:cTn id="21" fill="hold">
+                            <p:stCondLst>
+                              <p:cond delay="160"/>
+                            </p:stCondLst>
+                            <p:childTnLst>
+                              <p:animEffect transition="in" filter="wipe(up)">
+                                <p:cBhvr>
+                                  <p:cTn id="22" dur="380" fill="hold"/>
+                                  <p:tgtEl>
+                                    <p:spTgt spid="17"/>
+                                  </p:tgtEl>
+                                </p:cBhvr>
+                              </p:animEffect>
+                            </p:childTnLst>
+                          </p:cTn>
+                        </p:par>
+                        <p:par>
+                          <p:cTn id="23" fill="hold">
+                            <p:stCondLst>
+                              <p:cond delay="160"/>
+                            </p:stCondLst>
+                            <p:childTnLst>
+                              <p:animEffect transition="in" filter="wipe(up)">
+                                <p:cBhvr>
+                                  <p:cTn id="24" dur="380" fill="hold"/>
+                                  <p:tgtEl>
+                                    <p:spTgt spid="18"/>
                                   </p:tgtEl>
                                 </p:cBhvr>
                               </p:animEffect>
@@ -4515,100 +4651,7 @@
         <p:spPr>
           <a:xfrm>
             <a:off x="502920" y="365760"/>
-            <a:ext cx="1463040" cy="274320"/>
-          </a:xfrm>
-          <a:prstGeom prst="rect">
-            <a:avLst/>
-          </a:prstGeom>
-          <a:noFill/>
-          <a:ln w="15240">
-            <a:solidFill>
-              <a:srgbClr val="2FDFE5"/>
-            </a:solidFill>
-          </a:ln>
-        </p:spPr>
-        <p:style>
-          <a:lnRef idx="1">
-            <a:schemeClr val="accent1"/>
-          </a:lnRef>
-          <a:fillRef idx="3">
-            <a:schemeClr val="accent1"/>
-          </a:fillRef>
-          <a:effectRef idx="2">
-            <a:schemeClr val="accent1"/>
-          </a:effectRef>
-          <a:fontRef idx="minor">
-            <a:schemeClr val="lt1"/>
-          </a:fontRef>
-        </p:style>
-        <p:txBody lIns="76200" tIns="12700" rIns="76200" bIns="12700">
-          <a:bodyPr rtlCol="0" anchor="ctr" wrap="none"/>
-          <a:lstStyle/>
-          <a:p>
-            <a:pPr algn="ctr"/>
-            <a:r>
-              <a:rPr sz="800" b="1">
-                <a:solidFill>
-                  <a:srgbClr val="2FDFE5"/>
-                </a:solidFill>
-              </a:rPr>
-              <a:t>FASE 2</a:t>
-            </a:r>
-          </a:p>
-        </p:txBody>
-      </p:sp>
-      <p:sp>
-        <p:nvSpPr>
-          <p:cNvPr id="6" name="TextBox 5"/>
-          <p:cNvSpPr txBox="1"/>
-          <p:nvPr/>
-        </p:nvSpPr>
-        <p:spPr>
-          <a:xfrm>
-            <a:off x="502920" y="731520"/>
-            <a:ext cx="8961120" cy="960120"/>
-          </a:xfrm>
-          <a:prstGeom prst="rect">
-            <a:avLst/>
-          </a:prstGeom>
-          <a:noFill/>
-        </p:spPr>
-        <p:txBody lIns="0" tIns="0" rIns="0" bIns="0">
-          <a:bodyPr wrap="square">
-            <a:spAutoFit/>
-          </a:bodyPr>
-          <a:lstStyle/>
-          <a:p>
-            <a:pPr algn="l"/>
-            <a:r>
-              <a:rPr sz="4000" b="1">
-                <a:solidFill>
-                  <a:srgbClr val="FFFFFF"/>
-                </a:solidFill>
-              </a:rPr>
-              <a:t>Activación y </a:t>
-            </a:r>
-            <a:r>
-              <a:rPr sz="4000" b="1">
-                <a:solidFill>
-                  <a:srgbClr val="2FDFE5"/>
-                </a:solidFill>
-              </a:rPr>
-              <a:t>contacto</a:t>
-            </a:r>
-          </a:p>
-        </p:txBody>
-      </p:sp>
-      <p:sp>
-        <p:nvSpPr>
-          <p:cNvPr id="7" name="Rectangle 6"/>
-          <p:cNvSpPr/>
-          <p:nvPr/>
-        </p:nvSpPr>
-        <p:spPr>
-          <a:xfrm>
-            <a:off x="502920" y="1737360"/>
-            <a:ext cx="4389120" cy="31750"/>
+            <a:ext cx="1737360" cy="301752"/>
           </a:xfrm>
           <a:prstGeom prst="rect">
             <a:avLst/>
@@ -4634,24 +4677,32 @@
             <a:schemeClr val="lt1"/>
           </a:fontRef>
         </p:style>
-        <p:txBody>
-          <a:bodyPr rtlCol="0" anchor="ctr"/>
+        <p:txBody lIns="101600" tIns="25400" rIns="101600" bIns="25400">
+          <a:bodyPr rtlCol="0" anchor="ctr" wrap="none"/>
           <a:lstStyle/>
           <a:p>
             <a:pPr algn="ctr"/>
-          </a:p>
-        </p:txBody>
-      </p:sp>
-      <p:sp>
-        <p:nvSpPr>
-          <p:cNvPr id="8" name="TextBox 7"/>
+            <a:r>
+              <a:rPr sz="1100" b="1">
+                <a:solidFill>
+                  <a:srgbClr val="0A1638"/>
+                </a:solidFill>
+              </a:rPr>
+              <a:t>FASE 2</a:t>
+            </a:r>
+          </a:p>
+        </p:txBody>
+      </p:sp>
+      <p:sp>
+        <p:nvSpPr>
+          <p:cNvPr id="6" name="TextBox 5"/>
           <p:cNvSpPr txBox="1"/>
           <p:nvPr/>
         </p:nvSpPr>
         <p:spPr>
           <a:xfrm>
-            <a:off x="502920" y="1810512"/>
-            <a:ext cx="9265615" cy="384048"/>
+            <a:off x="502920" y="731520"/>
+            <a:ext cx="8961120" cy="960120"/>
           </a:xfrm>
           <a:prstGeom prst="rect">
             <a:avLst/>
@@ -4659,78 +4710,41 @@
           <a:noFill/>
         </p:spPr>
         <p:txBody lIns="0" tIns="0" rIns="0" bIns="0">
-          <a:bodyPr wrap="none">
+          <a:bodyPr wrap="square">
             <a:spAutoFit/>
           </a:bodyPr>
           <a:lstStyle/>
           <a:p>
             <a:pPr algn="l"/>
             <a:r>
-              <a:rPr sz="1300" i="1">
-                <a:solidFill>
-                  <a:srgbClr val="80A8CC"/>
-                </a:solidFill>
-              </a:rPr>
-              <a:t>Multiplicamos los canales de contacto y buscamos siempre la vía amistosa para llegar a un acuerdo.</a:t>
-            </a:r>
-          </a:p>
-        </p:txBody>
-      </p:sp>
-      <p:sp>
-        <p:nvSpPr>
-          <p:cNvPr id="9" name="Rectangle 8"/>
+              <a:rPr sz="4000" b="1">
+                <a:solidFill>
+                  <a:srgbClr val="FFFFFF"/>
+                </a:solidFill>
+              </a:rPr>
+              <a:t>Activación y </a:t>
+            </a:r>
+            <a:r>
+              <a:rPr sz="4000" b="1">
+                <a:solidFill>
+                  <a:srgbClr val="2FDFE5"/>
+                </a:solidFill>
+              </a:rPr>
+              <a:t>contacto</a:t>
+            </a:r>
+          </a:p>
+        </p:txBody>
+      </p:sp>
+      <p:sp>
+        <p:nvSpPr>
+          <p:cNvPr id="7" name="Rectangle 6"/>
           <p:cNvSpPr/>
           <p:nvPr/>
         </p:nvSpPr>
         <p:spPr>
           <a:xfrm>
-            <a:off x="502920" y="2267712"/>
-            <a:ext cx="5579211" cy="3785616"/>
-          </a:xfrm>
-          <a:prstGeom prst="rect">
-            <a:avLst/>
-          </a:prstGeom>
-          <a:solidFill>
-            <a:srgbClr val="081438"/>
-          </a:solidFill>
-          <a:ln w="10160">
-            <a:solidFill>
-              <a:srgbClr val="2FDFE5"/>
-            </a:solidFill>
-          </a:ln>
-        </p:spPr>
-        <p:style>
-          <a:lnRef idx="1">
-            <a:schemeClr val="accent1"/>
-          </a:lnRef>
-          <a:fillRef idx="3">
-            <a:schemeClr val="accent1"/>
-          </a:fillRef>
-          <a:effectRef idx="2">
-            <a:schemeClr val="accent1"/>
-          </a:effectRef>
-          <a:fontRef idx="minor">
-            <a:schemeClr val="lt1"/>
-          </a:fontRef>
-        </p:style>
-        <p:txBody>
-          <a:bodyPr rtlCol="0" anchor="ctr"/>
-          <a:lstStyle/>
-          <a:p>
-            <a:pPr algn="ctr"/>
-          </a:p>
-        </p:txBody>
-      </p:sp>
-      <p:sp>
-        <p:nvSpPr>
-          <p:cNvPr id="10" name="Rectangle 9"/>
-          <p:cNvSpPr/>
-          <p:nvPr/>
-        </p:nvSpPr>
-        <p:spPr>
-          <a:xfrm>
-            <a:off x="502920" y="2267712"/>
-            <a:ext cx="5579211" cy="63500"/>
+            <a:off x="502920" y="1737360"/>
+            <a:ext cx="4389120" cy="31750"/>
           </a:xfrm>
           <a:prstGeom prst="rect">
             <a:avLst/>
@@ -4766,21 +4780,143 @@
       </p:sp>
       <p:sp>
         <p:nvSpPr>
+          <p:cNvPr id="8" name="TextBox 7"/>
+          <p:cNvSpPr txBox="1"/>
+          <p:nvPr/>
+        </p:nvSpPr>
+        <p:spPr>
+          <a:xfrm>
+            <a:off x="502920" y="1810512"/>
+            <a:ext cx="9265615" cy="384048"/>
+          </a:xfrm>
+          <a:prstGeom prst="rect">
+            <a:avLst/>
+          </a:prstGeom>
+          <a:noFill/>
+        </p:spPr>
+        <p:txBody lIns="0" tIns="0" rIns="0" bIns="0">
+          <a:bodyPr wrap="none">
+            <a:spAutoFit/>
+          </a:bodyPr>
+          <a:lstStyle/>
+          <a:p>
+            <a:pPr algn="l"/>
+            <a:r>
+              <a:rPr sz="1300" i="1">
+                <a:solidFill>
+                  <a:srgbClr val="80A8CC"/>
+                </a:solidFill>
+              </a:rPr>
+              <a:t>Multiplicamos los canales de contacto y buscamos siempre la vía amistosa para llegar a un acuerdo.</a:t>
+            </a:r>
+          </a:p>
+        </p:txBody>
+      </p:sp>
+      <p:sp>
+        <p:nvSpPr>
+          <p:cNvPr id="9" name="Rectangle 8"/>
+          <p:cNvSpPr/>
+          <p:nvPr/>
+        </p:nvSpPr>
+        <p:spPr>
+          <a:xfrm>
+            <a:off x="502920" y="2267712"/>
+            <a:ext cx="5579211" cy="3328416"/>
+          </a:xfrm>
+          <a:prstGeom prst="rect">
+            <a:avLst/>
+          </a:prstGeom>
+          <a:solidFill>
+            <a:srgbClr val="081438"/>
+          </a:solidFill>
+          <a:ln w="12700">
+            <a:solidFill>
+              <a:srgbClr val="2FDFE5"/>
+            </a:solidFill>
+          </a:ln>
+        </p:spPr>
+        <p:style>
+          <a:lnRef idx="1">
+            <a:schemeClr val="accent1"/>
+          </a:lnRef>
+          <a:fillRef idx="3">
+            <a:schemeClr val="accent1"/>
+          </a:fillRef>
+          <a:effectRef idx="2">
+            <a:schemeClr val="accent1"/>
+          </a:effectRef>
+          <a:fontRef idx="minor">
+            <a:schemeClr val="lt1"/>
+          </a:fontRef>
+        </p:style>
+        <p:txBody>
+          <a:bodyPr rtlCol="0" anchor="ctr"/>
+          <a:lstStyle/>
+          <a:p>
+            <a:pPr algn="ctr"/>
+          </a:p>
+        </p:txBody>
+      </p:sp>
+      <p:sp>
+        <p:nvSpPr>
+          <p:cNvPr id="10" name="Rectangle 9"/>
+          <p:cNvSpPr/>
+          <p:nvPr/>
+        </p:nvSpPr>
+        <p:spPr>
+          <a:xfrm>
+            <a:off x="502920" y="2267712"/>
+            <a:ext cx="5579211" cy="63500"/>
+          </a:xfrm>
+          <a:prstGeom prst="rect">
+            <a:avLst/>
+          </a:prstGeom>
+          <a:solidFill>
+            <a:srgbClr val="2FDFE5"/>
+          </a:solidFill>
+          <a:ln>
+            <a:noFill/>
+          </a:ln>
+        </p:spPr>
+        <p:style>
+          <a:lnRef idx="1">
+            <a:schemeClr val="accent1"/>
+          </a:lnRef>
+          <a:fillRef idx="3">
+            <a:schemeClr val="accent1"/>
+          </a:fillRef>
+          <a:effectRef idx="2">
+            <a:schemeClr val="accent1"/>
+          </a:effectRef>
+          <a:fontRef idx="minor">
+            <a:schemeClr val="lt1"/>
+          </a:fontRef>
+        </p:style>
+        <p:txBody>
+          <a:bodyPr rtlCol="0" anchor="ctr"/>
+          <a:lstStyle/>
+          <a:p>
+            <a:pPr algn="ctr"/>
+          </a:p>
+        </p:txBody>
+      </p:sp>
+      <p:sp>
+        <p:nvSpPr>
           <p:cNvPr id="11" name="TextBox 10"/>
           <p:cNvSpPr txBox="1"/>
           <p:nvPr/>
         </p:nvSpPr>
         <p:spPr>
           <a:xfrm>
-            <a:off x="704088" y="2468880"/>
-            <a:ext cx="5176875" cy="621792"/>
+            <a:off x="704088" y="2487168"/>
+            <a:ext cx="5176875" cy="640080"/>
           </a:xfrm>
           <a:prstGeom prst="rect">
             <a:avLst/>
           </a:prstGeom>
           <a:noFill/>
         </p:spPr>
-        <p:txBody lIns="38100" tIns="50800" rIns="38100" bIns="25400">
+        <p:txBody lIns="38100" tIns="63500" rIns="38100" bIns="25400">
           <a:bodyPr wrap="square">
             <a:spAutoFit/>
           </a:bodyPr>
@@ -4788,7 +4924,7 @@
           <a:p>
             <a:pPr algn="l"/>
             <a:r>
-              <a:rPr sz="1800" b="1">
+              <a:rPr sz="1900" b="1">
                 <a:solidFill>
                   <a:srgbClr val="2FDFE5"/>
                 </a:solidFill>
@@ -4796,7 +4932,7 @@
               <a:t>3  </a:t>
             </a:r>
             <a:r>
-              <a:rPr sz="1800" b="1">
+              <a:rPr sz="1900" b="1">
                 <a:solidFill>
                   <a:srgbClr val="FFFFFF"/>
                 </a:solidFill>
@@ -4814,8 +4950,8 @@
         </p:nvSpPr>
         <p:spPr>
           <a:xfrm>
-            <a:off x="667512" y="3182112"/>
-            <a:ext cx="5250027" cy="15240"/>
+            <a:off x="667512" y="3218688"/>
+            <a:ext cx="5250027" cy="19050"/>
           </a:xfrm>
           <a:prstGeom prst="rect">
             <a:avLst/>
@@ -4857,15 +4993,15 @@
         </p:nvSpPr>
         <p:spPr>
           <a:xfrm>
-            <a:off x="667512" y="3283712"/>
-            <a:ext cx="5250027" cy="2685288"/>
+            <a:off x="667512" y="3345688"/>
+            <a:ext cx="5250027" cy="2249424"/>
           </a:xfrm>
           <a:prstGeom prst="rect">
             <a:avLst/>
           </a:prstGeom>
           <a:noFill/>
         </p:spPr>
-        <p:txBody lIns="50800" tIns="38100" rIns="50800" bIns="38100">
+        <p:txBody lIns="50800" tIns="50800" rIns="50800" bIns="50800">
           <a:bodyPr wrap="square">
             <a:spAutoFit/>
           </a:bodyPr>
@@ -4873,11 +5009,11 @@
           <a:p>
             <a:pPr algn="l">
               <a:spcBef>
-                <a:spcPts val="500"/>
+                <a:spcPts val="1800"/>
               </a:spcBef>
             </a:pPr>
             <a:r>
-              <a:rPr sz="1300">
+              <a:rPr sz="1400">
                 <a:solidFill>
                   <a:srgbClr val="2FDFE5"/>
                 </a:solidFill>
@@ -4885,7 +5021,7 @@
               <a:t>▸  </a:t>
             </a:r>
             <a:r>
-              <a:rPr sz="1400">
+              <a:rPr sz="1700">
                 <a:solidFill>
                   <a:srgbClr val="D8EAFF"/>
                 </a:solidFill>
@@ -4896,11 +5032,11 @@
           <a:p>
             <a:pPr algn="l">
               <a:spcBef>
-                <a:spcPts val="500"/>
+                <a:spcPts val="1800"/>
               </a:spcBef>
             </a:pPr>
             <a:r>
-              <a:rPr sz="1300">
+              <a:rPr sz="1400">
                 <a:solidFill>
                   <a:srgbClr val="2FDFE5"/>
                 </a:solidFill>
@@ -4908,7 +5044,7 @@
               <a:t>▸  </a:t>
             </a:r>
             <a:r>
-              <a:rPr sz="1400">
+              <a:rPr sz="1700">
                 <a:solidFill>
                   <a:srgbClr val="D8EAFF"/>
                 </a:solidFill>
@@ -4919,11 +5055,11 @@
           <a:p>
             <a:pPr algn="l">
               <a:spcBef>
-                <a:spcPts val="500"/>
+                <a:spcPts val="1800"/>
               </a:spcBef>
             </a:pPr>
             <a:r>
-              <a:rPr sz="1300">
+              <a:rPr sz="1400">
                 <a:solidFill>
                   <a:srgbClr val="2FDFE5"/>
                 </a:solidFill>
@@ -4931,7 +5067,7 @@
               <a:t>▸  </a:t>
             </a:r>
             <a:r>
-              <a:rPr sz="1400">
+              <a:rPr sz="1700">
                 <a:solidFill>
                   <a:srgbClr val="D8EAFF"/>
                 </a:solidFill>
@@ -4950,7 +5086,7 @@
         <p:spPr>
           <a:xfrm>
             <a:off x="6283299" y="2267712"/>
-            <a:ext cx="5579211" cy="3785616"/>
+            <a:ext cx="5579211" cy="3328416"/>
           </a:xfrm>
           <a:prstGeom prst="rect">
             <a:avLst/>
@@ -4958,7 +5094,7 @@
           <a:solidFill>
             <a:srgbClr val="081438"/>
           </a:solidFill>
-          <a:ln w="10160">
+          <a:ln w="12700">
             <a:solidFill>
               <a:srgbClr val="2FDFE5"/>
             </a:solidFill>
@@ -5037,15 +5173,15 @@
         </p:nvSpPr>
         <p:spPr>
           <a:xfrm>
-            <a:off x="6484467" y="2468880"/>
-            <a:ext cx="5176875" cy="621792"/>
+            <a:off x="6484467" y="2487168"/>
+            <a:ext cx="5176875" cy="640080"/>
           </a:xfrm>
           <a:prstGeom prst="rect">
             <a:avLst/>
           </a:prstGeom>
           <a:noFill/>
         </p:spPr>
-        <p:txBody lIns="38100" tIns="50800" rIns="38100" bIns="25400">
+        <p:txBody lIns="38100" tIns="63500" rIns="38100" bIns="25400">
           <a:bodyPr wrap="square">
             <a:spAutoFit/>
           </a:bodyPr>
@@ -5053,7 +5189,7 @@
           <a:p>
             <a:pPr algn="l"/>
             <a:r>
-              <a:rPr sz="1800" b="1">
+              <a:rPr sz="1900" b="1">
                 <a:solidFill>
                   <a:srgbClr val="2FDFE5"/>
                 </a:solidFill>
@@ -5061,7 +5197,7 @@
               <a:t>4  </a:t>
             </a:r>
             <a:r>
-              <a:rPr sz="1800" b="1">
+              <a:rPr sz="1900" b="1">
                 <a:solidFill>
                   <a:srgbClr val="FFFFFF"/>
                 </a:solidFill>
@@ -5079,8 +5215,8 @@
         </p:nvSpPr>
         <p:spPr>
           <a:xfrm>
-            <a:off x="6447891" y="3182112"/>
-            <a:ext cx="5250027" cy="15240"/>
+            <a:off x="6447891" y="3218688"/>
+            <a:ext cx="5250027" cy="19050"/>
           </a:xfrm>
           <a:prstGeom prst="rect">
             <a:avLst/>
@@ -5122,15 +5258,15 @@
         </p:nvSpPr>
         <p:spPr>
           <a:xfrm>
-            <a:off x="6447891" y="3283712"/>
-            <a:ext cx="5250027" cy="2685288"/>
+            <a:off x="6447891" y="3345688"/>
+            <a:ext cx="5250027" cy="2249424"/>
           </a:xfrm>
           <a:prstGeom prst="rect">
             <a:avLst/>
           </a:prstGeom>
           <a:noFill/>
         </p:spPr>
-        <p:txBody lIns="50800" tIns="38100" rIns="50800" bIns="38100">
+        <p:txBody lIns="50800" tIns="50800" rIns="50800" bIns="50800">
           <a:bodyPr wrap="square">
             <a:spAutoFit/>
           </a:bodyPr>
@@ -5138,11 +5274,11 @@
           <a:p>
             <a:pPr algn="l">
               <a:spcBef>
-                <a:spcPts val="500"/>
+                <a:spcPts val="1800"/>
               </a:spcBef>
             </a:pPr>
             <a:r>
-              <a:rPr sz="1300">
+              <a:rPr sz="1400">
                 <a:solidFill>
                   <a:srgbClr val="2FDFE5"/>
                 </a:solidFill>
@@ -5150,7 +5286,7 @@
               <a:t>▸  </a:t>
             </a:r>
             <a:r>
-              <a:rPr sz="1400">
+              <a:rPr sz="1700">
                 <a:solidFill>
                   <a:srgbClr val="D8EAFF"/>
                 </a:solidFill>
@@ -5161,11 +5297,11 @@
           <a:p>
             <a:pPr algn="l">
               <a:spcBef>
-                <a:spcPts val="500"/>
+                <a:spcPts val="1800"/>
               </a:spcBef>
             </a:pPr>
             <a:r>
-              <a:rPr sz="1300">
+              <a:rPr sz="1400">
                 <a:solidFill>
                   <a:srgbClr val="2FDFE5"/>
                 </a:solidFill>
@@ -5173,7 +5309,7 @@
               <a:t>▸  </a:t>
             </a:r>
             <a:r>
-              <a:rPr sz="1400">
+              <a:rPr sz="1700">
                 <a:solidFill>
                   <a:srgbClr val="D8EAFF"/>
                 </a:solidFill>
@@ -5184,11 +5320,11 @@
           <a:p>
             <a:pPr algn="l">
               <a:spcBef>
-                <a:spcPts val="500"/>
+                <a:spcPts val="1800"/>
               </a:spcBef>
             </a:pPr>
             <a:r>
-              <a:rPr sz="1300">
+              <a:rPr sz="1400">
                 <a:solidFill>
                   <a:srgbClr val="2FDFE5"/>
                 </a:solidFill>
@@ -5196,7 +5332,7 @@
               <a:t>▸  </a:t>
             </a:r>
             <a:r>
-              <a:rPr sz="1400">
+              <a:rPr sz="1700">
                 <a:solidFill>
                   <a:srgbClr val="D8EAFF"/>
                 </a:solidFill>
@@ -5208,7 +5344,7 @@
       </p:sp>
       <p:pic>
         <p:nvPicPr>
-          <p:cNvPr id="19" name="Picture 18" descr="logo_horiz.png"/>
+          <p:cNvPr id="25" name="Picture 24" descr="logo_horiz.png"/>
           <p:cNvPicPr>
             <a:picLocks noChangeAspect="1"/>
           </p:cNvPicPr>
@@ -5257,7 +5393,7 @@
                             <p:childTnLst>
                               <p:animEffect transition="in" filter="wipe(up)">
                                 <p:cBhvr>
-                                  <p:cTn id="6" dur="450" fill="hold"/>
+                                  <p:cTn id="6" dur="380" fill="hold"/>
                                   <p:tgtEl>
                                     <p:spTgt spid="9"/>
                                   </p:tgtEl>
@@ -5269,14 +5405,150 @@
                         <p:par>
                           <p:cTn id="7" fill="hold">
                             <p:stCondLst>
+                              <p:cond delay="0"/>
+                            </p:stCondLst>
+                            <p:childTnLst>
+                              <p:animEffect transition="in" filter="wipe(up)">
+                                <p:cBhvr>
+                                  <p:cTn id="8" dur="380" fill="hold"/>
+                                  <p:tgtEl>
+                                    <p:spTgt spid="10"/>
+                                  </p:tgtEl>
+                                </p:cBhvr>
+                              </p:animEffect>
+                            </p:childTnLst>
+                          </p:cTn>
+                        </p:par>
+                        <p:par>
+                          <p:cTn id="9" fill="hold">
+                            <p:stCondLst>
+                              <p:cond delay="0"/>
+                            </p:stCondLst>
+                            <p:childTnLst>
+                              <p:animEffect transition="in" filter="wipe(up)">
+                                <p:cBhvr>
+                                  <p:cTn id="10" dur="380" fill="hold"/>
+                                  <p:tgtEl>
+                                    <p:spTgt spid="11"/>
+                                  </p:tgtEl>
+                                </p:cBhvr>
+                              </p:animEffect>
+                            </p:childTnLst>
+                          </p:cTn>
+                        </p:par>
+                        <p:par>
+                          <p:cTn id="11" fill="hold">
+                            <p:stCondLst>
+                              <p:cond delay="0"/>
+                            </p:stCondLst>
+                            <p:childTnLst>
+                              <p:animEffect transition="in" filter="wipe(up)">
+                                <p:cBhvr>
+                                  <p:cTn id="12" dur="380" fill="hold"/>
+                                  <p:tgtEl>
+                                    <p:spTgt spid="12"/>
+                                  </p:tgtEl>
+                                </p:cBhvr>
+                              </p:animEffect>
+                            </p:childTnLst>
+                          </p:cTn>
+                        </p:par>
+                        <p:par>
+                          <p:cTn id="13" fill="hold">
+                            <p:stCondLst>
+                              <p:cond delay="0"/>
+                            </p:stCondLst>
+                            <p:childTnLst>
+                              <p:animEffect transition="in" filter="wipe(up)">
+                                <p:cBhvr>
+                                  <p:cTn id="14" dur="380" fill="hold"/>
+                                  <p:tgtEl>
+                                    <p:spTgt spid="13"/>
+                                  </p:tgtEl>
+                                </p:cBhvr>
+                              </p:animEffect>
+                            </p:childTnLst>
+                          </p:cTn>
+                        </p:par>
+                        <p:par>
+                          <p:cTn id="15" fill="hold">
+                            <p:stCondLst>
                               <p:cond delay="160"/>
                             </p:stCondLst>
                             <p:childTnLst>
                               <p:animEffect transition="in" filter="wipe(up)">
                                 <p:cBhvr>
-                                  <p:cTn id="8" dur="450" fill="hold"/>
+                                  <p:cTn id="16" dur="380" fill="hold"/>
                                   <p:tgtEl>
                                     <p:spTgt spid="14"/>
+                                  </p:tgtEl>
+                                </p:cBhvr>
+                              </p:animEffect>
+                            </p:childTnLst>
+                          </p:cTn>
+                        </p:par>
+                        <p:par>
+                          <p:cTn id="17" fill="hold">
+                            <p:stCondLst>
+                              <p:cond delay="160"/>
+                            </p:stCondLst>
+                            <p:childTnLst>
+                              <p:animEffect transition="in" filter="wipe(up)">
+                                <p:cBhvr>
+                                  <p:cTn id="18" dur="380" fill="hold"/>
+                                  <p:tgtEl>
+                                    <p:spTgt spid="15"/>
+                                  </p:tgtEl>
+                                </p:cBhvr>
+                              </p:animEffect>
+                            </p:childTnLst>
+                          </p:cTn>
+                        </p:par>
+                        <p:par>
+                          <p:cTn id="19" fill="hold">
+                            <p:stCondLst>
+                              <p:cond delay="160"/>
+                            </p:stCondLst>
+                            <p:childTnLst>
+                              <p:animEffect transition="in" filter="wipe(up)">
+                                <p:cBhvr>
+                                  <p:cTn id="20" dur="380" fill="hold"/>
+                                  <p:tgtEl>
+                                    <p:spTgt spid="16"/>
+                                  </p:tgtEl>
+                                </p:cBhvr>
+                              </p:animEffect>
+                            </p:childTnLst>
+                          </p:cTn>
+                        </p:par>
+                        <p:par>
+                          <p:cTn id="21" fill="hold">
+                            <p:stCondLst>
+                              <p:cond delay="160"/>
+                            </p:stCondLst>
+                            <p:childTnLst>
+                              <p:animEffect transition="in" filter="wipe(up)">
+                                <p:cBhvr>
+                                  <p:cTn id="22" dur="380" fill="hold"/>
+                                  <p:tgtEl>
+                                    <p:spTgt spid="17"/>
+                                  </p:tgtEl>
+                                </p:cBhvr>
+                              </p:animEffect>
+                            </p:childTnLst>
+                          </p:cTn>
+                        </p:par>
+                        <p:par>
+                          <p:cTn id="23" fill="hold">
+                            <p:stCondLst>
+                              <p:cond delay="160"/>
+                            </p:stCondLst>
+                            <p:childTnLst>
+                              <p:animEffect transition="in" filter="wipe(up)">
+                                <p:cBhvr>
+                                  <p:cTn id="24" dur="380" fill="hold"/>
+                                  <p:tgtEl>
+                                    <p:spTgt spid="18"/>
                                   </p:tgtEl>
                                 </p:cBhvr>
                               </p:animEffect>
@@ -5435,100 +5707,7 @@
         <p:spPr>
           <a:xfrm>
             <a:off x="502920" y="365760"/>
-            <a:ext cx="1463040" cy="274320"/>
-          </a:xfrm>
-          <a:prstGeom prst="rect">
-            <a:avLst/>
-          </a:prstGeom>
-          <a:noFill/>
-          <a:ln w="15240">
-            <a:solidFill>
-              <a:srgbClr val="2FDFE5"/>
-            </a:solidFill>
-          </a:ln>
-        </p:spPr>
-        <p:style>
-          <a:lnRef idx="1">
-            <a:schemeClr val="accent1"/>
-          </a:lnRef>
-          <a:fillRef idx="3">
-            <a:schemeClr val="accent1"/>
-          </a:fillRef>
-          <a:effectRef idx="2">
-            <a:schemeClr val="accent1"/>
-          </a:effectRef>
-          <a:fontRef idx="minor">
-            <a:schemeClr val="lt1"/>
-          </a:fontRef>
-        </p:style>
-        <p:txBody lIns="76200" tIns="12700" rIns="76200" bIns="12700">
-          <a:bodyPr rtlCol="0" anchor="ctr" wrap="none"/>
-          <a:lstStyle/>
-          <a:p>
-            <a:pPr algn="ctr"/>
-            <a:r>
-              <a:rPr sz="800" b="1">
-                <a:solidFill>
-                  <a:srgbClr val="2FDFE5"/>
-                </a:solidFill>
-              </a:rPr>
-              <a:t>FASE 3</a:t>
-            </a:r>
-          </a:p>
-        </p:txBody>
-      </p:sp>
-      <p:sp>
-        <p:nvSpPr>
-          <p:cNvPr id="6" name="TextBox 5"/>
-          <p:cNvSpPr txBox="1"/>
-          <p:nvPr/>
-        </p:nvSpPr>
-        <p:spPr>
-          <a:xfrm>
-            <a:off x="502920" y="731520"/>
-            <a:ext cx="8961120" cy="960120"/>
-          </a:xfrm>
-          <a:prstGeom prst="rect">
-            <a:avLst/>
-          </a:prstGeom>
-          <a:noFill/>
-        </p:spPr>
-        <p:txBody lIns="0" tIns="0" rIns="0" bIns="0">
-          <a:bodyPr wrap="square">
-            <a:spAutoFit/>
-          </a:bodyPr>
-          <a:lstStyle/>
-          <a:p>
-            <a:pPr algn="l"/>
-            <a:r>
-              <a:rPr sz="4000" b="1">
-                <a:solidFill>
-                  <a:srgbClr val="FFFFFF"/>
-                </a:solidFill>
-              </a:rPr>
-              <a:t>Gestión </a:t>
-            </a:r>
-            <a:r>
-              <a:rPr sz="4000" b="1">
-                <a:solidFill>
-                  <a:srgbClr val="2FDFE5"/>
-                </a:solidFill>
-              </a:rPr>
-              <a:t>continuada</a:t>
-            </a:r>
-          </a:p>
-        </p:txBody>
-      </p:sp>
-      <p:sp>
-        <p:nvSpPr>
-          <p:cNvPr id="7" name="Rectangle 6"/>
-          <p:cNvSpPr/>
-          <p:nvPr/>
-        </p:nvSpPr>
-        <p:spPr>
-          <a:xfrm>
-            <a:off x="502920" y="1737360"/>
-            <a:ext cx="4389120" cy="31750"/>
+            <a:ext cx="1737360" cy="301752"/>
           </a:xfrm>
           <a:prstGeom prst="rect">
             <a:avLst/>
@@ -5554,24 +5733,32 @@
             <a:schemeClr val="lt1"/>
           </a:fontRef>
         </p:style>
-        <p:txBody>
-          <a:bodyPr rtlCol="0" anchor="ctr"/>
+        <p:txBody lIns="101600" tIns="25400" rIns="101600" bIns="25400">
+          <a:bodyPr rtlCol="0" anchor="ctr" wrap="none"/>
           <a:lstStyle/>
           <a:p>
             <a:pPr algn="ctr"/>
-          </a:p>
-        </p:txBody>
-      </p:sp>
-      <p:sp>
-        <p:nvSpPr>
-          <p:cNvPr id="8" name="TextBox 7"/>
+            <a:r>
+              <a:rPr sz="1100" b="1">
+                <a:solidFill>
+                  <a:srgbClr val="0A1638"/>
+                </a:solidFill>
+              </a:rPr>
+              <a:t>FASE 3</a:t>
+            </a:r>
+          </a:p>
+        </p:txBody>
+      </p:sp>
+      <p:sp>
+        <p:nvSpPr>
+          <p:cNvPr id="6" name="TextBox 5"/>
           <p:cNvSpPr txBox="1"/>
           <p:nvPr/>
         </p:nvSpPr>
         <p:spPr>
           <a:xfrm>
-            <a:off x="502920" y="1810512"/>
-            <a:ext cx="9265615" cy="384048"/>
+            <a:off x="502920" y="731520"/>
+            <a:ext cx="8961120" cy="960120"/>
           </a:xfrm>
           <a:prstGeom prst="rect">
             <a:avLst/>
@@ -5579,78 +5766,41 @@
           <a:noFill/>
         </p:spPr>
         <p:txBody lIns="0" tIns="0" rIns="0" bIns="0">
-          <a:bodyPr wrap="none">
+          <a:bodyPr wrap="square">
             <a:spAutoFit/>
           </a:bodyPr>
           <a:lstStyle/>
           <a:p>
             <a:pPr algn="l"/>
             <a:r>
-              <a:rPr sz="1300" i="1">
-                <a:solidFill>
-                  <a:srgbClr val="80A8CC"/>
-                </a:solidFill>
-              </a:rPr>
-              <a:t>El seguimiento constante y la transparencia en el reporting mantienen cada expediente bajo control.</a:t>
-            </a:r>
-          </a:p>
-        </p:txBody>
-      </p:sp>
-      <p:sp>
-        <p:nvSpPr>
-          <p:cNvPr id="9" name="Rectangle 8"/>
+              <a:rPr sz="4000" b="1">
+                <a:solidFill>
+                  <a:srgbClr val="FFFFFF"/>
+                </a:solidFill>
+              </a:rPr>
+              <a:t>Gestión </a:t>
+            </a:r>
+            <a:r>
+              <a:rPr sz="4000" b="1">
+                <a:solidFill>
+                  <a:srgbClr val="2FDFE5"/>
+                </a:solidFill>
+              </a:rPr>
+              <a:t>continuada</a:t>
+            </a:r>
+          </a:p>
+        </p:txBody>
+      </p:sp>
+      <p:sp>
+        <p:nvSpPr>
+          <p:cNvPr id="7" name="Rectangle 6"/>
           <p:cNvSpPr/>
           <p:nvPr/>
         </p:nvSpPr>
         <p:spPr>
           <a:xfrm>
-            <a:off x="502920" y="2267712"/>
-            <a:ext cx="5579211" cy="3785616"/>
-          </a:xfrm>
-          <a:prstGeom prst="rect">
-            <a:avLst/>
-          </a:prstGeom>
-          <a:solidFill>
-            <a:srgbClr val="081438"/>
-          </a:solidFill>
-          <a:ln w="10160">
-            <a:solidFill>
-              <a:srgbClr val="2FDFE5"/>
-            </a:solidFill>
-          </a:ln>
-        </p:spPr>
-        <p:style>
-          <a:lnRef idx="1">
-            <a:schemeClr val="accent1"/>
-          </a:lnRef>
-          <a:fillRef idx="3">
-            <a:schemeClr val="accent1"/>
-          </a:fillRef>
-          <a:effectRef idx="2">
-            <a:schemeClr val="accent1"/>
-          </a:effectRef>
-          <a:fontRef idx="minor">
-            <a:schemeClr val="lt1"/>
-          </a:fontRef>
-        </p:style>
-        <p:txBody>
-          <a:bodyPr rtlCol="0" anchor="ctr"/>
-          <a:lstStyle/>
-          <a:p>
-            <a:pPr algn="ctr"/>
-          </a:p>
-        </p:txBody>
-      </p:sp>
-      <p:sp>
-        <p:nvSpPr>
-          <p:cNvPr id="10" name="Rectangle 9"/>
-          <p:cNvSpPr/>
-          <p:nvPr/>
-        </p:nvSpPr>
-        <p:spPr>
-          <a:xfrm>
-            <a:off x="502920" y="2267712"/>
-            <a:ext cx="5579211" cy="63500"/>
+            <a:off x="502920" y="1737360"/>
+            <a:ext cx="4389120" cy="31750"/>
           </a:xfrm>
           <a:prstGeom prst="rect">
             <a:avLst/>
@@ -5686,21 +5836,143 @@
       </p:sp>
       <p:sp>
         <p:nvSpPr>
+          <p:cNvPr id="8" name="TextBox 7"/>
+          <p:cNvSpPr txBox="1"/>
+          <p:nvPr/>
+        </p:nvSpPr>
+        <p:spPr>
+          <a:xfrm>
+            <a:off x="502920" y="1810512"/>
+            <a:ext cx="9265615" cy="384048"/>
+          </a:xfrm>
+          <a:prstGeom prst="rect">
+            <a:avLst/>
+          </a:prstGeom>
+          <a:noFill/>
+        </p:spPr>
+        <p:txBody lIns="0" tIns="0" rIns="0" bIns="0">
+          <a:bodyPr wrap="none">
+            <a:spAutoFit/>
+          </a:bodyPr>
+          <a:lstStyle/>
+          <a:p>
+            <a:pPr algn="l"/>
+            <a:r>
+              <a:rPr sz="1300" i="1">
+                <a:solidFill>
+                  <a:srgbClr val="80A8CC"/>
+                </a:solidFill>
+              </a:rPr>
+              <a:t>El seguimiento constante y la transparencia en el reporting mantienen cada expediente bajo control.</a:t>
+            </a:r>
+          </a:p>
+        </p:txBody>
+      </p:sp>
+      <p:sp>
+        <p:nvSpPr>
+          <p:cNvPr id="9" name="Rectangle 8"/>
+          <p:cNvSpPr/>
+          <p:nvPr/>
+        </p:nvSpPr>
+        <p:spPr>
+          <a:xfrm>
+            <a:off x="502920" y="2267712"/>
+            <a:ext cx="5579211" cy="3328416"/>
+          </a:xfrm>
+          <a:prstGeom prst="rect">
+            <a:avLst/>
+          </a:prstGeom>
+          <a:solidFill>
+            <a:srgbClr val="081438"/>
+          </a:solidFill>
+          <a:ln w="12700">
+            <a:solidFill>
+              <a:srgbClr val="2FDFE5"/>
+            </a:solidFill>
+          </a:ln>
+        </p:spPr>
+        <p:style>
+          <a:lnRef idx="1">
+            <a:schemeClr val="accent1"/>
+          </a:lnRef>
+          <a:fillRef idx="3">
+            <a:schemeClr val="accent1"/>
+          </a:fillRef>
+          <a:effectRef idx="2">
+            <a:schemeClr val="accent1"/>
+          </a:effectRef>
+          <a:fontRef idx="minor">
+            <a:schemeClr val="lt1"/>
+          </a:fontRef>
+        </p:style>
+        <p:txBody>
+          <a:bodyPr rtlCol="0" anchor="ctr"/>
+          <a:lstStyle/>
+          <a:p>
+            <a:pPr algn="ctr"/>
+          </a:p>
+        </p:txBody>
+      </p:sp>
+      <p:sp>
+        <p:nvSpPr>
+          <p:cNvPr id="10" name="Rectangle 9"/>
+          <p:cNvSpPr/>
+          <p:nvPr/>
+        </p:nvSpPr>
+        <p:spPr>
+          <a:xfrm>
+            <a:off x="502920" y="2267712"/>
+            <a:ext cx="5579211" cy="63500"/>
+          </a:xfrm>
+          <a:prstGeom prst="rect">
+            <a:avLst/>
+          </a:prstGeom>
+          <a:solidFill>
+            <a:srgbClr val="2FDFE5"/>
+          </a:solidFill>
+          <a:ln>
+            <a:noFill/>
+          </a:ln>
+        </p:spPr>
+        <p:style>
+          <a:lnRef idx="1">
+            <a:schemeClr val="accent1"/>
+          </a:lnRef>
+          <a:fillRef idx="3">
+            <a:schemeClr val="accent1"/>
+          </a:fillRef>
+          <a:effectRef idx="2">
+            <a:schemeClr val="accent1"/>
+          </a:effectRef>
+          <a:fontRef idx="minor">
+            <a:schemeClr val="lt1"/>
+          </a:fontRef>
+        </p:style>
+        <p:txBody>
+          <a:bodyPr rtlCol="0" anchor="ctr"/>
+          <a:lstStyle/>
+          <a:p>
+            <a:pPr algn="ctr"/>
+          </a:p>
+        </p:txBody>
+      </p:sp>
+      <p:sp>
+        <p:nvSpPr>
           <p:cNvPr id="11" name="TextBox 10"/>
           <p:cNvSpPr txBox="1"/>
           <p:nvPr/>
         </p:nvSpPr>
         <p:spPr>
           <a:xfrm>
-            <a:off x="704088" y="2468880"/>
-            <a:ext cx="5176875" cy="621792"/>
+            <a:off x="704088" y="2487168"/>
+            <a:ext cx="5176875" cy="640080"/>
           </a:xfrm>
           <a:prstGeom prst="rect">
             <a:avLst/>
           </a:prstGeom>
           <a:noFill/>
         </p:spPr>
-        <p:txBody lIns="38100" tIns="50800" rIns="38100" bIns="25400">
+        <p:txBody lIns="38100" tIns="63500" rIns="38100" bIns="25400">
           <a:bodyPr wrap="square">
             <a:spAutoFit/>
           </a:bodyPr>
@@ -5708,7 +5980,7 @@
           <a:p>
             <a:pPr algn="l"/>
             <a:r>
-              <a:rPr sz="1800" b="1">
+              <a:rPr sz="1900" b="1">
                 <a:solidFill>
                   <a:srgbClr val="2FDFE5"/>
                 </a:solidFill>
@@ -5716,7 +5988,7 @@
               <a:t>5  </a:t>
             </a:r>
             <a:r>
-              <a:rPr sz="1800" b="1">
+              <a:rPr sz="1900" b="1">
                 <a:solidFill>
                   <a:srgbClr val="FFFFFF"/>
                 </a:solidFill>
@@ -5734,8 +6006,8 @@
         </p:nvSpPr>
         <p:spPr>
           <a:xfrm>
-            <a:off x="667512" y="3182112"/>
-            <a:ext cx="5250027" cy="15240"/>
+            <a:off x="667512" y="3218688"/>
+            <a:ext cx="5250027" cy="19050"/>
           </a:xfrm>
           <a:prstGeom prst="rect">
             <a:avLst/>
@@ -5777,15 +6049,15 @@
         </p:nvSpPr>
         <p:spPr>
           <a:xfrm>
-            <a:off x="667512" y="3283712"/>
-            <a:ext cx="5250027" cy="2685288"/>
+            <a:off x="667512" y="3345688"/>
+            <a:ext cx="5250027" cy="2249424"/>
           </a:xfrm>
           <a:prstGeom prst="rect">
             <a:avLst/>
           </a:prstGeom>
           <a:noFill/>
         </p:spPr>
-        <p:txBody lIns="50800" tIns="38100" rIns="50800" bIns="38100">
+        <p:txBody lIns="50800" tIns="50800" rIns="50800" bIns="50800">
           <a:bodyPr wrap="square">
             <a:spAutoFit/>
           </a:bodyPr>
@@ -5793,11 +6065,11 @@
           <a:p>
             <a:pPr algn="l">
               <a:spcBef>
-                <a:spcPts val="500"/>
+                <a:spcPts val="1800"/>
               </a:spcBef>
             </a:pPr>
             <a:r>
-              <a:rPr sz="1300">
+              <a:rPr sz="1400">
                 <a:solidFill>
                   <a:srgbClr val="2FDFE5"/>
                 </a:solidFill>
@@ -5805,7 +6077,7 @@
               <a:t>▸  </a:t>
             </a:r>
             <a:r>
-              <a:rPr sz="1400">
+              <a:rPr sz="1700">
                 <a:solidFill>
                   <a:srgbClr val="D8EAFF"/>
                 </a:solidFill>
@@ -5816,11 +6088,11 @@
           <a:p>
             <a:pPr algn="l">
               <a:spcBef>
-                <a:spcPts val="500"/>
+                <a:spcPts val="1800"/>
               </a:spcBef>
             </a:pPr>
             <a:r>
-              <a:rPr sz="1300">
+              <a:rPr sz="1400">
                 <a:solidFill>
                   <a:srgbClr val="2FDFE5"/>
                 </a:solidFill>
@@ -5828,7 +6100,7 @@
               <a:t>▸  </a:t>
             </a:r>
             <a:r>
-              <a:rPr sz="1400">
+              <a:rPr sz="1700">
                 <a:solidFill>
                   <a:srgbClr val="D8EAFF"/>
                 </a:solidFill>
@@ -5839,11 +6111,11 @@
           <a:p>
             <a:pPr algn="l">
               <a:spcBef>
-                <a:spcPts val="500"/>
+                <a:spcPts val="1800"/>
               </a:spcBef>
             </a:pPr>
             <a:r>
-              <a:rPr sz="1300">
+              <a:rPr sz="1400">
                 <a:solidFill>
                   <a:srgbClr val="2FDFE5"/>
                 </a:solidFill>
@@ -5851,7 +6123,7 @@
               <a:t>▸  </a:t>
             </a:r>
             <a:r>
-              <a:rPr sz="1400">
+              <a:rPr sz="1700">
                 <a:solidFill>
                   <a:srgbClr val="D8EAFF"/>
                 </a:solidFill>
@@ -5870,7 +6142,7 @@
         <p:spPr>
           <a:xfrm>
             <a:off x="6283299" y="2267712"/>
-            <a:ext cx="5579211" cy="3785616"/>
+            <a:ext cx="5579211" cy="3328416"/>
           </a:xfrm>
           <a:prstGeom prst="rect">
             <a:avLst/>
@@ -5878,7 +6150,7 @@
           <a:solidFill>
             <a:srgbClr val="081438"/>
           </a:solidFill>
-          <a:ln w="10160">
+          <a:ln w="12700">
             <a:solidFill>
               <a:srgbClr val="2FDFE5"/>
             </a:solidFill>
@@ -5957,15 +6229,15 @@
         </p:nvSpPr>
         <p:spPr>
           <a:xfrm>
-            <a:off x="6484467" y="2468880"/>
-            <a:ext cx="5176875" cy="621792"/>
+            <a:off x="6484467" y="2487168"/>
+            <a:ext cx="5176875" cy="640080"/>
           </a:xfrm>
           <a:prstGeom prst="rect">
             <a:avLst/>
           </a:prstGeom>
           <a:noFill/>
         </p:spPr>
-        <p:txBody lIns="38100" tIns="50800" rIns="38100" bIns="25400">
+        <p:txBody lIns="38100" tIns="63500" rIns="38100" bIns="25400">
           <a:bodyPr wrap="square">
             <a:spAutoFit/>
           </a:bodyPr>
@@ -5973,7 +6245,7 @@
           <a:p>
             <a:pPr algn="l"/>
             <a:r>
-              <a:rPr sz="1800" b="1">
+              <a:rPr sz="1900" b="1">
                 <a:solidFill>
                   <a:srgbClr val="2FDFE5"/>
                 </a:solidFill>
@@ -5981,7 +6253,7 @@
               <a:t>6  </a:t>
             </a:r>
             <a:r>
-              <a:rPr sz="1800" b="1">
+              <a:rPr sz="1900" b="1">
                 <a:solidFill>
                   <a:srgbClr val="FFFFFF"/>
                 </a:solidFill>
@@ -5999,8 +6271,8 @@
         </p:nvSpPr>
         <p:spPr>
           <a:xfrm>
-            <a:off x="6447891" y="3182112"/>
-            <a:ext cx="5250027" cy="15240"/>
+            <a:off x="6447891" y="3218688"/>
+            <a:ext cx="5250027" cy="19050"/>
           </a:xfrm>
           <a:prstGeom prst="rect">
             <a:avLst/>
@@ -6042,15 +6314,15 @@
         </p:nvSpPr>
         <p:spPr>
           <a:xfrm>
-            <a:off x="6447891" y="3283712"/>
-            <a:ext cx="5250027" cy="2685288"/>
+            <a:off x="6447891" y="3345688"/>
+            <a:ext cx="5250027" cy="2249424"/>
           </a:xfrm>
           <a:prstGeom prst="rect">
             <a:avLst/>
           </a:prstGeom>
           <a:noFill/>
         </p:spPr>
-        <p:txBody lIns="50800" tIns="38100" rIns="50800" bIns="38100">
+        <p:txBody lIns="50800" tIns="50800" rIns="50800" bIns="50800">
           <a:bodyPr wrap="square">
             <a:spAutoFit/>
           </a:bodyPr>
@@ -6058,11 +6330,11 @@
           <a:p>
             <a:pPr algn="l">
               <a:spcBef>
-                <a:spcPts val="500"/>
+                <a:spcPts val="1800"/>
               </a:spcBef>
             </a:pPr>
             <a:r>
-              <a:rPr sz="1300">
+              <a:rPr sz="1400">
                 <a:solidFill>
                   <a:srgbClr val="2FDFE5"/>
                 </a:solidFill>
@@ -6070,7 +6342,7 @@
               <a:t>▸  </a:t>
             </a:r>
             <a:r>
-              <a:rPr sz="1400">
+              <a:rPr sz="1700">
                 <a:solidFill>
                   <a:srgbClr val="D8EAFF"/>
                 </a:solidFill>
@@ -6081,11 +6353,11 @@
           <a:p>
             <a:pPr algn="l">
               <a:spcBef>
-                <a:spcPts val="500"/>
+                <a:spcPts val="1800"/>
               </a:spcBef>
             </a:pPr>
             <a:r>
-              <a:rPr sz="1300">
+              <a:rPr sz="1400">
                 <a:solidFill>
                   <a:srgbClr val="2FDFE5"/>
                 </a:solidFill>
@@ -6093,7 +6365,7 @@
               <a:t>▸  </a:t>
             </a:r>
             <a:r>
-              <a:rPr sz="1400">
+              <a:rPr sz="1700">
                 <a:solidFill>
                   <a:srgbClr val="D8EAFF"/>
                 </a:solidFill>
@@ -6104,11 +6376,11 @@
           <a:p>
             <a:pPr algn="l">
               <a:spcBef>
-                <a:spcPts val="500"/>
+                <a:spcPts val="1800"/>
               </a:spcBef>
             </a:pPr>
             <a:r>
-              <a:rPr sz="1300">
+              <a:rPr sz="1400">
                 <a:solidFill>
                   <a:srgbClr val="2FDFE5"/>
                 </a:solidFill>
@@ -6116,7 +6388,7 @@
               <a:t>▸  </a:t>
             </a:r>
             <a:r>
-              <a:rPr sz="1400">
+              <a:rPr sz="1700">
                 <a:solidFill>
                   <a:srgbClr val="D8EAFF"/>
                 </a:solidFill>
@@ -6128,7 +6400,7 @@
       </p:sp>
       <p:pic>
         <p:nvPicPr>
-          <p:cNvPr id="19" name="Picture 18" descr="logo_horiz.png"/>
+          <p:cNvPr id="25" name="Picture 24" descr="logo_horiz.png"/>
           <p:cNvPicPr>
             <a:picLocks noChangeAspect="1"/>
           </p:cNvPicPr>
@@ -6177,7 +6449,7 @@
                             <p:childTnLst>
                               <p:animEffect transition="in" filter="wipe(up)">
                                 <p:cBhvr>
-                                  <p:cTn id="6" dur="450" fill="hold"/>
+                                  <p:cTn id="6" dur="380" fill="hold"/>
                                   <p:tgtEl>
                                     <p:spTgt spid="9"/>
                                   </p:tgtEl>
@@ -6189,14 +6461,150 @@
                         <p:par>
                           <p:cTn id="7" fill="hold">
                             <p:stCondLst>
+                              <p:cond delay="0"/>
+                            </p:stCondLst>
+                            <p:childTnLst>
+                              <p:animEffect transition="in" filter="wipe(up)">
+                                <p:cBhvr>
+                                  <p:cTn id="8" dur="380" fill="hold"/>
+                                  <p:tgtEl>
+                                    <p:spTgt spid="10"/>
+                                  </p:tgtEl>
+                                </p:cBhvr>
+                              </p:animEffect>
+                            </p:childTnLst>
+                          </p:cTn>
+                        </p:par>
+                        <p:par>
+                          <p:cTn id="9" fill="hold">
+                            <p:stCondLst>
+                              <p:cond delay="0"/>
+                            </p:stCondLst>
+                            <p:childTnLst>
+                              <p:animEffect transition="in" filter="wipe(up)">
+                                <p:cBhvr>
+                                  <p:cTn id="10" dur="380" fill="hold"/>
+                                  <p:tgtEl>
+                                    <p:spTgt spid="11"/>
+                                  </p:tgtEl>
+                                </p:cBhvr>
+                              </p:animEffect>
+                            </p:childTnLst>
+                          </p:cTn>
+                        </p:par>
+                        <p:par>
+                          <p:cTn id="11" fill="hold">
+                            <p:stCondLst>
+                              <p:cond delay="0"/>
+                            </p:stCondLst>
+                            <p:childTnLst>
+                              <p:animEffect transition="in" filter="wipe(up)">
+                                <p:cBhvr>
+                                  <p:cTn id="12" dur="380" fill="hold"/>
+                                  <p:tgtEl>
+                                    <p:spTgt spid="12"/>
+                                  </p:tgtEl>
+                                </p:cBhvr>
+                              </p:animEffect>
+                            </p:childTnLst>
+                          </p:cTn>
+                        </p:par>
+                        <p:par>
+                          <p:cTn id="13" fill="hold">
+                            <p:stCondLst>
+                              <p:cond delay="0"/>
+                            </p:stCondLst>
+                            <p:childTnLst>
+                              <p:animEffect transition="in" filter="wipe(up)">
+                                <p:cBhvr>
+                                  <p:cTn id="14" dur="380" fill="hold"/>
+                                  <p:tgtEl>
+                                    <p:spTgt spid="13"/>
+                                  </p:tgtEl>
+                                </p:cBhvr>
+                              </p:animEffect>
+                            </p:childTnLst>
+                          </p:cTn>
+                        </p:par>
+                        <p:par>
+                          <p:cTn id="15" fill="hold">
+                            <p:stCondLst>
                               <p:cond delay="160"/>
                             </p:stCondLst>
                             <p:childTnLst>
                               <p:animEffect transition="in" filter="wipe(up)">
                                 <p:cBhvr>
-                                  <p:cTn id="8" dur="450" fill="hold"/>
+                                  <p:cTn id="16" dur="380" fill="hold"/>
                                   <p:tgtEl>
                                     <p:spTgt spid="14"/>
+                                  </p:tgtEl>
+                                </p:cBhvr>
+                              </p:animEffect>
+                            </p:childTnLst>
+                          </p:cTn>
+                        </p:par>
+                        <p:par>
+                          <p:cTn id="17" fill="hold">
+                            <p:stCondLst>
+                              <p:cond delay="160"/>
+                            </p:stCondLst>
+                            <p:childTnLst>
+                              <p:animEffect transition="in" filter="wipe(up)">
+                                <p:cBhvr>
+                                  <p:cTn id="18" dur="380" fill="hold"/>
+                                  <p:tgtEl>
+                                    <p:spTgt spid="15"/>
+                                  </p:tgtEl>
+                                </p:cBhvr>
+                              </p:animEffect>
+                            </p:childTnLst>
+                          </p:cTn>
+                        </p:par>
+                        <p:par>
+                          <p:cTn id="19" fill="hold">
+                            <p:stCondLst>
+                              <p:cond delay="160"/>
+                            </p:stCondLst>
+                            <p:childTnLst>
+                              <p:animEffect transition="in" filter="wipe(up)">
+                                <p:cBhvr>
+                                  <p:cTn id="20" dur="380" fill="hold"/>
+                                  <p:tgtEl>
+                                    <p:spTgt spid="16"/>
+                                  </p:tgtEl>
+                                </p:cBhvr>
+                              </p:animEffect>
+                            </p:childTnLst>
+                          </p:cTn>
+                        </p:par>
+                        <p:par>
+                          <p:cTn id="21" fill="hold">
+                            <p:stCondLst>
+                              <p:cond delay="160"/>
+                            </p:stCondLst>
+                            <p:childTnLst>
+                              <p:animEffect transition="in" filter="wipe(up)">
+                                <p:cBhvr>
+                                  <p:cTn id="22" dur="380" fill="hold"/>
+                                  <p:tgtEl>
+                                    <p:spTgt spid="17"/>
+                                  </p:tgtEl>
+                                </p:cBhvr>
+                              </p:animEffect>
+                            </p:childTnLst>
+                          </p:cTn>
+                        </p:par>
+                        <p:par>
+                          <p:cTn id="23" fill="hold">
+                            <p:stCondLst>
+                              <p:cond delay="160"/>
+                            </p:stCondLst>
+                            <p:childTnLst>
+                              <p:animEffect transition="in" filter="wipe(up)">
+                                <p:cBhvr>
+                                  <p:cTn id="24" dur="380" fill="hold"/>
+                                  <p:tgtEl>
+                                    <p:spTgt spid="18"/>
                                   </p:tgtEl>
                                 </p:cBhvr>
                               </p:animEffect>
@@ -6355,100 +6763,7 @@
         <p:spPr>
           <a:xfrm>
             <a:off x="502920" y="365760"/>
-            <a:ext cx="1463040" cy="274320"/>
-          </a:xfrm>
-          <a:prstGeom prst="rect">
-            <a:avLst/>
-          </a:prstGeom>
-          <a:noFill/>
-          <a:ln w="15240">
-            <a:solidFill>
-              <a:srgbClr val="2FDFE5"/>
-            </a:solidFill>
-          </a:ln>
-        </p:spPr>
-        <p:style>
-          <a:lnRef idx="1">
-            <a:schemeClr val="accent1"/>
-          </a:lnRef>
-          <a:fillRef idx="3">
-            <a:schemeClr val="accent1"/>
-          </a:fillRef>
-          <a:effectRef idx="2">
-            <a:schemeClr val="accent1"/>
-          </a:effectRef>
-          <a:fontRef idx="minor">
-            <a:schemeClr val="lt1"/>
-          </a:fontRef>
-        </p:style>
-        <p:txBody lIns="76200" tIns="12700" rIns="76200" bIns="12700">
-          <a:bodyPr rtlCol="0" anchor="ctr" wrap="none"/>
-          <a:lstStyle/>
-          <a:p>
-            <a:pPr algn="ctr"/>
-            <a:r>
-              <a:rPr sz="800" b="1">
-                <a:solidFill>
-                  <a:srgbClr val="2FDFE5"/>
-                </a:solidFill>
-              </a:rPr>
-              <a:t>FASE 4</a:t>
-            </a:r>
-          </a:p>
-        </p:txBody>
-      </p:sp>
-      <p:sp>
-        <p:nvSpPr>
-          <p:cNvPr id="6" name="TextBox 5"/>
-          <p:cNvSpPr txBox="1"/>
-          <p:nvPr/>
-        </p:nvSpPr>
-        <p:spPr>
-          <a:xfrm>
-            <a:off x="502920" y="731520"/>
-            <a:ext cx="8961120" cy="960120"/>
-          </a:xfrm>
-          <a:prstGeom prst="rect">
-            <a:avLst/>
-          </a:prstGeom>
-          <a:noFill/>
-        </p:spPr>
-        <p:txBody lIns="0" tIns="0" rIns="0" bIns="0">
-          <a:bodyPr wrap="square">
-            <a:spAutoFit/>
-          </a:bodyPr>
-          <a:lstStyle/>
-          <a:p>
-            <a:pPr algn="l"/>
-            <a:r>
-              <a:rPr sz="4000" b="1">
-                <a:solidFill>
-                  <a:srgbClr val="FFFFFF"/>
-                </a:solidFill>
-              </a:rPr>
-              <a:t>Cierre y </a:t>
-            </a:r>
-            <a:r>
-              <a:rPr sz="4000" b="1">
-                <a:solidFill>
-                  <a:srgbClr val="2FDFE5"/>
-                </a:solidFill>
-              </a:rPr>
-              <a:t>condiciones</a:t>
-            </a:r>
-          </a:p>
-        </p:txBody>
-      </p:sp>
-      <p:sp>
-        <p:nvSpPr>
-          <p:cNvPr id="7" name="Rectangle 6"/>
-          <p:cNvSpPr/>
-          <p:nvPr/>
-        </p:nvSpPr>
-        <p:spPr>
-          <a:xfrm>
-            <a:off x="502920" y="1737360"/>
-            <a:ext cx="4389120" cy="31750"/>
+            <a:ext cx="1737360" cy="301752"/>
           </a:xfrm>
           <a:prstGeom prst="rect">
             <a:avLst/>
@@ -6474,24 +6789,32 @@
             <a:schemeClr val="lt1"/>
           </a:fontRef>
         </p:style>
-        <p:txBody>
-          <a:bodyPr rtlCol="0" anchor="ctr"/>
+        <p:txBody lIns="101600" tIns="25400" rIns="101600" bIns="25400">
+          <a:bodyPr rtlCol="0" anchor="ctr" wrap="none"/>
           <a:lstStyle/>
           <a:p>
             <a:pPr algn="ctr"/>
-          </a:p>
-        </p:txBody>
-      </p:sp>
-      <p:sp>
-        <p:nvSpPr>
-          <p:cNvPr id="8" name="TextBox 7"/>
+            <a:r>
+              <a:rPr sz="1100" b="1">
+                <a:solidFill>
+                  <a:srgbClr val="0A1638"/>
+                </a:solidFill>
+              </a:rPr>
+              <a:t>FASE 4</a:t>
+            </a:r>
+          </a:p>
+        </p:txBody>
+      </p:sp>
+      <p:sp>
+        <p:nvSpPr>
+          <p:cNvPr id="6" name="TextBox 5"/>
           <p:cNvSpPr txBox="1"/>
           <p:nvPr/>
         </p:nvSpPr>
         <p:spPr>
           <a:xfrm>
-            <a:off x="502920" y="1810512"/>
-            <a:ext cx="9265615" cy="384048"/>
+            <a:off x="502920" y="731520"/>
+            <a:ext cx="8961120" cy="960120"/>
           </a:xfrm>
           <a:prstGeom prst="rect">
             <a:avLst/>
@@ -6499,78 +6822,41 @@
           <a:noFill/>
         </p:spPr>
         <p:txBody lIns="0" tIns="0" rIns="0" bIns="0">
-          <a:bodyPr wrap="none">
+          <a:bodyPr wrap="square">
             <a:spAutoFit/>
           </a:bodyPr>
           <a:lstStyle/>
           <a:p>
             <a:pPr algn="l"/>
             <a:r>
-              <a:rPr sz="1300" i="1">
-                <a:solidFill>
-                  <a:srgbClr val="80A8CC"/>
-                </a:solidFill>
-              </a:rPr>
-              <a:t>Solo facturamos cuando recuperamos: nuestros incentivos están alineados con los de nuestro cliente.</a:t>
-            </a:r>
-          </a:p>
-        </p:txBody>
-      </p:sp>
-      <p:sp>
-        <p:nvSpPr>
-          <p:cNvPr id="9" name="Rectangle 8"/>
+              <a:rPr sz="4000" b="1">
+                <a:solidFill>
+                  <a:srgbClr val="FFFFFF"/>
+                </a:solidFill>
+              </a:rPr>
+              <a:t>Cierre y </a:t>
+            </a:r>
+            <a:r>
+              <a:rPr sz="4000" b="1">
+                <a:solidFill>
+                  <a:srgbClr val="2FDFE5"/>
+                </a:solidFill>
+              </a:rPr>
+              <a:t>condiciones</a:t>
+            </a:r>
+          </a:p>
+        </p:txBody>
+      </p:sp>
+      <p:sp>
+        <p:nvSpPr>
+          <p:cNvPr id="7" name="Rectangle 6"/>
           <p:cNvSpPr/>
           <p:nvPr/>
         </p:nvSpPr>
         <p:spPr>
           <a:xfrm>
-            <a:off x="502920" y="2267712"/>
-            <a:ext cx="5579211" cy="3785616"/>
-          </a:xfrm>
-          <a:prstGeom prst="rect">
-            <a:avLst/>
-          </a:prstGeom>
-          <a:solidFill>
-            <a:srgbClr val="081438"/>
-          </a:solidFill>
-          <a:ln w="10160">
-            <a:solidFill>
-              <a:srgbClr val="2FDFE5"/>
-            </a:solidFill>
-          </a:ln>
-        </p:spPr>
-        <p:style>
-          <a:lnRef idx="1">
-            <a:schemeClr val="accent1"/>
-          </a:lnRef>
-          <a:fillRef idx="3">
-            <a:schemeClr val="accent1"/>
-          </a:fillRef>
-          <a:effectRef idx="2">
-            <a:schemeClr val="accent1"/>
-          </a:effectRef>
-          <a:fontRef idx="minor">
-            <a:schemeClr val="lt1"/>
-          </a:fontRef>
-        </p:style>
-        <p:txBody>
-          <a:bodyPr rtlCol="0" anchor="ctr"/>
-          <a:lstStyle/>
-          <a:p>
-            <a:pPr algn="ctr"/>
-          </a:p>
-        </p:txBody>
-      </p:sp>
-      <p:sp>
-        <p:nvSpPr>
-          <p:cNvPr id="10" name="Rectangle 9"/>
-          <p:cNvSpPr/>
-          <p:nvPr/>
-        </p:nvSpPr>
-        <p:spPr>
-          <a:xfrm>
-            <a:off x="502920" y="2267712"/>
-            <a:ext cx="5579211" cy="63500"/>
+            <a:off x="502920" y="1737360"/>
+            <a:ext cx="4389120" cy="31750"/>
           </a:xfrm>
           <a:prstGeom prst="rect">
             <a:avLst/>
@@ -6606,21 +6892,143 @@
       </p:sp>
       <p:sp>
         <p:nvSpPr>
+          <p:cNvPr id="8" name="TextBox 7"/>
+          <p:cNvSpPr txBox="1"/>
+          <p:nvPr/>
+        </p:nvSpPr>
+        <p:spPr>
+          <a:xfrm>
+            <a:off x="502920" y="1810512"/>
+            <a:ext cx="9265615" cy="384048"/>
+          </a:xfrm>
+          <a:prstGeom prst="rect">
+            <a:avLst/>
+          </a:prstGeom>
+          <a:noFill/>
+        </p:spPr>
+        <p:txBody lIns="0" tIns="0" rIns="0" bIns="0">
+          <a:bodyPr wrap="none">
+            <a:spAutoFit/>
+          </a:bodyPr>
+          <a:lstStyle/>
+          <a:p>
+            <a:pPr algn="l"/>
+            <a:r>
+              <a:rPr sz="1300" i="1">
+                <a:solidFill>
+                  <a:srgbClr val="80A8CC"/>
+                </a:solidFill>
+              </a:rPr>
+              <a:t>Solo facturamos cuando recuperamos: nuestros incentivos están alineados con los de nuestro cliente.</a:t>
+            </a:r>
+          </a:p>
+        </p:txBody>
+      </p:sp>
+      <p:sp>
+        <p:nvSpPr>
+          <p:cNvPr id="9" name="Rectangle 8"/>
+          <p:cNvSpPr/>
+          <p:nvPr/>
+        </p:nvSpPr>
+        <p:spPr>
+          <a:xfrm>
+            <a:off x="502920" y="2267712"/>
+            <a:ext cx="5579211" cy="3328416"/>
+          </a:xfrm>
+          <a:prstGeom prst="rect">
+            <a:avLst/>
+          </a:prstGeom>
+          <a:solidFill>
+            <a:srgbClr val="081438"/>
+          </a:solidFill>
+          <a:ln w="12700">
+            <a:solidFill>
+              <a:srgbClr val="2FDFE5"/>
+            </a:solidFill>
+          </a:ln>
+        </p:spPr>
+        <p:style>
+          <a:lnRef idx="1">
+            <a:schemeClr val="accent1"/>
+          </a:lnRef>
+          <a:fillRef idx="3">
+            <a:schemeClr val="accent1"/>
+          </a:fillRef>
+          <a:effectRef idx="2">
+            <a:schemeClr val="accent1"/>
+          </a:effectRef>
+          <a:fontRef idx="minor">
+            <a:schemeClr val="lt1"/>
+          </a:fontRef>
+        </p:style>
+        <p:txBody>
+          <a:bodyPr rtlCol="0" anchor="ctr"/>
+          <a:lstStyle/>
+          <a:p>
+            <a:pPr algn="ctr"/>
+          </a:p>
+        </p:txBody>
+      </p:sp>
+      <p:sp>
+        <p:nvSpPr>
+          <p:cNvPr id="10" name="Rectangle 9"/>
+          <p:cNvSpPr/>
+          <p:nvPr/>
+        </p:nvSpPr>
+        <p:spPr>
+          <a:xfrm>
+            <a:off x="502920" y="2267712"/>
+            <a:ext cx="5579211" cy="63500"/>
+          </a:xfrm>
+          <a:prstGeom prst="rect">
+            <a:avLst/>
+          </a:prstGeom>
+          <a:solidFill>
+            <a:srgbClr val="2FDFE5"/>
+          </a:solidFill>
+          <a:ln>
+            <a:noFill/>
+          </a:ln>
+        </p:spPr>
+        <p:style>
+          <a:lnRef idx="1">
+            <a:schemeClr val="accent1"/>
+          </a:lnRef>
+          <a:fillRef idx="3">
+            <a:schemeClr val="accent1"/>
+          </a:fillRef>
+          <a:effectRef idx="2">
+            <a:schemeClr val="accent1"/>
+          </a:effectRef>
+          <a:fontRef idx="minor">
+            <a:schemeClr val="lt1"/>
+          </a:fontRef>
+        </p:style>
+        <p:txBody>
+          <a:bodyPr rtlCol="0" anchor="ctr"/>
+          <a:lstStyle/>
+          <a:p>
+            <a:pPr algn="ctr"/>
+          </a:p>
+        </p:txBody>
+      </p:sp>
+      <p:sp>
+        <p:nvSpPr>
           <p:cNvPr id="11" name="TextBox 10"/>
           <p:cNvSpPr txBox="1"/>
           <p:nvPr/>
         </p:nvSpPr>
         <p:spPr>
           <a:xfrm>
-            <a:off x="704088" y="2468880"/>
-            <a:ext cx="5176875" cy="621792"/>
+            <a:off x="704088" y="2487168"/>
+            <a:ext cx="5176875" cy="640080"/>
           </a:xfrm>
           <a:prstGeom prst="rect">
             <a:avLst/>
           </a:prstGeom>
           <a:noFill/>
         </p:spPr>
-        <p:txBody lIns="38100" tIns="50800" rIns="38100" bIns="25400">
+        <p:txBody lIns="38100" tIns="63500" rIns="38100" bIns="25400">
           <a:bodyPr wrap="square">
             <a:spAutoFit/>
           </a:bodyPr>
@@ -6628,7 +7036,7 @@
           <a:p>
             <a:pPr algn="l"/>
             <a:r>
-              <a:rPr sz="1800" b="1">
+              <a:rPr sz="1900" b="1">
                 <a:solidFill>
                   <a:srgbClr val="2FDFE5"/>
                 </a:solidFill>
@@ -6636,7 +7044,7 @@
               <a:t>7  </a:t>
             </a:r>
             <a:r>
-              <a:rPr sz="1800" b="1">
+              <a:rPr sz="1900" b="1">
                 <a:solidFill>
                   <a:srgbClr val="FFFFFF"/>
                 </a:solidFill>
@@ -6654,8 +7062,8 @@
         </p:nvSpPr>
         <p:spPr>
           <a:xfrm>
-            <a:off x="667512" y="3182112"/>
-            <a:ext cx="5250027" cy="15240"/>
+            <a:off x="667512" y="3218688"/>
+            <a:ext cx="5250027" cy="19050"/>
           </a:xfrm>
           <a:prstGeom prst="rect">
             <a:avLst/>
@@ -6697,15 +7105,15 @@
         </p:nvSpPr>
         <p:spPr>
           <a:xfrm>
-            <a:off x="667512" y="3283712"/>
-            <a:ext cx="5250027" cy="2685288"/>
+            <a:off x="667512" y="3345688"/>
+            <a:ext cx="5250027" cy="2249424"/>
           </a:xfrm>
           <a:prstGeom prst="rect">
             <a:avLst/>
           </a:prstGeom>
           <a:noFill/>
         </p:spPr>
-        <p:txBody lIns="50800" tIns="38100" rIns="50800" bIns="38100">
+        <p:txBody lIns="50800" tIns="50800" rIns="50800" bIns="50800">
           <a:bodyPr wrap="square">
             <a:spAutoFit/>
           </a:bodyPr>
@@ -6713,11 +7121,11 @@
           <a:p>
             <a:pPr algn="l">
               <a:spcBef>
-                <a:spcPts val="500"/>
+                <a:spcPts val="1800"/>
               </a:spcBef>
             </a:pPr>
             <a:r>
-              <a:rPr sz="1300">
+              <a:rPr sz="1400">
                 <a:solidFill>
                   <a:srgbClr val="2FDFE5"/>
                 </a:solidFill>
@@ -6725,7 +7133,7 @@
               <a:t>▸  </a:t>
             </a:r>
             <a:r>
-              <a:rPr sz="1400">
+              <a:rPr sz="1700">
                 <a:solidFill>
                   <a:srgbClr val="D8EAFF"/>
                 </a:solidFill>
@@ -6736,11 +7144,11 @@
           <a:p>
             <a:pPr algn="l">
               <a:spcBef>
-                <a:spcPts val="500"/>
+                <a:spcPts val="1800"/>
               </a:spcBef>
             </a:pPr>
             <a:r>
-              <a:rPr sz="1300">
+              <a:rPr sz="1400">
                 <a:solidFill>
                   <a:srgbClr val="2FDFE5"/>
                 </a:solidFill>
@@ -6748,7 +7156,7 @@
               <a:t>▸  </a:t>
             </a:r>
             <a:r>
-              <a:rPr sz="1400">
+              <a:rPr sz="1700">
                 <a:solidFill>
                   <a:srgbClr val="D8EAFF"/>
                 </a:solidFill>
@@ -6759,11 +7167,11 @@
           <a:p>
             <a:pPr algn="l">
               <a:spcBef>
-                <a:spcPts val="500"/>
+                <a:spcPts val="1800"/>
               </a:spcBef>
             </a:pPr>
             <a:r>
-              <a:rPr sz="1300">
+              <a:rPr sz="1400">
                 <a:solidFill>
                   <a:srgbClr val="2FDFE5"/>
                 </a:solidFill>
@@ -6771,7 +7179,7 @@
               <a:t>▸  </a:t>
             </a:r>
             <a:r>
-              <a:rPr sz="1400">
+              <a:rPr sz="1700">
                 <a:solidFill>
                   <a:srgbClr val="D8EAFF"/>
                 </a:solidFill>
@@ -6790,7 +7198,7 @@
         <p:spPr>
           <a:xfrm>
             <a:off x="6283299" y="2267712"/>
-            <a:ext cx="5579211" cy="3785616"/>
+            <a:ext cx="5579211" cy="3328416"/>
           </a:xfrm>
           <a:prstGeom prst="rect">
             <a:avLst/>
@@ -6798,7 +7206,7 @@
           <a:solidFill>
             <a:srgbClr val="081438"/>
           </a:solidFill>
-          <a:ln w="10160">
+          <a:ln w="12700">
             <a:solidFill>
               <a:srgbClr val="2FDFE5"/>
             </a:solidFill>
@@ -6877,15 +7285,15 @@
         </p:nvSpPr>
         <p:spPr>
           <a:xfrm>
-            <a:off x="6484467" y="2468880"/>
-            <a:ext cx="5176875" cy="621792"/>
+            <a:off x="6484467" y="2487168"/>
+            <a:ext cx="5176875" cy="640080"/>
           </a:xfrm>
           <a:prstGeom prst="rect">
             <a:avLst/>
           </a:prstGeom>
           <a:noFill/>
         </p:spPr>
-        <p:txBody lIns="38100" tIns="50800" rIns="38100" bIns="25400">
+        <p:txBody lIns="38100" tIns="63500" rIns="38100" bIns="25400">
           <a:bodyPr wrap="square">
             <a:spAutoFit/>
           </a:bodyPr>
@@ -6893,7 +7301,7 @@
           <a:p>
             <a:pPr algn="l"/>
             <a:r>
-              <a:rPr sz="1800" b="1">
+              <a:rPr sz="1900" b="1">
                 <a:solidFill>
                   <a:srgbClr val="2FDFE5"/>
                 </a:solidFill>
@@ -6901,7 +7309,7 @@
               <a:t>8  </a:t>
             </a:r>
             <a:r>
-              <a:rPr sz="1800" b="1">
+              <a:rPr sz="1900" b="1">
                 <a:solidFill>
                   <a:srgbClr val="FFFFFF"/>
                 </a:solidFill>
@@ -6919,8 +7327,8 @@
         </p:nvSpPr>
         <p:spPr>
           <a:xfrm>
-            <a:off x="6447891" y="3182112"/>
-            <a:ext cx="5250027" cy="15240"/>
+            <a:off x="6447891" y="3218688"/>
+            <a:ext cx="5250027" cy="19050"/>
           </a:xfrm>
           <a:prstGeom prst="rect">
             <a:avLst/>
@@ -6962,15 +7370,15 @@
         </p:nvSpPr>
         <p:spPr>
           <a:xfrm>
-            <a:off x="6447891" y="3283712"/>
-            <a:ext cx="5250027" cy="2685288"/>
+            <a:off x="6447891" y="3345688"/>
+            <a:ext cx="5250027" cy="2249424"/>
           </a:xfrm>
           <a:prstGeom prst="rect">
             <a:avLst/>
           </a:prstGeom>
           <a:noFill/>
         </p:spPr>
-        <p:txBody lIns="50800" tIns="38100" rIns="50800" bIns="38100">
+        <p:txBody lIns="50800" tIns="50800" rIns="50800" bIns="50800">
           <a:bodyPr wrap="square">
             <a:spAutoFit/>
           </a:bodyPr>
@@ -6978,11 +7386,11 @@
           <a:p>
             <a:pPr algn="l">
               <a:spcBef>
-                <a:spcPts val="500"/>
+                <a:spcPts val="1800"/>
               </a:spcBef>
             </a:pPr>
             <a:r>
-              <a:rPr sz="1300">
+              <a:rPr sz="1400">
                 <a:solidFill>
                   <a:srgbClr val="2FDFE5"/>
                 </a:solidFill>
@@ -6990,7 +7398,7 @@
               <a:t>▸  </a:t>
             </a:r>
             <a:r>
-              <a:rPr sz="1400">
+              <a:rPr sz="1700">
                 <a:solidFill>
                   <a:srgbClr val="D8EAFF"/>
                 </a:solidFill>
@@ -7001,11 +7409,11 @@
           <a:p>
             <a:pPr algn="l">
               <a:spcBef>
-                <a:spcPts val="500"/>
+                <a:spcPts val="1800"/>
               </a:spcBef>
             </a:pPr>
             <a:r>
-              <a:rPr sz="1300">
+              <a:rPr sz="1400">
                 <a:solidFill>
                   <a:srgbClr val="2FDFE5"/>
                 </a:solidFill>
@@ -7013,7 +7421,7 @@
               <a:t>▸  </a:t>
             </a:r>
             <a:r>
-              <a:rPr sz="1400">
+              <a:rPr sz="1700">
                 <a:solidFill>
                   <a:srgbClr val="D8EAFF"/>
                 </a:solidFill>
@@ -7024,11 +7432,11 @@
           <a:p>
             <a:pPr algn="l">
               <a:spcBef>
-                <a:spcPts val="500"/>
+                <a:spcPts val="1800"/>
               </a:spcBef>
             </a:pPr>
             <a:r>
-              <a:rPr sz="1300">
+              <a:rPr sz="1400">
                 <a:solidFill>
                   <a:srgbClr val="2FDFE5"/>
                 </a:solidFill>
@@ -7036,7 +7444,7 @@
               <a:t>▸  </a:t>
             </a:r>
             <a:r>
-              <a:rPr sz="1400">
+              <a:rPr sz="1700">
                 <a:solidFill>
                   <a:srgbClr val="D8EAFF"/>
                 </a:solidFill>
@@ -7048,7 +7456,7 @@
       </p:sp>
       <p:pic>
         <p:nvPicPr>
-          <p:cNvPr id="19" name="Picture 18" descr="logo_horiz.png"/>
+          <p:cNvPr id="25" name="Picture 24" descr="logo_horiz.png"/>
           <p:cNvPicPr>
             <a:picLocks noChangeAspect="1"/>
           </p:cNvPicPr>
@@ -7097,7 +7505,7 @@
                             <p:childTnLst>
                               <p:animEffect transition="in" filter="wipe(up)">
                                 <p:cBhvr>
-                                  <p:cTn id="6" dur="450" fill="hold"/>
+                                  <p:cTn id="6" dur="380" fill="hold"/>
                                   <p:tgtEl>
                                     <p:spTgt spid="9"/>
                                   </p:tgtEl>
@@ -7109,14 +7517,150 @@
                         <p:par>
                           <p:cTn id="7" fill="hold">
                             <p:stCondLst>
+                              <p:cond delay="0"/>
+                            </p:stCondLst>
+                            <p:childTnLst>
+                              <p:animEffect transition="in" filter="wipe(up)">
+                                <p:cBhvr>
+                                  <p:cTn id="8" dur="380" fill="hold"/>
+                                  <p:tgtEl>
+                                    <p:spTgt spid="10"/>
+                                  </p:tgtEl>
+                                </p:cBhvr>
+                              </p:animEffect>
+                            </p:childTnLst>
+                          </p:cTn>
+                        </p:par>
+                        <p:par>
+                          <p:cTn id="9" fill="hold">
+                            <p:stCondLst>
+                              <p:cond delay="0"/>
+                            </p:stCondLst>
+                            <p:childTnLst>
+                              <p:animEffect transition="in" filter="wipe(up)">
+                                <p:cBhvr>
+                                  <p:cTn id="10" dur="380" fill="hold"/>
+                                  <p:tgtEl>
+                                    <p:spTgt spid="11"/>
+                                  </p:tgtEl>
+                                </p:cBhvr>
+                              </p:animEffect>
+                            </p:childTnLst>
+                          </p:cTn>
+                        </p:par>
+                        <p:par>
+                          <p:cTn id="11" fill="hold">
+                            <p:stCondLst>
+                              <p:cond delay="0"/>
+                            </p:stCondLst>
+                            <p:childTnLst>
+                              <p:animEffect transition="in" filter="wipe(up)">
+                                <p:cBhvr>
+                                  <p:cTn id="12" dur="380" fill="hold"/>
+                                  <p:tgtEl>
+                                    <p:spTgt spid="12"/>
+                                  </p:tgtEl>
+                                </p:cBhvr>
+                              </p:animEffect>
+                            </p:childTnLst>
+                          </p:cTn>
+                        </p:par>
+                        <p:par>
+                          <p:cTn id="13" fill="hold">
+                            <p:stCondLst>
+                              <p:cond delay="0"/>
+                            </p:stCondLst>
+                            <p:childTnLst>
+                              <p:animEffect transition="in" filter="wipe(up)">
+                                <p:cBhvr>
+                                  <p:cTn id="14" dur="380" fill="hold"/>
+                                  <p:tgtEl>
+                                    <p:spTgt spid="13"/>
+                                  </p:tgtEl>
+                                </p:cBhvr>
+                              </p:animEffect>
+                            </p:childTnLst>
+                          </p:cTn>
+                        </p:par>
+                        <p:par>
+                          <p:cTn id="15" fill="hold">
+                            <p:stCondLst>
                               <p:cond delay="160"/>
                             </p:stCondLst>
                             <p:childTnLst>
                               <p:animEffect transition="in" filter="wipe(up)">
                                 <p:cBhvr>
-                                  <p:cTn id="8" dur="450" fill="hold"/>
+                                  <p:cTn id="16" dur="380" fill="hold"/>
                                   <p:tgtEl>
                                     <p:spTgt spid="14"/>
+                                  </p:tgtEl>
+                                </p:cBhvr>
+                              </p:animEffect>
+                            </p:childTnLst>
+                          </p:cTn>
+                        </p:par>
+                        <p:par>
+                          <p:cTn id="17" fill="hold">
+                            <p:stCondLst>
+                              <p:cond delay="160"/>
+                            </p:stCondLst>
+                            <p:childTnLst>
+                              <p:animEffect transition="in" filter="wipe(up)">
+                                <p:cBhvr>
+                                  <p:cTn id="18" dur="380" fill="hold"/>
+                                  <p:tgtEl>
+                                    <p:spTgt spid="15"/>
+                                  </p:tgtEl>
+                                </p:cBhvr>
+                              </p:animEffect>
+                            </p:childTnLst>
+                          </p:cTn>
+                        </p:par>
+                        <p:par>
+                          <p:cTn id="19" fill="hold">
+                            <p:stCondLst>
+                              <p:cond delay="160"/>
+                            </p:stCondLst>
+                            <p:childTnLst>
+                              <p:animEffect transition="in" filter="wipe(up)">
+                                <p:cBhvr>
+                                  <p:cTn id="20" dur="380" fill="hold"/>
+                                  <p:tgtEl>
+                                    <p:spTgt spid="16"/>
+                                  </p:tgtEl>
+                                </p:cBhvr>
+                              </p:animEffect>
+                            </p:childTnLst>
+                          </p:cTn>
+                        </p:par>
+                        <p:par>
+                          <p:cTn id="21" fill="hold">
+                            <p:stCondLst>
+                              <p:cond delay="160"/>
+                            </p:stCondLst>
+                            <p:childTnLst>
+                              <p:animEffect transition="in" filter="wipe(up)">
+                                <p:cBhvr>
+                                  <p:cTn id="22" dur="380" fill="hold"/>
+                                  <p:tgtEl>
+                                    <p:spTgt spid="17"/>
+                                  </p:tgtEl>
+                                </p:cBhvr>
+                              </p:animEffect>
+                            </p:childTnLst>
+                          </p:cTn>
+                        </p:par>
+                        <p:par>
+                          <p:cTn id="23" fill="hold">
+                            <p:stCondLst>
+                              <p:cond delay="160"/>
+                            </p:stCondLst>
+                            <p:childTnLst>
+                              <p:animEffect transition="in" filter="wipe(up)">
+                                <p:cBhvr>
+                                  <p:cTn id="24" dur="380" fill="hold"/>
+                                  <p:tgtEl>
+                                    <p:spTgt spid="18"/>
                                   </p:tgtEl>
                                 </p:cBhvr>
                               </p:animEffect>
@@ -7275,100 +7819,7 @@
         <p:spPr>
           <a:xfrm>
             <a:off x="502920" y="365760"/>
-            <a:ext cx="1463040" cy="274320"/>
-          </a:xfrm>
-          <a:prstGeom prst="rect">
-            <a:avLst/>
-          </a:prstGeom>
-          <a:noFill/>
-          <a:ln w="15240">
-            <a:solidFill>
-              <a:srgbClr val="2FDFE5"/>
-            </a:solidFill>
-          </a:ln>
-        </p:spPr>
-        <p:style>
-          <a:lnRef idx="1">
-            <a:schemeClr val="accent1"/>
-          </a:lnRef>
-          <a:fillRef idx="3">
-            <a:schemeClr val="accent1"/>
-          </a:fillRef>
-          <a:effectRef idx="2">
-            <a:schemeClr val="accent1"/>
-          </a:effectRef>
-          <a:fontRef idx="minor">
-            <a:schemeClr val="lt1"/>
-          </a:fontRef>
-        </p:style>
-        <p:txBody lIns="76200" tIns="12700" rIns="76200" bIns="12700">
-          <a:bodyPr rtlCol="0" anchor="ctr" wrap="none"/>
-          <a:lstStyle/>
-          <a:p>
-            <a:pPr algn="ctr"/>
-            <a:r>
-              <a:rPr sz="800" b="1">
-                <a:solidFill>
-                  <a:srgbClr val="2FDFE5"/>
-                </a:solidFill>
-              </a:rPr>
-              <a:t>FASE 5</a:t>
-            </a:r>
-          </a:p>
-        </p:txBody>
-      </p:sp>
-      <p:sp>
-        <p:nvSpPr>
-          <p:cNvPr id="6" name="TextBox 5"/>
-          <p:cNvSpPr txBox="1"/>
-          <p:nvPr/>
-        </p:nvSpPr>
-        <p:spPr>
-          <a:xfrm>
-            <a:off x="502920" y="731520"/>
-            <a:ext cx="8961120" cy="960120"/>
-          </a:xfrm>
-          <a:prstGeom prst="rect">
-            <a:avLst/>
-          </a:prstGeom>
-          <a:noFill/>
-        </p:spPr>
-        <p:txBody lIns="0" tIns="0" rIns="0" bIns="0">
-          <a:bodyPr wrap="square">
-            <a:spAutoFit/>
-          </a:bodyPr>
-          <a:lstStyle/>
-          <a:p>
-            <a:pPr algn="l"/>
-            <a:r>
-              <a:rPr sz="4000" b="1">
-                <a:solidFill>
-                  <a:srgbClr val="FFFFFF"/>
-                </a:solidFill>
-              </a:rPr>
-              <a:t>Servicios </a:t>
-            </a:r>
-            <a:r>
-              <a:rPr sz="4000" b="1">
-                <a:solidFill>
-                  <a:srgbClr val="2FDFE5"/>
-                </a:solidFill>
-              </a:rPr>
-              <a:t>adicionales</a:t>
-            </a:r>
-          </a:p>
-        </p:txBody>
-      </p:sp>
-      <p:sp>
-        <p:nvSpPr>
-          <p:cNvPr id="7" name="Rectangle 6"/>
-          <p:cNvSpPr/>
-          <p:nvPr/>
-        </p:nvSpPr>
-        <p:spPr>
-          <a:xfrm>
-            <a:off x="502920" y="1737360"/>
-            <a:ext cx="4389120" cy="31750"/>
+            <a:ext cx="1737360" cy="301752"/>
           </a:xfrm>
           <a:prstGeom prst="rect">
             <a:avLst/>
@@ -7394,69 +7845,74 @@
             <a:schemeClr val="lt1"/>
           </a:fontRef>
         </p:style>
-        <p:txBody>
-          <a:bodyPr rtlCol="0" anchor="ctr"/>
+        <p:txBody lIns="101600" tIns="25400" rIns="101600" bIns="25400">
+          <a:bodyPr rtlCol="0" anchor="ctr" wrap="none"/>
           <a:lstStyle/>
           <a:p>
             <a:pPr algn="ctr"/>
-          </a:p>
-        </p:txBody>
-      </p:sp>
-      <p:sp>
-        <p:nvSpPr>
-          <p:cNvPr id="8" name="Rectangle 7"/>
+            <a:r>
+              <a:rPr sz="1100" b="1">
+                <a:solidFill>
+                  <a:srgbClr val="0A1638"/>
+                </a:solidFill>
+              </a:rPr>
+              <a:t>FASE 5</a:t>
+            </a:r>
+          </a:p>
+        </p:txBody>
+      </p:sp>
+      <p:sp>
+        <p:nvSpPr>
+          <p:cNvPr id="6" name="TextBox 5"/>
+          <p:cNvSpPr txBox="1"/>
+          <p:nvPr/>
+        </p:nvSpPr>
+        <p:spPr>
+          <a:xfrm>
+            <a:off x="502920" y="731520"/>
+            <a:ext cx="8961120" cy="960120"/>
+          </a:xfrm>
+          <a:prstGeom prst="rect">
+            <a:avLst/>
+          </a:prstGeom>
+          <a:noFill/>
+        </p:spPr>
+        <p:txBody lIns="0" tIns="0" rIns="0" bIns="0">
+          <a:bodyPr wrap="square">
+            <a:spAutoFit/>
+          </a:bodyPr>
+          <a:lstStyle/>
+          <a:p>
+            <a:pPr algn="l"/>
+            <a:r>
+              <a:rPr sz="4000" b="1">
+                <a:solidFill>
+                  <a:srgbClr val="FFFFFF"/>
+                </a:solidFill>
+              </a:rPr>
+              <a:t>Servicios </a:t>
+            </a:r>
+            <a:r>
+              <a:rPr sz="4000" b="1">
+                <a:solidFill>
+                  <a:srgbClr val="2FDFE5"/>
+                </a:solidFill>
+              </a:rPr>
+              <a:t>adicionales</a:t>
+            </a:r>
+          </a:p>
+        </p:txBody>
+      </p:sp>
+      <p:sp>
+        <p:nvSpPr>
+          <p:cNvPr id="7" name="Rectangle 6"/>
           <p:cNvSpPr/>
           <p:nvPr/>
         </p:nvSpPr>
         <p:spPr>
           <a:xfrm>
-            <a:off x="502920" y="1920240"/>
-            <a:ext cx="5579211" cy="1993392"/>
-          </a:xfrm>
-          <a:prstGeom prst="rect">
-            <a:avLst/>
-          </a:prstGeom>
-          <a:solidFill>
-            <a:srgbClr val="081438"/>
-          </a:solidFill>
-          <a:ln w="10160">
-            <a:solidFill>
-              <a:srgbClr val="2FDFE5"/>
-            </a:solidFill>
-          </a:ln>
-        </p:spPr>
-        <p:style>
-          <a:lnRef idx="1">
-            <a:schemeClr val="accent1"/>
-          </a:lnRef>
-          <a:fillRef idx="3">
-            <a:schemeClr val="accent1"/>
-          </a:fillRef>
-          <a:effectRef idx="2">
-            <a:schemeClr val="accent1"/>
-          </a:effectRef>
-          <a:fontRef idx="minor">
-            <a:schemeClr val="lt1"/>
-          </a:fontRef>
-        </p:style>
-        <p:txBody>
-          <a:bodyPr rtlCol="0" anchor="ctr"/>
-          <a:lstStyle/>
-          <a:p>
-            <a:pPr algn="ctr"/>
-          </a:p>
-        </p:txBody>
-      </p:sp>
-      <p:sp>
-        <p:nvSpPr>
-          <p:cNvPr id="9" name="Rectangle 8"/>
-          <p:cNvSpPr/>
-          <p:nvPr/>
-        </p:nvSpPr>
-        <p:spPr>
-          <a:xfrm>
-            <a:off x="502920" y="1920240"/>
-            <a:ext cx="5579211" cy="63500"/>
+            <a:off x="502920" y="1737360"/>
+            <a:ext cx="4389120" cy="31750"/>
           </a:xfrm>
           <a:prstGeom prst="rect">
             <a:avLst/>
@@ -7492,21 +7948,109 @@
       </p:sp>
       <p:sp>
         <p:nvSpPr>
+          <p:cNvPr id="8" name="Rectangle 7"/>
+          <p:cNvSpPr/>
+          <p:nvPr/>
+        </p:nvSpPr>
+        <p:spPr>
+          <a:xfrm>
+            <a:off x="502920" y="1920240"/>
+            <a:ext cx="5579211" cy="1993392"/>
+          </a:xfrm>
+          <a:prstGeom prst="rect">
+            <a:avLst/>
+          </a:prstGeom>
+          <a:solidFill>
+            <a:srgbClr val="081438"/>
+          </a:solidFill>
+          <a:ln w="12700">
+            <a:solidFill>
+              <a:srgbClr val="2FDFE5"/>
+            </a:solidFill>
+          </a:ln>
+        </p:spPr>
+        <p:style>
+          <a:lnRef idx="1">
+            <a:schemeClr val="accent1"/>
+          </a:lnRef>
+          <a:fillRef idx="3">
+            <a:schemeClr val="accent1"/>
+          </a:fillRef>
+          <a:effectRef idx="2">
+            <a:schemeClr val="accent1"/>
+          </a:effectRef>
+          <a:fontRef idx="minor">
+            <a:schemeClr val="lt1"/>
+          </a:fontRef>
+        </p:style>
+        <p:txBody>
+          <a:bodyPr rtlCol="0" anchor="ctr"/>
+          <a:lstStyle/>
+          <a:p>
+            <a:pPr algn="ctr"/>
+          </a:p>
+        </p:txBody>
+      </p:sp>
+      <p:sp>
+        <p:nvSpPr>
+          <p:cNvPr id="9" name="Rectangle 8"/>
+          <p:cNvSpPr/>
+          <p:nvPr/>
+        </p:nvSpPr>
+        <p:spPr>
+          <a:xfrm>
+            <a:off x="502920" y="1920240"/>
+            <a:ext cx="5579211" cy="63500"/>
+          </a:xfrm>
+          <a:prstGeom prst="rect">
+            <a:avLst/>
+          </a:prstGeom>
+          <a:solidFill>
+            <a:srgbClr val="2FDFE5"/>
+          </a:solidFill>
+          <a:ln>
+            <a:noFill/>
+          </a:ln>
+        </p:spPr>
+        <p:style>
+          <a:lnRef idx="1">
+            <a:schemeClr val="accent1"/>
+          </a:lnRef>
+          <a:fillRef idx="3">
+            <a:schemeClr val="accent1"/>
+          </a:fillRef>
+          <a:effectRef idx="2">
+            <a:schemeClr val="accent1"/>
+          </a:effectRef>
+          <a:fontRef idx="minor">
+            <a:schemeClr val="lt1"/>
+          </a:fontRef>
+        </p:style>
+        <p:txBody>
+          <a:bodyPr rtlCol="0" anchor="ctr"/>
+          <a:lstStyle/>
+          <a:p>
+            <a:pPr algn="ctr"/>
+          </a:p>
+        </p:txBody>
+      </p:sp>
+      <p:sp>
+        <p:nvSpPr>
           <p:cNvPr id="10" name="TextBox 9"/>
           <p:cNvSpPr txBox="1"/>
           <p:nvPr/>
         </p:nvSpPr>
         <p:spPr>
           <a:xfrm>
-            <a:off x="685800" y="2084832"/>
-            <a:ext cx="5213451" cy="548640"/>
+            <a:off x="685800" y="2103120"/>
+            <a:ext cx="5213451" cy="585216"/>
           </a:xfrm>
           <a:prstGeom prst="rect">
             <a:avLst/>
           </a:prstGeom>
           <a:noFill/>
         </p:spPr>
-        <p:txBody lIns="38100" tIns="50800" rIns="38100" bIns="25400">
+        <p:txBody lIns="38100" tIns="63500" rIns="38100" bIns="25400">
           <a:bodyPr wrap="square">
             <a:spAutoFit/>
           </a:bodyPr>
@@ -7540,8 +8084,8 @@
         </p:nvSpPr>
         <p:spPr>
           <a:xfrm>
-            <a:off x="649224" y="2724912"/>
-            <a:ext cx="5286603" cy="12700"/>
+            <a:off x="649224" y="2779776"/>
+            <a:ext cx="5286603" cy="19050"/>
           </a:xfrm>
           <a:prstGeom prst="rect">
             <a:avLst/>
@@ -7583,15 +8127,15 @@
         </p:nvSpPr>
         <p:spPr>
           <a:xfrm>
-            <a:off x="649224" y="2813812"/>
-            <a:ext cx="5286603" cy="1033780"/>
+            <a:off x="649224" y="2881376"/>
+            <a:ext cx="5286603" cy="1005840"/>
           </a:xfrm>
           <a:prstGeom prst="rect">
             <a:avLst/>
           </a:prstGeom>
           <a:noFill/>
         </p:spPr>
-        <p:txBody lIns="50800" tIns="25400" rIns="50800" bIns="25400">
+        <p:txBody lIns="50800" tIns="50800" rIns="50800" bIns="50800">
           <a:bodyPr wrap="square">
             <a:spAutoFit/>
           </a:bodyPr>
@@ -7599,7 +8143,7 @@
           <a:p>
             <a:pPr algn="l"/>
             <a:r>
-              <a:rPr sz="1400">
+              <a:rPr sz="1500">
                 <a:solidFill>
                   <a:srgbClr val="D8EAFF"/>
                 </a:solidFill>
@@ -7626,7 +8170,7 @@
           <a:solidFill>
             <a:srgbClr val="081438"/>
           </a:solidFill>
-          <a:ln w="10160">
+          <a:ln w="12700">
             <a:solidFill>
               <a:srgbClr val="2FDFE5"/>
             </a:solidFill>
@@ -7705,15 +8249,15 @@
         </p:nvSpPr>
         <p:spPr>
           <a:xfrm>
-            <a:off x="6466179" y="2084832"/>
-            <a:ext cx="5213451" cy="548640"/>
+            <a:off x="6466179" y="2103120"/>
+            <a:ext cx="5213451" cy="585216"/>
           </a:xfrm>
           <a:prstGeom prst="rect">
             <a:avLst/>
           </a:prstGeom>
           <a:noFill/>
         </p:spPr>
-        <p:txBody lIns="38100" tIns="50800" rIns="38100" bIns="25400">
+        <p:txBody lIns="38100" tIns="63500" rIns="38100" bIns="25400">
           <a:bodyPr wrap="square">
             <a:spAutoFit/>
           </a:bodyPr>
@@ -7747,8 +8291,8 @@
         </p:nvSpPr>
         <p:spPr>
           <a:xfrm>
-            <a:off x="6429603" y="2724912"/>
-            <a:ext cx="5286603" cy="12700"/>
+            <a:off x="6429603" y="2779776"/>
+            <a:ext cx="5286603" cy="19050"/>
           </a:xfrm>
           <a:prstGeom prst="rect">
             <a:avLst/>
@@ -7790,15 +8334,15 @@
         </p:nvSpPr>
         <p:spPr>
           <a:xfrm>
-            <a:off x="6429603" y="2813812"/>
-            <a:ext cx="5286603" cy="1033780"/>
+            <a:off x="6429603" y="2881376"/>
+            <a:ext cx="5286603" cy="1005840"/>
           </a:xfrm>
           <a:prstGeom prst="rect">
             <a:avLst/>
           </a:prstGeom>
           <a:noFill/>
         </p:spPr>
-        <p:txBody lIns="50800" tIns="25400" rIns="50800" bIns="25400">
+        <p:txBody lIns="50800" tIns="50800" rIns="50800" bIns="50800">
           <a:bodyPr wrap="square">
             <a:spAutoFit/>
           </a:bodyPr>
@@ -7806,7 +8350,7 @@
           <a:p>
             <a:pPr algn="l"/>
             <a:r>
-              <a:rPr sz="1400">
+              <a:rPr sz="1500">
                 <a:solidFill>
                   <a:srgbClr val="D8EAFF"/>
                 </a:solidFill>
@@ -7833,7 +8377,7 @@
           <a:solidFill>
             <a:srgbClr val="081438"/>
           </a:solidFill>
-          <a:ln w="10160">
+          <a:ln w="12700">
             <a:solidFill>
               <a:srgbClr val="2FDFE5"/>
             </a:solidFill>
@@ -7912,15 +8456,15 @@
         </p:nvSpPr>
         <p:spPr>
           <a:xfrm>
-            <a:off x="685800" y="4224528"/>
-            <a:ext cx="5213451" cy="548640"/>
+            <a:off x="685800" y="4242816"/>
+            <a:ext cx="5213451" cy="585216"/>
           </a:xfrm>
           <a:prstGeom prst="rect">
             <a:avLst/>
           </a:prstGeom>
           <a:noFill/>
         </p:spPr>
-        <p:txBody lIns="38100" tIns="50800" rIns="38100" bIns="25400">
+        <p:txBody lIns="38100" tIns="63500" rIns="38100" bIns="25400">
           <a:bodyPr wrap="square">
             <a:spAutoFit/>
           </a:bodyPr>
@@ -7954,8 +8498,8 @@
         </p:nvSpPr>
         <p:spPr>
           <a:xfrm>
-            <a:off x="649224" y="4864608"/>
-            <a:ext cx="5286603" cy="12700"/>
+            <a:off x="649224" y="4919472"/>
+            <a:ext cx="5286603" cy="19050"/>
           </a:xfrm>
           <a:prstGeom prst="rect">
             <a:avLst/>
@@ -7997,15 +8541,15 @@
         </p:nvSpPr>
         <p:spPr>
           <a:xfrm>
-            <a:off x="649224" y="4953508"/>
-            <a:ext cx="5286603" cy="1033780"/>
+            <a:off x="649224" y="5021072"/>
+            <a:ext cx="5286603" cy="1005840"/>
           </a:xfrm>
           <a:prstGeom prst="rect">
             <a:avLst/>
           </a:prstGeom>
           <a:noFill/>
         </p:spPr>
-        <p:txBody lIns="50800" tIns="25400" rIns="50800" bIns="25400">
+        <p:txBody lIns="50800" tIns="50800" rIns="50800" bIns="50800">
           <a:bodyPr wrap="square">
             <a:spAutoFit/>
           </a:bodyPr>
@@ -8013,7 +8557,7 @@
           <a:p>
             <a:pPr algn="l"/>
             <a:r>
-              <a:rPr sz="1400">
+              <a:rPr sz="1500">
                 <a:solidFill>
                   <a:srgbClr val="D8EAFF"/>
                 </a:solidFill>
@@ -8040,7 +8584,7 @@
           <a:solidFill>
             <a:srgbClr val="081438"/>
           </a:solidFill>
-          <a:ln w="10160">
+          <a:ln w="12700">
             <a:solidFill>
               <a:srgbClr val="2FDFE5"/>
             </a:solidFill>
@@ -8119,15 +8663,15 @@
         </p:nvSpPr>
         <p:spPr>
           <a:xfrm>
-            <a:off x="6466179" y="4224528"/>
-            <a:ext cx="5213451" cy="548640"/>
+            <a:off x="6466179" y="4242816"/>
+            <a:ext cx="5213451" cy="585216"/>
           </a:xfrm>
           <a:prstGeom prst="rect">
             <a:avLst/>
           </a:prstGeom>
           <a:noFill/>
         </p:spPr>
-        <p:txBody lIns="38100" tIns="50800" rIns="38100" bIns="25400">
+        <p:txBody lIns="38100" tIns="63500" rIns="38100" bIns="25400">
           <a:bodyPr wrap="square">
             <a:spAutoFit/>
           </a:bodyPr>
@@ -8161,8 +8705,8 @@
         </p:nvSpPr>
         <p:spPr>
           <a:xfrm>
-            <a:off x="6429603" y="4864608"/>
-            <a:ext cx="5286603" cy="12700"/>
+            <a:off x="6429603" y="4919472"/>
+            <a:ext cx="5286603" cy="19050"/>
           </a:xfrm>
           <a:prstGeom prst="rect">
             <a:avLst/>
@@ -8204,15 +8748,15 @@
         </p:nvSpPr>
         <p:spPr>
           <a:xfrm>
-            <a:off x="6429603" y="4953508"/>
-            <a:ext cx="5286603" cy="1033780"/>
+            <a:off x="6429603" y="5021072"/>
+            <a:ext cx="5286603" cy="1005840"/>
           </a:xfrm>
           <a:prstGeom prst="rect">
             <a:avLst/>
           </a:prstGeom>
           <a:noFill/>
         </p:spPr>
-        <p:txBody lIns="50800" tIns="25400" rIns="50800" bIns="25400">
+        <p:txBody lIns="50800" tIns="50800" rIns="50800" bIns="50800">
           <a:bodyPr wrap="square">
             <a:spAutoFit/>
           </a:bodyPr>
@@ -8220,7 +8764,7 @@
           <a:p>
             <a:pPr algn="l"/>
             <a:r>
-              <a:rPr sz="1400">
+              <a:rPr sz="1500">
                 <a:solidFill>
                   <a:srgbClr val="D8EAFF"/>
                 </a:solidFill>
@@ -8232,7 +8776,7 @@
       </p:sp>
       <p:pic>
         <p:nvPicPr>
-          <p:cNvPr id="28" name="Picture 27" descr="logo_horiz.png"/>
+          <p:cNvPr id="45" name="Picture 44" descr="logo_horiz.png"/>
           <p:cNvPicPr>
             <a:picLocks noChangeAspect="1"/>
           </p:cNvPicPr>
@@ -8281,7 +8825,7 @@
                             <p:childTnLst>
                               <p:animEffect transition="in" filter="wipe(up)">
                                 <p:cBhvr>
-                                  <p:cTn id="6" dur="450" fill="hold"/>
+                                  <p:cTn id="6" dur="380" fill="hold"/>
                                   <p:tgtEl>
                                     <p:spTgt spid="8"/>
                                   </p:tgtEl>
@@ -8293,12 +8837,80 @@
                         <p:par>
                           <p:cTn id="7" fill="hold">
                             <p:stCondLst>
-                              <p:cond delay="160"/>
+                              <p:cond delay="0"/>
                             </p:stCondLst>
                             <p:childTnLst>
                               <p:animEffect transition="in" filter="wipe(up)">
                                 <p:cBhvr>
-                                  <p:cTn id="8" dur="450" fill="hold"/>
+                                  <p:cTn id="8" dur="380" fill="hold"/>
+                                  <p:tgtEl>
+                                    <p:spTgt spid="9"/>
+                                  </p:tgtEl>
+                                </p:cBhvr>
+                              </p:animEffect>
+                            </p:childTnLst>
+                          </p:cTn>
+                        </p:par>
+                        <p:par>
+                          <p:cTn id="9" fill="hold">
+                            <p:stCondLst>
+                              <p:cond delay="0"/>
+                            </p:stCondLst>
+                            <p:childTnLst>
+                              <p:animEffect transition="in" filter="wipe(up)">
+                                <p:cBhvr>
+                                  <p:cTn id="10" dur="380" fill="hold"/>
+                                  <p:tgtEl>
+                                    <p:spTgt spid="10"/>
+                                  </p:tgtEl>
+                                </p:cBhvr>
+                              </p:animEffect>
+                            </p:childTnLst>
+                          </p:cTn>
+                        </p:par>
+                        <p:par>
+                          <p:cTn id="11" fill="hold">
+                            <p:stCondLst>
+                              <p:cond delay="0"/>
+                            </p:stCondLst>
+                            <p:childTnLst>
+                              <p:animEffect transition="in" filter="wipe(up)">
+                                <p:cBhvr>
+                                  <p:cTn id="12" dur="380" fill="hold"/>
+                                  <p:tgtEl>
+                                    <p:spTgt spid="11"/>
+                                  </p:tgtEl>
+                                </p:cBhvr>
+                              </p:animEffect>
+                            </p:childTnLst>
+                          </p:cTn>
+                        </p:par>
+                        <p:par>
+                          <p:cTn id="13" fill="hold">
+                            <p:stCondLst>
+                              <p:cond delay="0"/>
+                            </p:stCondLst>
+                            <p:childTnLst>
+                              <p:animEffect transition="in" filter="wipe(up)">
+                                <p:cBhvr>
+                                  <p:cTn id="14" dur="380" fill="hold"/>
+                                  <p:tgtEl>
+                                    <p:spTgt spid="12"/>
+                                  </p:tgtEl>
+                                </p:cBhvr>
+                              </p:animEffect>
+                            </p:childTnLst>
+                          </p:cTn>
+                        </p:par>
+                        <p:par>
+                          <p:cTn id="15" fill="hold">
+                            <p:stCondLst>
+                              <p:cond delay="140"/>
+                            </p:stCondLst>
+                            <p:childTnLst>
+                              <p:animEffect transition="in" filter="wipe(up)">
+                                <p:cBhvr>
+                                  <p:cTn id="16" dur="380" fill="hold"/>
                                   <p:tgtEl>
                                     <p:spTgt spid="13"/>
                                   </p:tgtEl>
@@ -8308,14 +8920,82 @@
                           </p:cTn>
                         </p:par>
                         <p:par>
-                          <p:cTn id="9" fill="hold">
+                          <p:cTn id="17" fill="hold">
                             <p:stCondLst>
-                              <p:cond delay="320"/>
+                              <p:cond delay="140"/>
                             </p:stCondLst>
                             <p:childTnLst>
                               <p:animEffect transition="in" filter="wipe(up)">
                                 <p:cBhvr>
-                                  <p:cTn id="10" dur="450" fill="hold"/>
+                                  <p:cTn id="18" dur="380" fill="hold"/>
+                                  <p:tgtEl>
+                                    <p:spTgt spid="14"/>
+                                  </p:tgtEl>
+                                </p:cBhvr>
+                              </p:animEffect>
+                            </p:childTnLst>
+                          </p:cTn>
+                        </p:par>
+                        <p:par>
+                          <p:cTn id="19" fill="hold">
+                            <p:stCondLst>
+                              <p:cond delay="140"/>
+                            </p:stCondLst>
+                            <p:childTnLst>
+                              <p:animEffect transition="in" filter="wipe(up)">
+                                <p:cBhvr>
+                                  <p:cTn id="20" dur="380" fill="hold"/>
+                                  <p:tgtEl>
+                                    <p:spTgt spid="15"/>
+                                  </p:tgtEl>
+                                </p:cBhvr>
+                              </p:animEffect>
+                            </p:childTnLst>
+                          </p:cTn>
+                        </p:par>
+                        <p:par>
+                          <p:cTn id="21" fill="hold">
+                            <p:stCondLst>
+                              <p:cond delay="140"/>
+                            </p:stCondLst>
+                            <p:childTnLst>
+                              <p:animEffect transition="in" filter="wipe(up)">
+                                <p:cBhvr>
+                                  <p:cTn id="22" dur="380" fill="hold"/>
+                                  <p:tgtEl>
+                                    <p:spTgt spid="16"/>
+                                  </p:tgtEl>
+                                </p:cBhvr>
+                              </p:animEffect>
+                            </p:childTnLst>
+                          </p:cTn>
+                        </p:par>
+                        <p:par>
+                          <p:cTn id="23" fill="hold">
+                            <p:stCondLst>
+                              <p:cond delay="140"/>
+                            </p:stCondLst>
+                            <p:childTnLst>
+                              <p:animEffect transition="in" filter="wipe(up)">
+                                <p:cBhvr>
+                                  <p:cTn id="24" dur="380" fill="hold"/>
+                                  <p:tgtEl>
+                                    <p:spTgt spid="17"/>
+                                  </p:tgtEl>
+                                </p:cBhvr>
+                              </p:animEffect>
+                            </p:childTnLst>
+                          </p:cTn>
+                        </p:par>
+                        <p:par>
+                          <p:cTn id="25" fill="hold">
+                            <p:stCondLst>
+                              <p:cond delay="280"/>
+                            </p:stCondLst>
+                            <p:childTnLst>
+                              <p:animEffect transition="in" filter="wipe(up)">
+                                <p:cBhvr>
+                                  <p:cTn id="26" dur="380" fill="hold"/>
                                   <p:tgtEl>
                                     <p:spTgt spid="18"/>
                                   </p:tgtEl>
@@ -8325,16 +9005,152 @@
                           </p:cTn>
                         </p:par>
                         <p:par>
-                          <p:cTn id="11" fill="hold">
+                          <p:cTn id="27" fill="hold">
                             <p:stCondLst>
-                              <p:cond delay="480"/>
+                              <p:cond delay="280"/>
                             </p:stCondLst>
                             <p:childTnLst>
                               <p:animEffect transition="in" filter="wipe(up)">
                                 <p:cBhvr>
-                                  <p:cTn id="12" dur="450" fill="hold"/>
+                                  <p:cTn id="28" dur="380" fill="hold"/>
+                                  <p:tgtEl>
+                                    <p:spTgt spid="19"/>
+                                  </p:tgtEl>
+                                </p:cBhvr>
+                              </p:animEffect>
+                            </p:childTnLst>
+                          </p:cTn>
+                        </p:par>
+                        <p:par>
+                          <p:cTn id="29" fill="hold">
+                            <p:stCondLst>
+                              <p:cond delay="280"/>
+                            </p:stCondLst>
+                            <p:childTnLst>
+                              <p:animEffect transition="in" filter="wipe(up)">
+                                <p:cBhvr>
+                                  <p:cTn id="30" dur="380" fill="hold"/>
+                                  <p:tgtEl>
+                                    <p:spTgt spid="20"/>
+                                  </p:tgtEl>
+                                </p:cBhvr>
+                              </p:animEffect>
+                            </p:childTnLst>
+                          </p:cTn>
+                        </p:par>
+                        <p:par>
+                          <p:cTn id="31" fill="hold">
+                            <p:stCondLst>
+                              <p:cond delay="280"/>
+                            </p:stCondLst>
+                            <p:childTnLst>
+                              <p:animEffect transition="in" filter="wipe(up)">
+                                <p:cBhvr>
+                                  <p:cTn id="32" dur="380" fill="hold"/>
+                                  <p:tgtEl>
+                                    <p:spTgt spid="21"/>
+                                  </p:tgtEl>
+                                </p:cBhvr>
+                              </p:animEffect>
+                            </p:childTnLst>
+                          </p:cTn>
+                        </p:par>
+                        <p:par>
+                          <p:cTn id="33" fill="hold">
+                            <p:stCondLst>
+                              <p:cond delay="280"/>
+                            </p:stCondLst>
+                            <p:childTnLst>
+                              <p:animEffect transition="in" filter="wipe(up)">
+                                <p:cBhvr>
+                                  <p:cTn id="34" dur="380" fill="hold"/>
+                                  <p:tgtEl>
+                                    <p:spTgt spid="22"/>
+                                  </p:tgtEl>
+                                </p:cBhvr>
+                              </p:animEffect>
+                            </p:childTnLst>
+                          </p:cTn>
+                        </p:par>
+                        <p:par>
+                          <p:cTn id="35" fill="hold">
+                            <p:stCondLst>
+                              <p:cond delay="420"/>
+                            </p:stCondLst>
+                            <p:childTnLst>
+                              <p:animEffect transition="in" filter="wipe(up)">
+                                <p:cBhvr>
+                                  <p:cTn id="36" dur="380" fill="hold"/>
                                   <p:tgtEl>
                                     <p:spTgt spid="23"/>
+                                  </p:tgtEl>
+                                </p:cBhvr>
+                              </p:animEffect>
+                            </p:childTnLst>
+                          </p:cTn>
+                        </p:par>
+                        <p:par>
+                          <p:cTn id="37" fill="hold">
+                            <p:stCondLst>
+                              <p:cond delay="420"/>
+                            </p:stCondLst>
+                            <p:childTnLst>
+                              <p:animEffect transition="in" filter="wipe(up)">
+                                <p:cBhvr>
+                                  <p:cTn id="38" dur="380" fill="hold"/>
+                                  <p:tgtEl>
+                                    <p:spTgt spid="24"/>
+                                  </p:tgtEl>
+                                </p:cBhvr>
+                              </p:animEffect>
+                            </p:childTnLst>
+                          </p:cTn>
+                        </p:par>
+                        <p:par>
+                          <p:cTn id="39" fill="hold">
+                            <p:stCondLst>
+                              <p:cond delay="420"/>
+                            </p:stCondLst>
+                            <p:childTnLst>
+                              <p:animEffect transition="in" filter="wipe(up)">
+                                <p:cBhvr>
+                                  <p:cTn id="40" dur="380" fill="hold"/>
+                                  <p:tgtEl>
+                                    <p:spTgt spid="25"/>
+                                  </p:tgtEl>
+                                </p:cBhvr>
+                              </p:animEffect>
+                            </p:childTnLst>
+                          </p:cTn>
+                        </p:par>
+                        <p:par>
+                          <p:cTn id="41" fill="hold">
+                            <p:stCondLst>
+                              <p:cond delay="420"/>
+                            </p:stCondLst>
+                            <p:childTnLst>
+                              <p:animEffect transition="in" filter="wipe(up)">
+                                <p:cBhvr>
+                                  <p:cTn id="42" dur="380" fill="hold"/>
+                                  <p:tgtEl>
+                                    <p:spTgt spid="26"/>
+                                  </p:tgtEl>
+                                </p:cBhvr>
+                              </p:animEffect>
+                            </p:childTnLst>
+                          </p:cTn>
+                        </p:par>
+                        <p:par>
+                          <p:cTn id="43" fill="hold">
+                            <p:stCondLst>
+                              <p:cond delay="420"/>
+                            </p:stCondLst>
+                            <p:childTnLst>
+                              <p:animEffect transition="in" filter="wipe(up)">
+                                <p:cBhvr>
+                                  <p:cTn id="44" dur="380" fill="hold"/>
+                                  <p:tgtEl>
+                                    <p:spTgt spid="27"/>
                                   </p:tgtEl>
                                 </p:cBhvr>
                               </p:animEffect>
@@ -8634,11 +9450,11 @@
           <a:prstGeom prst="rect">
             <a:avLst/>
           </a:prstGeom>
-          <a:noFill/>
-          <a:ln w="15240">
-            <a:solidFill>
-              <a:srgbClr val="2FDFE5"/>
-            </a:solidFill>
+          <a:solidFill>
+            <a:srgbClr val="2FDFE5"/>
+          </a:solidFill>
+          <a:ln>
+            <a:noFill/>
           </a:ln>
         </p:spPr>
         <p:style>
@@ -8655,15 +9471,15 @@
             <a:schemeClr val="lt1"/>
           </a:fontRef>
         </p:style>
-        <p:txBody lIns="76200" tIns="12700" rIns="76200" bIns="12700">
+        <p:txBody lIns="101600" tIns="25400" rIns="101600" bIns="25400">
           <a:bodyPr rtlCol="0" anchor="ctr" wrap="none"/>
           <a:lstStyle/>
           <a:p>
             <a:pPr algn="ctr"/>
             <a:r>
-              <a:rPr sz="800" b="1">
-                <a:solidFill>
-                  <a:srgbClr val="2FDFE5"/>
+              <a:rPr sz="1100" b="1">
+                <a:solidFill>
+                  <a:srgbClr val="0A1638"/>
                 </a:solidFill>
               </a:rPr>
               <a:t>CONTACTO</a:t>

</xml_diff>

<commit_message>
Fix logo bug, replace building photo, fix contact card overflow
- foot_logo: compute height from PIL AR and add picture at final position directly
  (eliminates rendering bug where logo appeared at 0,0 on some viewers)
- Contact slide: replace building photo with abstract partnership panel
  (two overlapping teal rings on navy — proxy blocks external image downloads)
- Contact office cards: reduce cw from 2.36" to 2.15" so 3 cards (ending at
  7.36") no longer cross into the right photo panel (starts at 7.73")
</commit_message>
<xml_diff>
--- a/sendacredit_propuesta.pptx
+++ b/sendacredit_propuesta.pptx
@@ -9216,7 +9216,7 @@
       </p:pic>
       <p:pic>
         <p:nvPicPr>
-          <p:cNvPr id="3" name="Picture 2" descr="building_cropped.jpg"/>
+          <p:cNvPr id="3" name="Picture 2" descr="contact_panel.png"/>
           <p:cNvPicPr>
             <a:picLocks noChangeAspect="1"/>
           </p:cNvPicPr>
@@ -9254,7 +9254,7 @@
           </a:prstGeom>
           <a:solidFill>
             <a:srgbClr val="060E24">
-              <a:alpha val="22000"/>
+              <a:alpha val="8000"/>
             </a:srgbClr>
           </a:solidFill>
           <a:ln>
@@ -9618,7 +9618,7 @@
         <p:spPr>
           <a:xfrm>
             <a:off x="502920" y="3401568"/>
-            <a:ext cx="2157984" cy="1920240"/>
+            <a:ext cx="1965960" cy="1920240"/>
           </a:xfrm>
           <a:prstGeom prst="rect">
             <a:avLst/>
@@ -9663,7 +9663,7 @@
         <p:spPr>
           <a:xfrm>
             <a:off x="502920" y="3401568"/>
-            <a:ext cx="2157984" cy="63500"/>
+            <a:ext cx="1965960" cy="63500"/>
           </a:xfrm>
           <a:prstGeom prst="rect">
             <a:avLst/>
@@ -9706,7 +9706,7 @@
         <p:spPr>
           <a:xfrm>
             <a:off x="630936" y="3557016"/>
-            <a:ext cx="1901952" cy="310896"/>
+            <a:ext cx="1709928" cy="310896"/>
           </a:xfrm>
           <a:prstGeom prst="rect">
             <a:avLst/>
@@ -9740,7 +9740,7 @@
         <p:spPr>
           <a:xfrm>
             <a:off x="630936" y="3904488"/>
-            <a:ext cx="1901952" cy="12700"/>
+            <a:ext cx="1709928" cy="12700"/>
           </a:xfrm>
           <a:prstGeom prst="rect">
             <a:avLst/>
@@ -9783,7 +9783,7 @@
         <p:spPr>
           <a:xfrm>
             <a:off x="630936" y="3980688"/>
-            <a:ext cx="1901952" cy="1234440"/>
+            <a:ext cx="1709928" cy="1234440"/>
           </a:xfrm>
           <a:prstGeom prst="rect">
             <a:avLst/>
@@ -9850,8 +9850,8 @@
         </p:nvSpPr>
         <p:spPr>
           <a:xfrm>
-            <a:off x="2825496" y="3401568"/>
-            <a:ext cx="2157984" cy="1920240"/>
+            <a:off x="2633472" y="3401568"/>
+            <a:ext cx="1965960" cy="1920240"/>
           </a:xfrm>
           <a:prstGeom prst="rect">
             <a:avLst/>
@@ -9895,8 +9895,8 @@
         </p:nvSpPr>
         <p:spPr>
           <a:xfrm>
-            <a:off x="2825496" y="3401568"/>
-            <a:ext cx="2157984" cy="63500"/>
+            <a:off x="2633472" y="3401568"/>
+            <a:ext cx="1965960" cy="63500"/>
           </a:xfrm>
           <a:prstGeom prst="rect">
             <a:avLst/>
@@ -9938,8 +9938,8 @@
         </p:nvSpPr>
         <p:spPr>
           <a:xfrm>
-            <a:off x="2953512" y="3557016"/>
-            <a:ext cx="1901952" cy="310896"/>
+            <a:off x="2761488" y="3557016"/>
+            <a:ext cx="1709928" cy="310896"/>
           </a:xfrm>
           <a:prstGeom prst="rect">
             <a:avLst/>
@@ -9972,8 +9972,8 @@
         </p:nvSpPr>
         <p:spPr>
           <a:xfrm>
-            <a:off x="2953512" y="3904488"/>
-            <a:ext cx="1901952" cy="12700"/>
+            <a:off x="2761488" y="3904488"/>
+            <a:ext cx="1709928" cy="12700"/>
           </a:xfrm>
           <a:prstGeom prst="rect">
             <a:avLst/>
@@ -10015,8 +10015,8 @@
         </p:nvSpPr>
         <p:spPr>
           <a:xfrm>
-            <a:off x="2953512" y="3980688"/>
-            <a:ext cx="1901952" cy="1234440"/>
+            <a:off x="2761488" y="3980688"/>
+            <a:ext cx="1709928" cy="1234440"/>
           </a:xfrm>
           <a:prstGeom prst="rect">
             <a:avLst/>
@@ -10083,8 +10083,8 @@
         </p:nvSpPr>
         <p:spPr>
           <a:xfrm>
-            <a:off x="5148072" y="3401568"/>
-            <a:ext cx="2157984" cy="1920240"/>
+            <a:off x="4764024" y="3401568"/>
+            <a:ext cx="1965960" cy="1920240"/>
           </a:xfrm>
           <a:prstGeom prst="rect">
             <a:avLst/>
@@ -10128,8 +10128,8 @@
         </p:nvSpPr>
         <p:spPr>
           <a:xfrm>
-            <a:off x="5148072" y="3401568"/>
-            <a:ext cx="2157984" cy="63500"/>
+            <a:off x="4764024" y="3401568"/>
+            <a:ext cx="1965960" cy="63500"/>
           </a:xfrm>
           <a:prstGeom prst="rect">
             <a:avLst/>
@@ -10171,8 +10171,8 @@
         </p:nvSpPr>
         <p:spPr>
           <a:xfrm>
-            <a:off x="5276088" y="3557016"/>
-            <a:ext cx="1901952" cy="310896"/>
+            <a:off x="4892040" y="3557016"/>
+            <a:ext cx="1709928" cy="310896"/>
           </a:xfrm>
           <a:prstGeom prst="rect">
             <a:avLst/>
@@ -10205,8 +10205,8 @@
         </p:nvSpPr>
         <p:spPr>
           <a:xfrm>
-            <a:off x="5276088" y="3904488"/>
-            <a:ext cx="1901952" cy="12700"/>
+            <a:off x="4892040" y="3904488"/>
+            <a:ext cx="1709928" cy="12700"/>
           </a:xfrm>
           <a:prstGeom prst="rect">
             <a:avLst/>
@@ -10248,8 +10248,8 @@
         </p:nvSpPr>
         <p:spPr>
           <a:xfrm>
-            <a:off x="5276088" y="3980688"/>
-            <a:ext cx="1901952" cy="1234440"/>
+            <a:off x="4892040" y="3980688"/>
+            <a:ext cx="1709928" cy="1234440"/>
           </a:xfrm>
           <a:prstGeom prst="rect">
             <a:avLst/>

</xml_diff>

<commit_message>
Fix logo rendering bug: bake logo into background images via PIL compositing
Eliminates intermittent iOS bug where horizontal logo appeared oversized
in wrong position. Logo is now composited directly into background PNG
files before PPTX build, removing all add_picture() logo shapes whose
internal two-step positioning caused viewer-dependent rendering issues.
</commit_message>
<xml_diff>
--- a/sendacredit_propuesta.pptx
+++ b/sendacredit_propuesta.pptx
@@ -4286,30 +4286,6 @@
           </a:p>
         </p:txBody>
       </p:sp>
-      <p:pic>
-        <p:nvPicPr>
-          <p:cNvPr id="25" name="Picture 24" descr="logo_horiz.png"/>
-          <p:cNvPicPr>
-            <a:picLocks noChangeAspect="1"/>
-          </p:cNvPicPr>
-          <p:nvPr/>
-        </p:nvPicPr>
-        <p:blipFill>
-          <a:blip r:embed="rId3"/>
-          <a:stretch>
-            <a:fillRect/>
-          </a:stretch>
-        </p:blipFill>
-        <p:spPr>
-          <a:xfrm>
-            <a:off x="10024567" y="6062197"/>
-            <a:ext cx="1965960" cy="631211"/>
-          </a:xfrm>
-          <a:prstGeom prst="rect">
-            <a:avLst/>
-          </a:prstGeom>
-        </p:spPr>
-      </p:pic>
     </p:spTree>
   </p:cSld>
   <p:clrMapOvr>
@@ -5342,30 +5318,6 @@
           </a:p>
         </p:txBody>
       </p:sp>
-      <p:pic>
-        <p:nvPicPr>
-          <p:cNvPr id="25" name="Picture 24" descr="logo_horiz.png"/>
-          <p:cNvPicPr>
-            <a:picLocks noChangeAspect="1"/>
-          </p:cNvPicPr>
-          <p:nvPr/>
-        </p:nvPicPr>
-        <p:blipFill>
-          <a:blip r:embed="rId3"/>
-          <a:stretch>
-            <a:fillRect/>
-          </a:stretch>
-        </p:blipFill>
-        <p:spPr>
-          <a:xfrm>
-            <a:off x="10024567" y="6062197"/>
-            <a:ext cx="1965960" cy="631211"/>
-          </a:xfrm>
-          <a:prstGeom prst="rect">
-            <a:avLst/>
-          </a:prstGeom>
-        </p:spPr>
-      </p:pic>
     </p:spTree>
   </p:cSld>
   <p:clrMapOvr>
@@ -6398,30 +6350,6 @@
           </a:p>
         </p:txBody>
       </p:sp>
-      <p:pic>
-        <p:nvPicPr>
-          <p:cNvPr id="25" name="Picture 24" descr="logo_horiz.png"/>
-          <p:cNvPicPr>
-            <a:picLocks noChangeAspect="1"/>
-          </p:cNvPicPr>
-          <p:nvPr/>
-        </p:nvPicPr>
-        <p:blipFill>
-          <a:blip r:embed="rId3"/>
-          <a:stretch>
-            <a:fillRect/>
-          </a:stretch>
-        </p:blipFill>
-        <p:spPr>
-          <a:xfrm>
-            <a:off x="10024567" y="6062197"/>
-            <a:ext cx="1965960" cy="631211"/>
-          </a:xfrm>
-          <a:prstGeom prst="rect">
-            <a:avLst/>
-          </a:prstGeom>
-        </p:spPr>
-      </p:pic>
     </p:spTree>
   </p:cSld>
   <p:clrMapOvr>
@@ -7454,30 +7382,6 @@
           </a:p>
         </p:txBody>
       </p:sp>
-      <p:pic>
-        <p:nvPicPr>
-          <p:cNvPr id="25" name="Picture 24" descr="logo_horiz.png"/>
-          <p:cNvPicPr>
-            <a:picLocks noChangeAspect="1"/>
-          </p:cNvPicPr>
-          <p:nvPr/>
-        </p:nvPicPr>
-        <p:blipFill>
-          <a:blip r:embed="rId3"/>
-          <a:stretch>
-            <a:fillRect/>
-          </a:stretch>
-        </p:blipFill>
-        <p:spPr>
-          <a:xfrm>
-            <a:off x="10024567" y="6062197"/>
-            <a:ext cx="1965960" cy="631211"/>
-          </a:xfrm>
-          <a:prstGeom prst="rect">
-            <a:avLst/>
-          </a:prstGeom>
-        </p:spPr>
-      </p:pic>
     </p:spTree>
   </p:cSld>
   <p:clrMapOvr>
@@ -8774,30 +8678,6 @@
           </a:p>
         </p:txBody>
       </p:sp>
-      <p:pic>
-        <p:nvPicPr>
-          <p:cNvPr id="45" name="Picture 44" descr="logo_horiz.png"/>
-          <p:cNvPicPr>
-            <a:picLocks noChangeAspect="1"/>
-          </p:cNvPicPr>
-          <p:nvPr/>
-        </p:nvPicPr>
-        <p:blipFill>
-          <a:blip r:embed="rId3"/>
-          <a:stretch>
-            <a:fillRect/>
-          </a:stretch>
-        </p:blipFill>
-        <p:spPr>
-          <a:xfrm>
-            <a:off x="10024567" y="6062197"/>
-            <a:ext cx="1965960" cy="631211"/>
-          </a:xfrm>
-          <a:prstGeom prst="rect">
-            <a:avLst/>
-          </a:prstGeom>
-        </p:spPr>
-      </p:pic>
     </p:spTree>
   </p:cSld>
   <p:clrMapOvr>
@@ -10342,30 +10222,6 @@
           </a:p>
         </p:txBody>
       </p:sp>
-      <p:pic>
-        <p:nvPicPr>
-          <p:cNvPr id="29" name="Picture 28" descr="logo_horiz.png"/>
-          <p:cNvPicPr>
-            <a:picLocks noChangeAspect="1"/>
-          </p:cNvPicPr>
-          <p:nvPr/>
-        </p:nvPicPr>
-        <p:blipFill>
-          <a:blip r:embed="rId5"/>
-          <a:stretch>
-            <a:fillRect/>
-          </a:stretch>
-        </p:blipFill>
-        <p:spPr>
-          <a:xfrm>
-            <a:off x="10024567" y="6062197"/>
-            <a:ext cx="1965960" cy="631211"/>
-          </a:xfrm>
-          <a:prstGeom prst="rect">
-            <a:avLst/>
-          </a:prstGeom>
-        </p:spPr>
-      </p:pic>
     </p:spTree>
   </p:cSld>
   <p:clrMapOvr>

</xml_diff>

<commit_message>
Contact slide: full-width layout for office cards, no right panel photo
</commit_message>
<xml_diff>
--- a/sendacredit_propuesta.pptx
+++ b/sendacredit_propuesta.pptx
@@ -9094,9 +9094,95 @@
           </a:prstGeom>
         </p:spPr>
       </p:pic>
+      <p:sp>
+        <p:nvSpPr>
+          <p:cNvPr id="3" name="Rectangle 2"/>
+          <p:cNvSpPr/>
+          <p:nvPr/>
+        </p:nvSpPr>
+        <p:spPr>
+          <a:xfrm>
+            <a:off x="0" y="0"/>
+            <a:ext cx="63500" cy="6858000"/>
+          </a:xfrm>
+          <a:prstGeom prst="rect">
+            <a:avLst/>
+          </a:prstGeom>
+          <a:solidFill>
+            <a:srgbClr val="13B9BF"/>
+          </a:solidFill>
+          <a:ln>
+            <a:noFill/>
+          </a:ln>
+        </p:spPr>
+        <p:style>
+          <a:lnRef idx="1">
+            <a:schemeClr val="accent1"/>
+          </a:lnRef>
+          <a:fillRef idx="3">
+            <a:schemeClr val="accent1"/>
+          </a:fillRef>
+          <a:effectRef idx="2">
+            <a:schemeClr val="accent1"/>
+          </a:effectRef>
+          <a:fontRef idx="minor">
+            <a:schemeClr val="lt1"/>
+          </a:fontRef>
+        </p:style>
+        <p:txBody>
+          <a:bodyPr rtlCol="0" anchor="ctr"/>
+          <a:lstStyle/>
+          <a:p>
+            <a:pPr algn="ctr"/>
+          </a:p>
+        </p:txBody>
+      </p:sp>
+      <p:sp>
+        <p:nvSpPr>
+          <p:cNvPr id="4" name="Rectangle 3"/>
+          <p:cNvSpPr/>
+          <p:nvPr/>
+        </p:nvSpPr>
+        <p:spPr>
+          <a:xfrm>
+            <a:off x="0" y="0"/>
+            <a:ext cx="12191695" cy="50800"/>
+          </a:xfrm>
+          <a:prstGeom prst="rect">
+            <a:avLst/>
+          </a:prstGeom>
+          <a:solidFill>
+            <a:srgbClr val="2FDFE5"/>
+          </a:solidFill>
+          <a:ln>
+            <a:noFill/>
+          </a:ln>
+        </p:spPr>
+        <p:style>
+          <a:lnRef idx="1">
+            <a:schemeClr val="accent1"/>
+          </a:lnRef>
+          <a:fillRef idx="3">
+            <a:schemeClr val="accent1"/>
+          </a:fillRef>
+          <a:effectRef idx="2">
+            <a:schemeClr val="accent1"/>
+          </a:effectRef>
+          <a:fontRef idx="minor">
+            <a:schemeClr val="lt1"/>
+          </a:fontRef>
+        </p:style>
+        <p:txBody>
+          <a:bodyPr rtlCol="0" anchor="ctr"/>
+          <a:lstStyle/>
+          <a:p>
+            <a:pPr algn="ctr"/>
+          </a:p>
+        </p:txBody>
+      </p:sp>
       <p:pic>
         <p:nvPicPr>
-          <p:cNvPr id="3" name="Picture 2" descr="contact_panel.png"/>
+          <p:cNvPr id="5" name="Picture 4" descr="logo_round.png"/>
           <p:cNvPicPr>
             <a:picLocks noChangeAspect="1"/>
           </p:cNvPicPr>
@@ -9110,102 +9196,14 @@
         </p:blipFill>
         <p:spPr>
           <a:xfrm>
-            <a:off x="7071055" y="0"/>
-            <a:ext cx="5120640" cy="6858000"/>
+            <a:off x="502920" y="274320"/>
+            <a:ext cx="1024128" cy="593994"/>
           </a:xfrm>
           <a:prstGeom prst="rect">
             <a:avLst/>
           </a:prstGeom>
         </p:spPr>
       </p:pic>
-      <p:sp>
-        <p:nvSpPr>
-          <p:cNvPr id="4" name="Rectangle 3"/>
-          <p:cNvSpPr/>
-          <p:nvPr/>
-        </p:nvSpPr>
-        <p:spPr>
-          <a:xfrm>
-            <a:off x="7071055" y="0"/>
-            <a:ext cx="5120640" cy="6858000"/>
-          </a:xfrm>
-          <a:prstGeom prst="rect">
-            <a:avLst/>
-          </a:prstGeom>
-          <a:solidFill>
-            <a:srgbClr val="060E24">
-              <a:alpha val="8000"/>
-            </a:srgbClr>
-          </a:solidFill>
-          <a:ln>
-            <a:noFill/>
-          </a:ln>
-        </p:spPr>
-        <p:style>
-          <a:lnRef idx="1">
-            <a:schemeClr val="accent1"/>
-          </a:lnRef>
-          <a:fillRef idx="3">
-            <a:schemeClr val="accent1"/>
-          </a:fillRef>
-          <a:effectRef idx="2">
-            <a:schemeClr val="accent1"/>
-          </a:effectRef>
-          <a:fontRef idx="minor">
-            <a:schemeClr val="lt1"/>
-          </a:fontRef>
-        </p:style>
-        <p:txBody>
-          <a:bodyPr rtlCol="0" anchor="ctr"/>
-          <a:lstStyle/>
-          <a:p>
-            <a:pPr algn="ctr"/>
-          </a:p>
-        </p:txBody>
-      </p:sp>
-      <p:sp>
-        <p:nvSpPr>
-          <p:cNvPr id="5" name="Rectangle 4"/>
-          <p:cNvSpPr/>
-          <p:nvPr/>
-        </p:nvSpPr>
-        <p:spPr>
-          <a:xfrm>
-            <a:off x="7032955" y="0"/>
-            <a:ext cx="38100" cy="6858000"/>
-          </a:xfrm>
-          <a:prstGeom prst="rect">
-            <a:avLst/>
-          </a:prstGeom>
-          <a:solidFill>
-            <a:srgbClr val="2FDFE5"/>
-          </a:solidFill>
-          <a:ln>
-            <a:noFill/>
-          </a:ln>
-        </p:spPr>
-        <p:style>
-          <a:lnRef idx="1">
-            <a:schemeClr val="accent1"/>
-          </a:lnRef>
-          <a:fillRef idx="3">
-            <a:schemeClr val="accent1"/>
-          </a:fillRef>
-          <a:effectRef idx="2">
-            <a:schemeClr val="accent1"/>
-          </a:effectRef>
-          <a:fontRef idx="minor">
-            <a:schemeClr val="lt1"/>
-          </a:fontRef>
-        </p:style>
-        <p:txBody>
-          <a:bodyPr rtlCol="0" anchor="ctr"/>
-          <a:lstStyle/>
-          <a:p>
-            <a:pPr algn="ctr"/>
-          </a:p>
-        </p:txBody>
-      </p:sp>
       <p:sp>
         <p:nvSpPr>
           <p:cNvPr id="6" name="Rectangle 5"/>
@@ -9214,117 +9212,7 @@
         </p:nvSpPr>
         <p:spPr>
           <a:xfrm>
-            <a:off x="0" y="0"/>
-            <a:ext cx="63500" cy="6858000"/>
-          </a:xfrm>
-          <a:prstGeom prst="rect">
-            <a:avLst/>
-          </a:prstGeom>
-          <a:solidFill>
-            <a:srgbClr val="13B9BF"/>
-          </a:solidFill>
-          <a:ln>
-            <a:noFill/>
-          </a:ln>
-        </p:spPr>
-        <p:style>
-          <a:lnRef idx="1">
-            <a:schemeClr val="accent1"/>
-          </a:lnRef>
-          <a:fillRef idx="3">
-            <a:schemeClr val="accent1"/>
-          </a:fillRef>
-          <a:effectRef idx="2">
-            <a:schemeClr val="accent1"/>
-          </a:effectRef>
-          <a:fontRef idx="minor">
-            <a:schemeClr val="lt1"/>
-          </a:fontRef>
-        </p:style>
-        <p:txBody>
-          <a:bodyPr rtlCol="0" anchor="ctr"/>
-          <a:lstStyle/>
-          <a:p>
-            <a:pPr algn="ctr"/>
-          </a:p>
-        </p:txBody>
-      </p:sp>
-      <p:sp>
-        <p:nvSpPr>
-          <p:cNvPr id="7" name="Rectangle 6"/>
-          <p:cNvSpPr/>
-          <p:nvPr/>
-        </p:nvSpPr>
-        <p:spPr>
-          <a:xfrm>
-            <a:off x="0" y="0"/>
-            <a:ext cx="12191695" cy="50800"/>
-          </a:xfrm>
-          <a:prstGeom prst="rect">
-            <a:avLst/>
-          </a:prstGeom>
-          <a:solidFill>
-            <a:srgbClr val="2FDFE5"/>
-          </a:solidFill>
-          <a:ln>
-            <a:noFill/>
-          </a:ln>
-        </p:spPr>
-        <p:style>
-          <a:lnRef idx="1">
-            <a:schemeClr val="accent1"/>
-          </a:lnRef>
-          <a:fillRef idx="3">
-            <a:schemeClr val="accent1"/>
-          </a:fillRef>
-          <a:effectRef idx="2">
-            <a:schemeClr val="accent1"/>
-          </a:effectRef>
-          <a:fontRef idx="minor">
-            <a:schemeClr val="lt1"/>
-          </a:fontRef>
-        </p:style>
-        <p:txBody>
-          <a:bodyPr rtlCol="0" anchor="ctr"/>
-          <a:lstStyle/>
-          <a:p>
-            <a:pPr algn="ctr"/>
-          </a:p>
-        </p:txBody>
-      </p:sp>
-      <p:pic>
-        <p:nvPicPr>
-          <p:cNvPr id="8" name="Picture 7" descr="logo_round.png"/>
-          <p:cNvPicPr>
-            <a:picLocks noChangeAspect="1"/>
-          </p:cNvPicPr>
-          <p:nvPr/>
-        </p:nvPicPr>
-        <p:blipFill>
-          <a:blip r:embed="rId4"/>
-          <a:stretch>
-            <a:fillRect/>
-          </a:stretch>
-        </p:blipFill>
-        <p:spPr>
-          <a:xfrm>
-            <a:off x="502920" y="310896"/>
-            <a:ext cx="1024128" cy="593994"/>
-          </a:xfrm>
-          <a:prstGeom prst="rect">
-            <a:avLst/>
-          </a:prstGeom>
-        </p:spPr>
-      </p:pic>
-      <p:sp>
-        <p:nvSpPr>
-          <p:cNvPr id="9" name="Rectangle 8"/>
-          <p:cNvSpPr/>
-          <p:nvPr/>
-        </p:nvSpPr>
-        <p:spPr>
-          <a:xfrm>
-            <a:off x="502920" y="1417320"/>
+            <a:off x="502920" y="1389888"/>
             <a:ext cx="1554480" cy="274320"/>
           </a:xfrm>
           <a:prstGeom prst="rect">
@@ -9369,14 +9257,14 @@
       </p:sp>
       <p:sp>
         <p:nvSpPr>
-          <p:cNvPr id="10" name="TextBox 9"/>
+          <p:cNvPr id="7" name="TextBox 6"/>
           <p:cNvSpPr txBox="1"/>
           <p:nvPr/>
         </p:nvSpPr>
         <p:spPr>
           <a:xfrm>
-            <a:off x="502920" y="1801368"/>
-            <a:ext cx="5852160" cy="1051560"/>
+            <a:off x="502920" y="1755648"/>
+            <a:ext cx="11323015" cy="1005840"/>
           </a:xfrm>
           <a:prstGeom prst="rect">
             <a:avLst/>
@@ -9391,7 +9279,7 @@
           <a:p>
             <a:pPr algn="l"/>
             <a:r>
-              <a:rPr sz="3000" b="1">
+              <a:rPr sz="3800" b="1">
                 <a:solidFill>
                   <a:srgbClr val="FFFFFF"/>
                 </a:solidFill>
@@ -9402,7 +9290,7 @@
           <a:p>
             <a:pPr algn="l"/>
             <a:r>
-              <a:rPr sz="3000" b="1">
+              <a:rPr sz="3800" b="1">
                 <a:solidFill>
                   <a:srgbClr val="2FDFE5"/>
                 </a:solidFill>
@@ -9414,14 +9302,14 @@
       </p:sp>
       <p:sp>
         <p:nvSpPr>
-          <p:cNvPr id="11" name="Rectangle 10"/>
+          <p:cNvPr id="8" name="Rectangle 7"/>
           <p:cNvSpPr/>
           <p:nvPr/>
         </p:nvSpPr>
         <p:spPr>
           <a:xfrm>
-            <a:off x="502920" y="2834640"/>
-            <a:ext cx="3474720" cy="31750"/>
+            <a:off x="502920" y="2816352"/>
+            <a:ext cx="11323015" cy="31750"/>
           </a:xfrm>
           <a:prstGeom prst="rect">
             <a:avLst/>
@@ -9457,14 +9345,14 @@
       </p:sp>
       <p:sp>
         <p:nvSpPr>
-          <p:cNvPr id="12" name="TextBox 11"/>
+          <p:cNvPr id="9" name="TextBox 8"/>
           <p:cNvSpPr txBox="1"/>
           <p:nvPr/>
         </p:nvSpPr>
         <p:spPr>
           <a:xfrm>
-            <a:off x="502920" y="2971800"/>
-            <a:ext cx="5669280" cy="402336"/>
+            <a:off x="502920" y="2944368"/>
+            <a:ext cx="11323015" cy="402336"/>
           </a:xfrm>
           <a:prstGeom prst="rect">
             <a:avLst/>
@@ -9479,7 +9367,7 @@
           <a:p>
             <a:pPr algn="l"/>
             <a:r>
-              <a:rPr sz="1100" i="1">
+              <a:rPr sz="1300" i="1">
                 <a:solidFill>
                   <a:srgbClr val="C0E8FF"/>
                 </a:solidFill>
@@ -9491,14 +9379,14 @@
       </p:sp>
       <p:sp>
         <p:nvSpPr>
-          <p:cNvPr id="13" name="Rectangle 12"/>
+          <p:cNvPr id="10" name="Rectangle 9"/>
           <p:cNvSpPr/>
           <p:nvPr/>
         </p:nvSpPr>
         <p:spPr>
           <a:xfrm>
-            <a:off x="502920" y="3401568"/>
-            <a:ext cx="1965960" cy="1920240"/>
+            <a:off x="502920" y="3547872"/>
+            <a:ext cx="3603650" cy="2514600"/>
           </a:xfrm>
           <a:prstGeom prst="rect">
             <a:avLst/>
@@ -9536,14 +9424,14 @@
       </p:sp>
       <p:sp>
         <p:nvSpPr>
-          <p:cNvPr id="14" name="Rectangle 13"/>
+          <p:cNvPr id="11" name="Rectangle 10"/>
           <p:cNvSpPr/>
           <p:nvPr/>
         </p:nvSpPr>
         <p:spPr>
           <a:xfrm>
-            <a:off x="502920" y="3401568"/>
-            <a:ext cx="1965960" cy="63500"/>
+            <a:off x="502920" y="3547872"/>
+            <a:ext cx="3603650" cy="63500"/>
           </a:xfrm>
           <a:prstGeom prst="rect">
             <a:avLst/>
@@ -9579,14 +9467,14 @@
       </p:sp>
       <p:sp>
         <p:nvSpPr>
-          <p:cNvPr id="15" name="TextBox 14"/>
+          <p:cNvPr id="12" name="TextBox 11"/>
           <p:cNvSpPr txBox="1"/>
           <p:nvPr/>
         </p:nvSpPr>
         <p:spPr>
           <a:xfrm>
-            <a:off x="630936" y="3557016"/>
-            <a:ext cx="1709928" cy="310896"/>
+            <a:off x="704088" y="3767328"/>
+            <a:ext cx="3201314" cy="384048"/>
           </a:xfrm>
           <a:prstGeom prst="rect">
             <a:avLst/>
@@ -9601,7 +9489,7 @@
           <a:p>
             <a:pPr algn="l"/>
             <a:r>
-              <a:rPr sz="1300" b="1">
+              <a:rPr sz="1700" b="1">
                 <a:solidFill>
                   <a:srgbClr val="2FDFE5"/>
                 </a:solidFill>
@@ -9613,14 +9501,14 @@
       </p:sp>
       <p:sp>
         <p:nvSpPr>
-          <p:cNvPr id="16" name="Rectangle 15"/>
+          <p:cNvPr id="13" name="Rectangle 12"/>
           <p:cNvSpPr/>
           <p:nvPr/>
         </p:nvSpPr>
         <p:spPr>
           <a:xfrm>
-            <a:off x="630936" y="3904488"/>
-            <a:ext cx="1709928" cy="12700"/>
+            <a:off x="667512" y="4206240"/>
+            <a:ext cx="3274466" cy="12700"/>
           </a:xfrm>
           <a:prstGeom prst="rect">
             <a:avLst/>
@@ -9656,21 +9544,21 @@
       </p:sp>
       <p:sp>
         <p:nvSpPr>
-          <p:cNvPr id="17" name="TextBox 16"/>
+          <p:cNvPr id="14" name="TextBox 13"/>
           <p:cNvSpPr txBox="1"/>
           <p:nvPr/>
         </p:nvSpPr>
         <p:spPr>
           <a:xfrm>
-            <a:off x="630936" y="3980688"/>
-            <a:ext cx="1709928" cy="1234440"/>
+            <a:off x="704088" y="4333240"/>
+            <a:ext cx="3201314" cy="1572768"/>
           </a:xfrm>
           <a:prstGeom prst="rect">
             <a:avLst/>
           </a:prstGeom>
           <a:noFill/>
         </p:spPr>
-        <p:txBody lIns="38100" tIns="25400" rIns="38100" bIns="25400">
+        <p:txBody lIns="38100" tIns="38100" rIns="38100" bIns="38100">
           <a:bodyPr wrap="square">
             <a:spAutoFit/>
           </a:bodyPr>
@@ -9678,11 +9566,11 @@
           <a:p>
             <a:pPr algn="l">
               <a:spcBef>
-                <a:spcPts val="300"/>
+                <a:spcPts val="800"/>
               </a:spcBef>
             </a:pPr>
             <a:r>
-              <a:rPr sz="1000">
+              <a:rPr sz="1300">
                 <a:solidFill>
                   <a:srgbClr val="D8EAFF"/>
                 </a:solidFill>
@@ -9693,11 +9581,11 @@
           <a:p>
             <a:pPr algn="l">
               <a:spcBef>
-                <a:spcPts val="300"/>
+                <a:spcPts val="800"/>
               </a:spcBef>
             </a:pPr>
             <a:r>
-              <a:rPr sz="1000">
+              <a:rPr sz="1300">
                 <a:solidFill>
                   <a:srgbClr val="2FDFE5"/>
                 </a:solidFill>
@@ -9708,11 +9596,11 @@
           <a:p>
             <a:pPr algn="l">
               <a:spcBef>
-                <a:spcPts val="300"/>
+                <a:spcPts val="800"/>
               </a:spcBef>
             </a:pPr>
             <a:r>
-              <a:rPr sz="1000">
+              <a:rPr sz="1300">
                 <a:solidFill>
                   <a:srgbClr val="80A8CC"/>
                 </a:solidFill>
@@ -9724,14 +9612,14 @@
       </p:sp>
       <p:sp>
         <p:nvSpPr>
-          <p:cNvPr id="18" name="Rectangle 17"/>
+          <p:cNvPr id="15" name="Rectangle 14"/>
           <p:cNvSpPr/>
           <p:nvPr/>
         </p:nvSpPr>
         <p:spPr>
           <a:xfrm>
-            <a:off x="2633472" y="3401568"/>
-            <a:ext cx="1965960" cy="1920240"/>
+            <a:off x="4380890" y="3547872"/>
+            <a:ext cx="3603650" cy="2514600"/>
           </a:xfrm>
           <a:prstGeom prst="rect">
             <a:avLst/>
@@ -9769,14 +9657,14 @@
       </p:sp>
       <p:sp>
         <p:nvSpPr>
-          <p:cNvPr id="19" name="Rectangle 18"/>
+          <p:cNvPr id="16" name="Rectangle 15"/>
           <p:cNvSpPr/>
           <p:nvPr/>
         </p:nvSpPr>
         <p:spPr>
           <a:xfrm>
-            <a:off x="2633472" y="3401568"/>
-            <a:ext cx="1965960" cy="63500"/>
+            <a:off x="4380890" y="3547872"/>
+            <a:ext cx="3603650" cy="63500"/>
           </a:xfrm>
           <a:prstGeom prst="rect">
             <a:avLst/>
@@ -9812,14 +9700,14 @@
       </p:sp>
       <p:sp>
         <p:nvSpPr>
-          <p:cNvPr id="20" name="TextBox 19"/>
+          <p:cNvPr id="17" name="TextBox 16"/>
           <p:cNvSpPr txBox="1"/>
           <p:nvPr/>
         </p:nvSpPr>
         <p:spPr>
           <a:xfrm>
-            <a:off x="2761488" y="3557016"/>
-            <a:ext cx="1709928" cy="310896"/>
+            <a:off x="4582058" y="3767328"/>
+            <a:ext cx="3201314" cy="384048"/>
           </a:xfrm>
           <a:prstGeom prst="rect">
             <a:avLst/>
@@ -9834,7 +9722,7 @@
           <a:p>
             <a:pPr algn="l"/>
             <a:r>
-              <a:rPr sz="1300" b="1">
+              <a:rPr sz="1700" b="1">
                 <a:solidFill>
                   <a:srgbClr val="2FDFE5"/>
                 </a:solidFill>
@@ -9846,14 +9734,14 @@
       </p:sp>
       <p:sp>
         <p:nvSpPr>
-          <p:cNvPr id="21" name="Rectangle 20"/>
+          <p:cNvPr id="18" name="Rectangle 17"/>
           <p:cNvSpPr/>
           <p:nvPr/>
         </p:nvSpPr>
         <p:spPr>
           <a:xfrm>
-            <a:off x="2761488" y="3904488"/>
-            <a:ext cx="1709928" cy="12700"/>
+            <a:off x="4545482" y="4206240"/>
+            <a:ext cx="3274466" cy="12700"/>
           </a:xfrm>
           <a:prstGeom prst="rect">
             <a:avLst/>
@@ -9889,21 +9777,21 @@
       </p:sp>
       <p:sp>
         <p:nvSpPr>
-          <p:cNvPr id="22" name="TextBox 21"/>
+          <p:cNvPr id="19" name="TextBox 18"/>
           <p:cNvSpPr txBox="1"/>
           <p:nvPr/>
         </p:nvSpPr>
         <p:spPr>
           <a:xfrm>
-            <a:off x="2761488" y="3980688"/>
-            <a:ext cx="1709928" cy="1234440"/>
+            <a:off x="4582058" y="4333240"/>
+            <a:ext cx="3201314" cy="1572768"/>
           </a:xfrm>
           <a:prstGeom prst="rect">
             <a:avLst/>
           </a:prstGeom>
           <a:noFill/>
         </p:spPr>
-        <p:txBody lIns="38100" tIns="25400" rIns="38100" bIns="25400">
+        <p:txBody lIns="38100" tIns="38100" rIns="38100" bIns="38100">
           <a:bodyPr wrap="square">
             <a:spAutoFit/>
           </a:bodyPr>
@@ -9911,11 +9799,11 @@
           <a:p>
             <a:pPr algn="l">
               <a:spcBef>
-                <a:spcPts val="300"/>
+                <a:spcPts val="800"/>
               </a:spcBef>
             </a:pPr>
             <a:r>
-              <a:rPr sz="1000">
+              <a:rPr sz="1300">
                 <a:solidFill>
                   <a:srgbClr val="D8EAFF"/>
                 </a:solidFill>
@@ -9926,11 +9814,11 @@
           <a:p>
             <a:pPr algn="l">
               <a:spcBef>
-                <a:spcPts val="300"/>
+                <a:spcPts val="800"/>
               </a:spcBef>
             </a:pPr>
             <a:r>
-              <a:rPr sz="1000">
+              <a:rPr sz="1300">
                 <a:solidFill>
                   <a:srgbClr val="2FDFE5"/>
                 </a:solidFill>
@@ -9941,11 +9829,11 @@
           <a:p>
             <a:pPr algn="l">
               <a:spcBef>
-                <a:spcPts val="300"/>
+                <a:spcPts val="800"/>
               </a:spcBef>
             </a:pPr>
             <a:r>
-              <a:rPr sz="1000">
+              <a:rPr sz="1300">
                 <a:solidFill>
                   <a:srgbClr val="80A8CC"/>
                 </a:solidFill>
@@ -9957,14 +9845,14 @@
       </p:sp>
       <p:sp>
         <p:nvSpPr>
-          <p:cNvPr id="23" name="Rectangle 22"/>
+          <p:cNvPr id="20" name="Rectangle 19"/>
           <p:cNvSpPr/>
           <p:nvPr/>
         </p:nvSpPr>
         <p:spPr>
           <a:xfrm>
-            <a:off x="4764024" y="3401568"/>
-            <a:ext cx="1965960" cy="1920240"/>
+            <a:off x="8258860" y="3547872"/>
+            <a:ext cx="3603650" cy="2514600"/>
           </a:xfrm>
           <a:prstGeom prst="rect">
             <a:avLst/>
@@ -10002,14 +9890,14 @@
       </p:sp>
       <p:sp>
         <p:nvSpPr>
-          <p:cNvPr id="24" name="Rectangle 23"/>
+          <p:cNvPr id="21" name="Rectangle 20"/>
           <p:cNvSpPr/>
           <p:nvPr/>
         </p:nvSpPr>
         <p:spPr>
           <a:xfrm>
-            <a:off x="4764024" y="3401568"/>
-            <a:ext cx="1965960" cy="63500"/>
+            <a:off x="8258860" y="3547872"/>
+            <a:ext cx="3603650" cy="63500"/>
           </a:xfrm>
           <a:prstGeom prst="rect">
             <a:avLst/>
@@ -10045,14 +9933,14 @@
       </p:sp>
       <p:sp>
         <p:nvSpPr>
-          <p:cNvPr id="25" name="TextBox 24"/>
+          <p:cNvPr id="22" name="TextBox 21"/>
           <p:cNvSpPr txBox="1"/>
           <p:nvPr/>
         </p:nvSpPr>
         <p:spPr>
           <a:xfrm>
-            <a:off x="4892040" y="3557016"/>
-            <a:ext cx="1709928" cy="310896"/>
+            <a:off x="8460028" y="3767328"/>
+            <a:ext cx="3201314" cy="384048"/>
           </a:xfrm>
           <a:prstGeom prst="rect">
             <a:avLst/>
@@ -10067,7 +9955,7 @@
           <a:p>
             <a:pPr algn="l"/>
             <a:r>
-              <a:rPr sz="1300" b="1">
+              <a:rPr sz="1700" b="1">
                 <a:solidFill>
                   <a:srgbClr val="2FDFE5"/>
                 </a:solidFill>
@@ -10079,14 +9967,14 @@
       </p:sp>
       <p:sp>
         <p:nvSpPr>
-          <p:cNvPr id="26" name="Rectangle 25"/>
+          <p:cNvPr id="23" name="Rectangle 22"/>
           <p:cNvSpPr/>
           <p:nvPr/>
         </p:nvSpPr>
         <p:spPr>
           <a:xfrm>
-            <a:off x="4892040" y="3904488"/>
-            <a:ext cx="1709928" cy="12700"/>
+            <a:off x="8423452" y="4206240"/>
+            <a:ext cx="3274466" cy="12700"/>
           </a:xfrm>
           <a:prstGeom prst="rect">
             <a:avLst/>
@@ -10122,21 +10010,21 @@
       </p:sp>
       <p:sp>
         <p:nvSpPr>
-          <p:cNvPr id="27" name="TextBox 26"/>
+          <p:cNvPr id="24" name="TextBox 23"/>
           <p:cNvSpPr txBox="1"/>
           <p:nvPr/>
         </p:nvSpPr>
         <p:spPr>
           <a:xfrm>
-            <a:off x="4892040" y="3980688"/>
-            <a:ext cx="1709928" cy="1234440"/>
+            <a:off x="8460028" y="4333240"/>
+            <a:ext cx="3201314" cy="1572768"/>
           </a:xfrm>
           <a:prstGeom prst="rect">
             <a:avLst/>
           </a:prstGeom>
           <a:noFill/>
         </p:spPr>
-        <p:txBody lIns="38100" tIns="25400" rIns="38100" bIns="25400">
+        <p:txBody lIns="38100" tIns="38100" rIns="38100" bIns="38100">
           <a:bodyPr wrap="square">
             <a:spAutoFit/>
           </a:bodyPr>
@@ -10144,11 +10032,11 @@
           <a:p>
             <a:pPr algn="l">
               <a:spcBef>
-                <a:spcPts val="300"/>
+                <a:spcPts val="800"/>
               </a:spcBef>
             </a:pPr>
             <a:r>
-              <a:rPr sz="1000">
+              <a:rPr sz="1300">
                 <a:solidFill>
                   <a:srgbClr val="D8EAFF"/>
                 </a:solidFill>
@@ -10159,11 +10047,11 @@
           <a:p>
             <a:pPr algn="l">
               <a:spcBef>
-                <a:spcPts val="300"/>
+                <a:spcPts val="800"/>
               </a:spcBef>
             </a:pPr>
             <a:r>
-              <a:rPr sz="1000">
+              <a:rPr sz="1300">
                 <a:solidFill>
                   <a:srgbClr val="2FDFE5"/>
                 </a:solidFill>
@@ -10174,11 +10062,11 @@
           <a:p>
             <a:pPr algn="l">
               <a:spcBef>
-                <a:spcPts val="300"/>
+                <a:spcPts val="800"/>
               </a:spcBef>
             </a:pPr>
             <a:r>
-              <a:rPr sz="1000">
+              <a:rPr sz="1300">
                 <a:solidFill>
                   <a:srgbClr val="80A8CC"/>
                 </a:solidFill>
@@ -10190,14 +10078,14 @@
       </p:sp>
       <p:sp>
         <p:nvSpPr>
-          <p:cNvPr id="28" name="TextBox 27"/>
+          <p:cNvPr id="25" name="TextBox 24"/>
           <p:cNvSpPr txBox="1"/>
           <p:nvPr/>
         </p:nvSpPr>
         <p:spPr>
           <a:xfrm>
-            <a:off x="502920" y="6419088"/>
-            <a:ext cx="4572000" cy="274320"/>
+            <a:off x="502920" y="6437376"/>
+            <a:ext cx="5486400" cy="274320"/>
           </a:xfrm>
           <a:prstGeom prst="rect">
             <a:avLst/>
@@ -10212,7 +10100,7 @@
           <a:p>
             <a:pPr algn="l"/>
             <a:r>
-              <a:rPr sz="950">
+              <a:rPr sz="1000">
                 <a:solidFill>
                   <a:srgbClr val="2FDFE5"/>
                 </a:solidFill>
@@ -10251,7 +10139,7 @@
                                 <p:cBhvr>
                                   <p:cTn id="6" dur="450" fill="hold"/>
                                   <p:tgtEl>
-                                    <p:spTgt spid="13"/>
+                                    <p:spTgt spid="10"/>
                                   </p:tgtEl>
                                 </p:cBhvr>
                               </p:animEffect>
@@ -10268,7 +10156,7 @@
                                 <p:cBhvr>
                                   <p:cTn id="8" dur="450" fill="hold"/>
                                   <p:tgtEl>
-                                    <p:spTgt spid="18"/>
+                                    <p:spTgt spid="15"/>
                                   </p:tgtEl>
                                 </p:cBhvr>
                               </p:animEffect>
@@ -10285,7 +10173,7 @@
                                 <p:cBhvr>
                                   <p:cTn id="10" dur="450" fill="hold"/>
                                   <p:tgtEl>
-                                    <p:spTgt spid="23"/>
+                                    <p:spTgt spid="20"/>
                                   </p:tgtEl>
                                 </p:cBhvr>
                               </p:animEffect>

</xml_diff>

<commit_message>
Fix contact slide: line below cartera, restore original gradients and logo shapes
</commit_message>
<xml_diff>
--- a/sendacredit_propuesta.pptx
+++ b/sendacredit_propuesta.pptx
@@ -9264,7 +9264,7 @@
         <p:spPr>
           <a:xfrm>
             <a:off x="502920" y="1755648"/>
-            <a:ext cx="11323015" cy="1005840"/>
+            <a:ext cx="11323015" cy="1280160"/>
           </a:xfrm>
           <a:prstGeom prst="rect">
             <a:avLst/>
@@ -9308,7 +9308,7 @@
         </p:nvSpPr>
         <p:spPr>
           <a:xfrm>
-            <a:off x="502920" y="2816352"/>
+            <a:off x="502920" y="3127248"/>
             <a:ext cx="11323015" cy="31750"/>
           </a:xfrm>
           <a:prstGeom prst="rect">
@@ -9351,8 +9351,8 @@
         </p:nvSpPr>
         <p:spPr>
           <a:xfrm>
-            <a:off x="502920" y="2944368"/>
-            <a:ext cx="11323015" cy="402336"/>
+            <a:off x="502920" y="3255264"/>
+            <a:ext cx="11323015" cy="365760"/>
           </a:xfrm>
           <a:prstGeom prst="rect">
             <a:avLst/>
@@ -9385,8 +9385,8 @@
         </p:nvSpPr>
         <p:spPr>
           <a:xfrm>
-            <a:off x="502920" y="3547872"/>
-            <a:ext cx="3603650" cy="2514600"/>
+            <a:off x="502920" y="3730752"/>
+            <a:ext cx="3603650" cy="2304288"/>
           </a:xfrm>
           <a:prstGeom prst="rect">
             <a:avLst/>
@@ -9430,7 +9430,7 @@
         </p:nvSpPr>
         <p:spPr>
           <a:xfrm>
-            <a:off x="502920" y="3547872"/>
+            <a:off x="502920" y="3730752"/>
             <a:ext cx="3603650" cy="63500"/>
           </a:xfrm>
           <a:prstGeom prst="rect">
@@ -9473,7 +9473,7 @@
         </p:nvSpPr>
         <p:spPr>
           <a:xfrm>
-            <a:off x="704088" y="3767328"/>
+            <a:off x="704088" y="3950208"/>
             <a:ext cx="3201314" cy="384048"/>
           </a:xfrm>
           <a:prstGeom prst="rect">
@@ -9507,7 +9507,7 @@
         </p:nvSpPr>
         <p:spPr>
           <a:xfrm>
-            <a:off x="667512" y="4206240"/>
+            <a:off x="667512" y="4389120"/>
             <a:ext cx="3274466" cy="12700"/>
           </a:xfrm>
           <a:prstGeom prst="rect">
@@ -9550,7 +9550,7 @@
         </p:nvSpPr>
         <p:spPr>
           <a:xfrm>
-            <a:off x="704088" y="4333240"/>
+            <a:off x="704088" y="4516120"/>
             <a:ext cx="3201314" cy="1572768"/>
           </a:xfrm>
           <a:prstGeom prst="rect">
@@ -9618,8 +9618,8 @@
         </p:nvSpPr>
         <p:spPr>
           <a:xfrm>
-            <a:off x="4380890" y="3547872"/>
-            <a:ext cx="3603650" cy="2514600"/>
+            <a:off x="4380890" y="3730752"/>
+            <a:ext cx="3603650" cy="2304288"/>
           </a:xfrm>
           <a:prstGeom prst="rect">
             <a:avLst/>
@@ -9663,7 +9663,7 @@
         </p:nvSpPr>
         <p:spPr>
           <a:xfrm>
-            <a:off x="4380890" y="3547872"/>
+            <a:off x="4380890" y="3730752"/>
             <a:ext cx="3603650" cy="63500"/>
           </a:xfrm>
           <a:prstGeom prst="rect">
@@ -9706,7 +9706,7 @@
         </p:nvSpPr>
         <p:spPr>
           <a:xfrm>
-            <a:off x="4582058" y="3767328"/>
+            <a:off x="4582058" y="3950208"/>
             <a:ext cx="3201314" cy="384048"/>
           </a:xfrm>
           <a:prstGeom prst="rect">
@@ -9740,7 +9740,7 @@
         </p:nvSpPr>
         <p:spPr>
           <a:xfrm>
-            <a:off x="4545482" y="4206240"/>
+            <a:off x="4545482" y="4389120"/>
             <a:ext cx="3274466" cy="12700"/>
           </a:xfrm>
           <a:prstGeom prst="rect">
@@ -9783,7 +9783,7 @@
         </p:nvSpPr>
         <p:spPr>
           <a:xfrm>
-            <a:off x="4582058" y="4333240"/>
+            <a:off x="4582058" y="4516120"/>
             <a:ext cx="3201314" cy="1572768"/>
           </a:xfrm>
           <a:prstGeom prst="rect">
@@ -9851,8 +9851,8 @@
         </p:nvSpPr>
         <p:spPr>
           <a:xfrm>
-            <a:off x="8258860" y="3547872"/>
-            <a:ext cx="3603650" cy="2514600"/>
+            <a:off x="8258860" y="3730752"/>
+            <a:ext cx="3603650" cy="2304288"/>
           </a:xfrm>
           <a:prstGeom prst="rect">
             <a:avLst/>
@@ -9896,7 +9896,7 @@
         </p:nvSpPr>
         <p:spPr>
           <a:xfrm>
-            <a:off x="8258860" y="3547872"/>
+            <a:off x="8258860" y="3730752"/>
             <a:ext cx="3603650" cy="63500"/>
           </a:xfrm>
           <a:prstGeom prst="rect">
@@ -9939,7 +9939,7 @@
         </p:nvSpPr>
         <p:spPr>
           <a:xfrm>
-            <a:off x="8460028" y="3767328"/>
+            <a:off x="8460028" y="3950208"/>
             <a:ext cx="3201314" cy="384048"/>
           </a:xfrm>
           <a:prstGeom prst="rect">
@@ -9973,7 +9973,7 @@
         </p:nvSpPr>
         <p:spPr>
           <a:xfrm>
-            <a:off x="8423452" y="4206240"/>
+            <a:off x="8423452" y="4389120"/>
             <a:ext cx="3274466" cy="12700"/>
           </a:xfrm>
           <a:prstGeom prst="rect">
@@ -10016,7 +10016,7 @@
         </p:nvSpPr>
         <p:spPr>
           <a:xfrm>
-            <a:off x="8460028" y="4333240"/>
+            <a:off x="8460028" y="4516120"/>
             <a:ext cx="3201314" cy="1572768"/>
           </a:xfrm>
           <a:prstGeom prst="rect">

</xml_diff>

<commit_message>
Update content: logo bigger, FASE1 sub, FASE4 bullet, FASE5 feats + Sendacredit seal
</commit_message>
<xml_diff>
--- a/sendacredit_propuesta.pptx
+++ b/sendacredit_propuesta.pptx
@@ -3246,8 +3246,8 @@
         </p:blipFill>
         <p:spPr>
           <a:xfrm>
-            <a:off x="658368" y="347472"/>
-            <a:ext cx="1078992" cy="625815"/>
+            <a:off x="658368" y="182880"/>
+            <a:ext cx="1417320" cy="822046"/>
           </a:xfrm>
           <a:prstGeom prst="rect">
             <a:avLst/>
@@ -3751,7 +3751,7 @@
                   <a:srgbClr val="80A8CC"/>
                 </a:solidFill>
               </a:rPr>
-              <a:t>Cada caso entra en nuestro circuito con un punto de partida limpio, verificado y correctamente segmentado.</a:t>
+              <a:t>En un tiempo no superior a 48H para el inicio de las gestiones.</a:t>
             </a:r>
           </a:p>
         </p:txBody>
@@ -7377,7 +7377,7 @@
                   <a:srgbClr val="D8EAFF"/>
                 </a:solidFill>
               </a:rPr>
-              <a:t>Sin costes fijos: solo pagamos si recuperamos</a:t>
+              <a:t>Sin costes fijos: solo cobramos si recuperamos</a:t>
             </a:r>
           </a:p>
         </p:txBody>
@@ -8182,7 +8182,7 @@
                   <a:srgbClr val="FFFFFF"/>
                 </a:solidFill>
               </a:rPr>
-              <a:t>Acción disuasoria</a:t>
+              <a:t>Valoración y compra de carteras</a:t>
             </a:r>
           </a:p>
         </p:txBody>
@@ -8259,7 +8259,7 @@
                   <a:srgbClr val="D8EAFF"/>
                 </a:solidFill>
               </a:rPr>
-              <a:t>Identificación visible de la gestión por parte de Sendacredit como elemento disuasorio frente al impago.</a:t>
+              <a:t>Análisis, valoración y adquisición de carteras de deuda fallida para maximizar la recuperación de activos.</a:t>
             </a:r>
           </a:p>
         </p:txBody>
@@ -8596,7 +8596,7 @@
                   <a:srgbClr val="FFFFFF"/>
                 </a:solidFill>
               </a:rPr>
-              <a:t>Ficheros de morosidad</a:t>
+              <a:t>Sello preventivo Sendacredit</a:t>
             </a:r>
           </a:p>
         </p:txBody>
@@ -8653,7 +8653,7 @@
         <p:spPr>
           <a:xfrm>
             <a:off x="6429603" y="5021072"/>
-            <a:ext cx="5286603" cy="1005840"/>
+            <a:ext cx="4079595" cy="1005840"/>
           </a:xfrm>
           <a:prstGeom prst="rect">
             <a:avLst/>
@@ -8673,11 +8673,35 @@
                   <a:srgbClr val="D8EAFF"/>
                 </a:solidFill>
               </a:rPr>
-              <a:t>Registro del deudor en ficheros de morosidad como medida adicional de presión y prevención.</a:t>
-            </a:r>
-          </a:p>
-        </p:txBody>
-      </p:sp>
+              <a:t>Siéntase protegido frente a sus impagados.</a:t>
+            </a:r>
+          </a:p>
+        </p:txBody>
+      </p:sp>
+      <p:pic>
+        <p:nvPicPr>
+          <p:cNvPr id="28" name="Picture 27" descr="seal.png"/>
+          <p:cNvPicPr>
+            <a:picLocks noChangeAspect="1"/>
+          </p:cNvPicPr>
+          <p:nvPr/>
+        </p:nvPicPr>
+        <p:blipFill>
+          <a:blip r:embed="rId3"/>
+          <a:stretch>
+            <a:fillRect/>
+          </a:stretch>
+        </p:blipFill>
+        <p:spPr>
+          <a:xfrm>
+            <a:off x="10582351" y="4966208"/>
+            <a:ext cx="1115568" cy="1115568"/>
+          </a:xfrm>
+          <a:prstGeom prst="rect">
+            <a:avLst/>
+          </a:prstGeom>
+        </p:spPr>
+      </p:pic>
     </p:spTree>
   </p:cSld>
   <p:clrMapOvr>

</xml_diff>

<commit_message>
Redesign seal with white bg + shield, update contact phone/email
</commit_message>
<xml_diff>
--- a/sendacredit_propuesta.pptx
+++ b/sendacredit_propuesta.pptx
@@ -9614,7 +9614,7 @@
                   <a:srgbClr val="2FDFE5"/>
                 </a:solidFill>
               </a:rPr>
-              <a:t>+34 910 000 001</a:t>
+              <a:t>91 038 00 81</a:t>
             </a:r>
           </a:p>
           <a:p>
@@ -9629,7 +9629,7 @@
                   <a:srgbClr val="80A8CC"/>
                 </a:solidFill>
               </a:rPr>
-              <a:t>madrid@sendacredit.com</a:t>
+              <a:t>info@sendacredit.com</a:t>
             </a:r>
           </a:p>
         </p:txBody>
@@ -9847,7 +9847,7 @@
                   <a:srgbClr val="2FDFE5"/>
                 </a:solidFill>
               </a:rPr>
-              <a:t>+34 932 000 002</a:t>
+              <a:t>93 860 36 60</a:t>
             </a:r>
           </a:p>
           <a:p>
@@ -9862,7 +9862,7 @@
                   <a:srgbClr val="80A8CC"/>
                 </a:solidFill>
               </a:rPr>
-              <a:t>barcelona@sendacredit.com</a:t>
+              <a:t>info@sendacredit.com</a:t>
             </a:r>
           </a:p>
         </p:txBody>
@@ -10080,7 +10080,7 @@
                   <a:srgbClr val="2FDFE5"/>
                 </a:solidFill>
               </a:rPr>
-              <a:t>+34 952 000 003</a:t>
+              <a:t>95 174 57 01</a:t>
             </a:r>
           </a:p>
           <a:p>
@@ -10095,7 +10095,7 @@
                   <a:srgbClr val="80A8CC"/>
                 </a:solidFill>
               </a:rPr>
-              <a:t>malaga@sendacredit.com</a:t>
+              <a:t>info@sendacredit.com</a:t>
             </a:r>
           </a:p>
         </p:txBody>

</xml_diff>

<commit_message>
Subtítulos más grandes, sello 'frente a sus impagados', direcciones corregidas
</commit_message>
<xml_diff>
--- a/sendacredit_propuesta.pptx
+++ b/sendacredit_propuesta.pptx
@@ -3278,7 +3278,7 @@
           <a:p>
             <a:pPr algn="l"/>
             <a:r>
-              <a:rPr sz="1000" b="1">
+              <a:rPr sz="1400" b="1">
                 <a:solidFill>
                   <a:srgbClr val="2FDFE5"/>
                 </a:solidFill>
@@ -3411,7 +3411,7 @@
           <a:p>
             <a:pPr algn="l"/>
             <a:r>
-              <a:rPr sz="1150" i="1">
+              <a:rPr sz="1400" i="1">
                 <a:solidFill>
                   <a:srgbClr val="C0E8FF"/>
                 </a:solidFill>
@@ -3746,7 +3746,7 @@
           <a:p>
             <a:pPr algn="l"/>
             <a:r>
-              <a:rPr sz="1300" i="1">
+              <a:rPr sz="1500" i="1">
                 <a:solidFill>
                   <a:srgbClr val="80A8CC"/>
                 </a:solidFill>
@@ -4778,7 +4778,7 @@
           <a:p>
             <a:pPr algn="l"/>
             <a:r>
-              <a:rPr sz="1300" i="1">
+              <a:rPr sz="1500" i="1">
                 <a:solidFill>
                   <a:srgbClr val="80A8CC"/>
                 </a:solidFill>
@@ -5810,7 +5810,7 @@
           <a:p>
             <a:pPr algn="l"/>
             <a:r>
-              <a:rPr sz="1300" i="1">
+              <a:rPr sz="1500" i="1">
                 <a:solidFill>
                   <a:srgbClr val="80A8CC"/>
                 </a:solidFill>
@@ -6842,7 +6842,7 @@
           <a:p>
             <a:pPr algn="l"/>
             <a:r>
-              <a:rPr sz="1300" i="1">
+              <a:rPr sz="1500" i="1">
                 <a:solidFill>
                   <a:srgbClr val="80A8CC"/>
                 </a:solidFill>
@@ -9518,7 +9518,7 @@
                   <a:srgbClr val="2FDFE5"/>
                 </a:solidFill>
               </a:rPr>
-              <a:t>MADRID</a:t>
+              <a:t>BARCELONA</a:t>
             </a:r>
           </a:p>
         </p:txBody>
@@ -9599,7 +9599,7 @@
                   <a:srgbClr val="D8EAFF"/>
                 </a:solidFill>
               </a:rPr>
-              <a:t>Gran Vía 28, 4ª planta</a:t>
+              <a:t>C/Tarragona, 161, 08014 (Barcelona)</a:t>
             </a:r>
           </a:p>
           <a:p>
@@ -9614,7 +9614,7 @@
                   <a:srgbClr val="2FDFE5"/>
                 </a:solidFill>
               </a:rPr>
-              <a:t>91 038 00 81</a:t>
+              <a:t>93 860 36 60</a:t>
             </a:r>
           </a:p>
           <a:p>
@@ -9751,7 +9751,7 @@
                   <a:srgbClr val="2FDFE5"/>
                 </a:solidFill>
               </a:rPr>
-              <a:t>BARCELONA</a:t>
+              <a:t>MADRID</a:t>
             </a:r>
           </a:p>
         </p:txBody>
@@ -9832,7 +9832,7 @@
                   <a:srgbClr val="D8EAFF"/>
                 </a:solidFill>
               </a:rPr>
-              <a:t>Diagonal 211, 3ª planta</a:t>
+              <a:t>C/Paseo de la Castellana, 130, 28046 (Madrid)</a:t>
             </a:r>
           </a:p>
           <a:p>
@@ -9847,7 +9847,7 @@
                   <a:srgbClr val="2FDFE5"/>
                 </a:solidFill>
               </a:rPr>
-              <a:t>93 860 36 60</a:t>
+              <a:t>91 038 00 81</a:t>
             </a:r>
           </a:p>
           <a:p>
@@ -10065,7 +10065,7 @@
                   <a:srgbClr val="D8EAFF"/>
                 </a:solidFill>
               </a:rPr>
-              <a:t>Larios 12, 2ª planta</a:t>
+              <a:t>C/Marqués de Larios, 4, 29005 (Málaga)</a:t>
             </a:r>
           </a:p>
           <a:p>

</xml_diff>

<commit_message>
Subtítulos 18pt, arco inferior sello más grande (27pt) con texto minúsculas
</commit_message>
<xml_diff>
--- a/sendacredit_propuesta.pptx
+++ b/sendacredit_propuesta.pptx
@@ -3278,7 +3278,7 @@
           <a:p>
             <a:pPr algn="l"/>
             <a:r>
-              <a:rPr sz="1400" b="1">
+              <a:rPr sz="1800" b="1">
                 <a:solidFill>
                   <a:srgbClr val="2FDFE5"/>
                 </a:solidFill>
@@ -3411,7 +3411,7 @@
           <a:p>
             <a:pPr algn="l"/>
             <a:r>
-              <a:rPr sz="1400" i="1">
+              <a:rPr sz="1800" i="1">
                 <a:solidFill>
                   <a:srgbClr val="C0E8FF"/>
                 </a:solidFill>
@@ -3746,7 +3746,7 @@
           <a:p>
             <a:pPr algn="l"/>
             <a:r>
-              <a:rPr sz="1500" i="1">
+              <a:rPr sz="1800" i="1">
                 <a:solidFill>
                   <a:srgbClr val="80A8CC"/>
                 </a:solidFill>
@@ -4778,7 +4778,7 @@
           <a:p>
             <a:pPr algn="l"/>
             <a:r>
-              <a:rPr sz="1500" i="1">
+              <a:rPr sz="1800" i="1">
                 <a:solidFill>
                   <a:srgbClr val="80A8CC"/>
                 </a:solidFill>
@@ -5810,7 +5810,7 @@
           <a:p>
             <a:pPr algn="l"/>
             <a:r>
-              <a:rPr sz="1500" i="1">
+              <a:rPr sz="1800" i="1">
                 <a:solidFill>
                   <a:srgbClr val="80A8CC"/>
                 </a:solidFill>
@@ -6842,7 +6842,7 @@
           <a:p>
             <a:pPr algn="l"/>
             <a:r>
-              <a:rPr sz="1500" i="1">
+              <a:rPr sz="1800" i="1">
                 <a:solidFill>
                   <a:srgbClr val="80A8CC"/>
                 </a:solidFill>

</xml_diff>

<commit_message>
Sello arco en mayúsculas, subtítulo portada bajado y dentro del panel
</commit_message>
<xml_diff>
--- a/sendacredit_propuesta.pptx
+++ b/sendacredit_propuesta.pptx
@@ -3395,8 +3395,8 @@
         </p:nvSpPr>
         <p:spPr>
           <a:xfrm>
-            <a:off x="658368" y="4846320"/>
-            <a:ext cx="5303520" cy="475488"/>
+            <a:off x="658368" y="5102352"/>
+            <a:ext cx="4663440" cy="640080"/>
           </a:xfrm>
           <a:prstGeom prst="rect">
             <a:avLst/>

</xml_diff>

<commit_message>
Contacto: subtítulo 18pt, direcciones sin paréntesis, web centrada y más grande
</commit_message>
<xml_diff>
--- a/sendacredit_propuesta.pptx
+++ b/sendacredit_propuesta.pptx
@@ -9391,7 +9391,7 @@
           <a:p>
             <a:pPr algn="l"/>
             <a:r>
-              <a:rPr sz="1300" i="1">
+              <a:rPr sz="1800" i="1">
                 <a:solidFill>
                   <a:srgbClr val="C0E8FF"/>
                 </a:solidFill>
@@ -9599,7 +9599,7 @@
                   <a:srgbClr val="D8EAFF"/>
                 </a:solidFill>
               </a:rPr>
-              <a:t>C/Tarragona, 161, 08014 (Barcelona)</a:t>
+              <a:t>C/Tarragona, 161, 08014 Barcelona</a:t>
             </a:r>
           </a:p>
           <a:p>
@@ -9832,7 +9832,7 @@
                   <a:srgbClr val="D8EAFF"/>
                 </a:solidFill>
               </a:rPr>
-              <a:t>C/Paseo de la Castellana, 130, 28046 (Madrid)</a:t>
+              <a:t>C/Paseo de la Castellana, 130, 28046 Madrid</a:t>
             </a:r>
           </a:p>
           <a:p>
@@ -10065,7 +10065,7 @@
                   <a:srgbClr val="D8EAFF"/>
                 </a:solidFill>
               </a:rPr>
-              <a:t>C/Marqués de Larios, 4, 29005 (Málaga)</a:t>
+              <a:t>C/Marqués de Larios, 4, 29005 Málaga</a:t>
             </a:r>
           </a:p>
           <a:p>
@@ -10108,8 +10108,8 @@
         </p:nvSpPr>
         <p:spPr>
           <a:xfrm>
-            <a:off x="502920" y="6437376"/>
-            <a:ext cx="5486400" cy="274320"/>
+            <a:off x="0" y="6382512"/>
+            <a:ext cx="12191695" cy="365760"/>
           </a:xfrm>
           <a:prstGeom prst="rect">
             <a:avLst/>
@@ -10122,9 +10122,9 @@
           </a:bodyPr>
           <a:lstStyle/>
           <a:p>
-            <a:pPr algn="l"/>
-            <a:r>
-              <a:rPr sz="1000">
+            <a:pPr algn="ctr"/>
+            <a:r>
+              <a:rPr sz="1500">
                 <a:solidFill>
                   <a:srgbClr val="2FDFE5"/>
                 </a:solidFill>

</xml_diff>

<commit_message>
Contacto: añadir móviles a cada oficina
</commit_message>
<xml_diff>
--- a/sendacredit_propuesta.pptx
+++ b/sendacredit_propuesta.pptx
@@ -9614,7 +9614,7 @@
                   <a:srgbClr val="2FDFE5"/>
                 </a:solidFill>
               </a:rPr>
-              <a:t>93 860 36 60</a:t>
+              <a:t>93 860 36 60 - 637 39 66 68</a:t>
             </a:r>
           </a:p>
           <a:p>
@@ -9847,7 +9847,7 @@
                   <a:srgbClr val="2FDFE5"/>
                 </a:solidFill>
               </a:rPr>
-              <a:t>91 038 00 81</a:t>
+              <a:t>91 038 00 81 - 604 90 88 51</a:t>
             </a:r>
           </a:p>
           <a:p>
@@ -10080,7 +10080,7 @@
                   <a:srgbClr val="2FDFE5"/>
                 </a:solidFill>
               </a:rPr>
-              <a:t>95 174 57 01</a:t>
+              <a:t>95 174 57 01 - 678 86 02 76</a:t>
             </a:r>
           </a:p>
           <a:p>

</xml_diff>